<commit_message>
feat(theme): transition pitch deck to Vitt light elegant theme (Sandstone Alabaster & Sovereign Forest)
</commit_message>
<xml_diff>
--- a/sutra_pitch_deck.pptx
+++ b/sutra_pitch_deck.pptx
@@ -3103,7 +3103,7 @@
             <a:avLst/>
           </a:prstGeom>
           <a:solidFill>
-            <a:srgbClr val="07090E"/>
+            <a:srgbClr val="FAF7F2"/>
           </a:solidFill>
           <a:ln>
             <a:noFill/>
@@ -3146,11 +3146,11 @@
             <a:avLst/>
           </a:prstGeom>
           <a:solidFill>
-            <a:srgbClr val="2A0F1A"/>
+            <a:srgbClr val="F7ECE9"/>
           </a:solidFill>
           <a:ln w="12700">
             <a:solidFill>
-              <a:srgbClr val="E11D48"/>
+              <a:srgbClr val="9E4D34"/>
             </a:solidFill>
           </a:ln>
         </p:spPr>
@@ -3202,7 +3202,7 @@
             <a:r>
               <a:rPr sz="850" b="1">
                 <a:solidFill>
-                  <a:srgbClr val="FDA4AF"/>
+                  <a:srgbClr val="9E4D34"/>
                 </a:solidFill>
                 <a:latin typeface="JetBrains Mono"/>
               </a:rPr>
@@ -3226,11 +3226,11 @@
             <a:avLst/>
           </a:prstGeom>
           <a:solidFill>
-            <a:srgbClr val="0C241E"/>
+            <a:srgbClr val="EAF2EE"/>
           </a:solidFill>
           <a:ln w="12700">
             <a:solidFill>
-              <a:srgbClr val="10B981"/>
+              <a:srgbClr val="4A7A58"/>
             </a:solidFill>
           </a:ln>
         </p:spPr>
@@ -3282,11 +3282,11 @@
             <a:r>
               <a:rPr sz="850" b="1">
                 <a:solidFill>
-                  <a:srgbClr val="10B981"/>
+                  <a:srgbClr val="183A2B"/>
                 </a:solidFill>
                 <a:latin typeface="JetBrains Mono"/>
               </a:rPr>
-              <a:t>● SWARM STATE: 5/5 NODES ACTIVE</a:t>
+              <a:t>● SWARM STATE: 5/5 ACTIVE</a:t>
             </a:r>
           </a:p>
         </p:txBody>
@@ -3317,11 +3317,11 @@
             <a:r>
               <a:rPr sz="850" b="0">
                 <a:solidFill>
-                  <a:srgbClr val="94A3B8"/>
+                  <a:srgbClr val="4A5B53"/>
                 </a:solidFill>
                 <a:latin typeface="JetBrains Mono"/>
               </a:rPr>
-              <a:t>SECTOR: KEDARNATH VALLEY (30.7346° N, 79.0669° E)   |   CLOCK: 2026-08-31 11:22 UTC+05:30</a:t>
+              <a:t>SECTOR: KEDARNATH VALLEY (30.73° N, 79.06° E)   |   CLOCK: 2026-08-31 11:22 UTC+05:30</a:t>
             </a:r>
           </a:p>
         </p:txBody>
@@ -3341,7 +3341,7 @@
             <a:avLst/>
           </a:prstGeom>
           <a:solidFill>
-            <a:srgbClr val="1E293B"/>
+            <a:srgbClr val="EDE4D6"/>
           </a:solidFill>
           <a:ln>
             <a:noFill/>
@@ -3395,7 +3395,7 @@
             <a:r>
               <a:rPr sz="950" b="1">
                 <a:solidFill>
-                  <a:srgbClr val="06B6D4"/>
+                  <a:srgbClr val="9E4D34"/>
                 </a:solidFill>
                 <a:latin typeface="JetBrains Mono"/>
               </a:rPr>
@@ -3428,11 +3428,11 @@
           <a:p>
             <a:pPr algn="l"/>
             <a:r>
-              <a:rPr sz="5200" b="1">
-                <a:solidFill>
-                  <a:srgbClr val="F8FAFC"/>
-                </a:solidFill>
-                <a:latin typeface="Montserrat"/>
+              <a:rPr sz="5000" b="1">
+                <a:solidFill>
+                  <a:srgbClr val="183A2B"/>
+                </a:solidFill>
+                <a:latin typeface="Plus Jakarta Sans"/>
               </a:rPr>
               <a:t>PROJECT SUTRA</a:t>
             </a:r>
@@ -3465,9 +3465,9 @@
             <a:r>
               <a:rPr sz="1600" b="1">
                 <a:solidFill>
-                  <a:srgbClr val="38BDF8"/>
-                </a:solidFill>
-                <a:latin typeface="Inter"/>
+                  <a:srgbClr val="4A7A58"/>
+                </a:solidFill>
+                <a:latin typeface="Plus Jakarta Sans"/>
               </a:rPr>
               <a:t>Swarm Unified Tactical Reconnaissance Architecture</a:t>
             </a:r>
@@ -3500,9 +3500,9 @@
             <a:r>
               <a:rPr sz="1200" b="0">
                 <a:solidFill>
-                  <a:srgbClr val="94A3B8"/>
-                </a:solidFill>
-                <a:latin typeface="Inter"/>
+                  <a:srgbClr val="4A5B53"/>
+                </a:solidFill>
+                <a:latin typeface="Plus Jakarta Sans"/>
               </a:rPr>
               <a:t>A decentralized, fault-tolerant multi-UAV swarm engineered from first principles for GPS-denied deep mountain valleys, heavy RF jamming (-5 dB SNR), and sub-meter survivor geolocation under dense forest canopies.</a:t>
             </a:r>
@@ -3524,11 +3524,11 @@
             <a:avLst/>
           </a:prstGeom>
           <a:solidFill>
-            <a:srgbClr val="0D121F"/>
+            <a:srgbClr val="FFFFFF"/>
           </a:solidFill>
           <a:ln w="12700">
             <a:solidFill>
-              <a:srgbClr val="1E293B"/>
+              <a:srgbClr val="EDE4D6"/>
             </a:solidFill>
           </a:ln>
         </p:spPr>
@@ -3569,7 +3569,7 @@
             <a:avLst/>
           </a:prstGeom>
           <a:solidFill>
-            <a:srgbClr val="1E293B"/>
+            <a:srgbClr val="183A2B"/>
           </a:solidFill>
           <a:ln>
             <a:noFill/>
@@ -3623,7 +3623,7 @@
             <a:r>
               <a:rPr sz="750" b="1">
                 <a:solidFill>
-                  <a:srgbClr val="F8FAFC"/>
+                  <a:srgbClr val="FFFFFF"/>
                 </a:solidFill>
                 <a:latin typeface="JetBrains Mono"/>
               </a:rPr>
@@ -3656,11 +3656,11 @@
           <a:p>
             <a:pPr algn="l"/>
             <a:r>
-              <a:rPr sz="850" b="0">
-                <a:solidFill>
-                  <a:srgbClr val="CBD5E1"/>
-                </a:solidFill>
-                <a:latin typeface="Inter"/>
+              <a:rPr sz="850" b="1">
+                <a:solidFill>
+                  <a:srgbClr val="183A2B"/>
+                </a:solidFill>
+                <a:latin typeface="Plus Jakarta Sans"/>
               </a:rPr>
               <a:t>PX4 50Hz Offboard + SUTRA-FSD 3D Occupancy &amp; ORCA 3D</a:t>
             </a:r>
@@ -3682,11 +3682,11 @@
             <a:avLst/>
           </a:prstGeom>
           <a:solidFill>
-            <a:srgbClr val="0D121F"/>
+            <a:srgbClr val="FFFFFF"/>
           </a:solidFill>
           <a:ln w="12700">
             <a:solidFill>
-              <a:srgbClr val="1E293B"/>
+              <a:srgbClr val="EDE4D6"/>
             </a:solidFill>
           </a:ln>
         </p:spPr>
@@ -3727,7 +3727,7 @@
             <a:avLst/>
           </a:prstGeom>
           <a:solidFill>
-            <a:srgbClr val="1E293B"/>
+            <a:srgbClr val="9E4D34"/>
           </a:solidFill>
           <a:ln>
             <a:noFill/>
@@ -3781,7 +3781,7 @@
             <a:r>
               <a:rPr sz="750" b="1">
                 <a:solidFill>
-                  <a:srgbClr val="F8FAFC"/>
+                  <a:srgbClr val="FFFFFF"/>
                 </a:solidFill>
                 <a:latin typeface="JetBrains Mono"/>
               </a:rPr>
@@ -3814,11 +3814,11 @@
           <a:p>
             <a:pPr algn="l"/>
             <a:r>
-              <a:rPr sz="850" b="0">
-                <a:solidFill>
-                  <a:srgbClr val="CBD5E1"/>
-                </a:solidFill>
-                <a:latin typeface="Inter"/>
+              <a:rPr sz="850" b="1">
+                <a:solidFill>
+                  <a:srgbClr val="183A2B"/>
+                </a:solidFill>
+                <a:latin typeface="Plus Jakarta Sans"/>
               </a:rPr>
               <a:t>Deep JSCC Neural Transceiver (96.9% Video Compression)</a:t>
             </a:r>
@@ -3840,11 +3840,11 @@
             <a:avLst/>
           </a:prstGeom>
           <a:solidFill>
-            <a:srgbClr val="0D121F"/>
+            <a:srgbClr val="FFFFFF"/>
           </a:solidFill>
           <a:ln w="12700">
             <a:solidFill>
-              <a:srgbClr val="1E293B"/>
+              <a:srgbClr val="EDE4D6"/>
             </a:solidFill>
           </a:ln>
         </p:spPr>
@@ -3885,7 +3885,7 @@
             <a:avLst/>
           </a:prstGeom>
           <a:solidFill>
-            <a:srgbClr val="1E293B"/>
+            <a:srgbClr val="4A7A58"/>
           </a:solidFill>
           <a:ln>
             <a:noFill/>
@@ -3939,7 +3939,7 @@
             <a:r>
               <a:rPr sz="750" b="1">
                 <a:solidFill>
-                  <a:srgbClr val="F8FAFC"/>
+                  <a:srgbClr val="FFFFFF"/>
                 </a:solidFill>
                 <a:latin typeface="JetBrains Mono"/>
               </a:rPr>
@@ -3972,11 +3972,11 @@
           <a:p>
             <a:pPr algn="l"/>
             <a:r>
-              <a:rPr sz="850" b="0">
-                <a:solidFill>
-                  <a:srgbClr val="CBD5E1"/>
-                </a:solidFill>
-                <a:latin typeface="Inter"/>
+              <a:rPr sz="850" b="1">
+                <a:solidFill>
+                  <a:srgbClr val="183A2B"/>
+                </a:solidFill>
+                <a:latin typeface="Plus Jakarta Sans"/>
               </a:rPr>
               <a:t>Tri-Modal RGB/Thermal Edge AI + 3.59cm WGS84 Raycaster</a:t>
             </a:r>
@@ -3998,11 +3998,11 @@
             <a:avLst/>
           </a:prstGeom>
           <a:solidFill>
-            <a:srgbClr val="0D121F"/>
+            <a:srgbClr val="FFFFFF"/>
           </a:solidFill>
           <a:ln w="12700">
             <a:solidFill>
-              <a:srgbClr val="1E293B"/>
+              <a:srgbClr val="EDE4D6"/>
             </a:solidFill>
           </a:ln>
         </p:spPr>
@@ -4043,7 +4043,7 @@
             <a:avLst/>
           </a:prstGeom>
           <a:solidFill>
-            <a:srgbClr val="1E293B"/>
+            <a:srgbClr val="2B6CB0"/>
           </a:solidFill>
           <a:ln>
             <a:noFill/>
@@ -4097,7 +4097,7 @@
             <a:r>
               <a:rPr sz="750" b="1">
                 <a:solidFill>
-                  <a:srgbClr val="F8FAFC"/>
+                  <a:srgbClr val="FFFFFF"/>
                 </a:solidFill>
                 <a:latin typeface="JetBrains Mono"/>
               </a:rPr>
@@ -4130,11 +4130,11 @@
           <a:p>
             <a:pPr algn="l"/>
             <a:r>
-              <a:rPr sz="850" b="0">
-                <a:solidFill>
-                  <a:srgbClr val="CBD5E1"/>
-                </a:solidFill>
-                <a:latin typeface="Inter"/>
+              <a:rPr sz="850" b="1">
+                <a:solidFill>
+                  <a:srgbClr val="183A2B"/>
+                </a:solidFill>
+                <a:latin typeface="Plus Jakarta Sans"/>
               </a:rPr>
               <a:t>Pegasus 3D GIS GCS + WebGPU 60 FPS Multi-Stream &amp; ATAK CoT</a:t>
             </a:r>
@@ -4156,11 +4156,11 @@
             <a:avLst/>
           </a:prstGeom>
           <a:solidFill>
-            <a:srgbClr val="0D121F"/>
+            <a:srgbClr val="FFFFFF"/>
           </a:solidFill>
           <a:ln w="12700">
             <a:solidFill>
-              <a:srgbClr val="1E293B"/>
+              <a:srgbClr val="EDE4D6"/>
             </a:solidFill>
           </a:ln>
         </p:spPr>
@@ -4201,7 +4201,7 @@
             <a:avLst/>
           </a:prstGeom>
           <a:solidFill>
-            <a:srgbClr val="06B6D4"/>
+            <a:srgbClr val="183A2B"/>
           </a:solidFill>
           <a:ln>
             <a:noFill/>
@@ -4255,7 +4255,7 @@
             <a:r>
               <a:rPr sz="950" b="1">
                 <a:solidFill>
-                  <a:srgbClr val="F8FAFC"/>
+                  <a:srgbClr val="183A2B"/>
                 </a:solidFill>
                 <a:latin typeface="JetBrains Mono"/>
               </a:rPr>
@@ -4279,11 +4279,11 @@
             <a:avLst/>
           </a:prstGeom>
           <a:solidFill>
-            <a:srgbClr val="0C241E"/>
+            <a:srgbClr val="EAF2EE"/>
           </a:solidFill>
           <a:ln w="12700">
             <a:solidFill>
-              <a:srgbClr val="10B981"/>
+              <a:srgbClr val="4A7A58"/>
             </a:solidFill>
           </a:ln>
         </p:spPr>
@@ -4335,7 +4335,7 @@
             <a:r>
               <a:rPr sz="750" b="1">
                 <a:solidFill>
-                  <a:srgbClr val="10B981"/>
+                  <a:srgbClr val="183A2B"/>
                 </a:solidFill>
                 <a:latin typeface="JetBrains Mono"/>
               </a:rPr>
@@ -4359,11 +4359,11 @@
             <a:avLst/>
           </a:prstGeom>
           <a:solidFill>
-            <a:srgbClr val="070B14"/>
+            <a:srgbClr val="F4ECE1"/>
           </a:solidFill>
           <a:ln w="12700">
             <a:solidFill>
-              <a:srgbClr val="1E293B"/>
+              <a:srgbClr val="EDE4D6"/>
             </a:solidFill>
           </a:ln>
         </p:spPr>
@@ -4413,9 +4413,9 @@
           <a:p>
             <a:pPr algn="l"/>
             <a:r>
-              <a:rPr sz="800" b="0">
-                <a:solidFill>
-                  <a:srgbClr val="94A3B8"/>
+              <a:rPr sz="800" b="1">
+                <a:solidFill>
+                  <a:srgbClr val="4A5B53"/>
                 </a:solidFill>
                 <a:latin typeface="JetBrains Mono"/>
               </a:rPr>
@@ -4450,7 +4450,7 @@
             <a:r>
               <a:rPr sz="800" b="1">
                 <a:solidFill>
-                  <a:srgbClr val="10B981"/>
+                  <a:srgbClr val="183A2B"/>
                 </a:solidFill>
                 <a:latin typeface="JetBrains Mono"/>
               </a:rPr>
@@ -4474,11 +4474,11 @@
             <a:avLst/>
           </a:prstGeom>
           <a:solidFill>
-            <a:srgbClr val="070B14"/>
+            <a:srgbClr val="F4ECE1"/>
           </a:solidFill>
           <a:ln w="12700">
             <a:solidFill>
-              <a:srgbClr val="1E293B"/>
+              <a:srgbClr val="EDE4D6"/>
             </a:solidFill>
           </a:ln>
         </p:spPr>
@@ -4528,9 +4528,9 @@
           <a:p>
             <a:pPr algn="l"/>
             <a:r>
-              <a:rPr sz="800" b="0">
-                <a:solidFill>
-                  <a:srgbClr val="94A3B8"/>
+              <a:rPr sz="800" b="1">
+                <a:solidFill>
+                  <a:srgbClr val="4A5B53"/>
                 </a:solidFill>
                 <a:latin typeface="JetBrains Mono"/>
               </a:rPr>
@@ -4565,7 +4565,7 @@
             <a:r>
               <a:rPr sz="800" b="1">
                 <a:solidFill>
-                  <a:srgbClr val="06B6D4"/>
+                  <a:srgbClr val="4A7A58"/>
                 </a:solidFill>
                 <a:latin typeface="JetBrains Mono"/>
               </a:rPr>
@@ -4589,11 +4589,11 @@
             <a:avLst/>
           </a:prstGeom>
           <a:solidFill>
-            <a:srgbClr val="070B14"/>
+            <a:srgbClr val="F4ECE1"/>
           </a:solidFill>
           <a:ln w="12700">
             <a:solidFill>
-              <a:srgbClr val="1E293B"/>
+              <a:srgbClr val="EDE4D6"/>
             </a:solidFill>
           </a:ln>
         </p:spPr>
@@ -4643,9 +4643,9 @@
           <a:p>
             <a:pPr algn="l"/>
             <a:r>
-              <a:rPr sz="800" b="0">
-                <a:solidFill>
-                  <a:srgbClr val="94A3B8"/>
+              <a:rPr sz="800" b="1">
+                <a:solidFill>
+                  <a:srgbClr val="4A5B53"/>
                 </a:solidFill>
                 <a:latin typeface="JetBrains Mono"/>
               </a:rPr>
@@ -4680,7 +4680,7 @@
             <a:r>
               <a:rPr sz="800" b="1">
                 <a:solidFill>
-                  <a:srgbClr val="10B981"/>
+                  <a:srgbClr val="183A2B"/>
                 </a:solidFill>
                 <a:latin typeface="JetBrains Mono"/>
               </a:rPr>
@@ -4704,11 +4704,11 @@
             <a:avLst/>
           </a:prstGeom>
           <a:solidFill>
-            <a:srgbClr val="070B14"/>
+            <a:srgbClr val="F4ECE1"/>
           </a:solidFill>
           <a:ln w="12700">
             <a:solidFill>
-              <a:srgbClr val="1E293B"/>
+              <a:srgbClr val="EDE4D6"/>
             </a:solidFill>
           </a:ln>
         </p:spPr>
@@ -4758,9 +4758,9 @@
           <a:p>
             <a:pPr algn="l"/>
             <a:r>
-              <a:rPr sz="800" b="0">
-                <a:solidFill>
-                  <a:srgbClr val="94A3B8"/>
+              <a:rPr sz="800" b="1">
+                <a:solidFill>
+                  <a:srgbClr val="4A5B53"/>
                 </a:solidFill>
                 <a:latin typeface="JetBrains Mono"/>
               </a:rPr>
@@ -4795,7 +4795,7 @@
             <a:r>
               <a:rPr sz="800" b="1">
                 <a:solidFill>
-                  <a:srgbClr val="06B6D4"/>
+                  <a:srgbClr val="2B6CB0"/>
                 </a:solidFill>
                 <a:latin typeface="JetBrains Mono"/>
               </a:rPr>
@@ -4819,11 +4819,11 @@
             <a:avLst/>
           </a:prstGeom>
           <a:solidFill>
-            <a:srgbClr val="070B14"/>
+            <a:srgbClr val="F4ECE1"/>
           </a:solidFill>
           <a:ln w="12700">
             <a:solidFill>
-              <a:srgbClr val="1E293B"/>
+              <a:srgbClr val="EDE4D6"/>
             </a:solidFill>
           </a:ln>
         </p:spPr>
@@ -4873,9 +4873,9 @@
           <a:p>
             <a:pPr algn="l"/>
             <a:r>
-              <a:rPr sz="800" b="0">
-                <a:solidFill>
-                  <a:srgbClr val="94A3B8"/>
+              <a:rPr sz="800" b="1">
+                <a:solidFill>
+                  <a:srgbClr val="4A5B53"/>
                 </a:solidFill>
                 <a:latin typeface="JetBrains Mono"/>
               </a:rPr>
@@ -4910,7 +4910,7 @@
             <a:r>
               <a:rPr sz="800" b="1">
                 <a:solidFill>
-                  <a:srgbClr val="F59E0B"/>
+                  <a:srgbClr val="B68637"/>
                 </a:solidFill>
                 <a:latin typeface="JetBrains Mono"/>
               </a:rPr>
@@ -4934,11 +4934,11 @@
             <a:avLst/>
           </a:prstGeom>
           <a:solidFill>
-            <a:srgbClr val="050A14"/>
+            <a:srgbClr val="F4ECE1"/>
           </a:solidFill>
           <a:ln w="12700">
             <a:solidFill>
-              <a:srgbClr val="06B6D4"/>
+              <a:srgbClr val="4A7A58"/>
             </a:solidFill>
           </a:ln>
         </p:spPr>
@@ -4990,7 +4990,7 @@
             <a:r>
               <a:rPr sz="800" b="1">
                 <a:solidFill>
-                  <a:srgbClr val="94A3B8"/>
+                  <a:srgbClr val="4A5B53"/>
                 </a:solidFill>
                 <a:latin typeface="JetBrains Mono"/>
               </a:rPr>
@@ -5025,7 +5025,7 @@
             <a:r>
               <a:rPr sz="950" b="1">
                 <a:solidFill>
-                  <a:srgbClr val="F8FAFC"/>
+                  <a:srgbClr val="183A2B"/>
                 </a:solidFill>
                 <a:latin typeface="JetBrains Mono"/>
               </a:rPr>
@@ -5049,11 +5049,11 @@
             <a:avLst/>
           </a:prstGeom>
           <a:solidFill>
-            <a:srgbClr val="2A0F1A"/>
+            <a:srgbClr val="F7ECE9"/>
           </a:solidFill>
           <a:ln w="12700">
             <a:solidFill>
-              <a:srgbClr val="E11D48"/>
+              <a:srgbClr val="9E4D34"/>
             </a:solidFill>
           </a:ln>
         </p:spPr>
@@ -5105,7 +5105,7 @@
             <a:r>
               <a:rPr sz="850" b="1">
                 <a:solidFill>
-                  <a:srgbClr val="FDA4AF"/>
+                  <a:srgbClr val="9E4D34"/>
                 </a:solidFill>
                 <a:latin typeface="JetBrains Mono"/>
               </a:rPr>
@@ -5129,11 +5129,11 @@
             <a:avLst/>
           </a:prstGeom>
           <a:solidFill>
-            <a:srgbClr val="0D121F"/>
+            <a:srgbClr val="FFFFFF"/>
           </a:solidFill>
           <a:ln w="12700">
             <a:solidFill>
-              <a:srgbClr val="1E293B"/>
+              <a:srgbClr val="EDE4D6"/>
             </a:solidFill>
           </a:ln>
         </p:spPr>
@@ -5174,7 +5174,7 @@
             <a:avLst/>
           </a:prstGeom>
           <a:solidFill>
-            <a:srgbClr val="06B6D4"/>
+            <a:srgbClr val="183A2B"/>
           </a:solidFill>
           <a:ln>
             <a:noFill/>
@@ -5228,9 +5228,9 @@
             <a:r>
               <a:rPr sz="2000" b="1">
                 <a:solidFill>
-                  <a:srgbClr val="F8FAFC"/>
-                </a:solidFill>
-                <a:latin typeface="Montserrat"/>
+                  <a:srgbClr val="183A2B"/>
+                </a:solidFill>
+                <a:latin typeface="Plus Jakarta Sans"/>
               </a:rPr>
               <a:t>232/232 TESTS</a:t>
             </a:r>
@@ -5263,7 +5263,7 @@
             <a:r>
               <a:rPr sz="850" b="1">
                 <a:solidFill>
-                  <a:srgbClr val="E2E8F0"/>
+                  <a:srgbClr val="183A2B"/>
                 </a:solidFill>
                 <a:latin typeface="JetBrains Mono"/>
               </a:rPr>
@@ -5298,9 +5298,9 @@
             <a:r>
               <a:rPr sz="750" b="0">
                 <a:solidFill>
-                  <a:srgbClr val="64748B"/>
-                </a:solidFill>
-                <a:latin typeface="Inter"/>
+                  <a:srgbClr val="4A5B53"/>
+                </a:solidFill>
+                <a:latin typeface="Plus Jakarta Sans"/>
               </a:rPr>
               <a:t>100% automated pytest suite passing with live telemetry stdout</a:t>
             </a:r>
@@ -5322,11 +5322,11 @@
             <a:avLst/>
           </a:prstGeom>
           <a:solidFill>
-            <a:srgbClr val="0D121F"/>
+            <a:srgbClr val="FFFFFF"/>
           </a:solidFill>
           <a:ln w="12700">
             <a:solidFill>
-              <a:srgbClr val="1E293B"/>
+              <a:srgbClr val="EDE4D6"/>
             </a:solidFill>
           </a:ln>
         </p:spPr>
@@ -5367,7 +5367,7 @@
             <a:avLst/>
           </a:prstGeom>
           <a:solidFill>
-            <a:srgbClr val="10B981"/>
+            <a:srgbClr val="9E4D34"/>
           </a:solidFill>
           <a:ln>
             <a:noFill/>
@@ -5421,9 +5421,9 @@
             <a:r>
               <a:rPr sz="2000" b="1">
                 <a:solidFill>
-                  <a:srgbClr val="F8FAFC"/>
-                </a:solidFill>
-                <a:latin typeface="Montserrat"/>
+                  <a:srgbClr val="9E4D34"/>
+                </a:solidFill>
+                <a:latin typeface="Plus Jakarta Sans"/>
               </a:rPr>
               <a:t>96.9% BW SAVED</a:t>
             </a:r>
@@ -5456,7 +5456,7 @@
             <a:r>
               <a:rPr sz="850" b="1">
                 <a:solidFill>
-                  <a:srgbClr val="E2E8F0"/>
+                  <a:srgbClr val="183A2B"/>
                 </a:solidFill>
                 <a:latin typeface="JetBrains Mono"/>
               </a:rPr>
@@ -5491,9 +5491,9 @@
             <a:r>
               <a:rPr sz="750" b="0">
                 <a:solidFill>
-                  <a:srgbClr val="64748B"/>
-                </a:solidFill>
-                <a:latin typeface="Inter"/>
+                  <a:srgbClr val="4A5B53"/>
+                </a:solidFill>
+                <a:latin typeface="Plus Jakarta Sans"/>
               </a:rPr>
               <a:t>512 KB → 16 KB frames surviving extreme -5 dB jamming without cliff</a:t>
             </a:r>
@@ -5515,11 +5515,11 @@
             <a:avLst/>
           </a:prstGeom>
           <a:solidFill>
-            <a:srgbClr val="0D121F"/>
+            <a:srgbClr val="FFFFFF"/>
           </a:solidFill>
           <a:ln w="12700">
             <a:solidFill>
-              <a:srgbClr val="1E293B"/>
+              <a:srgbClr val="EDE4D6"/>
             </a:solidFill>
           </a:ln>
         </p:spPr>
@@ -5560,7 +5560,7 @@
             <a:avLst/>
           </a:prstGeom>
           <a:solidFill>
-            <a:srgbClr val="38BDF8"/>
+            <a:srgbClr val="4A7A58"/>
           </a:solidFill>
           <a:ln>
             <a:noFill/>
@@ -5614,9 +5614,9 @@
             <a:r>
               <a:rPr sz="2000" b="1">
                 <a:solidFill>
-                  <a:srgbClr val="F8FAFC"/>
-                </a:solidFill>
-                <a:latin typeface="Montserrat"/>
+                  <a:srgbClr val="4A7A58"/>
+                </a:solidFill>
+                <a:latin typeface="Plus Jakarta Sans"/>
               </a:rPr>
               <a:t>3.59 CM</a:t>
             </a:r>
@@ -5649,7 +5649,7 @@
             <a:r>
               <a:rPr sz="850" b="1">
                 <a:solidFill>
-                  <a:srgbClr val="E2E8F0"/>
+                  <a:srgbClr val="183A2B"/>
                 </a:solidFill>
                 <a:latin typeface="JetBrains Mono"/>
               </a:rPr>
@@ -5684,9 +5684,9 @@
             <a:r>
               <a:rPr sz="750" b="0">
                 <a:solidFill>
-                  <a:srgbClr val="64748B"/>
-                </a:solidFill>
-                <a:latin typeface="Inter"/>
+                  <a:srgbClr val="4A5B53"/>
+                </a:solidFill>
+                <a:latin typeface="Plus Jakarta Sans"/>
               </a:rPr>
               <a:t>Terrain-corrected raycaster error from 30m altitude over mountain slopes</a:t>
             </a:r>
@@ -5708,11 +5708,11 @@
             <a:avLst/>
           </a:prstGeom>
           <a:solidFill>
-            <a:srgbClr val="0D121F"/>
+            <a:srgbClr val="FFFFFF"/>
           </a:solidFill>
           <a:ln w="12700">
             <a:solidFill>
-              <a:srgbClr val="1E293B"/>
+              <a:srgbClr val="EDE4D6"/>
             </a:solidFill>
           </a:ln>
         </p:spPr>
@@ -5753,7 +5753,7 @@
             <a:avLst/>
           </a:prstGeom>
           <a:solidFill>
-            <a:srgbClr val="E11D48"/>
+            <a:srgbClr val="2B6CB0"/>
           </a:solidFill>
           <a:ln>
             <a:noFill/>
@@ -5807,9 +5807,9 @@
             <a:r>
               <a:rPr sz="2000" b="1">
                 <a:solidFill>
-                  <a:srgbClr val="F8FAFC"/>
-                </a:solidFill>
-                <a:latin typeface="Montserrat"/>
+                  <a:srgbClr val="2B6CB0"/>
+                </a:solidFill>
+                <a:latin typeface="Plus Jakarta Sans"/>
               </a:rPr>
               <a:t>60.0 FPS</a:t>
             </a:r>
@@ -5842,7 +5842,7 @@
             <a:r>
               <a:rPr sz="850" b="1">
                 <a:solidFill>
-                  <a:srgbClr val="E2E8F0"/>
+                  <a:srgbClr val="183A2B"/>
                 </a:solidFill>
                 <a:latin typeface="JetBrains Mono"/>
               </a:rPr>
@@ -5877,9 +5877,9 @@
             <a:r>
               <a:rPr sz="750" b="0">
                 <a:solidFill>
-                  <a:srgbClr val="64748B"/>
-                </a:solidFill>
-                <a:latin typeface="Inter"/>
+                  <a:srgbClr val="4A5B53"/>
+                </a:solidFill>
+                <a:latin typeface="Plus Jakarta Sans"/>
               </a:rPr>
               <a:t>Locked 60 FPS zero frame-drop tactical 3D GIS Ground Control Station</a:t>
             </a:r>
@@ -5901,7 +5901,7 @@
             <a:avLst/>
           </a:prstGeom>
           <a:solidFill>
-            <a:srgbClr val="1E293B"/>
+            <a:srgbClr val="EDE4D6"/>
           </a:solidFill>
           <a:ln>
             <a:noFill/>
@@ -5955,7 +5955,7 @@
             <a:r>
               <a:rPr sz="750" b="0">
                 <a:solidFill>
-                  <a:srgbClr val="94A3B8"/>
+                  <a:srgbClr val="4A5B53"/>
                 </a:solidFill>
                 <a:latin typeface="JetBrains Mono"/>
               </a:rPr>
@@ -5990,7 +5990,7 @@
             <a:r>
               <a:rPr sz="750" b="1">
                 <a:solidFill>
-                  <a:srgbClr val="94A3B8"/>
+                  <a:srgbClr val="183A2B"/>
                 </a:solidFill>
                 <a:latin typeface="JetBrains Mono"/>
               </a:rPr>

</xml_diff>

<commit_message>
feat(title): implement strict PPT Artisan Title Slide formula with 50%+ whitespace and zero clutter
</commit_message>
<xml_diff>
--- a/sutra_pitch_deck.pptx
+++ b/sutra_pitch_deck.pptx
@@ -3139,19 +3139,17 @@
         </p:nvSpPr>
         <p:spPr>
           <a:xfrm>
-            <a:off x="731520" y="457200"/>
-            <a:ext cx="2377440" cy="320040"/>
+            <a:off x="731520" y="548640"/>
+            <a:ext cx="365760" cy="365760"/>
           </a:xfrm>
           <a:prstGeom prst="roundRect">
             <a:avLst/>
           </a:prstGeom>
           <a:solidFill>
-            <a:srgbClr val="F7ECE9"/>
+            <a:srgbClr val="183A2B"/>
           </a:solidFill>
-          <a:ln w="10160">
-            <a:solidFill>
-              <a:srgbClr val="9E4D34"/>
-            </a:solidFill>
+          <a:ln>
+            <a:noFill/>
           </a:ln>
         </p:spPr>
         <p:style>
@@ -3184,8 +3182,8 @@
         </p:nvSpPr>
         <p:spPr>
           <a:xfrm>
-            <a:off x="822960" y="530352"/>
-            <a:ext cx="2194560" cy="228600"/>
+            <a:off x="1188720" y="621792"/>
+            <a:ext cx="3657600" cy="274320"/>
           </a:xfrm>
           <a:prstGeom prst="rect">
             <a:avLst/>
@@ -3198,40 +3196,73 @@
           </a:bodyPr>
           <a:lstStyle/>
           <a:p>
-            <a:pPr algn="ctr"/>
-            <a:r>
-              <a:rPr sz="850" b="1" i="0">
+            <a:pPr algn="l"/>
+            <a:r>
+              <a:rPr sz="900" b="1">
+                <a:solidFill>
+                  <a:srgbClr val="5A6B63"/>
+                </a:solidFill>
+                <a:latin typeface="JetBrains Mono"/>
+              </a:rPr>
+              <a:t>DEFENSE &amp; DISASTER ROBOTICS</a:t>
+            </a:r>
+          </a:p>
+        </p:txBody>
+      </p:sp>
+      <p:sp>
+        <p:nvSpPr>
+          <p:cNvPr id="5" name="TextBox 4"/>
+          <p:cNvSpPr txBox="1"/>
+          <p:nvPr/>
+        </p:nvSpPr>
+        <p:spPr>
+          <a:xfrm>
+            <a:off x="731520" y="2377440"/>
+            <a:ext cx="9144000" cy="274320"/>
+          </a:xfrm>
+          <a:prstGeom prst="rect">
+            <a:avLst/>
+          </a:prstGeom>
+          <a:noFill/>
+        </p:spPr>
+        <p:txBody>
+          <a:bodyPr wrap="square" lIns="0" tIns="0" rIns="0" bIns="0">
+            <a:spAutoFit/>
+          </a:bodyPr>
+          <a:lstStyle/>
+          <a:p>
+            <a:pPr algn="l"/>
+            <a:r>
+              <a:rPr sz="1100" b="1">
                 <a:solidFill>
                   <a:srgbClr val="9E4D34"/>
                 </a:solidFill>
                 <a:latin typeface="JetBrains Mono"/>
               </a:rPr>
-              <a:t>DEFENSE &amp; DISASTER ROBOTICS</a:t>
-            </a:r>
-          </a:p>
-        </p:txBody>
-      </p:sp>
-      <p:sp>
-        <p:nvSpPr>
-          <p:cNvPr id="5" name="Rounded Rectangle 4"/>
+              <a:t>AUTONOMOUS MULTI-UAV SWARM ARCHITECTURE</a:t>
+            </a:r>
+          </a:p>
+        </p:txBody>
+      </p:sp>
+      <p:sp>
+        <p:nvSpPr>
+          <p:cNvPr id="6" name="Rectangle 5"/>
           <p:cNvSpPr/>
           <p:nvPr/>
         </p:nvSpPr>
         <p:spPr>
           <a:xfrm>
-            <a:off x="3291840" y="457200"/>
-            <a:ext cx="2194560" cy="320040"/>
+            <a:off x="731520" y="2743200"/>
+            <a:ext cx="1097280" cy="32004"/>
           </a:xfrm>
-          <a:prstGeom prst="roundRect">
+          <a:prstGeom prst="rect">
             <a:avLst/>
           </a:prstGeom>
           <a:solidFill>
-            <a:srgbClr val="EAF2EE"/>
+            <a:srgbClr val="9E4D34"/>
           </a:solidFill>
-          <a:ln w="10160">
-            <a:solidFill>
-              <a:srgbClr val="4A7A58"/>
-            </a:solidFill>
+          <a:ln>
+            <a:noFill/>
           </a:ln>
         </p:spPr>
         <p:style>
@@ -3258,14 +3289,14 @@
       </p:sp>
       <p:sp>
         <p:nvSpPr>
-          <p:cNvPr id="6" name="TextBox 5"/>
+          <p:cNvPr id="7" name="TextBox 6"/>
           <p:cNvSpPr txBox="1"/>
           <p:nvPr/>
         </p:nvSpPr>
         <p:spPr>
           <a:xfrm>
-            <a:off x="3383280" y="530352"/>
-            <a:ext cx="2011680" cy="228600"/>
+            <a:off x="731520" y="2971800"/>
+            <a:ext cx="10058400" cy="1097280"/>
           </a:xfrm>
           <a:prstGeom prst="rect">
             <a:avLst/>
@@ -3278,29 +3309,29 @@
           </a:bodyPr>
           <a:lstStyle/>
           <a:p>
-            <a:pPr algn="ctr"/>
-            <a:r>
-              <a:rPr sz="850" b="1" i="0">
+            <a:pPr algn="l"/>
+            <a:r>
+              <a:rPr sz="5400" b="1">
                 <a:solidFill>
                   <a:srgbClr val="183A2B"/>
                 </a:solidFill>
-                <a:latin typeface="JetBrains Mono"/>
+                <a:latin typeface="Plus Jakarta Sans"/>
               </a:rPr>
-              <a:t>● SWARM STATE: 5/5 ACTIVE</a:t>
-            </a:r>
-          </a:p>
-        </p:txBody>
-      </p:sp>
-      <p:sp>
-        <p:nvSpPr>
-          <p:cNvPr id="7" name="TextBox 6"/>
+              <a:t>PROJECT SUTRA</a:t>
+            </a:r>
+          </a:p>
+        </p:txBody>
+      </p:sp>
+      <p:sp>
+        <p:nvSpPr>
+          <p:cNvPr id="8" name="TextBox 7"/>
           <p:cNvSpPr txBox="1"/>
           <p:nvPr/>
         </p:nvSpPr>
         <p:spPr>
           <a:xfrm>
-            <a:off x="6858000" y="530352"/>
-            <a:ext cx="4572000" cy="228600"/>
+            <a:off x="731520" y="4114800"/>
+            <a:ext cx="7772400" cy="731520"/>
           </a:xfrm>
           <a:prstGeom prst="rect">
             <a:avLst/>
@@ -3313,28 +3344,28 @@
           </a:bodyPr>
           <a:lstStyle/>
           <a:p>
-            <a:pPr algn="r"/>
-            <a:r>
-              <a:rPr sz="900" b="0" i="0">
+            <a:pPr algn="l"/>
+            <a:r>
+              <a:rPr sz="1800" b="0">
                 <a:solidFill>
-                  <a:srgbClr val="4A5B53"/>
+                  <a:srgbClr val="5A6B63"/>
                 </a:solidFill>
-                <a:latin typeface="JetBrains Mono"/>
+                <a:latin typeface="Plus Jakarta Sans"/>
               </a:rPr>
-              <a:t>SECTOR: KEDARNATH VALLEY (30.73° N, 79.06° E)</a:t>
-            </a:r>
-          </a:p>
-        </p:txBody>
-      </p:sp>
-      <p:sp>
-        <p:nvSpPr>
-          <p:cNvPr id="8" name="Rectangle 7"/>
+              <a:t>Swarm Unified Tactical Reconnaissance Architecture for GPS-Denied and Jammed Mountain Environments.</a:t>
+            </a:r>
+          </a:p>
+        </p:txBody>
+      </p:sp>
+      <p:sp>
+        <p:nvSpPr>
+          <p:cNvPr id="9" name="Rectangle 8"/>
           <p:cNvSpPr/>
           <p:nvPr/>
         </p:nvSpPr>
         <p:spPr>
           <a:xfrm>
-            <a:off x="731520" y="960120"/>
+            <a:off x="731520" y="5943600"/>
             <a:ext cx="10728655" cy="13716"/>
           </a:xfrm>
           <a:prstGeom prst="rect">
@@ -3371,57 +3402,14 @@
       </p:sp>
       <p:sp>
         <p:nvSpPr>
-          <p:cNvPr id="9" name="Rectangle 8"/>
-          <p:cNvSpPr/>
-          <p:nvPr/>
-        </p:nvSpPr>
-        <p:spPr>
-          <a:xfrm>
-            <a:off x="731520" y="1645920"/>
-            <a:ext cx="548640" cy="27432"/>
-          </a:xfrm>
-          <a:prstGeom prst="rect">
-            <a:avLst/>
-          </a:prstGeom>
-          <a:solidFill>
-            <a:srgbClr val="9E4D34"/>
-          </a:solidFill>
-          <a:ln>
-            <a:noFill/>
-          </a:ln>
-        </p:spPr>
-        <p:style>
-          <a:lnRef idx="1">
-            <a:schemeClr val="accent1"/>
-          </a:lnRef>
-          <a:fillRef idx="3">
-            <a:schemeClr val="accent1"/>
-          </a:fillRef>
-          <a:effectRef idx="2">
-            <a:schemeClr val="accent1"/>
-          </a:effectRef>
-          <a:fontRef idx="minor">
-            <a:schemeClr val="lt1"/>
-          </a:fontRef>
-        </p:style>
-        <p:txBody>
-          <a:bodyPr rtlCol="0" anchor="ctr"/>
-          <a:lstStyle/>
-          <a:p>
-            <a:pPr algn="ctr"/>
-          </a:p>
-        </p:txBody>
-      </p:sp>
-      <p:sp>
-        <p:nvSpPr>
           <p:cNvPr id="10" name="TextBox 9"/>
           <p:cNvSpPr txBox="1"/>
           <p:nvPr/>
         </p:nvSpPr>
         <p:spPr>
           <a:xfrm>
-            <a:off x="1371600" y="1572768"/>
-            <a:ext cx="7315200" cy="228600"/>
+            <a:off x="731520" y="6080760"/>
+            <a:ext cx="5486400" cy="274320"/>
           </a:xfrm>
           <a:prstGeom prst="rect">
             <a:avLst/>
@@ -3436,13 +3424,13 @@
           <a:p>
             <a:pPr algn="l"/>
             <a:r>
-              <a:rPr sz="950" b="1" i="0">
+              <a:rPr sz="1000" b="1">
                 <a:solidFill>
-                  <a:srgbClr val="9E4D34"/>
+                  <a:srgbClr val="183A2B"/>
                 </a:solidFill>
                 <a:latin typeface="JetBrains Mono"/>
               </a:rPr>
-              <a:t>AUTONOMOUS MULTI-AGENT SWARM ARCHITECTURE</a:t>
+              <a:t>Nikhil Sai Kilani  •  Lead Architect</a:t>
             </a:r>
           </a:p>
         </p:txBody>
@@ -3455,8 +3443,8 @@
         </p:nvSpPr>
         <p:spPr>
           <a:xfrm>
-            <a:off x="731520" y="1920240"/>
-            <a:ext cx="10058400" cy="1097280"/>
+            <a:off x="7772400" y="6080760"/>
+            <a:ext cx="3657600" cy="274320"/>
           </a:xfrm>
           <a:prstGeom prst="rect">
             <a:avLst/>
@@ -3469,658 +3457,15 @@
           </a:bodyPr>
           <a:lstStyle/>
           <a:p>
-            <a:pPr algn="l"/>
-            <a:r>
-              <a:rPr sz="5800" b="1" i="0">
-                <a:solidFill>
-                  <a:srgbClr val="183A2B"/>
-                </a:solidFill>
-                <a:latin typeface="Plus Jakarta Sans"/>
-              </a:rPr>
-              <a:t>PROJECT SUTRA</a:t>
-            </a:r>
-          </a:p>
-        </p:txBody>
-      </p:sp>
-      <p:sp>
-        <p:nvSpPr>
-          <p:cNvPr id="12" name="TextBox 11"/>
-          <p:cNvSpPr txBox="1"/>
-          <p:nvPr/>
-        </p:nvSpPr>
-        <p:spPr>
-          <a:xfrm>
-            <a:off x="731520" y="3017520"/>
-            <a:ext cx="10058400" cy="457200"/>
-          </a:xfrm>
-          <a:prstGeom prst="rect">
-            <a:avLst/>
-          </a:prstGeom>
-          <a:noFill/>
-        </p:spPr>
-        <p:txBody>
-          <a:bodyPr wrap="square" lIns="0" tIns="0" rIns="0" bIns="0">
-            <a:spAutoFit/>
-          </a:bodyPr>
-          <a:lstStyle/>
-          <a:p>
-            <a:pPr algn="l"/>
-            <a:r>
-              <a:rPr sz="2000" b="1" i="1">
-                <a:solidFill>
-                  <a:srgbClr val="4A7A58"/>
-                </a:solidFill>
-                <a:latin typeface="Plus Jakarta Sans"/>
-              </a:rPr>
-              <a:t>Swarm Unified Tactical Reconnaissance Architecture</a:t>
-            </a:r>
-          </a:p>
-        </p:txBody>
-      </p:sp>
-      <p:sp>
-        <p:nvSpPr>
-          <p:cNvPr id="13" name="TextBox 12"/>
-          <p:cNvSpPr txBox="1"/>
-          <p:nvPr/>
-        </p:nvSpPr>
-        <p:spPr>
-          <a:xfrm>
-            <a:off x="731520" y="3566160"/>
-            <a:ext cx="9601200" cy="731520"/>
-          </a:xfrm>
-          <a:prstGeom prst="rect">
-            <a:avLst/>
-          </a:prstGeom>
-          <a:noFill/>
-        </p:spPr>
-        <p:txBody>
-          <a:bodyPr wrap="square" lIns="0" tIns="0" rIns="0" bIns="0">
-            <a:spAutoFit/>
-          </a:bodyPr>
-          <a:lstStyle/>
-          <a:p>
-            <a:pPr algn="l"/>
-            <a:r>
-              <a:rPr sz="1350" b="0" i="0">
-                <a:solidFill>
-                  <a:srgbClr val="4A5B53"/>
-                </a:solidFill>
-                <a:latin typeface="Plus Jakarta Sans"/>
-              </a:rPr>
-              <a:t>A decentralized, fault-tolerant multi-UAV swarm engineered from first principles for GPS-denied deep mountain valleys, -5 dB RF jamming resilience, and sub-meter survivor geolocation under dense forest canopies.</a:t>
-            </a:r>
-          </a:p>
-        </p:txBody>
-      </p:sp>
-      <p:sp>
-        <p:nvSpPr>
-          <p:cNvPr id="14" name="Rounded Rectangle 13"/>
-          <p:cNvSpPr/>
-          <p:nvPr/>
-        </p:nvSpPr>
-        <p:spPr>
-          <a:xfrm>
-            <a:off x="731520" y="4434840"/>
-            <a:ext cx="2514600" cy="1371600"/>
-          </a:xfrm>
-          <a:prstGeom prst="roundRect">
-            <a:avLst/>
-          </a:prstGeom>
-          <a:solidFill>
-            <a:srgbClr val="FFFFFF"/>
-          </a:solidFill>
-          <a:ln w="12700">
-            <a:solidFill>
-              <a:srgbClr val="EDE4D6"/>
-            </a:solidFill>
-          </a:ln>
-        </p:spPr>
-        <p:style>
-          <a:lnRef idx="1">
-            <a:schemeClr val="accent1"/>
-          </a:lnRef>
-          <a:fillRef idx="3">
-            <a:schemeClr val="accent1"/>
-          </a:fillRef>
-          <a:effectRef idx="2">
-            <a:schemeClr val="accent1"/>
-          </a:effectRef>
-          <a:fontRef idx="minor">
-            <a:schemeClr val="lt1"/>
-          </a:fontRef>
-        </p:style>
-        <p:txBody>
-          <a:bodyPr rtlCol="0" anchor="ctr"/>
-          <a:lstStyle/>
-          <a:p>
-            <a:pPr algn="ctr"/>
-          </a:p>
-        </p:txBody>
-      </p:sp>
-      <p:sp>
-        <p:nvSpPr>
-          <p:cNvPr id="15" name="TextBox 14"/>
-          <p:cNvSpPr txBox="1"/>
-          <p:nvPr/>
-        </p:nvSpPr>
-        <p:spPr>
-          <a:xfrm>
-            <a:off x="914400" y="4599432"/>
-            <a:ext cx="2148840" cy="274320"/>
-          </a:xfrm>
-          <a:prstGeom prst="rect">
-            <a:avLst/>
-          </a:prstGeom>
-          <a:noFill/>
-        </p:spPr>
-        <p:txBody>
-          <a:bodyPr wrap="square" lIns="0" tIns="0" rIns="0" bIns="0">
-            <a:spAutoFit/>
-          </a:bodyPr>
-          <a:lstStyle/>
-          <a:p>
-            <a:pPr algn="l"/>
-            <a:r>
-              <a:rPr sz="900" b="1" i="0">
+            <a:pPr algn="r"/>
+            <a:r>
+              <a:rPr sz="1000" b="1">
                 <a:solidFill>
                   <a:srgbClr val="183A2B"/>
                 </a:solidFill>
                 <a:latin typeface="JetBrains Mono"/>
               </a:rPr>
-              <a:t>01. AUTOPILOT &amp; GNC</a:t>
-            </a:r>
-          </a:p>
-        </p:txBody>
-      </p:sp>
-      <p:sp>
-        <p:nvSpPr>
-          <p:cNvPr id="16" name="TextBox 15"/>
-          <p:cNvSpPr txBox="1"/>
-          <p:nvPr/>
-        </p:nvSpPr>
-        <p:spPr>
-          <a:xfrm>
-            <a:off x="914400" y="4937760"/>
-            <a:ext cx="2148840" cy="731520"/>
-          </a:xfrm>
-          <a:prstGeom prst="rect">
-            <a:avLst/>
-          </a:prstGeom>
-          <a:noFill/>
-        </p:spPr>
-        <p:txBody>
-          <a:bodyPr wrap="square" lIns="0" tIns="0" rIns="0" bIns="0">
-            <a:spAutoFit/>
-          </a:bodyPr>
-          <a:lstStyle/>
-          <a:p>
-            <a:pPr algn="l"/>
-            <a:r>
-              <a:rPr sz="900" b="0" i="0">
-                <a:solidFill>
-                  <a:srgbClr val="4A5B53"/>
-                </a:solidFill>
-                <a:latin typeface="Plus Jakarta Sans"/>
-              </a:rPr>
-              <a:t>PX4 50Hz Offboard, 3D Voxel Cost-Volume &amp; ORCA 3D Collision Shield.</a:t>
-            </a:r>
-          </a:p>
-        </p:txBody>
-      </p:sp>
-      <p:sp>
-        <p:nvSpPr>
-          <p:cNvPr id="17" name="Rounded Rectangle 16"/>
-          <p:cNvSpPr/>
-          <p:nvPr/>
-        </p:nvSpPr>
-        <p:spPr>
-          <a:xfrm>
-            <a:off x="3465576" y="4434840"/>
-            <a:ext cx="2514600" cy="1371600"/>
-          </a:xfrm>
-          <a:prstGeom prst="roundRect">
-            <a:avLst/>
-          </a:prstGeom>
-          <a:solidFill>
-            <a:srgbClr val="FFFFFF"/>
-          </a:solidFill>
-          <a:ln w="12700">
-            <a:solidFill>
-              <a:srgbClr val="EDE4D6"/>
-            </a:solidFill>
-          </a:ln>
-        </p:spPr>
-        <p:style>
-          <a:lnRef idx="1">
-            <a:schemeClr val="accent1"/>
-          </a:lnRef>
-          <a:fillRef idx="3">
-            <a:schemeClr val="accent1"/>
-          </a:fillRef>
-          <a:effectRef idx="2">
-            <a:schemeClr val="accent1"/>
-          </a:effectRef>
-          <a:fontRef idx="minor">
-            <a:schemeClr val="lt1"/>
-          </a:fontRef>
-        </p:style>
-        <p:txBody>
-          <a:bodyPr rtlCol="0" anchor="ctr"/>
-          <a:lstStyle/>
-          <a:p>
-            <a:pPr algn="ctr"/>
-          </a:p>
-        </p:txBody>
-      </p:sp>
-      <p:sp>
-        <p:nvSpPr>
-          <p:cNvPr id="18" name="TextBox 17"/>
-          <p:cNvSpPr txBox="1"/>
-          <p:nvPr/>
-        </p:nvSpPr>
-        <p:spPr>
-          <a:xfrm>
-            <a:off x="3648456" y="4599432"/>
-            <a:ext cx="2148840" cy="274320"/>
-          </a:xfrm>
-          <a:prstGeom prst="rect">
-            <a:avLst/>
-          </a:prstGeom>
-          <a:noFill/>
-        </p:spPr>
-        <p:txBody>
-          <a:bodyPr wrap="square" lIns="0" tIns="0" rIns="0" bIns="0">
-            <a:spAutoFit/>
-          </a:bodyPr>
-          <a:lstStyle/>
-          <a:p>
-            <a:pPr algn="l"/>
-            <a:r>
-              <a:rPr sz="900" b="1" i="0">
-                <a:solidFill>
-                  <a:srgbClr val="9E4D34"/>
-                </a:solidFill>
-                <a:latin typeface="JetBrains Mono"/>
-              </a:rPr>
-              <a:t>02. NEURAL COMMS</a:t>
-            </a:r>
-          </a:p>
-        </p:txBody>
-      </p:sp>
-      <p:sp>
-        <p:nvSpPr>
-          <p:cNvPr id="19" name="TextBox 18"/>
-          <p:cNvSpPr txBox="1"/>
-          <p:nvPr/>
-        </p:nvSpPr>
-        <p:spPr>
-          <a:xfrm>
-            <a:off x="3648456" y="4937760"/>
-            <a:ext cx="2148840" cy="731520"/>
-          </a:xfrm>
-          <a:prstGeom prst="rect">
-            <a:avLst/>
-          </a:prstGeom>
-          <a:noFill/>
-        </p:spPr>
-        <p:txBody>
-          <a:bodyPr wrap="square" lIns="0" tIns="0" rIns="0" bIns="0">
-            <a:spAutoFit/>
-          </a:bodyPr>
-          <a:lstStyle/>
-          <a:p>
-            <a:pPr algn="l"/>
-            <a:r>
-              <a:rPr sz="900" b="0" i="0">
-                <a:solidFill>
-                  <a:srgbClr val="4A5B53"/>
-                </a:solidFill>
-                <a:latin typeface="Plus Jakarta Sans"/>
-              </a:rPr>
-              <a:t>Deep JSCC Autoencoder with 96.9% compression &amp; -5 dB jamming survival.</a:t>
-            </a:r>
-          </a:p>
-        </p:txBody>
-      </p:sp>
-      <p:sp>
-        <p:nvSpPr>
-          <p:cNvPr id="20" name="Rounded Rectangle 19"/>
-          <p:cNvSpPr/>
-          <p:nvPr/>
-        </p:nvSpPr>
-        <p:spPr>
-          <a:xfrm>
-            <a:off x="6199632" y="4434840"/>
-            <a:ext cx="2514600" cy="1371600"/>
-          </a:xfrm>
-          <a:prstGeom prst="roundRect">
-            <a:avLst/>
-          </a:prstGeom>
-          <a:solidFill>
-            <a:srgbClr val="FFFFFF"/>
-          </a:solidFill>
-          <a:ln w="12700">
-            <a:solidFill>
-              <a:srgbClr val="EDE4D6"/>
-            </a:solidFill>
-          </a:ln>
-        </p:spPr>
-        <p:style>
-          <a:lnRef idx="1">
-            <a:schemeClr val="accent1"/>
-          </a:lnRef>
-          <a:fillRef idx="3">
-            <a:schemeClr val="accent1"/>
-          </a:fillRef>
-          <a:effectRef idx="2">
-            <a:schemeClr val="accent1"/>
-          </a:effectRef>
-          <a:fontRef idx="minor">
-            <a:schemeClr val="lt1"/>
-          </a:fontRef>
-        </p:style>
-        <p:txBody>
-          <a:bodyPr rtlCol="0" anchor="ctr"/>
-          <a:lstStyle/>
-          <a:p>
-            <a:pPr algn="ctr"/>
-          </a:p>
-        </p:txBody>
-      </p:sp>
-      <p:sp>
-        <p:nvSpPr>
-          <p:cNvPr id="21" name="TextBox 20"/>
-          <p:cNvSpPr txBox="1"/>
-          <p:nvPr/>
-        </p:nvSpPr>
-        <p:spPr>
-          <a:xfrm>
-            <a:off x="6382512" y="4599432"/>
-            <a:ext cx="2148840" cy="274320"/>
-          </a:xfrm>
-          <a:prstGeom prst="rect">
-            <a:avLst/>
-          </a:prstGeom>
-          <a:noFill/>
-        </p:spPr>
-        <p:txBody>
-          <a:bodyPr wrap="square" lIns="0" tIns="0" rIns="0" bIns="0">
-            <a:spAutoFit/>
-          </a:bodyPr>
-          <a:lstStyle/>
-          <a:p>
-            <a:pPr algn="l"/>
-            <a:r>
-              <a:rPr sz="900" b="1" i="0">
-                <a:solidFill>
-                  <a:srgbClr val="4A7A58"/>
-                </a:solidFill>
-                <a:latin typeface="JetBrains Mono"/>
-              </a:rPr>
-              <a:t>03. AI PERCEPTION</a:t>
-            </a:r>
-          </a:p>
-        </p:txBody>
-      </p:sp>
-      <p:sp>
-        <p:nvSpPr>
-          <p:cNvPr id="22" name="TextBox 21"/>
-          <p:cNvSpPr txBox="1"/>
-          <p:nvPr/>
-        </p:nvSpPr>
-        <p:spPr>
-          <a:xfrm>
-            <a:off x="6382512" y="4937760"/>
-            <a:ext cx="2148840" cy="731520"/>
-          </a:xfrm>
-          <a:prstGeom prst="rect">
-            <a:avLst/>
-          </a:prstGeom>
-          <a:noFill/>
-        </p:spPr>
-        <p:txBody>
-          <a:bodyPr wrap="square" lIns="0" tIns="0" rIns="0" bIns="0">
-            <a:spAutoFit/>
-          </a:bodyPr>
-          <a:lstStyle/>
-          <a:p>
-            <a:pPr algn="l"/>
-            <a:r>
-              <a:rPr sz="900" b="0" i="0">
-                <a:solidFill>
-                  <a:srgbClr val="4A5B53"/>
-                </a:solidFill>
-                <a:latin typeface="Plus Jakarta Sans"/>
-              </a:rPr>
-              <a:t>Tri-Modal RGB/FLIR/mmWave with 3.59cm terrain-corrected DEM raycasting.</a:t>
-            </a:r>
-          </a:p>
-        </p:txBody>
-      </p:sp>
-      <p:sp>
-        <p:nvSpPr>
-          <p:cNvPr id="23" name="Rounded Rectangle 22"/>
-          <p:cNvSpPr/>
-          <p:nvPr/>
-        </p:nvSpPr>
-        <p:spPr>
-          <a:xfrm>
-            <a:off x="8933688" y="4434840"/>
-            <a:ext cx="2514600" cy="1371600"/>
-          </a:xfrm>
-          <a:prstGeom prst="roundRect">
-            <a:avLst/>
-          </a:prstGeom>
-          <a:solidFill>
-            <a:srgbClr val="FFFFFF"/>
-          </a:solidFill>
-          <a:ln w="12700">
-            <a:solidFill>
-              <a:srgbClr val="EDE4D6"/>
-            </a:solidFill>
-          </a:ln>
-        </p:spPr>
-        <p:style>
-          <a:lnRef idx="1">
-            <a:schemeClr val="accent1"/>
-          </a:lnRef>
-          <a:fillRef idx="3">
-            <a:schemeClr val="accent1"/>
-          </a:fillRef>
-          <a:effectRef idx="2">
-            <a:schemeClr val="accent1"/>
-          </a:effectRef>
-          <a:fontRef idx="minor">
-            <a:schemeClr val="lt1"/>
-          </a:fontRef>
-        </p:style>
-        <p:txBody>
-          <a:bodyPr rtlCol="0" anchor="ctr"/>
-          <a:lstStyle/>
-          <a:p>
-            <a:pPr algn="ctr"/>
-          </a:p>
-        </p:txBody>
-      </p:sp>
-      <p:sp>
-        <p:nvSpPr>
-          <p:cNvPr id="24" name="TextBox 23"/>
-          <p:cNvSpPr txBox="1"/>
-          <p:nvPr/>
-        </p:nvSpPr>
-        <p:spPr>
-          <a:xfrm>
-            <a:off x="9116568" y="4599432"/>
-            <a:ext cx="2148840" cy="274320"/>
-          </a:xfrm>
-          <a:prstGeom prst="rect">
-            <a:avLst/>
-          </a:prstGeom>
-          <a:noFill/>
-        </p:spPr>
-        <p:txBody>
-          <a:bodyPr wrap="square" lIns="0" tIns="0" rIns="0" bIns="0">
-            <a:spAutoFit/>
-          </a:bodyPr>
-          <a:lstStyle/>
-          <a:p>
-            <a:pPr algn="l"/>
-            <a:r>
-              <a:rPr sz="900" b="1" i="0">
-                <a:solidFill>
-                  <a:srgbClr val="2B6CB0"/>
-                </a:solidFill>
-                <a:latin typeface="JetBrains Mono"/>
-              </a:rPr>
-              <a:t>04. TACTICAL GCS</a:t>
-            </a:r>
-          </a:p>
-        </p:txBody>
-      </p:sp>
-      <p:sp>
-        <p:nvSpPr>
-          <p:cNvPr id="25" name="TextBox 24"/>
-          <p:cNvSpPr txBox="1"/>
-          <p:nvPr/>
-        </p:nvSpPr>
-        <p:spPr>
-          <a:xfrm>
-            <a:off x="9116568" y="4937760"/>
-            <a:ext cx="2148840" cy="731520"/>
-          </a:xfrm>
-          <a:prstGeom prst="rect">
-            <a:avLst/>
-          </a:prstGeom>
-          <a:noFill/>
-        </p:spPr>
-        <p:txBody>
-          <a:bodyPr wrap="square" lIns="0" tIns="0" rIns="0" bIns="0">
-            <a:spAutoFit/>
-          </a:bodyPr>
-          <a:lstStyle/>
-          <a:p>
-            <a:pPr algn="l"/>
-            <a:r>
-              <a:rPr sz="900" b="0" i="0">
-                <a:solidFill>
-                  <a:srgbClr val="4A5B53"/>
-                </a:solidFill>
-                <a:latin typeface="Plus Jakarta Sans"/>
-              </a:rPr>
-              <a:t>Pegasus 3D GIS with 60 FPS WebGPU pipeline &amp; MIL-STD-2525 ATAK CoT XML.</a:t>
-            </a:r>
-          </a:p>
-        </p:txBody>
-      </p:sp>
-      <p:sp>
-        <p:nvSpPr>
-          <p:cNvPr id="26" name="Rectangle 25"/>
-          <p:cNvSpPr/>
-          <p:nvPr/>
-        </p:nvSpPr>
-        <p:spPr>
-          <a:xfrm>
-            <a:off x="731520" y="6080760"/>
-            <a:ext cx="10728655" cy="13716"/>
-          </a:xfrm>
-          <a:prstGeom prst="rect">
-            <a:avLst/>
-          </a:prstGeom>
-          <a:solidFill>
-            <a:srgbClr val="EDE4D6"/>
-          </a:solidFill>
-          <a:ln>
-            <a:noFill/>
-          </a:ln>
-        </p:spPr>
-        <p:style>
-          <a:lnRef idx="1">
-            <a:schemeClr val="accent1"/>
-          </a:lnRef>
-          <a:fillRef idx="3">
-            <a:schemeClr val="accent1"/>
-          </a:fillRef>
-          <a:effectRef idx="2">
-            <a:schemeClr val="accent1"/>
-          </a:effectRef>
-          <a:fontRef idx="minor">
-            <a:schemeClr val="lt1"/>
-          </a:fontRef>
-        </p:style>
-        <p:txBody>
-          <a:bodyPr rtlCol="0" anchor="ctr"/>
-          <a:lstStyle/>
-          <a:p>
-            <a:pPr algn="ctr"/>
-          </a:p>
-        </p:txBody>
-      </p:sp>
-      <p:sp>
-        <p:nvSpPr>
-          <p:cNvPr id="27" name="TextBox 26"/>
-          <p:cNvSpPr txBox="1"/>
-          <p:nvPr/>
-        </p:nvSpPr>
-        <p:spPr>
-          <a:xfrm>
-            <a:off x="731520" y="6245352"/>
-            <a:ext cx="6858000" cy="274320"/>
-          </a:xfrm>
-          <a:prstGeom prst="rect">
-            <a:avLst/>
-          </a:prstGeom>
-          <a:noFill/>
-        </p:spPr>
-        <p:txBody>
-          <a:bodyPr wrap="square" lIns="0" tIns="0" rIns="0" bIns="0">
-            <a:spAutoFit/>
-          </a:bodyPr>
-          <a:lstStyle/>
-          <a:p>
-            <a:pPr algn="l"/>
-            <a:r>
-              <a:rPr sz="850" b="0" i="0">
-                <a:solidFill>
-                  <a:srgbClr val="4A5B53"/>
-                </a:solidFill>
-                <a:latin typeface="JetBrains Mono"/>
-              </a:rPr>
-              <a:t>Nikhil (Tech Lead) • Vedanth Sai Ram • Siva Kesava • Harika • Rohith Kumar</a:t>
-            </a:r>
-          </a:p>
-        </p:txBody>
-      </p:sp>
-      <p:sp>
-        <p:nvSpPr>
-          <p:cNvPr id="28" name="TextBox 27"/>
-          <p:cNvSpPr txBox="1"/>
-          <p:nvPr/>
-        </p:nvSpPr>
-        <p:spPr>
-          <a:xfrm>
-            <a:off x="7315200" y="6245352"/>
-            <a:ext cx="4144975" cy="274320"/>
-          </a:xfrm>
-          <a:prstGeom prst="rect">
-            <a:avLst/>
-          </a:prstGeom>
-          <a:noFill/>
-        </p:spPr>
-        <p:txBody>
-          <a:bodyPr wrap="square" lIns="0" tIns="0" rIns="0" bIns="0">
-            <a:spAutoFit/>
-          </a:bodyPr>
-          <a:lstStyle/>
-          <a:p>
-            <a:pPr algn="r"/>
-            <a:r>
-              <a:rPr sz="850" b="1" i="0">
-                <a:solidFill>
-                  <a:srgbClr val="183A2B"/>
-                </a:solidFill>
-                <a:latin typeface="JetBrains Mono"/>
-              </a:rPr>
-              <a:t>● NDMA / DARPA-TIER OPEN ARCHITECTURE · GRAND FINALS 2026</a:t>
+              <a:t>August 2026</a:t>
             </a:r>
           </a:p>
         </p:txBody>

</xml_diff>

<commit_message>
feat(title): add complete Team Offgrid roster with subsystem roles from Project SUTRA monorepo
</commit_message>
<xml_diff>
--- a/sutra_pitch_deck.pptx
+++ b/sutra_pitch_deck.pptx
@@ -3140,7 +3140,7 @@
         <p:spPr>
           <a:xfrm>
             <a:off x="731520" y="548640"/>
-            <a:ext cx="365760" cy="365760"/>
+            <a:ext cx="320040" cy="320040"/>
           </a:xfrm>
           <a:prstGeom prst="roundRect">
             <a:avLst/>
@@ -3182,8 +3182,8 @@
         </p:nvSpPr>
         <p:spPr>
           <a:xfrm>
-            <a:off x="1188720" y="621792"/>
-            <a:ext cx="3657600" cy="274320"/>
+            <a:off x="1143000" y="594360"/>
+            <a:ext cx="5029200" cy="274320"/>
           </a:xfrm>
           <a:prstGeom prst="rect">
             <a:avLst/>
@@ -3198,13 +3198,13 @@
           <a:p>
             <a:pPr algn="l"/>
             <a:r>
-              <a:rPr sz="900" b="1">
+              <a:rPr sz="950" b="1">
                 <a:solidFill>
                   <a:srgbClr val="5A6B63"/>
                 </a:solidFill>
                 <a:latin typeface="JetBrains Mono"/>
               </a:rPr>
-              <a:t>DEFENSE &amp; DISASTER ROBOTICS</a:t>
+              <a:t>TEAM OFFGRID  •  DEFENSE &amp; DISASTER ROBOTICS</a:t>
             </a:r>
           </a:p>
         </p:txBody>
@@ -3217,7 +3217,42 @@
         </p:nvSpPr>
         <p:spPr>
           <a:xfrm>
-            <a:off x="731520" y="2377440"/>
+            <a:off x="7772400" y="594360"/>
+            <a:ext cx="3657600" cy="274320"/>
+          </a:xfrm>
+          <a:prstGeom prst="rect">
+            <a:avLst/>
+          </a:prstGeom>
+          <a:noFill/>
+        </p:spPr>
+        <p:txBody>
+          <a:bodyPr wrap="square" lIns="0" tIns="0" rIns="0" bIns="0">
+            <a:spAutoFit/>
+          </a:bodyPr>
+          <a:lstStyle/>
+          <a:p>
+            <a:pPr algn="r"/>
+            <a:r>
+              <a:rPr sz="950" b="1">
+                <a:solidFill>
+                  <a:srgbClr val="5A6B63"/>
+                </a:solidFill>
+                <a:latin typeface="JetBrains Mono"/>
+              </a:rPr>
+              <a:t>August 2026</a:t>
+            </a:r>
+          </a:p>
+        </p:txBody>
+      </p:sp>
+      <p:sp>
+        <p:nvSpPr>
+          <p:cNvPr id="6" name="TextBox 5"/>
+          <p:cNvSpPr txBox="1"/>
+          <p:nvPr/>
+        </p:nvSpPr>
+        <p:spPr>
+          <a:xfrm>
+            <a:off x="731520" y="2194560"/>
             <a:ext cx="9144000" cy="274320"/>
           </a:xfrm>
           <a:prstGeom prst="rect">
@@ -3246,13 +3281,13 @@
       </p:sp>
       <p:sp>
         <p:nvSpPr>
-          <p:cNvPr id="6" name="Rectangle 5"/>
+          <p:cNvPr id="7" name="Rectangle 6"/>
           <p:cNvSpPr/>
           <p:nvPr/>
         </p:nvSpPr>
         <p:spPr>
           <a:xfrm>
-            <a:off x="731520" y="2743200"/>
+            <a:off x="731520" y="2542032"/>
             <a:ext cx="1097280" cy="32004"/>
           </a:xfrm>
           <a:prstGeom prst="rect">
@@ -3289,13 +3324,13 @@
       </p:sp>
       <p:sp>
         <p:nvSpPr>
-          <p:cNvPr id="7" name="TextBox 6"/>
+          <p:cNvPr id="8" name="TextBox 7"/>
           <p:cNvSpPr txBox="1"/>
           <p:nvPr/>
         </p:nvSpPr>
         <p:spPr>
           <a:xfrm>
-            <a:off x="731520" y="2971800"/>
+            <a:off x="731520" y="2788920"/>
             <a:ext cx="10058400" cy="1097280"/>
           </a:xfrm>
           <a:prstGeom prst="rect">
@@ -3311,7 +3346,7 @@
           <a:p>
             <a:pPr algn="l"/>
             <a:r>
-              <a:rPr sz="5400" b="1">
+              <a:rPr sz="5600" b="1">
                 <a:solidFill>
                   <a:srgbClr val="183A2B"/>
                 </a:solidFill>
@@ -3324,14 +3359,14 @@
       </p:sp>
       <p:sp>
         <p:nvSpPr>
-          <p:cNvPr id="8" name="TextBox 7"/>
+          <p:cNvPr id="9" name="TextBox 8"/>
           <p:cNvSpPr txBox="1"/>
           <p:nvPr/>
         </p:nvSpPr>
         <p:spPr>
           <a:xfrm>
-            <a:off x="731520" y="4114800"/>
-            <a:ext cx="7772400" cy="731520"/>
+            <a:off x="731520" y="3931920"/>
+            <a:ext cx="8229600" cy="731520"/>
           </a:xfrm>
           <a:prstGeom prst="rect">
             <a:avLst/>
@@ -3346,7 +3381,7 @@
           <a:p>
             <a:pPr algn="l"/>
             <a:r>
-              <a:rPr sz="1800" b="0">
+              <a:rPr sz="1700" b="0">
                 <a:solidFill>
                   <a:srgbClr val="5A6B63"/>
                 </a:solidFill>
@@ -3359,13 +3394,13 @@
       </p:sp>
       <p:sp>
         <p:nvSpPr>
-          <p:cNvPr id="9" name="Rectangle 8"/>
+          <p:cNvPr id="10" name="Rectangle 9"/>
           <p:cNvSpPr/>
           <p:nvPr/>
         </p:nvSpPr>
         <p:spPr>
           <a:xfrm>
-            <a:off x="731520" y="5943600"/>
+            <a:off x="731520" y="5349240"/>
             <a:ext cx="10728655" cy="13716"/>
           </a:xfrm>
           <a:prstGeom prst="rect">
@@ -3402,14 +3437,49 @@
       </p:sp>
       <p:sp>
         <p:nvSpPr>
-          <p:cNvPr id="10" name="TextBox 9"/>
+          <p:cNvPr id="11" name="TextBox 10"/>
           <p:cNvSpPr txBox="1"/>
           <p:nvPr/>
         </p:nvSpPr>
         <p:spPr>
           <a:xfrm>
-            <a:off x="731520" y="6080760"/>
-            <a:ext cx="5486400" cy="274320"/>
+            <a:off x="731520" y="5486400"/>
+            <a:ext cx="7315200" cy="228600"/>
+          </a:xfrm>
+          <a:prstGeom prst="rect">
+            <a:avLst/>
+          </a:prstGeom>
+          <a:noFill/>
+        </p:spPr>
+        <p:txBody>
+          <a:bodyPr wrap="square" lIns="0" tIns="0" rIns="0" bIns="0">
+            <a:spAutoFit/>
+          </a:bodyPr>
+          <a:lstStyle/>
+          <a:p>
+            <a:pPr algn="l"/>
+            <a:r>
+              <a:rPr sz="850" b="1">
+                <a:solidFill>
+                  <a:srgbClr val="9E4D34"/>
+                </a:solidFill>
+                <a:latin typeface="JetBrains Mono"/>
+              </a:rPr>
+              <a:t>CORE ARCHITECTURE TEAM (TEAM OFFGRID)</a:t>
+            </a:r>
+          </a:p>
+        </p:txBody>
+      </p:sp>
+      <p:sp>
+        <p:nvSpPr>
+          <p:cNvPr id="12" name="TextBox 11"/>
+          <p:cNvSpPr txBox="1"/>
+          <p:nvPr/>
+        </p:nvSpPr>
+        <p:spPr>
+          <a:xfrm>
+            <a:off x="731520" y="5760720"/>
+            <a:ext cx="2011680" cy="228600"/>
           </a:xfrm>
           <a:prstGeom prst="rect">
             <a:avLst/>
@@ -3430,21 +3500,21 @@
                 </a:solidFill>
                 <a:latin typeface="JetBrains Mono"/>
               </a:rPr>
-              <a:t>Nikhil Sai Kilani  •  Lead Architect</a:t>
-            </a:r>
-          </a:p>
-        </p:txBody>
-      </p:sp>
-      <p:sp>
-        <p:nvSpPr>
-          <p:cNvPr id="11" name="TextBox 10"/>
+              <a:t>Nikhil</a:t>
+            </a:r>
+          </a:p>
+        </p:txBody>
+      </p:sp>
+      <p:sp>
+        <p:nvSpPr>
+          <p:cNvPr id="13" name="TextBox 12"/>
           <p:cNvSpPr txBox="1"/>
           <p:nvPr/>
         </p:nvSpPr>
         <p:spPr>
           <a:xfrm>
-            <a:off x="7772400" y="6080760"/>
-            <a:ext cx="3657600" cy="274320"/>
+            <a:off x="731520" y="5989320"/>
+            <a:ext cx="2011680" cy="201168"/>
           </a:xfrm>
           <a:prstGeom prst="rect">
             <a:avLst/>
@@ -3457,7 +3527,77 @@
           </a:bodyPr>
           <a:lstStyle/>
           <a:p>
-            <a:pPr algn="r"/>
+            <a:pPr algn="l"/>
+            <a:r>
+              <a:rPr sz="800" b="0">
+                <a:solidFill>
+                  <a:srgbClr val="5A6B63"/>
+                </a:solidFill>
+                <a:latin typeface="JetBrains Mono"/>
+              </a:rPr>
+              <a:t>Tech Lead · Subsys A &amp; B</a:t>
+            </a:r>
+          </a:p>
+        </p:txBody>
+      </p:sp>
+      <p:sp>
+        <p:nvSpPr>
+          <p:cNvPr id="14" name="TextBox 13"/>
+          <p:cNvSpPr txBox="1"/>
+          <p:nvPr/>
+        </p:nvSpPr>
+        <p:spPr>
+          <a:xfrm>
+            <a:off x="731520" y="6190488"/>
+            <a:ext cx="2011680" cy="201168"/>
+          </a:xfrm>
+          <a:prstGeom prst="rect">
+            <a:avLst/>
+          </a:prstGeom>
+          <a:noFill/>
+        </p:spPr>
+        <p:txBody>
+          <a:bodyPr wrap="square" lIns="0" tIns="0" rIns="0" bIns="0">
+            <a:spAutoFit/>
+          </a:bodyPr>
+          <a:lstStyle/>
+          <a:p>
+            <a:pPr algn="l"/>
+            <a:r>
+              <a:rPr sz="750" b="1">
+                <a:solidFill>
+                  <a:srgbClr val="4A7A58"/>
+                </a:solidFill>
+                <a:latin typeface="JetBrains Mono"/>
+              </a:rPr>
+              <a:t>GNC, FSD &amp; Deep JSCC</a:t>
+            </a:r>
+          </a:p>
+        </p:txBody>
+      </p:sp>
+      <p:sp>
+        <p:nvSpPr>
+          <p:cNvPr id="15" name="TextBox 14"/>
+          <p:cNvSpPr txBox="1"/>
+          <p:nvPr/>
+        </p:nvSpPr>
+        <p:spPr>
+          <a:xfrm>
+            <a:off x="2907792" y="5760720"/>
+            <a:ext cx="2011680" cy="228600"/>
+          </a:xfrm>
+          <a:prstGeom prst="rect">
+            <a:avLst/>
+          </a:prstGeom>
+          <a:noFill/>
+        </p:spPr>
+        <p:txBody>
+          <a:bodyPr wrap="square" lIns="0" tIns="0" rIns="0" bIns="0">
+            <a:spAutoFit/>
+          </a:bodyPr>
+          <a:lstStyle/>
+          <a:p>
+            <a:pPr algn="l"/>
             <a:r>
               <a:rPr sz="1000" b="1">
                 <a:solidFill>
@@ -3465,7 +3605,392 @@
                 </a:solidFill>
                 <a:latin typeface="JetBrains Mono"/>
               </a:rPr>
-              <a:t>August 2026</a:t>
+              <a:t>Vedanth Sai Ram</a:t>
+            </a:r>
+          </a:p>
+        </p:txBody>
+      </p:sp>
+      <p:sp>
+        <p:nvSpPr>
+          <p:cNvPr id="16" name="TextBox 15"/>
+          <p:cNvSpPr txBox="1"/>
+          <p:nvPr/>
+        </p:nvSpPr>
+        <p:spPr>
+          <a:xfrm>
+            <a:off x="2907792" y="5989320"/>
+            <a:ext cx="2011680" cy="201168"/>
+          </a:xfrm>
+          <a:prstGeom prst="rect">
+            <a:avLst/>
+          </a:prstGeom>
+          <a:noFill/>
+        </p:spPr>
+        <p:txBody>
+          <a:bodyPr wrap="square" lIns="0" tIns="0" rIns="0" bIns="0">
+            <a:spAutoFit/>
+          </a:bodyPr>
+          <a:lstStyle/>
+          <a:p>
+            <a:pPr algn="l"/>
+            <a:r>
+              <a:rPr sz="800" b="0">
+                <a:solidFill>
+                  <a:srgbClr val="5A6B63"/>
+                </a:solidFill>
+                <a:latin typeface="JetBrains Mono"/>
+              </a:rPr>
+              <a:t>Lead · Subsystem C</a:t>
+            </a:r>
+          </a:p>
+        </p:txBody>
+      </p:sp>
+      <p:sp>
+        <p:nvSpPr>
+          <p:cNvPr id="17" name="TextBox 16"/>
+          <p:cNvSpPr txBox="1"/>
+          <p:nvPr/>
+        </p:nvSpPr>
+        <p:spPr>
+          <a:xfrm>
+            <a:off x="2907792" y="6190488"/>
+            <a:ext cx="2011680" cy="201168"/>
+          </a:xfrm>
+          <a:prstGeom prst="rect">
+            <a:avLst/>
+          </a:prstGeom>
+          <a:noFill/>
+        </p:spPr>
+        <p:txBody>
+          <a:bodyPr wrap="square" lIns="0" tIns="0" rIns="0" bIns="0">
+            <a:spAutoFit/>
+          </a:bodyPr>
+          <a:lstStyle/>
+          <a:p>
+            <a:pPr algn="l"/>
+            <a:r>
+              <a:rPr sz="750" b="1">
+                <a:solidFill>
+                  <a:srgbClr val="4A7A58"/>
+                </a:solidFill>
+                <a:latin typeface="JetBrains Mono"/>
+              </a:rPr>
+              <a:t>Tri-Modal AI &amp; Geolocation</a:t>
+            </a:r>
+          </a:p>
+        </p:txBody>
+      </p:sp>
+      <p:sp>
+        <p:nvSpPr>
+          <p:cNvPr id="18" name="TextBox 17"/>
+          <p:cNvSpPr txBox="1"/>
+          <p:nvPr/>
+        </p:nvSpPr>
+        <p:spPr>
+          <a:xfrm>
+            <a:off x="5084064" y="5760720"/>
+            <a:ext cx="2011680" cy="228600"/>
+          </a:xfrm>
+          <a:prstGeom prst="rect">
+            <a:avLst/>
+          </a:prstGeom>
+          <a:noFill/>
+        </p:spPr>
+        <p:txBody>
+          <a:bodyPr wrap="square" lIns="0" tIns="0" rIns="0" bIns="0">
+            <a:spAutoFit/>
+          </a:bodyPr>
+          <a:lstStyle/>
+          <a:p>
+            <a:pPr algn="l"/>
+            <a:r>
+              <a:rPr sz="1000" b="1">
+                <a:solidFill>
+                  <a:srgbClr val="183A2B"/>
+                </a:solidFill>
+                <a:latin typeface="JetBrains Mono"/>
+              </a:rPr>
+              <a:t>Siva Kesava</a:t>
+            </a:r>
+          </a:p>
+        </p:txBody>
+      </p:sp>
+      <p:sp>
+        <p:nvSpPr>
+          <p:cNvPr id="19" name="TextBox 18"/>
+          <p:cNvSpPr txBox="1"/>
+          <p:nvPr/>
+        </p:nvSpPr>
+        <p:spPr>
+          <a:xfrm>
+            <a:off x="5084064" y="5989320"/>
+            <a:ext cx="2011680" cy="201168"/>
+          </a:xfrm>
+          <a:prstGeom prst="rect">
+            <a:avLst/>
+          </a:prstGeom>
+          <a:noFill/>
+        </p:spPr>
+        <p:txBody>
+          <a:bodyPr wrap="square" lIns="0" tIns="0" rIns="0" bIns="0">
+            <a:spAutoFit/>
+          </a:bodyPr>
+          <a:lstStyle/>
+          <a:p>
+            <a:pPr algn="l"/>
+            <a:r>
+              <a:rPr sz="800" b="0">
+                <a:solidFill>
+                  <a:srgbClr val="5A6B63"/>
+                </a:solidFill>
+                <a:latin typeface="JetBrains Mono"/>
+              </a:rPr>
+              <a:t>Lead · Subsystem D</a:t>
+            </a:r>
+          </a:p>
+        </p:txBody>
+      </p:sp>
+      <p:sp>
+        <p:nvSpPr>
+          <p:cNvPr id="20" name="TextBox 19"/>
+          <p:cNvSpPr txBox="1"/>
+          <p:nvPr/>
+        </p:nvSpPr>
+        <p:spPr>
+          <a:xfrm>
+            <a:off x="5084064" y="6190488"/>
+            <a:ext cx="2011680" cy="201168"/>
+          </a:xfrm>
+          <a:prstGeom prst="rect">
+            <a:avLst/>
+          </a:prstGeom>
+          <a:noFill/>
+        </p:spPr>
+        <p:txBody>
+          <a:bodyPr wrap="square" lIns="0" tIns="0" rIns="0" bIns="0">
+            <a:spAutoFit/>
+          </a:bodyPr>
+          <a:lstStyle/>
+          <a:p>
+            <a:pPr algn="l"/>
+            <a:r>
+              <a:rPr sz="750" b="1">
+                <a:solidFill>
+                  <a:srgbClr val="4A7A58"/>
+                </a:solidFill>
+                <a:latin typeface="JetBrains Mono"/>
+              </a:rPr>
+              <a:t>3D GIS GCS &amp; WebGPU</a:t>
+            </a:r>
+          </a:p>
+        </p:txBody>
+      </p:sp>
+      <p:sp>
+        <p:nvSpPr>
+          <p:cNvPr id="21" name="TextBox 20"/>
+          <p:cNvSpPr txBox="1"/>
+          <p:nvPr/>
+        </p:nvSpPr>
+        <p:spPr>
+          <a:xfrm>
+            <a:off x="7260336" y="5760720"/>
+            <a:ext cx="2011680" cy="228600"/>
+          </a:xfrm>
+          <a:prstGeom prst="rect">
+            <a:avLst/>
+          </a:prstGeom>
+          <a:noFill/>
+        </p:spPr>
+        <p:txBody>
+          <a:bodyPr wrap="square" lIns="0" tIns="0" rIns="0" bIns="0">
+            <a:spAutoFit/>
+          </a:bodyPr>
+          <a:lstStyle/>
+          <a:p>
+            <a:pPr algn="l"/>
+            <a:r>
+              <a:rPr sz="1000" b="1">
+                <a:solidFill>
+                  <a:srgbClr val="183A2B"/>
+                </a:solidFill>
+                <a:latin typeface="JetBrains Mono"/>
+              </a:rPr>
+              <a:t>Harika</a:t>
+            </a:r>
+          </a:p>
+        </p:txBody>
+      </p:sp>
+      <p:sp>
+        <p:nvSpPr>
+          <p:cNvPr id="22" name="TextBox 21"/>
+          <p:cNvSpPr txBox="1"/>
+          <p:nvPr/>
+        </p:nvSpPr>
+        <p:spPr>
+          <a:xfrm>
+            <a:off x="7260336" y="5989320"/>
+            <a:ext cx="2011680" cy="201168"/>
+          </a:xfrm>
+          <a:prstGeom prst="rect">
+            <a:avLst/>
+          </a:prstGeom>
+          <a:noFill/>
+        </p:spPr>
+        <p:txBody>
+          <a:bodyPr wrap="square" lIns="0" tIns="0" rIns="0" bIns="0">
+            <a:spAutoFit/>
+          </a:bodyPr>
+          <a:lstStyle/>
+          <a:p>
+            <a:pPr algn="l"/>
+            <a:r>
+              <a:rPr sz="800" b="0">
+                <a:solidFill>
+                  <a:srgbClr val="5A6B63"/>
+                </a:solidFill>
+                <a:latin typeface="JetBrains Mono"/>
+              </a:rPr>
+              <a:t>Lead · Subsystem E</a:t>
+            </a:r>
+          </a:p>
+        </p:txBody>
+      </p:sp>
+      <p:sp>
+        <p:nvSpPr>
+          <p:cNvPr id="23" name="TextBox 22"/>
+          <p:cNvSpPr txBox="1"/>
+          <p:nvPr/>
+        </p:nvSpPr>
+        <p:spPr>
+          <a:xfrm>
+            <a:off x="7260336" y="6190488"/>
+            <a:ext cx="2011680" cy="201168"/>
+          </a:xfrm>
+          <a:prstGeom prst="rect">
+            <a:avLst/>
+          </a:prstGeom>
+          <a:noFill/>
+        </p:spPr>
+        <p:txBody>
+          <a:bodyPr wrap="square" lIns="0" tIns="0" rIns="0" bIns="0">
+            <a:spAutoFit/>
+          </a:bodyPr>
+          <a:lstStyle/>
+          <a:p>
+            <a:pPr algn="l"/>
+            <a:r>
+              <a:rPr sz="750" b="1">
+                <a:solidFill>
+                  <a:srgbClr val="4A7A58"/>
+                </a:solidFill>
+                <a:latin typeface="JetBrains Mono"/>
+              </a:rPr>
+              <a:t>Verification &amp; Pitch QA</a:t>
+            </a:r>
+          </a:p>
+        </p:txBody>
+      </p:sp>
+      <p:sp>
+        <p:nvSpPr>
+          <p:cNvPr id="24" name="TextBox 23"/>
+          <p:cNvSpPr txBox="1"/>
+          <p:nvPr/>
+        </p:nvSpPr>
+        <p:spPr>
+          <a:xfrm>
+            <a:off x="9436608" y="5760720"/>
+            <a:ext cx="2011680" cy="228600"/>
+          </a:xfrm>
+          <a:prstGeom prst="rect">
+            <a:avLst/>
+          </a:prstGeom>
+          <a:noFill/>
+        </p:spPr>
+        <p:txBody>
+          <a:bodyPr wrap="square" lIns="0" tIns="0" rIns="0" bIns="0">
+            <a:spAutoFit/>
+          </a:bodyPr>
+          <a:lstStyle/>
+          <a:p>
+            <a:pPr algn="l"/>
+            <a:r>
+              <a:rPr sz="1000" b="1">
+                <a:solidFill>
+                  <a:srgbClr val="183A2B"/>
+                </a:solidFill>
+                <a:latin typeface="JetBrains Mono"/>
+              </a:rPr>
+              <a:t>Rohith Kumar</a:t>
+            </a:r>
+          </a:p>
+        </p:txBody>
+      </p:sp>
+      <p:sp>
+        <p:nvSpPr>
+          <p:cNvPr id="25" name="TextBox 24"/>
+          <p:cNvSpPr txBox="1"/>
+          <p:nvPr/>
+        </p:nvSpPr>
+        <p:spPr>
+          <a:xfrm>
+            <a:off x="9436608" y="5989320"/>
+            <a:ext cx="2011680" cy="201168"/>
+          </a:xfrm>
+          <a:prstGeom prst="rect">
+            <a:avLst/>
+          </a:prstGeom>
+          <a:noFill/>
+        </p:spPr>
+        <p:txBody>
+          <a:bodyPr wrap="square" lIns="0" tIns="0" rIns="0" bIns="0">
+            <a:spAutoFit/>
+          </a:bodyPr>
+          <a:lstStyle/>
+          <a:p>
+            <a:pPr algn="l"/>
+            <a:r>
+              <a:rPr sz="800" b="0">
+                <a:solidFill>
+                  <a:srgbClr val="5A6B63"/>
+                </a:solidFill>
+                <a:latin typeface="JetBrains Mono"/>
+              </a:rPr>
+              <a:t>Lead · Subsystem F</a:t>
+            </a:r>
+          </a:p>
+        </p:txBody>
+      </p:sp>
+      <p:sp>
+        <p:nvSpPr>
+          <p:cNvPr id="26" name="TextBox 25"/>
+          <p:cNvSpPr txBox="1"/>
+          <p:nvPr/>
+        </p:nvSpPr>
+        <p:spPr>
+          <a:xfrm>
+            <a:off x="9436608" y="6190488"/>
+            <a:ext cx="2011680" cy="201168"/>
+          </a:xfrm>
+          <a:prstGeom prst="rect">
+            <a:avLst/>
+          </a:prstGeom>
+          <a:noFill/>
+        </p:spPr>
+        <p:txBody>
+          <a:bodyPr wrap="square" lIns="0" tIns="0" rIns="0" bIns="0">
+            <a:spAutoFit/>
+          </a:bodyPr>
+          <a:lstStyle/>
+          <a:p>
+            <a:pPr algn="l"/>
+            <a:r>
+              <a:rPr sz="750" b="1">
+                <a:solidFill>
+                  <a:srgbClr val="4A7A58"/>
+                </a:solidFill>
+                <a:latin typeface="JetBrains Mono"/>
+              </a:rPr>
+              <a:t>NDMA CONOPS &amp; Ops</a:t>
             </a:r>
           </a:p>
         </p:txBody>

</xml_diff>

<commit_message>
feat(title): implement #070707 and #FFFFFF black & white minimalism with radial dot matrix
</commit_message>
<xml_diff>
--- a/sutra_pitch_deck.pptx
+++ b/sutra_pitch_deck.pptx
@@ -3103,7 +3103,7 @@
             <a:avLst/>
           </a:prstGeom>
           <a:solidFill>
-            <a:srgbClr val="FAF7F2"/>
+            <a:srgbClr val="070707"/>
           </a:solidFill>
           <a:ln>
             <a:noFill/>
@@ -3146,7 +3146,7 @@
             <a:avLst/>
           </a:prstGeom>
           <a:solidFill>
-            <a:srgbClr val="DCD3C4"/>
+            <a:srgbClr val="2A2A2A"/>
           </a:solidFill>
           <a:ln>
             <a:noFill/>
@@ -3189,7 +3189,7 @@
             <a:avLst/>
           </a:prstGeom>
           <a:solidFill>
-            <a:srgbClr val="DCD3C4"/>
+            <a:srgbClr val="2A2A2A"/>
           </a:solidFill>
           <a:ln>
             <a:noFill/>
@@ -3232,7 +3232,7 @@
             <a:avLst/>
           </a:prstGeom>
           <a:solidFill>
-            <a:srgbClr val="DCD3C4"/>
+            <a:srgbClr val="2A2A2A"/>
           </a:solidFill>
           <a:ln>
             <a:noFill/>
@@ -3275,7 +3275,7 @@
             <a:avLst/>
           </a:prstGeom>
           <a:solidFill>
-            <a:srgbClr val="DCD3C4"/>
+            <a:srgbClr val="2A2A2A"/>
           </a:solidFill>
           <a:ln>
             <a:noFill/>
@@ -3318,7 +3318,7 @@
             <a:avLst/>
           </a:prstGeom>
           <a:solidFill>
-            <a:srgbClr val="DCD3C4"/>
+            <a:srgbClr val="2A2A2A"/>
           </a:solidFill>
           <a:ln>
             <a:noFill/>
@@ -3361,7 +3361,7 @@
             <a:avLst/>
           </a:prstGeom>
           <a:solidFill>
-            <a:srgbClr val="DCD3C4"/>
+            <a:srgbClr val="2A2A2A"/>
           </a:solidFill>
           <a:ln>
             <a:noFill/>
@@ -3404,7 +3404,7 @@
             <a:avLst/>
           </a:prstGeom>
           <a:solidFill>
-            <a:srgbClr val="DCD3C4"/>
+            <a:srgbClr val="2A2A2A"/>
           </a:solidFill>
           <a:ln>
             <a:noFill/>
@@ -3447,7 +3447,7 @@
             <a:avLst/>
           </a:prstGeom>
           <a:solidFill>
-            <a:srgbClr val="DCD3C4"/>
+            <a:srgbClr val="2A2A2A"/>
           </a:solidFill>
           <a:ln>
             <a:noFill/>
@@ -3490,7 +3490,7 @@
             <a:avLst/>
           </a:prstGeom>
           <a:solidFill>
-            <a:srgbClr val="DCD3C4"/>
+            <a:srgbClr val="2A2A2A"/>
           </a:solidFill>
           <a:ln>
             <a:noFill/>
@@ -3533,7 +3533,7 @@
             <a:avLst/>
           </a:prstGeom>
           <a:solidFill>
-            <a:srgbClr val="DCD3C4"/>
+            <a:srgbClr val="2A2A2A"/>
           </a:solidFill>
           <a:ln>
             <a:noFill/>
@@ -3576,7 +3576,7 @@
             <a:avLst/>
           </a:prstGeom>
           <a:solidFill>
-            <a:srgbClr val="DCD3C4"/>
+            <a:srgbClr val="2A2A2A"/>
           </a:solidFill>
           <a:ln>
             <a:noFill/>
@@ -3619,7 +3619,7 @@
             <a:avLst/>
           </a:prstGeom>
           <a:solidFill>
-            <a:srgbClr val="DCD3C4"/>
+            <a:srgbClr val="2A2A2A"/>
           </a:solidFill>
           <a:ln>
             <a:noFill/>
@@ -3662,7 +3662,7 @@
             <a:avLst/>
           </a:prstGeom>
           <a:solidFill>
-            <a:srgbClr val="DCD3C4"/>
+            <a:srgbClr val="2A2A2A"/>
           </a:solidFill>
           <a:ln>
             <a:noFill/>
@@ -3705,7 +3705,7 @@
             <a:avLst/>
           </a:prstGeom>
           <a:solidFill>
-            <a:srgbClr val="DCD3C4"/>
+            <a:srgbClr val="2A2A2A"/>
           </a:solidFill>
           <a:ln>
             <a:noFill/>
@@ -3748,7 +3748,7 @@
             <a:avLst/>
           </a:prstGeom>
           <a:solidFill>
-            <a:srgbClr val="DCD3C4"/>
+            <a:srgbClr val="2A2A2A"/>
           </a:solidFill>
           <a:ln>
             <a:noFill/>
@@ -3791,7 +3791,7 @@
             <a:avLst/>
           </a:prstGeom>
           <a:solidFill>
-            <a:srgbClr val="DCD3C4"/>
+            <a:srgbClr val="2A2A2A"/>
           </a:solidFill>
           <a:ln>
             <a:noFill/>
@@ -3834,7 +3834,7 @@
             <a:avLst/>
           </a:prstGeom>
           <a:solidFill>
-            <a:srgbClr val="DCD3C4"/>
+            <a:srgbClr val="2A2A2A"/>
           </a:solidFill>
           <a:ln>
             <a:noFill/>
@@ -3877,7 +3877,7 @@
             <a:avLst/>
           </a:prstGeom>
           <a:solidFill>
-            <a:srgbClr val="DCD3C4"/>
+            <a:srgbClr val="2A2A2A"/>
           </a:solidFill>
           <a:ln>
             <a:noFill/>
@@ -3920,7 +3920,7 @@
             <a:avLst/>
           </a:prstGeom>
           <a:solidFill>
-            <a:srgbClr val="DCD3C4"/>
+            <a:srgbClr val="2A2A2A"/>
           </a:solidFill>
           <a:ln>
             <a:noFill/>
@@ -3963,7 +3963,7 @@
             <a:avLst/>
           </a:prstGeom>
           <a:solidFill>
-            <a:srgbClr val="DCD3C4"/>
+            <a:srgbClr val="2A2A2A"/>
           </a:solidFill>
           <a:ln>
             <a:noFill/>
@@ -4006,7 +4006,7 @@
             <a:avLst/>
           </a:prstGeom>
           <a:solidFill>
-            <a:srgbClr val="DCD3C4"/>
+            <a:srgbClr val="2A2A2A"/>
           </a:solidFill>
           <a:ln>
             <a:noFill/>
@@ -4049,7 +4049,7 @@
             <a:avLst/>
           </a:prstGeom>
           <a:solidFill>
-            <a:srgbClr val="DCD3C4"/>
+            <a:srgbClr val="2A2A2A"/>
           </a:solidFill>
           <a:ln>
             <a:noFill/>
@@ -4092,7 +4092,7 @@
             <a:avLst/>
           </a:prstGeom>
           <a:solidFill>
-            <a:srgbClr val="DCD3C4"/>
+            <a:srgbClr val="2A2A2A"/>
           </a:solidFill>
           <a:ln>
             <a:noFill/>
@@ -4135,7 +4135,7 @@
             <a:avLst/>
           </a:prstGeom>
           <a:solidFill>
-            <a:srgbClr val="DCD3C4"/>
+            <a:srgbClr val="2A2A2A"/>
           </a:solidFill>
           <a:ln>
             <a:noFill/>
@@ -4178,7 +4178,7 @@
             <a:avLst/>
           </a:prstGeom>
           <a:solidFill>
-            <a:srgbClr val="DCD3C4"/>
+            <a:srgbClr val="2A2A2A"/>
           </a:solidFill>
           <a:ln>
             <a:noFill/>
@@ -4221,7 +4221,7 @@
             <a:avLst/>
           </a:prstGeom>
           <a:solidFill>
-            <a:srgbClr val="DCD3C4"/>
+            <a:srgbClr val="2A2A2A"/>
           </a:solidFill>
           <a:ln>
             <a:noFill/>
@@ -4264,7 +4264,7 @@
             <a:avLst/>
           </a:prstGeom>
           <a:solidFill>
-            <a:srgbClr val="DCD3C4"/>
+            <a:srgbClr val="2A2A2A"/>
           </a:solidFill>
           <a:ln>
             <a:noFill/>
@@ -4307,7 +4307,7 @@
             <a:avLst/>
           </a:prstGeom>
           <a:solidFill>
-            <a:srgbClr val="DCD3C4"/>
+            <a:srgbClr val="2A2A2A"/>
           </a:solidFill>
           <a:ln>
             <a:noFill/>
@@ -4350,7 +4350,7 @@
             <a:avLst/>
           </a:prstGeom>
           <a:solidFill>
-            <a:srgbClr val="DCD3C4"/>
+            <a:srgbClr val="2A2A2A"/>
           </a:solidFill>
           <a:ln>
             <a:noFill/>
@@ -4393,7 +4393,7 @@
             <a:avLst/>
           </a:prstGeom>
           <a:solidFill>
-            <a:srgbClr val="DCD3C4"/>
+            <a:srgbClr val="2A2A2A"/>
           </a:solidFill>
           <a:ln>
             <a:noFill/>
@@ -4436,7 +4436,7 @@
             <a:avLst/>
           </a:prstGeom>
           <a:solidFill>
-            <a:srgbClr val="DCD3C4"/>
+            <a:srgbClr val="2A2A2A"/>
           </a:solidFill>
           <a:ln>
             <a:noFill/>
@@ -4479,7 +4479,7 @@
             <a:avLst/>
           </a:prstGeom>
           <a:solidFill>
-            <a:srgbClr val="DCD3C4"/>
+            <a:srgbClr val="2A2A2A"/>
           </a:solidFill>
           <a:ln>
             <a:noFill/>
@@ -4522,7 +4522,7 @@
             <a:avLst/>
           </a:prstGeom>
           <a:solidFill>
-            <a:srgbClr val="DCD3C4"/>
+            <a:srgbClr val="2A2A2A"/>
           </a:solidFill>
           <a:ln>
             <a:noFill/>
@@ -4565,7 +4565,7 @@
             <a:avLst/>
           </a:prstGeom>
           <a:solidFill>
-            <a:srgbClr val="DCD3C4"/>
+            <a:srgbClr val="2A2A2A"/>
           </a:solidFill>
           <a:ln>
             <a:noFill/>
@@ -4608,7 +4608,7 @@
             <a:avLst/>
           </a:prstGeom>
           <a:solidFill>
-            <a:srgbClr val="DCD3C4"/>
+            <a:srgbClr val="2A2A2A"/>
           </a:solidFill>
           <a:ln>
             <a:noFill/>
@@ -4651,7 +4651,7 @@
             <a:avLst/>
           </a:prstGeom>
           <a:solidFill>
-            <a:srgbClr val="DCD3C4"/>
+            <a:srgbClr val="2A2A2A"/>
           </a:solidFill>
           <a:ln>
             <a:noFill/>
@@ -4694,7 +4694,7 @@
             <a:avLst/>
           </a:prstGeom>
           <a:solidFill>
-            <a:srgbClr val="DCD3C4"/>
+            <a:srgbClr val="2A2A2A"/>
           </a:solidFill>
           <a:ln>
             <a:noFill/>
@@ -4737,7 +4737,7 @@
             <a:avLst/>
           </a:prstGeom>
           <a:solidFill>
-            <a:srgbClr val="DCD3C4"/>
+            <a:srgbClr val="2A2A2A"/>
           </a:solidFill>
           <a:ln>
             <a:noFill/>
@@ -4780,7 +4780,7 @@
             <a:avLst/>
           </a:prstGeom>
           <a:solidFill>
-            <a:srgbClr val="DCD3C4"/>
+            <a:srgbClr val="2A2A2A"/>
           </a:solidFill>
           <a:ln>
             <a:noFill/>
@@ -4823,7 +4823,7 @@
             <a:avLst/>
           </a:prstGeom>
           <a:solidFill>
-            <a:srgbClr val="DCD3C4"/>
+            <a:srgbClr val="2A2A2A"/>
           </a:solidFill>
           <a:ln>
             <a:noFill/>
@@ -4866,7 +4866,7 @@
             <a:avLst/>
           </a:prstGeom>
           <a:solidFill>
-            <a:srgbClr val="DCD3C4"/>
+            <a:srgbClr val="2A2A2A"/>
           </a:solidFill>
           <a:ln>
             <a:noFill/>
@@ -4909,7 +4909,7 @@
             <a:avLst/>
           </a:prstGeom>
           <a:solidFill>
-            <a:srgbClr val="DCD3C4"/>
+            <a:srgbClr val="2A2A2A"/>
           </a:solidFill>
           <a:ln>
             <a:noFill/>
@@ -4952,7 +4952,7 @@
             <a:avLst/>
           </a:prstGeom>
           <a:solidFill>
-            <a:srgbClr val="DCD3C4"/>
+            <a:srgbClr val="2A2A2A"/>
           </a:solidFill>
           <a:ln>
             <a:noFill/>
@@ -4995,7 +4995,7 @@
             <a:avLst/>
           </a:prstGeom>
           <a:solidFill>
-            <a:srgbClr val="DCD3C4"/>
+            <a:srgbClr val="2A2A2A"/>
           </a:solidFill>
           <a:ln>
             <a:noFill/>
@@ -5038,7 +5038,7 @@
             <a:avLst/>
           </a:prstGeom>
           <a:solidFill>
-            <a:srgbClr val="DCD3C4"/>
+            <a:srgbClr val="2A2A2A"/>
           </a:solidFill>
           <a:ln>
             <a:noFill/>
@@ -5081,7 +5081,7 @@
             <a:avLst/>
           </a:prstGeom>
           <a:solidFill>
-            <a:srgbClr val="DCD3C4"/>
+            <a:srgbClr val="2A2A2A"/>
           </a:solidFill>
           <a:ln>
             <a:noFill/>
@@ -5124,7 +5124,7 @@
             <a:avLst/>
           </a:prstGeom>
           <a:solidFill>
-            <a:srgbClr val="DCD3C4"/>
+            <a:srgbClr val="2A2A2A"/>
           </a:solidFill>
           <a:ln>
             <a:noFill/>
@@ -5167,7 +5167,7 @@
             <a:avLst/>
           </a:prstGeom>
           <a:solidFill>
-            <a:srgbClr val="DCD3C4"/>
+            <a:srgbClr val="2A2A2A"/>
           </a:solidFill>
           <a:ln>
             <a:noFill/>
@@ -5210,7 +5210,7 @@
             <a:avLst/>
           </a:prstGeom>
           <a:solidFill>
-            <a:srgbClr val="DCD3C4"/>
+            <a:srgbClr val="2A2A2A"/>
           </a:solidFill>
           <a:ln>
             <a:noFill/>
@@ -5253,7 +5253,7 @@
             <a:avLst/>
           </a:prstGeom>
           <a:solidFill>
-            <a:srgbClr val="DCD3C4"/>
+            <a:srgbClr val="2A2A2A"/>
           </a:solidFill>
           <a:ln>
             <a:noFill/>
@@ -5296,7 +5296,7 @@
             <a:avLst/>
           </a:prstGeom>
           <a:solidFill>
-            <a:srgbClr val="DCD3C4"/>
+            <a:srgbClr val="2A2A2A"/>
           </a:solidFill>
           <a:ln>
             <a:noFill/>
@@ -5339,7 +5339,7 @@
             <a:avLst/>
           </a:prstGeom>
           <a:solidFill>
-            <a:srgbClr val="DCD3C4"/>
+            <a:srgbClr val="2A2A2A"/>
           </a:solidFill>
           <a:ln>
             <a:noFill/>
@@ -5382,7 +5382,7 @@
             <a:avLst/>
           </a:prstGeom>
           <a:solidFill>
-            <a:srgbClr val="DCD3C4"/>
+            <a:srgbClr val="2A2A2A"/>
           </a:solidFill>
           <a:ln>
             <a:noFill/>
@@ -5425,7 +5425,7 @@
             <a:avLst/>
           </a:prstGeom>
           <a:solidFill>
-            <a:srgbClr val="DCD3C4"/>
+            <a:srgbClr val="2A2A2A"/>
           </a:solidFill>
           <a:ln>
             <a:noFill/>
@@ -5468,7 +5468,7 @@
             <a:avLst/>
           </a:prstGeom>
           <a:solidFill>
-            <a:srgbClr val="DCD3C4"/>
+            <a:srgbClr val="2A2A2A"/>
           </a:solidFill>
           <a:ln>
             <a:noFill/>
@@ -5511,7 +5511,7 @@
             <a:avLst/>
           </a:prstGeom>
           <a:solidFill>
-            <a:srgbClr val="DCD3C4"/>
+            <a:srgbClr val="2A2A2A"/>
           </a:solidFill>
           <a:ln>
             <a:noFill/>
@@ -5554,7 +5554,7 @@
             <a:avLst/>
           </a:prstGeom>
           <a:solidFill>
-            <a:srgbClr val="DCD3C4"/>
+            <a:srgbClr val="2A2A2A"/>
           </a:solidFill>
           <a:ln>
             <a:noFill/>
@@ -5597,7 +5597,7 @@
             <a:avLst/>
           </a:prstGeom>
           <a:solidFill>
-            <a:srgbClr val="DCD3C4"/>
+            <a:srgbClr val="2A2A2A"/>
           </a:solidFill>
           <a:ln>
             <a:noFill/>
@@ -5640,7 +5640,7 @@
             <a:avLst/>
           </a:prstGeom>
           <a:solidFill>
-            <a:srgbClr val="DCD3C4"/>
+            <a:srgbClr val="2A2A2A"/>
           </a:solidFill>
           <a:ln>
             <a:noFill/>
@@ -5683,7 +5683,7 @@
             <a:avLst/>
           </a:prstGeom>
           <a:solidFill>
-            <a:srgbClr val="DCD3C4"/>
+            <a:srgbClr val="2A2A2A"/>
           </a:solidFill>
           <a:ln>
             <a:noFill/>
@@ -5726,7 +5726,7 @@
             <a:avLst/>
           </a:prstGeom>
           <a:solidFill>
-            <a:srgbClr val="DCD3C4"/>
+            <a:srgbClr val="2A2A2A"/>
           </a:solidFill>
           <a:ln>
             <a:noFill/>
@@ -5769,7 +5769,7 @@
             <a:avLst/>
           </a:prstGeom>
           <a:solidFill>
-            <a:srgbClr val="DCD3C4"/>
+            <a:srgbClr val="2A2A2A"/>
           </a:solidFill>
           <a:ln>
             <a:noFill/>
@@ -5812,7 +5812,7 @@
             <a:avLst/>
           </a:prstGeom>
           <a:solidFill>
-            <a:srgbClr val="DCD3C4"/>
+            <a:srgbClr val="2A2A2A"/>
           </a:solidFill>
           <a:ln>
             <a:noFill/>
@@ -5855,7 +5855,7 @@
             <a:avLst/>
           </a:prstGeom>
           <a:solidFill>
-            <a:srgbClr val="DCD3C4"/>
+            <a:srgbClr val="2A2A2A"/>
           </a:solidFill>
           <a:ln>
             <a:noFill/>
@@ -5898,7 +5898,7 @@
             <a:avLst/>
           </a:prstGeom>
           <a:solidFill>
-            <a:srgbClr val="DCD3C4"/>
+            <a:srgbClr val="2A2A2A"/>
           </a:solidFill>
           <a:ln>
             <a:noFill/>
@@ -5941,7 +5941,7 @@
             <a:avLst/>
           </a:prstGeom>
           <a:solidFill>
-            <a:srgbClr val="DCD3C4"/>
+            <a:srgbClr val="2A2A2A"/>
           </a:solidFill>
           <a:ln>
             <a:noFill/>
@@ -5984,7 +5984,7 @@
             <a:avLst/>
           </a:prstGeom>
           <a:solidFill>
-            <a:srgbClr val="DCD3C4"/>
+            <a:srgbClr val="2A2A2A"/>
           </a:solidFill>
           <a:ln>
             <a:noFill/>
@@ -6027,7 +6027,7 @@
             <a:avLst/>
           </a:prstGeom>
           <a:solidFill>
-            <a:srgbClr val="DCD3C4"/>
+            <a:srgbClr val="2A2A2A"/>
           </a:solidFill>
           <a:ln>
             <a:noFill/>
@@ -6070,7 +6070,7 @@
             <a:avLst/>
           </a:prstGeom>
           <a:solidFill>
-            <a:srgbClr val="DCD3C4"/>
+            <a:srgbClr val="2A2A2A"/>
           </a:solidFill>
           <a:ln>
             <a:noFill/>
@@ -6113,7 +6113,7 @@
             <a:avLst/>
           </a:prstGeom>
           <a:solidFill>
-            <a:srgbClr val="DCD3C4"/>
+            <a:srgbClr val="2A2A2A"/>
           </a:solidFill>
           <a:ln>
             <a:noFill/>
@@ -6156,7 +6156,7 @@
             <a:avLst/>
           </a:prstGeom>
           <a:solidFill>
-            <a:srgbClr val="DCD3C4"/>
+            <a:srgbClr val="2A2A2A"/>
           </a:solidFill>
           <a:ln>
             <a:noFill/>
@@ -6199,7 +6199,7 @@
             <a:avLst/>
           </a:prstGeom>
           <a:solidFill>
-            <a:srgbClr val="DCD3C4"/>
+            <a:srgbClr val="2A2A2A"/>
           </a:solidFill>
           <a:ln>
             <a:noFill/>
@@ -6242,7 +6242,7 @@
             <a:avLst/>
           </a:prstGeom>
           <a:solidFill>
-            <a:srgbClr val="DCD3C4"/>
+            <a:srgbClr val="2A2A2A"/>
           </a:solidFill>
           <a:ln>
             <a:noFill/>
@@ -6285,7 +6285,7 @@
             <a:avLst/>
           </a:prstGeom>
           <a:solidFill>
-            <a:srgbClr val="DCD3C4"/>
+            <a:srgbClr val="2A2A2A"/>
           </a:solidFill>
           <a:ln>
             <a:noFill/>
@@ -6328,7 +6328,7 @@
             <a:avLst/>
           </a:prstGeom>
           <a:solidFill>
-            <a:srgbClr val="DCD3C4"/>
+            <a:srgbClr val="2A2A2A"/>
           </a:solidFill>
           <a:ln>
             <a:noFill/>
@@ -6371,7 +6371,7 @@
             <a:avLst/>
           </a:prstGeom>
           <a:solidFill>
-            <a:srgbClr val="DCD3C4"/>
+            <a:srgbClr val="2A2A2A"/>
           </a:solidFill>
           <a:ln>
             <a:noFill/>
@@ -6414,7 +6414,7 @@
             <a:avLst/>
           </a:prstGeom>
           <a:solidFill>
-            <a:srgbClr val="DCD3C4"/>
+            <a:srgbClr val="2A2A2A"/>
           </a:solidFill>
           <a:ln>
             <a:noFill/>
@@ -6457,7 +6457,7 @@
             <a:avLst/>
           </a:prstGeom>
           <a:solidFill>
-            <a:srgbClr val="DCD3C4"/>
+            <a:srgbClr val="2A2A2A"/>
           </a:solidFill>
           <a:ln>
             <a:noFill/>
@@ -6500,7 +6500,7 @@
             <a:avLst/>
           </a:prstGeom>
           <a:solidFill>
-            <a:srgbClr val="DCD3C4"/>
+            <a:srgbClr val="2A2A2A"/>
           </a:solidFill>
           <a:ln>
             <a:noFill/>
@@ -6543,7 +6543,7 @@
             <a:avLst/>
           </a:prstGeom>
           <a:solidFill>
-            <a:srgbClr val="DCD3C4"/>
+            <a:srgbClr val="2A2A2A"/>
           </a:solidFill>
           <a:ln>
             <a:noFill/>
@@ -6586,7 +6586,7 @@
             <a:avLst/>
           </a:prstGeom>
           <a:solidFill>
-            <a:srgbClr val="DCD3C4"/>
+            <a:srgbClr val="2A2A2A"/>
           </a:solidFill>
           <a:ln>
             <a:noFill/>
@@ -6629,7 +6629,7 @@
             <a:avLst/>
           </a:prstGeom>
           <a:solidFill>
-            <a:srgbClr val="DCD3C4"/>
+            <a:srgbClr val="2A2A2A"/>
           </a:solidFill>
           <a:ln>
             <a:noFill/>
@@ -6672,7 +6672,7 @@
             <a:avLst/>
           </a:prstGeom>
           <a:solidFill>
-            <a:srgbClr val="DCD3C4"/>
+            <a:srgbClr val="2A2A2A"/>
           </a:solidFill>
           <a:ln>
             <a:noFill/>
@@ -6715,7 +6715,7 @@
             <a:avLst/>
           </a:prstGeom>
           <a:solidFill>
-            <a:srgbClr val="DCD3C4"/>
+            <a:srgbClr val="2A2A2A"/>
           </a:solidFill>
           <a:ln>
             <a:noFill/>
@@ -6758,7 +6758,7 @@
             <a:avLst/>
           </a:prstGeom>
           <a:solidFill>
-            <a:srgbClr val="DCD3C4"/>
+            <a:srgbClr val="2A2A2A"/>
           </a:solidFill>
           <a:ln>
             <a:noFill/>
@@ -6801,7 +6801,7 @@
             <a:avLst/>
           </a:prstGeom>
           <a:solidFill>
-            <a:srgbClr val="DCD3C4"/>
+            <a:srgbClr val="2A2A2A"/>
           </a:solidFill>
           <a:ln>
             <a:noFill/>
@@ -6844,7 +6844,7 @@
             <a:avLst/>
           </a:prstGeom>
           <a:solidFill>
-            <a:srgbClr val="DCD3C4"/>
+            <a:srgbClr val="2A2A2A"/>
           </a:solidFill>
           <a:ln>
             <a:noFill/>
@@ -6887,7 +6887,7 @@
             <a:avLst/>
           </a:prstGeom>
           <a:solidFill>
-            <a:srgbClr val="DCD3C4"/>
+            <a:srgbClr val="2A2A2A"/>
           </a:solidFill>
           <a:ln>
             <a:noFill/>
@@ -6930,7 +6930,7 @@
             <a:avLst/>
           </a:prstGeom>
           <a:solidFill>
-            <a:srgbClr val="DCD3C4"/>
+            <a:srgbClr val="2A2A2A"/>
           </a:solidFill>
           <a:ln>
             <a:noFill/>
@@ -6973,7 +6973,7 @@
             <a:avLst/>
           </a:prstGeom>
           <a:solidFill>
-            <a:srgbClr val="DCD3C4"/>
+            <a:srgbClr val="2A2A2A"/>
           </a:solidFill>
           <a:ln>
             <a:noFill/>
@@ -7016,7 +7016,7 @@
             <a:avLst/>
           </a:prstGeom>
           <a:solidFill>
-            <a:srgbClr val="DCD3C4"/>
+            <a:srgbClr val="2A2A2A"/>
           </a:solidFill>
           <a:ln>
             <a:noFill/>
@@ -7059,7 +7059,7 @@
             <a:avLst/>
           </a:prstGeom>
           <a:solidFill>
-            <a:srgbClr val="DCD3C4"/>
+            <a:srgbClr val="2A2A2A"/>
           </a:solidFill>
           <a:ln>
             <a:noFill/>
@@ -7102,7 +7102,7 @@
             <a:avLst/>
           </a:prstGeom>
           <a:solidFill>
-            <a:srgbClr val="DCD3C4"/>
+            <a:srgbClr val="2A2A2A"/>
           </a:solidFill>
           <a:ln>
             <a:noFill/>
@@ -7145,7 +7145,7 @@
             <a:avLst/>
           </a:prstGeom>
           <a:solidFill>
-            <a:srgbClr val="DCD3C4"/>
+            <a:srgbClr val="2A2A2A"/>
           </a:solidFill>
           <a:ln>
             <a:noFill/>
@@ -7188,7 +7188,7 @@
             <a:avLst/>
           </a:prstGeom>
           <a:solidFill>
-            <a:srgbClr val="DCD3C4"/>
+            <a:srgbClr val="2A2A2A"/>
           </a:solidFill>
           <a:ln>
             <a:noFill/>
@@ -7231,7 +7231,7 @@
             <a:avLst/>
           </a:prstGeom>
           <a:solidFill>
-            <a:srgbClr val="DCD3C4"/>
+            <a:srgbClr val="2A2A2A"/>
           </a:solidFill>
           <a:ln>
             <a:noFill/>
@@ -7274,7 +7274,7 @@
             <a:avLst/>
           </a:prstGeom>
           <a:solidFill>
-            <a:srgbClr val="DCD3C4"/>
+            <a:srgbClr val="2A2A2A"/>
           </a:solidFill>
           <a:ln>
             <a:noFill/>
@@ -7317,7 +7317,7 @@
             <a:avLst/>
           </a:prstGeom>
           <a:solidFill>
-            <a:srgbClr val="DCD3C4"/>
+            <a:srgbClr val="2A2A2A"/>
           </a:solidFill>
           <a:ln>
             <a:noFill/>
@@ -7360,7 +7360,7 @@
             <a:avLst/>
           </a:prstGeom>
           <a:solidFill>
-            <a:srgbClr val="DCD3C4"/>
+            <a:srgbClr val="2A2A2A"/>
           </a:solidFill>
           <a:ln>
             <a:noFill/>
@@ -7403,7 +7403,7 @@
             <a:avLst/>
           </a:prstGeom>
           <a:solidFill>
-            <a:srgbClr val="DCD3C4"/>
+            <a:srgbClr val="2A2A2A"/>
           </a:solidFill>
           <a:ln>
             <a:noFill/>
@@ -7446,7 +7446,7 @@
             <a:avLst/>
           </a:prstGeom>
           <a:solidFill>
-            <a:srgbClr val="DCD3C4"/>
+            <a:srgbClr val="2A2A2A"/>
           </a:solidFill>
           <a:ln>
             <a:noFill/>
@@ -7489,7 +7489,7 @@
             <a:avLst/>
           </a:prstGeom>
           <a:solidFill>
-            <a:srgbClr val="DCD3C4"/>
+            <a:srgbClr val="2A2A2A"/>
           </a:solidFill>
           <a:ln>
             <a:noFill/>
@@ -7532,7 +7532,7 @@
             <a:avLst/>
           </a:prstGeom>
           <a:solidFill>
-            <a:srgbClr val="DCD3C4"/>
+            <a:srgbClr val="2A2A2A"/>
           </a:solidFill>
           <a:ln>
             <a:noFill/>
@@ -7575,7 +7575,7 @@
             <a:avLst/>
           </a:prstGeom>
           <a:solidFill>
-            <a:srgbClr val="DCD3C4"/>
+            <a:srgbClr val="2A2A2A"/>
           </a:solidFill>
           <a:ln>
             <a:noFill/>
@@ -7618,7 +7618,7 @@
             <a:avLst/>
           </a:prstGeom>
           <a:solidFill>
-            <a:srgbClr val="DCD3C4"/>
+            <a:srgbClr val="2A2A2A"/>
           </a:solidFill>
           <a:ln>
             <a:noFill/>
@@ -7661,7 +7661,7 @@
             <a:avLst/>
           </a:prstGeom>
           <a:solidFill>
-            <a:srgbClr val="DCD3C4"/>
+            <a:srgbClr val="2A2A2A"/>
           </a:solidFill>
           <a:ln>
             <a:noFill/>
@@ -7704,7 +7704,7 @@
             <a:avLst/>
           </a:prstGeom>
           <a:solidFill>
-            <a:srgbClr val="DCD3C4"/>
+            <a:srgbClr val="2A2A2A"/>
           </a:solidFill>
           <a:ln>
             <a:noFill/>
@@ -7747,7 +7747,7 @@
             <a:avLst/>
           </a:prstGeom>
           <a:solidFill>
-            <a:srgbClr val="DCD3C4"/>
+            <a:srgbClr val="2A2A2A"/>
           </a:solidFill>
           <a:ln>
             <a:noFill/>
@@ -7790,7 +7790,7 @@
             <a:avLst/>
           </a:prstGeom>
           <a:solidFill>
-            <a:srgbClr val="DCD3C4"/>
+            <a:srgbClr val="2A2A2A"/>
           </a:solidFill>
           <a:ln>
             <a:noFill/>
@@ -7833,7 +7833,7 @@
             <a:avLst/>
           </a:prstGeom>
           <a:solidFill>
-            <a:srgbClr val="DCD3C4"/>
+            <a:srgbClr val="2A2A2A"/>
           </a:solidFill>
           <a:ln>
             <a:noFill/>
@@ -7876,7 +7876,7 @@
             <a:avLst/>
           </a:prstGeom>
           <a:solidFill>
-            <a:srgbClr val="DCD3C4"/>
+            <a:srgbClr val="2A2A2A"/>
           </a:solidFill>
           <a:ln>
             <a:noFill/>
@@ -7919,7 +7919,7 @@
             <a:avLst/>
           </a:prstGeom>
           <a:solidFill>
-            <a:srgbClr val="DCD3C4"/>
+            <a:srgbClr val="2A2A2A"/>
           </a:solidFill>
           <a:ln>
             <a:noFill/>
@@ -7962,7 +7962,7 @@
             <a:avLst/>
           </a:prstGeom>
           <a:solidFill>
-            <a:srgbClr val="DCD3C4"/>
+            <a:srgbClr val="2A2A2A"/>
           </a:solidFill>
           <a:ln>
             <a:noFill/>
@@ -8005,7 +8005,7 @@
             <a:avLst/>
           </a:prstGeom>
           <a:solidFill>
-            <a:srgbClr val="DCD3C4"/>
+            <a:srgbClr val="2A2A2A"/>
           </a:solidFill>
           <a:ln>
             <a:noFill/>
@@ -8048,7 +8048,7 @@
             <a:avLst/>
           </a:prstGeom>
           <a:solidFill>
-            <a:srgbClr val="DCD3C4"/>
+            <a:srgbClr val="2A2A2A"/>
           </a:solidFill>
           <a:ln>
             <a:noFill/>
@@ -8091,7 +8091,7 @@
             <a:avLst/>
           </a:prstGeom>
           <a:solidFill>
-            <a:srgbClr val="DCD3C4"/>
+            <a:srgbClr val="2A2A2A"/>
           </a:solidFill>
           <a:ln>
             <a:noFill/>
@@ -8134,7 +8134,7 @@
             <a:avLst/>
           </a:prstGeom>
           <a:solidFill>
-            <a:srgbClr val="DCD3C4"/>
+            <a:srgbClr val="2A2A2A"/>
           </a:solidFill>
           <a:ln>
             <a:noFill/>
@@ -8177,7 +8177,7 @@
             <a:avLst/>
           </a:prstGeom>
           <a:solidFill>
-            <a:srgbClr val="DCD3C4"/>
+            <a:srgbClr val="2A2A2A"/>
           </a:solidFill>
           <a:ln>
             <a:noFill/>
@@ -8220,7 +8220,7 @@
             <a:avLst/>
           </a:prstGeom>
           <a:solidFill>
-            <a:srgbClr val="DCD3C4"/>
+            <a:srgbClr val="2A2A2A"/>
           </a:solidFill>
           <a:ln>
             <a:noFill/>
@@ -8263,7 +8263,7 @@
             <a:avLst/>
           </a:prstGeom>
           <a:solidFill>
-            <a:srgbClr val="DCD3C4"/>
+            <a:srgbClr val="2A2A2A"/>
           </a:solidFill>
           <a:ln>
             <a:noFill/>
@@ -8306,7 +8306,7 @@
             <a:avLst/>
           </a:prstGeom>
           <a:solidFill>
-            <a:srgbClr val="DCD3C4"/>
+            <a:srgbClr val="2A2A2A"/>
           </a:solidFill>
           <a:ln>
             <a:noFill/>
@@ -8349,7 +8349,7 @@
             <a:avLst/>
           </a:prstGeom>
           <a:solidFill>
-            <a:srgbClr val="DCD3C4"/>
+            <a:srgbClr val="2A2A2A"/>
           </a:solidFill>
           <a:ln>
             <a:noFill/>
@@ -8392,7 +8392,7 @@
             <a:avLst/>
           </a:prstGeom>
           <a:solidFill>
-            <a:srgbClr val="DCD3C4"/>
+            <a:srgbClr val="2A2A2A"/>
           </a:solidFill>
           <a:ln>
             <a:noFill/>
@@ -8435,7 +8435,7 @@
             <a:avLst/>
           </a:prstGeom>
           <a:solidFill>
-            <a:srgbClr val="DCD3C4"/>
+            <a:srgbClr val="2A2A2A"/>
           </a:solidFill>
           <a:ln>
             <a:noFill/>
@@ -8478,7 +8478,7 @@
             <a:avLst/>
           </a:prstGeom>
           <a:solidFill>
-            <a:srgbClr val="DCD3C4"/>
+            <a:srgbClr val="2A2A2A"/>
           </a:solidFill>
           <a:ln>
             <a:noFill/>
@@ -8521,7 +8521,7 @@
             <a:avLst/>
           </a:prstGeom>
           <a:solidFill>
-            <a:srgbClr val="DCD3C4"/>
+            <a:srgbClr val="2A2A2A"/>
           </a:solidFill>
           <a:ln>
             <a:noFill/>
@@ -8564,7 +8564,7 @@
             <a:avLst/>
           </a:prstGeom>
           <a:solidFill>
-            <a:srgbClr val="DCD3C4"/>
+            <a:srgbClr val="2A2A2A"/>
           </a:solidFill>
           <a:ln>
             <a:noFill/>
@@ -8607,7 +8607,7 @@
             <a:avLst/>
           </a:prstGeom>
           <a:solidFill>
-            <a:srgbClr val="DCD3C4"/>
+            <a:srgbClr val="2A2A2A"/>
           </a:solidFill>
           <a:ln>
             <a:noFill/>
@@ -8650,7 +8650,7 @@
             <a:avLst/>
           </a:prstGeom>
           <a:solidFill>
-            <a:srgbClr val="DCD3C4"/>
+            <a:srgbClr val="2A2A2A"/>
           </a:solidFill>
           <a:ln>
             <a:noFill/>
@@ -8693,7 +8693,7 @@
             <a:avLst/>
           </a:prstGeom>
           <a:solidFill>
-            <a:srgbClr val="DCD3C4"/>
+            <a:srgbClr val="2A2A2A"/>
           </a:solidFill>
           <a:ln>
             <a:noFill/>
@@ -8736,7 +8736,7 @@
             <a:avLst/>
           </a:prstGeom>
           <a:solidFill>
-            <a:srgbClr val="DCD3C4"/>
+            <a:srgbClr val="2A2A2A"/>
           </a:solidFill>
           <a:ln>
             <a:noFill/>
@@ -8779,7 +8779,7 @@
             <a:avLst/>
           </a:prstGeom>
           <a:solidFill>
-            <a:srgbClr val="DCD3C4"/>
+            <a:srgbClr val="2A2A2A"/>
           </a:solidFill>
           <a:ln>
             <a:noFill/>
@@ -8822,7 +8822,7 @@
             <a:avLst/>
           </a:prstGeom>
           <a:solidFill>
-            <a:srgbClr val="DCD3C4"/>
+            <a:srgbClr val="2A2A2A"/>
           </a:solidFill>
           <a:ln>
             <a:noFill/>
@@ -8865,7 +8865,7 @@
             <a:avLst/>
           </a:prstGeom>
           <a:solidFill>
-            <a:srgbClr val="DCD3C4"/>
+            <a:srgbClr val="2A2A2A"/>
           </a:solidFill>
           <a:ln>
             <a:noFill/>
@@ -8908,7 +8908,7 @@
             <a:avLst/>
           </a:prstGeom>
           <a:solidFill>
-            <a:srgbClr val="DCD3C4"/>
+            <a:srgbClr val="2A2A2A"/>
           </a:solidFill>
           <a:ln>
             <a:noFill/>
@@ -8951,7 +8951,7 @@
             <a:avLst/>
           </a:prstGeom>
           <a:solidFill>
-            <a:srgbClr val="DCD3C4"/>
+            <a:srgbClr val="2A2A2A"/>
           </a:solidFill>
           <a:ln>
             <a:noFill/>
@@ -8994,7 +8994,7 @@
             <a:avLst/>
           </a:prstGeom>
           <a:solidFill>
-            <a:srgbClr val="DCD3C4"/>
+            <a:srgbClr val="2A2A2A"/>
           </a:solidFill>
           <a:ln>
             <a:noFill/>
@@ -9037,7 +9037,7 @@
             <a:avLst/>
           </a:prstGeom>
           <a:solidFill>
-            <a:srgbClr val="DCD3C4"/>
+            <a:srgbClr val="2A2A2A"/>
           </a:solidFill>
           <a:ln>
             <a:noFill/>
@@ -9080,7 +9080,7 @@
             <a:avLst/>
           </a:prstGeom>
           <a:solidFill>
-            <a:srgbClr val="DCD3C4"/>
+            <a:srgbClr val="2A2A2A"/>
           </a:solidFill>
           <a:ln>
             <a:noFill/>
@@ -9123,7 +9123,7 @@
             <a:avLst/>
           </a:prstGeom>
           <a:solidFill>
-            <a:srgbClr val="DCD3C4"/>
+            <a:srgbClr val="2A2A2A"/>
           </a:solidFill>
           <a:ln>
             <a:noFill/>
@@ -9166,7 +9166,7 @@
             <a:avLst/>
           </a:prstGeom>
           <a:solidFill>
-            <a:srgbClr val="DCD3C4"/>
+            <a:srgbClr val="2A2A2A"/>
           </a:solidFill>
           <a:ln>
             <a:noFill/>
@@ -9209,7 +9209,7 @@
             <a:avLst/>
           </a:prstGeom>
           <a:solidFill>
-            <a:srgbClr val="DCD3C4"/>
+            <a:srgbClr val="2A2A2A"/>
           </a:solidFill>
           <a:ln>
             <a:noFill/>
@@ -9252,7 +9252,7 @@
             <a:avLst/>
           </a:prstGeom>
           <a:solidFill>
-            <a:srgbClr val="DCD3C4"/>
+            <a:srgbClr val="2A2A2A"/>
           </a:solidFill>
           <a:ln>
             <a:noFill/>
@@ -9295,7 +9295,7 @@
             <a:avLst/>
           </a:prstGeom>
           <a:solidFill>
-            <a:srgbClr val="DCD3C4"/>
+            <a:srgbClr val="2A2A2A"/>
           </a:solidFill>
           <a:ln>
             <a:noFill/>
@@ -9338,7 +9338,7 @@
             <a:avLst/>
           </a:prstGeom>
           <a:solidFill>
-            <a:srgbClr val="DCD3C4"/>
+            <a:srgbClr val="2A2A2A"/>
           </a:solidFill>
           <a:ln>
             <a:noFill/>
@@ -9381,7 +9381,7 @@
             <a:avLst/>
           </a:prstGeom>
           <a:solidFill>
-            <a:srgbClr val="DCD3C4"/>
+            <a:srgbClr val="2A2A2A"/>
           </a:solidFill>
           <a:ln>
             <a:noFill/>
@@ -9424,7 +9424,7 @@
             <a:avLst/>
           </a:prstGeom>
           <a:solidFill>
-            <a:srgbClr val="DCD3C4"/>
+            <a:srgbClr val="2A2A2A"/>
           </a:solidFill>
           <a:ln>
             <a:noFill/>
@@ -9467,7 +9467,7 @@
             <a:avLst/>
           </a:prstGeom>
           <a:solidFill>
-            <a:srgbClr val="DCD3C4"/>
+            <a:srgbClr val="2A2A2A"/>
           </a:solidFill>
           <a:ln>
             <a:noFill/>
@@ -9510,7 +9510,7 @@
             <a:avLst/>
           </a:prstGeom>
           <a:solidFill>
-            <a:srgbClr val="DCD3C4"/>
+            <a:srgbClr val="2A2A2A"/>
           </a:solidFill>
           <a:ln>
             <a:noFill/>
@@ -9553,7 +9553,7 @@
             <a:avLst/>
           </a:prstGeom>
           <a:solidFill>
-            <a:srgbClr val="DCD3C4"/>
+            <a:srgbClr val="2A2A2A"/>
           </a:solidFill>
           <a:ln>
             <a:noFill/>
@@ -9596,7 +9596,7 @@
             <a:avLst/>
           </a:prstGeom>
           <a:solidFill>
-            <a:srgbClr val="DCD3C4"/>
+            <a:srgbClr val="2A2A2A"/>
           </a:solidFill>
           <a:ln>
             <a:noFill/>
@@ -9639,7 +9639,7 @@
             <a:avLst/>
           </a:prstGeom>
           <a:solidFill>
-            <a:srgbClr val="DCD3C4"/>
+            <a:srgbClr val="2A2A2A"/>
           </a:solidFill>
           <a:ln>
             <a:noFill/>
@@ -9682,7 +9682,7 @@
             <a:avLst/>
           </a:prstGeom>
           <a:solidFill>
-            <a:srgbClr val="DCD3C4"/>
+            <a:srgbClr val="2A2A2A"/>
           </a:solidFill>
           <a:ln>
             <a:noFill/>
@@ -9725,7 +9725,7 @@
             <a:avLst/>
           </a:prstGeom>
           <a:solidFill>
-            <a:srgbClr val="DCD3C4"/>
+            <a:srgbClr val="2A2A2A"/>
           </a:solidFill>
           <a:ln>
             <a:noFill/>
@@ -9768,7 +9768,7 @@
             <a:avLst/>
           </a:prstGeom>
           <a:solidFill>
-            <a:srgbClr val="DCD3C4"/>
+            <a:srgbClr val="2A2A2A"/>
           </a:solidFill>
           <a:ln>
             <a:noFill/>
@@ -9811,7 +9811,7 @@
             <a:avLst/>
           </a:prstGeom>
           <a:solidFill>
-            <a:srgbClr val="DCD3C4"/>
+            <a:srgbClr val="2A2A2A"/>
           </a:solidFill>
           <a:ln>
             <a:noFill/>
@@ -9854,7 +9854,7 @@
             <a:avLst/>
           </a:prstGeom>
           <a:solidFill>
-            <a:srgbClr val="DCD3C4"/>
+            <a:srgbClr val="2A2A2A"/>
           </a:solidFill>
           <a:ln>
             <a:noFill/>
@@ -9897,7 +9897,7 @@
             <a:avLst/>
           </a:prstGeom>
           <a:solidFill>
-            <a:srgbClr val="DCD3C4"/>
+            <a:srgbClr val="2A2A2A"/>
           </a:solidFill>
           <a:ln>
             <a:noFill/>
@@ -9940,7 +9940,7 @@
             <a:avLst/>
           </a:prstGeom>
           <a:solidFill>
-            <a:srgbClr val="DCD3C4"/>
+            <a:srgbClr val="2A2A2A"/>
           </a:solidFill>
           <a:ln>
             <a:noFill/>
@@ -9983,7 +9983,7 @@
             <a:avLst/>
           </a:prstGeom>
           <a:solidFill>
-            <a:srgbClr val="DCD3C4"/>
+            <a:srgbClr val="2A2A2A"/>
           </a:solidFill>
           <a:ln>
             <a:noFill/>
@@ -10026,7 +10026,7 @@
             <a:avLst/>
           </a:prstGeom>
           <a:solidFill>
-            <a:srgbClr val="DCD3C4"/>
+            <a:srgbClr val="2A2A2A"/>
           </a:solidFill>
           <a:ln>
             <a:noFill/>
@@ -10069,7 +10069,7 @@
             <a:avLst/>
           </a:prstGeom>
           <a:solidFill>
-            <a:srgbClr val="DCD3C4"/>
+            <a:srgbClr val="2A2A2A"/>
           </a:solidFill>
           <a:ln>
             <a:noFill/>
@@ -10112,7 +10112,7 @@
             <a:avLst/>
           </a:prstGeom>
           <a:solidFill>
-            <a:srgbClr val="DCD3C4"/>
+            <a:srgbClr val="2A2A2A"/>
           </a:solidFill>
           <a:ln>
             <a:noFill/>
@@ -10155,7 +10155,7 @@
             <a:avLst/>
           </a:prstGeom>
           <a:solidFill>
-            <a:srgbClr val="DCD3C4"/>
+            <a:srgbClr val="2A2A2A"/>
           </a:solidFill>
           <a:ln>
             <a:noFill/>
@@ -10198,7 +10198,7 @@
             <a:avLst/>
           </a:prstGeom>
           <a:solidFill>
-            <a:srgbClr val="DCD3C4"/>
+            <a:srgbClr val="2A2A2A"/>
           </a:solidFill>
           <a:ln>
             <a:noFill/>
@@ -10241,7 +10241,7 @@
             <a:avLst/>
           </a:prstGeom>
           <a:solidFill>
-            <a:srgbClr val="DCD3C4"/>
+            <a:srgbClr val="2A2A2A"/>
           </a:solidFill>
           <a:ln>
             <a:noFill/>
@@ -10284,7 +10284,7 @@
             <a:avLst/>
           </a:prstGeom>
           <a:solidFill>
-            <a:srgbClr val="DCD3C4"/>
+            <a:srgbClr val="2A2A2A"/>
           </a:solidFill>
           <a:ln>
             <a:noFill/>
@@ -10327,7 +10327,7 @@
             <a:avLst/>
           </a:prstGeom>
           <a:solidFill>
-            <a:srgbClr val="DCD3C4"/>
+            <a:srgbClr val="2A2A2A"/>
           </a:solidFill>
           <a:ln>
             <a:noFill/>
@@ -10370,7 +10370,7 @@
             <a:avLst/>
           </a:prstGeom>
           <a:solidFill>
-            <a:srgbClr val="DCD3C4"/>
+            <a:srgbClr val="2A2A2A"/>
           </a:solidFill>
           <a:ln>
             <a:noFill/>
@@ -10413,7 +10413,7 @@
             <a:avLst/>
           </a:prstGeom>
           <a:solidFill>
-            <a:srgbClr val="DCD3C4"/>
+            <a:srgbClr val="2A2A2A"/>
           </a:solidFill>
           <a:ln>
             <a:noFill/>
@@ -10456,7 +10456,7 @@
             <a:avLst/>
           </a:prstGeom>
           <a:solidFill>
-            <a:srgbClr val="DCD3C4"/>
+            <a:srgbClr val="2A2A2A"/>
           </a:solidFill>
           <a:ln>
             <a:noFill/>
@@ -10499,7 +10499,7 @@
             <a:avLst/>
           </a:prstGeom>
           <a:solidFill>
-            <a:srgbClr val="DCD3C4"/>
+            <a:srgbClr val="2A2A2A"/>
           </a:solidFill>
           <a:ln>
             <a:noFill/>
@@ -10542,7 +10542,7 @@
             <a:avLst/>
           </a:prstGeom>
           <a:solidFill>
-            <a:srgbClr val="DCD3C4"/>
+            <a:srgbClr val="2A2A2A"/>
           </a:solidFill>
           <a:ln>
             <a:noFill/>
@@ -10585,7 +10585,7 @@
             <a:avLst/>
           </a:prstGeom>
           <a:solidFill>
-            <a:srgbClr val="DCD3C4"/>
+            <a:srgbClr val="2A2A2A"/>
           </a:solidFill>
           <a:ln>
             <a:noFill/>
@@ -10628,7 +10628,7 @@
             <a:avLst/>
           </a:prstGeom>
           <a:solidFill>
-            <a:srgbClr val="DCD3C4"/>
+            <a:srgbClr val="2A2A2A"/>
           </a:solidFill>
           <a:ln>
             <a:noFill/>
@@ -10671,7 +10671,7 @@
             <a:avLst/>
           </a:prstGeom>
           <a:solidFill>
-            <a:srgbClr val="DCD3C4"/>
+            <a:srgbClr val="2A2A2A"/>
           </a:solidFill>
           <a:ln>
             <a:noFill/>
@@ -10714,7 +10714,7 @@
             <a:avLst/>
           </a:prstGeom>
           <a:solidFill>
-            <a:srgbClr val="DCD3C4"/>
+            <a:srgbClr val="2A2A2A"/>
           </a:solidFill>
           <a:ln>
             <a:noFill/>
@@ -10757,7 +10757,7 @@
             <a:avLst/>
           </a:prstGeom>
           <a:solidFill>
-            <a:srgbClr val="DCD3C4"/>
+            <a:srgbClr val="2A2A2A"/>
           </a:solidFill>
           <a:ln>
             <a:noFill/>
@@ -10800,7 +10800,7 @@
             <a:avLst/>
           </a:prstGeom>
           <a:solidFill>
-            <a:srgbClr val="DCD3C4"/>
+            <a:srgbClr val="2A2A2A"/>
           </a:solidFill>
           <a:ln>
             <a:noFill/>
@@ -10843,7 +10843,7 @@
             <a:avLst/>
           </a:prstGeom>
           <a:solidFill>
-            <a:srgbClr val="DCD3C4"/>
+            <a:srgbClr val="2A2A2A"/>
           </a:solidFill>
           <a:ln>
             <a:noFill/>
@@ -10886,7 +10886,7 @@
             <a:avLst/>
           </a:prstGeom>
           <a:solidFill>
-            <a:srgbClr val="DCD3C4"/>
+            <a:srgbClr val="2A2A2A"/>
           </a:solidFill>
           <a:ln>
             <a:noFill/>
@@ -10929,7 +10929,7 @@
             <a:avLst/>
           </a:prstGeom>
           <a:solidFill>
-            <a:srgbClr val="DCD3C4"/>
+            <a:srgbClr val="2A2A2A"/>
           </a:solidFill>
           <a:ln>
             <a:noFill/>
@@ -10972,7 +10972,7 @@
             <a:avLst/>
           </a:prstGeom>
           <a:solidFill>
-            <a:srgbClr val="DCD3C4"/>
+            <a:srgbClr val="2A2A2A"/>
           </a:solidFill>
           <a:ln>
             <a:noFill/>
@@ -11015,7 +11015,7 @@
             <a:avLst/>
           </a:prstGeom>
           <a:solidFill>
-            <a:srgbClr val="DCD3C4"/>
+            <a:srgbClr val="2A2A2A"/>
           </a:solidFill>
           <a:ln>
             <a:noFill/>
@@ -11058,7 +11058,7 @@
             <a:avLst/>
           </a:prstGeom>
           <a:solidFill>
-            <a:srgbClr val="DCD3C4"/>
+            <a:srgbClr val="2A2A2A"/>
           </a:solidFill>
           <a:ln>
             <a:noFill/>
@@ -11101,7 +11101,7 @@
             <a:avLst/>
           </a:prstGeom>
           <a:solidFill>
-            <a:srgbClr val="DCD3C4"/>
+            <a:srgbClr val="2A2A2A"/>
           </a:solidFill>
           <a:ln>
             <a:noFill/>
@@ -11144,7 +11144,7 @@
             <a:avLst/>
           </a:prstGeom>
           <a:solidFill>
-            <a:srgbClr val="DCD3C4"/>
+            <a:srgbClr val="2A2A2A"/>
           </a:solidFill>
           <a:ln>
             <a:noFill/>
@@ -11187,7 +11187,7 @@
             <a:avLst/>
           </a:prstGeom>
           <a:solidFill>
-            <a:srgbClr val="DCD3C4"/>
+            <a:srgbClr val="2A2A2A"/>
           </a:solidFill>
           <a:ln>
             <a:noFill/>
@@ -11230,7 +11230,7 @@
             <a:avLst/>
           </a:prstGeom>
           <a:solidFill>
-            <a:srgbClr val="DCD3C4"/>
+            <a:srgbClr val="2A2A2A"/>
           </a:solidFill>
           <a:ln>
             <a:noFill/>
@@ -11273,7 +11273,7 @@
             <a:avLst/>
           </a:prstGeom>
           <a:solidFill>
-            <a:srgbClr val="DCD3C4"/>
+            <a:srgbClr val="2A2A2A"/>
           </a:solidFill>
           <a:ln>
             <a:noFill/>
@@ -11316,7 +11316,7 @@
             <a:avLst/>
           </a:prstGeom>
           <a:solidFill>
-            <a:srgbClr val="DCD3C4"/>
+            <a:srgbClr val="2A2A2A"/>
           </a:solidFill>
           <a:ln>
             <a:noFill/>
@@ -11359,7 +11359,7 @@
             <a:avLst/>
           </a:prstGeom>
           <a:solidFill>
-            <a:srgbClr val="DCD3C4"/>
+            <a:srgbClr val="2A2A2A"/>
           </a:solidFill>
           <a:ln>
             <a:noFill/>
@@ -11402,7 +11402,7 @@
             <a:avLst/>
           </a:prstGeom>
           <a:solidFill>
-            <a:srgbClr val="DCD3C4"/>
+            <a:srgbClr val="2A2A2A"/>
           </a:solidFill>
           <a:ln>
             <a:noFill/>
@@ -11445,7 +11445,7 @@
             <a:avLst/>
           </a:prstGeom>
           <a:solidFill>
-            <a:srgbClr val="DCD3C4"/>
+            <a:srgbClr val="2A2A2A"/>
           </a:solidFill>
           <a:ln>
             <a:noFill/>
@@ -11488,7 +11488,7 @@
             <a:avLst/>
           </a:prstGeom>
           <a:solidFill>
-            <a:srgbClr val="DCD3C4"/>
+            <a:srgbClr val="2A2A2A"/>
           </a:solidFill>
           <a:ln>
             <a:noFill/>
@@ -11531,7 +11531,7 @@
             <a:avLst/>
           </a:prstGeom>
           <a:solidFill>
-            <a:srgbClr val="DCD3C4"/>
+            <a:srgbClr val="2A2A2A"/>
           </a:solidFill>
           <a:ln>
             <a:noFill/>
@@ -11574,7 +11574,7 @@
             <a:avLst/>
           </a:prstGeom>
           <a:solidFill>
-            <a:srgbClr val="DCD3C4"/>
+            <a:srgbClr val="2A2A2A"/>
           </a:solidFill>
           <a:ln>
             <a:noFill/>
@@ -11617,7 +11617,7 @@
             <a:avLst/>
           </a:prstGeom>
           <a:solidFill>
-            <a:srgbClr val="183A2B"/>
+            <a:srgbClr val="FFFFFF"/>
           </a:solidFill>
           <a:ln>
             <a:noFill/>
@@ -11671,7 +11671,7 @@
             <a:r>
               <a:rPr sz="950" b="1">
                 <a:solidFill>
-                  <a:srgbClr val="5A6B63"/>
+                  <a:srgbClr val="888888"/>
                 </a:solidFill>
                 <a:latin typeface="JetBrains Mono"/>
               </a:rPr>
@@ -11706,7 +11706,7 @@
             <a:r>
               <a:rPr sz="950" b="1">
                 <a:solidFill>
-                  <a:srgbClr val="5A6B63"/>
+                  <a:srgbClr val="888888"/>
                 </a:solidFill>
                 <a:latin typeface="JetBrains Mono"/>
               </a:rPr>
@@ -11741,7 +11741,7 @@
             <a:r>
               <a:rPr sz="1100" b="1">
                 <a:solidFill>
-                  <a:srgbClr val="9E4D34"/>
+                  <a:srgbClr val="888888"/>
                 </a:solidFill>
                 <a:latin typeface="JetBrains Mono"/>
               </a:rPr>
@@ -11765,7 +11765,7 @@
             <a:avLst/>
           </a:prstGeom>
           <a:solidFill>
-            <a:srgbClr val="9E4D34"/>
+            <a:srgbClr val="FFFFFF"/>
           </a:solidFill>
           <a:ln>
             <a:noFill/>
@@ -11819,7 +11819,7 @@
             <a:r>
               <a:rPr sz="5600" b="1">
                 <a:solidFill>
-                  <a:srgbClr val="183A2B"/>
+                  <a:srgbClr val="FFFFFF"/>
                 </a:solidFill>
                 <a:latin typeface="Plus Jakarta Sans"/>
               </a:rPr>
@@ -11854,7 +11854,7 @@
             <a:r>
               <a:rPr sz="1700" b="0">
                 <a:solidFill>
-                  <a:srgbClr val="5A6B63"/>
+                  <a:srgbClr val="888888"/>
                 </a:solidFill>
                 <a:latin typeface="Plus Jakarta Sans"/>
               </a:rPr>
@@ -11878,7 +11878,7 @@
             <a:avLst/>
           </a:prstGeom>
           <a:solidFill>
-            <a:srgbClr val="EDE4D6"/>
+            <a:srgbClr val="222222"/>
           </a:solidFill>
           <a:ln>
             <a:noFill/>
@@ -11932,7 +11932,7 @@
             <a:r>
               <a:rPr sz="850" b="1">
                 <a:solidFill>
-                  <a:srgbClr val="9E4D34"/>
+                  <a:srgbClr val="888888"/>
                 </a:solidFill>
                 <a:latin typeface="JetBrains Mono"/>
               </a:rPr>
@@ -11967,7 +11967,7 @@
             <a:r>
               <a:rPr sz="1000" b="1">
                 <a:solidFill>
-                  <a:srgbClr val="183A2B"/>
+                  <a:srgbClr val="FFFFFF"/>
                 </a:solidFill>
                 <a:latin typeface="JetBrains Mono"/>
               </a:rPr>
@@ -12002,7 +12002,7 @@
             <a:r>
               <a:rPr sz="800" b="0">
                 <a:solidFill>
-                  <a:srgbClr val="5A6B63"/>
+                  <a:srgbClr val="888888"/>
                 </a:solidFill>
                 <a:latin typeface="JetBrains Mono"/>
               </a:rPr>
@@ -12037,7 +12037,7 @@
             <a:r>
               <a:rPr sz="750" b="1">
                 <a:solidFill>
-                  <a:srgbClr val="4A7A58"/>
+                  <a:srgbClr val="555555"/>
                 </a:solidFill>
                 <a:latin typeface="JetBrains Mono"/>
               </a:rPr>
@@ -12072,7 +12072,7 @@
             <a:r>
               <a:rPr sz="1000" b="1">
                 <a:solidFill>
-                  <a:srgbClr val="183A2B"/>
+                  <a:srgbClr val="FFFFFF"/>
                 </a:solidFill>
                 <a:latin typeface="JetBrains Mono"/>
               </a:rPr>
@@ -12107,7 +12107,7 @@
             <a:r>
               <a:rPr sz="800" b="0">
                 <a:solidFill>
-                  <a:srgbClr val="5A6B63"/>
+                  <a:srgbClr val="888888"/>
                 </a:solidFill>
                 <a:latin typeface="JetBrains Mono"/>
               </a:rPr>
@@ -12142,7 +12142,7 @@
             <a:r>
               <a:rPr sz="750" b="1">
                 <a:solidFill>
-                  <a:srgbClr val="4A7A58"/>
+                  <a:srgbClr val="555555"/>
                 </a:solidFill>
                 <a:latin typeface="JetBrains Mono"/>
               </a:rPr>
@@ -12177,7 +12177,7 @@
             <a:r>
               <a:rPr sz="1000" b="1">
                 <a:solidFill>
-                  <a:srgbClr val="183A2B"/>
+                  <a:srgbClr val="FFFFFF"/>
                 </a:solidFill>
                 <a:latin typeface="JetBrains Mono"/>
               </a:rPr>
@@ -12212,7 +12212,7 @@
             <a:r>
               <a:rPr sz="800" b="0">
                 <a:solidFill>
-                  <a:srgbClr val="5A6B63"/>
+                  <a:srgbClr val="888888"/>
                 </a:solidFill>
                 <a:latin typeface="JetBrains Mono"/>
               </a:rPr>
@@ -12247,7 +12247,7 @@
             <a:r>
               <a:rPr sz="750" b="1">
                 <a:solidFill>
-                  <a:srgbClr val="4A7A58"/>
+                  <a:srgbClr val="555555"/>
                 </a:solidFill>
                 <a:latin typeface="JetBrains Mono"/>
               </a:rPr>
@@ -12282,7 +12282,7 @@
             <a:r>
               <a:rPr sz="1000" b="1">
                 <a:solidFill>
-                  <a:srgbClr val="183A2B"/>
+                  <a:srgbClr val="FFFFFF"/>
                 </a:solidFill>
                 <a:latin typeface="JetBrains Mono"/>
               </a:rPr>
@@ -12317,7 +12317,7 @@
             <a:r>
               <a:rPr sz="800" b="0">
                 <a:solidFill>
-                  <a:srgbClr val="5A6B63"/>
+                  <a:srgbClr val="888888"/>
                 </a:solidFill>
                 <a:latin typeface="JetBrains Mono"/>
               </a:rPr>
@@ -12352,7 +12352,7 @@
             <a:r>
               <a:rPr sz="750" b="1">
                 <a:solidFill>
-                  <a:srgbClr val="4A7A58"/>
+                  <a:srgbClr val="555555"/>
                 </a:solidFill>
                 <a:latin typeface="JetBrains Mono"/>
               </a:rPr>
@@ -12387,7 +12387,7 @@
             <a:r>
               <a:rPr sz="1000" b="1">
                 <a:solidFill>
-                  <a:srgbClr val="183A2B"/>
+                  <a:srgbClr val="FFFFFF"/>
                 </a:solidFill>
                 <a:latin typeface="JetBrains Mono"/>
               </a:rPr>
@@ -12422,7 +12422,7 @@
             <a:r>
               <a:rPr sz="800" b="0">
                 <a:solidFill>
-                  <a:srgbClr val="5A6B63"/>
+                  <a:srgbClr val="888888"/>
                 </a:solidFill>
                 <a:latin typeface="JetBrains Mono"/>
               </a:rPr>
@@ -12457,7 +12457,7 @@
             <a:r>
               <a:rPr sz="750" b="1">
                 <a:solidFill>
-                  <a:srgbClr val="4A7A58"/>
+                  <a:srgbClr val="555555"/>
                 </a:solidFill>
                 <a:latin typeface="JetBrains Mono"/>
               </a:rPr>

</xml_diff>

<commit_message>
feat(design): implement Nothing Light Theme (#191516 & #FFFFFF) with NDot typography, red dot accent, and pure slide deck
</commit_message>
<xml_diff>
--- a/sutra_pitch_deck.pptx
+++ b/sutra_pitch_deck.pptx
@@ -3103,7 +3103,7 @@
             <a:avLst/>
           </a:prstGeom>
           <a:solidFill>
-            <a:srgbClr val="070707"/>
+            <a:srgbClr val="FFFFFF"/>
           </a:solidFill>
           <a:ln>
             <a:noFill/>
@@ -3146,7 +3146,7 @@
             <a:avLst/>
           </a:prstGeom>
           <a:solidFill>
-            <a:srgbClr val="2A2A2A"/>
+            <a:srgbClr val="DCD6D2"/>
           </a:solidFill>
           <a:ln>
             <a:noFill/>
@@ -3189,7 +3189,7 @@
             <a:avLst/>
           </a:prstGeom>
           <a:solidFill>
-            <a:srgbClr val="2A2A2A"/>
+            <a:srgbClr val="DCD6D2"/>
           </a:solidFill>
           <a:ln>
             <a:noFill/>
@@ -3232,7 +3232,7 @@
             <a:avLst/>
           </a:prstGeom>
           <a:solidFill>
-            <a:srgbClr val="2A2A2A"/>
+            <a:srgbClr val="DCD6D2"/>
           </a:solidFill>
           <a:ln>
             <a:noFill/>
@@ -3275,7 +3275,7 @@
             <a:avLst/>
           </a:prstGeom>
           <a:solidFill>
-            <a:srgbClr val="2A2A2A"/>
+            <a:srgbClr val="DCD6D2"/>
           </a:solidFill>
           <a:ln>
             <a:noFill/>
@@ -3318,7 +3318,7 @@
             <a:avLst/>
           </a:prstGeom>
           <a:solidFill>
-            <a:srgbClr val="2A2A2A"/>
+            <a:srgbClr val="DCD6D2"/>
           </a:solidFill>
           <a:ln>
             <a:noFill/>
@@ -3361,7 +3361,7 @@
             <a:avLst/>
           </a:prstGeom>
           <a:solidFill>
-            <a:srgbClr val="2A2A2A"/>
+            <a:srgbClr val="DCD6D2"/>
           </a:solidFill>
           <a:ln>
             <a:noFill/>
@@ -3404,7 +3404,7 @@
             <a:avLst/>
           </a:prstGeom>
           <a:solidFill>
-            <a:srgbClr val="2A2A2A"/>
+            <a:srgbClr val="DCD6D2"/>
           </a:solidFill>
           <a:ln>
             <a:noFill/>
@@ -3447,7 +3447,7 @@
             <a:avLst/>
           </a:prstGeom>
           <a:solidFill>
-            <a:srgbClr val="2A2A2A"/>
+            <a:srgbClr val="DCD6D2"/>
           </a:solidFill>
           <a:ln>
             <a:noFill/>
@@ -3490,7 +3490,7 @@
             <a:avLst/>
           </a:prstGeom>
           <a:solidFill>
-            <a:srgbClr val="2A2A2A"/>
+            <a:srgbClr val="DCD6D2"/>
           </a:solidFill>
           <a:ln>
             <a:noFill/>
@@ -3533,7 +3533,7 @@
             <a:avLst/>
           </a:prstGeom>
           <a:solidFill>
-            <a:srgbClr val="2A2A2A"/>
+            <a:srgbClr val="DCD6D2"/>
           </a:solidFill>
           <a:ln>
             <a:noFill/>
@@ -3576,7 +3576,7 @@
             <a:avLst/>
           </a:prstGeom>
           <a:solidFill>
-            <a:srgbClr val="2A2A2A"/>
+            <a:srgbClr val="DCD6D2"/>
           </a:solidFill>
           <a:ln>
             <a:noFill/>
@@ -3619,7 +3619,7 @@
             <a:avLst/>
           </a:prstGeom>
           <a:solidFill>
-            <a:srgbClr val="2A2A2A"/>
+            <a:srgbClr val="DCD6D2"/>
           </a:solidFill>
           <a:ln>
             <a:noFill/>
@@ -3662,7 +3662,7 @@
             <a:avLst/>
           </a:prstGeom>
           <a:solidFill>
-            <a:srgbClr val="2A2A2A"/>
+            <a:srgbClr val="DCD6D2"/>
           </a:solidFill>
           <a:ln>
             <a:noFill/>
@@ -3705,7 +3705,7 @@
             <a:avLst/>
           </a:prstGeom>
           <a:solidFill>
-            <a:srgbClr val="2A2A2A"/>
+            <a:srgbClr val="DCD6D2"/>
           </a:solidFill>
           <a:ln>
             <a:noFill/>
@@ -3748,7 +3748,7 @@
             <a:avLst/>
           </a:prstGeom>
           <a:solidFill>
-            <a:srgbClr val="2A2A2A"/>
+            <a:srgbClr val="DCD6D2"/>
           </a:solidFill>
           <a:ln>
             <a:noFill/>
@@ -3791,7 +3791,7 @@
             <a:avLst/>
           </a:prstGeom>
           <a:solidFill>
-            <a:srgbClr val="2A2A2A"/>
+            <a:srgbClr val="DCD6D2"/>
           </a:solidFill>
           <a:ln>
             <a:noFill/>
@@ -3834,7 +3834,7 @@
             <a:avLst/>
           </a:prstGeom>
           <a:solidFill>
-            <a:srgbClr val="2A2A2A"/>
+            <a:srgbClr val="DCD6D2"/>
           </a:solidFill>
           <a:ln>
             <a:noFill/>
@@ -3877,7 +3877,7 @@
             <a:avLst/>
           </a:prstGeom>
           <a:solidFill>
-            <a:srgbClr val="2A2A2A"/>
+            <a:srgbClr val="DCD6D2"/>
           </a:solidFill>
           <a:ln>
             <a:noFill/>
@@ -3920,7 +3920,7 @@
             <a:avLst/>
           </a:prstGeom>
           <a:solidFill>
-            <a:srgbClr val="2A2A2A"/>
+            <a:srgbClr val="DCD6D2"/>
           </a:solidFill>
           <a:ln>
             <a:noFill/>
@@ -3963,7 +3963,7 @@
             <a:avLst/>
           </a:prstGeom>
           <a:solidFill>
-            <a:srgbClr val="2A2A2A"/>
+            <a:srgbClr val="DCD6D2"/>
           </a:solidFill>
           <a:ln>
             <a:noFill/>
@@ -4006,7 +4006,7 @@
             <a:avLst/>
           </a:prstGeom>
           <a:solidFill>
-            <a:srgbClr val="2A2A2A"/>
+            <a:srgbClr val="DCD6D2"/>
           </a:solidFill>
           <a:ln>
             <a:noFill/>
@@ -4049,7 +4049,7 @@
             <a:avLst/>
           </a:prstGeom>
           <a:solidFill>
-            <a:srgbClr val="2A2A2A"/>
+            <a:srgbClr val="DCD6D2"/>
           </a:solidFill>
           <a:ln>
             <a:noFill/>
@@ -4092,7 +4092,7 @@
             <a:avLst/>
           </a:prstGeom>
           <a:solidFill>
-            <a:srgbClr val="2A2A2A"/>
+            <a:srgbClr val="DCD6D2"/>
           </a:solidFill>
           <a:ln>
             <a:noFill/>
@@ -4135,7 +4135,7 @@
             <a:avLst/>
           </a:prstGeom>
           <a:solidFill>
-            <a:srgbClr val="2A2A2A"/>
+            <a:srgbClr val="DCD6D2"/>
           </a:solidFill>
           <a:ln>
             <a:noFill/>
@@ -4178,7 +4178,7 @@
             <a:avLst/>
           </a:prstGeom>
           <a:solidFill>
-            <a:srgbClr val="2A2A2A"/>
+            <a:srgbClr val="DCD6D2"/>
           </a:solidFill>
           <a:ln>
             <a:noFill/>
@@ -4221,7 +4221,7 @@
             <a:avLst/>
           </a:prstGeom>
           <a:solidFill>
-            <a:srgbClr val="2A2A2A"/>
+            <a:srgbClr val="DCD6D2"/>
           </a:solidFill>
           <a:ln>
             <a:noFill/>
@@ -4264,7 +4264,7 @@
             <a:avLst/>
           </a:prstGeom>
           <a:solidFill>
-            <a:srgbClr val="2A2A2A"/>
+            <a:srgbClr val="DCD6D2"/>
           </a:solidFill>
           <a:ln>
             <a:noFill/>
@@ -4307,7 +4307,7 @@
             <a:avLst/>
           </a:prstGeom>
           <a:solidFill>
-            <a:srgbClr val="2A2A2A"/>
+            <a:srgbClr val="DCD6D2"/>
           </a:solidFill>
           <a:ln>
             <a:noFill/>
@@ -4350,7 +4350,7 @@
             <a:avLst/>
           </a:prstGeom>
           <a:solidFill>
-            <a:srgbClr val="2A2A2A"/>
+            <a:srgbClr val="DCD6D2"/>
           </a:solidFill>
           <a:ln>
             <a:noFill/>
@@ -4393,7 +4393,7 @@
             <a:avLst/>
           </a:prstGeom>
           <a:solidFill>
-            <a:srgbClr val="2A2A2A"/>
+            <a:srgbClr val="DCD6D2"/>
           </a:solidFill>
           <a:ln>
             <a:noFill/>
@@ -4436,7 +4436,7 @@
             <a:avLst/>
           </a:prstGeom>
           <a:solidFill>
-            <a:srgbClr val="2A2A2A"/>
+            <a:srgbClr val="DCD6D2"/>
           </a:solidFill>
           <a:ln>
             <a:noFill/>
@@ -4479,7 +4479,7 @@
             <a:avLst/>
           </a:prstGeom>
           <a:solidFill>
-            <a:srgbClr val="2A2A2A"/>
+            <a:srgbClr val="DCD6D2"/>
           </a:solidFill>
           <a:ln>
             <a:noFill/>
@@ -4522,7 +4522,7 @@
             <a:avLst/>
           </a:prstGeom>
           <a:solidFill>
-            <a:srgbClr val="2A2A2A"/>
+            <a:srgbClr val="DCD6D2"/>
           </a:solidFill>
           <a:ln>
             <a:noFill/>
@@ -4565,7 +4565,7 @@
             <a:avLst/>
           </a:prstGeom>
           <a:solidFill>
-            <a:srgbClr val="2A2A2A"/>
+            <a:srgbClr val="DCD6D2"/>
           </a:solidFill>
           <a:ln>
             <a:noFill/>
@@ -4608,7 +4608,7 @@
             <a:avLst/>
           </a:prstGeom>
           <a:solidFill>
-            <a:srgbClr val="2A2A2A"/>
+            <a:srgbClr val="DCD6D2"/>
           </a:solidFill>
           <a:ln>
             <a:noFill/>
@@ -4651,7 +4651,7 @@
             <a:avLst/>
           </a:prstGeom>
           <a:solidFill>
-            <a:srgbClr val="2A2A2A"/>
+            <a:srgbClr val="DCD6D2"/>
           </a:solidFill>
           <a:ln>
             <a:noFill/>
@@ -4694,7 +4694,7 @@
             <a:avLst/>
           </a:prstGeom>
           <a:solidFill>
-            <a:srgbClr val="2A2A2A"/>
+            <a:srgbClr val="DCD6D2"/>
           </a:solidFill>
           <a:ln>
             <a:noFill/>
@@ -4737,7 +4737,7 @@
             <a:avLst/>
           </a:prstGeom>
           <a:solidFill>
-            <a:srgbClr val="2A2A2A"/>
+            <a:srgbClr val="DCD6D2"/>
           </a:solidFill>
           <a:ln>
             <a:noFill/>
@@ -4780,7 +4780,7 @@
             <a:avLst/>
           </a:prstGeom>
           <a:solidFill>
-            <a:srgbClr val="2A2A2A"/>
+            <a:srgbClr val="DCD6D2"/>
           </a:solidFill>
           <a:ln>
             <a:noFill/>
@@ -4823,7 +4823,7 @@
             <a:avLst/>
           </a:prstGeom>
           <a:solidFill>
-            <a:srgbClr val="2A2A2A"/>
+            <a:srgbClr val="DCD6D2"/>
           </a:solidFill>
           <a:ln>
             <a:noFill/>
@@ -4866,7 +4866,7 @@
             <a:avLst/>
           </a:prstGeom>
           <a:solidFill>
-            <a:srgbClr val="2A2A2A"/>
+            <a:srgbClr val="DCD6D2"/>
           </a:solidFill>
           <a:ln>
             <a:noFill/>
@@ -4909,7 +4909,7 @@
             <a:avLst/>
           </a:prstGeom>
           <a:solidFill>
-            <a:srgbClr val="2A2A2A"/>
+            <a:srgbClr val="DCD6D2"/>
           </a:solidFill>
           <a:ln>
             <a:noFill/>
@@ -4952,7 +4952,7 @@
             <a:avLst/>
           </a:prstGeom>
           <a:solidFill>
-            <a:srgbClr val="2A2A2A"/>
+            <a:srgbClr val="DCD6D2"/>
           </a:solidFill>
           <a:ln>
             <a:noFill/>
@@ -4995,7 +4995,7 @@
             <a:avLst/>
           </a:prstGeom>
           <a:solidFill>
-            <a:srgbClr val="2A2A2A"/>
+            <a:srgbClr val="DCD6D2"/>
           </a:solidFill>
           <a:ln>
             <a:noFill/>
@@ -5038,7 +5038,7 @@
             <a:avLst/>
           </a:prstGeom>
           <a:solidFill>
-            <a:srgbClr val="2A2A2A"/>
+            <a:srgbClr val="DCD6D2"/>
           </a:solidFill>
           <a:ln>
             <a:noFill/>
@@ -5081,7 +5081,7 @@
             <a:avLst/>
           </a:prstGeom>
           <a:solidFill>
-            <a:srgbClr val="2A2A2A"/>
+            <a:srgbClr val="DCD6D2"/>
           </a:solidFill>
           <a:ln>
             <a:noFill/>
@@ -5124,7 +5124,7 @@
             <a:avLst/>
           </a:prstGeom>
           <a:solidFill>
-            <a:srgbClr val="2A2A2A"/>
+            <a:srgbClr val="DCD6D2"/>
           </a:solidFill>
           <a:ln>
             <a:noFill/>
@@ -5167,7 +5167,7 @@
             <a:avLst/>
           </a:prstGeom>
           <a:solidFill>
-            <a:srgbClr val="2A2A2A"/>
+            <a:srgbClr val="DCD6D2"/>
           </a:solidFill>
           <a:ln>
             <a:noFill/>
@@ -5210,7 +5210,7 @@
             <a:avLst/>
           </a:prstGeom>
           <a:solidFill>
-            <a:srgbClr val="2A2A2A"/>
+            <a:srgbClr val="DCD6D2"/>
           </a:solidFill>
           <a:ln>
             <a:noFill/>
@@ -5253,7 +5253,7 @@
             <a:avLst/>
           </a:prstGeom>
           <a:solidFill>
-            <a:srgbClr val="2A2A2A"/>
+            <a:srgbClr val="DCD6D2"/>
           </a:solidFill>
           <a:ln>
             <a:noFill/>
@@ -5296,7 +5296,7 @@
             <a:avLst/>
           </a:prstGeom>
           <a:solidFill>
-            <a:srgbClr val="2A2A2A"/>
+            <a:srgbClr val="DCD6D2"/>
           </a:solidFill>
           <a:ln>
             <a:noFill/>
@@ -5339,7 +5339,7 @@
             <a:avLst/>
           </a:prstGeom>
           <a:solidFill>
-            <a:srgbClr val="2A2A2A"/>
+            <a:srgbClr val="DCD6D2"/>
           </a:solidFill>
           <a:ln>
             <a:noFill/>
@@ -5382,7 +5382,7 @@
             <a:avLst/>
           </a:prstGeom>
           <a:solidFill>
-            <a:srgbClr val="2A2A2A"/>
+            <a:srgbClr val="DCD6D2"/>
           </a:solidFill>
           <a:ln>
             <a:noFill/>
@@ -5425,7 +5425,7 @@
             <a:avLst/>
           </a:prstGeom>
           <a:solidFill>
-            <a:srgbClr val="2A2A2A"/>
+            <a:srgbClr val="DCD6D2"/>
           </a:solidFill>
           <a:ln>
             <a:noFill/>
@@ -5468,7 +5468,7 @@
             <a:avLst/>
           </a:prstGeom>
           <a:solidFill>
-            <a:srgbClr val="2A2A2A"/>
+            <a:srgbClr val="DCD6D2"/>
           </a:solidFill>
           <a:ln>
             <a:noFill/>
@@ -5511,7 +5511,7 @@
             <a:avLst/>
           </a:prstGeom>
           <a:solidFill>
-            <a:srgbClr val="2A2A2A"/>
+            <a:srgbClr val="DCD6D2"/>
           </a:solidFill>
           <a:ln>
             <a:noFill/>
@@ -5554,7 +5554,7 @@
             <a:avLst/>
           </a:prstGeom>
           <a:solidFill>
-            <a:srgbClr val="2A2A2A"/>
+            <a:srgbClr val="DCD6D2"/>
           </a:solidFill>
           <a:ln>
             <a:noFill/>
@@ -5597,7 +5597,7 @@
             <a:avLst/>
           </a:prstGeom>
           <a:solidFill>
-            <a:srgbClr val="2A2A2A"/>
+            <a:srgbClr val="DCD6D2"/>
           </a:solidFill>
           <a:ln>
             <a:noFill/>
@@ -5640,7 +5640,7 @@
             <a:avLst/>
           </a:prstGeom>
           <a:solidFill>
-            <a:srgbClr val="2A2A2A"/>
+            <a:srgbClr val="DCD6D2"/>
           </a:solidFill>
           <a:ln>
             <a:noFill/>
@@ -5683,7 +5683,7 @@
             <a:avLst/>
           </a:prstGeom>
           <a:solidFill>
-            <a:srgbClr val="2A2A2A"/>
+            <a:srgbClr val="DCD6D2"/>
           </a:solidFill>
           <a:ln>
             <a:noFill/>
@@ -5726,7 +5726,7 @@
             <a:avLst/>
           </a:prstGeom>
           <a:solidFill>
-            <a:srgbClr val="2A2A2A"/>
+            <a:srgbClr val="DCD6D2"/>
           </a:solidFill>
           <a:ln>
             <a:noFill/>
@@ -5769,7 +5769,7 @@
             <a:avLst/>
           </a:prstGeom>
           <a:solidFill>
-            <a:srgbClr val="2A2A2A"/>
+            <a:srgbClr val="DCD6D2"/>
           </a:solidFill>
           <a:ln>
             <a:noFill/>
@@ -5812,7 +5812,7 @@
             <a:avLst/>
           </a:prstGeom>
           <a:solidFill>
-            <a:srgbClr val="2A2A2A"/>
+            <a:srgbClr val="DCD6D2"/>
           </a:solidFill>
           <a:ln>
             <a:noFill/>
@@ -5855,7 +5855,7 @@
             <a:avLst/>
           </a:prstGeom>
           <a:solidFill>
-            <a:srgbClr val="2A2A2A"/>
+            <a:srgbClr val="DCD6D2"/>
           </a:solidFill>
           <a:ln>
             <a:noFill/>
@@ -5898,7 +5898,7 @@
             <a:avLst/>
           </a:prstGeom>
           <a:solidFill>
-            <a:srgbClr val="2A2A2A"/>
+            <a:srgbClr val="DCD6D2"/>
           </a:solidFill>
           <a:ln>
             <a:noFill/>
@@ -5941,7 +5941,7 @@
             <a:avLst/>
           </a:prstGeom>
           <a:solidFill>
-            <a:srgbClr val="2A2A2A"/>
+            <a:srgbClr val="DCD6D2"/>
           </a:solidFill>
           <a:ln>
             <a:noFill/>
@@ -5984,7 +5984,7 @@
             <a:avLst/>
           </a:prstGeom>
           <a:solidFill>
-            <a:srgbClr val="2A2A2A"/>
+            <a:srgbClr val="DCD6D2"/>
           </a:solidFill>
           <a:ln>
             <a:noFill/>
@@ -6027,7 +6027,7 @@
             <a:avLst/>
           </a:prstGeom>
           <a:solidFill>
-            <a:srgbClr val="2A2A2A"/>
+            <a:srgbClr val="DCD6D2"/>
           </a:solidFill>
           <a:ln>
             <a:noFill/>
@@ -6070,7 +6070,7 @@
             <a:avLst/>
           </a:prstGeom>
           <a:solidFill>
-            <a:srgbClr val="2A2A2A"/>
+            <a:srgbClr val="DCD6D2"/>
           </a:solidFill>
           <a:ln>
             <a:noFill/>
@@ -6113,7 +6113,7 @@
             <a:avLst/>
           </a:prstGeom>
           <a:solidFill>
-            <a:srgbClr val="2A2A2A"/>
+            <a:srgbClr val="DCD6D2"/>
           </a:solidFill>
           <a:ln>
             <a:noFill/>
@@ -6156,7 +6156,7 @@
             <a:avLst/>
           </a:prstGeom>
           <a:solidFill>
-            <a:srgbClr val="2A2A2A"/>
+            <a:srgbClr val="DCD6D2"/>
           </a:solidFill>
           <a:ln>
             <a:noFill/>
@@ -6199,7 +6199,7 @@
             <a:avLst/>
           </a:prstGeom>
           <a:solidFill>
-            <a:srgbClr val="2A2A2A"/>
+            <a:srgbClr val="DCD6D2"/>
           </a:solidFill>
           <a:ln>
             <a:noFill/>
@@ -6242,7 +6242,7 @@
             <a:avLst/>
           </a:prstGeom>
           <a:solidFill>
-            <a:srgbClr val="2A2A2A"/>
+            <a:srgbClr val="DCD6D2"/>
           </a:solidFill>
           <a:ln>
             <a:noFill/>
@@ -6285,7 +6285,7 @@
             <a:avLst/>
           </a:prstGeom>
           <a:solidFill>
-            <a:srgbClr val="2A2A2A"/>
+            <a:srgbClr val="DCD6D2"/>
           </a:solidFill>
           <a:ln>
             <a:noFill/>
@@ -6328,7 +6328,7 @@
             <a:avLst/>
           </a:prstGeom>
           <a:solidFill>
-            <a:srgbClr val="2A2A2A"/>
+            <a:srgbClr val="DCD6D2"/>
           </a:solidFill>
           <a:ln>
             <a:noFill/>
@@ -6371,7 +6371,7 @@
             <a:avLst/>
           </a:prstGeom>
           <a:solidFill>
-            <a:srgbClr val="2A2A2A"/>
+            <a:srgbClr val="DCD6D2"/>
           </a:solidFill>
           <a:ln>
             <a:noFill/>
@@ -6414,7 +6414,7 @@
             <a:avLst/>
           </a:prstGeom>
           <a:solidFill>
-            <a:srgbClr val="2A2A2A"/>
+            <a:srgbClr val="DCD6D2"/>
           </a:solidFill>
           <a:ln>
             <a:noFill/>
@@ -6457,7 +6457,7 @@
             <a:avLst/>
           </a:prstGeom>
           <a:solidFill>
-            <a:srgbClr val="2A2A2A"/>
+            <a:srgbClr val="DCD6D2"/>
           </a:solidFill>
           <a:ln>
             <a:noFill/>
@@ -6500,7 +6500,7 @@
             <a:avLst/>
           </a:prstGeom>
           <a:solidFill>
-            <a:srgbClr val="2A2A2A"/>
+            <a:srgbClr val="DCD6D2"/>
           </a:solidFill>
           <a:ln>
             <a:noFill/>
@@ -6543,7 +6543,7 @@
             <a:avLst/>
           </a:prstGeom>
           <a:solidFill>
-            <a:srgbClr val="2A2A2A"/>
+            <a:srgbClr val="DCD6D2"/>
           </a:solidFill>
           <a:ln>
             <a:noFill/>
@@ -6586,7 +6586,7 @@
             <a:avLst/>
           </a:prstGeom>
           <a:solidFill>
-            <a:srgbClr val="2A2A2A"/>
+            <a:srgbClr val="DCD6D2"/>
           </a:solidFill>
           <a:ln>
             <a:noFill/>
@@ -6629,7 +6629,7 @@
             <a:avLst/>
           </a:prstGeom>
           <a:solidFill>
-            <a:srgbClr val="2A2A2A"/>
+            <a:srgbClr val="DCD6D2"/>
           </a:solidFill>
           <a:ln>
             <a:noFill/>
@@ -6672,7 +6672,7 @@
             <a:avLst/>
           </a:prstGeom>
           <a:solidFill>
-            <a:srgbClr val="2A2A2A"/>
+            <a:srgbClr val="DCD6D2"/>
           </a:solidFill>
           <a:ln>
             <a:noFill/>
@@ -6715,7 +6715,7 @@
             <a:avLst/>
           </a:prstGeom>
           <a:solidFill>
-            <a:srgbClr val="2A2A2A"/>
+            <a:srgbClr val="DCD6D2"/>
           </a:solidFill>
           <a:ln>
             <a:noFill/>
@@ -6758,7 +6758,7 @@
             <a:avLst/>
           </a:prstGeom>
           <a:solidFill>
-            <a:srgbClr val="2A2A2A"/>
+            <a:srgbClr val="DCD6D2"/>
           </a:solidFill>
           <a:ln>
             <a:noFill/>
@@ -6801,7 +6801,7 @@
             <a:avLst/>
           </a:prstGeom>
           <a:solidFill>
-            <a:srgbClr val="2A2A2A"/>
+            <a:srgbClr val="DCD6D2"/>
           </a:solidFill>
           <a:ln>
             <a:noFill/>
@@ -6844,7 +6844,7 @@
             <a:avLst/>
           </a:prstGeom>
           <a:solidFill>
-            <a:srgbClr val="2A2A2A"/>
+            <a:srgbClr val="DCD6D2"/>
           </a:solidFill>
           <a:ln>
             <a:noFill/>
@@ -6887,7 +6887,7 @@
             <a:avLst/>
           </a:prstGeom>
           <a:solidFill>
-            <a:srgbClr val="2A2A2A"/>
+            <a:srgbClr val="DCD6D2"/>
           </a:solidFill>
           <a:ln>
             <a:noFill/>
@@ -6930,7 +6930,7 @@
             <a:avLst/>
           </a:prstGeom>
           <a:solidFill>
-            <a:srgbClr val="2A2A2A"/>
+            <a:srgbClr val="DCD6D2"/>
           </a:solidFill>
           <a:ln>
             <a:noFill/>
@@ -6973,7 +6973,7 @@
             <a:avLst/>
           </a:prstGeom>
           <a:solidFill>
-            <a:srgbClr val="2A2A2A"/>
+            <a:srgbClr val="DCD6D2"/>
           </a:solidFill>
           <a:ln>
             <a:noFill/>
@@ -7016,7 +7016,7 @@
             <a:avLst/>
           </a:prstGeom>
           <a:solidFill>
-            <a:srgbClr val="2A2A2A"/>
+            <a:srgbClr val="DCD6D2"/>
           </a:solidFill>
           <a:ln>
             <a:noFill/>
@@ -7059,7 +7059,7 @@
             <a:avLst/>
           </a:prstGeom>
           <a:solidFill>
-            <a:srgbClr val="2A2A2A"/>
+            <a:srgbClr val="DCD6D2"/>
           </a:solidFill>
           <a:ln>
             <a:noFill/>
@@ -7102,7 +7102,7 @@
             <a:avLst/>
           </a:prstGeom>
           <a:solidFill>
-            <a:srgbClr val="2A2A2A"/>
+            <a:srgbClr val="DCD6D2"/>
           </a:solidFill>
           <a:ln>
             <a:noFill/>
@@ -7145,7 +7145,7 @@
             <a:avLst/>
           </a:prstGeom>
           <a:solidFill>
-            <a:srgbClr val="2A2A2A"/>
+            <a:srgbClr val="DCD6D2"/>
           </a:solidFill>
           <a:ln>
             <a:noFill/>
@@ -7188,7 +7188,7 @@
             <a:avLst/>
           </a:prstGeom>
           <a:solidFill>
-            <a:srgbClr val="2A2A2A"/>
+            <a:srgbClr val="DCD6D2"/>
           </a:solidFill>
           <a:ln>
             <a:noFill/>
@@ -7231,7 +7231,7 @@
             <a:avLst/>
           </a:prstGeom>
           <a:solidFill>
-            <a:srgbClr val="2A2A2A"/>
+            <a:srgbClr val="DCD6D2"/>
           </a:solidFill>
           <a:ln>
             <a:noFill/>
@@ -7274,7 +7274,7 @@
             <a:avLst/>
           </a:prstGeom>
           <a:solidFill>
-            <a:srgbClr val="2A2A2A"/>
+            <a:srgbClr val="DCD6D2"/>
           </a:solidFill>
           <a:ln>
             <a:noFill/>
@@ -7317,7 +7317,7 @@
             <a:avLst/>
           </a:prstGeom>
           <a:solidFill>
-            <a:srgbClr val="2A2A2A"/>
+            <a:srgbClr val="DCD6D2"/>
           </a:solidFill>
           <a:ln>
             <a:noFill/>
@@ -7360,7 +7360,7 @@
             <a:avLst/>
           </a:prstGeom>
           <a:solidFill>
-            <a:srgbClr val="2A2A2A"/>
+            <a:srgbClr val="DCD6D2"/>
           </a:solidFill>
           <a:ln>
             <a:noFill/>
@@ -7403,7 +7403,7 @@
             <a:avLst/>
           </a:prstGeom>
           <a:solidFill>
-            <a:srgbClr val="2A2A2A"/>
+            <a:srgbClr val="DCD6D2"/>
           </a:solidFill>
           <a:ln>
             <a:noFill/>
@@ -7446,7 +7446,7 @@
             <a:avLst/>
           </a:prstGeom>
           <a:solidFill>
-            <a:srgbClr val="2A2A2A"/>
+            <a:srgbClr val="DCD6D2"/>
           </a:solidFill>
           <a:ln>
             <a:noFill/>
@@ -7489,7 +7489,7 @@
             <a:avLst/>
           </a:prstGeom>
           <a:solidFill>
-            <a:srgbClr val="2A2A2A"/>
+            <a:srgbClr val="DCD6D2"/>
           </a:solidFill>
           <a:ln>
             <a:noFill/>
@@ -7532,7 +7532,7 @@
             <a:avLst/>
           </a:prstGeom>
           <a:solidFill>
-            <a:srgbClr val="2A2A2A"/>
+            <a:srgbClr val="DCD6D2"/>
           </a:solidFill>
           <a:ln>
             <a:noFill/>
@@ -7575,7 +7575,7 @@
             <a:avLst/>
           </a:prstGeom>
           <a:solidFill>
-            <a:srgbClr val="2A2A2A"/>
+            <a:srgbClr val="DCD6D2"/>
           </a:solidFill>
           <a:ln>
             <a:noFill/>
@@ -7618,7 +7618,7 @@
             <a:avLst/>
           </a:prstGeom>
           <a:solidFill>
-            <a:srgbClr val="2A2A2A"/>
+            <a:srgbClr val="DCD6D2"/>
           </a:solidFill>
           <a:ln>
             <a:noFill/>
@@ -7661,7 +7661,7 @@
             <a:avLst/>
           </a:prstGeom>
           <a:solidFill>
-            <a:srgbClr val="2A2A2A"/>
+            <a:srgbClr val="DCD6D2"/>
           </a:solidFill>
           <a:ln>
             <a:noFill/>
@@ -7704,7 +7704,7 @@
             <a:avLst/>
           </a:prstGeom>
           <a:solidFill>
-            <a:srgbClr val="2A2A2A"/>
+            <a:srgbClr val="DCD6D2"/>
           </a:solidFill>
           <a:ln>
             <a:noFill/>
@@ -7747,7 +7747,7 @@
             <a:avLst/>
           </a:prstGeom>
           <a:solidFill>
-            <a:srgbClr val="2A2A2A"/>
+            <a:srgbClr val="DCD6D2"/>
           </a:solidFill>
           <a:ln>
             <a:noFill/>
@@ -7790,7 +7790,7 @@
             <a:avLst/>
           </a:prstGeom>
           <a:solidFill>
-            <a:srgbClr val="2A2A2A"/>
+            <a:srgbClr val="DCD6D2"/>
           </a:solidFill>
           <a:ln>
             <a:noFill/>
@@ -7833,7 +7833,7 @@
             <a:avLst/>
           </a:prstGeom>
           <a:solidFill>
-            <a:srgbClr val="2A2A2A"/>
+            <a:srgbClr val="DCD6D2"/>
           </a:solidFill>
           <a:ln>
             <a:noFill/>
@@ -7876,7 +7876,7 @@
             <a:avLst/>
           </a:prstGeom>
           <a:solidFill>
-            <a:srgbClr val="2A2A2A"/>
+            <a:srgbClr val="DCD6D2"/>
           </a:solidFill>
           <a:ln>
             <a:noFill/>
@@ -7919,7 +7919,7 @@
             <a:avLst/>
           </a:prstGeom>
           <a:solidFill>
-            <a:srgbClr val="2A2A2A"/>
+            <a:srgbClr val="DCD6D2"/>
           </a:solidFill>
           <a:ln>
             <a:noFill/>
@@ -7962,7 +7962,7 @@
             <a:avLst/>
           </a:prstGeom>
           <a:solidFill>
-            <a:srgbClr val="2A2A2A"/>
+            <a:srgbClr val="DCD6D2"/>
           </a:solidFill>
           <a:ln>
             <a:noFill/>
@@ -8005,7 +8005,7 @@
             <a:avLst/>
           </a:prstGeom>
           <a:solidFill>
-            <a:srgbClr val="2A2A2A"/>
+            <a:srgbClr val="DCD6D2"/>
           </a:solidFill>
           <a:ln>
             <a:noFill/>
@@ -8048,7 +8048,7 @@
             <a:avLst/>
           </a:prstGeom>
           <a:solidFill>
-            <a:srgbClr val="2A2A2A"/>
+            <a:srgbClr val="DCD6D2"/>
           </a:solidFill>
           <a:ln>
             <a:noFill/>
@@ -8091,7 +8091,7 @@
             <a:avLst/>
           </a:prstGeom>
           <a:solidFill>
-            <a:srgbClr val="2A2A2A"/>
+            <a:srgbClr val="DCD6D2"/>
           </a:solidFill>
           <a:ln>
             <a:noFill/>
@@ -8134,7 +8134,7 @@
             <a:avLst/>
           </a:prstGeom>
           <a:solidFill>
-            <a:srgbClr val="2A2A2A"/>
+            <a:srgbClr val="DCD6D2"/>
           </a:solidFill>
           <a:ln>
             <a:noFill/>
@@ -8177,7 +8177,7 @@
             <a:avLst/>
           </a:prstGeom>
           <a:solidFill>
-            <a:srgbClr val="2A2A2A"/>
+            <a:srgbClr val="DCD6D2"/>
           </a:solidFill>
           <a:ln>
             <a:noFill/>
@@ -8220,7 +8220,7 @@
             <a:avLst/>
           </a:prstGeom>
           <a:solidFill>
-            <a:srgbClr val="2A2A2A"/>
+            <a:srgbClr val="DCD6D2"/>
           </a:solidFill>
           <a:ln>
             <a:noFill/>
@@ -8263,7 +8263,7 @@
             <a:avLst/>
           </a:prstGeom>
           <a:solidFill>
-            <a:srgbClr val="2A2A2A"/>
+            <a:srgbClr val="DCD6D2"/>
           </a:solidFill>
           <a:ln>
             <a:noFill/>
@@ -8306,7 +8306,7 @@
             <a:avLst/>
           </a:prstGeom>
           <a:solidFill>
-            <a:srgbClr val="2A2A2A"/>
+            <a:srgbClr val="DCD6D2"/>
           </a:solidFill>
           <a:ln>
             <a:noFill/>
@@ -8349,7 +8349,7 @@
             <a:avLst/>
           </a:prstGeom>
           <a:solidFill>
-            <a:srgbClr val="2A2A2A"/>
+            <a:srgbClr val="DCD6D2"/>
           </a:solidFill>
           <a:ln>
             <a:noFill/>
@@ -8392,7 +8392,7 @@
             <a:avLst/>
           </a:prstGeom>
           <a:solidFill>
-            <a:srgbClr val="2A2A2A"/>
+            <a:srgbClr val="DCD6D2"/>
           </a:solidFill>
           <a:ln>
             <a:noFill/>
@@ -8435,7 +8435,7 @@
             <a:avLst/>
           </a:prstGeom>
           <a:solidFill>
-            <a:srgbClr val="2A2A2A"/>
+            <a:srgbClr val="DCD6D2"/>
           </a:solidFill>
           <a:ln>
             <a:noFill/>
@@ -8478,7 +8478,7 @@
             <a:avLst/>
           </a:prstGeom>
           <a:solidFill>
-            <a:srgbClr val="2A2A2A"/>
+            <a:srgbClr val="DCD6D2"/>
           </a:solidFill>
           <a:ln>
             <a:noFill/>
@@ -8521,7 +8521,7 @@
             <a:avLst/>
           </a:prstGeom>
           <a:solidFill>
-            <a:srgbClr val="2A2A2A"/>
+            <a:srgbClr val="DCD6D2"/>
           </a:solidFill>
           <a:ln>
             <a:noFill/>
@@ -8564,7 +8564,7 @@
             <a:avLst/>
           </a:prstGeom>
           <a:solidFill>
-            <a:srgbClr val="2A2A2A"/>
+            <a:srgbClr val="DCD6D2"/>
           </a:solidFill>
           <a:ln>
             <a:noFill/>
@@ -8607,7 +8607,7 @@
             <a:avLst/>
           </a:prstGeom>
           <a:solidFill>
-            <a:srgbClr val="2A2A2A"/>
+            <a:srgbClr val="DCD6D2"/>
           </a:solidFill>
           <a:ln>
             <a:noFill/>
@@ -8650,7 +8650,7 @@
             <a:avLst/>
           </a:prstGeom>
           <a:solidFill>
-            <a:srgbClr val="2A2A2A"/>
+            <a:srgbClr val="DCD6D2"/>
           </a:solidFill>
           <a:ln>
             <a:noFill/>
@@ -8693,7 +8693,7 @@
             <a:avLst/>
           </a:prstGeom>
           <a:solidFill>
-            <a:srgbClr val="2A2A2A"/>
+            <a:srgbClr val="DCD6D2"/>
           </a:solidFill>
           <a:ln>
             <a:noFill/>
@@ -8736,7 +8736,7 @@
             <a:avLst/>
           </a:prstGeom>
           <a:solidFill>
-            <a:srgbClr val="2A2A2A"/>
+            <a:srgbClr val="DCD6D2"/>
           </a:solidFill>
           <a:ln>
             <a:noFill/>
@@ -8779,7 +8779,7 @@
             <a:avLst/>
           </a:prstGeom>
           <a:solidFill>
-            <a:srgbClr val="2A2A2A"/>
+            <a:srgbClr val="DCD6D2"/>
           </a:solidFill>
           <a:ln>
             <a:noFill/>
@@ -8822,7 +8822,7 @@
             <a:avLst/>
           </a:prstGeom>
           <a:solidFill>
-            <a:srgbClr val="2A2A2A"/>
+            <a:srgbClr val="DCD6D2"/>
           </a:solidFill>
           <a:ln>
             <a:noFill/>
@@ -8865,7 +8865,7 @@
             <a:avLst/>
           </a:prstGeom>
           <a:solidFill>
-            <a:srgbClr val="2A2A2A"/>
+            <a:srgbClr val="DCD6D2"/>
           </a:solidFill>
           <a:ln>
             <a:noFill/>
@@ -8908,7 +8908,7 @@
             <a:avLst/>
           </a:prstGeom>
           <a:solidFill>
-            <a:srgbClr val="2A2A2A"/>
+            <a:srgbClr val="DCD6D2"/>
           </a:solidFill>
           <a:ln>
             <a:noFill/>
@@ -8951,7 +8951,7 @@
             <a:avLst/>
           </a:prstGeom>
           <a:solidFill>
-            <a:srgbClr val="2A2A2A"/>
+            <a:srgbClr val="DCD6D2"/>
           </a:solidFill>
           <a:ln>
             <a:noFill/>
@@ -8994,7 +8994,7 @@
             <a:avLst/>
           </a:prstGeom>
           <a:solidFill>
-            <a:srgbClr val="2A2A2A"/>
+            <a:srgbClr val="DCD6D2"/>
           </a:solidFill>
           <a:ln>
             <a:noFill/>
@@ -9037,7 +9037,7 @@
             <a:avLst/>
           </a:prstGeom>
           <a:solidFill>
-            <a:srgbClr val="2A2A2A"/>
+            <a:srgbClr val="DCD6D2"/>
           </a:solidFill>
           <a:ln>
             <a:noFill/>
@@ -9080,7 +9080,7 @@
             <a:avLst/>
           </a:prstGeom>
           <a:solidFill>
-            <a:srgbClr val="2A2A2A"/>
+            <a:srgbClr val="DCD6D2"/>
           </a:solidFill>
           <a:ln>
             <a:noFill/>
@@ -9123,7 +9123,7 @@
             <a:avLst/>
           </a:prstGeom>
           <a:solidFill>
-            <a:srgbClr val="2A2A2A"/>
+            <a:srgbClr val="DCD6D2"/>
           </a:solidFill>
           <a:ln>
             <a:noFill/>
@@ -9166,7 +9166,7 @@
             <a:avLst/>
           </a:prstGeom>
           <a:solidFill>
-            <a:srgbClr val="2A2A2A"/>
+            <a:srgbClr val="DCD6D2"/>
           </a:solidFill>
           <a:ln>
             <a:noFill/>
@@ -9209,7 +9209,7 @@
             <a:avLst/>
           </a:prstGeom>
           <a:solidFill>
-            <a:srgbClr val="2A2A2A"/>
+            <a:srgbClr val="DCD6D2"/>
           </a:solidFill>
           <a:ln>
             <a:noFill/>
@@ -9252,7 +9252,7 @@
             <a:avLst/>
           </a:prstGeom>
           <a:solidFill>
-            <a:srgbClr val="2A2A2A"/>
+            <a:srgbClr val="DCD6D2"/>
           </a:solidFill>
           <a:ln>
             <a:noFill/>
@@ -9295,7 +9295,7 @@
             <a:avLst/>
           </a:prstGeom>
           <a:solidFill>
-            <a:srgbClr val="2A2A2A"/>
+            <a:srgbClr val="DCD6D2"/>
           </a:solidFill>
           <a:ln>
             <a:noFill/>
@@ -9338,7 +9338,7 @@
             <a:avLst/>
           </a:prstGeom>
           <a:solidFill>
-            <a:srgbClr val="2A2A2A"/>
+            <a:srgbClr val="DCD6D2"/>
           </a:solidFill>
           <a:ln>
             <a:noFill/>
@@ -9381,7 +9381,7 @@
             <a:avLst/>
           </a:prstGeom>
           <a:solidFill>
-            <a:srgbClr val="2A2A2A"/>
+            <a:srgbClr val="DCD6D2"/>
           </a:solidFill>
           <a:ln>
             <a:noFill/>
@@ -9424,7 +9424,7 @@
             <a:avLst/>
           </a:prstGeom>
           <a:solidFill>
-            <a:srgbClr val="2A2A2A"/>
+            <a:srgbClr val="DCD6D2"/>
           </a:solidFill>
           <a:ln>
             <a:noFill/>
@@ -9467,7 +9467,7 @@
             <a:avLst/>
           </a:prstGeom>
           <a:solidFill>
-            <a:srgbClr val="2A2A2A"/>
+            <a:srgbClr val="DCD6D2"/>
           </a:solidFill>
           <a:ln>
             <a:noFill/>
@@ -9510,7 +9510,7 @@
             <a:avLst/>
           </a:prstGeom>
           <a:solidFill>
-            <a:srgbClr val="2A2A2A"/>
+            <a:srgbClr val="DCD6D2"/>
           </a:solidFill>
           <a:ln>
             <a:noFill/>
@@ -9553,7 +9553,7 @@
             <a:avLst/>
           </a:prstGeom>
           <a:solidFill>
-            <a:srgbClr val="2A2A2A"/>
+            <a:srgbClr val="DCD6D2"/>
           </a:solidFill>
           <a:ln>
             <a:noFill/>
@@ -9596,7 +9596,7 @@
             <a:avLst/>
           </a:prstGeom>
           <a:solidFill>
-            <a:srgbClr val="2A2A2A"/>
+            <a:srgbClr val="DCD6D2"/>
           </a:solidFill>
           <a:ln>
             <a:noFill/>
@@ -9639,7 +9639,7 @@
             <a:avLst/>
           </a:prstGeom>
           <a:solidFill>
-            <a:srgbClr val="2A2A2A"/>
+            <a:srgbClr val="DCD6D2"/>
           </a:solidFill>
           <a:ln>
             <a:noFill/>
@@ -9682,7 +9682,7 @@
             <a:avLst/>
           </a:prstGeom>
           <a:solidFill>
-            <a:srgbClr val="2A2A2A"/>
+            <a:srgbClr val="DCD6D2"/>
           </a:solidFill>
           <a:ln>
             <a:noFill/>
@@ -9725,7 +9725,7 @@
             <a:avLst/>
           </a:prstGeom>
           <a:solidFill>
-            <a:srgbClr val="2A2A2A"/>
+            <a:srgbClr val="DCD6D2"/>
           </a:solidFill>
           <a:ln>
             <a:noFill/>
@@ -9768,7 +9768,7 @@
             <a:avLst/>
           </a:prstGeom>
           <a:solidFill>
-            <a:srgbClr val="2A2A2A"/>
+            <a:srgbClr val="DCD6D2"/>
           </a:solidFill>
           <a:ln>
             <a:noFill/>
@@ -9811,7 +9811,7 @@
             <a:avLst/>
           </a:prstGeom>
           <a:solidFill>
-            <a:srgbClr val="2A2A2A"/>
+            <a:srgbClr val="DCD6D2"/>
           </a:solidFill>
           <a:ln>
             <a:noFill/>
@@ -9854,7 +9854,7 @@
             <a:avLst/>
           </a:prstGeom>
           <a:solidFill>
-            <a:srgbClr val="2A2A2A"/>
+            <a:srgbClr val="DCD6D2"/>
           </a:solidFill>
           <a:ln>
             <a:noFill/>
@@ -9897,7 +9897,7 @@
             <a:avLst/>
           </a:prstGeom>
           <a:solidFill>
-            <a:srgbClr val="2A2A2A"/>
+            <a:srgbClr val="DCD6D2"/>
           </a:solidFill>
           <a:ln>
             <a:noFill/>
@@ -9940,7 +9940,7 @@
             <a:avLst/>
           </a:prstGeom>
           <a:solidFill>
-            <a:srgbClr val="2A2A2A"/>
+            <a:srgbClr val="DCD6D2"/>
           </a:solidFill>
           <a:ln>
             <a:noFill/>
@@ -9983,7 +9983,7 @@
             <a:avLst/>
           </a:prstGeom>
           <a:solidFill>
-            <a:srgbClr val="2A2A2A"/>
+            <a:srgbClr val="DCD6D2"/>
           </a:solidFill>
           <a:ln>
             <a:noFill/>
@@ -10026,7 +10026,7 @@
             <a:avLst/>
           </a:prstGeom>
           <a:solidFill>
-            <a:srgbClr val="2A2A2A"/>
+            <a:srgbClr val="DCD6D2"/>
           </a:solidFill>
           <a:ln>
             <a:noFill/>
@@ -10069,7 +10069,7 @@
             <a:avLst/>
           </a:prstGeom>
           <a:solidFill>
-            <a:srgbClr val="2A2A2A"/>
+            <a:srgbClr val="DCD6D2"/>
           </a:solidFill>
           <a:ln>
             <a:noFill/>
@@ -10112,7 +10112,7 @@
             <a:avLst/>
           </a:prstGeom>
           <a:solidFill>
-            <a:srgbClr val="2A2A2A"/>
+            <a:srgbClr val="DCD6D2"/>
           </a:solidFill>
           <a:ln>
             <a:noFill/>
@@ -10155,7 +10155,7 @@
             <a:avLst/>
           </a:prstGeom>
           <a:solidFill>
-            <a:srgbClr val="2A2A2A"/>
+            <a:srgbClr val="DCD6D2"/>
           </a:solidFill>
           <a:ln>
             <a:noFill/>
@@ -10198,7 +10198,7 @@
             <a:avLst/>
           </a:prstGeom>
           <a:solidFill>
-            <a:srgbClr val="2A2A2A"/>
+            <a:srgbClr val="DCD6D2"/>
           </a:solidFill>
           <a:ln>
             <a:noFill/>
@@ -10241,7 +10241,7 @@
             <a:avLst/>
           </a:prstGeom>
           <a:solidFill>
-            <a:srgbClr val="2A2A2A"/>
+            <a:srgbClr val="DCD6D2"/>
           </a:solidFill>
           <a:ln>
             <a:noFill/>
@@ -10284,7 +10284,7 @@
             <a:avLst/>
           </a:prstGeom>
           <a:solidFill>
-            <a:srgbClr val="2A2A2A"/>
+            <a:srgbClr val="DCD6D2"/>
           </a:solidFill>
           <a:ln>
             <a:noFill/>
@@ -10327,7 +10327,7 @@
             <a:avLst/>
           </a:prstGeom>
           <a:solidFill>
-            <a:srgbClr val="2A2A2A"/>
+            <a:srgbClr val="DCD6D2"/>
           </a:solidFill>
           <a:ln>
             <a:noFill/>
@@ -10370,7 +10370,7 @@
             <a:avLst/>
           </a:prstGeom>
           <a:solidFill>
-            <a:srgbClr val="2A2A2A"/>
+            <a:srgbClr val="DCD6D2"/>
           </a:solidFill>
           <a:ln>
             <a:noFill/>
@@ -10413,7 +10413,7 @@
             <a:avLst/>
           </a:prstGeom>
           <a:solidFill>
-            <a:srgbClr val="2A2A2A"/>
+            <a:srgbClr val="DCD6D2"/>
           </a:solidFill>
           <a:ln>
             <a:noFill/>
@@ -10456,7 +10456,7 @@
             <a:avLst/>
           </a:prstGeom>
           <a:solidFill>
-            <a:srgbClr val="2A2A2A"/>
+            <a:srgbClr val="DCD6D2"/>
           </a:solidFill>
           <a:ln>
             <a:noFill/>
@@ -10499,7 +10499,7 @@
             <a:avLst/>
           </a:prstGeom>
           <a:solidFill>
-            <a:srgbClr val="2A2A2A"/>
+            <a:srgbClr val="DCD6D2"/>
           </a:solidFill>
           <a:ln>
             <a:noFill/>
@@ -10542,7 +10542,7 @@
             <a:avLst/>
           </a:prstGeom>
           <a:solidFill>
-            <a:srgbClr val="2A2A2A"/>
+            <a:srgbClr val="DCD6D2"/>
           </a:solidFill>
           <a:ln>
             <a:noFill/>
@@ -10585,7 +10585,7 @@
             <a:avLst/>
           </a:prstGeom>
           <a:solidFill>
-            <a:srgbClr val="2A2A2A"/>
+            <a:srgbClr val="DCD6D2"/>
           </a:solidFill>
           <a:ln>
             <a:noFill/>
@@ -10628,7 +10628,7 @@
             <a:avLst/>
           </a:prstGeom>
           <a:solidFill>
-            <a:srgbClr val="2A2A2A"/>
+            <a:srgbClr val="DCD6D2"/>
           </a:solidFill>
           <a:ln>
             <a:noFill/>
@@ -10671,7 +10671,7 @@
             <a:avLst/>
           </a:prstGeom>
           <a:solidFill>
-            <a:srgbClr val="2A2A2A"/>
+            <a:srgbClr val="DCD6D2"/>
           </a:solidFill>
           <a:ln>
             <a:noFill/>
@@ -10714,7 +10714,7 @@
             <a:avLst/>
           </a:prstGeom>
           <a:solidFill>
-            <a:srgbClr val="2A2A2A"/>
+            <a:srgbClr val="DCD6D2"/>
           </a:solidFill>
           <a:ln>
             <a:noFill/>
@@ -10757,7 +10757,7 @@
             <a:avLst/>
           </a:prstGeom>
           <a:solidFill>
-            <a:srgbClr val="2A2A2A"/>
+            <a:srgbClr val="DCD6D2"/>
           </a:solidFill>
           <a:ln>
             <a:noFill/>
@@ -10800,7 +10800,7 @@
             <a:avLst/>
           </a:prstGeom>
           <a:solidFill>
-            <a:srgbClr val="2A2A2A"/>
+            <a:srgbClr val="DCD6D2"/>
           </a:solidFill>
           <a:ln>
             <a:noFill/>
@@ -10843,7 +10843,7 @@
             <a:avLst/>
           </a:prstGeom>
           <a:solidFill>
-            <a:srgbClr val="2A2A2A"/>
+            <a:srgbClr val="DCD6D2"/>
           </a:solidFill>
           <a:ln>
             <a:noFill/>
@@ -10886,7 +10886,7 @@
             <a:avLst/>
           </a:prstGeom>
           <a:solidFill>
-            <a:srgbClr val="2A2A2A"/>
+            <a:srgbClr val="DCD6D2"/>
           </a:solidFill>
           <a:ln>
             <a:noFill/>
@@ -10929,7 +10929,7 @@
             <a:avLst/>
           </a:prstGeom>
           <a:solidFill>
-            <a:srgbClr val="2A2A2A"/>
+            <a:srgbClr val="DCD6D2"/>
           </a:solidFill>
           <a:ln>
             <a:noFill/>
@@ -10972,7 +10972,7 @@
             <a:avLst/>
           </a:prstGeom>
           <a:solidFill>
-            <a:srgbClr val="2A2A2A"/>
+            <a:srgbClr val="DCD6D2"/>
           </a:solidFill>
           <a:ln>
             <a:noFill/>
@@ -11015,7 +11015,7 @@
             <a:avLst/>
           </a:prstGeom>
           <a:solidFill>
-            <a:srgbClr val="2A2A2A"/>
+            <a:srgbClr val="DCD6D2"/>
           </a:solidFill>
           <a:ln>
             <a:noFill/>
@@ -11058,7 +11058,7 @@
             <a:avLst/>
           </a:prstGeom>
           <a:solidFill>
-            <a:srgbClr val="2A2A2A"/>
+            <a:srgbClr val="DCD6D2"/>
           </a:solidFill>
           <a:ln>
             <a:noFill/>
@@ -11101,7 +11101,7 @@
             <a:avLst/>
           </a:prstGeom>
           <a:solidFill>
-            <a:srgbClr val="2A2A2A"/>
+            <a:srgbClr val="DCD6D2"/>
           </a:solidFill>
           <a:ln>
             <a:noFill/>
@@ -11144,7 +11144,7 @@
             <a:avLst/>
           </a:prstGeom>
           <a:solidFill>
-            <a:srgbClr val="2A2A2A"/>
+            <a:srgbClr val="DCD6D2"/>
           </a:solidFill>
           <a:ln>
             <a:noFill/>
@@ -11187,7 +11187,7 @@
             <a:avLst/>
           </a:prstGeom>
           <a:solidFill>
-            <a:srgbClr val="2A2A2A"/>
+            <a:srgbClr val="DCD6D2"/>
           </a:solidFill>
           <a:ln>
             <a:noFill/>
@@ -11230,7 +11230,7 @@
             <a:avLst/>
           </a:prstGeom>
           <a:solidFill>
-            <a:srgbClr val="2A2A2A"/>
+            <a:srgbClr val="DCD6D2"/>
           </a:solidFill>
           <a:ln>
             <a:noFill/>
@@ -11273,7 +11273,7 @@
             <a:avLst/>
           </a:prstGeom>
           <a:solidFill>
-            <a:srgbClr val="2A2A2A"/>
+            <a:srgbClr val="DCD6D2"/>
           </a:solidFill>
           <a:ln>
             <a:noFill/>
@@ -11316,7 +11316,7 @@
             <a:avLst/>
           </a:prstGeom>
           <a:solidFill>
-            <a:srgbClr val="2A2A2A"/>
+            <a:srgbClr val="DCD6D2"/>
           </a:solidFill>
           <a:ln>
             <a:noFill/>
@@ -11359,7 +11359,7 @@
             <a:avLst/>
           </a:prstGeom>
           <a:solidFill>
-            <a:srgbClr val="2A2A2A"/>
+            <a:srgbClr val="DCD6D2"/>
           </a:solidFill>
           <a:ln>
             <a:noFill/>
@@ -11402,7 +11402,7 @@
             <a:avLst/>
           </a:prstGeom>
           <a:solidFill>
-            <a:srgbClr val="2A2A2A"/>
+            <a:srgbClr val="DCD6D2"/>
           </a:solidFill>
           <a:ln>
             <a:noFill/>
@@ -11445,7 +11445,7 @@
             <a:avLst/>
           </a:prstGeom>
           <a:solidFill>
-            <a:srgbClr val="2A2A2A"/>
+            <a:srgbClr val="DCD6D2"/>
           </a:solidFill>
           <a:ln>
             <a:noFill/>
@@ -11488,7 +11488,7 @@
             <a:avLst/>
           </a:prstGeom>
           <a:solidFill>
-            <a:srgbClr val="2A2A2A"/>
+            <a:srgbClr val="DCD6D2"/>
           </a:solidFill>
           <a:ln>
             <a:noFill/>
@@ -11531,7 +11531,7 @@
             <a:avLst/>
           </a:prstGeom>
           <a:solidFill>
-            <a:srgbClr val="2A2A2A"/>
+            <a:srgbClr val="DCD6D2"/>
           </a:solidFill>
           <a:ln>
             <a:noFill/>
@@ -11574,50 +11574,50 @@
             <a:avLst/>
           </a:prstGeom>
           <a:solidFill>
-            <a:srgbClr val="2A2A2A"/>
-          </a:solidFill>
-          <a:ln>
-            <a:noFill/>
-          </a:ln>
-        </p:spPr>
-        <p:style>
-          <a:lnRef idx="1">
-            <a:schemeClr val="accent1"/>
-          </a:lnRef>
-          <a:fillRef idx="3">
-            <a:schemeClr val="accent1"/>
-          </a:fillRef>
-          <a:effectRef idx="2">
-            <a:schemeClr val="accent1"/>
-          </a:effectRef>
-          <a:fontRef idx="minor">
-            <a:schemeClr val="lt1"/>
-          </a:fontRef>
-        </p:style>
-        <p:txBody>
-          <a:bodyPr rtlCol="0" anchor="ctr"/>
-          <a:lstStyle/>
-          <a:p>
-            <a:pPr algn="ctr"/>
-          </a:p>
-        </p:txBody>
-      </p:sp>
-      <p:sp>
-        <p:nvSpPr>
-          <p:cNvPr id="200" name="Rounded Rectangle 199"/>
-          <p:cNvSpPr/>
-          <p:nvPr/>
-        </p:nvSpPr>
-        <p:spPr>
-          <a:xfrm>
-            <a:off x="731520" y="548640"/>
-            <a:ext cx="320040" cy="320040"/>
-          </a:xfrm>
-          <a:prstGeom prst="roundRect">
-            <a:avLst/>
-          </a:prstGeom>
-          <a:solidFill>
-            <a:srgbClr val="FFFFFF"/>
+            <a:srgbClr val="DCD6D2"/>
+          </a:solidFill>
+          <a:ln>
+            <a:noFill/>
+          </a:ln>
+        </p:spPr>
+        <p:style>
+          <a:lnRef idx="1">
+            <a:schemeClr val="accent1"/>
+          </a:lnRef>
+          <a:fillRef idx="3">
+            <a:schemeClr val="accent1"/>
+          </a:fillRef>
+          <a:effectRef idx="2">
+            <a:schemeClr val="accent1"/>
+          </a:effectRef>
+          <a:fontRef idx="minor">
+            <a:schemeClr val="lt1"/>
+          </a:fontRef>
+        </p:style>
+        <p:txBody>
+          <a:bodyPr rtlCol="0" anchor="ctr"/>
+          <a:lstStyle/>
+          <a:p>
+            <a:pPr algn="ctr"/>
+          </a:p>
+        </p:txBody>
+      </p:sp>
+      <p:sp>
+        <p:nvSpPr>
+          <p:cNvPr id="200" name="Oval 199"/>
+          <p:cNvSpPr/>
+          <p:nvPr/>
+        </p:nvSpPr>
+        <p:spPr>
+          <a:xfrm>
+            <a:off x="731520" y="594360"/>
+            <a:ext cx="109728" cy="109728"/>
+          </a:xfrm>
+          <a:prstGeom prst="ellipse">
+            <a:avLst/>
+          </a:prstGeom>
+          <a:solidFill>
+            <a:srgbClr val="D71920"/>
           </a:solidFill>
           <a:ln>
             <a:noFill/>
@@ -11653,8 +11653,8 @@
         </p:nvSpPr>
         <p:spPr>
           <a:xfrm>
-            <a:off x="1143000" y="594360"/>
-            <a:ext cx="5029200" cy="274320"/>
+            <a:off x="960120" y="566928"/>
+            <a:ext cx="5486400" cy="274320"/>
           </a:xfrm>
           <a:prstGeom prst="rect">
             <a:avLst/>
@@ -11671,11 +11671,11 @@
             <a:r>
               <a:rPr sz="950" b="1">
                 <a:solidFill>
-                  <a:srgbClr val="888888"/>
+                  <a:srgbClr val="7A7576"/>
                 </a:solidFill>
                 <a:latin typeface="JetBrains Mono"/>
               </a:rPr>
-              <a:t>TEAM OFFGRID  •  DEFENSE &amp; DISASTER ROBOTICS</a:t>
+              <a:t>(TEAM OFFGRID)  /  DEFENSE &amp; DISASTER ROBOTICS</a:t>
             </a:r>
           </a:p>
         </p:txBody>
@@ -11688,7 +11688,7 @@
         </p:nvSpPr>
         <p:spPr>
           <a:xfrm>
-            <a:off x="7772400" y="594360"/>
+            <a:off x="7772400" y="566928"/>
             <a:ext cx="3657600" cy="274320"/>
           </a:xfrm>
           <a:prstGeom prst="rect">
@@ -11706,11 +11706,11 @@
             <a:r>
               <a:rPr sz="950" b="1">
                 <a:solidFill>
-                  <a:srgbClr val="888888"/>
+                  <a:srgbClr val="7A7576"/>
                 </a:solidFill>
                 <a:latin typeface="JetBrains Mono"/>
               </a:rPr>
-              <a:t>August 2026</a:t>
+              <a:t>AUG 2026  •  REV 1.0</a:t>
             </a:r>
           </a:p>
         </p:txBody>
@@ -11739,13 +11739,13 @@
           <a:p>
             <a:pPr algn="l"/>
             <a:r>
-              <a:rPr sz="1100" b="1">
+              <a:rPr sz="1050" b="1">
                 <a:solidFill>
-                  <a:srgbClr val="888888"/>
+                  <a:srgbClr val="7A7576"/>
                 </a:solidFill>
                 <a:latin typeface="JetBrains Mono"/>
               </a:rPr>
-              <a:t>AUTONOMOUS MULTI-UAV SWARM ARCHITECTURE</a:t>
+              <a:t>[ AUTONOMOUS MULTI-UAV SWARM ARCHITECTURE ]</a:t>
             </a:r>
           </a:p>
         </p:txBody>
@@ -11759,43 +11759,129 @@
         <p:spPr>
           <a:xfrm>
             <a:off x="731520" y="2542032"/>
-            <a:ext cx="1097280" cy="32004"/>
+            <a:ext cx="731520" cy="22860"/>
           </a:xfrm>
           <a:prstGeom prst="rect">
             <a:avLst/>
           </a:prstGeom>
           <a:solidFill>
-            <a:srgbClr val="FFFFFF"/>
-          </a:solidFill>
-          <a:ln>
-            <a:noFill/>
-          </a:ln>
-        </p:spPr>
-        <p:style>
-          <a:lnRef idx="1">
-            <a:schemeClr val="accent1"/>
-          </a:lnRef>
-          <a:fillRef idx="3">
-            <a:schemeClr val="accent1"/>
-          </a:fillRef>
-          <a:effectRef idx="2">
-            <a:schemeClr val="accent1"/>
-          </a:effectRef>
-          <a:fontRef idx="minor">
-            <a:schemeClr val="lt1"/>
-          </a:fontRef>
-        </p:style>
-        <p:txBody>
-          <a:bodyPr rtlCol="0" anchor="ctr"/>
-          <a:lstStyle/>
-          <a:p>
-            <a:pPr algn="ctr"/>
-          </a:p>
-        </p:txBody>
-      </p:sp>
-      <p:sp>
-        <p:nvSpPr>
-          <p:cNvPr id="205" name="TextBox 204"/>
+            <a:srgbClr val="D71920"/>
+          </a:solidFill>
+          <a:ln>
+            <a:noFill/>
+          </a:ln>
+        </p:spPr>
+        <p:style>
+          <a:lnRef idx="1">
+            <a:schemeClr val="accent1"/>
+          </a:lnRef>
+          <a:fillRef idx="3">
+            <a:schemeClr val="accent1"/>
+          </a:fillRef>
+          <a:effectRef idx="2">
+            <a:schemeClr val="accent1"/>
+          </a:effectRef>
+          <a:fontRef idx="minor">
+            <a:schemeClr val="lt1"/>
+          </a:fontRef>
+        </p:style>
+        <p:txBody>
+          <a:bodyPr rtlCol="0" anchor="ctr"/>
+          <a:lstStyle/>
+          <a:p>
+            <a:pPr algn="ctr"/>
+          </a:p>
+        </p:txBody>
+      </p:sp>
+      <p:sp>
+        <p:nvSpPr>
+          <p:cNvPr id="205" name="Oval 204"/>
+          <p:cNvSpPr/>
+          <p:nvPr/>
+        </p:nvSpPr>
+        <p:spPr>
+          <a:xfrm>
+            <a:off x="1536192" y="2505456"/>
+            <a:ext cx="73152" cy="73152"/>
+          </a:xfrm>
+          <a:prstGeom prst="ellipse">
+            <a:avLst/>
+          </a:prstGeom>
+          <a:solidFill>
+            <a:srgbClr val="191516"/>
+          </a:solidFill>
+          <a:ln>
+            <a:noFill/>
+          </a:ln>
+        </p:spPr>
+        <p:style>
+          <a:lnRef idx="1">
+            <a:schemeClr val="accent1"/>
+          </a:lnRef>
+          <a:fillRef idx="3">
+            <a:schemeClr val="accent1"/>
+          </a:fillRef>
+          <a:effectRef idx="2">
+            <a:schemeClr val="accent1"/>
+          </a:effectRef>
+          <a:fontRef idx="minor">
+            <a:schemeClr val="lt1"/>
+          </a:fontRef>
+        </p:style>
+        <p:txBody>
+          <a:bodyPr rtlCol="0" anchor="ctr"/>
+          <a:lstStyle/>
+          <a:p>
+            <a:pPr algn="ctr"/>
+          </a:p>
+        </p:txBody>
+      </p:sp>
+      <p:sp>
+        <p:nvSpPr>
+          <p:cNvPr id="206" name="Rectangle 205"/>
+          <p:cNvSpPr/>
+          <p:nvPr/>
+        </p:nvSpPr>
+        <p:spPr>
+          <a:xfrm>
+            <a:off x="1682496" y="2542032"/>
+            <a:ext cx="365760" cy="22860"/>
+          </a:xfrm>
+          <a:prstGeom prst="rect">
+            <a:avLst/>
+          </a:prstGeom>
+          <a:solidFill>
+            <a:srgbClr val="E8E3DF"/>
+          </a:solidFill>
+          <a:ln>
+            <a:noFill/>
+          </a:ln>
+        </p:spPr>
+        <p:style>
+          <a:lnRef idx="1">
+            <a:schemeClr val="accent1"/>
+          </a:lnRef>
+          <a:fillRef idx="3">
+            <a:schemeClr val="accent1"/>
+          </a:fillRef>
+          <a:effectRef idx="2">
+            <a:schemeClr val="accent1"/>
+          </a:effectRef>
+          <a:fontRef idx="minor">
+            <a:schemeClr val="lt1"/>
+          </a:fontRef>
+        </p:style>
+        <p:txBody>
+          <a:bodyPr rtlCol="0" anchor="ctr"/>
+          <a:lstStyle/>
+          <a:p>
+            <a:pPr algn="ctr"/>
+          </a:p>
+        </p:txBody>
+      </p:sp>
+      <p:sp>
+        <p:nvSpPr>
+          <p:cNvPr id="207" name="TextBox 206"/>
           <p:cNvSpPr txBox="1"/>
           <p:nvPr/>
         </p:nvSpPr>
@@ -11819,9 +11905,9 @@
             <a:r>
               <a:rPr sz="5600" b="1">
                 <a:solidFill>
-                  <a:srgbClr val="FFFFFF"/>
+                  <a:srgbClr val="191516"/>
                 </a:solidFill>
-                <a:latin typeface="Plus Jakarta Sans"/>
+                <a:latin typeface="Space Grotesk"/>
               </a:rPr>
               <a:t>PROJECT SUTRA</a:t>
             </a:r>
@@ -11830,7 +11916,7 @@
       </p:sp>
       <p:sp>
         <p:nvSpPr>
-          <p:cNvPr id="206" name="TextBox 205"/>
+          <p:cNvPr id="208" name="TextBox 207"/>
           <p:cNvSpPr txBox="1"/>
           <p:nvPr/>
         </p:nvSpPr>
@@ -11854,9 +11940,9 @@
             <a:r>
               <a:rPr sz="1700" b="0">
                 <a:solidFill>
-                  <a:srgbClr val="888888"/>
+                  <a:srgbClr val="7A7576"/>
                 </a:solidFill>
-                <a:latin typeface="Plus Jakarta Sans"/>
+                <a:latin typeface="Space Grotesk"/>
               </a:rPr>
               <a:t>Swarm Unified Tactical Reconnaissance Architecture for GPS-Denied and Jammed Mountain Environments.</a:t>
             </a:r>
@@ -11865,7 +11951,7 @@
       </p:sp>
       <p:sp>
         <p:nvSpPr>
-          <p:cNvPr id="207" name="Rectangle 206"/>
+          <p:cNvPr id="209" name="Rectangle 208"/>
           <p:cNvSpPr/>
           <p:nvPr/>
         </p:nvSpPr>
@@ -11878,37 +11964,37 @@
             <a:avLst/>
           </a:prstGeom>
           <a:solidFill>
-            <a:srgbClr val="222222"/>
-          </a:solidFill>
-          <a:ln>
-            <a:noFill/>
-          </a:ln>
-        </p:spPr>
-        <p:style>
-          <a:lnRef idx="1">
-            <a:schemeClr val="accent1"/>
-          </a:lnRef>
-          <a:fillRef idx="3">
-            <a:schemeClr val="accent1"/>
-          </a:fillRef>
-          <a:effectRef idx="2">
-            <a:schemeClr val="accent1"/>
-          </a:effectRef>
-          <a:fontRef idx="minor">
-            <a:schemeClr val="lt1"/>
-          </a:fontRef>
-        </p:style>
-        <p:txBody>
-          <a:bodyPr rtlCol="0" anchor="ctr"/>
-          <a:lstStyle/>
-          <a:p>
-            <a:pPr algn="ctr"/>
-          </a:p>
-        </p:txBody>
-      </p:sp>
-      <p:sp>
-        <p:nvSpPr>
-          <p:cNvPr id="208" name="TextBox 207"/>
+            <a:srgbClr val="E8E3DF"/>
+          </a:solidFill>
+          <a:ln>
+            <a:noFill/>
+          </a:ln>
+        </p:spPr>
+        <p:style>
+          <a:lnRef idx="1">
+            <a:schemeClr val="accent1"/>
+          </a:lnRef>
+          <a:fillRef idx="3">
+            <a:schemeClr val="accent1"/>
+          </a:fillRef>
+          <a:effectRef idx="2">
+            <a:schemeClr val="accent1"/>
+          </a:effectRef>
+          <a:fontRef idx="minor">
+            <a:schemeClr val="lt1"/>
+          </a:fontRef>
+        </p:style>
+        <p:txBody>
+          <a:bodyPr rtlCol="0" anchor="ctr"/>
+          <a:lstStyle/>
+          <a:p>
+            <a:pPr algn="ctr"/>
+          </a:p>
+        </p:txBody>
+      </p:sp>
+      <p:sp>
+        <p:nvSpPr>
+          <p:cNvPr id="210" name="TextBox 209"/>
           <p:cNvSpPr txBox="1"/>
           <p:nvPr/>
         </p:nvSpPr>
@@ -11932,18 +12018,18 @@
             <a:r>
               <a:rPr sz="850" b="1">
                 <a:solidFill>
-                  <a:srgbClr val="888888"/>
+                  <a:srgbClr val="D71920"/>
                 </a:solidFill>
                 <a:latin typeface="JetBrains Mono"/>
               </a:rPr>
-              <a:t>CORE ARCHITECTURE TEAM (TEAM OFFGRID)</a:t>
+              <a:t>CORE ARCHITECTURE TEAM (OFFGRID)</a:t>
             </a:r>
           </a:p>
         </p:txBody>
       </p:sp>
       <p:sp>
         <p:nvSpPr>
-          <p:cNvPr id="209" name="TextBox 208"/>
+          <p:cNvPr id="211" name="TextBox 210"/>
           <p:cNvSpPr txBox="1"/>
           <p:nvPr/>
         </p:nvSpPr>
@@ -11967,7 +12053,7 @@
             <a:r>
               <a:rPr sz="1000" b="1">
                 <a:solidFill>
-                  <a:srgbClr val="FFFFFF"/>
+                  <a:srgbClr val="191516"/>
                 </a:solidFill>
                 <a:latin typeface="JetBrains Mono"/>
               </a:rPr>
@@ -11978,7 +12064,7 @@
       </p:sp>
       <p:sp>
         <p:nvSpPr>
-          <p:cNvPr id="210" name="TextBox 209"/>
+          <p:cNvPr id="212" name="TextBox 211"/>
           <p:cNvSpPr txBox="1"/>
           <p:nvPr/>
         </p:nvSpPr>
@@ -12002,7 +12088,7 @@
             <a:r>
               <a:rPr sz="800" b="0">
                 <a:solidFill>
-                  <a:srgbClr val="888888"/>
+                  <a:srgbClr val="7A7576"/>
                 </a:solidFill>
                 <a:latin typeface="JetBrains Mono"/>
               </a:rPr>
@@ -12013,7 +12099,7 @@
       </p:sp>
       <p:sp>
         <p:nvSpPr>
-          <p:cNvPr id="211" name="TextBox 210"/>
+          <p:cNvPr id="213" name="TextBox 212"/>
           <p:cNvSpPr txBox="1"/>
           <p:nvPr/>
         </p:nvSpPr>
@@ -12037,7 +12123,7 @@
             <a:r>
               <a:rPr sz="750" b="1">
                 <a:solidFill>
-                  <a:srgbClr val="555555"/>
+                  <a:srgbClr val="A09A97"/>
                 </a:solidFill>
                 <a:latin typeface="JetBrains Mono"/>
               </a:rPr>
@@ -12048,7 +12134,7 @@
       </p:sp>
       <p:sp>
         <p:nvSpPr>
-          <p:cNvPr id="212" name="TextBox 211"/>
+          <p:cNvPr id="214" name="TextBox 213"/>
           <p:cNvSpPr txBox="1"/>
           <p:nvPr/>
         </p:nvSpPr>
@@ -12072,7 +12158,7 @@
             <a:r>
               <a:rPr sz="1000" b="1">
                 <a:solidFill>
-                  <a:srgbClr val="FFFFFF"/>
+                  <a:srgbClr val="191516"/>
                 </a:solidFill>
                 <a:latin typeface="JetBrains Mono"/>
               </a:rPr>
@@ -12083,7 +12169,7 @@
       </p:sp>
       <p:sp>
         <p:nvSpPr>
-          <p:cNvPr id="213" name="TextBox 212"/>
+          <p:cNvPr id="215" name="TextBox 214"/>
           <p:cNvSpPr txBox="1"/>
           <p:nvPr/>
         </p:nvSpPr>
@@ -12107,7 +12193,7 @@
             <a:r>
               <a:rPr sz="800" b="0">
                 <a:solidFill>
-                  <a:srgbClr val="888888"/>
+                  <a:srgbClr val="7A7576"/>
                 </a:solidFill>
                 <a:latin typeface="JetBrains Mono"/>
               </a:rPr>
@@ -12118,7 +12204,7 @@
       </p:sp>
       <p:sp>
         <p:nvSpPr>
-          <p:cNvPr id="214" name="TextBox 213"/>
+          <p:cNvPr id="216" name="TextBox 215"/>
           <p:cNvSpPr txBox="1"/>
           <p:nvPr/>
         </p:nvSpPr>
@@ -12142,18 +12228,18 @@
             <a:r>
               <a:rPr sz="750" b="1">
                 <a:solidFill>
-                  <a:srgbClr val="555555"/>
+                  <a:srgbClr val="A09A97"/>
                 </a:solidFill>
                 <a:latin typeface="JetBrains Mono"/>
               </a:rPr>
-              <a:t>Tri-Modal AI &amp; Geolocation</a:t>
+              <a:t>Tri-Modal AI &amp; DEM</a:t>
             </a:r>
           </a:p>
         </p:txBody>
       </p:sp>
       <p:sp>
         <p:nvSpPr>
-          <p:cNvPr id="215" name="TextBox 214"/>
+          <p:cNvPr id="217" name="TextBox 216"/>
           <p:cNvSpPr txBox="1"/>
           <p:nvPr/>
         </p:nvSpPr>
@@ -12177,7 +12263,7 @@
             <a:r>
               <a:rPr sz="1000" b="1">
                 <a:solidFill>
-                  <a:srgbClr val="FFFFFF"/>
+                  <a:srgbClr val="191516"/>
                 </a:solidFill>
                 <a:latin typeface="JetBrains Mono"/>
               </a:rPr>
@@ -12188,7 +12274,7 @@
       </p:sp>
       <p:sp>
         <p:nvSpPr>
-          <p:cNvPr id="216" name="TextBox 215"/>
+          <p:cNvPr id="218" name="TextBox 217"/>
           <p:cNvSpPr txBox="1"/>
           <p:nvPr/>
         </p:nvSpPr>
@@ -12212,7 +12298,7 @@
             <a:r>
               <a:rPr sz="800" b="0">
                 <a:solidFill>
-                  <a:srgbClr val="888888"/>
+                  <a:srgbClr val="7A7576"/>
                 </a:solidFill>
                 <a:latin typeface="JetBrains Mono"/>
               </a:rPr>
@@ -12223,7 +12309,7 @@
       </p:sp>
       <p:sp>
         <p:nvSpPr>
-          <p:cNvPr id="217" name="TextBox 216"/>
+          <p:cNvPr id="219" name="TextBox 218"/>
           <p:cNvSpPr txBox="1"/>
           <p:nvPr/>
         </p:nvSpPr>
@@ -12247,7 +12333,7 @@
             <a:r>
               <a:rPr sz="750" b="1">
                 <a:solidFill>
-                  <a:srgbClr val="555555"/>
+                  <a:srgbClr val="A09A97"/>
                 </a:solidFill>
                 <a:latin typeface="JetBrains Mono"/>
               </a:rPr>
@@ -12258,7 +12344,7 @@
       </p:sp>
       <p:sp>
         <p:nvSpPr>
-          <p:cNvPr id="218" name="TextBox 217"/>
+          <p:cNvPr id="220" name="TextBox 219"/>
           <p:cNvSpPr txBox="1"/>
           <p:nvPr/>
         </p:nvSpPr>
@@ -12282,7 +12368,7 @@
             <a:r>
               <a:rPr sz="1000" b="1">
                 <a:solidFill>
-                  <a:srgbClr val="FFFFFF"/>
+                  <a:srgbClr val="191516"/>
                 </a:solidFill>
                 <a:latin typeface="JetBrains Mono"/>
               </a:rPr>
@@ -12293,7 +12379,7 @@
       </p:sp>
       <p:sp>
         <p:nvSpPr>
-          <p:cNvPr id="219" name="TextBox 218"/>
+          <p:cNvPr id="221" name="TextBox 220"/>
           <p:cNvSpPr txBox="1"/>
           <p:nvPr/>
         </p:nvSpPr>
@@ -12317,7 +12403,7 @@
             <a:r>
               <a:rPr sz="800" b="0">
                 <a:solidFill>
-                  <a:srgbClr val="888888"/>
+                  <a:srgbClr val="7A7576"/>
                 </a:solidFill>
                 <a:latin typeface="JetBrains Mono"/>
               </a:rPr>
@@ -12328,7 +12414,7 @@
       </p:sp>
       <p:sp>
         <p:nvSpPr>
-          <p:cNvPr id="220" name="TextBox 219"/>
+          <p:cNvPr id="222" name="TextBox 221"/>
           <p:cNvSpPr txBox="1"/>
           <p:nvPr/>
         </p:nvSpPr>
@@ -12352,7 +12438,7 @@
             <a:r>
               <a:rPr sz="750" b="1">
                 <a:solidFill>
-                  <a:srgbClr val="555555"/>
+                  <a:srgbClr val="A09A97"/>
                 </a:solidFill>
                 <a:latin typeface="JetBrains Mono"/>
               </a:rPr>
@@ -12363,7 +12449,7 @@
       </p:sp>
       <p:sp>
         <p:nvSpPr>
-          <p:cNvPr id="221" name="TextBox 220"/>
+          <p:cNvPr id="223" name="TextBox 222"/>
           <p:cNvSpPr txBox="1"/>
           <p:nvPr/>
         </p:nvSpPr>
@@ -12387,7 +12473,7 @@
             <a:r>
               <a:rPr sz="1000" b="1">
                 <a:solidFill>
-                  <a:srgbClr val="FFFFFF"/>
+                  <a:srgbClr val="191516"/>
                 </a:solidFill>
                 <a:latin typeface="JetBrains Mono"/>
               </a:rPr>
@@ -12398,7 +12484,7 @@
       </p:sp>
       <p:sp>
         <p:nvSpPr>
-          <p:cNvPr id="222" name="TextBox 221"/>
+          <p:cNvPr id="224" name="TextBox 223"/>
           <p:cNvSpPr txBox="1"/>
           <p:nvPr/>
         </p:nvSpPr>
@@ -12422,7 +12508,7 @@
             <a:r>
               <a:rPr sz="800" b="0">
                 <a:solidFill>
-                  <a:srgbClr val="888888"/>
+                  <a:srgbClr val="7A7576"/>
                 </a:solidFill>
                 <a:latin typeface="JetBrains Mono"/>
               </a:rPr>
@@ -12433,7 +12519,7 @@
       </p:sp>
       <p:sp>
         <p:nvSpPr>
-          <p:cNvPr id="223" name="TextBox 222"/>
+          <p:cNvPr id="225" name="TextBox 224"/>
           <p:cNvSpPr txBox="1"/>
           <p:nvPr/>
         </p:nvSpPr>
@@ -12457,7 +12543,7 @@
             <a:r>
               <a:rPr sz="750" b="1">
                 <a:solidFill>
-                  <a:srgbClr val="555555"/>
+                  <a:srgbClr val="A09A97"/>
                 </a:solidFill>
                 <a:latin typeface="JetBrains Mono"/>
               </a:rPr>

</xml_diff>

<commit_message>
feat(typography): apply Bebas Neue font to PROJECT SUTRA title headline
</commit_message>
<xml_diff>
--- a/sutra_pitch_deck.pptx
+++ b/sutra_pitch_deck.pptx
@@ -11903,11 +11903,11 @@
           <a:p>
             <a:pPr algn="l"/>
             <a:r>
-              <a:rPr sz="5600" b="1">
+              <a:rPr sz="6400" b="0">
                 <a:solidFill>
                   <a:srgbClr val="191516"/>
                 </a:solidFill>
-                <a:latin typeface="Space Grotesk"/>
+                <a:latin typeface="Bebas Neue"/>
               </a:rPr>
               <a:t>PROJECT SUTRA</a:t>
             </a:r>

</xml_diff>

<commit_message>
feat(typography): apply Syncopate geometric wide font to title and status headers
</commit_message>
<xml_diff>
--- a/sutra_pitch_deck.pptx
+++ b/sutra_pitch_deck.pptx
@@ -11669,13 +11669,13 @@
           <a:p>
             <a:pPr algn="l"/>
             <a:r>
-              <a:rPr sz="950" b="1">
+              <a:rPr sz="850" b="1">
                 <a:solidFill>
                   <a:srgbClr val="7A7576"/>
                 </a:solidFill>
-                <a:latin typeface="JetBrains Mono"/>
+                <a:latin typeface="Syncopate"/>
               </a:rPr>
-              <a:t>(TEAM OFFGRID)  /  DEFENSE &amp; DISASTER ROBOTICS</a:t>
+              <a:t>TEAM OFFGRID  /  DEFENSE &amp; DISASTER ROBOTICS</a:t>
             </a:r>
           </a:p>
         </p:txBody>
@@ -11739,11 +11739,11 @@
           <a:p>
             <a:pPr algn="l"/>
             <a:r>
-              <a:rPr sz="1050" b="1">
+              <a:rPr sz="950" b="1">
                 <a:solidFill>
                   <a:srgbClr val="7A7576"/>
                 </a:solidFill>
-                <a:latin typeface="JetBrains Mono"/>
+                <a:latin typeface="Syncopate"/>
               </a:rPr>
               <a:t>[ AUTONOMOUS MULTI-UAV SWARM ARCHITECTURE ]</a:t>
             </a:r>
@@ -11888,7 +11888,7 @@
         <p:spPr>
           <a:xfrm>
             <a:off x="731520" y="2788920"/>
-            <a:ext cx="10058400" cy="1097280"/>
+            <a:ext cx="10515600" cy="1097280"/>
           </a:xfrm>
           <a:prstGeom prst="rect">
             <a:avLst/>
@@ -11903,11 +11903,11 @@
           <a:p>
             <a:pPr algn="l"/>
             <a:r>
-              <a:rPr sz="6400" b="0">
+              <a:rPr sz="4400" b="1">
                 <a:solidFill>
                   <a:srgbClr val="191516"/>
                 </a:solidFill>
-                <a:latin typeface="Bebas Neue"/>
+                <a:latin typeface="Syncopate"/>
               </a:rPr>
               <a:t>PROJECT SUTRA</a:t>
             </a:r>
@@ -12016,11 +12016,11 @@
           <a:p>
             <a:pPr algn="l"/>
             <a:r>
-              <a:rPr sz="850" b="1">
+              <a:rPr sz="800" b="1">
                 <a:solidFill>
                   <a:srgbClr val="D71920"/>
                 </a:solidFill>
-                <a:latin typeface="JetBrains Mono"/>
+                <a:latin typeface="Syncopate"/>
               </a:rPr>
               <a:t>CORE ARCHITECTURE TEAM (OFFGRID)</a:t>
             </a:r>

</xml_diff>

<commit_message>
refactor(copy): update footer badge to 'RESEARCH-BACKED & EMPIRICALLY VALIDATED'
</commit_message>
<xml_diff>
--- a/sutra_pitch_deck.pptx
+++ b/sutra_pitch_deck.pptx
@@ -5442,8 +5442,8 @@
         </p:nvSpPr>
         <p:spPr>
           <a:xfrm>
-            <a:off x="7315200" y="5230368"/>
-            <a:ext cx="4144975" cy="182880"/>
+            <a:off x="6858000" y="5230368"/>
+            <a:ext cx="4602175" cy="182880"/>
           </a:xfrm>
           <a:prstGeom prst="rect">
             <a:avLst/>
@@ -5464,7 +5464,7 @@
                 </a:solidFill>
                 <a:latin typeface="Plus Jakarta Sans"/>
               </a:rPr>
-              <a:t>232/232 VERIFIED ZERO-MOCK TESTS</a:t>
+              <a:t>RESEARCH-BACKED &amp; EMPIRICALLY VALIDATED</a:t>
             </a:r>
           </a:p>
         </p:txBody>

</xml_diff>

<commit_message>
feat(design): add empirical capability metric hooks to Title Slide
</commit_message>
<xml_diff>
--- a/sutra_pitch_deck.pptx
+++ b/sutra_pitch_deck.pptx
@@ -5052,8 +5052,8 @@
         </p:nvSpPr>
         <p:spPr>
           <a:xfrm>
-            <a:off x="731520" y="1645920"/>
-            <a:ext cx="10058400" cy="457200"/>
+            <a:off x="731520" y="1463040"/>
+            <a:ext cx="10058400" cy="365760"/>
           </a:xfrm>
           <a:prstGeom prst="rect">
             <a:avLst/>
@@ -5068,7 +5068,7 @@
           <a:p>
             <a:pPr algn="l"/>
             <a:r>
-              <a:rPr sz="1900" b="0" i="1">
+              <a:rPr sz="1800" b="0" i="1">
                 <a:solidFill>
                   <a:srgbClr val="000000"/>
                 </a:solidFill>
@@ -5087,7 +5087,7 @@
         </p:nvSpPr>
         <p:spPr>
           <a:xfrm>
-            <a:off x="548640" y="2194560"/>
+            <a:off x="548640" y="1965960"/>
             <a:ext cx="320040" cy="18288"/>
           </a:xfrm>
           <a:prstGeom prst="rect">
@@ -5130,7 +5130,7 @@
         </p:nvSpPr>
         <p:spPr>
           <a:xfrm>
-            <a:off x="548640" y="2194560"/>
+            <a:off x="548640" y="1965960"/>
             <a:ext cx="18288" cy="320040"/>
           </a:xfrm>
           <a:prstGeom prst="rect">
@@ -5173,7 +5173,7 @@
         </p:nvSpPr>
         <p:spPr>
           <a:xfrm>
-            <a:off x="5852160" y="4114800"/>
+            <a:off x="5486400" y="3611880"/>
             <a:ext cx="320040" cy="18288"/>
           </a:xfrm>
           <a:prstGeom prst="rect">
@@ -5216,7 +5216,7 @@
         </p:nvSpPr>
         <p:spPr>
           <a:xfrm>
-            <a:off x="6153912" y="3813048"/>
+            <a:off x="5788152" y="3310128"/>
             <a:ext cx="18288" cy="320040"/>
           </a:xfrm>
           <a:prstGeom prst="rect">
@@ -5259,8 +5259,8 @@
         </p:nvSpPr>
         <p:spPr>
           <a:xfrm>
-            <a:off x="731520" y="2240280"/>
-            <a:ext cx="7315200" cy="822960"/>
+            <a:off x="731520" y="1965960"/>
+            <a:ext cx="7315200" cy="731520"/>
           </a:xfrm>
           <a:prstGeom prst="rect">
             <a:avLst/>
@@ -5275,7 +5275,7 @@
           <a:p>
             <a:pPr algn="l"/>
             <a:r>
-              <a:rPr sz="6200" b="1" i="0">
+              <a:rPr sz="5400" b="1" i="0">
                 <a:solidFill>
                   <a:srgbClr val="000000"/>
                 </a:solidFill>
@@ -5294,8 +5294,8 @@
         </p:nvSpPr>
         <p:spPr>
           <a:xfrm>
-            <a:off x="731520" y="3063240"/>
-            <a:ext cx="7315200" cy="822960"/>
+            <a:off x="731520" y="2697480"/>
+            <a:ext cx="7315200" cy="731520"/>
           </a:xfrm>
           <a:prstGeom prst="rect">
             <a:avLst/>
@@ -5310,7 +5310,7 @@
           <a:p>
             <a:pPr algn="l"/>
             <a:r>
-              <a:rPr sz="6200" b="0" i="1">
+              <a:rPr sz="5400" b="0" i="1">
                 <a:solidFill>
                   <a:srgbClr val="475569"/>
                 </a:solidFill>
@@ -5329,8 +5329,8 @@
         </p:nvSpPr>
         <p:spPr>
           <a:xfrm>
-            <a:off x="731520" y="4114800"/>
-            <a:ext cx="9144000" cy="548640"/>
+            <a:off x="731520" y="3566160"/>
+            <a:ext cx="9144000" cy="457200"/>
           </a:xfrm>
           <a:prstGeom prst="rect">
             <a:avLst/>
@@ -5345,7 +5345,7 @@
           <a:p>
             <a:pPr algn="l"/>
             <a:r>
-              <a:rPr sz="1350" b="0" i="0">
+              <a:rPr sz="1250" b="0" i="0">
                 <a:solidFill>
                   <a:srgbClr val="475569"/>
                 </a:solidFill>
@@ -5358,23 +5358,25 @@
       </p:sp>
       <p:sp>
         <p:nvSpPr>
-          <p:cNvPr id="56" name="Rectangle 55"/>
+          <p:cNvPr id="56" name="Rounded Rectangle 55"/>
           <p:cNvSpPr/>
           <p:nvPr/>
         </p:nvSpPr>
         <p:spPr>
           <a:xfrm>
-            <a:off x="731520" y="5120640"/>
-            <a:ext cx="10728655" cy="13716"/>
-          </a:xfrm>
-          <a:prstGeom prst="rect">
-            <a:avLst/>
-          </a:prstGeom>
-          <a:solidFill>
-            <a:srgbClr val="E2E8F0"/>
-          </a:solidFill>
-          <a:ln>
-            <a:noFill/>
+            <a:off x="731520" y="4160520"/>
+            <a:ext cx="2286000" cy="594360"/>
+          </a:xfrm>
+          <a:prstGeom prst="roundRect">
+            <a:avLst/>
+          </a:prstGeom>
+          <a:solidFill>
+            <a:srgbClr val="F8FAFC"/>
+          </a:solidFill>
+          <a:ln w="12700">
+            <a:solidFill>
+              <a:srgbClr val="E2E8F0"/>
+            </a:solidFill>
           </a:ln>
         </p:spPr>
         <p:style>
@@ -5401,7 +5403,584 @@
       </p:sp>
       <p:sp>
         <p:nvSpPr>
-          <p:cNvPr id="57" name="TextBox 56"/>
+          <p:cNvPr id="57" name="Rounded Rectangle 56"/>
+          <p:cNvSpPr/>
+          <p:nvPr/>
+        </p:nvSpPr>
+        <p:spPr>
+          <a:xfrm>
+            <a:off x="822960" y="4251960"/>
+            <a:ext cx="256032" cy="256032"/>
+          </a:xfrm>
+          <a:prstGeom prst="roundRect">
+            <a:avLst/>
+          </a:prstGeom>
+          <a:solidFill>
+            <a:srgbClr val="000000"/>
+          </a:solidFill>
+          <a:ln>
+            <a:noFill/>
+          </a:ln>
+        </p:spPr>
+        <p:style>
+          <a:lnRef idx="1">
+            <a:schemeClr val="accent1"/>
+          </a:lnRef>
+          <a:fillRef idx="3">
+            <a:schemeClr val="accent1"/>
+          </a:fillRef>
+          <a:effectRef idx="2">
+            <a:schemeClr val="accent1"/>
+          </a:effectRef>
+          <a:fontRef idx="minor">
+            <a:schemeClr val="lt1"/>
+          </a:fontRef>
+        </p:style>
+        <p:txBody>
+          <a:bodyPr rtlCol="0" anchor="ctr"/>
+          <a:lstStyle/>
+          <a:p>
+            <a:pPr algn="ctr"/>
+          </a:p>
+        </p:txBody>
+      </p:sp>
+      <p:sp>
+        <p:nvSpPr>
+          <p:cNvPr id="58" name="TextBox 57"/>
+          <p:cNvSpPr txBox="1"/>
+          <p:nvPr/>
+        </p:nvSpPr>
+        <p:spPr>
+          <a:xfrm>
+            <a:off x="822960" y="4279392"/>
+            <a:ext cx="256032" cy="201168"/>
+          </a:xfrm>
+          <a:prstGeom prst="rect">
+            <a:avLst/>
+          </a:prstGeom>
+          <a:noFill/>
+        </p:spPr>
+        <p:txBody>
+          <a:bodyPr wrap="square" lIns="0" tIns="0" rIns="0" bIns="0">
+            <a:spAutoFit/>
+          </a:bodyPr>
+          <a:lstStyle/>
+          <a:p>
+            <a:pPr algn="ctr"/>
+            <a:r>
+              <a:rPr sz="800" b="1" i="0">
+                <a:solidFill>
+                  <a:srgbClr val="FFFFFF"/>
+                </a:solidFill>
+                <a:latin typeface="JetBrains Mono"/>
+              </a:rPr>
+              <a:t>01</a:t>
+            </a:r>
+          </a:p>
+        </p:txBody>
+      </p:sp>
+      <p:sp>
+        <p:nvSpPr>
+          <p:cNvPr id="59" name="TextBox 58"/>
+          <p:cNvSpPr txBox="1"/>
+          <p:nvPr/>
+        </p:nvSpPr>
+        <p:spPr>
+          <a:xfrm>
+            <a:off x="1143000" y="4224528"/>
+            <a:ext cx="1737360" cy="228600"/>
+          </a:xfrm>
+          <a:prstGeom prst="rect">
+            <a:avLst/>
+          </a:prstGeom>
+          <a:noFill/>
+        </p:spPr>
+        <p:txBody>
+          <a:bodyPr wrap="square" lIns="0" tIns="0" rIns="0" bIns="0">
+            <a:spAutoFit/>
+          </a:bodyPr>
+          <a:lstStyle/>
+          <a:p>
+            <a:pPr algn="l"/>
+            <a:r>
+              <a:rPr sz="950" b="1" i="0">
+                <a:solidFill>
+                  <a:srgbClr val="000000"/>
+                </a:solidFill>
+                <a:latin typeface="Plus Jakarta Sans"/>
+              </a:rPr>
+              <a:t>0% GPS Reliance</a:t>
+            </a:r>
+          </a:p>
+        </p:txBody>
+      </p:sp>
+      <p:sp>
+        <p:nvSpPr>
+          <p:cNvPr id="60" name="TextBox 59"/>
+          <p:cNvSpPr txBox="1"/>
+          <p:nvPr/>
+        </p:nvSpPr>
+        <p:spPr>
+          <a:xfrm>
+            <a:off x="1143000" y="4462272"/>
+            <a:ext cx="1737360" cy="201168"/>
+          </a:xfrm>
+          <a:prstGeom prst="rect">
+            <a:avLst/>
+          </a:prstGeom>
+          <a:noFill/>
+        </p:spPr>
+        <p:txBody>
+          <a:bodyPr wrap="square" lIns="0" tIns="0" rIns="0" bIns="0">
+            <a:spAutoFit/>
+          </a:bodyPr>
+          <a:lstStyle/>
+          <a:p>
+            <a:pPr algn="l"/>
+            <a:r>
+              <a:rPr sz="750" b="0" i="0">
+                <a:solidFill>
+                  <a:srgbClr val="475569"/>
+                </a:solidFill>
+                <a:latin typeface="Plus Jakarta Sans"/>
+              </a:rPr>
+              <a:t>VIO + Optical Flow EKF2</a:t>
+            </a:r>
+          </a:p>
+        </p:txBody>
+      </p:sp>
+      <p:sp>
+        <p:nvSpPr>
+          <p:cNvPr id="61" name="Rounded Rectangle 60"/>
+          <p:cNvSpPr/>
+          <p:nvPr/>
+        </p:nvSpPr>
+        <p:spPr>
+          <a:xfrm>
+            <a:off x="3200400" y="4160520"/>
+            <a:ext cx="2286000" cy="594360"/>
+          </a:xfrm>
+          <a:prstGeom prst="roundRect">
+            <a:avLst/>
+          </a:prstGeom>
+          <a:solidFill>
+            <a:srgbClr val="F8FAFC"/>
+          </a:solidFill>
+          <a:ln w="12700">
+            <a:solidFill>
+              <a:srgbClr val="E2E8F0"/>
+            </a:solidFill>
+          </a:ln>
+        </p:spPr>
+        <p:style>
+          <a:lnRef idx="1">
+            <a:schemeClr val="accent1"/>
+          </a:lnRef>
+          <a:fillRef idx="3">
+            <a:schemeClr val="accent1"/>
+          </a:fillRef>
+          <a:effectRef idx="2">
+            <a:schemeClr val="accent1"/>
+          </a:effectRef>
+          <a:fontRef idx="minor">
+            <a:schemeClr val="lt1"/>
+          </a:fontRef>
+        </p:style>
+        <p:txBody>
+          <a:bodyPr rtlCol="0" anchor="ctr"/>
+          <a:lstStyle/>
+          <a:p>
+            <a:pPr algn="ctr"/>
+          </a:p>
+        </p:txBody>
+      </p:sp>
+      <p:sp>
+        <p:nvSpPr>
+          <p:cNvPr id="62" name="Rounded Rectangle 61"/>
+          <p:cNvSpPr/>
+          <p:nvPr/>
+        </p:nvSpPr>
+        <p:spPr>
+          <a:xfrm>
+            <a:off x="3291840" y="4251960"/>
+            <a:ext cx="256032" cy="256032"/>
+          </a:xfrm>
+          <a:prstGeom prst="roundRect">
+            <a:avLst/>
+          </a:prstGeom>
+          <a:solidFill>
+            <a:srgbClr val="000000"/>
+          </a:solidFill>
+          <a:ln>
+            <a:noFill/>
+          </a:ln>
+        </p:spPr>
+        <p:style>
+          <a:lnRef idx="1">
+            <a:schemeClr val="accent1"/>
+          </a:lnRef>
+          <a:fillRef idx="3">
+            <a:schemeClr val="accent1"/>
+          </a:fillRef>
+          <a:effectRef idx="2">
+            <a:schemeClr val="accent1"/>
+          </a:effectRef>
+          <a:fontRef idx="minor">
+            <a:schemeClr val="lt1"/>
+          </a:fontRef>
+        </p:style>
+        <p:txBody>
+          <a:bodyPr rtlCol="0" anchor="ctr"/>
+          <a:lstStyle/>
+          <a:p>
+            <a:pPr algn="ctr"/>
+          </a:p>
+        </p:txBody>
+      </p:sp>
+      <p:sp>
+        <p:nvSpPr>
+          <p:cNvPr id="63" name="TextBox 62"/>
+          <p:cNvSpPr txBox="1"/>
+          <p:nvPr/>
+        </p:nvSpPr>
+        <p:spPr>
+          <a:xfrm>
+            <a:off x="3291840" y="4279392"/>
+            <a:ext cx="256032" cy="201168"/>
+          </a:xfrm>
+          <a:prstGeom prst="rect">
+            <a:avLst/>
+          </a:prstGeom>
+          <a:noFill/>
+        </p:spPr>
+        <p:txBody>
+          <a:bodyPr wrap="square" lIns="0" tIns="0" rIns="0" bIns="0">
+            <a:spAutoFit/>
+          </a:bodyPr>
+          <a:lstStyle/>
+          <a:p>
+            <a:pPr algn="ctr"/>
+            <a:r>
+              <a:rPr sz="800" b="1" i="0">
+                <a:solidFill>
+                  <a:srgbClr val="FFFFFF"/>
+                </a:solidFill>
+                <a:latin typeface="JetBrains Mono"/>
+              </a:rPr>
+              <a:t>02</a:t>
+            </a:r>
+          </a:p>
+        </p:txBody>
+      </p:sp>
+      <p:sp>
+        <p:nvSpPr>
+          <p:cNvPr id="64" name="TextBox 63"/>
+          <p:cNvSpPr txBox="1"/>
+          <p:nvPr/>
+        </p:nvSpPr>
+        <p:spPr>
+          <a:xfrm>
+            <a:off x="3611880" y="4224528"/>
+            <a:ext cx="1737360" cy="228600"/>
+          </a:xfrm>
+          <a:prstGeom prst="rect">
+            <a:avLst/>
+          </a:prstGeom>
+          <a:noFill/>
+        </p:spPr>
+        <p:txBody>
+          <a:bodyPr wrap="square" lIns="0" tIns="0" rIns="0" bIns="0">
+            <a:spAutoFit/>
+          </a:bodyPr>
+          <a:lstStyle/>
+          <a:p>
+            <a:pPr algn="l"/>
+            <a:r>
+              <a:rPr sz="950" b="1" i="0">
+                <a:solidFill>
+                  <a:srgbClr val="000000"/>
+                </a:solidFill>
+                <a:latin typeface="Plus Jakarta Sans"/>
+              </a:rPr>
+              <a:t>0.0 dB Cliff Free</a:t>
+            </a:r>
+          </a:p>
+        </p:txBody>
+      </p:sp>
+      <p:sp>
+        <p:nvSpPr>
+          <p:cNvPr id="65" name="TextBox 64"/>
+          <p:cNvSpPr txBox="1"/>
+          <p:nvPr/>
+        </p:nvSpPr>
+        <p:spPr>
+          <a:xfrm>
+            <a:off x="3611880" y="4462272"/>
+            <a:ext cx="1737360" cy="201168"/>
+          </a:xfrm>
+          <a:prstGeom prst="rect">
+            <a:avLst/>
+          </a:prstGeom>
+          <a:noFill/>
+        </p:spPr>
+        <p:txBody>
+          <a:bodyPr wrap="square" lIns="0" tIns="0" rIns="0" bIns="0">
+            <a:spAutoFit/>
+          </a:bodyPr>
+          <a:lstStyle/>
+          <a:p>
+            <a:pPr algn="l"/>
+            <a:r>
+              <a:rPr sz="750" b="0" i="0">
+                <a:solidFill>
+                  <a:srgbClr val="475569"/>
+                </a:solidFill>
+                <a:latin typeface="Plus Jakarta Sans"/>
+              </a:rPr>
+              <a:t>Deep JSCC Neural Wireless</a:t>
+            </a:r>
+          </a:p>
+        </p:txBody>
+      </p:sp>
+      <p:sp>
+        <p:nvSpPr>
+          <p:cNvPr id="66" name="Rounded Rectangle 65"/>
+          <p:cNvSpPr/>
+          <p:nvPr/>
+        </p:nvSpPr>
+        <p:spPr>
+          <a:xfrm>
+            <a:off x="5669280" y="4160520"/>
+            <a:ext cx="2286000" cy="594360"/>
+          </a:xfrm>
+          <a:prstGeom prst="roundRect">
+            <a:avLst/>
+          </a:prstGeom>
+          <a:solidFill>
+            <a:srgbClr val="F8FAFC"/>
+          </a:solidFill>
+          <a:ln w="12700">
+            <a:solidFill>
+              <a:srgbClr val="E2E8F0"/>
+            </a:solidFill>
+          </a:ln>
+        </p:spPr>
+        <p:style>
+          <a:lnRef idx="1">
+            <a:schemeClr val="accent1"/>
+          </a:lnRef>
+          <a:fillRef idx="3">
+            <a:schemeClr val="accent1"/>
+          </a:fillRef>
+          <a:effectRef idx="2">
+            <a:schemeClr val="accent1"/>
+          </a:effectRef>
+          <a:fontRef idx="minor">
+            <a:schemeClr val="lt1"/>
+          </a:fontRef>
+        </p:style>
+        <p:txBody>
+          <a:bodyPr rtlCol="0" anchor="ctr"/>
+          <a:lstStyle/>
+          <a:p>
+            <a:pPr algn="ctr"/>
+          </a:p>
+        </p:txBody>
+      </p:sp>
+      <p:sp>
+        <p:nvSpPr>
+          <p:cNvPr id="67" name="Rounded Rectangle 66"/>
+          <p:cNvSpPr/>
+          <p:nvPr/>
+        </p:nvSpPr>
+        <p:spPr>
+          <a:xfrm>
+            <a:off x="5760720" y="4251960"/>
+            <a:ext cx="256032" cy="256032"/>
+          </a:xfrm>
+          <a:prstGeom prst="roundRect">
+            <a:avLst/>
+          </a:prstGeom>
+          <a:solidFill>
+            <a:srgbClr val="000000"/>
+          </a:solidFill>
+          <a:ln>
+            <a:noFill/>
+          </a:ln>
+        </p:spPr>
+        <p:style>
+          <a:lnRef idx="1">
+            <a:schemeClr val="accent1"/>
+          </a:lnRef>
+          <a:fillRef idx="3">
+            <a:schemeClr val="accent1"/>
+          </a:fillRef>
+          <a:effectRef idx="2">
+            <a:schemeClr val="accent1"/>
+          </a:effectRef>
+          <a:fontRef idx="minor">
+            <a:schemeClr val="lt1"/>
+          </a:fontRef>
+        </p:style>
+        <p:txBody>
+          <a:bodyPr rtlCol="0" anchor="ctr"/>
+          <a:lstStyle/>
+          <a:p>
+            <a:pPr algn="ctr"/>
+          </a:p>
+        </p:txBody>
+      </p:sp>
+      <p:sp>
+        <p:nvSpPr>
+          <p:cNvPr id="68" name="TextBox 67"/>
+          <p:cNvSpPr txBox="1"/>
+          <p:nvPr/>
+        </p:nvSpPr>
+        <p:spPr>
+          <a:xfrm>
+            <a:off x="5760720" y="4279392"/>
+            <a:ext cx="256032" cy="201168"/>
+          </a:xfrm>
+          <a:prstGeom prst="rect">
+            <a:avLst/>
+          </a:prstGeom>
+          <a:noFill/>
+        </p:spPr>
+        <p:txBody>
+          <a:bodyPr wrap="square" lIns="0" tIns="0" rIns="0" bIns="0">
+            <a:spAutoFit/>
+          </a:bodyPr>
+          <a:lstStyle/>
+          <a:p>
+            <a:pPr algn="ctr"/>
+            <a:r>
+              <a:rPr sz="800" b="1" i="0">
+                <a:solidFill>
+                  <a:srgbClr val="FFFFFF"/>
+                </a:solidFill>
+                <a:latin typeface="JetBrains Mono"/>
+              </a:rPr>
+              <a:t>03</a:t>
+            </a:r>
+          </a:p>
+        </p:txBody>
+      </p:sp>
+      <p:sp>
+        <p:nvSpPr>
+          <p:cNvPr id="69" name="TextBox 68"/>
+          <p:cNvSpPr txBox="1"/>
+          <p:nvPr/>
+        </p:nvSpPr>
+        <p:spPr>
+          <a:xfrm>
+            <a:off x="6080760" y="4224528"/>
+            <a:ext cx="1737360" cy="228600"/>
+          </a:xfrm>
+          <a:prstGeom prst="rect">
+            <a:avLst/>
+          </a:prstGeom>
+          <a:noFill/>
+        </p:spPr>
+        <p:txBody>
+          <a:bodyPr wrap="square" lIns="0" tIns="0" rIns="0" bIns="0">
+            <a:spAutoFit/>
+          </a:bodyPr>
+          <a:lstStyle/>
+          <a:p>
+            <a:pPr algn="l"/>
+            <a:r>
+              <a:rPr sz="950" b="1" i="0">
+                <a:solidFill>
+                  <a:srgbClr val="000000"/>
+                </a:solidFill>
+                <a:latin typeface="Plus Jakarta Sans"/>
+              </a:rPr>
+              <a:t>3.59cm Precision</a:t>
+            </a:r>
+          </a:p>
+        </p:txBody>
+      </p:sp>
+      <p:sp>
+        <p:nvSpPr>
+          <p:cNvPr id="70" name="TextBox 69"/>
+          <p:cNvSpPr txBox="1"/>
+          <p:nvPr/>
+        </p:nvSpPr>
+        <p:spPr>
+          <a:xfrm>
+            <a:off x="6080760" y="4462272"/>
+            <a:ext cx="1737360" cy="201168"/>
+          </a:xfrm>
+          <a:prstGeom prst="rect">
+            <a:avLst/>
+          </a:prstGeom>
+          <a:noFill/>
+        </p:spPr>
+        <p:txBody>
+          <a:bodyPr wrap="square" lIns="0" tIns="0" rIns="0" bIns="0">
+            <a:spAutoFit/>
+          </a:bodyPr>
+          <a:lstStyle/>
+          <a:p>
+            <a:pPr algn="l"/>
+            <a:r>
+              <a:rPr sz="750" b="0" i="0">
+                <a:solidFill>
+                  <a:srgbClr val="475569"/>
+                </a:solidFill>
+                <a:latin typeface="Plus Jakarta Sans"/>
+              </a:rPr>
+              <a:t>DEM Raycast Geolocation</a:t>
+            </a:r>
+          </a:p>
+        </p:txBody>
+      </p:sp>
+      <p:sp>
+        <p:nvSpPr>
+          <p:cNvPr id="71" name="Rectangle 70"/>
+          <p:cNvSpPr/>
+          <p:nvPr/>
+        </p:nvSpPr>
+        <p:spPr>
+          <a:xfrm>
+            <a:off x="731520" y="5120640"/>
+            <a:ext cx="10728655" cy="13716"/>
+          </a:xfrm>
+          <a:prstGeom prst="rect">
+            <a:avLst/>
+          </a:prstGeom>
+          <a:solidFill>
+            <a:srgbClr val="E2E8F0"/>
+          </a:solidFill>
+          <a:ln>
+            <a:noFill/>
+          </a:ln>
+        </p:spPr>
+        <p:style>
+          <a:lnRef idx="1">
+            <a:schemeClr val="accent1"/>
+          </a:lnRef>
+          <a:fillRef idx="3">
+            <a:schemeClr val="accent1"/>
+          </a:fillRef>
+          <a:effectRef idx="2">
+            <a:schemeClr val="accent1"/>
+          </a:effectRef>
+          <a:fontRef idx="minor">
+            <a:schemeClr val="lt1"/>
+          </a:fontRef>
+        </p:style>
+        <p:txBody>
+          <a:bodyPr rtlCol="0" anchor="ctr"/>
+          <a:lstStyle/>
+          <a:p>
+            <a:pPr algn="ctr"/>
+          </a:p>
+        </p:txBody>
+      </p:sp>
+      <p:sp>
+        <p:nvSpPr>
+          <p:cNvPr id="72" name="TextBox 71"/>
           <p:cNvSpPr txBox="1"/>
           <p:nvPr/>
         </p:nvSpPr>
@@ -5436,7 +6015,7 @@
       </p:sp>
       <p:sp>
         <p:nvSpPr>
-          <p:cNvPr id="58" name="TextBox 57"/>
+          <p:cNvPr id="73" name="TextBox 72"/>
           <p:cNvSpPr txBox="1"/>
           <p:nvPr/>
         </p:nvSpPr>
@@ -5471,7 +6050,7 @@
       </p:sp>
       <p:sp>
         <p:nvSpPr>
-          <p:cNvPr id="59" name="Rounded Rectangle 58"/>
+          <p:cNvPr id="74" name="Rounded Rectangle 73"/>
           <p:cNvSpPr/>
           <p:nvPr/>
         </p:nvSpPr>
@@ -5516,7 +6095,7 @@
       </p:sp>
       <p:sp>
         <p:nvSpPr>
-          <p:cNvPr id="60" name="TextBox 59"/>
+          <p:cNvPr id="75" name="TextBox 74"/>
           <p:cNvSpPr txBox="1"/>
           <p:nvPr/>
         </p:nvSpPr>
@@ -5551,7 +6130,7 @@
       </p:sp>
       <p:sp>
         <p:nvSpPr>
-          <p:cNvPr id="61" name="TextBox 60"/>
+          <p:cNvPr id="76" name="TextBox 75"/>
           <p:cNvSpPr txBox="1"/>
           <p:nvPr/>
         </p:nvSpPr>
@@ -5586,7 +6165,7 @@
       </p:sp>
       <p:sp>
         <p:nvSpPr>
-          <p:cNvPr id="62" name="Rounded Rectangle 61"/>
+          <p:cNvPr id="77" name="Rounded Rectangle 76"/>
           <p:cNvSpPr/>
           <p:nvPr/>
         </p:nvSpPr>
@@ -5629,7 +6208,7 @@
       </p:sp>
       <p:sp>
         <p:nvSpPr>
-          <p:cNvPr id="63" name="TextBox 62"/>
+          <p:cNvPr id="78" name="TextBox 77"/>
           <p:cNvSpPr txBox="1"/>
           <p:nvPr/>
         </p:nvSpPr>
@@ -5664,7 +6243,7 @@
       </p:sp>
       <p:sp>
         <p:nvSpPr>
-          <p:cNvPr id="64" name="Rounded Rectangle 63"/>
+          <p:cNvPr id="79" name="Rounded Rectangle 78"/>
           <p:cNvSpPr/>
           <p:nvPr/>
         </p:nvSpPr>
@@ -5709,7 +6288,7 @@
       </p:sp>
       <p:sp>
         <p:nvSpPr>
-          <p:cNvPr id="65" name="TextBox 64"/>
+          <p:cNvPr id="80" name="TextBox 79"/>
           <p:cNvSpPr txBox="1"/>
           <p:nvPr/>
         </p:nvSpPr>
@@ -5744,7 +6323,7 @@
       </p:sp>
       <p:sp>
         <p:nvSpPr>
-          <p:cNvPr id="66" name="TextBox 65"/>
+          <p:cNvPr id="81" name="TextBox 80"/>
           <p:cNvSpPr txBox="1"/>
           <p:nvPr/>
         </p:nvSpPr>
@@ -5779,7 +6358,7 @@
       </p:sp>
       <p:sp>
         <p:nvSpPr>
-          <p:cNvPr id="67" name="Rounded Rectangle 66"/>
+          <p:cNvPr id="82" name="Rounded Rectangle 81"/>
           <p:cNvSpPr/>
           <p:nvPr/>
         </p:nvSpPr>
@@ -5822,7 +6401,7 @@
       </p:sp>
       <p:sp>
         <p:nvSpPr>
-          <p:cNvPr id="68" name="TextBox 67"/>
+          <p:cNvPr id="83" name="TextBox 82"/>
           <p:cNvSpPr txBox="1"/>
           <p:nvPr/>
         </p:nvSpPr>
@@ -5857,7 +6436,7 @@
       </p:sp>
       <p:sp>
         <p:nvSpPr>
-          <p:cNvPr id="69" name="Rounded Rectangle 68"/>
+          <p:cNvPr id="84" name="Rounded Rectangle 83"/>
           <p:cNvSpPr/>
           <p:nvPr/>
         </p:nvSpPr>
@@ -5902,7 +6481,7 @@
       </p:sp>
       <p:sp>
         <p:nvSpPr>
-          <p:cNvPr id="70" name="TextBox 69"/>
+          <p:cNvPr id="85" name="TextBox 84"/>
           <p:cNvSpPr txBox="1"/>
           <p:nvPr/>
         </p:nvSpPr>
@@ -5937,7 +6516,7 @@
       </p:sp>
       <p:sp>
         <p:nvSpPr>
-          <p:cNvPr id="71" name="TextBox 70"/>
+          <p:cNvPr id="86" name="TextBox 85"/>
           <p:cNvSpPr txBox="1"/>
           <p:nvPr/>
         </p:nvSpPr>
@@ -5972,7 +6551,7 @@
       </p:sp>
       <p:sp>
         <p:nvSpPr>
-          <p:cNvPr id="72" name="Rounded Rectangle 71"/>
+          <p:cNvPr id="87" name="Rounded Rectangle 86"/>
           <p:cNvSpPr/>
           <p:nvPr/>
         </p:nvSpPr>
@@ -6015,7 +6594,7 @@
       </p:sp>
       <p:sp>
         <p:nvSpPr>
-          <p:cNvPr id="73" name="TextBox 72"/>
+          <p:cNvPr id="88" name="TextBox 87"/>
           <p:cNvSpPr txBox="1"/>
           <p:nvPr/>
         </p:nvSpPr>
@@ -6050,7 +6629,7 @@
       </p:sp>
       <p:sp>
         <p:nvSpPr>
-          <p:cNvPr id="74" name="Rounded Rectangle 73"/>
+          <p:cNvPr id="89" name="Rounded Rectangle 88"/>
           <p:cNvSpPr/>
           <p:nvPr/>
         </p:nvSpPr>
@@ -6095,7 +6674,7 @@
       </p:sp>
       <p:sp>
         <p:nvSpPr>
-          <p:cNvPr id="75" name="TextBox 74"/>
+          <p:cNvPr id="90" name="TextBox 89"/>
           <p:cNvSpPr txBox="1"/>
           <p:nvPr/>
         </p:nvSpPr>
@@ -6130,7 +6709,7 @@
       </p:sp>
       <p:sp>
         <p:nvSpPr>
-          <p:cNvPr id="76" name="TextBox 75"/>
+          <p:cNvPr id="91" name="TextBox 90"/>
           <p:cNvSpPr txBox="1"/>
           <p:nvPr/>
         </p:nvSpPr>
@@ -6165,7 +6744,7 @@
       </p:sp>
       <p:sp>
         <p:nvSpPr>
-          <p:cNvPr id="77" name="Rounded Rectangle 76"/>
+          <p:cNvPr id="92" name="Rounded Rectangle 91"/>
           <p:cNvSpPr/>
           <p:nvPr/>
         </p:nvSpPr>
@@ -6208,7 +6787,7 @@
       </p:sp>
       <p:sp>
         <p:nvSpPr>
-          <p:cNvPr id="78" name="TextBox 77"/>
+          <p:cNvPr id="93" name="TextBox 92"/>
           <p:cNvSpPr txBox="1"/>
           <p:nvPr/>
         </p:nvSpPr>
@@ -6243,7 +6822,7 @@
       </p:sp>
       <p:sp>
         <p:nvSpPr>
-          <p:cNvPr id="79" name="Rounded Rectangle 78"/>
+          <p:cNvPr id="94" name="Rounded Rectangle 93"/>
           <p:cNvSpPr/>
           <p:nvPr/>
         </p:nvSpPr>
@@ -6288,7 +6867,7 @@
       </p:sp>
       <p:sp>
         <p:nvSpPr>
-          <p:cNvPr id="80" name="TextBox 79"/>
+          <p:cNvPr id="95" name="TextBox 94"/>
           <p:cNvSpPr txBox="1"/>
           <p:nvPr/>
         </p:nvSpPr>
@@ -6323,7 +6902,7 @@
       </p:sp>
       <p:sp>
         <p:nvSpPr>
-          <p:cNvPr id="81" name="TextBox 80"/>
+          <p:cNvPr id="96" name="TextBox 95"/>
           <p:cNvSpPr txBox="1"/>
           <p:nvPr/>
         </p:nvSpPr>
@@ -6358,7 +6937,7 @@
       </p:sp>
       <p:sp>
         <p:nvSpPr>
-          <p:cNvPr id="82" name="Rounded Rectangle 81"/>
+          <p:cNvPr id="97" name="Rounded Rectangle 96"/>
           <p:cNvSpPr/>
           <p:nvPr/>
         </p:nvSpPr>
@@ -6401,7 +6980,7 @@
       </p:sp>
       <p:sp>
         <p:nvSpPr>
-          <p:cNvPr id="83" name="TextBox 82"/>
+          <p:cNvPr id="98" name="TextBox 97"/>
           <p:cNvSpPr txBox="1"/>
           <p:nvPr/>
         </p:nvSpPr>

</xml_diff>

<commit_message>
feat(design): upgrade capability tabs to punchy Web Aura hero stat cards with watermarks and badges
</commit_message>
<xml_diff>
--- a/sutra_pitch_deck.pptx
+++ b/sutra_pitch_deck.pptx
@@ -5052,7 +5052,7 @@
         </p:nvSpPr>
         <p:spPr>
           <a:xfrm>
-            <a:off x="731520" y="1463040"/>
+            <a:off x="731520" y="1417320"/>
             <a:ext cx="10058400" cy="365760"/>
           </a:xfrm>
           <a:prstGeom prst="rect">
@@ -5087,7 +5087,7 @@
         </p:nvSpPr>
         <p:spPr>
           <a:xfrm>
-            <a:off x="548640" y="1965960"/>
+            <a:off x="548640" y="1874519"/>
             <a:ext cx="320040" cy="18288"/>
           </a:xfrm>
           <a:prstGeom prst="rect">
@@ -5130,7 +5130,7 @@
         </p:nvSpPr>
         <p:spPr>
           <a:xfrm>
-            <a:off x="548640" y="1965960"/>
+            <a:off x="548640" y="1874519"/>
             <a:ext cx="18288" cy="320040"/>
           </a:xfrm>
           <a:prstGeom prst="rect">
@@ -5173,7 +5173,7 @@
         </p:nvSpPr>
         <p:spPr>
           <a:xfrm>
-            <a:off x="5486400" y="3611880"/>
+            <a:off x="5486400" y="3429000"/>
             <a:ext cx="320040" cy="18288"/>
           </a:xfrm>
           <a:prstGeom prst="rect">
@@ -5216,7 +5216,7 @@
         </p:nvSpPr>
         <p:spPr>
           <a:xfrm>
-            <a:off x="5788152" y="3310128"/>
+            <a:off x="5788152" y="3127248"/>
             <a:ext cx="18288" cy="320040"/>
           </a:xfrm>
           <a:prstGeom prst="rect">
@@ -5259,7 +5259,7 @@
         </p:nvSpPr>
         <p:spPr>
           <a:xfrm>
-            <a:off x="731520" y="1965960"/>
+            <a:off x="731520" y="1874519"/>
             <a:ext cx="7315200" cy="731520"/>
           </a:xfrm>
           <a:prstGeom prst="rect">
@@ -5275,7 +5275,7 @@
           <a:p>
             <a:pPr algn="l"/>
             <a:r>
-              <a:rPr sz="5400" b="1" i="0">
+              <a:rPr sz="5200" b="1" i="0">
                 <a:solidFill>
                   <a:srgbClr val="000000"/>
                 </a:solidFill>
@@ -5294,7 +5294,7 @@
         </p:nvSpPr>
         <p:spPr>
           <a:xfrm>
-            <a:off x="731520" y="2697480"/>
+            <a:off x="731520" y="2560320"/>
             <a:ext cx="7315200" cy="731520"/>
           </a:xfrm>
           <a:prstGeom prst="rect">
@@ -5310,7 +5310,7 @@
           <a:p>
             <a:pPr algn="l"/>
             <a:r>
-              <a:rPr sz="5400" b="0" i="1">
+              <a:rPr sz="5200" b="0" i="1">
                 <a:solidFill>
                   <a:srgbClr val="475569"/>
                 </a:solidFill>
@@ -5329,8 +5329,8 @@
         </p:nvSpPr>
         <p:spPr>
           <a:xfrm>
-            <a:off x="731520" y="3566160"/>
-            <a:ext cx="9144000" cy="457200"/>
+            <a:off x="731520" y="3364992"/>
+            <a:ext cx="9144000" cy="411480"/>
           </a:xfrm>
           <a:prstGeom prst="rect">
             <a:avLst/>
@@ -5345,7 +5345,7 @@
           <a:p>
             <a:pPr algn="l"/>
             <a:r>
-              <a:rPr sz="1250" b="0" i="0">
+              <a:rPr sz="1200" b="0" i="0">
                 <a:solidFill>
                   <a:srgbClr val="475569"/>
                 </a:solidFill>
@@ -5364,8 +5364,8 @@
         </p:nvSpPr>
         <p:spPr>
           <a:xfrm>
-            <a:off x="731520" y="4160520"/>
-            <a:ext cx="2286000" cy="594360"/>
+            <a:off x="731520" y="3931920"/>
+            <a:ext cx="2468880" cy="1051560"/>
           </a:xfrm>
           <a:prstGeom prst="roundRect">
             <a:avLst/>
@@ -5403,14 +5403,49 @@
       </p:sp>
       <p:sp>
         <p:nvSpPr>
-          <p:cNvPr id="57" name="Rounded Rectangle 56"/>
+          <p:cNvPr id="57" name="TextBox 56"/>
+          <p:cNvSpPr txBox="1"/>
+          <p:nvPr/>
+        </p:nvSpPr>
+        <p:spPr>
+          <a:xfrm>
+            <a:off x="2377440" y="3886200"/>
+            <a:ext cx="731520" cy="548640"/>
+          </a:xfrm>
+          <a:prstGeom prst="rect">
+            <a:avLst/>
+          </a:prstGeom>
+          <a:noFill/>
+        </p:spPr>
+        <p:txBody>
+          <a:bodyPr wrap="square" lIns="0" tIns="0" rIns="0" bIns="0">
+            <a:spAutoFit/>
+          </a:bodyPr>
+          <a:lstStyle/>
+          <a:p>
+            <a:pPr algn="r"/>
+            <a:r>
+              <a:rPr sz="2800" b="1" i="0">
+                <a:solidFill>
+                  <a:srgbClr val="F1F5F9"/>
+                </a:solidFill>
+                <a:latin typeface="JetBrains Mono"/>
+              </a:rPr>
+              <a:t>01</a:t>
+            </a:r>
+          </a:p>
+        </p:txBody>
+      </p:sp>
+      <p:sp>
+        <p:nvSpPr>
+          <p:cNvPr id="58" name="Rounded Rectangle 57"/>
           <p:cNvSpPr/>
           <p:nvPr/>
         </p:nvSpPr>
         <p:spPr>
           <a:xfrm>
-            <a:off x="822960" y="4251960"/>
-            <a:ext cx="256032" cy="256032"/>
+            <a:off x="841248" y="4023360"/>
+            <a:ext cx="1005840" cy="182880"/>
           </a:xfrm>
           <a:prstGeom prst="roundRect">
             <a:avLst/>
@@ -5446,14 +5481,14 @@
       </p:sp>
       <p:sp>
         <p:nvSpPr>
-          <p:cNvPr id="58" name="TextBox 57"/>
+          <p:cNvPr id="59" name="TextBox 58"/>
           <p:cNvSpPr txBox="1"/>
           <p:nvPr/>
         </p:nvSpPr>
         <p:spPr>
           <a:xfrm>
-            <a:off x="822960" y="4279392"/>
-            <a:ext cx="256032" cy="201168"/>
+            <a:off x="841248" y="4041648"/>
+            <a:ext cx="1005840" cy="164592"/>
           </a:xfrm>
           <a:prstGeom prst="rect">
             <a:avLst/>
@@ -5468,27 +5503,27 @@
           <a:p>
             <a:pPr algn="ctr"/>
             <a:r>
-              <a:rPr sz="800" b="1" i="0">
+              <a:rPr sz="650" b="1" i="0">
                 <a:solidFill>
                   <a:srgbClr val="FFFFFF"/>
                 </a:solidFill>
-                <a:latin typeface="JetBrains Mono"/>
+                <a:latin typeface="Plus Jakarta Sans"/>
               </a:rPr>
-              <a:t>01</a:t>
-            </a:r>
-          </a:p>
-        </p:txBody>
-      </p:sp>
-      <p:sp>
-        <p:nvSpPr>
-          <p:cNvPr id="59" name="TextBox 58"/>
+              <a:t>GPS-DENIED</a:t>
+            </a:r>
+          </a:p>
+        </p:txBody>
+      </p:sp>
+      <p:sp>
+        <p:nvSpPr>
+          <p:cNvPr id="60" name="TextBox 59"/>
           <p:cNvSpPr txBox="1"/>
           <p:nvPr/>
         </p:nvSpPr>
         <p:spPr>
           <a:xfrm>
-            <a:off x="1143000" y="4224528"/>
-            <a:ext cx="1737360" cy="228600"/>
+            <a:off x="841248" y="4251960"/>
+            <a:ext cx="1280160" cy="365760"/>
           </a:xfrm>
           <a:prstGeom prst="rect">
             <a:avLst/>
@@ -5503,27 +5538,27 @@
           <a:p>
             <a:pPr algn="l"/>
             <a:r>
-              <a:rPr sz="950" b="1" i="0">
+              <a:rPr sz="2000" b="1" i="0">
                 <a:solidFill>
                   <a:srgbClr val="000000"/>
                 </a:solidFill>
                 <a:latin typeface="Plus Jakarta Sans"/>
               </a:rPr>
-              <a:t>0% GPS Reliance</a:t>
-            </a:r>
-          </a:p>
-        </p:txBody>
-      </p:sp>
-      <p:sp>
-        <p:nvSpPr>
-          <p:cNvPr id="60" name="TextBox 59"/>
+              <a:t>0%</a:t>
+            </a:r>
+          </a:p>
+        </p:txBody>
+      </p:sp>
+      <p:sp>
+        <p:nvSpPr>
+          <p:cNvPr id="61" name="TextBox 60"/>
           <p:cNvSpPr txBox="1"/>
           <p:nvPr/>
         </p:nvSpPr>
         <p:spPr>
           <a:xfrm>
-            <a:off x="1143000" y="4462272"/>
-            <a:ext cx="1737360" cy="201168"/>
+            <a:off x="1920240" y="4315968"/>
+            <a:ext cx="1097280" cy="274320"/>
           </a:xfrm>
           <a:prstGeom prst="rect">
             <a:avLst/>
@@ -5538,12 +5573,47 @@
           <a:p>
             <a:pPr algn="l"/>
             <a:r>
-              <a:rPr sz="750" b="0" i="0">
+              <a:rPr sz="900" b="1" i="0">
                 <a:solidFill>
                   <a:srgbClr val="475569"/>
                 </a:solidFill>
                 <a:latin typeface="Plus Jakarta Sans"/>
               </a:rPr>
+              <a:t>Reliance</a:t>
+            </a:r>
+          </a:p>
+        </p:txBody>
+      </p:sp>
+      <p:sp>
+        <p:nvSpPr>
+          <p:cNvPr id="62" name="TextBox 61"/>
+          <p:cNvSpPr txBox="1"/>
+          <p:nvPr/>
+        </p:nvSpPr>
+        <p:spPr>
+          <a:xfrm>
+            <a:off x="841248" y="4663440"/>
+            <a:ext cx="2240280" cy="228600"/>
+          </a:xfrm>
+          <a:prstGeom prst="rect">
+            <a:avLst/>
+          </a:prstGeom>
+          <a:noFill/>
+        </p:spPr>
+        <p:txBody>
+          <a:bodyPr wrap="square" lIns="0" tIns="0" rIns="0" bIns="0">
+            <a:spAutoFit/>
+          </a:bodyPr>
+          <a:lstStyle/>
+          <a:p>
+            <a:pPr algn="l"/>
+            <a:r>
+              <a:rPr sz="750" b="0" i="0">
+                <a:solidFill>
+                  <a:srgbClr val="64748B"/>
+                </a:solidFill>
+                <a:latin typeface="Plus Jakarta Sans"/>
+              </a:rPr>
               <a:t>VIO + Optical Flow EKF2</a:t>
             </a:r>
           </a:p>
@@ -5551,14 +5621,14 @@
       </p:sp>
       <p:sp>
         <p:nvSpPr>
-          <p:cNvPr id="61" name="Rounded Rectangle 60"/>
+          <p:cNvPr id="63" name="Rounded Rectangle 62"/>
           <p:cNvSpPr/>
           <p:nvPr/>
         </p:nvSpPr>
         <p:spPr>
           <a:xfrm>
-            <a:off x="3200400" y="4160520"/>
-            <a:ext cx="2286000" cy="594360"/>
+            <a:off x="3383280" y="3931920"/>
+            <a:ext cx="2468880" cy="1051560"/>
           </a:xfrm>
           <a:prstGeom prst="roundRect">
             <a:avLst/>
@@ -5596,20 +5666,55 @@
       </p:sp>
       <p:sp>
         <p:nvSpPr>
-          <p:cNvPr id="62" name="Rounded Rectangle 61"/>
+          <p:cNvPr id="64" name="TextBox 63"/>
+          <p:cNvSpPr txBox="1"/>
+          <p:nvPr/>
+        </p:nvSpPr>
+        <p:spPr>
+          <a:xfrm>
+            <a:off x="5029200" y="3886200"/>
+            <a:ext cx="731520" cy="548640"/>
+          </a:xfrm>
+          <a:prstGeom prst="rect">
+            <a:avLst/>
+          </a:prstGeom>
+          <a:noFill/>
+        </p:spPr>
+        <p:txBody>
+          <a:bodyPr wrap="square" lIns="0" tIns="0" rIns="0" bIns="0">
+            <a:spAutoFit/>
+          </a:bodyPr>
+          <a:lstStyle/>
+          <a:p>
+            <a:pPr algn="r"/>
+            <a:r>
+              <a:rPr sz="2800" b="1" i="0">
+                <a:solidFill>
+                  <a:srgbClr val="F1F5F9"/>
+                </a:solidFill>
+                <a:latin typeface="JetBrains Mono"/>
+              </a:rPr>
+              <a:t>02</a:t>
+            </a:r>
+          </a:p>
+        </p:txBody>
+      </p:sp>
+      <p:sp>
+        <p:nvSpPr>
+          <p:cNvPr id="65" name="Rounded Rectangle 64"/>
           <p:cNvSpPr/>
           <p:nvPr/>
         </p:nvSpPr>
         <p:spPr>
           <a:xfrm>
-            <a:off x="3291840" y="4251960"/>
-            <a:ext cx="256032" cy="256032"/>
+            <a:off x="3493008" y="4023360"/>
+            <a:ext cx="1005840" cy="182880"/>
           </a:xfrm>
           <a:prstGeom prst="roundRect">
             <a:avLst/>
           </a:prstGeom>
           <a:solidFill>
-            <a:srgbClr val="000000"/>
+            <a:srgbClr val="0A1628"/>
           </a:solidFill>
           <a:ln>
             <a:noFill/>
@@ -5639,14 +5744,14 @@
       </p:sp>
       <p:sp>
         <p:nvSpPr>
-          <p:cNvPr id="63" name="TextBox 62"/>
+          <p:cNvPr id="66" name="TextBox 65"/>
           <p:cNvSpPr txBox="1"/>
           <p:nvPr/>
         </p:nvSpPr>
         <p:spPr>
           <a:xfrm>
-            <a:off x="3291840" y="4279392"/>
-            <a:ext cx="256032" cy="201168"/>
+            <a:off x="3493008" y="4041648"/>
+            <a:ext cx="1005840" cy="164592"/>
           </a:xfrm>
           <a:prstGeom prst="rect">
             <a:avLst/>
@@ -5661,27 +5766,27 @@
           <a:p>
             <a:pPr algn="ctr"/>
             <a:r>
-              <a:rPr sz="800" b="1" i="0">
+              <a:rPr sz="650" b="1" i="0">
                 <a:solidFill>
                   <a:srgbClr val="FFFFFF"/>
                 </a:solidFill>
-                <a:latin typeface="JetBrains Mono"/>
+                <a:latin typeface="Plus Jakarta Sans"/>
               </a:rPr>
-              <a:t>02</a:t>
-            </a:r>
-          </a:p>
-        </p:txBody>
-      </p:sp>
-      <p:sp>
-        <p:nvSpPr>
-          <p:cNvPr id="64" name="TextBox 63"/>
+              <a:t>ZERO-CLIFF</a:t>
+            </a:r>
+          </a:p>
+        </p:txBody>
+      </p:sp>
+      <p:sp>
+        <p:nvSpPr>
+          <p:cNvPr id="67" name="TextBox 66"/>
           <p:cNvSpPr txBox="1"/>
           <p:nvPr/>
         </p:nvSpPr>
         <p:spPr>
           <a:xfrm>
-            <a:off x="3611880" y="4224528"/>
-            <a:ext cx="1737360" cy="228600"/>
+            <a:off x="3493008" y="4251960"/>
+            <a:ext cx="1280160" cy="365760"/>
           </a:xfrm>
           <a:prstGeom prst="rect">
             <a:avLst/>
@@ -5696,27 +5801,27 @@
           <a:p>
             <a:pPr algn="l"/>
             <a:r>
-              <a:rPr sz="950" b="1" i="0">
+              <a:rPr sz="2000" b="1" i="0">
                 <a:solidFill>
                   <a:srgbClr val="000000"/>
                 </a:solidFill>
                 <a:latin typeface="Plus Jakarta Sans"/>
               </a:rPr>
-              <a:t>0.0 dB Cliff Free</a:t>
-            </a:r>
-          </a:p>
-        </p:txBody>
-      </p:sp>
-      <p:sp>
-        <p:nvSpPr>
-          <p:cNvPr id="65" name="TextBox 64"/>
+              <a:t>0.0 dB</a:t>
+            </a:r>
+          </a:p>
+        </p:txBody>
+      </p:sp>
+      <p:sp>
+        <p:nvSpPr>
+          <p:cNvPr id="68" name="TextBox 67"/>
           <p:cNvSpPr txBox="1"/>
           <p:nvPr/>
         </p:nvSpPr>
         <p:spPr>
           <a:xfrm>
-            <a:off x="3611880" y="4462272"/>
-            <a:ext cx="1737360" cy="201168"/>
+            <a:off x="4572000" y="4315968"/>
+            <a:ext cx="1097280" cy="274320"/>
           </a:xfrm>
           <a:prstGeom prst="rect">
             <a:avLst/>
@@ -5731,12 +5836,47 @@
           <a:p>
             <a:pPr algn="l"/>
             <a:r>
-              <a:rPr sz="750" b="0" i="0">
+              <a:rPr sz="900" b="1" i="0">
                 <a:solidFill>
                   <a:srgbClr val="475569"/>
                 </a:solidFill>
                 <a:latin typeface="Plus Jakarta Sans"/>
               </a:rPr>
+              <a:t>Cliff Free</a:t>
+            </a:r>
+          </a:p>
+        </p:txBody>
+      </p:sp>
+      <p:sp>
+        <p:nvSpPr>
+          <p:cNvPr id="69" name="TextBox 68"/>
+          <p:cNvSpPr txBox="1"/>
+          <p:nvPr/>
+        </p:nvSpPr>
+        <p:spPr>
+          <a:xfrm>
+            <a:off x="3493008" y="4663440"/>
+            <a:ext cx="2240280" cy="228600"/>
+          </a:xfrm>
+          <a:prstGeom prst="rect">
+            <a:avLst/>
+          </a:prstGeom>
+          <a:noFill/>
+        </p:spPr>
+        <p:txBody>
+          <a:bodyPr wrap="square" lIns="0" tIns="0" rIns="0" bIns="0">
+            <a:spAutoFit/>
+          </a:bodyPr>
+          <a:lstStyle/>
+          <a:p>
+            <a:pPr algn="l"/>
+            <a:r>
+              <a:rPr sz="750" b="0" i="0">
+                <a:solidFill>
+                  <a:srgbClr val="64748B"/>
+                </a:solidFill>
+                <a:latin typeface="Plus Jakarta Sans"/>
+              </a:rPr>
               <a:t>Deep JSCC Neural Wireless</a:t>
             </a:r>
           </a:p>
@@ -5744,14 +5884,14 @@
       </p:sp>
       <p:sp>
         <p:nvSpPr>
-          <p:cNvPr id="66" name="Rounded Rectangle 65"/>
+          <p:cNvPr id="70" name="Rounded Rectangle 69"/>
           <p:cNvSpPr/>
           <p:nvPr/>
         </p:nvSpPr>
         <p:spPr>
           <a:xfrm>
-            <a:off x="5669280" y="4160520"/>
-            <a:ext cx="2286000" cy="594360"/>
+            <a:off x="6035040" y="3931920"/>
+            <a:ext cx="2468880" cy="1051560"/>
           </a:xfrm>
           <a:prstGeom prst="roundRect">
             <a:avLst/>
@@ -5789,20 +5929,55 @@
       </p:sp>
       <p:sp>
         <p:nvSpPr>
-          <p:cNvPr id="67" name="Rounded Rectangle 66"/>
+          <p:cNvPr id="71" name="TextBox 70"/>
+          <p:cNvSpPr txBox="1"/>
+          <p:nvPr/>
+        </p:nvSpPr>
+        <p:spPr>
+          <a:xfrm>
+            <a:off x="7680960" y="3886200"/>
+            <a:ext cx="731520" cy="548640"/>
+          </a:xfrm>
+          <a:prstGeom prst="rect">
+            <a:avLst/>
+          </a:prstGeom>
+          <a:noFill/>
+        </p:spPr>
+        <p:txBody>
+          <a:bodyPr wrap="square" lIns="0" tIns="0" rIns="0" bIns="0">
+            <a:spAutoFit/>
+          </a:bodyPr>
+          <a:lstStyle/>
+          <a:p>
+            <a:pPr algn="r"/>
+            <a:r>
+              <a:rPr sz="2800" b="1" i="0">
+                <a:solidFill>
+                  <a:srgbClr val="F1F5F9"/>
+                </a:solidFill>
+                <a:latin typeface="JetBrains Mono"/>
+              </a:rPr>
+              <a:t>03</a:t>
+            </a:r>
+          </a:p>
+        </p:txBody>
+      </p:sp>
+      <p:sp>
+        <p:nvSpPr>
+          <p:cNvPr id="72" name="Rounded Rectangle 71"/>
           <p:cNvSpPr/>
           <p:nvPr/>
         </p:nvSpPr>
         <p:spPr>
           <a:xfrm>
-            <a:off x="5760720" y="4251960"/>
-            <a:ext cx="256032" cy="256032"/>
+            <a:off x="6144768" y="4023360"/>
+            <a:ext cx="1005840" cy="182880"/>
           </a:xfrm>
           <a:prstGeom prst="roundRect">
             <a:avLst/>
           </a:prstGeom>
           <a:solidFill>
-            <a:srgbClr val="000000"/>
+            <a:srgbClr val="059669"/>
           </a:solidFill>
           <a:ln>
             <a:noFill/>
@@ -5832,14 +6007,14 @@
       </p:sp>
       <p:sp>
         <p:nvSpPr>
-          <p:cNvPr id="68" name="TextBox 67"/>
+          <p:cNvPr id="73" name="TextBox 72"/>
           <p:cNvSpPr txBox="1"/>
           <p:nvPr/>
         </p:nvSpPr>
         <p:spPr>
           <a:xfrm>
-            <a:off x="5760720" y="4279392"/>
-            <a:ext cx="256032" cy="201168"/>
+            <a:off x="6144768" y="4041648"/>
+            <a:ext cx="1005840" cy="164592"/>
           </a:xfrm>
           <a:prstGeom prst="rect">
             <a:avLst/>
@@ -5854,27 +6029,27 @@
           <a:p>
             <a:pPr algn="ctr"/>
             <a:r>
-              <a:rPr sz="800" b="1" i="0">
+              <a:rPr sz="650" b="1" i="0">
                 <a:solidFill>
                   <a:srgbClr val="FFFFFF"/>
                 </a:solidFill>
-                <a:latin typeface="JetBrains Mono"/>
+                <a:latin typeface="Plus Jakarta Sans"/>
               </a:rPr>
-              <a:t>03</a:t>
-            </a:r>
-          </a:p>
-        </p:txBody>
-      </p:sp>
-      <p:sp>
-        <p:nvSpPr>
-          <p:cNvPr id="69" name="TextBox 68"/>
+              <a:t>SUB-DECIMETER</a:t>
+            </a:r>
+          </a:p>
+        </p:txBody>
+      </p:sp>
+      <p:sp>
+        <p:nvSpPr>
+          <p:cNvPr id="74" name="TextBox 73"/>
           <p:cNvSpPr txBox="1"/>
           <p:nvPr/>
         </p:nvSpPr>
         <p:spPr>
           <a:xfrm>
-            <a:off x="6080760" y="4224528"/>
-            <a:ext cx="1737360" cy="228600"/>
+            <a:off x="6144768" y="4251960"/>
+            <a:ext cx="1280160" cy="365760"/>
           </a:xfrm>
           <a:prstGeom prst="rect">
             <a:avLst/>
@@ -5889,27 +6064,27 @@
           <a:p>
             <a:pPr algn="l"/>
             <a:r>
-              <a:rPr sz="950" b="1" i="0">
+              <a:rPr sz="2000" b="1" i="0">
                 <a:solidFill>
                   <a:srgbClr val="000000"/>
                 </a:solidFill>
                 <a:latin typeface="Plus Jakarta Sans"/>
               </a:rPr>
-              <a:t>3.59cm Precision</a:t>
-            </a:r>
-          </a:p>
-        </p:txBody>
-      </p:sp>
-      <p:sp>
-        <p:nvSpPr>
-          <p:cNvPr id="70" name="TextBox 69"/>
+              <a:t>3.59cm</a:t>
+            </a:r>
+          </a:p>
+        </p:txBody>
+      </p:sp>
+      <p:sp>
+        <p:nvSpPr>
+          <p:cNvPr id="75" name="TextBox 74"/>
           <p:cNvSpPr txBox="1"/>
           <p:nvPr/>
         </p:nvSpPr>
         <p:spPr>
           <a:xfrm>
-            <a:off x="6080760" y="4462272"/>
-            <a:ext cx="1737360" cy="201168"/>
+            <a:off x="7223760" y="4315968"/>
+            <a:ext cx="1097280" cy="274320"/>
           </a:xfrm>
           <a:prstGeom prst="rect">
             <a:avLst/>
@@ -5924,26 +6099,61 @@
           <a:p>
             <a:pPr algn="l"/>
             <a:r>
-              <a:rPr sz="750" b="0" i="0">
+              <a:rPr sz="900" b="1" i="0">
                 <a:solidFill>
                   <a:srgbClr val="475569"/>
                 </a:solidFill>
                 <a:latin typeface="Plus Jakarta Sans"/>
               </a:rPr>
-              <a:t>DEM Raycast Geolocation</a:t>
-            </a:r>
-          </a:p>
-        </p:txBody>
-      </p:sp>
-      <p:sp>
-        <p:nvSpPr>
-          <p:cNvPr id="71" name="Rectangle 70"/>
+              <a:t>Geo-Fix</a:t>
+            </a:r>
+          </a:p>
+        </p:txBody>
+      </p:sp>
+      <p:sp>
+        <p:nvSpPr>
+          <p:cNvPr id="76" name="TextBox 75"/>
+          <p:cNvSpPr txBox="1"/>
+          <p:nvPr/>
+        </p:nvSpPr>
+        <p:spPr>
+          <a:xfrm>
+            <a:off x="6144768" y="4663440"/>
+            <a:ext cx="2240280" cy="228600"/>
+          </a:xfrm>
+          <a:prstGeom prst="rect">
+            <a:avLst/>
+          </a:prstGeom>
+          <a:noFill/>
+        </p:spPr>
+        <p:txBody>
+          <a:bodyPr wrap="square" lIns="0" tIns="0" rIns="0" bIns="0">
+            <a:spAutoFit/>
+          </a:bodyPr>
+          <a:lstStyle/>
+          <a:p>
+            <a:pPr algn="l"/>
+            <a:r>
+              <a:rPr sz="750" b="0" i="0">
+                <a:solidFill>
+                  <a:srgbClr val="64748B"/>
+                </a:solidFill>
+                <a:latin typeface="Plus Jakarta Sans"/>
+              </a:rPr>
+              <a:t>3D DEM Terrain Raycast</a:t>
+            </a:r>
+          </a:p>
+        </p:txBody>
+      </p:sp>
+      <p:sp>
+        <p:nvSpPr>
+          <p:cNvPr id="77" name="Rectangle 76"/>
           <p:cNvSpPr/>
           <p:nvPr/>
         </p:nvSpPr>
         <p:spPr>
           <a:xfrm>
-            <a:off x="731520" y="5120640"/>
+            <a:off x="731520" y="5166360"/>
             <a:ext cx="10728655" cy="13716"/>
           </a:xfrm>
           <a:prstGeom prst="rect">
@@ -5980,13 +6190,13 @@
       </p:sp>
       <p:sp>
         <p:nvSpPr>
-          <p:cNvPr id="72" name="TextBox 71"/>
+          <p:cNvPr id="78" name="TextBox 77"/>
           <p:cNvSpPr txBox="1"/>
           <p:nvPr/>
         </p:nvSpPr>
         <p:spPr>
           <a:xfrm>
-            <a:off x="731520" y="5230368"/>
+            <a:off x="731520" y="5257800"/>
             <a:ext cx="5486400" cy="182880"/>
           </a:xfrm>
           <a:prstGeom prst="rect">
@@ -6015,13 +6225,13 @@
       </p:sp>
       <p:sp>
         <p:nvSpPr>
-          <p:cNvPr id="73" name="TextBox 72"/>
+          <p:cNvPr id="79" name="TextBox 78"/>
           <p:cNvSpPr txBox="1"/>
           <p:nvPr/>
         </p:nvSpPr>
         <p:spPr>
           <a:xfrm>
-            <a:off x="6858000" y="5230368"/>
+            <a:off x="6858000" y="5257800"/>
             <a:ext cx="4602175" cy="182880"/>
           </a:xfrm>
           <a:prstGeom prst="rect">
@@ -6050,7 +6260,7 @@
       </p:sp>
       <p:sp>
         <p:nvSpPr>
-          <p:cNvPr id="74" name="Rounded Rectangle 73"/>
+          <p:cNvPr id="80" name="Rounded Rectangle 79"/>
           <p:cNvSpPr/>
           <p:nvPr/>
         </p:nvSpPr>
@@ -6095,7 +6305,7 @@
       </p:sp>
       <p:sp>
         <p:nvSpPr>
-          <p:cNvPr id="75" name="TextBox 74"/>
+          <p:cNvPr id="81" name="TextBox 80"/>
           <p:cNvSpPr txBox="1"/>
           <p:nvPr/>
         </p:nvSpPr>
@@ -6130,7 +6340,7 @@
       </p:sp>
       <p:sp>
         <p:nvSpPr>
-          <p:cNvPr id="76" name="TextBox 75"/>
+          <p:cNvPr id="82" name="TextBox 81"/>
           <p:cNvSpPr txBox="1"/>
           <p:nvPr/>
         </p:nvSpPr>
@@ -6165,7 +6375,7 @@
       </p:sp>
       <p:sp>
         <p:nvSpPr>
-          <p:cNvPr id="77" name="Rounded Rectangle 76"/>
+          <p:cNvPr id="83" name="Rounded Rectangle 82"/>
           <p:cNvSpPr/>
           <p:nvPr/>
         </p:nvSpPr>
@@ -6208,7 +6418,7 @@
       </p:sp>
       <p:sp>
         <p:nvSpPr>
-          <p:cNvPr id="78" name="TextBox 77"/>
+          <p:cNvPr id="84" name="TextBox 83"/>
           <p:cNvSpPr txBox="1"/>
           <p:nvPr/>
         </p:nvSpPr>
@@ -6243,7 +6453,7 @@
       </p:sp>
       <p:sp>
         <p:nvSpPr>
-          <p:cNvPr id="79" name="Rounded Rectangle 78"/>
+          <p:cNvPr id="85" name="Rounded Rectangle 84"/>
           <p:cNvSpPr/>
           <p:nvPr/>
         </p:nvSpPr>
@@ -6288,7 +6498,7 @@
       </p:sp>
       <p:sp>
         <p:nvSpPr>
-          <p:cNvPr id="80" name="TextBox 79"/>
+          <p:cNvPr id="86" name="TextBox 85"/>
           <p:cNvSpPr txBox="1"/>
           <p:nvPr/>
         </p:nvSpPr>
@@ -6323,7 +6533,7 @@
       </p:sp>
       <p:sp>
         <p:nvSpPr>
-          <p:cNvPr id="81" name="TextBox 80"/>
+          <p:cNvPr id="87" name="TextBox 86"/>
           <p:cNvSpPr txBox="1"/>
           <p:nvPr/>
         </p:nvSpPr>
@@ -6358,7 +6568,7 @@
       </p:sp>
       <p:sp>
         <p:nvSpPr>
-          <p:cNvPr id="82" name="Rounded Rectangle 81"/>
+          <p:cNvPr id="88" name="Rounded Rectangle 87"/>
           <p:cNvSpPr/>
           <p:nvPr/>
         </p:nvSpPr>
@@ -6401,7 +6611,7 @@
       </p:sp>
       <p:sp>
         <p:nvSpPr>
-          <p:cNvPr id="83" name="TextBox 82"/>
+          <p:cNvPr id="89" name="TextBox 88"/>
           <p:cNvSpPr txBox="1"/>
           <p:nvPr/>
         </p:nvSpPr>
@@ -6436,7 +6646,7 @@
       </p:sp>
       <p:sp>
         <p:nvSpPr>
-          <p:cNvPr id="84" name="Rounded Rectangle 83"/>
+          <p:cNvPr id="90" name="Rounded Rectangle 89"/>
           <p:cNvSpPr/>
           <p:nvPr/>
         </p:nvSpPr>
@@ -6481,7 +6691,7 @@
       </p:sp>
       <p:sp>
         <p:nvSpPr>
-          <p:cNvPr id="85" name="TextBox 84"/>
+          <p:cNvPr id="91" name="TextBox 90"/>
           <p:cNvSpPr txBox="1"/>
           <p:nvPr/>
         </p:nvSpPr>
@@ -6516,7 +6726,7 @@
       </p:sp>
       <p:sp>
         <p:nvSpPr>
-          <p:cNvPr id="86" name="TextBox 85"/>
+          <p:cNvPr id="92" name="TextBox 91"/>
           <p:cNvSpPr txBox="1"/>
           <p:nvPr/>
         </p:nvSpPr>
@@ -6551,7 +6761,7 @@
       </p:sp>
       <p:sp>
         <p:nvSpPr>
-          <p:cNvPr id="87" name="Rounded Rectangle 86"/>
+          <p:cNvPr id="93" name="Rounded Rectangle 92"/>
           <p:cNvSpPr/>
           <p:nvPr/>
         </p:nvSpPr>
@@ -6594,7 +6804,7 @@
       </p:sp>
       <p:sp>
         <p:nvSpPr>
-          <p:cNvPr id="88" name="TextBox 87"/>
+          <p:cNvPr id="94" name="TextBox 93"/>
           <p:cNvSpPr txBox="1"/>
           <p:nvPr/>
         </p:nvSpPr>
@@ -6629,7 +6839,7 @@
       </p:sp>
       <p:sp>
         <p:nvSpPr>
-          <p:cNvPr id="89" name="Rounded Rectangle 88"/>
+          <p:cNvPr id="95" name="Rounded Rectangle 94"/>
           <p:cNvSpPr/>
           <p:nvPr/>
         </p:nvSpPr>
@@ -6674,7 +6884,7 @@
       </p:sp>
       <p:sp>
         <p:nvSpPr>
-          <p:cNvPr id="90" name="TextBox 89"/>
+          <p:cNvPr id="96" name="TextBox 95"/>
           <p:cNvSpPr txBox="1"/>
           <p:nvPr/>
         </p:nvSpPr>
@@ -6709,7 +6919,7 @@
       </p:sp>
       <p:sp>
         <p:nvSpPr>
-          <p:cNvPr id="91" name="TextBox 90"/>
+          <p:cNvPr id="97" name="TextBox 96"/>
           <p:cNvSpPr txBox="1"/>
           <p:nvPr/>
         </p:nvSpPr>
@@ -6744,7 +6954,7 @@
       </p:sp>
       <p:sp>
         <p:nvSpPr>
-          <p:cNvPr id="92" name="Rounded Rectangle 91"/>
+          <p:cNvPr id="98" name="Rounded Rectangle 97"/>
           <p:cNvSpPr/>
           <p:nvPr/>
         </p:nvSpPr>
@@ -6787,7 +6997,7 @@
       </p:sp>
       <p:sp>
         <p:nvSpPr>
-          <p:cNvPr id="93" name="TextBox 92"/>
+          <p:cNvPr id="99" name="TextBox 98"/>
           <p:cNvSpPr txBox="1"/>
           <p:nvPr/>
         </p:nvSpPr>
@@ -6822,7 +7032,7 @@
       </p:sp>
       <p:sp>
         <p:nvSpPr>
-          <p:cNvPr id="94" name="Rounded Rectangle 93"/>
+          <p:cNvPr id="100" name="Rounded Rectangle 99"/>
           <p:cNvSpPr/>
           <p:nvPr/>
         </p:nvSpPr>
@@ -6867,7 +7077,7 @@
       </p:sp>
       <p:sp>
         <p:nvSpPr>
-          <p:cNvPr id="95" name="TextBox 94"/>
+          <p:cNvPr id="101" name="TextBox 100"/>
           <p:cNvSpPr txBox="1"/>
           <p:nvPr/>
         </p:nvSpPr>
@@ -6902,7 +7112,7 @@
       </p:sp>
       <p:sp>
         <p:nvSpPr>
-          <p:cNvPr id="96" name="TextBox 95"/>
+          <p:cNvPr id="102" name="TextBox 101"/>
           <p:cNvSpPr txBox="1"/>
           <p:nvPr/>
         </p:nvSpPr>
@@ -6937,7 +7147,7 @@
       </p:sp>
       <p:sp>
         <p:nvSpPr>
-          <p:cNvPr id="97" name="Rounded Rectangle 96"/>
+          <p:cNvPr id="103" name="Rounded Rectangle 102"/>
           <p:cNvSpPr/>
           <p:nvPr/>
         </p:nvSpPr>
@@ -6980,7 +7190,7 @@
       </p:sp>
       <p:sp>
         <p:nvSpPr>
-          <p:cNvPr id="98" name="TextBox 97"/>
+          <p:cNvPr id="104" name="TextBox 103"/>
           <p:cNvSpPr txBox="1"/>
           <p:nvPr/>
         </p:nvSpPr>

</xml_diff>

<commit_message>
feat(design): replace artificial zeros with grounded engineering benchmarks (50Hz GNC, -5dB Comms, 3.59cm Geolocation)
</commit_message>
<xml_diff>
--- a/sutra_pitch_deck.pptx
+++ b/sutra_pitch_deck.pptx
@@ -5445,7 +5445,7 @@
         <p:spPr>
           <a:xfrm>
             <a:off x="841248" y="4023360"/>
-            <a:ext cx="1005840" cy="182880"/>
+            <a:ext cx="1188720" cy="182880"/>
           </a:xfrm>
           <a:prstGeom prst="roundRect">
             <a:avLst/>
@@ -5488,7 +5488,7 @@
         <p:spPr>
           <a:xfrm>
             <a:off x="841248" y="4041648"/>
-            <a:ext cx="1005840" cy="164592"/>
+            <a:ext cx="1188720" cy="164592"/>
           </a:xfrm>
           <a:prstGeom prst="rect">
             <a:avLst/>
@@ -5503,13 +5503,13 @@
           <a:p>
             <a:pPr algn="ctr"/>
             <a:r>
-              <a:rPr sz="650" b="1" i="0">
+              <a:rPr sz="620" b="1" i="0">
                 <a:solidFill>
                   <a:srgbClr val="FFFFFF"/>
                 </a:solidFill>
                 <a:latin typeface="Plus Jakarta Sans"/>
               </a:rPr>
-              <a:t>GPS-DENIED</a:t>
+              <a:t>DECENTRALIZED GNC</a:t>
             </a:r>
           </a:p>
         </p:txBody>
@@ -5538,13 +5538,13 @@
           <a:p>
             <a:pPr algn="l"/>
             <a:r>
-              <a:rPr sz="2000" b="1" i="0">
+              <a:rPr sz="1900" b="1" i="0">
                 <a:solidFill>
                   <a:srgbClr val="000000"/>
                 </a:solidFill>
                 <a:latin typeface="Plus Jakarta Sans"/>
               </a:rPr>
-              <a:t>0%</a:t>
+              <a:t>50Hz</a:t>
             </a:r>
           </a:p>
         </p:txBody>
@@ -5557,8 +5557,8 @@
         </p:nvSpPr>
         <p:spPr>
           <a:xfrm>
-            <a:off x="1920240" y="4315968"/>
-            <a:ext cx="1097280" cy="274320"/>
+            <a:off x="1828800" y="4315968"/>
+            <a:ext cx="1188720" cy="274320"/>
           </a:xfrm>
           <a:prstGeom prst="rect">
             <a:avLst/>
@@ -5579,7 +5579,7 @@
                 </a:solidFill>
                 <a:latin typeface="Plus Jakarta Sans"/>
               </a:rPr>
-              <a:t>Reliance</a:t>
+              <a:t>Offboard Rate</a:t>
             </a:r>
           </a:p>
         </p:txBody>
@@ -5614,7 +5614,7 @@
                 </a:solidFill>
                 <a:latin typeface="Plus Jakarta Sans"/>
               </a:rPr>
-              <a:t>VIO + Optical Flow EKF2</a:t>
+              <a:t>PX4 MicroXRCE + VIO EKF2</a:t>
             </a:r>
           </a:p>
         </p:txBody>
@@ -5708,7 +5708,7 @@
         <p:spPr>
           <a:xfrm>
             <a:off x="3493008" y="4023360"/>
-            <a:ext cx="1005840" cy="182880"/>
+            <a:ext cx="1188720" cy="182880"/>
           </a:xfrm>
           <a:prstGeom prst="roundRect">
             <a:avLst/>
@@ -5751,7 +5751,7 @@
         <p:spPr>
           <a:xfrm>
             <a:off x="3493008" y="4041648"/>
-            <a:ext cx="1005840" cy="164592"/>
+            <a:ext cx="1188720" cy="164592"/>
           </a:xfrm>
           <a:prstGeom prst="rect">
             <a:avLst/>
@@ -5766,13 +5766,13 @@
           <a:p>
             <a:pPr algn="ctr"/>
             <a:r>
-              <a:rPr sz="650" b="1" i="0">
+              <a:rPr sz="620" b="1" i="0">
                 <a:solidFill>
                   <a:srgbClr val="FFFFFF"/>
                 </a:solidFill>
                 <a:latin typeface="Plus Jakarta Sans"/>
               </a:rPr>
-              <a:t>ZERO-CLIFF</a:t>
+              <a:t>SEMANTIC WIRELESS</a:t>
             </a:r>
           </a:p>
         </p:txBody>
@@ -5801,13 +5801,13 @@
           <a:p>
             <a:pPr algn="l"/>
             <a:r>
-              <a:rPr sz="2000" b="1" i="0">
+              <a:rPr sz="1900" b="1" i="0">
                 <a:solidFill>
                   <a:srgbClr val="000000"/>
                 </a:solidFill>
                 <a:latin typeface="Plus Jakarta Sans"/>
               </a:rPr>
-              <a:t>0.0 dB</a:t>
+              <a:t>-5dB</a:t>
             </a:r>
           </a:p>
         </p:txBody>
@@ -5820,8 +5820,8 @@
         </p:nvSpPr>
         <p:spPr>
           <a:xfrm>
-            <a:off x="4572000" y="4315968"/>
-            <a:ext cx="1097280" cy="274320"/>
+            <a:off x="4480560" y="4315968"/>
+            <a:ext cx="1188720" cy="274320"/>
           </a:xfrm>
           <a:prstGeom prst="rect">
             <a:avLst/>
@@ -5842,7 +5842,7 @@
                 </a:solidFill>
                 <a:latin typeface="Plus Jakarta Sans"/>
               </a:rPr>
-              <a:t>Cliff Free</a:t>
+              <a:t>Jam Resilience</a:t>
             </a:r>
           </a:p>
         </p:txBody>
@@ -5877,7 +5877,7 @@
                 </a:solidFill>
                 <a:latin typeface="Plus Jakarta Sans"/>
               </a:rPr>
-              <a:t>Deep JSCC Neural Wireless</a:t>
+              <a:t>Deep JSCC Zero-Cliff Video</a:t>
             </a:r>
           </a:p>
         </p:txBody>
@@ -5971,7 +5971,7 @@
         <p:spPr>
           <a:xfrm>
             <a:off x="6144768" y="4023360"/>
-            <a:ext cx="1005840" cy="182880"/>
+            <a:ext cx="1188720" cy="182880"/>
           </a:xfrm>
           <a:prstGeom prst="roundRect">
             <a:avLst/>
@@ -6014,7 +6014,7 @@
         <p:spPr>
           <a:xfrm>
             <a:off x="6144768" y="4041648"/>
-            <a:ext cx="1005840" cy="164592"/>
+            <a:ext cx="1188720" cy="164592"/>
           </a:xfrm>
           <a:prstGeom prst="rect">
             <a:avLst/>
@@ -6029,13 +6029,13 @@
           <a:p>
             <a:pPr algn="ctr"/>
             <a:r>
-              <a:rPr sz="650" b="1" i="0">
+              <a:rPr sz="620" b="1" i="0">
                 <a:solidFill>
                   <a:srgbClr val="FFFFFF"/>
                 </a:solidFill>
                 <a:latin typeface="Plus Jakarta Sans"/>
               </a:rPr>
-              <a:t>SUB-DECIMETER</a:t>
+              <a:t>TERRAIN GEOLOCATION</a:t>
             </a:r>
           </a:p>
         </p:txBody>
@@ -6064,7 +6064,7 @@
           <a:p>
             <a:pPr algn="l"/>
             <a:r>
-              <a:rPr sz="2000" b="1" i="0">
+              <a:rPr sz="1900" b="1" i="0">
                 <a:solidFill>
                   <a:srgbClr val="000000"/>
                 </a:solidFill>
@@ -6083,8 +6083,8 @@
         </p:nvSpPr>
         <p:spPr>
           <a:xfrm>
-            <a:off x="7223760" y="4315968"/>
-            <a:ext cx="1097280" cy="274320"/>
+            <a:off x="7132320" y="4315968"/>
+            <a:ext cx="1188720" cy="274320"/>
           </a:xfrm>
           <a:prstGeom prst="rect">
             <a:avLst/>
@@ -6105,7 +6105,7 @@
                 </a:solidFill>
                 <a:latin typeface="Plus Jakarta Sans"/>
               </a:rPr>
-              <a:t>Geo-Fix</a:t>
+              <a:t>Geo-Accuracy</a:t>
             </a:r>
           </a:p>
         </p:txBody>
@@ -6140,7 +6140,7 @@
                 </a:solidFill>
                 <a:latin typeface="Plus Jakarta Sans"/>
               </a:rPr>
-              <a:t>3D DEM Terrain Raycast</a:t>
+              <a:t>WGS84 3D DEM Raycasting</a:t>
             </a:r>
           </a:p>
         </p:txBody>

</xml_diff>

<commit_message>
feat(slides): implement Slide 2 (The Problem) compliant with PPT Artisan 6x6 rule and conclusion headline
</commit_message>
<xml_diff>
--- a/sutra_pitch_deck.pptx
+++ b/sutra_pitch_deck.pptx
@@ -6,6 +6,7 @@
   </p:sldMasterIdLst>
   <p:sldIdLst>
     <p:sldId id="256" r:id="rId7"/>
+    <p:sldId id="257" r:id="rId8"/>
   </p:sldIdLst>
   <p:sldSz cx="12191695" cy="6858000" type="screen4x3"/>
   <p:notesSz cx="6858000" cy="9144000"/>
@@ -5349,7 +5350,7 @@
                 <a:solidFill>
                   <a:srgbClr val="475569"/>
                 </a:solidFill>
-                <a:latin typeface="Plus Jakarta Sans"/>
+                <a:latin typeface="Inter"/>
               </a:rPr>
               <a:t>Swarm Unified Tactical Reconnaissance Architecture — decentralized multi-UAV flight, Deep JSCC neural zero-cliff video, and 3.59cm terrain-corrected DEM survivor geolocation.</a:t>
             </a:r>
@@ -5612,7 +5613,7 @@
                 <a:solidFill>
                   <a:srgbClr val="64748B"/>
                 </a:solidFill>
-                <a:latin typeface="Plus Jakarta Sans"/>
+                <a:latin typeface="Inter"/>
               </a:rPr>
               <a:t>PX4 MicroXRCE + VIO EKF2</a:t>
             </a:r>
@@ -5875,7 +5876,7 @@
                 <a:solidFill>
                   <a:srgbClr val="64748B"/>
                 </a:solidFill>
-                <a:latin typeface="Plus Jakarta Sans"/>
+                <a:latin typeface="Inter"/>
               </a:rPr>
               <a:t>Deep JSCC Zero-Cliff Video</a:t>
             </a:r>
@@ -6138,7 +6139,7 @@
                 <a:solidFill>
                   <a:srgbClr val="64748B"/>
                 </a:solidFill>
-                <a:latin typeface="Plus Jakarta Sans"/>
+                <a:latin typeface="Inter"/>
               </a:rPr>
               <a:t>WGS84 3D DEM Raycasting</a:t>
             </a:r>
@@ -6366,7 +6367,7 @@
                 <a:solidFill>
                   <a:srgbClr val="475569"/>
                 </a:solidFill>
-                <a:latin typeface="Plus Jakarta Sans"/>
+                <a:latin typeface="Inter"/>
               </a:rPr>
               <a:t>Tech Lead · Subsys A &amp; B</a:t>
             </a:r>
@@ -6559,7 +6560,7 @@
                 <a:solidFill>
                   <a:srgbClr val="475569"/>
                 </a:solidFill>
-                <a:latin typeface="Plus Jakarta Sans"/>
+                <a:latin typeface="Inter"/>
               </a:rPr>
               <a:t>Lead · Subsystem C</a:t>
             </a:r>
@@ -6752,7 +6753,7 @@
                 <a:solidFill>
                   <a:srgbClr val="475569"/>
                 </a:solidFill>
-                <a:latin typeface="Plus Jakarta Sans"/>
+                <a:latin typeface="Inter"/>
               </a:rPr>
               <a:t>Lead · Subsystem D</a:t>
             </a:r>
@@ -6945,7 +6946,7 @@
                 <a:solidFill>
                   <a:srgbClr val="475569"/>
                 </a:solidFill>
-                <a:latin typeface="Plus Jakarta Sans"/>
+                <a:latin typeface="Inter"/>
               </a:rPr>
               <a:t>Lead · Subsystem E</a:t>
             </a:r>
@@ -7138,7 +7139,7 @@
                 <a:solidFill>
                   <a:srgbClr val="475569"/>
                 </a:solidFill>
-                <a:latin typeface="Plus Jakarta Sans"/>
+                <a:latin typeface="Inter"/>
               </a:rPr>
               <a:t>Lead · Subsystem F</a:t>
             </a:r>
@@ -7219,6 +7220,2360 @@
                 <a:latin typeface="Plus Jakarta Sans"/>
               </a:rPr>
               <a:t>NDMA CONOPS</a:t>
+            </a:r>
+          </a:p>
+        </p:txBody>
+      </p:sp>
+    </p:spTree>
+  </p:cSld>
+  <p:clrMapOvr>
+    <a:masterClrMapping/>
+  </p:clrMapOvr>
+</p:sld>
+</file>
+
+<file path=ppt/slides/slide2.xml><?xml version="1.0" encoding="utf-8"?>
+<p:sld xmlns:a="http://schemas.openxmlformats.org/drawingml/2006/main" xmlns:p="http://schemas.openxmlformats.org/presentationml/2006/main" xmlns:r="http://schemas.openxmlformats.org/officeDocument/2006/relationships">
+  <p:cSld>
+    <p:spTree>
+      <p:nvGrpSpPr>
+        <p:cNvPr id="1" name=""/>
+        <p:cNvGrpSpPr/>
+        <p:nvPr/>
+      </p:nvGrpSpPr>
+      <p:grpSpPr/>
+      <p:sp>
+        <p:nvSpPr>
+          <p:cNvPr id="2" name="Rectangle 1"/>
+          <p:cNvSpPr/>
+          <p:nvPr/>
+        </p:nvSpPr>
+        <p:spPr>
+          <a:xfrm>
+            <a:off x="0" y="0"/>
+            <a:ext cx="12191695" cy="6858000"/>
+          </a:xfrm>
+          <a:prstGeom prst="rect">
+            <a:avLst/>
+          </a:prstGeom>
+          <a:solidFill>
+            <a:srgbClr val="FFFFFF"/>
+          </a:solidFill>
+          <a:ln>
+            <a:noFill/>
+          </a:ln>
+        </p:spPr>
+        <p:style>
+          <a:lnRef idx="1">
+            <a:schemeClr val="accent1"/>
+          </a:lnRef>
+          <a:fillRef idx="3">
+            <a:schemeClr val="accent1"/>
+          </a:fillRef>
+          <a:effectRef idx="2">
+            <a:schemeClr val="accent1"/>
+          </a:effectRef>
+          <a:fontRef idx="minor">
+            <a:schemeClr val="lt1"/>
+          </a:fontRef>
+        </p:style>
+        <p:txBody>
+          <a:bodyPr rtlCol="0" anchor="ctr"/>
+          <a:lstStyle/>
+          <a:p>
+            <a:pPr algn="ctr"/>
+          </a:p>
+        </p:txBody>
+      </p:sp>
+      <p:sp>
+        <p:nvSpPr>
+          <p:cNvPr id="3" name="Rectangle 2"/>
+          <p:cNvSpPr/>
+          <p:nvPr/>
+        </p:nvSpPr>
+        <p:spPr>
+          <a:xfrm>
+            <a:off x="457200" y="0"/>
+            <a:ext cx="7315" cy="6858000"/>
+          </a:xfrm>
+          <a:prstGeom prst="rect">
+            <a:avLst/>
+          </a:prstGeom>
+          <a:solidFill>
+            <a:srgbClr val="E2E8F0"/>
+          </a:solidFill>
+          <a:ln>
+            <a:noFill/>
+          </a:ln>
+        </p:spPr>
+        <p:style>
+          <a:lnRef idx="1">
+            <a:schemeClr val="accent1"/>
+          </a:lnRef>
+          <a:fillRef idx="3">
+            <a:schemeClr val="accent1"/>
+          </a:fillRef>
+          <a:effectRef idx="2">
+            <a:schemeClr val="accent1"/>
+          </a:effectRef>
+          <a:fontRef idx="minor">
+            <a:schemeClr val="lt1"/>
+          </a:fontRef>
+        </p:style>
+        <p:txBody>
+          <a:bodyPr rtlCol="0" anchor="ctr"/>
+          <a:lstStyle/>
+          <a:p>
+            <a:pPr algn="ctr"/>
+          </a:p>
+        </p:txBody>
+      </p:sp>
+      <p:sp>
+        <p:nvSpPr>
+          <p:cNvPr id="4" name="Rectangle 3"/>
+          <p:cNvSpPr/>
+          <p:nvPr/>
+        </p:nvSpPr>
+        <p:spPr>
+          <a:xfrm>
+            <a:off x="914400" y="0"/>
+            <a:ext cx="7315" cy="6858000"/>
+          </a:xfrm>
+          <a:prstGeom prst="rect">
+            <a:avLst/>
+          </a:prstGeom>
+          <a:solidFill>
+            <a:srgbClr val="E2E8F0"/>
+          </a:solidFill>
+          <a:ln>
+            <a:noFill/>
+          </a:ln>
+        </p:spPr>
+        <p:style>
+          <a:lnRef idx="1">
+            <a:schemeClr val="accent1"/>
+          </a:lnRef>
+          <a:fillRef idx="3">
+            <a:schemeClr val="accent1"/>
+          </a:fillRef>
+          <a:effectRef idx="2">
+            <a:schemeClr val="accent1"/>
+          </a:effectRef>
+          <a:fontRef idx="minor">
+            <a:schemeClr val="lt1"/>
+          </a:fontRef>
+        </p:style>
+        <p:txBody>
+          <a:bodyPr rtlCol="0" anchor="ctr"/>
+          <a:lstStyle/>
+          <a:p>
+            <a:pPr algn="ctr"/>
+          </a:p>
+        </p:txBody>
+      </p:sp>
+      <p:sp>
+        <p:nvSpPr>
+          <p:cNvPr id="5" name="Rectangle 4"/>
+          <p:cNvSpPr/>
+          <p:nvPr/>
+        </p:nvSpPr>
+        <p:spPr>
+          <a:xfrm>
+            <a:off x="1371600" y="0"/>
+            <a:ext cx="7315" cy="6858000"/>
+          </a:xfrm>
+          <a:prstGeom prst="rect">
+            <a:avLst/>
+          </a:prstGeom>
+          <a:solidFill>
+            <a:srgbClr val="E2E8F0"/>
+          </a:solidFill>
+          <a:ln>
+            <a:noFill/>
+          </a:ln>
+        </p:spPr>
+        <p:style>
+          <a:lnRef idx="1">
+            <a:schemeClr val="accent1"/>
+          </a:lnRef>
+          <a:fillRef idx="3">
+            <a:schemeClr val="accent1"/>
+          </a:fillRef>
+          <a:effectRef idx="2">
+            <a:schemeClr val="accent1"/>
+          </a:effectRef>
+          <a:fontRef idx="minor">
+            <a:schemeClr val="lt1"/>
+          </a:fontRef>
+        </p:style>
+        <p:txBody>
+          <a:bodyPr rtlCol="0" anchor="ctr"/>
+          <a:lstStyle/>
+          <a:p>
+            <a:pPr algn="ctr"/>
+          </a:p>
+        </p:txBody>
+      </p:sp>
+      <p:sp>
+        <p:nvSpPr>
+          <p:cNvPr id="6" name="Rectangle 5"/>
+          <p:cNvSpPr/>
+          <p:nvPr/>
+        </p:nvSpPr>
+        <p:spPr>
+          <a:xfrm>
+            <a:off x="1828800" y="0"/>
+            <a:ext cx="7315" cy="6858000"/>
+          </a:xfrm>
+          <a:prstGeom prst="rect">
+            <a:avLst/>
+          </a:prstGeom>
+          <a:solidFill>
+            <a:srgbClr val="E2E8F0"/>
+          </a:solidFill>
+          <a:ln>
+            <a:noFill/>
+          </a:ln>
+        </p:spPr>
+        <p:style>
+          <a:lnRef idx="1">
+            <a:schemeClr val="accent1"/>
+          </a:lnRef>
+          <a:fillRef idx="3">
+            <a:schemeClr val="accent1"/>
+          </a:fillRef>
+          <a:effectRef idx="2">
+            <a:schemeClr val="accent1"/>
+          </a:effectRef>
+          <a:fontRef idx="minor">
+            <a:schemeClr val="lt1"/>
+          </a:fontRef>
+        </p:style>
+        <p:txBody>
+          <a:bodyPr rtlCol="0" anchor="ctr"/>
+          <a:lstStyle/>
+          <a:p>
+            <a:pPr algn="ctr"/>
+          </a:p>
+        </p:txBody>
+      </p:sp>
+      <p:sp>
+        <p:nvSpPr>
+          <p:cNvPr id="7" name="Rectangle 6"/>
+          <p:cNvSpPr/>
+          <p:nvPr/>
+        </p:nvSpPr>
+        <p:spPr>
+          <a:xfrm>
+            <a:off x="2286000" y="0"/>
+            <a:ext cx="7315" cy="6858000"/>
+          </a:xfrm>
+          <a:prstGeom prst="rect">
+            <a:avLst/>
+          </a:prstGeom>
+          <a:solidFill>
+            <a:srgbClr val="E2E8F0"/>
+          </a:solidFill>
+          <a:ln>
+            <a:noFill/>
+          </a:ln>
+        </p:spPr>
+        <p:style>
+          <a:lnRef idx="1">
+            <a:schemeClr val="accent1"/>
+          </a:lnRef>
+          <a:fillRef idx="3">
+            <a:schemeClr val="accent1"/>
+          </a:fillRef>
+          <a:effectRef idx="2">
+            <a:schemeClr val="accent1"/>
+          </a:effectRef>
+          <a:fontRef idx="minor">
+            <a:schemeClr val="lt1"/>
+          </a:fontRef>
+        </p:style>
+        <p:txBody>
+          <a:bodyPr rtlCol="0" anchor="ctr"/>
+          <a:lstStyle/>
+          <a:p>
+            <a:pPr algn="ctr"/>
+          </a:p>
+        </p:txBody>
+      </p:sp>
+      <p:sp>
+        <p:nvSpPr>
+          <p:cNvPr id="8" name="Rectangle 7"/>
+          <p:cNvSpPr/>
+          <p:nvPr/>
+        </p:nvSpPr>
+        <p:spPr>
+          <a:xfrm>
+            <a:off x="2743200" y="0"/>
+            <a:ext cx="7315" cy="6858000"/>
+          </a:xfrm>
+          <a:prstGeom prst="rect">
+            <a:avLst/>
+          </a:prstGeom>
+          <a:solidFill>
+            <a:srgbClr val="E2E8F0"/>
+          </a:solidFill>
+          <a:ln>
+            <a:noFill/>
+          </a:ln>
+        </p:spPr>
+        <p:style>
+          <a:lnRef idx="1">
+            <a:schemeClr val="accent1"/>
+          </a:lnRef>
+          <a:fillRef idx="3">
+            <a:schemeClr val="accent1"/>
+          </a:fillRef>
+          <a:effectRef idx="2">
+            <a:schemeClr val="accent1"/>
+          </a:effectRef>
+          <a:fontRef idx="minor">
+            <a:schemeClr val="lt1"/>
+          </a:fontRef>
+        </p:style>
+        <p:txBody>
+          <a:bodyPr rtlCol="0" anchor="ctr"/>
+          <a:lstStyle/>
+          <a:p>
+            <a:pPr algn="ctr"/>
+          </a:p>
+        </p:txBody>
+      </p:sp>
+      <p:sp>
+        <p:nvSpPr>
+          <p:cNvPr id="9" name="Rectangle 8"/>
+          <p:cNvSpPr/>
+          <p:nvPr/>
+        </p:nvSpPr>
+        <p:spPr>
+          <a:xfrm>
+            <a:off x="3200400" y="0"/>
+            <a:ext cx="7315" cy="6858000"/>
+          </a:xfrm>
+          <a:prstGeom prst="rect">
+            <a:avLst/>
+          </a:prstGeom>
+          <a:solidFill>
+            <a:srgbClr val="E2E8F0"/>
+          </a:solidFill>
+          <a:ln>
+            <a:noFill/>
+          </a:ln>
+        </p:spPr>
+        <p:style>
+          <a:lnRef idx="1">
+            <a:schemeClr val="accent1"/>
+          </a:lnRef>
+          <a:fillRef idx="3">
+            <a:schemeClr val="accent1"/>
+          </a:fillRef>
+          <a:effectRef idx="2">
+            <a:schemeClr val="accent1"/>
+          </a:effectRef>
+          <a:fontRef idx="minor">
+            <a:schemeClr val="lt1"/>
+          </a:fontRef>
+        </p:style>
+        <p:txBody>
+          <a:bodyPr rtlCol="0" anchor="ctr"/>
+          <a:lstStyle/>
+          <a:p>
+            <a:pPr algn="ctr"/>
+          </a:p>
+        </p:txBody>
+      </p:sp>
+      <p:sp>
+        <p:nvSpPr>
+          <p:cNvPr id="10" name="Rectangle 9"/>
+          <p:cNvSpPr/>
+          <p:nvPr/>
+        </p:nvSpPr>
+        <p:spPr>
+          <a:xfrm>
+            <a:off x="3657600" y="0"/>
+            <a:ext cx="7315" cy="6858000"/>
+          </a:xfrm>
+          <a:prstGeom prst="rect">
+            <a:avLst/>
+          </a:prstGeom>
+          <a:solidFill>
+            <a:srgbClr val="E2E8F0"/>
+          </a:solidFill>
+          <a:ln>
+            <a:noFill/>
+          </a:ln>
+        </p:spPr>
+        <p:style>
+          <a:lnRef idx="1">
+            <a:schemeClr val="accent1"/>
+          </a:lnRef>
+          <a:fillRef idx="3">
+            <a:schemeClr val="accent1"/>
+          </a:fillRef>
+          <a:effectRef idx="2">
+            <a:schemeClr val="accent1"/>
+          </a:effectRef>
+          <a:fontRef idx="minor">
+            <a:schemeClr val="lt1"/>
+          </a:fontRef>
+        </p:style>
+        <p:txBody>
+          <a:bodyPr rtlCol="0" anchor="ctr"/>
+          <a:lstStyle/>
+          <a:p>
+            <a:pPr algn="ctr"/>
+          </a:p>
+        </p:txBody>
+      </p:sp>
+      <p:sp>
+        <p:nvSpPr>
+          <p:cNvPr id="11" name="Rectangle 10"/>
+          <p:cNvSpPr/>
+          <p:nvPr/>
+        </p:nvSpPr>
+        <p:spPr>
+          <a:xfrm>
+            <a:off x="4114800" y="0"/>
+            <a:ext cx="7315" cy="6858000"/>
+          </a:xfrm>
+          <a:prstGeom prst="rect">
+            <a:avLst/>
+          </a:prstGeom>
+          <a:solidFill>
+            <a:srgbClr val="E2E8F0"/>
+          </a:solidFill>
+          <a:ln>
+            <a:noFill/>
+          </a:ln>
+        </p:spPr>
+        <p:style>
+          <a:lnRef idx="1">
+            <a:schemeClr val="accent1"/>
+          </a:lnRef>
+          <a:fillRef idx="3">
+            <a:schemeClr val="accent1"/>
+          </a:fillRef>
+          <a:effectRef idx="2">
+            <a:schemeClr val="accent1"/>
+          </a:effectRef>
+          <a:fontRef idx="minor">
+            <a:schemeClr val="lt1"/>
+          </a:fontRef>
+        </p:style>
+        <p:txBody>
+          <a:bodyPr rtlCol="0" anchor="ctr"/>
+          <a:lstStyle/>
+          <a:p>
+            <a:pPr algn="ctr"/>
+          </a:p>
+        </p:txBody>
+      </p:sp>
+      <p:sp>
+        <p:nvSpPr>
+          <p:cNvPr id="12" name="Rectangle 11"/>
+          <p:cNvSpPr/>
+          <p:nvPr/>
+        </p:nvSpPr>
+        <p:spPr>
+          <a:xfrm>
+            <a:off x="4572000" y="0"/>
+            <a:ext cx="7315" cy="6858000"/>
+          </a:xfrm>
+          <a:prstGeom prst="rect">
+            <a:avLst/>
+          </a:prstGeom>
+          <a:solidFill>
+            <a:srgbClr val="E2E8F0"/>
+          </a:solidFill>
+          <a:ln>
+            <a:noFill/>
+          </a:ln>
+        </p:spPr>
+        <p:style>
+          <a:lnRef idx="1">
+            <a:schemeClr val="accent1"/>
+          </a:lnRef>
+          <a:fillRef idx="3">
+            <a:schemeClr val="accent1"/>
+          </a:fillRef>
+          <a:effectRef idx="2">
+            <a:schemeClr val="accent1"/>
+          </a:effectRef>
+          <a:fontRef idx="minor">
+            <a:schemeClr val="lt1"/>
+          </a:fontRef>
+        </p:style>
+        <p:txBody>
+          <a:bodyPr rtlCol="0" anchor="ctr"/>
+          <a:lstStyle/>
+          <a:p>
+            <a:pPr algn="ctr"/>
+          </a:p>
+        </p:txBody>
+      </p:sp>
+      <p:sp>
+        <p:nvSpPr>
+          <p:cNvPr id="13" name="Rectangle 12"/>
+          <p:cNvSpPr/>
+          <p:nvPr/>
+        </p:nvSpPr>
+        <p:spPr>
+          <a:xfrm>
+            <a:off x="5029200" y="0"/>
+            <a:ext cx="7315" cy="6858000"/>
+          </a:xfrm>
+          <a:prstGeom prst="rect">
+            <a:avLst/>
+          </a:prstGeom>
+          <a:solidFill>
+            <a:srgbClr val="E2E8F0"/>
+          </a:solidFill>
+          <a:ln>
+            <a:noFill/>
+          </a:ln>
+        </p:spPr>
+        <p:style>
+          <a:lnRef idx="1">
+            <a:schemeClr val="accent1"/>
+          </a:lnRef>
+          <a:fillRef idx="3">
+            <a:schemeClr val="accent1"/>
+          </a:fillRef>
+          <a:effectRef idx="2">
+            <a:schemeClr val="accent1"/>
+          </a:effectRef>
+          <a:fontRef idx="minor">
+            <a:schemeClr val="lt1"/>
+          </a:fontRef>
+        </p:style>
+        <p:txBody>
+          <a:bodyPr rtlCol="0" anchor="ctr"/>
+          <a:lstStyle/>
+          <a:p>
+            <a:pPr algn="ctr"/>
+          </a:p>
+        </p:txBody>
+      </p:sp>
+      <p:sp>
+        <p:nvSpPr>
+          <p:cNvPr id="14" name="Rectangle 13"/>
+          <p:cNvSpPr/>
+          <p:nvPr/>
+        </p:nvSpPr>
+        <p:spPr>
+          <a:xfrm>
+            <a:off x="5486400" y="0"/>
+            <a:ext cx="7315" cy="6858000"/>
+          </a:xfrm>
+          <a:prstGeom prst="rect">
+            <a:avLst/>
+          </a:prstGeom>
+          <a:solidFill>
+            <a:srgbClr val="E2E8F0"/>
+          </a:solidFill>
+          <a:ln>
+            <a:noFill/>
+          </a:ln>
+        </p:spPr>
+        <p:style>
+          <a:lnRef idx="1">
+            <a:schemeClr val="accent1"/>
+          </a:lnRef>
+          <a:fillRef idx="3">
+            <a:schemeClr val="accent1"/>
+          </a:fillRef>
+          <a:effectRef idx="2">
+            <a:schemeClr val="accent1"/>
+          </a:effectRef>
+          <a:fontRef idx="minor">
+            <a:schemeClr val="lt1"/>
+          </a:fontRef>
+        </p:style>
+        <p:txBody>
+          <a:bodyPr rtlCol="0" anchor="ctr"/>
+          <a:lstStyle/>
+          <a:p>
+            <a:pPr algn="ctr"/>
+          </a:p>
+        </p:txBody>
+      </p:sp>
+      <p:sp>
+        <p:nvSpPr>
+          <p:cNvPr id="15" name="Rectangle 14"/>
+          <p:cNvSpPr/>
+          <p:nvPr/>
+        </p:nvSpPr>
+        <p:spPr>
+          <a:xfrm>
+            <a:off x="5943600" y="0"/>
+            <a:ext cx="7315" cy="6858000"/>
+          </a:xfrm>
+          <a:prstGeom prst="rect">
+            <a:avLst/>
+          </a:prstGeom>
+          <a:solidFill>
+            <a:srgbClr val="E2E8F0"/>
+          </a:solidFill>
+          <a:ln>
+            <a:noFill/>
+          </a:ln>
+        </p:spPr>
+        <p:style>
+          <a:lnRef idx="1">
+            <a:schemeClr val="accent1"/>
+          </a:lnRef>
+          <a:fillRef idx="3">
+            <a:schemeClr val="accent1"/>
+          </a:fillRef>
+          <a:effectRef idx="2">
+            <a:schemeClr val="accent1"/>
+          </a:effectRef>
+          <a:fontRef idx="minor">
+            <a:schemeClr val="lt1"/>
+          </a:fontRef>
+        </p:style>
+        <p:txBody>
+          <a:bodyPr rtlCol="0" anchor="ctr"/>
+          <a:lstStyle/>
+          <a:p>
+            <a:pPr algn="ctr"/>
+          </a:p>
+        </p:txBody>
+      </p:sp>
+      <p:sp>
+        <p:nvSpPr>
+          <p:cNvPr id="16" name="Rectangle 15"/>
+          <p:cNvSpPr/>
+          <p:nvPr/>
+        </p:nvSpPr>
+        <p:spPr>
+          <a:xfrm>
+            <a:off x="6400800" y="0"/>
+            <a:ext cx="7315" cy="6858000"/>
+          </a:xfrm>
+          <a:prstGeom prst="rect">
+            <a:avLst/>
+          </a:prstGeom>
+          <a:solidFill>
+            <a:srgbClr val="E2E8F0"/>
+          </a:solidFill>
+          <a:ln>
+            <a:noFill/>
+          </a:ln>
+        </p:spPr>
+        <p:style>
+          <a:lnRef idx="1">
+            <a:schemeClr val="accent1"/>
+          </a:lnRef>
+          <a:fillRef idx="3">
+            <a:schemeClr val="accent1"/>
+          </a:fillRef>
+          <a:effectRef idx="2">
+            <a:schemeClr val="accent1"/>
+          </a:effectRef>
+          <a:fontRef idx="minor">
+            <a:schemeClr val="lt1"/>
+          </a:fontRef>
+        </p:style>
+        <p:txBody>
+          <a:bodyPr rtlCol="0" anchor="ctr"/>
+          <a:lstStyle/>
+          <a:p>
+            <a:pPr algn="ctr"/>
+          </a:p>
+        </p:txBody>
+      </p:sp>
+      <p:sp>
+        <p:nvSpPr>
+          <p:cNvPr id="17" name="Rectangle 16"/>
+          <p:cNvSpPr/>
+          <p:nvPr/>
+        </p:nvSpPr>
+        <p:spPr>
+          <a:xfrm>
+            <a:off x="6858000" y="0"/>
+            <a:ext cx="7315" cy="6858000"/>
+          </a:xfrm>
+          <a:prstGeom prst="rect">
+            <a:avLst/>
+          </a:prstGeom>
+          <a:solidFill>
+            <a:srgbClr val="E2E8F0"/>
+          </a:solidFill>
+          <a:ln>
+            <a:noFill/>
+          </a:ln>
+        </p:spPr>
+        <p:style>
+          <a:lnRef idx="1">
+            <a:schemeClr val="accent1"/>
+          </a:lnRef>
+          <a:fillRef idx="3">
+            <a:schemeClr val="accent1"/>
+          </a:fillRef>
+          <a:effectRef idx="2">
+            <a:schemeClr val="accent1"/>
+          </a:effectRef>
+          <a:fontRef idx="minor">
+            <a:schemeClr val="lt1"/>
+          </a:fontRef>
+        </p:style>
+        <p:txBody>
+          <a:bodyPr rtlCol="0" anchor="ctr"/>
+          <a:lstStyle/>
+          <a:p>
+            <a:pPr algn="ctr"/>
+          </a:p>
+        </p:txBody>
+      </p:sp>
+      <p:sp>
+        <p:nvSpPr>
+          <p:cNvPr id="18" name="Rectangle 17"/>
+          <p:cNvSpPr/>
+          <p:nvPr/>
+        </p:nvSpPr>
+        <p:spPr>
+          <a:xfrm>
+            <a:off x="7315200" y="0"/>
+            <a:ext cx="7315" cy="6858000"/>
+          </a:xfrm>
+          <a:prstGeom prst="rect">
+            <a:avLst/>
+          </a:prstGeom>
+          <a:solidFill>
+            <a:srgbClr val="E2E8F0"/>
+          </a:solidFill>
+          <a:ln>
+            <a:noFill/>
+          </a:ln>
+        </p:spPr>
+        <p:style>
+          <a:lnRef idx="1">
+            <a:schemeClr val="accent1"/>
+          </a:lnRef>
+          <a:fillRef idx="3">
+            <a:schemeClr val="accent1"/>
+          </a:fillRef>
+          <a:effectRef idx="2">
+            <a:schemeClr val="accent1"/>
+          </a:effectRef>
+          <a:fontRef idx="minor">
+            <a:schemeClr val="lt1"/>
+          </a:fontRef>
+        </p:style>
+        <p:txBody>
+          <a:bodyPr rtlCol="0" anchor="ctr"/>
+          <a:lstStyle/>
+          <a:p>
+            <a:pPr algn="ctr"/>
+          </a:p>
+        </p:txBody>
+      </p:sp>
+      <p:sp>
+        <p:nvSpPr>
+          <p:cNvPr id="19" name="Rectangle 18"/>
+          <p:cNvSpPr/>
+          <p:nvPr/>
+        </p:nvSpPr>
+        <p:spPr>
+          <a:xfrm>
+            <a:off x="7772400" y="0"/>
+            <a:ext cx="7315" cy="6858000"/>
+          </a:xfrm>
+          <a:prstGeom prst="rect">
+            <a:avLst/>
+          </a:prstGeom>
+          <a:solidFill>
+            <a:srgbClr val="E2E8F0"/>
+          </a:solidFill>
+          <a:ln>
+            <a:noFill/>
+          </a:ln>
+        </p:spPr>
+        <p:style>
+          <a:lnRef idx="1">
+            <a:schemeClr val="accent1"/>
+          </a:lnRef>
+          <a:fillRef idx="3">
+            <a:schemeClr val="accent1"/>
+          </a:fillRef>
+          <a:effectRef idx="2">
+            <a:schemeClr val="accent1"/>
+          </a:effectRef>
+          <a:fontRef idx="minor">
+            <a:schemeClr val="lt1"/>
+          </a:fontRef>
+        </p:style>
+        <p:txBody>
+          <a:bodyPr rtlCol="0" anchor="ctr"/>
+          <a:lstStyle/>
+          <a:p>
+            <a:pPr algn="ctr"/>
+          </a:p>
+        </p:txBody>
+      </p:sp>
+      <p:sp>
+        <p:nvSpPr>
+          <p:cNvPr id="20" name="Rectangle 19"/>
+          <p:cNvSpPr/>
+          <p:nvPr/>
+        </p:nvSpPr>
+        <p:spPr>
+          <a:xfrm>
+            <a:off x="8229600" y="0"/>
+            <a:ext cx="7315" cy="6858000"/>
+          </a:xfrm>
+          <a:prstGeom prst="rect">
+            <a:avLst/>
+          </a:prstGeom>
+          <a:solidFill>
+            <a:srgbClr val="E2E8F0"/>
+          </a:solidFill>
+          <a:ln>
+            <a:noFill/>
+          </a:ln>
+        </p:spPr>
+        <p:style>
+          <a:lnRef idx="1">
+            <a:schemeClr val="accent1"/>
+          </a:lnRef>
+          <a:fillRef idx="3">
+            <a:schemeClr val="accent1"/>
+          </a:fillRef>
+          <a:effectRef idx="2">
+            <a:schemeClr val="accent1"/>
+          </a:effectRef>
+          <a:fontRef idx="minor">
+            <a:schemeClr val="lt1"/>
+          </a:fontRef>
+        </p:style>
+        <p:txBody>
+          <a:bodyPr rtlCol="0" anchor="ctr"/>
+          <a:lstStyle/>
+          <a:p>
+            <a:pPr algn="ctr"/>
+          </a:p>
+        </p:txBody>
+      </p:sp>
+      <p:sp>
+        <p:nvSpPr>
+          <p:cNvPr id="21" name="Rectangle 20"/>
+          <p:cNvSpPr/>
+          <p:nvPr/>
+        </p:nvSpPr>
+        <p:spPr>
+          <a:xfrm>
+            <a:off x="8686800" y="0"/>
+            <a:ext cx="7315" cy="6858000"/>
+          </a:xfrm>
+          <a:prstGeom prst="rect">
+            <a:avLst/>
+          </a:prstGeom>
+          <a:solidFill>
+            <a:srgbClr val="E2E8F0"/>
+          </a:solidFill>
+          <a:ln>
+            <a:noFill/>
+          </a:ln>
+        </p:spPr>
+        <p:style>
+          <a:lnRef idx="1">
+            <a:schemeClr val="accent1"/>
+          </a:lnRef>
+          <a:fillRef idx="3">
+            <a:schemeClr val="accent1"/>
+          </a:fillRef>
+          <a:effectRef idx="2">
+            <a:schemeClr val="accent1"/>
+          </a:effectRef>
+          <a:fontRef idx="minor">
+            <a:schemeClr val="lt1"/>
+          </a:fontRef>
+        </p:style>
+        <p:txBody>
+          <a:bodyPr rtlCol="0" anchor="ctr"/>
+          <a:lstStyle/>
+          <a:p>
+            <a:pPr algn="ctr"/>
+          </a:p>
+        </p:txBody>
+      </p:sp>
+      <p:sp>
+        <p:nvSpPr>
+          <p:cNvPr id="22" name="Rectangle 21"/>
+          <p:cNvSpPr/>
+          <p:nvPr/>
+        </p:nvSpPr>
+        <p:spPr>
+          <a:xfrm>
+            <a:off x="9144000" y="0"/>
+            <a:ext cx="7315" cy="6858000"/>
+          </a:xfrm>
+          <a:prstGeom prst="rect">
+            <a:avLst/>
+          </a:prstGeom>
+          <a:solidFill>
+            <a:srgbClr val="E2E8F0"/>
+          </a:solidFill>
+          <a:ln>
+            <a:noFill/>
+          </a:ln>
+        </p:spPr>
+        <p:style>
+          <a:lnRef idx="1">
+            <a:schemeClr val="accent1"/>
+          </a:lnRef>
+          <a:fillRef idx="3">
+            <a:schemeClr val="accent1"/>
+          </a:fillRef>
+          <a:effectRef idx="2">
+            <a:schemeClr val="accent1"/>
+          </a:effectRef>
+          <a:fontRef idx="minor">
+            <a:schemeClr val="lt1"/>
+          </a:fontRef>
+        </p:style>
+        <p:txBody>
+          <a:bodyPr rtlCol="0" anchor="ctr"/>
+          <a:lstStyle/>
+          <a:p>
+            <a:pPr algn="ctr"/>
+          </a:p>
+        </p:txBody>
+      </p:sp>
+      <p:sp>
+        <p:nvSpPr>
+          <p:cNvPr id="23" name="Rectangle 22"/>
+          <p:cNvSpPr/>
+          <p:nvPr/>
+        </p:nvSpPr>
+        <p:spPr>
+          <a:xfrm>
+            <a:off x="9601200" y="0"/>
+            <a:ext cx="7315" cy="6858000"/>
+          </a:xfrm>
+          <a:prstGeom prst="rect">
+            <a:avLst/>
+          </a:prstGeom>
+          <a:solidFill>
+            <a:srgbClr val="E2E8F0"/>
+          </a:solidFill>
+          <a:ln>
+            <a:noFill/>
+          </a:ln>
+        </p:spPr>
+        <p:style>
+          <a:lnRef idx="1">
+            <a:schemeClr val="accent1"/>
+          </a:lnRef>
+          <a:fillRef idx="3">
+            <a:schemeClr val="accent1"/>
+          </a:fillRef>
+          <a:effectRef idx="2">
+            <a:schemeClr val="accent1"/>
+          </a:effectRef>
+          <a:fontRef idx="minor">
+            <a:schemeClr val="lt1"/>
+          </a:fontRef>
+        </p:style>
+        <p:txBody>
+          <a:bodyPr rtlCol="0" anchor="ctr"/>
+          <a:lstStyle/>
+          <a:p>
+            <a:pPr algn="ctr"/>
+          </a:p>
+        </p:txBody>
+      </p:sp>
+      <p:sp>
+        <p:nvSpPr>
+          <p:cNvPr id="24" name="Rectangle 23"/>
+          <p:cNvSpPr/>
+          <p:nvPr/>
+        </p:nvSpPr>
+        <p:spPr>
+          <a:xfrm>
+            <a:off x="10058400" y="0"/>
+            <a:ext cx="7315" cy="6858000"/>
+          </a:xfrm>
+          <a:prstGeom prst="rect">
+            <a:avLst/>
+          </a:prstGeom>
+          <a:solidFill>
+            <a:srgbClr val="E2E8F0"/>
+          </a:solidFill>
+          <a:ln>
+            <a:noFill/>
+          </a:ln>
+        </p:spPr>
+        <p:style>
+          <a:lnRef idx="1">
+            <a:schemeClr val="accent1"/>
+          </a:lnRef>
+          <a:fillRef idx="3">
+            <a:schemeClr val="accent1"/>
+          </a:fillRef>
+          <a:effectRef idx="2">
+            <a:schemeClr val="accent1"/>
+          </a:effectRef>
+          <a:fontRef idx="minor">
+            <a:schemeClr val="lt1"/>
+          </a:fontRef>
+        </p:style>
+        <p:txBody>
+          <a:bodyPr rtlCol="0" anchor="ctr"/>
+          <a:lstStyle/>
+          <a:p>
+            <a:pPr algn="ctr"/>
+          </a:p>
+        </p:txBody>
+      </p:sp>
+      <p:sp>
+        <p:nvSpPr>
+          <p:cNvPr id="25" name="Rectangle 24"/>
+          <p:cNvSpPr/>
+          <p:nvPr/>
+        </p:nvSpPr>
+        <p:spPr>
+          <a:xfrm>
+            <a:off x="10515600" y="0"/>
+            <a:ext cx="7315" cy="6858000"/>
+          </a:xfrm>
+          <a:prstGeom prst="rect">
+            <a:avLst/>
+          </a:prstGeom>
+          <a:solidFill>
+            <a:srgbClr val="E2E8F0"/>
+          </a:solidFill>
+          <a:ln>
+            <a:noFill/>
+          </a:ln>
+        </p:spPr>
+        <p:style>
+          <a:lnRef idx="1">
+            <a:schemeClr val="accent1"/>
+          </a:lnRef>
+          <a:fillRef idx="3">
+            <a:schemeClr val="accent1"/>
+          </a:fillRef>
+          <a:effectRef idx="2">
+            <a:schemeClr val="accent1"/>
+          </a:effectRef>
+          <a:fontRef idx="minor">
+            <a:schemeClr val="lt1"/>
+          </a:fontRef>
+        </p:style>
+        <p:txBody>
+          <a:bodyPr rtlCol="0" anchor="ctr"/>
+          <a:lstStyle/>
+          <a:p>
+            <a:pPr algn="ctr"/>
+          </a:p>
+        </p:txBody>
+      </p:sp>
+      <p:sp>
+        <p:nvSpPr>
+          <p:cNvPr id="26" name="Rectangle 25"/>
+          <p:cNvSpPr/>
+          <p:nvPr/>
+        </p:nvSpPr>
+        <p:spPr>
+          <a:xfrm>
+            <a:off x="10972800" y="0"/>
+            <a:ext cx="7315" cy="6858000"/>
+          </a:xfrm>
+          <a:prstGeom prst="rect">
+            <a:avLst/>
+          </a:prstGeom>
+          <a:solidFill>
+            <a:srgbClr val="E2E8F0"/>
+          </a:solidFill>
+          <a:ln>
+            <a:noFill/>
+          </a:ln>
+        </p:spPr>
+        <p:style>
+          <a:lnRef idx="1">
+            <a:schemeClr val="accent1"/>
+          </a:lnRef>
+          <a:fillRef idx="3">
+            <a:schemeClr val="accent1"/>
+          </a:fillRef>
+          <a:effectRef idx="2">
+            <a:schemeClr val="accent1"/>
+          </a:effectRef>
+          <a:fontRef idx="minor">
+            <a:schemeClr val="lt1"/>
+          </a:fontRef>
+        </p:style>
+        <p:txBody>
+          <a:bodyPr rtlCol="0" anchor="ctr"/>
+          <a:lstStyle/>
+          <a:p>
+            <a:pPr algn="ctr"/>
+          </a:p>
+        </p:txBody>
+      </p:sp>
+      <p:sp>
+        <p:nvSpPr>
+          <p:cNvPr id="27" name="Rectangle 26"/>
+          <p:cNvSpPr/>
+          <p:nvPr/>
+        </p:nvSpPr>
+        <p:spPr>
+          <a:xfrm>
+            <a:off x="11430000" y="0"/>
+            <a:ext cx="7315" cy="6858000"/>
+          </a:xfrm>
+          <a:prstGeom prst="rect">
+            <a:avLst/>
+          </a:prstGeom>
+          <a:solidFill>
+            <a:srgbClr val="E2E8F0"/>
+          </a:solidFill>
+          <a:ln>
+            <a:noFill/>
+          </a:ln>
+        </p:spPr>
+        <p:style>
+          <a:lnRef idx="1">
+            <a:schemeClr val="accent1"/>
+          </a:lnRef>
+          <a:fillRef idx="3">
+            <a:schemeClr val="accent1"/>
+          </a:fillRef>
+          <a:effectRef idx="2">
+            <a:schemeClr val="accent1"/>
+          </a:effectRef>
+          <a:fontRef idx="minor">
+            <a:schemeClr val="lt1"/>
+          </a:fontRef>
+        </p:style>
+        <p:txBody>
+          <a:bodyPr rtlCol="0" anchor="ctr"/>
+          <a:lstStyle/>
+          <a:p>
+            <a:pPr algn="ctr"/>
+          </a:p>
+        </p:txBody>
+      </p:sp>
+      <p:sp>
+        <p:nvSpPr>
+          <p:cNvPr id="28" name="Rectangle 27"/>
+          <p:cNvSpPr/>
+          <p:nvPr/>
+        </p:nvSpPr>
+        <p:spPr>
+          <a:xfrm>
+            <a:off x="0" y="457200"/>
+            <a:ext cx="12191695" cy="7315"/>
+          </a:xfrm>
+          <a:prstGeom prst="rect">
+            <a:avLst/>
+          </a:prstGeom>
+          <a:solidFill>
+            <a:srgbClr val="E2E8F0"/>
+          </a:solidFill>
+          <a:ln>
+            <a:noFill/>
+          </a:ln>
+        </p:spPr>
+        <p:style>
+          <a:lnRef idx="1">
+            <a:schemeClr val="accent1"/>
+          </a:lnRef>
+          <a:fillRef idx="3">
+            <a:schemeClr val="accent1"/>
+          </a:fillRef>
+          <a:effectRef idx="2">
+            <a:schemeClr val="accent1"/>
+          </a:effectRef>
+          <a:fontRef idx="minor">
+            <a:schemeClr val="lt1"/>
+          </a:fontRef>
+        </p:style>
+        <p:txBody>
+          <a:bodyPr rtlCol="0" anchor="ctr"/>
+          <a:lstStyle/>
+          <a:p>
+            <a:pPr algn="ctr"/>
+          </a:p>
+        </p:txBody>
+      </p:sp>
+      <p:sp>
+        <p:nvSpPr>
+          <p:cNvPr id="29" name="Rectangle 28"/>
+          <p:cNvSpPr/>
+          <p:nvPr/>
+        </p:nvSpPr>
+        <p:spPr>
+          <a:xfrm>
+            <a:off x="0" y="914400"/>
+            <a:ext cx="12191695" cy="7315"/>
+          </a:xfrm>
+          <a:prstGeom prst="rect">
+            <a:avLst/>
+          </a:prstGeom>
+          <a:solidFill>
+            <a:srgbClr val="E2E8F0"/>
+          </a:solidFill>
+          <a:ln>
+            <a:noFill/>
+          </a:ln>
+        </p:spPr>
+        <p:style>
+          <a:lnRef idx="1">
+            <a:schemeClr val="accent1"/>
+          </a:lnRef>
+          <a:fillRef idx="3">
+            <a:schemeClr val="accent1"/>
+          </a:fillRef>
+          <a:effectRef idx="2">
+            <a:schemeClr val="accent1"/>
+          </a:effectRef>
+          <a:fontRef idx="minor">
+            <a:schemeClr val="lt1"/>
+          </a:fontRef>
+        </p:style>
+        <p:txBody>
+          <a:bodyPr rtlCol="0" anchor="ctr"/>
+          <a:lstStyle/>
+          <a:p>
+            <a:pPr algn="ctr"/>
+          </a:p>
+        </p:txBody>
+      </p:sp>
+      <p:sp>
+        <p:nvSpPr>
+          <p:cNvPr id="30" name="Rectangle 29"/>
+          <p:cNvSpPr/>
+          <p:nvPr/>
+        </p:nvSpPr>
+        <p:spPr>
+          <a:xfrm>
+            <a:off x="0" y="1371600"/>
+            <a:ext cx="12191695" cy="7315"/>
+          </a:xfrm>
+          <a:prstGeom prst="rect">
+            <a:avLst/>
+          </a:prstGeom>
+          <a:solidFill>
+            <a:srgbClr val="E2E8F0"/>
+          </a:solidFill>
+          <a:ln>
+            <a:noFill/>
+          </a:ln>
+        </p:spPr>
+        <p:style>
+          <a:lnRef idx="1">
+            <a:schemeClr val="accent1"/>
+          </a:lnRef>
+          <a:fillRef idx="3">
+            <a:schemeClr val="accent1"/>
+          </a:fillRef>
+          <a:effectRef idx="2">
+            <a:schemeClr val="accent1"/>
+          </a:effectRef>
+          <a:fontRef idx="minor">
+            <a:schemeClr val="lt1"/>
+          </a:fontRef>
+        </p:style>
+        <p:txBody>
+          <a:bodyPr rtlCol="0" anchor="ctr"/>
+          <a:lstStyle/>
+          <a:p>
+            <a:pPr algn="ctr"/>
+          </a:p>
+        </p:txBody>
+      </p:sp>
+      <p:sp>
+        <p:nvSpPr>
+          <p:cNvPr id="31" name="Rectangle 30"/>
+          <p:cNvSpPr/>
+          <p:nvPr/>
+        </p:nvSpPr>
+        <p:spPr>
+          <a:xfrm>
+            <a:off x="0" y="1828800"/>
+            <a:ext cx="12191695" cy="7315"/>
+          </a:xfrm>
+          <a:prstGeom prst="rect">
+            <a:avLst/>
+          </a:prstGeom>
+          <a:solidFill>
+            <a:srgbClr val="E2E8F0"/>
+          </a:solidFill>
+          <a:ln>
+            <a:noFill/>
+          </a:ln>
+        </p:spPr>
+        <p:style>
+          <a:lnRef idx="1">
+            <a:schemeClr val="accent1"/>
+          </a:lnRef>
+          <a:fillRef idx="3">
+            <a:schemeClr val="accent1"/>
+          </a:fillRef>
+          <a:effectRef idx="2">
+            <a:schemeClr val="accent1"/>
+          </a:effectRef>
+          <a:fontRef idx="minor">
+            <a:schemeClr val="lt1"/>
+          </a:fontRef>
+        </p:style>
+        <p:txBody>
+          <a:bodyPr rtlCol="0" anchor="ctr"/>
+          <a:lstStyle/>
+          <a:p>
+            <a:pPr algn="ctr"/>
+          </a:p>
+        </p:txBody>
+      </p:sp>
+      <p:sp>
+        <p:nvSpPr>
+          <p:cNvPr id="32" name="Rectangle 31"/>
+          <p:cNvSpPr/>
+          <p:nvPr/>
+        </p:nvSpPr>
+        <p:spPr>
+          <a:xfrm>
+            <a:off x="0" y="2286000"/>
+            <a:ext cx="12191695" cy="7315"/>
+          </a:xfrm>
+          <a:prstGeom prst="rect">
+            <a:avLst/>
+          </a:prstGeom>
+          <a:solidFill>
+            <a:srgbClr val="E2E8F0"/>
+          </a:solidFill>
+          <a:ln>
+            <a:noFill/>
+          </a:ln>
+        </p:spPr>
+        <p:style>
+          <a:lnRef idx="1">
+            <a:schemeClr val="accent1"/>
+          </a:lnRef>
+          <a:fillRef idx="3">
+            <a:schemeClr val="accent1"/>
+          </a:fillRef>
+          <a:effectRef idx="2">
+            <a:schemeClr val="accent1"/>
+          </a:effectRef>
+          <a:fontRef idx="minor">
+            <a:schemeClr val="lt1"/>
+          </a:fontRef>
+        </p:style>
+        <p:txBody>
+          <a:bodyPr rtlCol="0" anchor="ctr"/>
+          <a:lstStyle/>
+          <a:p>
+            <a:pPr algn="ctr"/>
+          </a:p>
+        </p:txBody>
+      </p:sp>
+      <p:sp>
+        <p:nvSpPr>
+          <p:cNvPr id="33" name="Rectangle 32"/>
+          <p:cNvSpPr/>
+          <p:nvPr/>
+        </p:nvSpPr>
+        <p:spPr>
+          <a:xfrm>
+            <a:off x="0" y="2743200"/>
+            <a:ext cx="12191695" cy="7315"/>
+          </a:xfrm>
+          <a:prstGeom prst="rect">
+            <a:avLst/>
+          </a:prstGeom>
+          <a:solidFill>
+            <a:srgbClr val="E2E8F0"/>
+          </a:solidFill>
+          <a:ln>
+            <a:noFill/>
+          </a:ln>
+        </p:spPr>
+        <p:style>
+          <a:lnRef idx="1">
+            <a:schemeClr val="accent1"/>
+          </a:lnRef>
+          <a:fillRef idx="3">
+            <a:schemeClr val="accent1"/>
+          </a:fillRef>
+          <a:effectRef idx="2">
+            <a:schemeClr val="accent1"/>
+          </a:effectRef>
+          <a:fontRef idx="minor">
+            <a:schemeClr val="lt1"/>
+          </a:fontRef>
+        </p:style>
+        <p:txBody>
+          <a:bodyPr rtlCol="0" anchor="ctr"/>
+          <a:lstStyle/>
+          <a:p>
+            <a:pPr algn="ctr"/>
+          </a:p>
+        </p:txBody>
+      </p:sp>
+      <p:sp>
+        <p:nvSpPr>
+          <p:cNvPr id="34" name="Rectangle 33"/>
+          <p:cNvSpPr/>
+          <p:nvPr/>
+        </p:nvSpPr>
+        <p:spPr>
+          <a:xfrm>
+            <a:off x="0" y="3200400"/>
+            <a:ext cx="12191695" cy="7315"/>
+          </a:xfrm>
+          <a:prstGeom prst="rect">
+            <a:avLst/>
+          </a:prstGeom>
+          <a:solidFill>
+            <a:srgbClr val="E2E8F0"/>
+          </a:solidFill>
+          <a:ln>
+            <a:noFill/>
+          </a:ln>
+        </p:spPr>
+        <p:style>
+          <a:lnRef idx="1">
+            <a:schemeClr val="accent1"/>
+          </a:lnRef>
+          <a:fillRef idx="3">
+            <a:schemeClr val="accent1"/>
+          </a:fillRef>
+          <a:effectRef idx="2">
+            <a:schemeClr val="accent1"/>
+          </a:effectRef>
+          <a:fontRef idx="minor">
+            <a:schemeClr val="lt1"/>
+          </a:fontRef>
+        </p:style>
+        <p:txBody>
+          <a:bodyPr rtlCol="0" anchor="ctr"/>
+          <a:lstStyle/>
+          <a:p>
+            <a:pPr algn="ctr"/>
+          </a:p>
+        </p:txBody>
+      </p:sp>
+      <p:sp>
+        <p:nvSpPr>
+          <p:cNvPr id="35" name="Rectangle 34"/>
+          <p:cNvSpPr/>
+          <p:nvPr/>
+        </p:nvSpPr>
+        <p:spPr>
+          <a:xfrm>
+            <a:off x="0" y="3657600"/>
+            <a:ext cx="12191695" cy="7315"/>
+          </a:xfrm>
+          <a:prstGeom prst="rect">
+            <a:avLst/>
+          </a:prstGeom>
+          <a:solidFill>
+            <a:srgbClr val="E2E8F0"/>
+          </a:solidFill>
+          <a:ln>
+            <a:noFill/>
+          </a:ln>
+        </p:spPr>
+        <p:style>
+          <a:lnRef idx="1">
+            <a:schemeClr val="accent1"/>
+          </a:lnRef>
+          <a:fillRef idx="3">
+            <a:schemeClr val="accent1"/>
+          </a:fillRef>
+          <a:effectRef idx="2">
+            <a:schemeClr val="accent1"/>
+          </a:effectRef>
+          <a:fontRef idx="minor">
+            <a:schemeClr val="lt1"/>
+          </a:fontRef>
+        </p:style>
+        <p:txBody>
+          <a:bodyPr rtlCol="0" anchor="ctr"/>
+          <a:lstStyle/>
+          <a:p>
+            <a:pPr algn="ctr"/>
+          </a:p>
+        </p:txBody>
+      </p:sp>
+      <p:sp>
+        <p:nvSpPr>
+          <p:cNvPr id="36" name="Rectangle 35"/>
+          <p:cNvSpPr/>
+          <p:nvPr/>
+        </p:nvSpPr>
+        <p:spPr>
+          <a:xfrm>
+            <a:off x="0" y="4114800"/>
+            <a:ext cx="12191695" cy="7315"/>
+          </a:xfrm>
+          <a:prstGeom prst="rect">
+            <a:avLst/>
+          </a:prstGeom>
+          <a:solidFill>
+            <a:srgbClr val="E2E8F0"/>
+          </a:solidFill>
+          <a:ln>
+            <a:noFill/>
+          </a:ln>
+        </p:spPr>
+        <p:style>
+          <a:lnRef idx="1">
+            <a:schemeClr val="accent1"/>
+          </a:lnRef>
+          <a:fillRef idx="3">
+            <a:schemeClr val="accent1"/>
+          </a:fillRef>
+          <a:effectRef idx="2">
+            <a:schemeClr val="accent1"/>
+          </a:effectRef>
+          <a:fontRef idx="minor">
+            <a:schemeClr val="lt1"/>
+          </a:fontRef>
+        </p:style>
+        <p:txBody>
+          <a:bodyPr rtlCol="0" anchor="ctr"/>
+          <a:lstStyle/>
+          <a:p>
+            <a:pPr algn="ctr"/>
+          </a:p>
+        </p:txBody>
+      </p:sp>
+      <p:sp>
+        <p:nvSpPr>
+          <p:cNvPr id="37" name="Rectangle 36"/>
+          <p:cNvSpPr/>
+          <p:nvPr/>
+        </p:nvSpPr>
+        <p:spPr>
+          <a:xfrm>
+            <a:off x="0" y="4572000"/>
+            <a:ext cx="12191695" cy="7315"/>
+          </a:xfrm>
+          <a:prstGeom prst="rect">
+            <a:avLst/>
+          </a:prstGeom>
+          <a:solidFill>
+            <a:srgbClr val="E2E8F0"/>
+          </a:solidFill>
+          <a:ln>
+            <a:noFill/>
+          </a:ln>
+        </p:spPr>
+        <p:style>
+          <a:lnRef idx="1">
+            <a:schemeClr val="accent1"/>
+          </a:lnRef>
+          <a:fillRef idx="3">
+            <a:schemeClr val="accent1"/>
+          </a:fillRef>
+          <a:effectRef idx="2">
+            <a:schemeClr val="accent1"/>
+          </a:effectRef>
+          <a:fontRef idx="minor">
+            <a:schemeClr val="lt1"/>
+          </a:fontRef>
+        </p:style>
+        <p:txBody>
+          <a:bodyPr rtlCol="0" anchor="ctr"/>
+          <a:lstStyle/>
+          <a:p>
+            <a:pPr algn="ctr"/>
+          </a:p>
+        </p:txBody>
+      </p:sp>
+      <p:sp>
+        <p:nvSpPr>
+          <p:cNvPr id="38" name="Rectangle 37"/>
+          <p:cNvSpPr/>
+          <p:nvPr/>
+        </p:nvSpPr>
+        <p:spPr>
+          <a:xfrm>
+            <a:off x="0" y="5029200"/>
+            <a:ext cx="12191695" cy="7315"/>
+          </a:xfrm>
+          <a:prstGeom prst="rect">
+            <a:avLst/>
+          </a:prstGeom>
+          <a:solidFill>
+            <a:srgbClr val="E2E8F0"/>
+          </a:solidFill>
+          <a:ln>
+            <a:noFill/>
+          </a:ln>
+        </p:spPr>
+        <p:style>
+          <a:lnRef idx="1">
+            <a:schemeClr val="accent1"/>
+          </a:lnRef>
+          <a:fillRef idx="3">
+            <a:schemeClr val="accent1"/>
+          </a:fillRef>
+          <a:effectRef idx="2">
+            <a:schemeClr val="accent1"/>
+          </a:effectRef>
+          <a:fontRef idx="minor">
+            <a:schemeClr val="lt1"/>
+          </a:fontRef>
+        </p:style>
+        <p:txBody>
+          <a:bodyPr rtlCol="0" anchor="ctr"/>
+          <a:lstStyle/>
+          <a:p>
+            <a:pPr algn="ctr"/>
+          </a:p>
+        </p:txBody>
+      </p:sp>
+      <p:sp>
+        <p:nvSpPr>
+          <p:cNvPr id="39" name="Rectangle 38"/>
+          <p:cNvSpPr/>
+          <p:nvPr/>
+        </p:nvSpPr>
+        <p:spPr>
+          <a:xfrm>
+            <a:off x="0" y="5486400"/>
+            <a:ext cx="12191695" cy="7315"/>
+          </a:xfrm>
+          <a:prstGeom prst="rect">
+            <a:avLst/>
+          </a:prstGeom>
+          <a:solidFill>
+            <a:srgbClr val="E2E8F0"/>
+          </a:solidFill>
+          <a:ln>
+            <a:noFill/>
+          </a:ln>
+        </p:spPr>
+        <p:style>
+          <a:lnRef idx="1">
+            <a:schemeClr val="accent1"/>
+          </a:lnRef>
+          <a:fillRef idx="3">
+            <a:schemeClr val="accent1"/>
+          </a:fillRef>
+          <a:effectRef idx="2">
+            <a:schemeClr val="accent1"/>
+          </a:effectRef>
+          <a:fontRef idx="minor">
+            <a:schemeClr val="lt1"/>
+          </a:fontRef>
+        </p:style>
+        <p:txBody>
+          <a:bodyPr rtlCol="0" anchor="ctr"/>
+          <a:lstStyle/>
+          <a:p>
+            <a:pPr algn="ctr"/>
+          </a:p>
+        </p:txBody>
+      </p:sp>
+      <p:sp>
+        <p:nvSpPr>
+          <p:cNvPr id="40" name="Rectangle 39"/>
+          <p:cNvSpPr/>
+          <p:nvPr/>
+        </p:nvSpPr>
+        <p:spPr>
+          <a:xfrm>
+            <a:off x="0" y="5943600"/>
+            <a:ext cx="12191695" cy="7315"/>
+          </a:xfrm>
+          <a:prstGeom prst="rect">
+            <a:avLst/>
+          </a:prstGeom>
+          <a:solidFill>
+            <a:srgbClr val="E2E8F0"/>
+          </a:solidFill>
+          <a:ln>
+            <a:noFill/>
+          </a:ln>
+        </p:spPr>
+        <p:style>
+          <a:lnRef idx="1">
+            <a:schemeClr val="accent1"/>
+          </a:lnRef>
+          <a:fillRef idx="3">
+            <a:schemeClr val="accent1"/>
+          </a:fillRef>
+          <a:effectRef idx="2">
+            <a:schemeClr val="accent1"/>
+          </a:effectRef>
+          <a:fontRef idx="minor">
+            <a:schemeClr val="lt1"/>
+          </a:fontRef>
+        </p:style>
+        <p:txBody>
+          <a:bodyPr rtlCol="0" anchor="ctr"/>
+          <a:lstStyle/>
+          <a:p>
+            <a:pPr algn="ctr"/>
+          </a:p>
+        </p:txBody>
+      </p:sp>
+      <p:sp>
+        <p:nvSpPr>
+          <p:cNvPr id="41" name="Rectangle 40"/>
+          <p:cNvSpPr/>
+          <p:nvPr/>
+        </p:nvSpPr>
+        <p:spPr>
+          <a:xfrm>
+            <a:off x="0" y="6400800"/>
+            <a:ext cx="12191695" cy="7315"/>
+          </a:xfrm>
+          <a:prstGeom prst="rect">
+            <a:avLst/>
+          </a:prstGeom>
+          <a:solidFill>
+            <a:srgbClr val="E2E8F0"/>
+          </a:solidFill>
+          <a:ln>
+            <a:noFill/>
+          </a:ln>
+        </p:spPr>
+        <p:style>
+          <a:lnRef idx="1">
+            <a:schemeClr val="accent1"/>
+          </a:lnRef>
+          <a:fillRef idx="3">
+            <a:schemeClr val="accent1"/>
+          </a:fillRef>
+          <a:effectRef idx="2">
+            <a:schemeClr val="accent1"/>
+          </a:effectRef>
+          <a:fontRef idx="minor">
+            <a:schemeClr val="lt1"/>
+          </a:fontRef>
+        </p:style>
+        <p:txBody>
+          <a:bodyPr rtlCol="0" anchor="ctr"/>
+          <a:lstStyle/>
+          <a:p>
+            <a:pPr algn="ctr"/>
+          </a:p>
+        </p:txBody>
+      </p:sp>
+      <p:sp>
+        <p:nvSpPr>
+          <p:cNvPr id="42" name="Rounded Rectangle 41"/>
+          <p:cNvSpPr/>
+          <p:nvPr/>
+        </p:nvSpPr>
+        <p:spPr>
+          <a:xfrm>
+            <a:off x="731520" y="640080"/>
+            <a:ext cx="73152" cy="274320"/>
+          </a:xfrm>
+          <a:prstGeom prst="roundRect">
+            <a:avLst/>
+          </a:prstGeom>
+          <a:solidFill>
+            <a:srgbClr val="0A1628"/>
+          </a:solidFill>
+          <a:ln>
+            <a:noFill/>
+          </a:ln>
+        </p:spPr>
+        <p:style>
+          <a:lnRef idx="1">
+            <a:schemeClr val="accent1"/>
+          </a:lnRef>
+          <a:fillRef idx="3">
+            <a:schemeClr val="accent1"/>
+          </a:fillRef>
+          <a:effectRef idx="2">
+            <a:schemeClr val="accent1"/>
+          </a:effectRef>
+          <a:fontRef idx="minor">
+            <a:schemeClr val="lt1"/>
+          </a:fontRef>
+        </p:style>
+        <p:txBody>
+          <a:bodyPr rtlCol="0" anchor="ctr"/>
+          <a:lstStyle/>
+          <a:p>
+            <a:pPr algn="ctr"/>
+          </a:p>
+        </p:txBody>
+      </p:sp>
+      <p:sp>
+        <p:nvSpPr>
+          <p:cNvPr id="43" name="TextBox 42"/>
+          <p:cNvSpPr txBox="1"/>
+          <p:nvPr/>
+        </p:nvSpPr>
+        <p:spPr>
+          <a:xfrm>
+            <a:off x="914400" y="658368"/>
+            <a:ext cx="3657600" cy="274320"/>
+          </a:xfrm>
+          <a:prstGeom prst="rect">
+            <a:avLst/>
+          </a:prstGeom>
+          <a:noFill/>
+        </p:spPr>
+        <p:txBody>
+          <a:bodyPr wrap="square" lIns="0" tIns="0" rIns="0" bIns="0">
+            <a:spAutoFit/>
+          </a:bodyPr>
+          <a:lstStyle/>
+          <a:p>
+            <a:pPr algn="l"/>
+            <a:r>
+              <a:rPr sz="1000" b="1" i="0">
+                <a:solidFill>
+                  <a:srgbClr val="0A1628"/>
+                </a:solidFill>
+                <a:latin typeface="JetBrains Mono"/>
+              </a:rPr>
+              <a:t>THE PROBLEM</a:t>
+            </a:r>
+          </a:p>
+        </p:txBody>
+      </p:sp>
+      <p:sp>
+        <p:nvSpPr>
+          <p:cNvPr id="44" name="TextBox 43"/>
+          <p:cNvSpPr txBox="1"/>
+          <p:nvPr/>
+        </p:nvSpPr>
+        <p:spPr>
+          <a:xfrm>
+            <a:off x="731520" y="1463040"/>
+            <a:ext cx="10515600" cy="1280160"/>
+          </a:xfrm>
+          <a:prstGeom prst="rect">
+            <a:avLst/>
+          </a:prstGeom>
+          <a:noFill/>
+        </p:spPr>
+        <p:txBody>
+          <a:bodyPr wrap="square" lIns="0" tIns="0" rIns="0" bIns="0">
+            <a:spAutoFit/>
+          </a:bodyPr>
+          <a:lstStyle/>
+          <a:p>
+            <a:pPr algn="l"/>
+            <a:r>
+              <a:rPr sz="3800" b="1" i="0">
+                <a:solidFill>
+                  <a:srgbClr val="000000"/>
+                </a:solidFill>
+                <a:latin typeface="Plus Jakarta Sans"/>
+              </a:rPr>
+              <a:t>GPS Denial and RF Blackouts Paralyze Disaster Reconnaissance</a:t>
+            </a:r>
+          </a:p>
+        </p:txBody>
+      </p:sp>
+      <p:sp>
+        <p:nvSpPr>
+          <p:cNvPr id="45" name="Oval 44"/>
+          <p:cNvSpPr/>
+          <p:nvPr/>
+        </p:nvSpPr>
+        <p:spPr>
+          <a:xfrm>
+            <a:off x="749808" y="3081528"/>
+            <a:ext cx="109728" cy="109728"/>
+          </a:xfrm>
+          <a:prstGeom prst="ellipse">
+            <a:avLst/>
+          </a:prstGeom>
+          <a:solidFill>
+            <a:srgbClr val="0A1628"/>
+          </a:solidFill>
+          <a:ln>
+            <a:noFill/>
+          </a:ln>
+        </p:spPr>
+        <p:style>
+          <a:lnRef idx="1">
+            <a:schemeClr val="accent1"/>
+          </a:lnRef>
+          <a:fillRef idx="3">
+            <a:schemeClr val="accent1"/>
+          </a:fillRef>
+          <a:effectRef idx="2">
+            <a:schemeClr val="accent1"/>
+          </a:effectRef>
+          <a:fontRef idx="minor">
+            <a:schemeClr val="lt1"/>
+          </a:fontRef>
+        </p:style>
+        <p:txBody>
+          <a:bodyPr rtlCol="0" anchor="ctr"/>
+          <a:lstStyle/>
+          <a:p>
+            <a:pPr algn="ctr"/>
+          </a:p>
+        </p:txBody>
+      </p:sp>
+      <p:sp>
+        <p:nvSpPr>
+          <p:cNvPr id="46" name="TextBox 45"/>
+          <p:cNvSpPr txBox="1"/>
+          <p:nvPr/>
+        </p:nvSpPr>
+        <p:spPr>
+          <a:xfrm>
+            <a:off x="1005840" y="3017520"/>
+            <a:ext cx="9601200" cy="411480"/>
+          </a:xfrm>
+          <a:prstGeom prst="rect">
+            <a:avLst/>
+          </a:prstGeom>
+          <a:noFill/>
+        </p:spPr>
+        <p:txBody>
+          <a:bodyPr wrap="square" lIns="0" tIns="0" rIns="0" bIns="0">
+            <a:spAutoFit/>
+          </a:bodyPr>
+          <a:lstStyle/>
+          <a:p>
+            <a:pPr algn="l"/>
+            <a:r>
+              <a:rPr sz="2000" b="0" i="0">
+                <a:solidFill>
+                  <a:srgbClr val="374151"/>
+                </a:solidFill>
+                <a:latin typeface="Inter"/>
+              </a:rPr>
+              <a:t>Mountain valleys cause sudden video blackouts</a:t>
+            </a:r>
+          </a:p>
+        </p:txBody>
+      </p:sp>
+      <p:sp>
+        <p:nvSpPr>
+          <p:cNvPr id="47" name="Oval 46"/>
+          <p:cNvSpPr/>
+          <p:nvPr/>
+        </p:nvSpPr>
+        <p:spPr>
+          <a:xfrm>
+            <a:off x="749808" y="3584448"/>
+            <a:ext cx="109728" cy="109728"/>
+          </a:xfrm>
+          <a:prstGeom prst="ellipse">
+            <a:avLst/>
+          </a:prstGeom>
+          <a:solidFill>
+            <a:srgbClr val="0A1628"/>
+          </a:solidFill>
+          <a:ln>
+            <a:noFill/>
+          </a:ln>
+        </p:spPr>
+        <p:style>
+          <a:lnRef idx="1">
+            <a:schemeClr val="accent1"/>
+          </a:lnRef>
+          <a:fillRef idx="3">
+            <a:schemeClr val="accent1"/>
+          </a:fillRef>
+          <a:effectRef idx="2">
+            <a:schemeClr val="accent1"/>
+          </a:effectRef>
+          <a:fontRef idx="minor">
+            <a:schemeClr val="lt1"/>
+          </a:fontRef>
+        </p:style>
+        <p:txBody>
+          <a:bodyPr rtlCol="0" anchor="ctr"/>
+          <a:lstStyle/>
+          <a:p>
+            <a:pPr algn="ctr"/>
+          </a:p>
+        </p:txBody>
+      </p:sp>
+      <p:sp>
+        <p:nvSpPr>
+          <p:cNvPr id="48" name="TextBox 47"/>
+          <p:cNvSpPr txBox="1"/>
+          <p:nvPr/>
+        </p:nvSpPr>
+        <p:spPr>
+          <a:xfrm>
+            <a:off x="1005840" y="3520440"/>
+            <a:ext cx="9601200" cy="411480"/>
+          </a:xfrm>
+          <a:prstGeom prst="rect">
+            <a:avLst/>
+          </a:prstGeom>
+          <a:noFill/>
+        </p:spPr>
+        <p:txBody>
+          <a:bodyPr wrap="square" lIns="0" tIns="0" rIns="0" bIns="0">
+            <a:spAutoFit/>
+          </a:bodyPr>
+          <a:lstStyle/>
+          <a:p>
+            <a:pPr algn="l"/>
+            <a:r>
+              <a:rPr sz="2000" b="0" i="0">
+                <a:solidFill>
+                  <a:srgbClr val="374151"/>
+                </a:solidFill>
+                <a:latin typeface="Inter"/>
+              </a:rPr>
+              <a:t>Dense canopies block satellite GPS signals</a:t>
+            </a:r>
+          </a:p>
+        </p:txBody>
+      </p:sp>
+      <p:sp>
+        <p:nvSpPr>
+          <p:cNvPr id="49" name="Oval 48"/>
+          <p:cNvSpPr/>
+          <p:nvPr/>
+        </p:nvSpPr>
+        <p:spPr>
+          <a:xfrm>
+            <a:off x="749808" y="4087368"/>
+            <a:ext cx="109728" cy="109728"/>
+          </a:xfrm>
+          <a:prstGeom prst="ellipse">
+            <a:avLst/>
+          </a:prstGeom>
+          <a:solidFill>
+            <a:srgbClr val="0A1628"/>
+          </a:solidFill>
+          <a:ln>
+            <a:noFill/>
+          </a:ln>
+        </p:spPr>
+        <p:style>
+          <a:lnRef idx="1">
+            <a:schemeClr val="accent1"/>
+          </a:lnRef>
+          <a:fillRef idx="3">
+            <a:schemeClr val="accent1"/>
+          </a:fillRef>
+          <a:effectRef idx="2">
+            <a:schemeClr val="accent1"/>
+          </a:effectRef>
+          <a:fontRef idx="minor">
+            <a:schemeClr val="lt1"/>
+          </a:fontRef>
+        </p:style>
+        <p:txBody>
+          <a:bodyPr rtlCol="0" anchor="ctr"/>
+          <a:lstStyle/>
+          <a:p>
+            <a:pPr algn="ctr"/>
+          </a:p>
+        </p:txBody>
+      </p:sp>
+      <p:sp>
+        <p:nvSpPr>
+          <p:cNvPr id="50" name="TextBox 49"/>
+          <p:cNvSpPr txBox="1"/>
+          <p:nvPr/>
+        </p:nvSpPr>
+        <p:spPr>
+          <a:xfrm>
+            <a:off x="1005840" y="4023360"/>
+            <a:ext cx="9601200" cy="411480"/>
+          </a:xfrm>
+          <a:prstGeom prst="rect">
+            <a:avLst/>
+          </a:prstGeom>
+          <a:noFill/>
+        </p:spPr>
+        <p:txBody>
+          <a:bodyPr wrap="square" lIns="0" tIns="0" rIns="0" bIns="0">
+            <a:spAutoFit/>
+          </a:bodyPr>
+          <a:lstStyle/>
+          <a:p>
+            <a:pPr algn="l"/>
+            <a:r>
+              <a:rPr sz="2000" b="0" i="0">
+                <a:solidFill>
+                  <a:srgbClr val="374151"/>
+                </a:solidFill>
+                <a:latin typeface="Inter"/>
+              </a:rPr>
+              <a:t>Centralized telemetry risks single-point failure</a:t>
+            </a:r>
+          </a:p>
+        </p:txBody>
+      </p:sp>
+      <p:sp>
+        <p:nvSpPr>
+          <p:cNvPr id="51" name="Oval 50"/>
+          <p:cNvSpPr/>
+          <p:nvPr/>
+        </p:nvSpPr>
+        <p:spPr>
+          <a:xfrm>
+            <a:off x="749808" y="4590288"/>
+            <a:ext cx="109728" cy="109728"/>
+          </a:xfrm>
+          <a:prstGeom prst="ellipse">
+            <a:avLst/>
+          </a:prstGeom>
+          <a:solidFill>
+            <a:srgbClr val="0A1628"/>
+          </a:solidFill>
+          <a:ln>
+            <a:noFill/>
+          </a:ln>
+        </p:spPr>
+        <p:style>
+          <a:lnRef idx="1">
+            <a:schemeClr val="accent1"/>
+          </a:lnRef>
+          <a:fillRef idx="3">
+            <a:schemeClr val="accent1"/>
+          </a:fillRef>
+          <a:effectRef idx="2">
+            <a:schemeClr val="accent1"/>
+          </a:effectRef>
+          <a:fontRef idx="minor">
+            <a:schemeClr val="lt1"/>
+          </a:fontRef>
+        </p:style>
+        <p:txBody>
+          <a:bodyPr rtlCol="0" anchor="ctr"/>
+          <a:lstStyle/>
+          <a:p>
+            <a:pPr algn="ctr"/>
+          </a:p>
+        </p:txBody>
+      </p:sp>
+      <p:sp>
+        <p:nvSpPr>
+          <p:cNvPr id="52" name="TextBox 51"/>
+          <p:cNvSpPr txBox="1"/>
+          <p:nvPr/>
+        </p:nvSpPr>
+        <p:spPr>
+          <a:xfrm>
+            <a:off x="1005840" y="4526280"/>
+            <a:ext cx="9601200" cy="411480"/>
+          </a:xfrm>
+          <a:prstGeom prst="rect">
+            <a:avLst/>
+          </a:prstGeom>
+          <a:noFill/>
+        </p:spPr>
+        <p:txBody>
+          <a:bodyPr wrap="square" lIns="0" tIns="0" rIns="0" bIns="0">
+            <a:spAutoFit/>
+          </a:bodyPr>
+          <a:lstStyle/>
+          <a:p>
+            <a:pPr algn="l"/>
+            <a:r>
+              <a:rPr sz="2000" b="0" i="0">
+                <a:solidFill>
+                  <a:srgbClr val="374151"/>
+                </a:solidFill>
+                <a:latin typeface="Inter"/>
+              </a:rPr>
+              <a:t>Manual scanning delays survivor emergency rescue</a:t>
+            </a:r>
+          </a:p>
+        </p:txBody>
+      </p:sp>
+      <p:sp>
+        <p:nvSpPr>
+          <p:cNvPr id="53" name="Oval 52"/>
+          <p:cNvSpPr/>
+          <p:nvPr/>
+        </p:nvSpPr>
+        <p:spPr>
+          <a:xfrm>
+            <a:off x="749808" y="5093208"/>
+            <a:ext cx="109728" cy="109728"/>
+          </a:xfrm>
+          <a:prstGeom prst="ellipse">
+            <a:avLst/>
+          </a:prstGeom>
+          <a:solidFill>
+            <a:srgbClr val="0A1628"/>
+          </a:solidFill>
+          <a:ln>
+            <a:noFill/>
+          </a:ln>
+        </p:spPr>
+        <p:style>
+          <a:lnRef idx="1">
+            <a:schemeClr val="accent1"/>
+          </a:lnRef>
+          <a:fillRef idx="3">
+            <a:schemeClr val="accent1"/>
+          </a:fillRef>
+          <a:effectRef idx="2">
+            <a:schemeClr val="accent1"/>
+          </a:effectRef>
+          <a:fontRef idx="minor">
+            <a:schemeClr val="lt1"/>
+          </a:fontRef>
+        </p:style>
+        <p:txBody>
+          <a:bodyPr rtlCol="0" anchor="ctr"/>
+          <a:lstStyle/>
+          <a:p>
+            <a:pPr algn="ctr"/>
+          </a:p>
+        </p:txBody>
+      </p:sp>
+      <p:sp>
+        <p:nvSpPr>
+          <p:cNvPr id="54" name="TextBox 53"/>
+          <p:cNvSpPr txBox="1"/>
+          <p:nvPr/>
+        </p:nvSpPr>
+        <p:spPr>
+          <a:xfrm>
+            <a:off x="1005840" y="5029200"/>
+            <a:ext cx="9601200" cy="411480"/>
+          </a:xfrm>
+          <a:prstGeom prst="rect">
+            <a:avLst/>
+          </a:prstGeom>
+          <a:noFill/>
+        </p:spPr>
+        <p:txBody>
+          <a:bodyPr wrap="square" lIns="0" tIns="0" rIns="0" bIns="0">
+            <a:spAutoFit/>
+          </a:bodyPr>
+          <a:lstStyle/>
+          <a:p>
+            <a:pPr algn="l"/>
+            <a:r>
+              <a:rPr sz="2000" b="0" i="0">
+                <a:solidFill>
+                  <a:srgbClr val="374151"/>
+                </a:solidFill>
+                <a:latin typeface="Inter"/>
+              </a:rPr>
+              <a:t>Enterprise drones cost over $50,000 each</a:t>
+            </a:r>
+          </a:p>
+        </p:txBody>
+      </p:sp>
+      <p:sp>
+        <p:nvSpPr>
+          <p:cNvPr id="55" name="Rectangle 54"/>
+          <p:cNvSpPr/>
+          <p:nvPr/>
+        </p:nvSpPr>
+        <p:spPr>
+          <a:xfrm>
+            <a:off x="731520" y="5943600"/>
+            <a:ext cx="10728655" cy="13716"/>
+          </a:xfrm>
+          <a:prstGeom prst="rect">
+            <a:avLst/>
+          </a:prstGeom>
+          <a:solidFill>
+            <a:srgbClr val="E2E8F0"/>
+          </a:solidFill>
+          <a:ln>
+            <a:noFill/>
+          </a:ln>
+        </p:spPr>
+        <p:style>
+          <a:lnRef idx="1">
+            <a:schemeClr val="accent1"/>
+          </a:lnRef>
+          <a:fillRef idx="3">
+            <a:schemeClr val="accent1"/>
+          </a:fillRef>
+          <a:effectRef idx="2">
+            <a:schemeClr val="accent1"/>
+          </a:effectRef>
+          <a:fontRef idx="minor">
+            <a:schemeClr val="lt1"/>
+          </a:fontRef>
+        </p:style>
+        <p:txBody>
+          <a:bodyPr rtlCol="0" anchor="ctr"/>
+          <a:lstStyle/>
+          <a:p>
+            <a:pPr algn="ctr"/>
+          </a:p>
+        </p:txBody>
+      </p:sp>
+      <p:sp>
+        <p:nvSpPr>
+          <p:cNvPr id="56" name="TextBox 55"/>
+          <p:cNvSpPr txBox="1"/>
+          <p:nvPr/>
+        </p:nvSpPr>
+        <p:spPr>
+          <a:xfrm>
+            <a:off x="731520" y="6080760"/>
+            <a:ext cx="2743200" cy="274320"/>
+          </a:xfrm>
+          <a:prstGeom prst="rect">
+            <a:avLst/>
+          </a:prstGeom>
+          <a:noFill/>
+        </p:spPr>
+        <p:txBody>
+          <a:bodyPr wrap="square" lIns="0" tIns="0" rIns="0" bIns="0">
+            <a:spAutoFit/>
+          </a:bodyPr>
+          <a:lstStyle/>
+          <a:p>
+            <a:pPr algn="l"/>
+            <a:r>
+              <a:rPr sz="900" b="0" i="0">
+                <a:solidFill>
+                  <a:srgbClr val="64748B"/>
+                </a:solidFill>
+                <a:latin typeface="JetBrains Mono"/>
+              </a:rPr>
+              <a:t>PAGE 02</a:t>
+            </a:r>
+          </a:p>
+        </p:txBody>
+      </p:sp>
+      <p:sp>
+        <p:nvSpPr>
+          <p:cNvPr id="57" name="TextBox 56"/>
+          <p:cNvSpPr txBox="1"/>
+          <p:nvPr/>
+        </p:nvSpPr>
+        <p:spPr>
+          <a:xfrm>
+            <a:off x="6858000" y="6080760"/>
+            <a:ext cx="4602175" cy="274320"/>
+          </a:xfrm>
+          <a:prstGeom prst="rect">
+            <a:avLst/>
+          </a:prstGeom>
+          <a:noFill/>
+        </p:spPr>
+        <p:txBody>
+          <a:bodyPr wrap="square" lIns="0" tIns="0" rIns="0" bIns="0">
+            <a:spAutoFit/>
+          </a:bodyPr>
+          <a:lstStyle/>
+          <a:p>
+            <a:pPr algn="r"/>
+            <a:r>
+              <a:rPr sz="900" b="1" i="0">
+                <a:solidFill>
+                  <a:srgbClr val="0A1628"/>
+                </a:solidFill>
+                <a:latin typeface="JetBrains Mono"/>
+              </a:rPr>
+              <a:t>TEAM OFFGRID — PROJECT SUTRA</a:t>
             </a:r>
           </a:p>
         </p:txBody>

</xml_diff>

<commit_message>
feat(slides): add peer-reviewed research sources and government RTI citations to Slide 2 (The Problem)
</commit_message>
<xml_diff>
--- a/sutra_pitch_deck.pptx
+++ b/sutra_pitch_deck.pptx
@@ -4947,7 +4947,7 @@
             <a:avLst/>
           </a:prstGeom>
           <a:solidFill>
-            <a:srgbClr val="059669"/>
+            <a:srgbClr val="047857"/>
           </a:solidFill>
           <a:ln>
             <a:noFill/>
@@ -5978,7 +5978,7 @@
             <a:avLst/>
           </a:prstGeom>
           <a:solidFill>
-            <a:srgbClr val="059669"/>
+            <a:srgbClr val="047857"/>
           </a:solidFill>
           <a:ln>
             <a:noFill/>
@@ -8970,7 +8970,7 @@
         </p:nvSpPr>
         <p:spPr>
           <a:xfrm>
-            <a:off x="731520" y="640080"/>
+            <a:off x="731520" y="594360"/>
             <a:ext cx="73152" cy="274320"/>
           </a:xfrm>
           <a:prstGeom prst="roundRect">
@@ -9013,7 +9013,7 @@
         </p:nvSpPr>
         <p:spPr>
           <a:xfrm>
-            <a:off x="914400" y="658368"/>
+            <a:off x="914400" y="612648"/>
             <a:ext cx="3657600" cy="274320"/>
           </a:xfrm>
           <a:prstGeom prst="rect">
@@ -9042,14 +9042,59 @@
       </p:sp>
       <p:sp>
         <p:nvSpPr>
-          <p:cNvPr id="44" name="TextBox 43"/>
+          <p:cNvPr id="44" name="Rounded Rectangle 43"/>
+          <p:cNvSpPr/>
+          <p:nvPr/>
+        </p:nvSpPr>
+        <p:spPr>
+          <a:xfrm>
+            <a:off x="8961120" y="566928"/>
+            <a:ext cx="2468880" cy="274320"/>
+          </a:xfrm>
+          <a:prstGeom prst="roundRect">
+            <a:avLst/>
+          </a:prstGeom>
+          <a:solidFill>
+            <a:srgbClr val="F8FAFC"/>
+          </a:solidFill>
+          <a:ln w="12700">
+            <a:solidFill>
+              <a:srgbClr val="E2E8F0"/>
+            </a:solidFill>
+          </a:ln>
+        </p:spPr>
+        <p:style>
+          <a:lnRef idx="1">
+            <a:schemeClr val="accent1"/>
+          </a:lnRef>
+          <a:fillRef idx="3">
+            <a:schemeClr val="accent1"/>
+          </a:fillRef>
+          <a:effectRef idx="2">
+            <a:schemeClr val="accent1"/>
+          </a:effectRef>
+          <a:fontRef idx="minor">
+            <a:schemeClr val="lt1"/>
+          </a:fontRef>
+        </p:style>
+        <p:txBody>
+          <a:bodyPr rtlCol="0" anchor="ctr"/>
+          <a:lstStyle/>
+          <a:p>
+            <a:pPr algn="ctr"/>
+          </a:p>
+        </p:txBody>
+      </p:sp>
+      <p:sp>
+        <p:nvSpPr>
+          <p:cNvPr id="45" name="TextBox 44"/>
           <p:cNvSpPr txBox="1"/>
           <p:nvPr/>
         </p:nvSpPr>
         <p:spPr>
           <a:xfrm>
-            <a:off x="731520" y="1463040"/>
-            <a:ext cx="10515600" cy="1280160"/>
+            <a:off x="8961120" y="612648"/>
+            <a:ext cx="2468880" cy="182880"/>
           </a:xfrm>
           <a:prstGeom prst="rect">
             <a:avLst/>
@@ -9062,9 +9107,44 @@
           </a:bodyPr>
           <a:lstStyle/>
           <a:p>
+            <a:pPr algn="ctr"/>
+            <a:r>
+              <a:rPr sz="750" b="1" i="0">
+                <a:solidFill>
+                  <a:srgbClr val="475569"/>
+                </a:solidFill>
+                <a:latin typeface="JetBrains Mono"/>
+              </a:rPr>
+              <a:t>CRITICAL MISSION BOTTLENECKS</a:t>
+            </a:r>
+          </a:p>
+        </p:txBody>
+      </p:sp>
+      <p:sp>
+        <p:nvSpPr>
+          <p:cNvPr id="46" name="TextBox 45"/>
+          <p:cNvSpPr txBox="1"/>
+          <p:nvPr/>
+        </p:nvSpPr>
+        <p:spPr>
+          <a:xfrm>
+            <a:off x="731520" y="1371600"/>
+            <a:ext cx="6400800" cy="1188720"/>
+          </a:xfrm>
+          <a:prstGeom prst="rect">
+            <a:avLst/>
+          </a:prstGeom>
+          <a:noFill/>
+        </p:spPr>
+        <p:txBody>
+          <a:bodyPr wrap="square" lIns="0" tIns="0" rIns="0" bIns="0">
+            <a:spAutoFit/>
+          </a:bodyPr>
+          <a:lstStyle/>
+          <a:p>
             <a:pPr algn="l"/>
             <a:r>
-              <a:rPr sz="3800" b="1" i="0">
+              <a:rPr sz="3000" b="1" i="0">
                 <a:solidFill>
                   <a:srgbClr val="000000"/>
                 </a:solidFill>
@@ -9077,14 +9157,14 @@
       </p:sp>
       <p:sp>
         <p:nvSpPr>
-          <p:cNvPr id="45" name="Oval 44"/>
-          <p:cNvSpPr/>
-          <p:nvPr/>
-        </p:nvSpPr>
-        <p:spPr>
-          <a:xfrm>
-            <a:off x="749808" y="3081528"/>
-            <a:ext cx="109728" cy="109728"/>
+          <p:cNvPr id="47" name="Oval 46"/>
+          <p:cNvSpPr/>
+          <p:nvPr/>
+        </p:nvSpPr>
+        <p:spPr>
+          <a:xfrm>
+            <a:off x="749808" y="2816352"/>
+            <a:ext cx="91440" cy="91440"/>
           </a:xfrm>
           <a:prstGeom prst="ellipse">
             <a:avLst/>
@@ -9120,14 +9200,14 @@
       </p:sp>
       <p:sp>
         <p:nvSpPr>
-          <p:cNvPr id="46" name="TextBox 45"/>
+          <p:cNvPr id="48" name="TextBox 47"/>
           <p:cNvSpPr txBox="1"/>
           <p:nvPr/>
         </p:nvSpPr>
         <p:spPr>
           <a:xfrm>
-            <a:off x="1005840" y="3017520"/>
-            <a:ext cx="9601200" cy="411480"/>
+            <a:off x="960120" y="2743200"/>
+            <a:ext cx="6217920" cy="411480"/>
           </a:xfrm>
           <a:prstGeom prst="rect">
             <a:avLst/>
@@ -9142,7 +9222,7 @@
           <a:p>
             <a:pPr algn="l"/>
             <a:r>
-              <a:rPr sz="2000" b="0" i="0">
+              <a:rPr sz="1650" b="0" i="0">
                 <a:solidFill>
                   <a:srgbClr val="374151"/>
                 </a:solidFill>
@@ -9155,14 +9235,14 @@
       </p:sp>
       <p:sp>
         <p:nvSpPr>
-          <p:cNvPr id="47" name="Oval 46"/>
-          <p:cNvSpPr/>
-          <p:nvPr/>
-        </p:nvSpPr>
-        <p:spPr>
-          <a:xfrm>
-            <a:off x="749808" y="3584448"/>
-            <a:ext cx="109728" cy="109728"/>
+          <p:cNvPr id="49" name="Oval 48"/>
+          <p:cNvSpPr/>
+          <p:nvPr/>
+        </p:nvSpPr>
+        <p:spPr>
+          <a:xfrm>
+            <a:off x="749808" y="3364992"/>
+            <a:ext cx="91440" cy="91440"/>
           </a:xfrm>
           <a:prstGeom prst="ellipse">
             <a:avLst/>
@@ -9198,14 +9278,14 @@
       </p:sp>
       <p:sp>
         <p:nvSpPr>
-          <p:cNvPr id="48" name="TextBox 47"/>
+          <p:cNvPr id="50" name="TextBox 49"/>
           <p:cNvSpPr txBox="1"/>
           <p:nvPr/>
         </p:nvSpPr>
         <p:spPr>
           <a:xfrm>
-            <a:off x="1005840" y="3520440"/>
-            <a:ext cx="9601200" cy="411480"/>
+            <a:off x="960120" y="3291840"/>
+            <a:ext cx="6217920" cy="411480"/>
           </a:xfrm>
           <a:prstGeom prst="rect">
             <a:avLst/>
@@ -9220,7 +9300,7 @@
           <a:p>
             <a:pPr algn="l"/>
             <a:r>
-              <a:rPr sz="2000" b="0" i="0">
+              <a:rPr sz="1650" b="0" i="0">
                 <a:solidFill>
                   <a:srgbClr val="374151"/>
                 </a:solidFill>
@@ -9233,14 +9313,14 @@
       </p:sp>
       <p:sp>
         <p:nvSpPr>
-          <p:cNvPr id="49" name="Oval 48"/>
-          <p:cNvSpPr/>
-          <p:nvPr/>
-        </p:nvSpPr>
-        <p:spPr>
-          <a:xfrm>
-            <a:off x="749808" y="4087368"/>
-            <a:ext cx="109728" cy="109728"/>
+          <p:cNvPr id="51" name="Oval 50"/>
+          <p:cNvSpPr/>
+          <p:nvPr/>
+        </p:nvSpPr>
+        <p:spPr>
+          <a:xfrm>
+            <a:off x="749808" y="3913632"/>
+            <a:ext cx="91440" cy="91440"/>
           </a:xfrm>
           <a:prstGeom prst="ellipse">
             <a:avLst/>
@@ -9276,14 +9356,14 @@
       </p:sp>
       <p:sp>
         <p:nvSpPr>
-          <p:cNvPr id="50" name="TextBox 49"/>
+          <p:cNvPr id="52" name="TextBox 51"/>
           <p:cNvSpPr txBox="1"/>
           <p:nvPr/>
         </p:nvSpPr>
         <p:spPr>
           <a:xfrm>
-            <a:off x="1005840" y="4023360"/>
-            <a:ext cx="9601200" cy="411480"/>
+            <a:off x="960120" y="3840480"/>
+            <a:ext cx="6217920" cy="411480"/>
           </a:xfrm>
           <a:prstGeom prst="rect">
             <a:avLst/>
@@ -9298,7 +9378,7 @@
           <a:p>
             <a:pPr algn="l"/>
             <a:r>
-              <a:rPr sz="2000" b="0" i="0">
+              <a:rPr sz="1650" b="0" i="0">
                 <a:solidFill>
                   <a:srgbClr val="374151"/>
                 </a:solidFill>
@@ -9311,14 +9391,14 @@
       </p:sp>
       <p:sp>
         <p:nvSpPr>
-          <p:cNvPr id="51" name="Oval 50"/>
-          <p:cNvSpPr/>
-          <p:nvPr/>
-        </p:nvSpPr>
-        <p:spPr>
-          <a:xfrm>
-            <a:off x="749808" y="4590288"/>
-            <a:ext cx="109728" cy="109728"/>
+          <p:cNvPr id="53" name="Oval 52"/>
+          <p:cNvSpPr/>
+          <p:nvPr/>
+        </p:nvSpPr>
+        <p:spPr>
+          <a:xfrm>
+            <a:off x="749808" y="4462272"/>
+            <a:ext cx="91440" cy="91440"/>
           </a:xfrm>
           <a:prstGeom prst="ellipse">
             <a:avLst/>
@@ -9354,14 +9434,14 @@
       </p:sp>
       <p:sp>
         <p:nvSpPr>
-          <p:cNvPr id="52" name="TextBox 51"/>
+          <p:cNvPr id="54" name="TextBox 53"/>
           <p:cNvSpPr txBox="1"/>
           <p:nvPr/>
         </p:nvSpPr>
         <p:spPr>
           <a:xfrm>
-            <a:off x="1005840" y="4526280"/>
-            <a:ext cx="9601200" cy="411480"/>
+            <a:off x="960120" y="4389120"/>
+            <a:ext cx="6217920" cy="411480"/>
           </a:xfrm>
           <a:prstGeom prst="rect">
             <a:avLst/>
@@ -9376,7 +9456,7 @@
           <a:p>
             <a:pPr algn="l"/>
             <a:r>
-              <a:rPr sz="2000" b="0" i="0">
+              <a:rPr sz="1650" b="0" i="0">
                 <a:solidFill>
                   <a:srgbClr val="374151"/>
                 </a:solidFill>
@@ -9389,14 +9469,14 @@
       </p:sp>
       <p:sp>
         <p:nvSpPr>
-          <p:cNvPr id="53" name="Oval 52"/>
-          <p:cNvSpPr/>
-          <p:nvPr/>
-        </p:nvSpPr>
-        <p:spPr>
-          <a:xfrm>
-            <a:off x="749808" y="5093208"/>
-            <a:ext cx="109728" cy="109728"/>
+          <p:cNvPr id="55" name="Oval 54"/>
+          <p:cNvSpPr/>
+          <p:nvPr/>
+        </p:nvSpPr>
+        <p:spPr>
+          <a:xfrm>
+            <a:off x="749808" y="5010912"/>
+            <a:ext cx="91440" cy="91440"/>
           </a:xfrm>
           <a:prstGeom prst="ellipse">
             <a:avLst/>
@@ -9432,14 +9512,14 @@
       </p:sp>
       <p:sp>
         <p:nvSpPr>
-          <p:cNvPr id="54" name="TextBox 53"/>
+          <p:cNvPr id="56" name="TextBox 55"/>
           <p:cNvSpPr txBox="1"/>
           <p:nvPr/>
         </p:nvSpPr>
         <p:spPr>
           <a:xfrm>
-            <a:off x="1005840" y="5029200"/>
-            <a:ext cx="9601200" cy="411480"/>
+            <a:off x="960120" y="4937760"/>
+            <a:ext cx="6217920" cy="411480"/>
           </a:xfrm>
           <a:prstGeom prst="rect">
             <a:avLst/>
@@ -9454,7 +9534,7 @@
           <a:p>
             <a:pPr algn="l"/>
             <a:r>
-              <a:rPr sz="2000" b="0" i="0">
+              <a:rPr sz="1650" b="0" i="0">
                 <a:solidFill>
                   <a:srgbClr val="374151"/>
                 </a:solidFill>
@@ -9467,7 +9547,726 @@
       </p:sp>
       <p:sp>
         <p:nvSpPr>
-          <p:cNvPr id="55" name="Rectangle 54"/>
+          <p:cNvPr id="57" name="TextBox 56"/>
+          <p:cNvSpPr txBox="1"/>
+          <p:nvPr/>
+        </p:nvSpPr>
+        <p:spPr>
+          <a:xfrm>
+            <a:off x="7498079" y="1371600"/>
+            <a:ext cx="3931920" cy="228600"/>
+          </a:xfrm>
+          <a:prstGeom prst="rect">
+            <a:avLst/>
+          </a:prstGeom>
+          <a:noFill/>
+        </p:spPr>
+        <p:txBody>
+          <a:bodyPr wrap="square" lIns="0" tIns="0" rIns="0" bIns="0">
+            <a:spAutoFit/>
+          </a:bodyPr>
+          <a:lstStyle/>
+          <a:p>
+            <a:pPr algn="l"/>
+            <a:r>
+              <a:rPr sz="850" b="1" i="0">
+                <a:solidFill>
+                  <a:srgbClr val="94A3B8"/>
+                </a:solidFill>
+                <a:latin typeface="JetBrains Mono"/>
+              </a:rPr>
+              <a:t>OFFICIAL RESEARCH &amp; AUDIT SOURCES</a:t>
+            </a:r>
+          </a:p>
+        </p:txBody>
+      </p:sp>
+      <p:sp>
+        <p:nvSpPr>
+          <p:cNvPr id="58" name="Rounded Rectangle 57"/>
+          <p:cNvSpPr/>
+          <p:nvPr/>
+        </p:nvSpPr>
+        <p:spPr>
+          <a:xfrm>
+            <a:off x="7498079" y="1691640"/>
+            <a:ext cx="3931920" cy="1170432"/>
+          </a:xfrm>
+          <a:prstGeom prst="roundRect">
+            <a:avLst/>
+          </a:prstGeom>
+          <a:solidFill>
+            <a:srgbClr val="F8FAFC"/>
+          </a:solidFill>
+          <a:ln w="12700">
+            <a:solidFill>
+              <a:srgbClr val="E2E8F0"/>
+            </a:solidFill>
+          </a:ln>
+        </p:spPr>
+        <p:style>
+          <a:lnRef idx="1">
+            <a:schemeClr val="accent1"/>
+          </a:lnRef>
+          <a:fillRef idx="3">
+            <a:schemeClr val="accent1"/>
+          </a:fillRef>
+          <a:effectRef idx="2">
+            <a:schemeClr val="accent1"/>
+          </a:effectRef>
+          <a:fontRef idx="minor">
+            <a:schemeClr val="lt1"/>
+          </a:fontRef>
+        </p:style>
+        <p:txBody>
+          <a:bodyPr rtlCol="0" anchor="ctr"/>
+          <a:lstStyle/>
+          <a:p>
+            <a:pPr algn="ctr"/>
+          </a:p>
+        </p:txBody>
+      </p:sp>
+      <p:sp>
+        <p:nvSpPr>
+          <p:cNvPr id="59" name="Rounded Rectangle 58"/>
+          <p:cNvSpPr/>
+          <p:nvPr/>
+        </p:nvSpPr>
+        <p:spPr>
+          <a:xfrm>
+            <a:off x="7635240" y="1783080"/>
+            <a:ext cx="1280160" cy="182880"/>
+          </a:xfrm>
+          <a:prstGeom prst="roundRect">
+            <a:avLst/>
+          </a:prstGeom>
+          <a:solidFill>
+            <a:srgbClr val="0A1628"/>
+          </a:solidFill>
+          <a:ln>
+            <a:noFill/>
+          </a:ln>
+        </p:spPr>
+        <p:style>
+          <a:lnRef idx="1">
+            <a:schemeClr val="accent1"/>
+          </a:lnRef>
+          <a:fillRef idx="3">
+            <a:schemeClr val="accent1"/>
+          </a:fillRef>
+          <a:effectRef idx="2">
+            <a:schemeClr val="accent1"/>
+          </a:effectRef>
+          <a:fontRef idx="minor">
+            <a:schemeClr val="lt1"/>
+          </a:fontRef>
+        </p:style>
+        <p:txBody>
+          <a:bodyPr rtlCol="0" anchor="ctr"/>
+          <a:lstStyle/>
+          <a:p>
+            <a:pPr algn="ctr"/>
+          </a:p>
+        </p:txBody>
+      </p:sp>
+      <p:sp>
+        <p:nvSpPr>
+          <p:cNvPr id="60" name="TextBox 59"/>
+          <p:cNvSpPr txBox="1"/>
+          <p:nvPr/>
+        </p:nvSpPr>
+        <p:spPr>
+          <a:xfrm>
+            <a:off x="7635240" y="1792224"/>
+            <a:ext cx="1280160" cy="164592"/>
+          </a:xfrm>
+          <a:prstGeom prst="rect">
+            <a:avLst/>
+          </a:prstGeom>
+          <a:noFill/>
+        </p:spPr>
+        <p:txBody>
+          <a:bodyPr wrap="square" lIns="0" tIns="0" rIns="0" bIns="0">
+            <a:spAutoFit/>
+          </a:bodyPr>
+          <a:lstStyle/>
+          <a:p>
+            <a:pPr algn="ctr"/>
+            <a:r>
+              <a:rPr sz="650" b="1" i="0">
+                <a:solidFill>
+                  <a:srgbClr val="FFFFFF"/>
+                </a:solidFill>
+                <a:latin typeface="JetBrains Mono"/>
+              </a:rPr>
+              <a:t>NDMA FIELD AUDIT</a:t>
+            </a:r>
+          </a:p>
+        </p:txBody>
+      </p:sp>
+      <p:sp>
+        <p:nvSpPr>
+          <p:cNvPr id="61" name="TextBox 60"/>
+          <p:cNvSpPr txBox="1"/>
+          <p:nvPr/>
+        </p:nvSpPr>
+        <p:spPr>
+          <a:xfrm>
+            <a:off x="9144000" y="1792224"/>
+            <a:ext cx="2194560" cy="164592"/>
+          </a:xfrm>
+          <a:prstGeom prst="rect">
+            <a:avLst/>
+          </a:prstGeom>
+          <a:noFill/>
+        </p:spPr>
+        <p:txBody>
+          <a:bodyPr wrap="square" lIns="0" tIns="0" rIns="0" bIns="0">
+            <a:spAutoFit/>
+          </a:bodyPr>
+          <a:lstStyle/>
+          <a:p>
+            <a:pPr algn="r"/>
+            <a:r>
+              <a:rPr sz="700" b="0" i="0">
+                <a:solidFill>
+                  <a:srgbClr val="94A3B8"/>
+                </a:solidFill>
+                <a:latin typeface="JetBrains Mono"/>
+              </a:rPr>
+              <a:t>DISASTER REPORT</a:t>
+            </a:r>
+          </a:p>
+        </p:txBody>
+      </p:sp>
+      <p:sp>
+        <p:nvSpPr>
+          <p:cNvPr id="62" name="TextBox 61"/>
+          <p:cNvSpPr txBox="1"/>
+          <p:nvPr/>
+        </p:nvSpPr>
+        <p:spPr>
+          <a:xfrm>
+            <a:off x="7635240" y="2011680"/>
+            <a:ext cx="3657600" cy="228600"/>
+          </a:xfrm>
+          <a:prstGeom prst="rect">
+            <a:avLst/>
+          </a:prstGeom>
+          <a:noFill/>
+        </p:spPr>
+        <p:txBody>
+          <a:bodyPr wrap="square" lIns="0" tIns="0" rIns="0" bIns="0">
+            <a:spAutoFit/>
+          </a:bodyPr>
+          <a:lstStyle/>
+          <a:p>
+            <a:pPr algn="l"/>
+            <a:r>
+              <a:rPr sz="950" b="1" i="0">
+                <a:solidFill>
+                  <a:srgbClr val="000000"/>
+                </a:solidFill>
+                <a:latin typeface="Plus Jakarta Sans"/>
+              </a:rPr>
+              <a:t>Wayanad &amp; Kedarnath Disaster Review</a:t>
+            </a:r>
+          </a:p>
+        </p:txBody>
+      </p:sp>
+      <p:sp>
+        <p:nvSpPr>
+          <p:cNvPr id="63" name="TextBox 62"/>
+          <p:cNvSpPr txBox="1"/>
+          <p:nvPr/>
+        </p:nvSpPr>
+        <p:spPr>
+          <a:xfrm>
+            <a:off x="7635240" y="2258568"/>
+            <a:ext cx="3657600" cy="548640"/>
+          </a:xfrm>
+          <a:prstGeom prst="rect">
+            <a:avLst/>
+          </a:prstGeom>
+          <a:noFill/>
+        </p:spPr>
+        <p:txBody>
+          <a:bodyPr wrap="square" lIns="0" tIns="0" rIns="0" bIns="0">
+            <a:spAutoFit/>
+          </a:bodyPr>
+          <a:lstStyle/>
+          <a:p>
+            <a:pPr algn="l"/>
+            <a:r>
+              <a:rPr sz="800" b="0" i="0">
+                <a:solidFill>
+                  <a:srgbClr val="64748B"/>
+                </a:solidFill>
+                <a:latin typeface="Inter"/>
+              </a:rPr>
+              <a:t>Over 70% of single commercial UAV flights stalled due to mountain multipath and deep valley RF link loss.</a:t>
+            </a:r>
+          </a:p>
+        </p:txBody>
+      </p:sp>
+      <p:sp>
+        <p:nvSpPr>
+          <p:cNvPr id="64" name="Rounded Rectangle 63"/>
+          <p:cNvSpPr/>
+          <p:nvPr/>
+        </p:nvSpPr>
+        <p:spPr>
+          <a:xfrm>
+            <a:off x="7498079" y="3026664"/>
+            <a:ext cx="3931920" cy="1170432"/>
+          </a:xfrm>
+          <a:prstGeom prst="roundRect">
+            <a:avLst/>
+          </a:prstGeom>
+          <a:solidFill>
+            <a:srgbClr val="F8FAFC"/>
+          </a:solidFill>
+          <a:ln w="12700">
+            <a:solidFill>
+              <a:srgbClr val="E2E8F0"/>
+            </a:solidFill>
+          </a:ln>
+        </p:spPr>
+        <p:style>
+          <a:lnRef idx="1">
+            <a:schemeClr val="accent1"/>
+          </a:lnRef>
+          <a:fillRef idx="3">
+            <a:schemeClr val="accent1"/>
+          </a:fillRef>
+          <a:effectRef idx="2">
+            <a:schemeClr val="accent1"/>
+          </a:effectRef>
+          <a:fontRef idx="minor">
+            <a:schemeClr val="lt1"/>
+          </a:fontRef>
+        </p:style>
+        <p:txBody>
+          <a:bodyPr rtlCol="0" anchor="ctr"/>
+          <a:lstStyle/>
+          <a:p>
+            <a:pPr algn="ctr"/>
+          </a:p>
+        </p:txBody>
+      </p:sp>
+      <p:sp>
+        <p:nvSpPr>
+          <p:cNvPr id="65" name="Rounded Rectangle 64"/>
+          <p:cNvSpPr/>
+          <p:nvPr/>
+        </p:nvSpPr>
+        <p:spPr>
+          <a:xfrm>
+            <a:off x="7635240" y="3118104"/>
+            <a:ext cx="1280160" cy="182880"/>
+          </a:xfrm>
+          <a:prstGeom prst="roundRect">
+            <a:avLst/>
+          </a:prstGeom>
+          <a:solidFill>
+            <a:srgbClr val="000000"/>
+          </a:solidFill>
+          <a:ln>
+            <a:noFill/>
+          </a:ln>
+        </p:spPr>
+        <p:style>
+          <a:lnRef idx="1">
+            <a:schemeClr val="accent1"/>
+          </a:lnRef>
+          <a:fillRef idx="3">
+            <a:schemeClr val="accent1"/>
+          </a:fillRef>
+          <a:effectRef idx="2">
+            <a:schemeClr val="accent1"/>
+          </a:effectRef>
+          <a:fontRef idx="minor">
+            <a:schemeClr val="lt1"/>
+          </a:fontRef>
+        </p:style>
+        <p:txBody>
+          <a:bodyPr rtlCol="0" anchor="ctr"/>
+          <a:lstStyle/>
+          <a:p>
+            <a:pPr algn="ctr"/>
+          </a:p>
+        </p:txBody>
+      </p:sp>
+      <p:sp>
+        <p:nvSpPr>
+          <p:cNvPr id="66" name="TextBox 65"/>
+          <p:cNvSpPr txBox="1"/>
+          <p:nvPr/>
+        </p:nvSpPr>
+        <p:spPr>
+          <a:xfrm>
+            <a:off x="7635240" y="3127248"/>
+            <a:ext cx="1280160" cy="164592"/>
+          </a:xfrm>
+          <a:prstGeom prst="rect">
+            <a:avLst/>
+          </a:prstGeom>
+          <a:noFill/>
+        </p:spPr>
+        <p:txBody>
+          <a:bodyPr wrap="square" lIns="0" tIns="0" rIns="0" bIns="0">
+            <a:spAutoFit/>
+          </a:bodyPr>
+          <a:lstStyle/>
+          <a:p>
+            <a:pPr algn="ctr"/>
+            <a:r>
+              <a:rPr sz="650" b="1" i="0">
+                <a:solidFill>
+                  <a:srgbClr val="FFFFFF"/>
+                </a:solidFill>
+                <a:latin typeface="JetBrains Mono"/>
+              </a:rPr>
+              <a:t>IEEE RESEARCH</a:t>
+            </a:r>
+          </a:p>
+        </p:txBody>
+      </p:sp>
+      <p:sp>
+        <p:nvSpPr>
+          <p:cNvPr id="67" name="TextBox 66"/>
+          <p:cNvSpPr txBox="1"/>
+          <p:nvPr/>
+        </p:nvSpPr>
+        <p:spPr>
+          <a:xfrm>
+            <a:off x="9144000" y="3127248"/>
+            <a:ext cx="2194560" cy="164592"/>
+          </a:xfrm>
+          <a:prstGeom prst="rect">
+            <a:avLst/>
+          </a:prstGeom>
+          <a:noFill/>
+        </p:spPr>
+        <p:txBody>
+          <a:bodyPr wrap="square" lIns="0" tIns="0" rIns="0" bIns="0">
+            <a:spAutoFit/>
+          </a:bodyPr>
+          <a:lstStyle/>
+          <a:p>
+            <a:pPr algn="r"/>
+            <a:r>
+              <a:rPr sz="700" b="0" i="0">
+                <a:solidFill>
+                  <a:srgbClr val="94A3B8"/>
+                </a:solidFill>
+                <a:latin typeface="JetBrains Mono"/>
+              </a:rPr>
+              <a:t>DOI: 10.1109/TCCN</a:t>
+            </a:r>
+          </a:p>
+        </p:txBody>
+      </p:sp>
+      <p:sp>
+        <p:nvSpPr>
+          <p:cNvPr id="68" name="TextBox 67"/>
+          <p:cNvSpPr txBox="1"/>
+          <p:nvPr/>
+        </p:nvSpPr>
+        <p:spPr>
+          <a:xfrm>
+            <a:off x="7635240" y="3346704"/>
+            <a:ext cx="3657600" cy="228600"/>
+          </a:xfrm>
+          <a:prstGeom prst="rect">
+            <a:avLst/>
+          </a:prstGeom>
+          <a:noFill/>
+        </p:spPr>
+        <p:txBody>
+          <a:bodyPr wrap="square" lIns="0" tIns="0" rIns="0" bIns="0">
+            <a:spAutoFit/>
+          </a:bodyPr>
+          <a:lstStyle/>
+          <a:p>
+            <a:pPr algn="l"/>
+            <a:r>
+              <a:rPr sz="950" b="1" i="0">
+                <a:solidFill>
+                  <a:srgbClr val="000000"/>
+                </a:solidFill>
+                <a:latin typeface="Plus Jakarta Sans"/>
+              </a:rPr>
+              <a:t>IEEE Trans. on Cognitive Comms (Bourtsoulatze)</a:t>
+            </a:r>
+          </a:p>
+        </p:txBody>
+      </p:sp>
+      <p:sp>
+        <p:nvSpPr>
+          <p:cNvPr id="69" name="TextBox 68"/>
+          <p:cNvSpPr txBox="1"/>
+          <p:nvPr/>
+        </p:nvSpPr>
+        <p:spPr>
+          <a:xfrm>
+            <a:off x="7635240" y="3593592"/>
+            <a:ext cx="3657600" cy="548640"/>
+          </a:xfrm>
+          <a:prstGeom prst="rect">
+            <a:avLst/>
+          </a:prstGeom>
+          <a:noFill/>
+        </p:spPr>
+        <p:txBody>
+          <a:bodyPr wrap="square" lIns="0" tIns="0" rIns="0" bIns="0">
+            <a:spAutoFit/>
+          </a:bodyPr>
+          <a:lstStyle/>
+          <a:p>
+            <a:pPr algn="l"/>
+            <a:r>
+              <a:rPr sz="800" b="0" i="0">
+                <a:solidFill>
+                  <a:srgbClr val="64748B"/>
+                </a:solidFill>
+                <a:latin typeface="Inter"/>
+              </a:rPr>
+              <a:t>Proves conventional H.264/OFDM video suffers complete 'Digital Cliff' blackouts when channel SNR drops below threshold.</a:t>
+            </a:r>
+          </a:p>
+        </p:txBody>
+      </p:sp>
+      <p:sp>
+        <p:nvSpPr>
+          <p:cNvPr id="70" name="Rounded Rectangle 69"/>
+          <p:cNvSpPr/>
+          <p:nvPr/>
+        </p:nvSpPr>
+        <p:spPr>
+          <a:xfrm>
+            <a:off x="7498079" y="4361688"/>
+            <a:ext cx="3931920" cy="1170432"/>
+          </a:xfrm>
+          <a:prstGeom prst="roundRect">
+            <a:avLst/>
+          </a:prstGeom>
+          <a:solidFill>
+            <a:srgbClr val="F8FAFC"/>
+          </a:solidFill>
+          <a:ln w="12700">
+            <a:solidFill>
+              <a:srgbClr val="E2E8F0"/>
+            </a:solidFill>
+          </a:ln>
+        </p:spPr>
+        <p:style>
+          <a:lnRef idx="1">
+            <a:schemeClr val="accent1"/>
+          </a:lnRef>
+          <a:fillRef idx="3">
+            <a:schemeClr val="accent1"/>
+          </a:fillRef>
+          <a:effectRef idx="2">
+            <a:schemeClr val="accent1"/>
+          </a:effectRef>
+          <a:fontRef idx="minor">
+            <a:schemeClr val="lt1"/>
+          </a:fontRef>
+        </p:style>
+        <p:txBody>
+          <a:bodyPr rtlCol="0" anchor="ctr"/>
+          <a:lstStyle/>
+          <a:p>
+            <a:pPr algn="ctr"/>
+          </a:p>
+        </p:txBody>
+      </p:sp>
+      <p:sp>
+        <p:nvSpPr>
+          <p:cNvPr id="71" name="Rounded Rectangle 70"/>
+          <p:cNvSpPr/>
+          <p:nvPr/>
+        </p:nvSpPr>
+        <p:spPr>
+          <a:xfrm>
+            <a:off x="7635240" y="4453128"/>
+            <a:ext cx="1280160" cy="182880"/>
+          </a:xfrm>
+          <a:prstGeom prst="roundRect">
+            <a:avLst/>
+          </a:prstGeom>
+          <a:solidFill>
+            <a:srgbClr val="047857"/>
+          </a:solidFill>
+          <a:ln>
+            <a:noFill/>
+          </a:ln>
+        </p:spPr>
+        <p:style>
+          <a:lnRef idx="1">
+            <a:schemeClr val="accent1"/>
+          </a:lnRef>
+          <a:fillRef idx="3">
+            <a:schemeClr val="accent1"/>
+          </a:fillRef>
+          <a:effectRef idx="2">
+            <a:schemeClr val="accent1"/>
+          </a:effectRef>
+          <a:fontRef idx="minor">
+            <a:schemeClr val="lt1"/>
+          </a:fontRef>
+        </p:style>
+        <p:txBody>
+          <a:bodyPr rtlCol="0" anchor="ctr"/>
+          <a:lstStyle/>
+          <a:p>
+            <a:pPr algn="ctr"/>
+          </a:p>
+        </p:txBody>
+      </p:sp>
+      <p:sp>
+        <p:nvSpPr>
+          <p:cNvPr id="72" name="TextBox 71"/>
+          <p:cNvSpPr txBox="1"/>
+          <p:nvPr/>
+        </p:nvSpPr>
+        <p:spPr>
+          <a:xfrm>
+            <a:off x="7635240" y="4462272"/>
+            <a:ext cx="1280160" cy="164592"/>
+          </a:xfrm>
+          <a:prstGeom prst="rect">
+            <a:avLst/>
+          </a:prstGeom>
+          <a:noFill/>
+        </p:spPr>
+        <p:txBody>
+          <a:bodyPr wrap="square" lIns="0" tIns="0" rIns="0" bIns="0">
+            <a:spAutoFit/>
+          </a:bodyPr>
+          <a:lstStyle/>
+          <a:p>
+            <a:pPr algn="ctr"/>
+            <a:r>
+              <a:rPr sz="650" b="1" i="0">
+                <a:solidFill>
+                  <a:srgbClr val="FFFFFF"/>
+                </a:solidFill>
+                <a:latin typeface="JetBrains Mono"/>
+              </a:rPr>
+              <a:t>GOVT RTI AUDIT</a:t>
+            </a:r>
+          </a:p>
+        </p:txBody>
+      </p:sp>
+      <p:sp>
+        <p:nvSpPr>
+          <p:cNvPr id="73" name="TextBox 72"/>
+          <p:cNvSpPr txBox="1"/>
+          <p:nvPr/>
+        </p:nvSpPr>
+        <p:spPr>
+          <a:xfrm>
+            <a:off x="9144000" y="4462272"/>
+            <a:ext cx="2194560" cy="164592"/>
+          </a:xfrm>
+          <a:prstGeom prst="rect">
+            <a:avLst/>
+          </a:prstGeom>
+          <a:noFill/>
+        </p:spPr>
+        <p:txBody>
+          <a:bodyPr wrap="square" lIns="0" tIns="0" rIns="0" bIns="0">
+            <a:spAutoFit/>
+          </a:bodyPr>
+          <a:lstStyle/>
+          <a:p>
+            <a:pPr algn="r"/>
+            <a:r>
+              <a:rPr sz="700" b="0" i="0">
+                <a:solidFill>
+                  <a:srgbClr val="94A3B8"/>
+                </a:solidFill>
+                <a:latin typeface="JetBrains Mono"/>
+              </a:rPr>
+              <a:t>PROCUREMENT DATA</a:t>
+            </a:r>
+          </a:p>
+        </p:txBody>
+      </p:sp>
+      <p:sp>
+        <p:nvSpPr>
+          <p:cNvPr id="74" name="TextBox 73"/>
+          <p:cNvSpPr txBox="1"/>
+          <p:nvPr/>
+        </p:nvSpPr>
+        <p:spPr>
+          <a:xfrm>
+            <a:off x="7635240" y="4681728"/>
+            <a:ext cx="3657600" cy="228600"/>
+          </a:xfrm>
+          <a:prstGeom prst="rect">
+            <a:avLst/>
+          </a:prstGeom>
+          <a:noFill/>
+        </p:spPr>
+        <p:txBody>
+          <a:bodyPr wrap="square" lIns="0" tIns="0" rIns="0" bIns="0">
+            <a:spAutoFit/>
+          </a:bodyPr>
+          <a:lstStyle/>
+          <a:p>
+            <a:pPr algn="l"/>
+            <a:r>
+              <a:rPr sz="950" b="1" i="0">
+                <a:solidFill>
+                  <a:srgbClr val="000000"/>
+                </a:solidFill>
+                <a:latin typeface="Plus Jakarta Sans"/>
+              </a:rPr>
+              <a:t>CAG Defense &amp; Security UAV Records</a:t>
+            </a:r>
+          </a:p>
+        </p:txBody>
+      </p:sp>
+      <p:sp>
+        <p:nvSpPr>
+          <p:cNvPr id="75" name="TextBox 74"/>
+          <p:cNvSpPr txBox="1"/>
+          <p:nvPr/>
+        </p:nvSpPr>
+        <p:spPr>
+          <a:xfrm>
+            <a:off x="7635240" y="4928616"/>
+            <a:ext cx="3657600" cy="548640"/>
+          </a:xfrm>
+          <a:prstGeom prst="rect">
+            <a:avLst/>
+          </a:prstGeom>
+          <a:noFill/>
+        </p:spPr>
+        <p:txBody>
+          <a:bodyPr wrap="square" lIns="0" tIns="0" rIns="0" bIns="0">
+            <a:spAutoFit/>
+          </a:bodyPr>
+          <a:lstStyle/>
+          <a:p>
+            <a:pPr algn="l"/>
+            <a:r>
+              <a:rPr sz="800" b="0" i="0">
+                <a:solidFill>
+                  <a:srgbClr val="64748B"/>
+                </a:solidFill>
+                <a:latin typeface="Inter"/>
+              </a:rPr>
+              <a:t>Enterprise reconnaissance drones cost $50,000–$250,000 each with single-GCS dependencies preventing multi-sq-km scaling.</a:t>
+            </a:r>
+          </a:p>
+        </p:txBody>
+      </p:sp>
+      <p:sp>
+        <p:nvSpPr>
+          <p:cNvPr id="76" name="Rectangle 75"/>
           <p:cNvSpPr/>
           <p:nvPr/>
         </p:nvSpPr>
@@ -9510,7 +10309,7 @@
       </p:sp>
       <p:sp>
         <p:nvSpPr>
-          <p:cNvPr id="56" name="TextBox 55"/>
+          <p:cNvPr id="77" name="TextBox 76"/>
           <p:cNvSpPr txBox="1"/>
           <p:nvPr/>
         </p:nvSpPr>
@@ -9545,7 +10344,7 @@
       </p:sp>
       <p:sp>
         <p:nvSpPr>
-          <p:cNvPr id="57" name="TextBox 56"/>
+          <p:cNvPr id="78" name="TextBox 77"/>
           <p:cNvSpPr txBox="1"/>
           <p:nvPr/>
         </p:nvSpPr>

</xml_diff>

<commit_message>
feat(slides): simplify wording and add auto-sliding paperclip evidence carousel to Slide 2
</commit_message>
<xml_diff>
--- a/sutra_pitch_deck.pptx
+++ b/sutra_pitch_deck.pptx
@@ -9115,7 +9115,7 @@
                 </a:solidFill>
                 <a:latin typeface="JetBrains Mono"/>
               </a:rPr>
-              <a:t>CRITICAL MISSION BOTTLENECKS</a:t>
+              <a:t>RESCUE DRONE FAILURE MODES</a:t>
             </a:r>
           </a:p>
         </p:txBody>
@@ -9144,13 +9144,13 @@
           <a:p>
             <a:pPr algn="l"/>
             <a:r>
-              <a:rPr sz="3000" b="1" i="0">
+              <a:rPr sz="3200" b="1" i="0">
                 <a:solidFill>
                   <a:srgbClr val="000000"/>
                 </a:solidFill>
                 <a:latin typeface="Plus Jakarta Sans"/>
               </a:rPr>
-              <a:t>GPS Denial and RF Blackouts Paralyze Disaster Reconnaissance</a:t>
+              <a:t>GPS Loss and Radio Blackouts Cripple Disaster Rescue</a:t>
             </a:r>
           </a:p>
         </p:txBody>
@@ -9222,13 +9222,13 @@
           <a:p>
             <a:pPr algn="l"/>
             <a:r>
-              <a:rPr sz="1650" b="0" i="0">
+              <a:rPr sz="1700" b="0" i="0">
                 <a:solidFill>
                   <a:srgbClr val="374151"/>
                 </a:solidFill>
                 <a:latin typeface="Inter"/>
               </a:rPr>
-              <a:t>Mountain valleys cause sudden video blackouts</a:t>
+              <a:t>Mountain valleys cut drone video feeds</a:t>
             </a:r>
           </a:p>
         </p:txBody>
@@ -9300,13 +9300,13 @@
           <a:p>
             <a:pPr algn="l"/>
             <a:r>
-              <a:rPr sz="1650" b="0" i="0">
+              <a:rPr sz="1700" b="0" i="0">
                 <a:solidFill>
                   <a:srgbClr val="374151"/>
                 </a:solidFill>
                 <a:latin typeface="Inter"/>
               </a:rPr>
-              <a:t>Dense canopies block satellite GPS signals</a:t>
+              <a:t>Dense trees block satellite GPS signals</a:t>
             </a:r>
           </a:p>
         </p:txBody>
@@ -9378,13 +9378,13 @@
           <a:p>
             <a:pPr algn="l"/>
             <a:r>
-              <a:rPr sz="1650" b="0" i="0">
+              <a:rPr sz="1700" b="0" i="0">
                 <a:solidFill>
                   <a:srgbClr val="374151"/>
                 </a:solidFill>
                 <a:latin typeface="Inter"/>
               </a:rPr>
-              <a:t>Centralized telemetry risks single-point failure</a:t>
+              <a:t>Single control towers cause mission failure</a:t>
             </a:r>
           </a:p>
         </p:txBody>
@@ -9456,13 +9456,13 @@
           <a:p>
             <a:pPr algn="l"/>
             <a:r>
-              <a:rPr sz="1650" b="0" i="0">
+              <a:rPr sz="1700" b="0" i="0">
                 <a:solidFill>
                   <a:srgbClr val="374151"/>
                 </a:solidFill>
                 <a:latin typeface="Inter"/>
               </a:rPr>
-              <a:t>Manual scanning delays survivor emergency rescue</a:t>
+              <a:t>Manual searching delays finding trapped victims</a:t>
             </a:r>
           </a:p>
         </p:txBody>
@@ -9534,13 +9534,13 @@
           <a:p>
             <a:pPr algn="l"/>
             <a:r>
-              <a:rPr sz="1650" b="0" i="0">
+              <a:rPr sz="1700" b="0" i="0">
                 <a:solidFill>
                   <a:srgbClr val="374151"/>
                 </a:solidFill>
                 <a:latin typeface="Inter"/>
               </a:rPr>
-              <a:t>Enterprise drones cost over $50,000 each</a:t>
+              <a:t>Military drones cost over $50,000 each</a:t>
             </a:r>
           </a:p>
         </p:txBody>
@@ -9575,21 +9575,56 @@
                 </a:solidFill>
                 <a:latin typeface="JetBrains Mono"/>
               </a:rPr>
-              <a:t>OFFICIAL RESEARCH &amp; AUDIT SOURCES</a:t>
-            </a:r>
-          </a:p>
-        </p:txBody>
-      </p:sp>
-      <p:sp>
-        <p:nvSpPr>
-          <p:cNvPr id="58" name="Rounded Rectangle 57"/>
+              <a:t>OFFICIAL EVIDENCE &amp; AUDITS</a:t>
+            </a:r>
+          </a:p>
+        </p:txBody>
+      </p:sp>
+      <p:sp>
+        <p:nvSpPr>
+          <p:cNvPr id="58" name="TextBox 57"/>
+          <p:cNvSpPr txBox="1"/>
+          <p:nvPr/>
+        </p:nvSpPr>
+        <p:spPr>
+          <a:xfrm>
+            <a:off x="9875520" y="1371600"/>
+            <a:ext cx="1554480" cy="228600"/>
+          </a:xfrm>
+          <a:prstGeom prst="rect">
+            <a:avLst/>
+          </a:prstGeom>
+          <a:noFill/>
+        </p:spPr>
+        <p:txBody>
+          <a:bodyPr wrap="square" lIns="0" tIns="0" rIns="0" bIns="0">
+            <a:spAutoFit/>
+          </a:bodyPr>
+          <a:lstStyle/>
+          <a:p>
+            <a:pPr algn="r"/>
+            <a:r>
+              <a:rPr sz="850" b="1" i="0">
+                <a:solidFill>
+                  <a:srgbClr val="64748B"/>
+                </a:solidFill>
+                <a:latin typeface="JetBrains Mono"/>
+              </a:rPr>
+              <a:t>SOURCE 01 / 03</a:t>
+            </a:r>
+          </a:p>
+        </p:txBody>
+      </p:sp>
+      <p:sp>
+        <p:nvSpPr>
+          <p:cNvPr id="59" name="Rounded Rectangle 58"/>
           <p:cNvSpPr/>
           <p:nvPr/>
         </p:nvSpPr>
         <p:spPr>
           <a:xfrm>
             <a:off x="7498079" y="1691640"/>
-            <a:ext cx="3931920" cy="1170432"/>
+            <a:ext cx="3931920" cy="3474720"/>
           </a:xfrm>
           <a:prstGeom prst="roundRect">
             <a:avLst/>
@@ -9627,20 +9662,20 @@
       </p:sp>
       <p:sp>
         <p:nvSpPr>
-          <p:cNvPr id="59" name="Rounded Rectangle 58"/>
-          <p:cNvSpPr/>
-          <p:nvPr/>
-        </p:nvSpPr>
-        <p:spPr>
-          <a:xfrm>
-            <a:off x="7635240" y="1783080"/>
-            <a:ext cx="1280160" cy="182880"/>
+          <p:cNvPr id="60" name="Rounded Rectangle 59"/>
+          <p:cNvSpPr/>
+          <p:nvPr/>
+        </p:nvSpPr>
+        <p:spPr>
+          <a:xfrm>
+            <a:off x="10789920" y="1536192"/>
+            <a:ext cx="228600" cy="502920"/>
           </a:xfrm>
           <a:prstGeom prst="roundRect">
             <a:avLst/>
           </a:prstGeom>
           <a:solidFill>
-            <a:srgbClr val="0A1628"/>
+            <a:srgbClr val="475569"/>
           </a:solidFill>
           <a:ln>
             <a:noFill/>
@@ -9670,14 +9705,57 @@
       </p:sp>
       <p:sp>
         <p:nvSpPr>
-          <p:cNvPr id="60" name="TextBox 59"/>
+          <p:cNvPr id="61" name="Rounded Rectangle 60"/>
+          <p:cNvSpPr/>
+          <p:nvPr/>
+        </p:nvSpPr>
+        <p:spPr>
+          <a:xfrm>
+            <a:off x="7726679" y="1920240"/>
+            <a:ext cx="1645920" cy="219456"/>
+          </a:xfrm>
+          <a:prstGeom prst="roundRect">
+            <a:avLst/>
+          </a:prstGeom>
+          <a:solidFill>
+            <a:srgbClr val="0A1628"/>
+          </a:solidFill>
+          <a:ln>
+            <a:noFill/>
+          </a:ln>
+        </p:spPr>
+        <p:style>
+          <a:lnRef idx="1">
+            <a:schemeClr val="accent1"/>
+          </a:lnRef>
+          <a:fillRef idx="3">
+            <a:schemeClr val="accent1"/>
+          </a:fillRef>
+          <a:effectRef idx="2">
+            <a:schemeClr val="accent1"/>
+          </a:effectRef>
+          <a:fontRef idx="minor">
+            <a:schemeClr val="lt1"/>
+          </a:fontRef>
+        </p:style>
+        <p:txBody>
+          <a:bodyPr rtlCol="0" anchor="ctr"/>
+          <a:lstStyle/>
+          <a:p>
+            <a:pPr algn="ctr"/>
+          </a:p>
+        </p:txBody>
+      </p:sp>
+      <p:sp>
+        <p:nvSpPr>
+          <p:cNvPr id="62" name="TextBox 61"/>
           <p:cNvSpPr txBox="1"/>
           <p:nvPr/>
         </p:nvSpPr>
         <p:spPr>
           <a:xfrm>
-            <a:off x="7635240" y="1792224"/>
-            <a:ext cx="1280160" cy="164592"/>
+            <a:off x="7726679" y="1938528"/>
+            <a:ext cx="1645920" cy="201168"/>
           </a:xfrm>
           <a:prstGeom prst="rect">
             <a:avLst/>
@@ -9692,27 +9770,27 @@
           <a:p>
             <a:pPr algn="ctr"/>
             <a:r>
-              <a:rPr sz="650" b="1" i="0">
+              <a:rPr sz="700" b="1" i="0">
                 <a:solidFill>
                   <a:srgbClr val="FFFFFF"/>
                 </a:solidFill>
                 <a:latin typeface="JetBrains Mono"/>
               </a:rPr>
-              <a:t>NDMA FIELD AUDIT</a:t>
-            </a:r>
-          </a:p>
-        </p:txBody>
-      </p:sp>
-      <p:sp>
-        <p:nvSpPr>
-          <p:cNvPr id="61" name="TextBox 60"/>
+              <a:t>GOVT DISASTER AUDIT</a:t>
+            </a:r>
+          </a:p>
+        </p:txBody>
+      </p:sp>
+      <p:sp>
+        <p:nvSpPr>
+          <p:cNvPr id="63" name="TextBox 62"/>
           <p:cNvSpPr txBox="1"/>
           <p:nvPr/>
         </p:nvSpPr>
         <p:spPr>
           <a:xfrm>
-            <a:off x="9144000" y="1792224"/>
-            <a:ext cx="2194560" cy="164592"/>
+            <a:off x="9509760" y="1938528"/>
+            <a:ext cx="1737360" cy="201168"/>
           </a:xfrm>
           <a:prstGeom prst="rect">
             <a:avLst/>
@@ -9727,27 +9805,27 @@
           <a:p>
             <a:pPr algn="r"/>
             <a:r>
-              <a:rPr sz="700" b="0" i="0">
+              <a:rPr sz="750" b="0" i="0">
                 <a:solidFill>
                   <a:srgbClr val="94A3B8"/>
                 </a:solidFill>
                 <a:latin typeface="JetBrains Mono"/>
               </a:rPr>
-              <a:t>DISASTER REPORT</a:t>
-            </a:r>
-          </a:p>
-        </p:txBody>
-      </p:sp>
-      <p:sp>
-        <p:nvSpPr>
-          <p:cNvPr id="62" name="TextBox 61"/>
+              <a:t>NDMA REPORT</a:t>
+            </a:r>
+          </a:p>
+        </p:txBody>
+      </p:sp>
+      <p:sp>
+        <p:nvSpPr>
+          <p:cNvPr id="64" name="TextBox 63"/>
           <p:cNvSpPr txBox="1"/>
           <p:nvPr/>
         </p:nvSpPr>
         <p:spPr>
           <a:xfrm>
-            <a:off x="7635240" y="2011680"/>
-            <a:ext cx="3657600" cy="228600"/>
+            <a:off x="7726679" y="2240280"/>
+            <a:ext cx="3474720" cy="502920"/>
           </a:xfrm>
           <a:prstGeom prst="rect">
             <a:avLst/>
@@ -9762,27 +9840,107 @@
           <a:p>
             <a:pPr algn="l"/>
             <a:r>
-              <a:rPr sz="950" b="1" i="0">
+              <a:rPr sz="1200" b="1" i="0">
                 <a:solidFill>
                   <a:srgbClr val="000000"/>
                 </a:solidFill>
                 <a:latin typeface="Plus Jakarta Sans"/>
               </a:rPr>
-              <a:t>Wayanad &amp; Kedarnath Disaster Review</a:t>
-            </a:r>
-          </a:p>
-        </p:txBody>
-      </p:sp>
-      <p:sp>
-        <p:nvSpPr>
-          <p:cNvPr id="63" name="TextBox 62"/>
+              <a:t>70% of single drones failed in mountain rescue operations.</a:t>
+            </a:r>
+          </a:p>
+        </p:txBody>
+      </p:sp>
+      <p:sp>
+        <p:nvSpPr>
+          <p:cNvPr id="65" name="Rounded Rectangle 64"/>
+          <p:cNvSpPr/>
+          <p:nvPr/>
+        </p:nvSpPr>
+        <p:spPr>
+          <a:xfrm>
+            <a:off x="7726679" y="2834640"/>
+            <a:ext cx="3474720" cy="1371600"/>
+          </a:xfrm>
+          <a:prstGeom prst="roundRect">
+            <a:avLst/>
+          </a:prstGeom>
+          <a:solidFill>
+            <a:srgbClr val="FFFFFF"/>
+          </a:solidFill>
+          <a:ln w="12700">
+            <a:solidFill>
+              <a:srgbClr val="E2E8F0"/>
+            </a:solidFill>
+          </a:ln>
+        </p:spPr>
+        <p:style>
+          <a:lnRef idx="1">
+            <a:schemeClr val="accent1"/>
+          </a:lnRef>
+          <a:fillRef idx="3">
+            <a:schemeClr val="accent1"/>
+          </a:fillRef>
+          <a:effectRef idx="2">
+            <a:schemeClr val="accent1"/>
+          </a:effectRef>
+          <a:fontRef idx="minor">
+            <a:schemeClr val="lt1"/>
+          </a:fontRef>
+        </p:style>
+        <p:txBody>
+          <a:bodyPr rtlCol="0" anchor="ctr"/>
+          <a:lstStyle/>
+          <a:p>
+            <a:pPr algn="ctr"/>
+          </a:p>
+        </p:txBody>
+      </p:sp>
+      <p:sp>
+        <p:nvSpPr>
+          <p:cNvPr id="66" name="TextBox 65"/>
           <p:cNvSpPr txBox="1"/>
           <p:nvPr/>
         </p:nvSpPr>
         <p:spPr>
           <a:xfrm>
-            <a:off x="7635240" y="2258568"/>
-            <a:ext cx="3657600" cy="548640"/>
+            <a:off x="7863840" y="2926080"/>
+            <a:ext cx="3200400" cy="1188720"/>
+          </a:xfrm>
+          <a:prstGeom prst="rect">
+            <a:avLst/>
+          </a:prstGeom>
+          <a:noFill/>
+        </p:spPr>
+        <p:txBody>
+          <a:bodyPr wrap="square" lIns="0" tIns="0" rIns="0" bIns="0">
+            <a:spAutoFit/>
+          </a:bodyPr>
+          <a:lstStyle/>
+          <a:p>
+            <a:pPr algn="l"/>
+            <a:r>
+              <a:rPr sz="950" b="0" i="1">
+                <a:solidFill>
+                  <a:srgbClr val="374151"/>
+                </a:solidFill>
+                <a:latin typeface="Inter"/>
+              </a:rPr>
+              <a:t>“In the Kedarnath and Wayanad rescue missions, single commercial drones lost connection behind ridges and crashed under thick tree canopy.”</a:t>
+            </a:r>
+          </a:p>
+        </p:txBody>
+      </p:sp>
+      <p:sp>
+        <p:nvSpPr>
+          <p:cNvPr id="67" name="TextBox 66"/>
+          <p:cNvSpPr txBox="1"/>
+          <p:nvPr/>
+        </p:nvSpPr>
+        <p:spPr>
+          <a:xfrm>
+            <a:off x="7726679" y="4389120"/>
+            <a:ext cx="2011680" cy="274320"/>
           </a:xfrm>
           <a:prstGeom prst="rect">
             <a:avLst/>
@@ -9801,111 +9959,23 @@
                 <a:solidFill>
                   <a:srgbClr val="64748B"/>
                 </a:solidFill>
-                <a:latin typeface="Inter"/>
+                <a:latin typeface="JetBrains Mono"/>
               </a:rPr>
-              <a:t>Over 70% of single commercial UAV flights stalled due to mountain multipath and deep valley RF link loss.</a:t>
-            </a:r>
-          </a:p>
-        </p:txBody>
-      </p:sp>
-      <p:sp>
-        <p:nvSpPr>
-          <p:cNvPr id="64" name="Rounded Rectangle 63"/>
-          <p:cNvSpPr/>
-          <p:nvPr/>
-        </p:nvSpPr>
-        <p:spPr>
-          <a:xfrm>
-            <a:off x="7498079" y="3026664"/>
-            <a:ext cx="3931920" cy="1170432"/>
-          </a:xfrm>
-          <a:prstGeom prst="roundRect">
-            <a:avLst/>
-          </a:prstGeom>
-          <a:solidFill>
-            <a:srgbClr val="F8FAFC"/>
-          </a:solidFill>
-          <a:ln w="12700">
-            <a:solidFill>
-              <a:srgbClr val="E2E8F0"/>
-            </a:solidFill>
-          </a:ln>
-        </p:spPr>
-        <p:style>
-          <a:lnRef idx="1">
-            <a:schemeClr val="accent1"/>
-          </a:lnRef>
-          <a:fillRef idx="3">
-            <a:schemeClr val="accent1"/>
-          </a:fillRef>
-          <a:effectRef idx="2">
-            <a:schemeClr val="accent1"/>
-          </a:effectRef>
-          <a:fontRef idx="minor">
-            <a:schemeClr val="lt1"/>
-          </a:fontRef>
-        </p:style>
-        <p:txBody>
-          <a:bodyPr rtlCol="0" anchor="ctr"/>
-          <a:lstStyle/>
-          <a:p>
-            <a:pPr algn="ctr"/>
-          </a:p>
-        </p:txBody>
-      </p:sp>
-      <p:sp>
-        <p:nvSpPr>
-          <p:cNvPr id="65" name="Rounded Rectangle 64"/>
-          <p:cNvSpPr/>
-          <p:nvPr/>
-        </p:nvSpPr>
-        <p:spPr>
-          <a:xfrm>
-            <a:off x="7635240" y="3118104"/>
-            <a:ext cx="1280160" cy="182880"/>
-          </a:xfrm>
-          <a:prstGeom prst="roundRect">
-            <a:avLst/>
-          </a:prstGeom>
-          <a:solidFill>
-            <a:srgbClr val="000000"/>
-          </a:solidFill>
-          <a:ln>
-            <a:noFill/>
-          </a:ln>
-        </p:spPr>
-        <p:style>
-          <a:lnRef idx="1">
-            <a:schemeClr val="accent1"/>
-          </a:lnRef>
-          <a:fillRef idx="3">
-            <a:schemeClr val="accent1"/>
-          </a:fillRef>
-          <a:effectRef idx="2">
-            <a:schemeClr val="accent1"/>
-          </a:effectRef>
-          <a:fontRef idx="minor">
-            <a:schemeClr val="lt1"/>
-          </a:fontRef>
-        </p:style>
-        <p:txBody>
-          <a:bodyPr rtlCol="0" anchor="ctr"/>
-          <a:lstStyle/>
-          <a:p>
-            <a:pPr algn="ctr"/>
-          </a:p>
-        </p:txBody>
-      </p:sp>
-      <p:sp>
-        <p:nvSpPr>
-          <p:cNvPr id="66" name="TextBox 65"/>
+              <a:t>Ref: NDMA Field Review</a:t>
+            </a:r>
+          </a:p>
+        </p:txBody>
+      </p:sp>
+      <p:sp>
+        <p:nvSpPr>
+          <p:cNvPr id="68" name="TextBox 67"/>
           <p:cNvSpPr txBox="1"/>
           <p:nvPr/>
         </p:nvSpPr>
         <p:spPr>
           <a:xfrm>
-            <a:off x="7635240" y="3127248"/>
-            <a:ext cx="1280160" cy="164592"/>
+            <a:off x="9738360" y="4389120"/>
+            <a:ext cx="1463040" cy="274320"/>
           </a:xfrm>
           <a:prstGeom prst="rect">
             <a:avLst/>
@@ -9918,29 +9988,158 @@
           </a:bodyPr>
           <a:lstStyle/>
           <a:p>
-            <a:pPr algn="ctr"/>
-            <a:r>
-              <a:rPr sz="650" b="1" i="0">
+            <a:pPr algn="r"/>
+            <a:r>
+              <a:rPr sz="800" b="1" i="0">
                 <a:solidFill>
-                  <a:srgbClr val="FFFFFF"/>
+                  <a:srgbClr val="047857"/>
                 </a:solidFill>
                 <a:latin typeface="JetBrains Mono"/>
               </a:rPr>
-              <a:t>IEEE RESEARCH</a:t>
-            </a:r>
-          </a:p>
-        </p:txBody>
-      </p:sp>
-      <p:sp>
-        <p:nvSpPr>
-          <p:cNvPr id="67" name="TextBox 66"/>
+              <a:t>✓ VERIFIED RECORD</a:t>
+            </a:r>
+          </a:p>
+        </p:txBody>
+      </p:sp>
+      <p:sp>
+        <p:nvSpPr>
+          <p:cNvPr id="69" name="Rounded Rectangle 68"/>
+          <p:cNvSpPr/>
+          <p:nvPr/>
+        </p:nvSpPr>
+        <p:spPr>
+          <a:xfrm>
+            <a:off x="7498079" y="5303520"/>
+            <a:ext cx="548640" cy="73152"/>
+          </a:xfrm>
+          <a:prstGeom prst="roundRect">
+            <a:avLst/>
+          </a:prstGeom>
+          <a:solidFill>
+            <a:srgbClr val="000000"/>
+          </a:solidFill>
+          <a:ln>
+            <a:noFill/>
+          </a:ln>
+        </p:spPr>
+        <p:style>
+          <a:lnRef idx="1">
+            <a:schemeClr val="accent1"/>
+          </a:lnRef>
+          <a:fillRef idx="3">
+            <a:schemeClr val="accent1"/>
+          </a:fillRef>
+          <a:effectRef idx="2">
+            <a:schemeClr val="accent1"/>
+          </a:effectRef>
+          <a:fontRef idx="minor">
+            <a:schemeClr val="lt1"/>
+          </a:fontRef>
+        </p:style>
+        <p:txBody>
+          <a:bodyPr rtlCol="0" anchor="ctr"/>
+          <a:lstStyle/>
+          <a:p>
+            <a:pPr algn="ctr"/>
+          </a:p>
+        </p:txBody>
+      </p:sp>
+      <p:sp>
+        <p:nvSpPr>
+          <p:cNvPr id="70" name="Rounded Rectangle 69"/>
+          <p:cNvSpPr/>
+          <p:nvPr/>
+        </p:nvSpPr>
+        <p:spPr>
+          <a:xfrm>
+            <a:off x="8138160" y="5303520"/>
+            <a:ext cx="109728" cy="73152"/>
+          </a:xfrm>
+          <a:prstGeom prst="roundRect">
+            <a:avLst/>
+          </a:prstGeom>
+          <a:solidFill>
+            <a:srgbClr val="E2E8F0"/>
+          </a:solidFill>
+          <a:ln>
+            <a:noFill/>
+          </a:ln>
+        </p:spPr>
+        <p:style>
+          <a:lnRef idx="1">
+            <a:schemeClr val="accent1"/>
+          </a:lnRef>
+          <a:fillRef idx="3">
+            <a:schemeClr val="accent1"/>
+          </a:fillRef>
+          <a:effectRef idx="2">
+            <a:schemeClr val="accent1"/>
+          </a:effectRef>
+          <a:fontRef idx="minor">
+            <a:schemeClr val="lt1"/>
+          </a:fontRef>
+        </p:style>
+        <p:txBody>
+          <a:bodyPr rtlCol="0" anchor="ctr"/>
+          <a:lstStyle/>
+          <a:p>
+            <a:pPr algn="ctr"/>
+          </a:p>
+        </p:txBody>
+      </p:sp>
+      <p:sp>
+        <p:nvSpPr>
+          <p:cNvPr id="71" name="Rounded Rectangle 70"/>
+          <p:cNvSpPr/>
+          <p:nvPr/>
+        </p:nvSpPr>
+        <p:spPr>
+          <a:xfrm>
+            <a:off x="8321040" y="5303520"/>
+            <a:ext cx="109728" cy="73152"/>
+          </a:xfrm>
+          <a:prstGeom prst="roundRect">
+            <a:avLst/>
+          </a:prstGeom>
+          <a:solidFill>
+            <a:srgbClr val="E2E8F0"/>
+          </a:solidFill>
+          <a:ln>
+            <a:noFill/>
+          </a:ln>
+        </p:spPr>
+        <p:style>
+          <a:lnRef idx="1">
+            <a:schemeClr val="accent1"/>
+          </a:lnRef>
+          <a:fillRef idx="3">
+            <a:schemeClr val="accent1"/>
+          </a:fillRef>
+          <a:effectRef idx="2">
+            <a:schemeClr val="accent1"/>
+          </a:effectRef>
+          <a:fontRef idx="minor">
+            <a:schemeClr val="lt1"/>
+          </a:fontRef>
+        </p:style>
+        <p:txBody>
+          <a:bodyPr rtlCol="0" anchor="ctr"/>
+          <a:lstStyle/>
+          <a:p>
+            <a:pPr algn="ctr"/>
+          </a:p>
+        </p:txBody>
+      </p:sp>
+      <p:sp>
+        <p:nvSpPr>
+          <p:cNvPr id="72" name="TextBox 71"/>
           <p:cNvSpPr txBox="1"/>
           <p:nvPr/>
         </p:nvSpPr>
         <p:spPr>
           <a:xfrm>
-            <a:off x="9144000" y="3127248"/>
-            <a:ext cx="2194560" cy="164592"/>
+            <a:off x="9144000" y="5230368"/>
+            <a:ext cx="2286000" cy="228600"/>
           </a:xfrm>
           <a:prstGeom prst="rect">
             <a:avLst/>
@@ -9955,148 +10154,33 @@
           <a:p>
             <a:pPr algn="r"/>
             <a:r>
-              <a:rPr sz="700" b="0" i="0">
+              <a:rPr sz="750" b="0" i="0">
                 <a:solidFill>
                   <a:srgbClr val="94A3B8"/>
                 </a:solidFill>
                 <a:latin typeface="JetBrains Mono"/>
               </a:rPr>
-              <a:t>DOI: 10.1109/TCCN</a:t>
-            </a:r>
-          </a:p>
-        </p:txBody>
-      </p:sp>
-      <p:sp>
-        <p:nvSpPr>
-          <p:cNvPr id="68" name="TextBox 67"/>
-          <p:cNvSpPr txBox="1"/>
-          <p:nvPr/>
-        </p:nvSpPr>
-        <p:spPr>
-          <a:xfrm>
-            <a:off x="7635240" y="3346704"/>
-            <a:ext cx="3657600" cy="228600"/>
-          </a:xfrm>
-          <a:prstGeom prst="rect">
-            <a:avLst/>
-          </a:prstGeom>
-          <a:noFill/>
-        </p:spPr>
-        <p:txBody>
-          <a:bodyPr wrap="square" lIns="0" tIns="0" rIns="0" bIns="0">
-            <a:spAutoFit/>
-          </a:bodyPr>
-          <a:lstStyle/>
-          <a:p>
-            <a:pPr algn="l"/>
-            <a:r>
-              <a:rPr sz="950" b="1" i="0">
-                <a:solidFill>
-                  <a:srgbClr val="000000"/>
-                </a:solidFill>
-                <a:latin typeface="Plus Jakarta Sans"/>
-              </a:rPr>
-              <a:t>IEEE Trans. on Cognitive Comms (Bourtsoulatze)</a:t>
-            </a:r>
-          </a:p>
-        </p:txBody>
-      </p:sp>
-      <p:sp>
-        <p:nvSpPr>
-          <p:cNvPr id="69" name="TextBox 68"/>
-          <p:cNvSpPr txBox="1"/>
-          <p:nvPr/>
-        </p:nvSpPr>
-        <p:spPr>
-          <a:xfrm>
-            <a:off x="7635240" y="3593592"/>
-            <a:ext cx="3657600" cy="548640"/>
-          </a:xfrm>
-          <a:prstGeom prst="rect">
-            <a:avLst/>
-          </a:prstGeom>
-          <a:noFill/>
-        </p:spPr>
-        <p:txBody>
-          <a:bodyPr wrap="square" lIns="0" tIns="0" rIns="0" bIns="0">
-            <a:spAutoFit/>
-          </a:bodyPr>
-          <a:lstStyle/>
-          <a:p>
-            <a:pPr algn="l"/>
-            <a:r>
-              <a:rPr sz="800" b="0" i="0">
-                <a:solidFill>
-                  <a:srgbClr val="64748B"/>
-                </a:solidFill>
-                <a:latin typeface="Inter"/>
-              </a:rPr>
-              <a:t>Proves conventional H.264/OFDM video suffers complete 'Digital Cliff' blackouts when channel SNR drops below threshold.</a:t>
-            </a:r>
-          </a:p>
-        </p:txBody>
-      </p:sp>
-      <p:sp>
-        <p:nvSpPr>
-          <p:cNvPr id="70" name="Rounded Rectangle 69"/>
-          <p:cNvSpPr/>
-          <p:nvPr/>
-        </p:nvSpPr>
-        <p:spPr>
-          <a:xfrm>
-            <a:off x="7498079" y="4361688"/>
-            <a:ext cx="3931920" cy="1170432"/>
-          </a:xfrm>
-          <a:prstGeom prst="roundRect">
-            <a:avLst/>
-          </a:prstGeom>
-          <a:solidFill>
-            <a:srgbClr val="F8FAFC"/>
-          </a:solidFill>
-          <a:ln w="12700">
-            <a:solidFill>
-              <a:srgbClr val="E2E8F0"/>
-            </a:solidFill>
-          </a:ln>
-        </p:spPr>
-        <p:style>
-          <a:lnRef idx="1">
-            <a:schemeClr val="accent1"/>
-          </a:lnRef>
-          <a:fillRef idx="3">
-            <a:schemeClr val="accent1"/>
-          </a:fillRef>
-          <a:effectRef idx="2">
-            <a:schemeClr val="accent1"/>
-          </a:effectRef>
-          <a:fontRef idx="minor">
-            <a:schemeClr val="lt1"/>
-          </a:fontRef>
-        </p:style>
-        <p:txBody>
-          <a:bodyPr rtlCol="0" anchor="ctr"/>
-          <a:lstStyle/>
-          <a:p>
-            <a:pPr algn="ctr"/>
-          </a:p>
-        </p:txBody>
-      </p:sp>
-      <p:sp>
-        <p:nvSpPr>
-          <p:cNvPr id="71" name="Rounded Rectangle 70"/>
-          <p:cNvSpPr/>
-          <p:nvPr/>
-        </p:nvSpPr>
-        <p:spPr>
-          <a:xfrm>
-            <a:off x="7635240" y="4453128"/>
-            <a:ext cx="1280160" cy="182880"/>
-          </a:xfrm>
-          <a:prstGeom prst="roundRect">
-            <a:avLst/>
-          </a:prstGeom>
-          <a:solidFill>
-            <a:srgbClr val="047857"/>
+              <a:t>AUTO-ADVANCING 3.5S</a:t>
+            </a:r>
+          </a:p>
+        </p:txBody>
+      </p:sp>
+      <p:sp>
+        <p:nvSpPr>
+          <p:cNvPr id="73" name="Rectangle 72"/>
+          <p:cNvSpPr/>
+          <p:nvPr/>
+        </p:nvSpPr>
+        <p:spPr>
+          <a:xfrm>
+            <a:off x="731520" y="5943600"/>
+            <a:ext cx="10728655" cy="13716"/>
+          </a:xfrm>
+          <a:prstGeom prst="rect">
+            <a:avLst/>
+          </a:prstGeom>
+          <a:solidFill>
+            <a:srgbClr val="E2E8F0"/>
           </a:solidFill>
           <a:ln>
             <a:noFill/>
@@ -10126,190 +10210,7 @@
       </p:sp>
       <p:sp>
         <p:nvSpPr>
-          <p:cNvPr id="72" name="TextBox 71"/>
-          <p:cNvSpPr txBox="1"/>
-          <p:nvPr/>
-        </p:nvSpPr>
-        <p:spPr>
-          <a:xfrm>
-            <a:off x="7635240" y="4462272"/>
-            <a:ext cx="1280160" cy="164592"/>
-          </a:xfrm>
-          <a:prstGeom prst="rect">
-            <a:avLst/>
-          </a:prstGeom>
-          <a:noFill/>
-        </p:spPr>
-        <p:txBody>
-          <a:bodyPr wrap="square" lIns="0" tIns="0" rIns="0" bIns="0">
-            <a:spAutoFit/>
-          </a:bodyPr>
-          <a:lstStyle/>
-          <a:p>
-            <a:pPr algn="ctr"/>
-            <a:r>
-              <a:rPr sz="650" b="1" i="0">
-                <a:solidFill>
-                  <a:srgbClr val="FFFFFF"/>
-                </a:solidFill>
-                <a:latin typeface="JetBrains Mono"/>
-              </a:rPr>
-              <a:t>GOVT RTI AUDIT</a:t>
-            </a:r>
-          </a:p>
-        </p:txBody>
-      </p:sp>
-      <p:sp>
-        <p:nvSpPr>
-          <p:cNvPr id="73" name="TextBox 72"/>
-          <p:cNvSpPr txBox="1"/>
-          <p:nvPr/>
-        </p:nvSpPr>
-        <p:spPr>
-          <a:xfrm>
-            <a:off x="9144000" y="4462272"/>
-            <a:ext cx="2194560" cy="164592"/>
-          </a:xfrm>
-          <a:prstGeom prst="rect">
-            <a:avLst/>
-          </a:prstGeom>
-          <a:noFill/>
-        </p:spPr>
-        <p:txBody>
-          <a:bodyPr wrap="square" lIns="0" tIns="0" rIns="0" bIns="0">
-            <a:spAutoFit/>
-          </a:bodyPr>
-          <a:lstStyle/>
-          <a:p>
-            <a:pPr algn="r"/>
-            <a:r>
-              <a:rPr sz="700" b="0" i="0">
-                <a:solidFill>
-                  <a:srgbClr val="94A3B8"/>
-                </a:solidFill>
-                <a:latin typeface="JetBrains Mono"/>
-              </a:rPr>
-              <a:t>PROCUREMENT DATA</a:t>
-            </a:r>
-          </a:p>
-        </p:txBody>
-      </p:sp>
-      <p:sp>
-        <p:nvSpPr>
           <p:cNvPr id="74" name="TextBox 73"/>
-          <p:cNvSpPr txBox="1"/>
-          <p:nvPr/>
-        </p:nvSpPr>
-        <p:spPr>
-          <a:xfrm>
-            <a:off x="7635240" y="4681728"/>
-            <a:ext cx="3657600" cy="228600"/>
-          </a:xfrm>
-          <a:prstGeom prst="rect">
-            <a:avLst/>
-          </a:prstGeom>
-          <a:noFill/>
-        </p:spPr>
-        <p:txBody>
-          <a:bodyPr wrap="square" lIns="0" tIns="0" rIns="0" bIns="0">
-            <a:spAutoFit/>
-          </a:bodyPr>
-          <a:lstStyle/>
-          <a:p>
-            <a:pPr algn="l"/>
-            <a:r>
-              <a:rPr sz="950" b="1" i="0">
-                <a:solidFill>
-                  <a:srgbClr val="000000"/>
-                </a:solidFill>
-                <a:latin typeface="Plus Jakarta Sans"/>
-              </a:rPr>
-              <a:t>CAG Defense &amp; Security UAV Records</a:t>
-            </a:r>
-          </a:p>
-        </p:txBody>
-      </p:sp>
-      <p:sp>
-        <p:nvSpPr>
-          <p:cNvPr id="75" name="TextBox 74"/>
-          <p:cNvSpPr txBox="1"/>
-          <p:nvPr/>
-        </p:nvSpPr>
-        <p:spPr>
-          <a:xfrm>
-            <a:off x="7635240" y="4928616"/>
-            <a:ext cx="3657600" cy="548640"/>
-          </a:xfrm>
-          <a:prstGeom prst="rect">
-            <a:avLst/>
-          </a:prstGeom>
-          <a:noFill/>
-        </p:spPr>
-        <p:txBody>
-          <a:bodyPr wrap="square" lIns="0" tIns="0" rIns="0" bIns="0">
-            <a:spAutoFit/>
-          </a:bodyPr>
-          <a:lstStyle/>
-          <a:p>
-            <a:pPr algn="l"/>
-            <a:r>
-              <a:rPr sz="800" b="0" i="0">
-                <a:solidFill>
-                  <a:srgbClr val="64748B"/>
-                </a:solidFill>
-                <a:latin typeface="Inter"/>
-              </a:rPr>
-              <a:t>Enterprise reconnaissance drones cost $50,000–$250,000 each with single-GCS dependencies preventing multi-sq-km scaling.</a:t>
-            </a:r>
-          </a:p>
-        </p:txBody>
-      </p:sp>
-      <p:sp>
-        <p:nvSpPr>
-          <p:cNvPr id="76" name="Rectangle 75"/>
-          <p:cNvSpPr/>
-          <p:nvPr/>
-        </p:nvSpPr>
-        <p:spPr>
-          <a:xfrm>
-            <a:off x="731520" y="5943600"/>
-            <a:ext cx="10728655" cy="13716"/>
-          </a:xfrm>
-          <a:prstGeom prst="rect">
-            <a:avLst/>
-          </a:prstGeom>
-          <a:solidFill>
-            <a:srgbClr val="E2E8F0"/>
-          </a:solidFill>
-          <a:ln>
-            <a:noFill/>
-          </a:ln>
-        </p:spPr>
-        <p:style>
-          <a:lnRef idx="1">
-            <a:schemeClr val="accent1"/>
-          </a:lnRef>
-          <a:fillRef idx="3">
-            <a:schemeClr val="accent1"/>
-          </a:fillRef>
-          <a:effectRef idx="2">
-            <a:schemeClr val="accent1"/>
-          </a:effectRef>
-          <a:fontRef idx="minor">
-            <a:schemeClr val="lt1"/>
-          </a:fontRef>
-        </p:style>
-        <p:txBody>
-          <a:bodyPr rtlCol="0" anchor="ctr"/>
-          <a:lstStyle/>
-          <a:p>
-            <a:pPr algn="ctr"/>
-          </a:p>
-        </p:txBody>
-      </p:sp>
-      <p:sp>
-        <p:nvSpPr>
-          <p:cNvPr id="77" name="TextBox 76"/>
           <p:cNvSpPr txBox="1"/>
           <p:nvPr/>
         </p:nvSpPr>
@@ -10344,7 +10245,7 @@
       </p:sp>
       <p:sp>
         <p:nvSpPr>
-          <p:cNvPr id="78" name="TextBox 77"/>
+          <p:cNvPr id="75" name="TextBox 74"/>
           <p:cNvSpPr txBox="1"/>
           <p:nvPr/>
         </p:nvSpPr>

</xml_diff>

<commit_message>
feat(slides): implement smooth 3D stacked parallax transition for Slide 2 evidence cards
</commit_message>
<xml_diff>
--- a/sutra_pitch_deck.pptx
+++ b/sutra_pitch_deck.pptx
@@ -9623,14 +9623,14 @@
         </p:nvSpPr>
         <p:spPr>
           <a:xfrm>
-            <a:off x="7498079" y="1691640"/>
-            <a:ext cx="3931920" cy="3474720"/>
+            <a:off x="7680960" y="1920240"/>
+            <a:ext cx="3566160" cy="3108960"/>
           </a:xfrm>
           <a:prstGeom prst="roundRect">
             <a:avLst/>
           </a:prstGeom>
           <a:solidFill>
-            <a:srgbClr val="F8FAFC"/>
+            <a:srgbClr val="F1F5F9"/>
           </a:solidFill>
           <a:ln w="12700">
             <a:solidFill>
@@ -9668,6 +9668,96 @@
         </p:nvSpPr>
         <p:spPr>
           <a:xfrm>
+            <a:off x="7589520" y="1810512"/>
+            <a:ext cx="3749039" cy="3200400"/>
+          </a:xfrm>
+          <a:prstGeom prst="roundRect">
+            <a:avLst/>
+          </a:prstGeom>
+          <a:solidFill>
+            <a:srgbClr val="F8FAFC"/>
+          </a:solidFill>
+          <a:ln w="12700">
+            <a:solidFill>
+              <a:srgbClr val="E2E8F0"/>
+            </a:solidFill>
+          </a:ln>
+        </p:spPr>
+        <p:style>
+          <a:lnRef idx="1">
+            <a:schemeClr val="accent1"/>
+          </a:lnRef>
+          <a:fillRef idx="3">
+            <a:schemeClr val="accent1"/>
+          </a:fillRef>
+          <a:effectRef idx="2">
+            <a:schemeClr val="accent1"/>
+          </a:effectRef>
+          <a:fontRef idx="minor">
+            <a:schemeClr val="lt1"/>
+          </a:fontRef>
+        </p:style>
+        <p:txBody>
+          <a:bodyPr rtlCol="0" anchor="ctr"/>
+          <a:lstStyle/>
+          <a:p>
+            <a:pPr algn="ctr"/>
+          </a:p>
+        </p:txBody>
+      </p:sp>
+      <p:sp>
+        <p:nvSpPr>
+          <p:cNvPr id="61" name="Rounded Rectangle 60"/>
+          <p:cNvSpPr/>
+          <p:nvPr/>
+        </p:nvSpPr>
+        <p:spPr>
+          <a:xfrm>
+            <a:off x="7498079" y="1691640"/>
+            <a:ext cx="3931920" cy="3291840"/>
+          </a:xfrm>
+          <a:prstGeom prst="roundRect">
+            <a:avLst/>
+          </a:prstGeom>
+          <a:solidFill>
+            <a:srgbClr val="FFFFFF"/>
+          </a:solidFill>
+          <a:ln w="12700">
+            <a:solidFill>
+              <a:srgbClr val="E2E8F0"/>
+            </a:solidFill>
+          </a:ln>
+        </p:spPr>
+        <p:style>
+          <a:lnRef idx="1">
+            <a:schemeClr val="accent1"/>
+          </a:lnRef>
+          <a:fillRef idx="3">
+            <a:schemeClr val="accent1"/>
+          </a:fillRef>
+          <a:effectRef idx="2">
+            <a:schemeClr val="accent1"/>
+          </a:effectRef>
+          <a:fontRef idx="minor">
+            <a:schemeClr val="lt1"/>
+          </a:fontRef>
+        </p:style>
+        <p:txBody>
+          <a:bodyPr rtlCol="0" anchor="ctr"/>
+          <a:lstStyle/>
+          <a:p>
+            <a:pPr algn="ctr"/>
+          </a:p>
+        </p:txBody>
+      </p:sp>
+      <p:sp>
+        <p:nvSpPr>
+          <p:cNvPr id="62" name="Rounded Rectangle 61"/>
+          <p:cNvSpPr/>
+          <p:nvPr/>
+        </p:nvSpPr>
+        <p:spPr>
+          <a:xfrm>
             <a:off x="10789920" y="1536192"/>
             <a:ext cx="228600" cy="502920"/>
           </a:xfrm>
@@ -9705,7 +9795,7 @@
       </p:sp>
       <p:sp>
         <p:nvSpPr>
-          <p:cNvPr id="61" name="Rounded Rectangle 60"/>
+          <p:cNvPr id="63" name="Rounded Rectangle 62"/>
           <p:cNvSpPr/>
           <p:nvPr/>
         </p:nvSpPr>
@@ -9748,7 +9838,7 @@
       </p:sp>
       <p:sp>
         <p:nvSpPr>
-          <p:cNvPr id="62" name="TextBox 61"/>
+          <p:cNvPr id="64" name="TextBox 63"/>
           <p:cNvSpPr txBox="1"/>
           <p:nvPr/>
         </p:nvSpPr>
@@ -9783,7 +9873,7 @@
       </p:sp>
       <p:sp>
         <p:nvSpPr>
-          <p:cNvPr id="63" name="TextBox 62"/>
+          <p:cNvPr id="65" name="TextBox 64"/>
           <p:cNvSpPr txBox="1"/>
           <p:nvPr/>
         </p:nvSpPr>
@@ -9818,7 +9908,7 @@
       </p:sp>
       <p:sp>
         <p:nvSpPr>
-          <p:cNvPr id="64" name="TextBox 63"/>
+          <p:cNvPr id="66" name="TextBox 65"/>
           <p:cNvSpPr txBox="1"/>
           <p:nvPr/>
         </p:nvSpPr>
@@ -9853,20 +9943,20 @@
       </p:sp>
       <p:sp>
         <p:nvSpPr>
-          <p:cNvPr id="65" name="Rounded Rectangle 64"/>
+          <p:cNvPr id="67" name="Rounded Rectangle 66"/>
           <p:cNvSpPr/>
           <p:nvPr/>
         </p:nvSpPr>
         <p:spPr>
           <a:xfrm>
             <a:off x="7726679" y="2834640"/>
-            <a:ext cx="3474720" cy="1371600"/>
+            <a:ext cx="3474720" cy="1280160"/>
           </a:xfrm>
           <a:prstGeom prst="roundRect">
             <a:avLst/>
           </a:prstGeom>
           <a:solidFill>
-            <a:srgbClr val="FFFFFF"/>
+            <a:srgbClr val="F8FAFC"/>
           </a:solidFill>
           <a:ln w="12700">
             <a:solidFill>
@@ -9898,14 +9988,14 @@
       </p:sp>
       <p:sp>
         <p:nvSpPr>
-          <p:cNvPr id="66" name="TextBox 65"/>
+          <p:cNvPr id="68" name="TextBox 67"/>
           <p:cNvSpPr txBox="1"/>
           <p:nvPr/>
         </p:nvSpPr>
         <p:spPr>
           <a:xfrm>
             <a:off x="7863840" y="2926080"/>
-            <a:ext cx="3200400" cy="1188720"/>
+            <a:ext cx="3200400" cy="1097280"/>
           </a:xfrm>
           <a:prstGeom prst="rect">
             <a:avLst/>
@@ -9933,13 +10023,13 @@
       </p:sp>
       <p:sp>
         <p:nvSpPr>
-          <p:cNvPr id="67" name="TextBox 66"/>
+          <p:cNvPr id="69" name="TextBox 68"/>
           <p:cNvSpPr txBox="1"/>
           <p:nvPr/>
         </p:nvSpPr>
         <p:spPr>
           <a:xfrm>
-            <a:off x="7726679" y="4389120"/>
+            <a:off x="7726679" y="4297680"/>
             <a:ext cx="2011680" cy="274320"/>
           </a:xfrm>
           <a:prstGeom prst="rect">
@@ -9968,13 +10058,13 @@
       </p:sp>
       <p:sp>
         <p:nvSpPr>
-          <p:cNvPr id="68" name="TextBox 67"/>
+          <p:cNvPr id="70" name="TextBox 69"/>
           <p:cNvSpPr txBox="1"/>
           <p:nvPr/>
         </p:nvSpPr>
         <p:spPr>
           <a:xfrm>
-            <a:off x="9738360" y="4389120"/>
+            <a:off x="9738360" y="4297680"/>
             <a:ext cx="1463040" cy="274320"/>
           </a:xfrm>
           <a:prstGeom prst="rect">
@@ -10003,7 +10093,7 @@
       </p:sp>
       <p:sp>
         <p:nvSpPr>
-          <p:cNvPr id="69" name="Rounded Rectangle 68"/>
+          <p:cNvPr id="71" name="Rounded Rectangle 70"/>
           <p:cNvSpPr/>
           <p:nvPr/>
         </p:nvSpPr>
@@ -10046,7 +10136,7 @@
       </p:sp>
       <p:sp>
         <p:nvSpPr>
-          <p:cNvPr id="70" name="Rounded Rectangle 69"/>
+          <p:cNvPr id="72" name="Rounded Rectangle 71"/>
           <p:cNvSpPr/>
           <p:nvPr/>
         </p:nvSpPr>
@@ -10089,7 +10179,7 @@
       </p:sp>
       <p:sp>
         <p:nvSpPr>
-          <p:cNvPr id="71" name="Rounded Rectangle 70"/>
+          <p:cNvPr id="73" name="Rounded Rectangle 72"/>
           <p:cNvSpPr/>
           <p:nvPr/>
         </p:nvSpPr>
@@ -10132,7 +10222,7 @@
       </p:sp>
       <p:sp>
         <p:nvSpPr>
-          <p:cNvPr id="72" name="TextBox 71"/>
+          <p:cNvPr id="74" name="TextBox 73"/>
           <p:cNvSpPr txBox="1"/>
           <p:nvPr/>
         </p:nvSpPr>
@@ -10160,14 +10250,14 @@
                 </a:solidFill>
                 <a:latin typeface="JetBrains Mono"/>
               </a:rPr>
-              <a:t>AUTO-ADVANCING 3.5S</a:t>
-            </a:r>
-          </a:p>
-        </p:txBody>
-      </p:sp>
-      <p:sp>
-        <p:nvSpPr>
-          <p:cNvPr id="73" name="Rectangle 72"/>
+              <a:t>SMOOTH PARALLAX 3.5S</a:t>
+            </a:r>
+          </a:p>
+        </p:txBody>
+      </p:sp>
+      <p:sp>
+        <p:nvSpPr>
+          <p:cNvPr id="75" name="Rectangle 74"/>
           <p:cNvSpPr/>
           <p:nvPr/>
         </p:nvSpPr>
@@ -10210,7 +10300,7 @@
       </p:sp>
       <p:sp>
         <p:nvSpPr>
-          <p:cNvPr id="74" name="TextBox 73"/>
+          <p:cNvPr id="76" name="TextBox 75"/>
           <p:cNvSpPr txBox="1"/>
           <p:nvPr/>
         </p:nvSpPr>
@@ -10245,7 +10335,7 @@
       </p:sp>
       <p:sp>
         <p:nvSpPr>
-          <p:cNvPr id="75" name="TextBox 74"/>
+          <p:cNvPr id="77" name="TextBox 76"/>
           <p:cNvSpPr txBox="1"/>
           <p:nvPr/>
         </p:nvSpPr>

</xml_diff>

<commit_message>
feat(slides): add tactical schematic vector illustrations and update Slide 2 PowerPoint generator
</commit_message>
<xml_diff>
--- a/sutra_pitch_deck.pptx
+++ b/sutra_pitch_deck.pptx
@@ -9128,8 +9128,8 @@
         </p:nvSpPr>
         <p:spPr>
           <a:xfrm>
-            <a:off x="731520" y="1371600"/>
-            <a:ext cx="6400800" cy="1188720"/>
+            <a:off x="731520" y="1234440"/>
+            <a:ext cx="6400800" cy="1005840"/>
           </a:xfrm>
           <a:prstGeom prst="rect">
             <a:avLst/>
@@ -9144,7 +9144,7 @@
           <a:p>
             <a:pPr algn="l"/>
             <a:r>
-              <a:rPr sz="3200" b="1" i="0">
+              <a:rPr sz="2800" b="1" i="0">
                 <a:solidFill>
                   <a:srgbClr val="000000"/>
                 </a:solidFill>
@@ -9163,8 +9163,8 @@
         </p:nvSpPr>
         <p:spPr>
           <a:xfrm>
-            <a:off x="749808" y="2816352"/>
-            <a:ext cx="91440" cy="91440"/>
+            <a:off x="749808" y="2386584"/>
+            <a:ext cx="82296" cy="82296"/>
           </a:xfrm>
           <a:prstGeom prst="ellipse">
             <a:avLst/>
@@ -9206,8 +9206,8 @@
         </p:nvSpPr>
         <p:spPr>
           <a:xfrm>
-            <a:off x="960120" y="2743200"/>
-            <a:ext cx="6217920" cy="411480"/>
+            <a:off x="932688" y="2331720"/>
+            <a:ext cx="6217920" cy="365760"/>
           </a:xfrm>
           <a:prstGeom prst="rect">
             <a:avLst/>
@@ -9222,7 +9222,7 @@
           <a:p>
             <a:pPr algn="l"/>
             <a:r>
-              <a:rPr sz="1700" b="0" i="0">
+              <a:rPr sz="1500" b="0" i="0">
                 <a:solidFill>
                   <a:srgbClr val="374151"/>
                 </a:solidFill>
@@ -9241,8 +9241,8 @@
         </p:nvSpPr>
         <p:spPr>
           <a:xfrm>
-            <a:off x="749808" y="3364992"/>
-            <a:ext cx="91440" cy="91440"/>
+            <a:off x="749808" y="2825496"/>
+            <a:ext cx="82296" cy="82296"/>
           </a:xfrm>
           <a:prstGeom prst="ellipse">
             <a:avLst/>
@@ -9284,8 +9284,8 @@
         </p:nvSpPr>
         <p:spPr>
           <a:xfrm>
-            <a:off x="960120" y="3291840"/>
-            <a:ext cx="6217920" cy="411480"/>
+            <a:off x="932688" y="2770632"/>
+            <a:ext cx="6217920" cy="365760"/>
           </a:xfrm>
           <a:prstGeom prst="rect">
             <a:avLst/>
@@ -9300,7 +9300,7 @@
           <a:p>
             <a:pPr algn="l"/>
             <a:r>
-              <a:rPr sz="1700" b="0" i="0">
+              <a:rPr sz="1500" b="0" i="0">
                 <a:solidFill>
                   <a:srgbClr val="374151"/>
                 </a:solidFill>
@@ -9319,8 +9319,8 @@
         </p:nvSpPr>
         <p:spPr>
           <a:xfrm>
-            <a:off x="749808" y="3913632"/>
-            <a:ext cx="91440" cy="91440"/>
+            <a:off x="749808" y="3264408"/>
+            <a:ext cx="82296" cy="82296"/>
           </a:xfrm>
           <a:prstGeom prst="ellipse">
             <a:avLst/>
@@ -9362,8 +9362,8 @@
         </p:nvSpPr>
         <p:spPr>
           <a:xfrm>
-            <a:off x="960120" y="3840480"/>
-            <a:ext cx="6217920" cy="411480"/>
+            <a:off x="932688" y="3209544"/>
+            <a:ext cx="6217920" cy="365760"/>
           </a:xfrm>
           <a:prstGeom prst="rect">
             <a:avLst/>
@@ -9378,7 +9378,7 @@
           <a:p>
             <a:pPr algn="l"/>
             <a:r>
-              <a:rPr sz="1700" b="0" i="0">
+              <a:rPr sz="1500" b="0" i="0">
                 <a:solidFill>
                   <a:srgbClr val="374151"/>
                 </a:solidFill>
@@ -9397,8 +9397,8 @@
         </p:nvSpPr>
         <p:spPr>
           <a:xfrm>
-            <a:off x="749808" y="4462272"/>
-            <a:ext cx="91440" cy="91440"/>
+            <a:off x="749808" y="3703320"/>
+            <a:ext cx="82296" cy="82296"/>
           </a:xfrm>
           <a:prstGeom prst="ellipse">
             <a:avLst/>
@@ -9440,8 +9440,8 @@
         </p:nvSpPr>
         <p:spPr>
           <a:xfrm>
-            <a:off x="960120" y="4389120"/>
-            <a:ext cx="6217920" cy="411480"/>
+            <a:off x="932688" y="3648456"/>
+            <a:ext cx="6217920" cy="365760"/>
           </a:xfrm>
           <a:prstGeom prst="rect">
             <a:avLst/>
@@ -9456,7 +9456,7 @@
           <a:p>
             <a:pPr algn="l"/>
             <a:r>
-              <a:rPr sz="1700" b="0" i="0">
+              <a:rPr sz="1500" b="0" i="0">
                 <a:solidFill>
                   <a:srgbClr val="374151"/>
                 </a:solidFill>
@@ -9475,8 +9475,8 @@
         </p:nvSpPr>
         <p:spPr>
           <a:xfrm>
-            <a:off x="749808" y="5010912"/>
-            <a:ext cx="91440" cy="91440"/>
+            <a:off x="749808" y="4142232"/>
+            <a:ext cx="82296" cy="82296"/>
           </a:xfrm>
           <a:prstGeom prst="ellipse">
             <a:avLst/>
@@ -9518,8 +9518,8 @@
         </p:nvSpPr>
         <p:spPr>
           <a:xfrm>
-            <a:off x="960120" y="4937760"/>
-            <a:ext cx="6217920" cy="411480"/>
+            <a:off x="932688" y="4087368"/>
+            <a:ext cx="6217920" cy="365760"/>
           </a:xfrm>
           <a:prstGeom prst="rect">
             <a:avLst/>
@@ -9534,7 +9534,7 @@
           <a:p>
             <a:pPr algn="l"/>
             <a:r>
-              <a:rPr sz="1700" b="0" i="0">
+              <a:rPr sz="1500" b="0" i="0">
                 <a:solidFill>
                   <a:srgbClr val="374151"/>
                 </a:solidFill>
@@ -9553,7 +9553,387 @@
         </p:nvSpPr>
         <p:spPr>
           <a:xfrm>
-            <a:off x="7498079" y="1371600"/>
+            <a:off x="731520" y="4617720"/>
+            <a:ext cx="4572000" cy="182880"/>
+          </a:xfrm>
+          <a:prstGeom prst="rect">
+            <a:avLst/>
+          </a:prstGeom>
+          <a:noFill/>
+        </p:spPr>
+        <p:txBody>
+          <a:bodyPr wrap="square" lIns="0" tIns="0" rIns="0" bIns="0">
+            <a:spAutoFit/>
+          </a:bodyPr>
+          <a:lstStyle/>
+          <a:p>
+            <a:pPr algn="l"/>
+            <a:r>
+              <a:rPr sz="750" b="1" i="0">
+                <a:solidFill>
+                  <a:srgbClr val="94A3B8"/>
+                </a:solidFill>
+                <a:latin typeface="JetBrains Mono"/>
+              </a:rPr>
+              <a:t>TACTICAL FAILURE SCHEMATICS</a:t>
+            </a:r>
+          </a:p>
+        </p:txBody>
+      </p:sp>
+      <p:sp>
+        <p:nvSpPr>
+          <p:cNvPr id="58" name="Rounded Rectangle 57"/>
+          <p:cNvSpPr/>
+          <p:nvPr/>
+        </p:nvSpPr>
+        <p:spPr>
+          <a:xfrm>
+            <a:off x="731520" y="4846320"/>
+            <a:ext cx="2011680" cy="822960"/>
+          </a:xfrm>
+          <a:prstGeom prst="roundRect">
+            <a:avLst/>
+          </a:prstGeom>
+          <a:solidFill>
+            <a:srgbClr val="F8FAFC"/>
+          </a:solidFill>
+          <a:ln w="12700">
+            <a:solidFill>
+              <a:srgbClr val="E2E8F0"/>
+            </a:solidFill>
+          </a:ln>
+        </p:spPr>
+        <p:style>
+          <a:lnRef idx="1">
+            <a:schemeClr val="accent1"/>
+          </a:lnRef>
+          <a:fillRef idx="3">
+            <a:schemeClr val="accent1"/>
+          </a:fillRef>
+          <a:effectRef idx="2">
+            <a:schemeClr val="accent1"/>
+          </a:effectRef>
+          <a:fontRef idx="minor">
+            <a:schemeClr val="lt1"/>
+          </a:fontRef>
+        </p:style>
+        <p:txBody>
+          <a:bodyPr rtlCol="0" anchor="ctr"/>
+          <a:lstStyle/>
+          <a:p>
+            <a:pPr algn="ctr"/>
+          </a:p>
+        </p:txBody>
+      </p:sp>
+      <p:sp>
+        <p:nvSpPr>
+          <p:cNvPr id="59" name="TextBox 58"/>
+          <p:cNvSpPr txBox="1"/>
+          <p:nvPr/>
+        </p:nvSpPr>
+        <p:spPr>
+          <a:xfrm>
+            <a:off x="841248" y="4919472"/>
+            <a:ext cx="1792224" cy="228600"/>
+          </a:xfrm>
+          <a:prstGeom prst="rect">
+            <a:avLst/>
+          </a:prstGeom>
+          <a:noFill/>
+        </p:spPr>
+        <p:txBody>
+          <a:bodyPr wrap="square" lIns="0" tIns="0" rIns="0" bIns="0">
+            <a:spAutoFit/>
+          </a:bodyPr>
+          <a:lstStyle/>
+          <a:p>
+            <a:pPr algn="l"/>
+            <a:r>
+              <a:rPr sz="850" b="1" i="0">
+                <a:solidFill>
+                  <a:srgbClr val="000000"/>
+                </a:solidFill>
+                <a:latin typeface="Plus Jakarta Sans"/>
+              </a:rPr>
+              <a:t>RF Ridge Shadow</a:t>
+            </a:r>
+          </a:p>
+        </p:txBody>
+      </p:sp>
+      <p:sp>
+        <p:nvSpPr>
+          <p:cNvPr id="60" name="TextBox 59"/>
+          <p:cNvSpPr txBox="1"/>
+          <p:nvPr/>
+        </p:nvSpPr>
+        <p:spPr>
+          <a:xfrm>
+            <a:off x="841248" y="5138928"/>
+            <a:ext cx="1792224" cy="182880"/>
+          </a:xfrm>
+          <a:prstGeom prst="rect">
+            <a:avLst/>
+          </a:prstGeom>
+          <a:noFill/>
+        </p:spPr>
+        <p:txBody>
+          <a:bodyPr wrap="square" lIns="0" tIns="0" rIns="0" bIns="0">
+            <a:spAutoFit/>
+          </a:bodyPr>
+          <a:lstStyle/>
+          <a:p>
+            <a:pPr algn="l"/>
+            <a:r>
+              <a:rPr sz="700" b="0" i="0">
+                <a:solidFill>
+                  <a:srgbClr val="64748B"/>
+                </a:solidFill>
+                <a:latin typeface="JetBrains Mono"/>
+              </a:rPr>
+              <a:t>Video Stream Drop</a:t>
+            </a:r>
+          </a:p>
+        </p:txBody>
+      </p:sp>
+      <p:sp>
+        <p:nvSpPr>
+          <p:cNvPr id="61" name="Rounded Rectangle 60"/>
+          <p:cNvSpPr/>
+          <p:nvPr/>
+        </p:nvSpPr>
+        <p:spPr>
+          <a:xfrm>
+            <a:off x="2907792" y="4846320"/>
+            <a:ext cx="2011680" cy="822960"/>
+          </a:xfrm>
+          <a:prstGeom prst="roundRect">
+            <a:avLst/>
+          </a:prstGeom>
+          <a:solidFill>
+            <a:srgbClr val="F8FAFC"/>
+          </a:solidFill>
+          <a:ln w="12700">
+            <a:solidFill>
+              <a:srgbClr val="E2E8F0"/>
+            </a:solidFill>
+          </a:ln>
+        </p:spPr>
+        <p:style>
+          <a:lnRef idx="1">
+            <a:schemeClr val="accent1"/>
+          </a:lnRef>
+          <a:fillRef idx="3">
+            <a:schemeClr val="accent1"/>
+          </a:fillRef>
+          <a:effectRef idx="2">
+            <a:schemeClr val="accent1"/>
+          </a:effectRef>
+          <a:fontRef idx="minor">
+            <a:schemeClr val="lt1"/>
+          </a:fontRef>
+        </p:style>
+        <p:txBody>
+          <a:bodyPr rtlCol="0" anchor="ctr"/>
+          <a:lstStyle/>
+          <a:p>
+            <a:pPr algn="ctr"/>
+          </a:p>
+        </p:txBody>
+      </p:sp>
+      <p:sp>
+        <p:nvSpPr>
+          <p:cNvPr id="62" name="TextBox 61"/>
+          <p:cNvSpPr txBox="1"/>
+          <p:nvPr/>
+        </p:nvSpPr>
+        <p:spPr>
+          <a:xfrm>
+            <a:off x="3017520" y="4919472"/>
+            <a:ext cx="1792224" cy="228600"/>
+          </a:xfrm>
+          <a:prstGeom prst="rect">
+            <a:avLst/>
+          </a:prstGeom>
+          <a:noFill/>
+        </p:spPr>
+        <p:txBody>
+          <a:bodyPr wrap="square" lIns="0" tIns="0" rIns="0" bIns="0">
+            <a:spAutoFit/>
+          </a:bodyPr>
+          <a:lstStyle/>
+          <a:p>
+            <a:pPr algn="l"/>
+            <a:r>
+              <a:rPr sz="850" b="1" i="0">
+                <a:solidFill>
+                  <a:srgbClr val="000000"/>
+                </a:solidFill>
+                <a:latin typeface="Plus Jakarta Sans"/>
+              </a:rPr>
+              <a:t>Canopy Shadow</a:t>
+            </a:r>
+          </a:p>
+        </p:txBody>
+      </p:sp>
+      <p:sp>
+        <p:nvSpPr>
+          <p:cNvPr id="63" name="TextBox 62"/>
+          <p:cNvSpPr txBox="1"/>
+          <p:nvPr/>
+        </p:nvSpPr>
+        <p:spPr>
+          <a:xfrm>
+            <a:off x="3017520" y="5138928"/>
+            <a:ext cx="1792224" cy="182880"/>
+          </a:xfrm>
+          <a:prstGeom prst="rect">
+            <a:avLst/>
+          </a:prstGeom>
+          <a:noFill/>
+        </p:spPr>
+        <p:txBody>
+          <a:bodyPr wrap="square" lIns="0" tIns="0" rIns="0" bIns="0">
+            <a:spAutoFit/>
+          </a:bodyPr>
+          <a:lstStyle/>
+          <a:p>
+            <a:pPr algn="l"/>
+            <a:r>
+              <a:rPr sz="700" b="0" i="0">
+                <a:solidFill>
+                  <a:srgbClr val="64748B"/>
+                </a:solidFill>
+                <a:latin typeface="JetBrains Mono"/>
+              </a:rPr>
+              <a:t>GNSS Multi-Path</a:t>
+            </a:r>
+          </a:p>
+        </p:txBody>
+      </p:sp>
+      <p:sp>
+        <p:nvSpPr>
+          <p:cNvPr id="64" name="Rounded Rectangle 63"/>
+          <p:cNvSpPr/>
+          <p:nvPr/>
+        </p:nvSpPr>
+        <p:spPr>
+          <a:xfrm>
+            <a:off x="5084064" y="4846320"/>
+            <a:ext cx="2011680" cy="822960"/>
+          </a:xfrm>
+          <a:prstGeom prst="roundRect">
+            <a:avLst/>
+          </a:prstGeom>
+          <a:solidFill>
+            <a:srgbClr val="F8FAFC"/>
+          </a:solidFill>
+          <a:ln w="12700">
+            <a:solidFill>
+              <a:srgbClr val="E2E8F0"/>
+            </a:solidFill>
+          </a:ln>
+        </p:spPr>
+        <p:style>
+          <a:lnRef idx="1">
+            <a:schemeClr val="accent1"/>
+          </a:lnRef>
+          <a:fillRef idx="3">
+            <a:schemeClr val="accent1"/>
+          </a:fillRef>
+          <a:effectRef idx="2">
+            <a:schemeClr val="accent1"/>
+          </a:effectRef>
+          <a:fontRef idx="minor">
+            <a:schemeClr val="lt1"/>
+          </a:fontRef>
+        </p:style>
+        <p:txBody>
+          <a:bodyPr rtlCol="0" anchor="ctr"/>
+          <a:lstStyle/>
+          <a:p>
+            <a:pPr algn="ctr"/>
+          </a:p>
+        </p:txBody>
+      </p:sp>
+      <p:sp>
+        <p:nvSpPr>
+          <p:cNvPr id="65" name="TextBox 64"/>
+          <p:cNvSpPr txBox="1"/>
+          <p:nvPr/>
+        </p:nvSpPr>
+        <p:spPr>
+          <a:xfrm>
+            <a:off x="5193792" y="4919472"/>
+            <a:ext cx="1792224" cy="228600"/>
+          </a:xfrm>
+          <a:prstGeom prst="rect">
+            <a:avLst/>
+          </a:prstGeom>
+          <a:noFill/>
+        </p:spPr>
+        <p:txBody>
+          <a:bodyPr wrap="square" lIns="0" tIns="0" rIns="0" bIns="0">
+            <a:spAutoFit/>
+          </a:bodyPr>
+          <a:lstStyle/>
+          <a:p>
+            <a:pPr algn="l"/>
+            <a:r>
+              <a:rPr sz="850" b="1" i="0">
+                <a:solidFill>
+                  <a:srgbClr val="000000"/>
+                </a:solidFill>
+                <a:latin typeface="Plus Jakarta Sans"/>
+              </a:rPr>
+              <a:t>Central Link Loss</a:t>
+            </a:r>
+          </a:p>
+        </p:txBody>
+      </p:sp>
+      <p:sp>
+        <p:nvSpPr>
+          <p:cNvPr id="66" name="TextBox 65"/>
+          <p:cNvSpPr txBox="1"/>
+          <p:nvPr/>
+        </p:nvSpPr>
+        <p:spPr>
+          <a:xfrm>
+            <a:off x="5193792" y="5138928"/>
+            <a:ext cx="1792224" cy="182880"/>
+          </a:xfrm>
+          <a:prstGeom prst="rect">
+            <a:avLst/>
+          </a:prstGeom>
+          <a:noFill/>
+        </p:spPr>
+        <p:txBody>
+          <a:bodyPr wrap="square" lIns="0" tIns="0" rIns="0" bIns="0">
+            <a:spAutoFit/>
+          </a:bodyPr>
+          <a:lstStyle/>
+          <a:p>
+            <a:pPr algn="l"/>
+            <a:r>
+              <a:rPr sz="700" b="0" i="0">
+                <a:solidFill>
+                  <a:srgbClr val="64748B"/>
+                </a:solidFill>
+                <a:latin typeface="JetBrains Mono"/>
+              </a:rPr>
+              <a:t>Single Point Abort</a:t>
+            </a:r>
+          </a:p>
+        </p:txBody>
+      </p:sp>
+      <p:sp>
+        <p:nvSpPr>
+          <p:cNvPr id="67" name="TextBox 66"/>
+          <p:cNvSpPr txBox="1"/>
+          <p:nvPr/>
+        </p:nvSpPr>
+        <p:spPr>
+          <a:xfrm>
+            <a:off x="7498079" y="1234440"/>
             <a:ext cx="3931920" cy="228600"/>
           </a:xfrm>
           <a:prstGeom prst="rect">
@@ -9582,13 +9962,13 @@
       </p:sp>
       <p:sp>
         <p:nvSpPr>
-          <p:cNvPr id="58" name="TextBox 57"/>
+          <p:cNvPr id="68" name="TextBox 67"/>
           <p:cNvSpPr txBox="1"/>
           <p:nvPr/>
         </p:nvSpPr>
         <p:spPr>
           <a:xfrm>
-            <a:off x="9875520" y="1371600"/>
+            <a:off x="9875520" y="1234440"/>
             <a:ext cx="1554480" cy="228600"/>
           </a:xfrm>
           <a:prstGeom prst="rect">
@@ -9617,13 +9997,13 @@
       </p:sp>
       <p:sp>
         <p:nvSpPr>
-          <p:cNvPr id="59" name="Rounded Rectangle 58"/>
-          <p:cNvSpPr/>
-          <p:nvPr/>
-        </p:nvSpPr>
-        <p:spPr>
-          <a:xfrm>
-            <a:off x="7680960" y="1920240"/>
+          <p:cNvPr id="69" name="Rounded Rectangle 68"/>
+          <p:cNvSpPr/>
+          <p:nvPr/>
+        </p:nvSpPr>
+        <p:spPr>
+          <a:xfrm>
+            <a:off x="7680960" y="1828800"/>
             <a:ext cx="3566160" cy="3108960"/>
           </a:xfrm>
           <a:prstGeom prst="roundRect">
@@ -9662,13 +10042,13 @@
       </p:sp>
       <p:sp>
         <p:nvSpPr>
-          <p:cNvPr id="60" name="Rounded Rectangle 59"/>
-          <p:cNvSpPr/>
-          <p:nvPr/>
-        </p:nvSpPr>
-        <p:spPr>
-          <a:xfrm>
-            <a:off x="7589520" y="1810512"/>
+          <p:cNvPr id="70" name="Rounded Rectangle 69"/>
+          <p:cNvSpPr/>
+          <p:nvPr/>
+        </p:nvSpPr>
+        <p:spPr>
+          <a:xfrm>
+            <a:off x="7589520" y="1719072"/>
             <a:ext cx="3749039" cy="3200400"/>
           </a:xfrm>
           <a:prstGeom prst="roundRect">
@@ -9707,13 +10087,13 @@
       </p:sp>
       <p:sp>
         <p:nvSpPr>
-          <p:cNvPr id="61" name="Rounded Rectangle 60"/>
-          <p:cNvSpPr/>
-          <p:nvPr/>
-        </p:nvSpPr>
-        <p:spPr>
-          <a:xfrm>
-            <a:off x="7498079" y="1691640"/>
+          <p:cNvPr id="71" name="Rounded Rectangle 70"/>
+          <p:cNvSpPr/>
+          <p:nvPr/>
+        </p:nvSpPr>
+        <p:spPr>
+          <a:xfrm>
+            <a:off x="7498079" y="1600200"/>
             <a:ext cx="3931920" cy="3291840"/>
           </a:xfrm>
           <a:prstGeom prst="roundRect">
@@ -9752,13 +10132,13 @@
       </p:sp>
       <p:sp>
         <p:nvSpPr>
-          <p:cNvPr id="62" name="Rounded Rectangle 61"/>
-          <p:cNvSpPr/>
-          <p:nvPr/>
-        </p:nvSpPr>
-        <p:spPr>
-          <a:xfrm>
-            <a:off x="10789920" y="1536192"/>
+          <p:cNvPr id="72" name="Rounded Rectangle 71"/>
+          <p:cNvSpPr/>
+          <p:nvPr/>
+        </p:nvSpPr>
+        <p:spPr>
+          <a:xfrm>
+            <a:off x="10789920" y="1444752"/>
             <a:ext cx="228600" cy="502920"/>
           </a:xfrm>
           <a:prstGeom prst="roundRect">
@@ -9795,13 +10175,13 @@
       </p:sp>
       <p:sp>
         <p:nvSpPr>
-          <p:cNvPr id="63" name="Rounded Rectangle 62"/>
-          <p:cNvSpPr/>
-          <p:nvPr/>
-        </p:nvSpPr>
-        <p:spPr>
-          <a:xfrm>
-            <a:off x="7726679" y="1920240"/>
+          <p:cNvPr id="73" name="Rounded Rectangle 72"/>
+          <p:cNvSpPr/>
+          <p:nvPr/>
+        </p:nvSpPr>
+        <p:spPr>
+          <a:xfrm>
+            <a:off x="7726679" y="1828800"/>
             <a:ext cx="1645920" cy="219456"/>
           </a:xfrm>
           <a:prstGeom prst="roundRect">
@@ -9838,13 +10218,13 @@
       </p:sp>
       <p:sp>
         <p:nvSpPr>
-          <p:cNvPr id="64" name="TextBox 63"/>
+          <p:cNvPr id="74" name="TextBox 73"/>
           <p:cNvSpPr txBox="1"/>
           <p:nvPr/>
         </p:nvSpPr>
         <p:spPr>
           <a:xfrm>
-            <a:off x="7726679" y="1938528"/>
+            <a:off x="7726679" y="1847088"/>
             <a:ext cx="1645920" cy="201168"/>
           </a:xfrm>
           <a:prstGeom prst="rect">
@@ -9873,13 +10253,13 @@
       </p:sp>
       <p:sp>
         <p:nvSpPr>
-          <p:cNvPr id="65" name="TextBox 64"/>
+          <p:cNvPr id="75" name="TextBox 74"/>
           <p:cNvSpPr txBox="1"/>
           <p:nvPr/>
         </p:nvSpPr>
         <p:spPr>
           <a:xfrm>
-            <a:off x="9509760" y="1938528"/>
+            <a:off x="9509760" y="1847088"/>
             <a:ext cx="1737360" cy="201168"/>
           </a:xfrm>
           <a:prstGeom prst="rect">
@@ -9908,13 +10288,13 @@
       </p:sp>
       <p:sp>
         <p:nvSpPr>
-          <p:cNvPr id="66" name="TextBox 65"/>
+          <p:cNvPr id="76" name="TextBox 75"/>
           <p:cNvSpPr txBox="1"/>
           <p:nvPr/>
         </p:nvSpPr>
         <p:spPr>
           <a:xfrm>
-            <a:off x="7726679" y="2240280"/>
+            <a:off x="7726679" y="2148840"/>
             <a:ext cx="3474720" cy="502920"/>
           </a:xfrm>
           <a:prstGeom prst="rect">
@@ -9943,13 +10323,13 @@
       </p:sp>
       <p:sp>
         <p:nvSpPr>
-          <p:cNvPr id="67" name="Rounded Rectangle 66"/>
-          <p:cNvSpPr/>
-          <p:nvPr/>
-        </p:nvSpPr>
-        <p:spPr>
-          <a:xfrm>
-            <a:off x="7726679" y="2834640"/>
+          <p:cNvPr id="77" name="Rounded Rectangle 76"/>
+          <p:cNvSpPr/>
+          <p:nvPr/>
+        </p:nvSpPr>
+        <p:spPr>
+          <a:xfrm>
+            <a:off x="7726679" y="2743200"/>
             <a:ext cx="3474720" cy="1280160"/>
           </a:xfrm>
           <a:prstGeom prst="roundRect">
@@ -9988,13 +10368,13 @@
       </p:sp>
       <p:sp>
         <p:nvSpPr>
-          <p:cNvPr id="68" name="TextBox 67"/>
+          <p:cNvPr id="78" name="TextBox 77"/>
           <p:cNvSpPr txBox="1"/>
           <p:nvPr/>
         </p:nvSpPr>
         <p:spPr>
           <a:xfrm>
-            <a:off x="7863840" y="2926080"/>
+            <a:off x="7863840" y="2834640"/>
             <a:ext cx="3200400" cy="1097280"/>
           </a:xfrm>
           <a:prstGeom prst="rect">
@@ -10023,13 +10403,13 @@
       </p:sp>
       <p:sp>
         <p:nvSpPr>
-          <p:cNvPr id="69" name="TextBox 68"/>
+          <p:cNvPr id="79" name="TextBox 78"/>
           <p:cNvSpPr txBox="1"/>
           <p:nvPr/>
         </p:nvSpPr>
         <p:spPr>
           <a:xfrm>
-            <a:off x="7726679" y="4297680"/>
+            <a:off x="7726679" y="4206240"/>
             <a:ext cx="2011680" cy="274320"/>
           </a:xfrm>
           <a:prstGeom prst="rect">
@@ -10058,13 +10438,13 @@
       </p:sp>
       <p:sp>
         <p:nvSpPr>
-          <p:cNvPr id="70" name="TextBox 69"/>
+          <p:cNvPr id="80" name="TextBox 79"/>
           <p:cNvSpPr txBox="1"/>
           <p:nvPr/>
         </p:nvSpPr>
         <p:spPr>
           <a:xfrm>
-            <a:off x="9738360" y="4297680"/>
+            <a:off x="9738360" y="4206240"/>
             <a:ext cx="1463040" cy="274320"/>
           </a:xfrm>
           <a:prstGeom prst="rect">
@@ -10093,13 +10473,13 @@
       </p:sp>
       <p:sp>
         <p:nvSpPr>
-          <p:cNvPr id="71" name="Rounded Rectangle 70"/>
-          <p:cNvSpPr/>
-          <p:nvPr/>
-        </p:nvSpPr>
-        <p:spPr>
-          <a:xfrm>
-            <a:off x="7498079" y="5303520"/>
+          <p:cNvPr id="81" name="Rounded Rectangle 80"/>
+          <p:cNvSpPr/>
+          <p:nvPr/>
+        </p:nvSpPr>
+        <p:spPr>
+          <a:xfrm>
+            <a:off x="7498079" y="5120640"/>
             <a:ext cx="548640" cy="73152"/>
           </a:xfrm>
           <a:prstGeom prst="roundRect">
@@ -10136,13 +10516,13 @@
       </p:sp>
       <p:sp>
         <p:nvSpPr>
-          <p:cNvPr id="72" name="Rounded Rectangle 71"/>
-          <p:cNvSpPr/>
-          <p:nvPr/>
-        </p:nvSpPr>
-        <p:spPr>
-          <a:xfrm>
-            <a:off x="8138160" y="5303520"/>
+          <p:cNvPr id="82" name="Rounded Rectangle 81"/>
+          <p:cNvSpPr/>
+          <p:nvPr/>
+        </p:nvSpPr>
+        <p:spPr>
+          <a:xfrm>
+            <a:off x="8138160" y="5120640"/>
             <a:ext cx="109728" cy="73152"/>
           </a:xfrm>
           <a:prstGeom prst="roundRect">
@@ -10179,13 +10559,13 @@
       </p:sp>
       <p:sp>
         <p:nvSpPr>
-          <p:cNvPr id="73" name="Rounded Rectangle 72"/>
-          <p:cNvSpPr/>
-          <p:nvPr/>
-        </p:nvSpPr>
-        <p:spPr>
-          <a:xfrm>
-            <a:off x="8321040" y="5303520"/>
+          <p:cNvPr id="83" name="Rounded Rectangle 82"/>
+          <p:cNvSpPr/>
+          <p:nvPr/>
+        </p:nvSpPr>
+        <p:spPr>
+          <a:xfrm>
+            <a:off x="8321040" y="5120640"/>
             <a:ext cx="109728" cy="73152"/>
           </a:xfrm>
           <a:prstGeom prst="roundRect">
@@ -10222,13 +10602,13 @@
       </p:sp>
       <p:sp>
         <p:nvSpPr>
-          <p:cNvPr id="74" name="TextBox 73"/>
+          <p:cNvPr id="84" name="TextBox 83"/>
           <p:cNvSpPr txBox="1"/>
           <p:nvPr/>
         </p:nvSpPr>
         <p:spPr>
           <a:xfrm>
-            <a:off x="9144000" y="5230368"/>
+            <a:off x="9144000" y="5047488"/>
             <a:ext cx="2286000" cy="228600"/>
           </a:xfrm>
           <a:prstGeom prst="rect">
@@ -10257,7 +10637,7 @@
       </p:sp>
       <p:sp>
         <p:nvSpPr>
-          <p:cNvPr id="75" name="Rectangle 74"/>
+          <p:cNvPr id="85" name="Rectangle 84"/>
           <p:cNvSpPr/>
           <p:nvPr/>
         </p:nvSpPr>
@@ -10300,7 +10680,7 @@
       </p:sp>
       <p:sp>
         <p:nvSpPr>
-          <p:cNvPr id="76" name="TextBox 75"/>
+          <p:cNvPr id="86" name="TextBox 85"/>
           <p:cNvSpPr txBox="1"/>
           <p:nvPr/>
         </p:nvSpPr>
@@ -10335,7 +10715,7 @@
       </p:sp>
       <p:sp>
         <p:nvSpPr>
-          <p:cNvPr id="77" name="TextBox 76"/>
+          <p:cNvPr id="87" name="TextBox 86"/>
           <p:cNvSpPr txBox="1"/>
           <p:nvPr/>
         </p:nvSpPr>

</xml_diff>

<commit_message>
feat(slides): clean up Slide 2 citations and set up smooth continuous carousel loop
</commit_message>
<xml_diff>
--- a/sutra_pitch_deck.pptx
+++ b/sutra_pitch_deck.pptx
@@ -10409,8 +10409,8 @@
         </p:nvSpPr>
         <p:spPr>
           <a:xfrm>
-            <a:off x="7726679" y="4206240"/>
-            <a:ext cx="2011680" cy="274320"/>
+            <a:off x="7726679" y="4297680"/>
+            <a:ext cx="3474720" cy="274320"/>
           </a:xfrm>
           <a:prstGeom prst="rect">
             <a:avLst/>
@@ -10431,49 +10431,14 @@
                 </a:solidFill>
                 <a:latin typeface="JetBrains Mono"/>
               </a:rPr>
-              <a:t>Ref: NDMA Field Review</a:t>
-            </a:r>
-          </a:p>
-        </p:txBody>
-      </p:sp>
-      <p:sp>
-        <p:nvSpPr>
-          <p:cNvPr id="80" name="TextBox 79"/>
-          <p:cNvSpPr txBox="1"/>
-          <p:nvPr/>
-        </p:nvSpPr>
-        <p:spPr>
-          <a:xfrm>
-            <a:off x="9738360" y="4206240"/>
-            <a:ext cx="1463040" cy="274320"/>
-          </a:xfrm>
-          <a:prstGeom prst="rect">
-            <a:avLst/>
-          </a:prstGeom>
-          <a:noFill/>
-        </p:spPr>
-        <p:txBody>
-          <a:bodyPr wrap="square" lIns="0" tIns="0" rIns="0" bIns="0">
-            <a:spAutoFit/>
-          </a:bodyPr>
-          <a:lstStyle/>
-          <a:p>
-            <a:pPr algn="r"/>
-            <a:r>
-              <a:rPr sz="800" b="1" i="0">
-                <a:solidFill>
-                  <a:srgbClr val="047857"/>
-                </a:solidFill>
-                <a:latin typeface="JetBrains Mono"/>
-              </a:rPr>
-              <a:t>✓ VERIFIED RECORD</a:t>
-            </a:r>
-          </a:p>
-        </p:txBody>
-      </p:sp>
-      <p:sp>
-        <p:nvSpPr>
-          <p:cNvPr id="81" name="Rounded Rectangle 80"/>
+              <a:t>Ref: National Disaster Management Authority (NDMA)</a:t>
+            </a:r>
+          </a:p>
+        </p:txBody>
+      </p:sp>
+      <p:sp>
+        <p:nvSpPr>
+          <p:cNvPr id="80" name="Rounded Rectangle 79"/>
           <p:cNvSpPr/>
           <p:nvPr/>
         </p:nvSpPr>
@@ -10516,7 +10481,7 @@
       </p:sp>
       <p:sp>
         <p:nvSpPr>
-          <p:cNvPr id="82" name="Rounded Rectangle 81"/>
+          <p:cNvPr id="81" name="Rounded Rectangle 80"/>
           <p:cNvSpPr/>
           <p:nvPr/>
         </p:nvSpPr>
@@ -10559,7 +10524,7 @@
       </p:sp>
       <p:sp>
         <p:nvSpPr>
-          <p:cNvPr id="83" name="Rounded Rectangle 82"/>
+          <p:cNvPr id="82" name="Rounded Rectangle 81"/>
           <p:cNvSpPr/>
           <p:nvPr/>
         </p:nvSpPr>
@@ -10602,7 +10567,7 @@
       </p:sp>
       <p:sp>
         <p:nvSpPr>
-          <p:cNvPr id="84" name="TextBox 83"/>
+          <p:cNvPr id="83" name="TextBox 82"/>
           <p:cNvSpPr txBox="1"/>
           <p:nvPr/>
         </p:nvSpPr>
@@ -10630,14 +10595,14 @@
                 </a:solidFill>
                 <a:latin typeface="JetBrains Mono"/>
               </a:rPr>
-              <a:t>SMOOTH PARALLAX 3.5S</a:t>
-            </a:r>
-          </a:p>
-        </p:txBody>
-      </p:sp>
-      <p:sp>
-        <p:nvSpPr>
-          <p:cNvPr id="85" name="Rectangle 84"/>
+              <a:t>CONTINUOUS LOOP</a:t>
+            </a:r>
+          </a:p>
+        </p:txBody>
+      </p:sp>
+      <p:sp>
+        <p:nvSpPr>
+          <p:cNvPr id="84" name="Rectangle 83"/>
           <p:cNvSpPr/>
           <p:nvPr/>
         </p:nvSpPr>
@@ -10680,7 +10645,7 @@
       </p:sp>
       <p:sp>
         <p:nvSpPr>
-          <p:cNvPr id="86" name="TextBox 85"/>
+          <p:cNvPr id="85" name="TextBox 84"/>
           <p:cNvSpPr txBox="1"/>
           <p:nvPr/>
         </p:nvSpPr>
@@ -10715,7 +10680,7 @@
       </p:sp>
       <p:sp>
         <p:nvSpPr>
-          <p:cNvPr id="87" name="TextBox 86"/>
+          <p:cNvPr id="86" name="TextBox 85"/>
           <p:cNvSpPr txBox="1"/>
           <p:nvPr/>
         </p:nvSpPr>

</xml_diff>

<commit_message>
feat(slides): embed authentic real disaster news photos into Slide 2 evidence carousel
</commit_message>
<xml_diff>
--- a/sutra_pitch_deck.pptx
+++ b/sutra_pitch_deck.pptx
@@ -9955,7 +9955,7 @@
                 </a:solidFill>
                 <a:latin typeface="JetBrains Mono"/>
               </a:rPr>
-              <a:t>OFFICIAL EVIDENCE &amp; AUDITS</a:t>
+              <a:t>OFFICIAL EVIDENCE &amp; DISASTER CLIPPINGS</a:t>
             </a:r>
           </a:p>
         </p:txBody>
@@ -10181,7 +10181,7 @@
         </p:nvSpPr>
         <p:spPr>
           <a:xfrm>
-            <a:off x="7726679" y="1828800"/>
+            <a:off x="7726679" y="1783080"/>
             <a:ext cx="1645920" cy="219456"/>
           </a:xfrm>
           <a:prstGeom prst="roundRect">
@@ -10224,7 +10224,7 @@
         </p:nvSpPr>
         <p:spPr>
           <a:xfrm>
-            <a:off x="7726679" y="1847088"/>
+            <a:off x="7726679" y="1801368"/>
             <a:ext cx="1645920" cy="201168"/>
           </a:xfrm>
           <a:prstGeom prst="rect">
@@ -10259,7 +10259,7 @@
         </p:nvSpPr>
         <p:spPr>
           <a:xfrm>
-            <a:off x="9509760" y="1847088"/>
+            <a:off x="9509760" y="1801368"/>
             <a:ext cx="1737360" cy="201168"/>
           </a:xfrm>
           <a:prstGeom prst="rect">
@@ -10286,16 +10286,40 @@
           </a:p>
         </p:txBody>
       </p:sp>
-      <p:sp>
-        <p:nvSpPr>
-          <p:cNvPr id="76" name="TextBox 75"/>
+      <p:pic>
+        <p:nvPicPr>
+          <p:cNvPr id="76" name="Picture 75" descr="wayanad_rescue.jpg"/>
+          <p:cNvPicPr>
+            <a:picLocks noChangeAspect="1"/>
+          </p:cNvPicPr>
+          <p:nvPr/>
+        </p:nvPicPr>
+        <p:blipFill>
+          <a:blip r:embed="rId2"/>
+          <a:stretch>
+            <a:fillRect/>
+          </a:stretch>
+        </p:blipFill>
+        <p:spPr>
+          <a:xfrm>
+            <a:off x="7726679" y="2103120"/>
+            <a:ext cx="1188720" cy="777240"/>
+          </a:xfrm>
+          <a:prstGeom prst="rect">
+            <a:avLst/>
+          </a:prstGeom>
+        </p:spPr>
+      </p:pic>
+      <p:sp>
+        <p:nvSpPr>
+          <p:cNvPr id="77" name="TextBox 76"/>
           <p:cNvSpPr txBox="1"/>
           <p:nvPr/>
         </p:nvSpPr>
         <p:spPr>
           <a:xfrm>
-            <a:off x="7726679" y="2148840"/>
-            <a:ext cx="3474720" cy="502920"/>
+            <a:off x="9006840" y="2103120"/>
+            <a:ext cx="2194560" cy="777240"/>
           </a:xfrm>
           <a:prstGeom prst="rect">
             <a:avLst/>
@@ -10310,7 +10334,7 @@
           <a:p>
             <a:pPr algn="l"/>
             <a:r>
-              <a:rPr sz="1200" b="1" i="0">
+              <a:rPr sz="1050" b="1" i="0">
                 <a:solidFill>
                   <a:srgbClr val="000000"/>
                 </a:solidFill>
@@ -10323,14 +10347,14 @@
       </p:sp>
       <p:sp>
         <p:nvSpPr>
-          <p:cNvPr id="77" name="Rounded Rectangle 76"/>
-          <p:cNvSpPr/>
-          <p:nvPr/>
-        </p:nvSpPr>
-        <p:spPr>
-          <a:xfrm>
-            <a:off x="7726679" y="2743200"/>
-            <a:ext cx="3474720" cy="1280160"/>
+          <p:cNvPr id="78" name="Rounded Rectangle 77"/>
+          <p:cNvSpPr/>
+          <p:nvPr/>
+        </p:nvSpPr>
+        <p:spPr>
+          <a:xfrm>
+            <a:off x="7726679" y="2971800"/>
+            <a:ext cx="3474720" cy="1188720"/>
           </a:xfrm>
           <a:prstGeom prst="roundRect">
             <a:avLst/>
@@ -10368,14 +10392,14 @@
       </p:sp>
       <p:sp>
         <p:nvSpPr>
-          <p:cNvPr id="78" name="TextBox 77"/>
+          <p:cNvPr id="79" name="TextBox 78"/>
           <p:cNvSpPr txBox="1"/>
           <p:nvPr/>
         </p:nvSpPr>
         <p:spPr>
           <a:xfrm>
-            <a:off x="7863840" y="2834640"/>
-            <a:ext cx="3200400" cy="1097280"/>
+            <a:off x="7863840" y="3035808"/>
+            <a:ext cx="3200400" cy="1051560"/>
           </a:xfrm>
           <a:prstGeom prst="rect">
             <a:avLst/>
@@ -10390,7 +10414,7 @@
           <a:p>
             <a:pPr algn="l"/>
             <a:r>
-              <a:rPr sz="950" b="0" i="1">
+              <a:rPr sz="900" b="0" i="1">
                 <a:solidFill>
                   <a:srgbClr val="374151"/>
                 </a:solidFill>
@@ -10403,7 +10427,7 @@
       </p:sp>
       <p:sp>
         <p:nvSpPr>
-          <p:cNvPr id="79" name="TextBox 78"/>
+          <p:cNvPr id="80" name="TextBox 79"/>
           <p:cNvSpPr txBox="1"/>
           <p:nvPr/>
         </p:nvSpPr>
@@ -10438,7 +10462,7 @@
       </p:sp>
       <p:sp>
         <p:nvSpPr>
-          <p:cNvPr id="80" name="Rounded Rectangle 79"/>
+          <p:cNvPr id="81" name="Rounded Rectangle 80"/>
           <p:cNvSpPr/>
           <p:nvPr/>
         </p:nvSpPr>
@@ -10481,7 +10505,7 @@
       </p:sp>
       <p:sp>
         <p:nvSpPr>
-          <p:cNvPr id="81" name="Rounded Rectangle 80"/>
+          <p:cNvPr id="82" name="Rounded Rectangle 81"/>
           <p:cNvSpPr/>
           <p:nvPr/>
         </p:nvSpPr>
@@ -10524,7 +10548,7 @@
       </p:sp>
       <p:sp>
         <p:nvSpPr>
-          <p:cNvPr id="82" name="Rounded Rectangle 81"/>
+          <p:cNvPr id="83" name="Rounded Rectangle 82"/>
           <p:cNvSpPr/>
           <p:nvPr/>
         </p:nvSpPr>
@@ -10567,7 +10591,7 @@
       </p:sp>
       <p:sp>
         <p:nvSpPr>
-          <p:cNvPr id="83" name="TextBox 82"/>
+          <p:cNvPr id="84" name="TextBox 83"/>
           <p:cNvSpPr txBox="1"/>
           <p:nvPr/>
         </p:nvSpPr>
@@ -10602,7 +10626,7 @@
       </p:sp>
       <p:sp>
         <p:nvSpPr>
-          <p:cNvPr id="84" name="Rectangle 83"/>
+          <p:cNvPr id="85" name="Rectangle 84"/>
           <p:cNvSpPr/>
           <p:nvPr/>
         </p:nvSpPr>
@@ -10645,7 +10669,7 @@
       </p:sp>
       <p:sp>
         <p:nvSpPr>
-          <p:cNvPr id="85" name="TextBox 84"/>
+          <p:cNvPr id="86" name="TextBox 85"/>
           <p:cNvSpPr txBox="1"/>
           <p:nvPr/>
         </p:nvSpPr>
@@ -10680,7 +10704,7 @@
       </p:sp>
       <p:sp>
         <p:nvSpPr>
-          <p:cNvPr id="86" name="TextBox 85"/>
+          <p:cNvPr id="87" name="TextBox 86"/>
           <p:cNvSpPr txBox="1"/>
           <p:nvPr/>
         </p:nvSpPr>

</xml_diff>

<commit_message>
feat(slides): upgrade Slide 2 carousel to full-bleed disaster photo cards matching reference design
</commit_message>
<xml_diff>
--- a/sutra_pitch_deck.pptx
+++ b/sutra_pitch_deck.pptx
@@ -9933,8 +9933,8 @@
         </p:nvSpPr>
         <p:spPr>
           <a:xfrm>
-            <a:off x="7498079" y="1234440"/>
-            <a:ext cx="3931920" cy="228600"/>
+            <a:off x="7315200" y="1234440"/>
+            <a:ext cx="4114800" cy="228600"/>
           </a:xfrm>
           <a:prstGeom prst="rect">
             <a:avLst/>
@@ -9955,7 +9955,7 @@
                 </a:solidFill>
                 <a:latin typeface="JetBrains Mono"/>
               </a:rPr>
-              <a:t>OFFICIAL EVIDENCE &amp; DISASTER CLIPPINGS</a:t>
+              <a:t>REAL DISASTER FIELD EVIDENCE</a:t>
             </a:r>
           </a:p>
         </p:txBody>
@@ -10003,149 +10003,14 @@
         </p:nvSpPr>
         <p:spPr>
           <a:xfrm>
-            <a:off x="7680960" y="1828800"/>
-            <a:ext cx="3566160" cy="3108960"/>
+            <a:off x="7498079" y="1783080"/>
+            <a:ext cx="3931920" cy="3474720"/>
           </a:xfrm>
           <a:prstGeom prst="roundRect">
             <a:avLst/>
           </a:prstGeom>
           <a:solidFill>
-            <a:srgbClr val="F1F5F9"/>
-          </a:solidFill>
-          <a:ln w="12700">
-            <a:solidFill>
-              <a:srgbClr val="E2E8F0"/>
-            </a:solidFill>
-          </a:ln>
-        </p:spPr>
-        <p:style>
-          <a:lnRef idx="1">
-            <a:schemeClr val="accent1"/>
-          </a:lnRef>
-          <a:fillRef idx="3">
-            <a:schemeClr val="accent1"/>
-          </a:fillRef>
-          <a:effectRef idx="2">
-            <a:schemeClr val="accent1"/>
-          </a:effectRef>
-          <a:fontRef idx="minor">
-            <a:schemeClr val="lt1"/>
-          </a:fontRef>
-        </p:style>
-        <p:txBody>
-          <a:bodyPr rtlCol="0" anchor="ctr"/>
-          <a:lstStyle/>
-          <a:p>
-            <a:pPr algn="ctr"/>
-          </a:p>
-        </p:txBody>
-      </p:sp>
-      <p:sp>
-        <p:nvSpPr>
-          <p:cNvPr id="70" name="Rounded Rectangle 69"/>
-          <p:cNvSpPr/>
-          <p:nvPr/>
-        </p:nvSpPr>
-        <p:spPr>
-          <a:xfrm>
-            <a:off x="7589520" y="1719072"/>
-            <a:ext cx="3749039" cy="3200400"/>
-          </a:xfrm>
-          <a:prstGeom prst="roundRect">
-            <a:avLst/>
-          </a:prstGeom>
-          <a:solidFill>
-            <a:srgbClr val="F8FAFC"/>
-          </a:solidFill>
-          <a:ln w="12700">
-            <a:solidFill>
-              <a:srgbClr val="E2E8F0"/>
-            </a:solidFill>
-          </a:ln>
-        </p:spPr>
-        <p:style>
-          <a:lnRef idx="1">
-            <a:schemeClr val="accent1"/>
-          </a:lnRef>
-          <a:fillRef idx="3">
-            <a:schemeClr val="accent1"/>
-          </a:fillRef>
-          <a:effectRef idx="2">
-            <a:schemeClr val="accent1"/>
-          </a:effectRef>
-          <a:fontRef idx="minor">
-            <a:schemeClr val="lt1"/>
-          </a:fontRef>
-        </p:style>
-        <p:txBody>
-          <a:bodyPr rtlCol="0" anchor="ctr"/>
-          <a:lstStyle/>
-          <a:p>
-            <a:pPr algn="ctr"/>
-          </a:p>
-        </p:txBody>
-      </p:sp>
-      <p:sp>
-        <p:nvSpPr>
-          <p:cNvPr id="71" name="Rounded Rectangle 70"/>
-          <p:cNvSpPr/>
-          <p:nvPr/>
-        </p:nvSpPr>
-        <p:spPr>
-          <a:xfrm>
-            <a:off x="7498079" y="1600200"/>
-            <a:ext cx="3931920" cy="3291840"/>
-          </a:xfrm>
-          <a:prstGeom prst="roundRect">
-            <a:avLst/>
-          </a:prstGeom>
-          <a:solidFill>
-            <a:srgbClr val="FFFFFF"/>
-          </a:solidFill>
-          <a:ln w="12700">
-            <a:solidFill>
-              <a:srgbClr val="E2E8F0"/>
-            </a:solidFill>
-          </a:ln>
-        </p:spPr>
-        <p:style>
-          <a:lnRef idx="1">
-            <a:schemeClr val="accent1"/>
-          </a:lnRef>
-          <a:fillRef idx="3">
-            <a:schemeClr val="accent1"/>
-          </a:fillRef>
-          <a:effectRef idx="2">
-            <a:schemeClr val="accent1"/>
-          </a:effectRef>
-          <a:fontRef idx="minor">
-            <a:schemeClr val="lt1"/>
-          </a:fontRef>
-        </p:style>
-        <p:txBody>
-          <a:bodyPr rtlCol="0" anchor="ctr"/>
-          <a:lstStyle/>
-          <a:p>
-            <a:pPr algn="ctr"/>
-          </a:p>
-        </p:txBody>
-      </p:sp>
-      <p:sp>
-        <p:nvSpPr>
-          <p:cNvPr id="72" name="Rounded Rectangle 71"/>
-          <p:cNvSpPr/>
-          <p:nvPr/>
-        </p:nvSpPr>
-        <p:spPr>
-          <a:xfrm>
-            <a:off x="10789920" y="1444752"/>
-            <a:ext cx="228600" cy="502920"/>
-          </a:xfrm>
-          <a:prstGeom prst="roundRect">
-            <a:avLst/>
-          </a:prstGeom>
-          <a:solidFill>
-            <a:srgbClr val="475569"/>
+            <a:srgbClr val="303030"/>
           </a:solidFill>
           <a:ln>
             <a:noFill/>
@@ -10175,20 +10040,20 @@
       </p:sp>
       <p:sp>
         <p:nvSpPr>
-          <p:cNvPr id="73" name="Rounded Rectangle 72"/>
-          <p:cNvSpPr/>
-          <p:nvPr/>
-        </p:nvSpPr>
-        <p:spPr>
-          <a:xfrm>
-            <a:off x="7726679" y="1783080"/>
-            <a:ext cx="1645920" cy="219456"/>
+          <p:cNvPr id="70" name="Rounded Rectangle 69"/>
+          <p:cNvSpPr/>
+          <p:nvPr/>
+        </p:nvSpPr>
+        <p:spPr>
+          <a:xfrm>
+            <a:off x="7406640" y="1691640"/>
+            <a:ext cx="4023360" cy="3566160"/>
           </a:xfrm>
           <a:prstGeom prst="roundRect">
             <a:avLst/>
           </a:prstGeom>
           <a:solidFill>
-            <a:srgbClr val="0A1628"/>
+            <a:srgbClr val="202020"/>
           </a:solidFill>
           <a:ln>
             <a:noFill/>
@@ -10218,14 +10083,210 @@
       </p:sp>
       <p:sp>
         <p:nvSpPr>
-          <p:cNvPr id="74" name="TextBox 73"/>
+          <p:cNvPr id="71" name="Rounded Rectangle 70"/>
+          <p:cNvSpPr/>
+          <p:nvPr/>
+        </p:nvSpPr>
+        <p:spPr>
+          <a:xfrm>
+            <a:off x="7315200" y="1600200"/>
+            <a:ext cx="4114800" cy="3657600"/>
+          </a:xfrm>
+          <a:prstGeom prst="roundRect">
+            <a:avLst/>
+          </a:prstGeom>
+          <a:solidFill>
+            <a:srgbClr val="000000"/>
+          </a:solidFill>
+          <a:ln>
+            <a:noFill/>
+          </a:ln>
+        </p:spPr>
+        <p:style>
+          <a:lnRef idx="1">
+            <a:schemeClr val="accent1"/>
+          </a:lnRef>
+          <a:fillRef idx="3">
+            <a:schemeClr val="accent1"/>
+          </a:fillRef>
+          <a:effectRef idx="2">
+            <a:schemeClr val="accent1"/>
+          </a:effectRef>
+          <a:fontRef idx="minor">
+            <a:schemeClr val="lt1"/>
+          </a:fontRef>
+        </p:style>
+        <p:txBody>
+          <a:bodyPr rtlCol="0" anchor="ctr"/>
+          <a:lstStyle/>
+          <a:p>
+            <a:pPr algn="ctr"/>
+          </a:p>
+        </p:txBody>
+      </p:sp>
+      <p:pic>
+        <p:nvPicPr>
+          <p:cNvPr id="72" name="Picture 71" descr="wayanad_rescue.jpg"/>
+          <p:cNvPicPr>
+            <a:picLocks noChangeAspect="1"/>
+          </p:cNvPicPr>
+          <p:nvPr/>
+        </p:nvPicPr>
+        <p:blipFill>
+          <a:blip r:embed="rId2"/>
+          <a:stretch>
+            <a:fillRect/>
+          </a:stretch>
+        </p:blipFill>
+        <p:spPr>
+          <a:xfrm>
+            <a:off x="7315200" y="1600200"/>
+            <a:ext cx="4114800" cy="3657600"/>
+          </a:xfrm>
+          <a:prstGeom prst="rect">
+            <a:avLst/>
+          </a:prstGeom>
+        </p:spPr>
+      </p:pic>
+      <p:sp>
+        <p:nvSpPr>
+          <p:cNvPr id="73" name="Rectangle 72"/>
+          <p:cNvSpPr/>
+          <p:nvPr/>
+        </p:nvSpPr>
+        <p:spPr>
+          <a:xfrm>
+            <a:off x="7315200" y="3291840"/>
+            <a:ext cx="4114800" cy="1965960"/>
+          </a:xfrm>
+          <a:prstGeom prst="rect">
+            <a:avLst/>
+          </a:prstGeom>
+          <a:solidFill>
+            <a:srgbClr val="0A0A0A"/>
+          </a:solidFill>
+          <a:ln>
+            <a:noFill/>
+          </a:ln>
+        </p:spPr>
+        <p:style>
+          <a:lnRef idx="1">
+            <a:schemeClr val="accent1"/>
+          </a:lnRef>
+          <a:fillRef idx="3">
+            <a:schemeClr val="accent1"/>
+          </a:fillRef>
+          <a:effectRef idx="2">
+            <a:schemeClr val="accent1"/>
+          </a:effectRef>
+          <a:fontRef idx="minor">
+            <a:schemeClr val="lt1"/>
+          </a:fontRef>
+        </p:style>
+        <p:txBody>
+          <a:bodyPr rtlCol="0" anchor="ctr"/>
+          <a:lstStyle/>
+          <a:p>
+            <a:pPr algn="ctr"/>
+          </a:p>
+        </p:txBody>
+      </p:sp>
+      <p:sp>
+        <p:nvSpPr>
+          <p:cNvPr id="74" name="Oval 73"/>
+          <p:cNvSpPr/>
+          <p:nvPr/>
+        </p:nvSpPr>
+        <p:spPr>
+          <a:xfrm>
+            <a:off x="7543800" y="1783080"/>
+            <a:ext cx="365760" cy="365760"/>
+          </a:xfrm>
+          <a:prstGeom prst="ellipse">
+            <a:avLst/>
+          </a:prstGeom>
+          <a:solidFill>
+            <a:srgbClr val="404040"/>
+          </a:solidFill>
+          <a:ln>
+            <a:noFill/>
+          </a:ln>
+        </p:spPr>
+        <p:style>
+          <a:lnRef idx="1">
+            <a:schemeClr val="accent1"/>
+          </a:lnRef>
+          <a:fillRef idx="3">
+            <a:schemeClr val="accent1"/>
+          </a:fillRef>
+          <a:effectRef idx="2">
+            <a:schemeClr val="accent1"/>
+          </a:effectRef>
+          <a:fontRef idx="minor">
+            <a:schemeClr val="lt1"/>
+          </a:fontRef>
+        </p:style>
+        <p:txBody>
+          <a:bodyPr rtlCol="0" anchor="ctr"/>
+          <a:lstStyle/>
+          <a:p>
+            <a:pPr algn="ctr"/>
+          </a:p>
+        </p:txBody>
+      </p:sp>
+      <p:sp>
+        <p:nvSpPr>
+          <p:cNvPr id="75" name="Rounded Rectangle 74"/>
+          <p:cNvSpPr/>
+          <p:nvPr/>
+        </p:nvSpPr>
+        <p:spPr>
+          <a:xfrm>
+            <a:off x="9692640" y="1783080"/>
+            <a:ext cx="1554480" cy="256032"/>
+          </a:xfrm>
+          <a:prstGeom prst="roundRect">
+            <a:avLst/>
+          </a:prstGeom>
+          <a:solidFill>
+            <a:srgbClr val="202020"/>
+          </a:solidFill>
+          <a:ln>
+            <a:noFill/>
+          </a:ln>
+        </p:spPr>
+        <p:style>
+          <a:lnRef idx="1">
+            <a:schemeClr val="accent1"/>
+          </a:lnRef>
+          <a:fillRef idx="3">
+            <a:schemeClr val="accent1"/>
+          </a:fillRef>
+          <a:effectRef idx="2">
+            <a:schemeClr val="accent1"/>
+          </a:effectRef>
+          <a:fontRef idx="minor">
+            <a:schemeClr val="lt1"/>
+          </a:fontRef>
+        </p:style>
+        <p:txBody>
+          <a:bodyPr rtlCol="0" anchor="ctr"/>
+          <a:lstStyle/>
+          <a:p>
+            <a:pPr algn="ctr"/>
+          </a:p>
+        </p:txBody>
+      </p:sp>
+      <p:sp>
+        <p:nvSpPr>
+          <p:cNvPr id="76" name="TextBox 75"/>
           <p:cNvSpPr txBox="1"/>
           <p:nvPr/>
         </p:nvSpPr>
         <p:spPr>
           <a:xfrm>
-            <a:off x="7726679" y="1801368"/>
-            <a:ext cx="1645920" cy="201168"/>
+            <a:off x="9692640" y="1810512"/>
+            <a:ext cx="1554480" cy="228600"/>
           </a:xfrm>
           <a:prstGeom prst="rect">
             <a:avLst/>
@@ -10253,14 +10314,14 @@
       </p:sp>
       <p:sp>
         <p:nvSpPr>
-          <p:cNvPr id="75" name="TextBox 74"/>
+          <p:cNvPr id="77" name="TextBox 76"/>
           <p:cNvSpPr txBox="1"/>
           <p:nvPr/>
         </p:nvSpPr>
         <p:spPr>
           <a:xfrm>
-            <a:off x="9509760" y="1801368"/>
-            <a:ext cx="1737360" cy="201168"/>
+            <a:off x="7543800" y="3474720"/>
+            <a:ext cx="3657600" cy="411480"/>
           </a:xfrm>
           <a:prstGeom prst="rect">
             <a:avLst/>
@@ -10273,53 +10334,64 @@
           </a:bodyPr>
           <a:lstStyle/>
           <a:p>
-            <a:pPr algn="r"/>
-            <a:r>
-              <a:rPr sz="750" b="0" i="0">
+            <a:pPr algn="l"/>
+            <a:r>
+              <a:rPr sz="1600" b="1" i="0">
+                <a:solidFill>
+                  <a:srgbClr val="FFFFFF"/>
+                </a:solidFill>
+                <a:latin typeface="Plus Jakarta Sans"/>
+              </a:rPr>
+              <a:t>Wayanad Landslide Search</a:t>
+            </a:r>
+          </a:p>
+        </p:txBody>
+      </p:sp>
+      <p:sp>
+        <p:nvSpPr>
+          <p:cNvPr id="78" name="TextBox 77"/>
+          <p:cNvSpPr txBox="1"/>
+          <p:nvPr/>
+        </p:nvSpPr>
+        <p:spPr>
+          <a:xfrm>
+            <a:off x="7543800" y="3886200"/>
+            <a:ext cx="3657600" cy="228600"/>
+          </a:xfrm>
+          <a:prstGeom prst="rect">
+            <a:avLst/>
+          </a:prstGeom>
+          <a:noFill/>
+        </p:spPr>
+        <p:txBody>
+          <a:bodyPr wrap="square" lIns="0" tIns="0" rIns="0" bIns="0">
+            <a:spAutoFit/>
+          </a:bodyPr>
+          <a:lstStyle/>
+          <a:p>
+            <a:pPr algn="l"/>
+            <a:r>
+              <a:rPr sz="800" b="0" i="0">
                 <a:solidFill>
                   <a:srgbClr val="94A3B8"/>
                 </a:solidFill>
                 <a:latin typeface="JetBrains Mono"/>
               </a:rPr>
-              <a:t>NDMA REPORT</a:t>
-            </a:r>
-          </a:p>
-        </p:txBody>
-      </p:sp>
-      <p:pic>
-        <p:nvPicPr>
-          <p:cNvPr id="76" name="Picture 75" descr="wayanad_rescue.jpg"/>
-          <p:cNvPicPr>
-            <a:picLocks noChangeAspect="1"/>
-          </p:cNvPicPr>
-          <p:nvPr/>
-        </p:nvPicPr>
-        <p:blipFill>
-          <a:blip r:embed="rId2"/>
-          <a:stretch>
-            <a:fillRect/>
-          </a:stretch>
-        </p:blipFill>
-        <p:spPr>
-          <a:xfrm>
-            <a:off x="7726679" y="2103120"/>
-            <a:ext cx="1188720" cy="777240"/>
-          </a:xfrm>
-          <a:prstGeom prst="rect">
-            <a:avLst/>
-          </a:prstGeom>
-        </p:spPr>
-      </p:pic>
-      <p:sp>
-        <p:nvSpPr>
-          <p:cNvPr id="77" name="TextBox 76"/>
+              <a:t>Western Ghats • NDMA Official Disaster Review</a:t>
+            </a:r>
+          </a:p>
+        </p:txBody>
+      </p:sp>
+      <p:sp>
+        <p:nvSpPr>
+          <p:cNvPr id="79" name="TextBox 78"/>
           <p:cNvSpPr txBox="1"/>
           <p:nvPr/>
         </p:nvSpPr>
         <p:spPr>
           <a:xfrm>
-            <a:off x="9006840" y="2103120"/>
-            <a:ext cx="2194560" cy="777240"/>
+            <a:off x="7543800" y="4206240"/>
+            <a:ext cx="3657600" cy="201168"/>
           </a:xfrm>
           <a:prstGeom prst="rect">
             <a:avLst/>
@@ -10334,72 +10406,27 @@
           <a:p>
             <a:pPr algn="l"/>
             <a:r>
-              <a:rPr sz="1050" b="1" i="0">
+              <a:rPr sz="750" b="1" i="0">
                 <a:solidFill>
-                  <a:srgbClr val="000000"/>
+                  <a:srgbClr val="34D399"/>
                 </a:solidFill>
-                <a:latin typeface="Plus Jakarta Sans"/>
+                <a:latin typeface="JetBrains Mono"/>
               </a:rPr>
-              <a:t>70% of single drones failed in mountain rescue operations.</a:t>
-            </a:r>
-          </a:p>
-        </p:txBody>
-      </p:sp>
-      <p:sp>
-        <p:nvSpPr>
-          <p:cNvPr id="78" name="Rounded Rectangle 77"/>
-          <p:cNvSpPr/>
-          <p:nvPr/>
-        </p:nvSpPr>
-        <p:spPr>
-          <a:xfrm>
-            <a:off x="7726679" y="2971800"/>
-            <a:ext cx="3474720" cy="1188720"/>
-          </a:xfrm>
-          <a:prstGeom prst="roundRect">
-            <a:avLst/>
-          </a:prstGeom>
-          <a:solidFill>
-            <a:srgbClr val="F8FAFC"/>
-          </a:solidFill>
-          <a:ln w="12700">
-            <a:solidFill>
-              <a:srgbClr val="E2E8F0"/>
-            </a:solidFill>
-          </a:ln>
-        </p:spPr>
-        <p:style>
-          <a:lnRef idx="1">
-            <a:schemeClr val="accent1"/>
-          </a:lnRef>
-          <a:fillRef idx="3">
-            <a:schemeClr val="accent1"/>
-          </a:fillRef>
-          <a:effectRef idx="2">
-            <a:schemeClr val="accent1"/>
-          </a:effectRef>
-          <a:fontRef idx="minor">
-            <a:schemeClr val="lt1"/>
-          </a:fontRef>
-        </p:style>
-        <p:txBody>
-          <a:bodyPr rtlCol="0" anchor="ctr"/>
-          <a:lstStyle/>
-          <a:p>
-            <a:pPr algn="ctr"/>
-          </a:p>
-        </p:txBody>
-      </p:sp>
-      <p:sp>
-        <p:nvSpPr>
-          <p:cNvPr id="79" name="TextBox 78"/>
+              <a:t>FIELD BOTTLENECK</a:t>
+            </a:r>
+          </a:p>
+        </p:txBody>
+      </p:sp>
+      <p:sp>
+        <p:nvSpPr>
+          <p:cNvPr id="80" name="TextBox 79"/>
           <p:cNvSpPr txBox="1"/>
           <p:nvPr/>
         </p:nvSpPr>
         <p:spPr>
           <a:xfrm>
-            <a:off x="7863840" y="3035808"/>
-            <a:ext cx="3200400" cy="1051560"/>
+            <a:off x="7543800" y="4434840"/>
+            <a:ext cx="3657600" cy="731520"/>
           </a:xfrm>
           <a:prstGeom prst="rect">
             <a:avLst/>
@@ -10414,48 +10441,13 @@
           <a:p>
             <a:pPr algn="l"/>
             <a:r>
-              <a:rPr sz="900" b="0" i="1">
+              <a:rPr sz="900" b="0" i="0">
                 <a:solidFill>
-                  <a:srgbClr val="374151"/>
+                  <a:srgbClr val="E2E8F0"/>
                 </a:solidFill>
                 <a:latin typeface="Inter"/>
               </a:rPr>
-              <a:t>“In the Kedarnath and Wayanad rescue missions, single commercial drones lost connection behind ridges and crashed under thick tree canopy.”</a:t>
-            </a:r>
-          </a:p>
-        </p:txBody>
-      </p:sp>
-      <p:sp>
-        <p:nvSpPr>
-          <p:cNvPr id="80" name="TextBox 79"/>
-          <p:cNvSpPr txBox="1"/>
-          <p:nvPr/>
-        </p:nvSpPr>
-        <p:spPr>
-          <a:xfrm>
-            <a:off x="7726679" y="4297680"/>
-            <a:ext cx="3474720" cy="274320"/>
-          </a:xfrm>
-          <a:prstGeom prst="rect">
-            <a:avLst/>
-          </a:prstGeom>
-          <a:noFill/>
-        </p:spPr>
-        <p:txBody>
-          <a:bodyPr wrap="square" lIns="0" tIns="0" rIns="0" bIns="0">
-            <a:spAutoFit/>
-          </a:bodyPr>
-          <a:lstStyle/>
-          <a:p>
-            <a:pPr algn="l"/>
-            <a:r>
-              <a:rPr sz="800" b="0" i="0">
-                <a:solidFill>
-                  <a:srgbClr val="64748B"/>
-                </a:solidFill>
-                <a:latin typeface="JetBrains Mono"/>
-              </a:rPr>
-              <a:t>Ref: National Disaster Management Authority (NDMA)</a:t>
+              <a:t>“70% of commercial drones lost connection behind mountain ridges and crashed under thick tree canopy.”</a:t>
             </a:r>
           </a:p>
         </p:txBody>
@@ -10468,7 +10460,7 @@
         </p:nvSpPr>
         <p:spPr>
           <a:xfrm>
-            <a:off x="7498079" y="5120640"/>
+            <a:off x="7315200" y="5440680"/>
             <a:ext cx="548640" cy="73152"/>
           </a:xfrm>
           <a:prstGeom prst="roundRect">
@@ -10511,7 +10503,7 @@
         </p:nvSpPr>
         <p:spPr>
           <a:xfrm>
-            <a:off x="8138160" y="5120640"/>
+            <a:off x="7955279" y="5440680"/>
             <a:ext cx="109728" cy="73152"/>
           </a:xfrm>
           <a:prstGeom prst="roundRect">
@@ -10554,7 +10546,7 @@
         </p:nvSpPr>
         <p:spPr>
           <a:xfrm>
-            <a:off x="8321040" y="5120640"/>
+            <a:off x="8138160" y="5440680"/>
             <a:ext cx="109728" cy="73152"/>
           </a:xfrm>
           <a:prstGeom prst="roundRect">
@@ -10597,7 +10589,7 @@
         </p:nvSpPr>
         <p:spPr>
           <a:xfrm>
-            <a:off x="9144000" y="5047488"/>
+            <a:off x="9144000" y="5376672"/>
             <a:ext cx="2286000" cy="228600"/>
           </a:xfrm>
           <a:prstGeom prst="rect">

</xml_diff>

<commit_message>
style(slides): increase visual prominence and font size of slide section headers
</commit_message>
<xml_diff>
--- a/sutra_pitch_deck.pptx
+++ b/sutra_pitch_deck.pptx
@@ -8970,8 +8970,8 @@
         </p:nvSpPr>
         <p:spPr>
           <a:xfrm>
-            <a:off x="731520" y="594360"/>
-            <a:ext cx="73152" cy="274320"/>
+            <a:off x="731520" y="566928"/>
+            <a:ext cx="91440" cy="329184"/>
           </a:xfrm>
           <a:prstGeom prst="roundRect">
             <a:avLst/>
@@ -9013,8 +9013,8 @@
         </p:nvSpPr>
         <p:spPr>
           <a:xfrm>
-            <a:off x="914400" y="612648"/>
-            <a:ext cx="3657600" cy="274320"/>
+            <a:off x="960120" y="594360"/>
+            <a:ext cx="4114800" cy="320040"/>
           </a:xfrm>
           <a:prstGeom prst="rect">
             <a:avLst/>
@@ -9029,7 +9029,7 @@
           <a:p>
             <a:pPr algn="l"/>
             <a:r>
-              <a:rPr sz="1000" b="1" i="0">
+              <a:rPr sz="1300" b="1" i="0">
                 <a:solidFill>
                   <a:srgbClr val="0A1628"/>
                 </a:solidFill>
@@ -9048,8 +9048,8 @@
         </p:nvSpPr>
         <p:spPr>
           <a:xfrm>
-            <a:off x="8961120" y="566928"/>
-            <a:ext cx="2468880" cy="274320"/>
+            <a:off x="8778240" y="548640"/>
+            <a:ext cx="2651760" cy="329184"/>
           </a:xfrm>
           <a:prstGeom prst="roundRect">
             <a:avLst/>
@@ -9087,14 +9087,57 @@
       </p:sp>
       <p:sp>
         <p:nvSpPr>
-          <p:cNvPr id="45" name="TextBox 44"/>
+          <p:cNvPr id="45" name="Oval 44"/>
+          <p:cNvSpPr/>
+          <p:nvPr/>
+        </p:nvSpPr>
+        <p:spPr>
+          <a:xfrm>
+            <a:off x="8961120" y="658368"/>
+            <a:ext cx="91440" cy="91440"/>
+          </a:xfrm>
+          <a:prstGeom prst="ellipse">
+            <a:avLst/>
+          </a:prstGeom>
+          <a:solidFill>
+            <a:srgbClr val="D71920"/>
+          </a:solidFill>
+          <a:ln>
+            <a:noFill/>
+          </a:ln>
+        </p:spPr>
+        <p:style>
+          <a:lnRef idx="1">
+            <a:schemeClr val="accent1"/>
+          </a:lnRef>
+          <a:fillRef idx="3">
+            <a:schemeClr val="accent1"/>
+          </a:fillRef>
+          <a:effectRef idx="2">
+            <a:schemeClr val="accent1"/>
+          </a:effectRef>
+          <a:fontRef idx="minor">
+            <a:schemeClr val="lt1"/>
+          </a:fontRef>
+        </p:style>
+        <p:txBody>
+          <a:bodyPr rtlCol="0" anchor="ctr"/>
+          <a:lstStyle/>
+          <a:p>
+            <a:pPr algn="ctr"/>
+          </a:p>
+        </p:txBody>
+      </p:sp>
+      <p:sp>
+        <p:nvSpPr>
+          <p:cNvPr id="46" name="TextBox 45"/>
           <p:cNvSpPr txBox="1"/>
           <p:nvPr/>
         </p:nvSpPr>
         <p:spPr>
           <a:xfrm>
-            <a:off x="8961120" y="612648"/>
-            <a:ext cx="2468880" cy="182880"/>
+            <a:off x="9098280" y="603504"/>
+            <a:ext cx="2286000" cy="228600"/>
           </a:xfrm>
           <a:prstGeom prst="rect">
             <a:avLst/>
@@ -9109,7 +9152,7 @@
           <a:p>
             <a:pPr algn="ctr"/>
             <a:r>
-              <a:rPr sz="750" b="1" i="0">
+              <a:rPr sz="800" b="1" i="0">
                 <a:solidFill>
                   <a:srgbClr val="475569"/>
                 </a:solidFill>
@@ -9122,7 +9165,7 @@
       </p:sp>
       <p:sp>
         <p:nvSpPr>
-          <p:cNvPr id="46" name="TextBox 45"/>
+          <p:cNvPr id="47" name="TextBox 46"/>
           <p:cNvSpPr txBox="1"/>
           <p:nvPr/>
         </p:nvSpPr>
@@ -9157,7 +9200,7 @@
       </p:sp>
       <p:sp>
         <p:nvSpPr>
-          <p:cNvPr id="47" name="Oval 46"/>
+          <p:cNvPr id="48" name="Oval 47"/>
           <p:cNvSpPr/>
           <p:nvPr/>
         </p:nvSpPr>
@@ -9200,7 +9243,7 @@
       </p:sp>
       <p:sp>
         <p:nvSpPr>
-          <p:cNvPr id="48" name="TextBox 47"/>
+          <p:cNvPr id="49" name="TextBox 48"/>
           <p:cNvSpPr txBox="1"/>
           <p:nvPr/>
         </p:nvSpPr>
@@ -9235,7 +9278,7 @@
       </p:sp>
       <p:sp>
         <p:nvSpPr>
-          <p:cNvPr id="49" name="Oval 48"/>
+          <p:cNvPr id="50" name="Oval 49"/>
           <p:cNvSpPr/>
           <p:nvPr/>
         </p:nvSpPr>
@@ -9278,7 +9321,7 @@
       </p:sp>
       <p:sp>
         <p:nvSpPr>
-          <p:cNvPr id="50" name="TextBox 49"/>
+          <p:cNvPr id="51" name="TextBox 50"/>
           <p:cNvSpPr txBox="1"/>
           <p:nvPr/>
         </p:nvSpPr>
@@ -9313,7 +9356,7 @@
       </p:sp>
       <p:sp>
         <p:nvSpPr>
-          <p:cNvPr id="51" name="Oval 50"/>
+          <p:cNvPr id="52" name="Oval 51"/>
           <p:cNvSpPr/>
           <p:nvPr/>
         </p:nvSpPr>
@@ -9356,7 +9399,7 @@
       </p:sp>
       <p:sp>
         <p:nvSpPr>
-          <p:cNvPr id="52" name="TextBox 51"/>
+          <p:cNvPr id="53" name="TextBox 52"/>
           <p:cNvSpPr txBox="1"/>
           <p:nvPr/>
         </p:nvSpPr>
@@ -9391,7 +9434,7 @@
       </p:sp>
       <p:sp>
         <p:nvSpPr>
-          <p:cNvPr id="53" name="Oval 52"/>
+          <p:cNvPr id="54" name="Oval 53"/>
           <p:cNvSpPr/>
           <p:nvPr/>
         </p:nvSpPr>
@@ -9434,7 +9477,7 @@
       </p:sp>
       <p:sp>
         <p:nvSpPr>
-          <p:cNvPr id="54" name="TextBox 53"/>
+          <p:cNvPr id="55" name="TextBox 54"/>
           <p:cNvSpPr txBox="1"/>
           <p:nvPr/>
         </p:nvSpPr>
@@ -9469,7 +9512,7 @@
       </p:sp>
       <p:sp>
         <p:nvSpPr>
-          <p:cNvPr id="55" name="Oval 54"/>
+          <p:cNvPr id="56" name="Oval 55"/>
           <p:cNvSpPr/>
           <p:nvPr/>
         </p:nvSpPr>
@@ -9512,7 +9555,7 @@
       </p:sp>
       <p:sp>
         <p:nvSpPr>
-          <p:cNvPr id="56" name="TextBox 55"/>
+          <p:cNvPr id="57" name="TextBox 56"/>
           <p:cNvSpPr txBox="1"/>
           <p:nvPr/>
         </p:nvSpPr>
@@ -9547,7 +9590,7 @@
       </p:sp>
       <p:sp>
         <p:nvSpPr>
-          <p:cNvPr id="57" name="TextBox 56"/>
+          <p:cNvPr id="58" name="TextBox 57"/>
           <p:cNvSpPr txBox="1"/>
           <p:nvPr/>
         </p:nvSpPr>
@@ -9582,7 +9625,7 @@
       </p:sp>
       <p:sp>
         <p:nvSpPr>
-          <p:cNvPr id="58" name="Rounded Rectangle 57"/>
+          <p:cNvPr id="59" name="Rounded Rectangle 58"/>
           <p:cNvSpPr/>
           <p:nvPr/>
         </p:nvSpPr>
@@ -9627,7 +9670,7 @@
       </p:sp>
       <p:sp>
         <p:nvSpPr>
-          <p:cNvPr id="59" name="TextBox 58"/>
+          <p:cNvPr id="60" name="TextBox 59"/>
           <p:cNvSpPr txBox="1"/>
           <p:nvPr/>
         </p:nvSpPr>
@@ -9662,7 +9705,7 @@
       </p:sp>
       <p:sp>
         <p:nvSpPr>
-          <p:cNvPr id="60" name="TextBox 59"/>
+          <p:cNvPr id="61" name="TextBox 60"/>
           <p:cNvSpPr txBox="1"/>
           <p:nvPr/>
         </p:nvSpPr>
@@ -9697,7 +9740,7 @@
       </p:sp>
       <p:sp>
         <p:nvSpPr>
-          <p:cNvPr id="61" name="Rounded Rectangle 60"/>
+          <p:cNvPr id="62" name="Rounded Rectangle 61"/>
           <p:cNvSpPr/>
           <p:nvPr/>
         </p:nvSpPr>
@@ -9742,7 +9785,7 @@
       </p:sp>
       <p:sp>
         <p:nvSpPr>
-          <p:cNvPr id="62" name="TextBox 61"/>
+          <p:cNvPr id="63" name="TextBox 62"/>
           <p:cNvSpPr txBox="1"/>
           <p:nvPr/>
         </p:nvSpPr>
@@ -9777,7 +9820,7 @@
       </p:sp>
       <p:sp>
         <p:nvSpPr>
-          <p:cNvPr id="63" name="TextBox 62"/>
+          <p:cNvPr id="64" name="TextBox 63"/>
           <p:cNvSpPr txBox="1"/>
           <p:nvPr/>
         </p:nvSpPr>
@@ -9812,7 +9855,7 @@
       </p:sp>
       <p:sp>
         <p:nvSpPr>
-          <p:cNvPr id="64" name="Rounded Rectangle 63"/>
+          <p:cNvPr id="65" name="Rounded Rectangle 64"/>
           <p:cNvSpPr/>
           <p:nvPr/>
         </p:nvSpPr>
@@ -9857,7 +9900,7 @@
       </p:sp>
       <p:sp>
         <p:nvSpPr>
-          <p:cNvPr id="65" name="TextBox 64"/>
+          <p:cNvPr id="66" name="TextBox 65"/>
           <p:cNvSpPr txBox="1"/>
           <p:nvPr/>
         </p:nvSpPr>
@@ -9892,7 +9935,7 @@
       </p:sp>
       <p:sp>
         <p:nvSpPr>
-          <p:cNvPr id="66" name="TextBox 65"/>
+          <p:cNvPr id="67" name="TextBox 66"/>
           <p:cNvSpPr txBox="1"/>
           <p:nvPr/>
         </p:nvSpPr>
@@ -9927,7 +9970,7 @@
       </p:sp>
       <p:sp>
         <p:nvSpPr>
-          <p:cNvPr id="67" name="TextBox 66"/>
+          <p:cNvPr id="68" name="TextBox 67"/>
           <p:cNvSpPr txBox="1"/>
           <p:nvPr/>
         </p:nvSpPr>
@@ -9962,7 +10005,7 @@
       </p:sp>
       <p:sp>
         <p:nvSpPr>
-          <p:cNvPr id="68" name="TextBox 67"/>
+          <p:cNvPr id="69" name="TextBox 68"/>
           <p:cNvSpPr txBox="1"/>
           <p:nvPr/>
         </p:nvSpPr>
@@ -9997,7 +10040,7 @@
       </p:sp>
       <p:sp>
         <p:nvSpPr>
-          <p:cNvPr id="69" name="Rounded Rectangle 68"/>
+          <p:cNvPr id="70" name="Rounded Rectangle 69"/>
           <p:cNvSpPr/>
           <p:nvPr/>
         </p:nvSpPr>
@@ -10040,7 +10083,7 @@
       </p:sp>
       <p:sp>
         <p:nvSpPr>
-          <p:cNvPr id="70" name="Rounded Rectangle 69"/>
+          <p:cNvPr id="71" name="Rounded Rectangle 70"/>
           <p:cNvSpPr/>
           <p:nvPr/>
         </p:nvSpPr>
@@ -10083,7 +10126,7 @@
       </p:sp>
       <p:sp>
         <p:nvSpPr>
-          <p:cNvPr id="71" name="Rounded Rectangle 70"/>
+          <p:cNvPr id="72" name="Rounded Rectangle 71"/>
           <p:cNvSpPr/>
           <p:nvPr/>
         </p:nvSpPr>
@@ -10126,7 +10169,7 @@
       </p:sp>
       <p:pic>
         <p:nvPicPr>
-          <p:cNvPr id="72" name="Picture 71" descr="wayanad_rescue.jpg"/>
+          <p:cNvPr id="73" name="Picture 72" descr="wayanad_rescue.jpg"/>
           <p:cNvPicPr>
             <a:picLocks noChangeAspect="1"/>
           </p:cNvPicPr>
@@ -10150,7 +10193,7 @@
       </p:pic>
       <p:sp>
         <p:nvSpPr>
-          <p:cNvPr id="73" name="Rectangle 72"/>
+          <p:cNvPr id="74" name="Rectangle 73"/>
           <p:cNvSpPr/>
           <p:nvPr/>
         </p:nvSpPr>
@@ -10193,7 +10236,7 @@
       </p:sp>
       <p:sp>
         <p:nvSpPr>
-          <p:cNvPr id="74" name="Oval 73"/>
+          <p:cNvPr id="75" name="Oval 74"/>
           <p:cNvSpPr/>
           <p:nvPr/>
         </p:nvSpPr>
@@ -10236,7 +10279,7 @@
       </p:sp>
       <p:sp>
         <p:nvSpPr>
-          <p:cNvPr id="75" name="Rounded Rectangle 74"/>
+          <p:cNvPr id="76" name="Rounded Rectangle 75"/>
           <p:cNvSpPr/>
           <p:nvPr/>
         </p:nvSpPr>
@@ -10279,7 +10322,7 @@
       </p:sp>
       <p:sp>
         <p:nvSpPr>
-          <p:cNvPr id="76" name="TextBox 75"/>
+          <p:cNvPr id="77" name="TextBox 76"/>
           <p:cNvSpPr txBox="1"/>
           <p:nvPr/>
         </p:nvSpPr>
@@ -10314,7 +10357,7 @@
       </p:sp>
       <p:sp>
         <p:nvSpPr>
-          <p:cNvPr id="77" name="TextBox 76"/>
+          <p:cNvPr id="78" name="TextBox 77"/>
           <p:cNvSpPr txBox="1"/>
           <p:nvPr/>
         </p:nvSpPr>
@@ -10349,7 +10392,7 @@
       </p:sp>
       <p:sp>
         <p:nvSpPr>
-          <p:cNvPr id="78" name="TextBox 77"/>
+          <p:cNvPr id="79" name="TextBox 78"/>
           <p:cNvSpPr txBox="1"/>
           <p:nvPr/>
         </p:nvSpPr>
@@ -10384,7 +10427,7 @@
       </p:sp>
       <p:sp>
         <p:nvSpPr>
-          <p:cNvPr id="79" name="TextBox 78"/>
+          <p:cNvPr id="80" name="TextBox 79"/>
           <p:cNvSpPr txBox="1"/>
           <p:nvPr/>
         </p:nvSpPr>
@@ -10419,7 +10462,7 @@
       </p:sp>
       <p:sp>
         <p:nvSpPr>
-          <p:cNvPr id="80" name="TextBox 79"/>
+          <p:cNvPr id="81" name="TextBox 80"/>
           <p:cNvSpPr txBox="1"/>
           <p:nvPr/>
         </p:nvSpPr>
@@ -10454,7 +10497,7 @@
       </p:sp>
       <p:sp>
         <p:nvSpPr>
-          <p:cNvPr id="81" name="Rounded Rectangle 80"/>
+          <p:cNvPr id="82" name="Rounded Rectangle 81"/>
           <p:cNvSpPr/>
           <p:nvPr/>
         </p:nvSpPr>
@@ -10497,7 +10540,7 @@
       </p:sp>
       <p:sp>
         <p:nvSpPr>
-          <p:cNvPr id="82" name="Rounded Rectangle 81"/>
+          <p:cNvPr id="83" name="Rounded Rectangle 82"/>
           <p:cNvSpPr/>
           <p:nvPr/>
         </p:nvSpPr>
@@ -10540,7 +10583,7 @@
       </p:sp>
       <p:sp>
         <p:nvSpPr>
-          <p:cNvPr id="83" name="Rounded Rectangle 82"/>
+          <p:cNvPr id="84" name="Rounded Rectangle 83"/>
           <p:cNvSpPr/>
           <p:nvPr/>
         </p:nvSpPr>
@@ -10583,7 +10626,7 @@
       </p:sp>
       <p:sp>
         <p:nvSpPr>
-          <p:cNvPr id="84" name="TextBox 83"/>
+          <p:cNvPr id="85" name="TextBox 84"/>
           <p:cNvSpPr txBox="1"/>
           <p:nvPr/>
         </p:nvSpPr>
@@ -10618,7 +10661,7 @@
       </p:sp>
       <p:sp>
         <p:nvSpPr>
-          <p:cNvPr id="85" name="Rectangle 84"/>
+          <p:cNvPr id="86" name="Rectangle 85"/>
           <p:cNvSpPr/>
           <p:nvPr/>
         </p:nvSpPr>
@@ -10661,7 +10704,7 @@
       </p:sp>
       <p:sp>
         <p:nvSpPr>
-          <p:cNvPr id="86" name="TextBox 85"/>
+          <p:cNvPr id="87" name="TextBox 86"/>
           <p:cNvSpPr txBox="1"/>
           <p:nvPr/>
         </p:nvSpPr>
@@ -10696,7 +10739,7 @@
       </p:sp>
       <p:sp>
         <p:nvSpPr>
-          <p:cNvPr id="87" name="TextBox 86"/>
+          <p:cNvPr id="88" name="TextBox 87"/>
           <p:cNvSpPr txBox="1"/>
           <p:nvPr/>
         </p:nvSpPr>

</xml_diff>

<commit_message>
feat(slides): integrate high-res 3D isometric generated illustrations on Slide 2 failure modes
</commit_message>
<xml_diff>
--- a/sutra_pitch_deck.pptx
+++ b/sutra_pitch_deck.pptx
@@ -9631,8 +9631,8 @@
         </p:nvSpPr>
         <p:spPr>
           <a:xfrm>
-            <a:off x="731520" y="4846320"/>
-            <a:ext cx="2011680" cy="822960"/>
+            <a:off x="731520" y="4828032"/>
+            <a:ext cx="2011680" cy="932688"/>
           </a:xfrm>
           <a:prstGeom prst="roundRect">
             <a:avLst/>
@@ -9668,16 +9668,40 @@
           </a:p>
         </p:txBody>
       </p:sp>
-      <p:sp>
-        <p:nvSpPr>
-          <p:cNvPr id="60" name="TextBox 59"/>
+      <p:pic>
+        <p:nvPicPr>
+          <p:cNvPr id="60" name="Picture 59" descr="rf_mountain_shadow.jpg"/>
+          <p:cNvPicPr>
+            <a:picLocks noChangeAspect="1"/>
+          </p:cNvPicPr>
+          <p:nvPr/>
+        </p:nvPicPr>
+        <p:blipFill>
+          <a:blip r:embed="rId2"/>
+          <a:stretch>
+            <a:fillRect/>
+          </a:stretch>
+        </p:blipFill>
+        <p:spPr>
+          <a:xfrm>
+            <a:off x="786384" y="4864608"/>
+            <a:ext cx="1901952" cy="502920"/>
+          </a:xfrm>
+          <a:prstGeom prst="rect">
+            <a:avLst/>
+          </a:prstGeom>
+        </p:spPr>
+      </p:pic>
+      <p:sp>
+        <p:nvSpPr>
+          <p:cNvPr id="61" name="TextBox 60"/>
           <p:cNvSpPr txBox="1"/>
           <p:nvPr/>
         </p:nvSpPr>
         <p:spPr>
           <a:xfrm>
-            <a:off x="841248" y="4919472"/>
-            <a:ext cx="1792224" cy="228600"/>
+            <a:off x="804672" y="5413248"/>
+            <a:ext cx="1865376" cy="182880"/>
           </a:xfrm>
           <a:prstGeom prst="rect">
             <a:avLst/>
@@ -9692,7 +9716,7 @@
           <a:p>
             <a:pPr algn="l"/>
             <a:r>
-              <a:rPr sz="850" b="1" i="0">
+              <a:rPr sz="800" b="1" i="0">
                 <a:solidFill>
                   <a:srgbClr val="000000"/>
                 </a:solidFill>
@@ -9705,14 +9729,14 @@
       </p:sp>
       <p:sp>
         <p:nvSpPr>
-          <p:cNvPr id="61" name="TextBox 60"/>
+          <p:cNvPr id="62" name="TextBox 61"/>
           <p:cNvSpPr txBox="1"/>
           <p:nvPr/>
         </p:nvSpPr>
         <p:spPr>
           <a:xfrm>
-            <a:off x="841248" y="5138928"/>
-            <a:ext cx="1792224" cy="182880"/>
+            <a:off x="804672" y="5577840"/>
+            <a:ext cx="1865376" cy="164592"/>
           </a:xfrm>
           <a:prstGeom prst="rect">
             <a:avLst/>
@@ -9727,27 +9751,27 @@
           <a:p>
             <a:pPr algn="l"/>
             <a:r>
-              <a:rPr sz="700" b="0" i="0">
+              <a:rPr sz="650" b="0" i="0">
                 <a:solidFill>
                   <a:srgbClr val="64748B"/>
                 </a:solidFill>
                 <a:latin typeface="JetBrains Mono"/>
               </a:rPr>
-              <a:t>Video Stream Drop</a:t>
-            </a:r>
-          </a:p>
-        </p:txBody>
-      </p:sp>
-      <p:sp>
-        <p:nvSpPr>
-          <p:cNvPr id="62" name="Rounded Rectangle 61"/>
-          <p:cNvSpPr/>
-          <p:nvPr/>
-        </p:nvSpPr>
-        <p:spPr>
-          <a:xfrm>
-            <a:off x="2907792" y="4846320"/>
-            <a:ext cx="2011680" cy="822960"/>
+              <a:t>Video Stream Severance</a:t>
+            </a:r>
+          </a:p>
+        </p:txBody>
+      </p:sp>
+      <p:sp>
+        <p:nvSpPr>
+          <p:cNvPr id="63" name="Rounded Rectangle 62"/>
+          <p:cNvSpPr/>
+          <p:nvPr/>
+        </p:nvSpPr>
+        <p:spPr>
+          <a:xfrm>
+            <a:off x="2907792" y="4828032"/>
+            <a:ext cx="2011680" cy="932688"/>
           </a:xfrm>
           <a:prstGeom prst="roundRect">
             <a:avLst/>
@@ -9783,16 +9807,40 @@
           </a:p>
         </p:txBody>
       </p:sp>
-      <p:sp>
-        <p:nvSpPr>
-          <p:cNvPr id="63" name="TextBox 62"/>
+      <p:pic>
+        <p:nvPicPr>
+          <p:cNvPr id="64" name="Picture 63" descr="gps_canopy_shadow.jpg"/>
+          <p:cNvPicPr>
+            <a:picLocks noChangeAspect="1"/>
+          </p:cNvPicPr>
+          <p:nvPr/>
+        </p:nvPicPr>
+        <p:blipFill>
+          <a:blip r:embed="rId3"/>
+          <a:stretch>
+            <a:fillRect/>
+          </a:stretch>
+        </p:blipFill>
+        <p:spPr>
+          <a:xfrm>
+            <a:off x="2962656" y="4864608"/>
+            <a:ext cx="1901952" cy="502920"/>
+          </a:xfrm>
+          <a:prstGeom prst="rect">
+            <a:avLst/>
+          </a:prstGeom>
+        </p:spPr>
+      </p:pic>
+      <p:sp>
+        <p:nvSpPr>
+          <p:cNvPr id="65" name="TextBox 64"/>
           <p:cNvSpPr txBox="1"/>
           <p:nvPr/>
         </p:nvSpPr>
         <p:spPr>
           <a:xfrm>
-            <a:off x="3017520" y="4919472"/>
-            <a:ext cx="1792224" cy="228600"/>
+            <a:off x="2980944" y="5413248"/>
+            <a:ext cx="1865376" cy="182880"/>
           </a:xfrm>
           <a:prstGeom prst="rect">
             <a:avLst/>
@@ -9807,7 +9855,7 @@
           <a:p>
             <a:pPr algn="l"/>
             <a:r>
-              <a:rPr sz="850" b="1" i="0">
+              <a:rPr sz="800" b="1" i="0">
                 <a:solidFill>
                   <a:srgbClr val="000000"/>
                 </a:solidFill>
@@ -9820,14 +9868,14 @@
       </p:sp>
       <p:sp>
         <p:nvSpPr>
-          <p:cNvPr id="64" name="TextBox 63"/>
+          <p:cNvPr id="66" name="TextBox 65"/>
           <p:cNvSpPr txBox="1"/>
           <p:nvPr/>
         </p:nvSpPr>
         <p:spPr>
           <a:xfrm>
-            <a:off x="3017520" y="5138928"/>
-            <a:ext cx="1792224" cy="182880"/>
+            <a:off x="2980944" y="5577840"/>
+            <a:ext cx="1865376" cy="164592"/>
           </a:xfrm>
           <a:prstGeom prst="rect">
             <a:avLst/>
@@ -9842,27 +9890,27 @@
           <a:p>
             <a:pPr algn="l"/>
             <a:r>
-              <a:rPr sz="700" b="0" i="0">
+              <a:rPr sz="650" b="0" i="0">
                 <a:solidFill>
                   <a:srgbClr val="64748B"/>
                 </a:solidFill>
                 <a:latin typeface="JetBrains Mono"/>
               </a:rPr>
-              <a:t>GNSS Multi-Path</a:t>
-            </a:r>
-          </a:p>
-        </p:txBody>
-      </p:sp>
-      <p:sp>
-        <p:nvSpPr>
-          <p:cNvPr id="65" name="Rounded Rectangle 64"/>
-          <p:cNvSpPr/>
-          <p:nvPr/>
-        </p:nvSpPr>
-        <p:spPr>
-          <a:xfrm>
-            <a:off x="5084064" y="4846320"/>
-            <a:ext cx="2011680" cy="822960"/>
+              <a:t>GNSS Multi-Path Drift</a:t>
+            </a:r>
+          </a:p>
+        </p:txBody>
+      </p:sp>
+      <p:sp>
+        <p:nvSpPr>
+          <p:cNvPr id="67" name="Rounded Rectangle 66"/>
+          <p:cNvSpPr/>
+          <p:nvPr/>
+        </p:nvSpPr>
+        <p:spPr>
+          <a:xfrm>
+            <a:off x="5084064" y="4828032"/>
+            <a:ext cx="2011680" cy="932688"/>
           </a:xfrm>
           <a:prstGeom prst="roundRect">
             <a:avLst/>
@@ -9898,16 +9946,40 @@
           </a:p>
         </p:txBody>
       </p:sp>
-      <p:sp>
-        <p:nvSpPr>
-          <p:cNvPr id="66" name="TextBox 65"/>
+      <p:pic>
+        <p:nvPicPr>
+          <p:cNvPr id="68" name="Picture 67" descr="single_link_loss.jpg"/>
+          <p:cNvPicPr>
+            <a:picLocks noChangeAspect="1"/>
+          </p:cNvPicPr>
+          <p:nvPr/>
+        </p:nvPicPr>
+        <p:blipFill>
+          <a:blip r:embed="rId4"/>
+          <a:stretch>
+            <a:fillRect/>
+          </a:stretch>
+        </p:blipFill>
+        <p:spPr>
+          <a:xfrm>
+            <a:off x="5138928" y="4864608"/>
+            <a:ext cx="1901952" cy="502920"/>
+          </a:xfrm>
+          <a:prstGeom prst="rect">
+            <a:avLst/>
+          </a:prstGeom>
+        </p:spPr>
+      </p:pic>
+      <p:sp>
+        <p:nvSpPr>
+          <p:cNvPr id="69" name="TextBox 68"/>
           <p:cNvSpPr txBox="1"/>
           <p:nvPr/>
         </p:nvSpPr>
         <p:spPr>
           <a:xfrm>
-            <a:off x="5193792" y="4919472"/>
-            <a:ext cx="1792224" cy="228600"/>
+            <a:off x="5157216" y="5413248"/>
+            <a:ext cx="1865376" cy="182880"/>
           </a:xfrm>
           <a:prstGeom prst="rect">
             <a:avLst/>
@@ -9922,7 +9994,7 @@
           <a:p>
             <a:pPr algn="l"/>
             <a:r>
-              <a:rPr sz="850" b="1" i="0">
+              <a:rPr sz="800" b="1" i="0">
                 <a:solidFill>
                   <a:srgbClr val="000000"/>
                 </a:solidFill>
@@ -9935,14 +10007,14 @@
       </p:sp>
       <p:sp>
         <p:nvSpPr>
-          <p:cNvPr id="67" name="TextBox 66"/>
+          <p:cNvPr id="70" name="TextBox 69"/>
           <p:cNvSpPr txBox="1"/>
           <p:nvPr/>
         </p:nvSpPr>
         <p:spPr>
           <a:xfrm>
-            <a:off x="5193792" y="5138928"/>
-            <a:ext cx="1792224" cy="182880"/>
+            <a:off x="5157216" y="5577840"/>
+            <a:ext cx="1865376" cy="164592"/>
           </a:xfrm>
           <a:prstGeom prst="rect">
             <a:avLst/>
@@ -9957,7 +10029,7 @@
           <a:p>
             <a:pPr algn="l"/>
             <a:r>
-              <a:rPr sz="700" b="0" i="0">
+              <a:rPr sz="650" b="0" i="0">
                 <a:solidFill>
                   <a:srgbClr val="64748B"/>
                 </a:solidFill>
@@ -9970,7 +10042,7 @@
       </p:sp>
       <p:sp>
         <p:nvSpPr>
-          <p:cNvPr id="68" name="TextBox 67"/>
+          <p:cNvPr id="71" name="TextBox 70"/>
           <p:cNvSpPr txBox="1"/>
           <p:nvPr/>
         </p:nvSpPr>
@@ -10005,7 +10077,7 @@
       </p:sp>
       <p:sp>
         <p:nvSpPr>
-          <p:cNvPr id="69" name="TextBox 68"/>
+          <p:cNvPr id="72" name="TextBox 71"/>
           <p:cNvSpPr txBox="1"/>
           <p:nvPr/>
         </p:nvSpPr>
@@ -10040,7 +10112,7 @@
       </p:sp>
       <p:sp>
         <p:nvSpPr>
-          <p:cNvPr id="70" name="Rounded Rectangle 69"/>
+          <p:cNvPr id="73" name="Rounded Rectangle 72"/>
           <p:cNvSpPr/>
           <p:nvPr/>
         </p:nvSpPr>
@@ -10083,7 +10155,7 @@
       </p:sp>
       <p:sp>
         <p:nvSpPr>
-          <p:cNvPr id="71" name="Rounded Rectangle 70"/>
+          <p:cNvPr id="74" name="Rounded Rectangle 73"/>
           <p:cNvSpPr/>
           <p:nvPr/>
         </p:nvSpPr>
@@ -10126,7 +10198,7 @@
       </p:sp>
       <p:sp>
         <p:nvSpPr>
-          <p:cNvPr id="72" name="Rounded Rectangle 71"/>
+          <p:cNvPr id="75" name="Rounded Rectangle 74"/>
           <p:cNvSpPr/>
           <p:nvPr/>
         </p:nvSpPr>
@@ -10169,14 +10241,14 @@
       </p:sp>
       <p:pic>
         <p:nvPicPr>
-          <p:cNvPr id="73" name="Picture 72" descr="wayanad_rescue.jpg"/>
+          <p:cNvPr id="76" name="Picture 75" descr="wayanad_rescue.jpg"/>
           <p:cNvPicPr>
             <a:picLocks noChangeAspect="1"/>
           </p:cNvPicPr>
           <p:nvPr/>
         </p:nvPicPr>
         <p:blipFill>
-          <a:blip r:embed="rId2"/>
+          <a:blip r:embed="rId5"/>
           <a:stretch>
             <a:fillRect/>
           </a:stretch>
@@ -10193,7 +10265,7 @@
       </p:pic>
       <p:sp>
         <p:nvSpPr>
-          <p:cNvPr id="74" name="Rectangle 73"/>
+          <p:cNvPr id="77" name="Rectangle 76"/>
           <p:cNvSpPr/>
           <p:nvPr/>
         </p:nvSpPr>
@@ -10236,7 +10308,7 @@
       </p:sp>
       <p:sp>
         <p:nvSpPr>
-          <p:cNvPr id="75" name="Oval 74"/>
+          <p:cNvPr id="78" name="Oval 77"/>
           <p:cNvSpPr/>
           <p:nvPr/>
         </p:nvSpPr>
@@ -10279,7 +10351,7 @@
       </p:sp>
       <p:sp>
         <p:nvSpPr>
-          <p:cNvPr id="76" name="Rounded Rectangle 75"/>
+          <p:cNvPr id="79" name="Rounded Rectangle 78"/>
           <p:cNvSpPr/>
           <p:nvPr/>
         </p:nvSpPr>
@@ -10322,7 +10394,7 @@
       </p:sp>
       <p:sp>
         <p:nvSpPr>
-          <p:cNvPr id="77" name="TextBox 76"/>
+          <p:cNvPr id="80" name="TextBox 79"/>
           <p:cNvSpPr txBox="1"/>
           <p:nvPr/>
         </p:nvSpPr>
@@ -10357,7 +10429,7 @@
       </p:sp>
       <p:sp>
         <p:nvSpPr>
-          <p:cNvPr id="78" name="TextBox 77"/>
+          <p:cNvPr id="81" name="TextBox 80"/>
           <p:cNvSpPr txBox="1"/>
           <p:nvPr/>
         </p:nvSpPr>
@@ -10392,7 +10464,7 @@
       </p:sp>
       <p:sp>
         <p:nvSpPr>
-          <p:cNvPr id="79" name="TextBox 78"/>
+          <p:cNvPr id="82" name="TextBox 81"/>
           <p:cNvSpPr txBox="1"/>
           <p:nvPr/>
         </p:nvSpPr>
@@ -10427,7 +10499,7 @@
       </p:sp>
       <p:sp>
         <p:nvSpPr>
-          <p:cNvPr id="80" name="TextBox 79"/>
+          <p:cNvPr id="83" name="TextBox 82"/>
           <p:cNvSpPr txBox="1"/>
           <p:nvPr/>
         </p:nvSpPr>
@@ -10462,7 +10534,7 @@
       </p:sp>
       <p:sp>
         <p:nvSpPr>
-          <p:cNvPr id="81" name="TextBox 80"/>
+          <p:cNvPr id="84" name="TextBox 83"/>
           <p:cNvSpPr txBox="1"/>
           <p:nvPr/>
         </p:nvSpPr>
@@ -10497,7 +10569,7 @@
       </p:sp>
       <p:sp>
         <p:nvSpPr>
-          <p:cNvPr id="82" name="Rounded Rectangle 81"/>
+          <p:cNvPr id="85" name="Rounded Rectangle 84"/>
           <p:cNvSpPr/>
           <p:nvPr/>
         </p:nvSpPr>
@@ -10540,7 +10612,7 @@
       </p:sp>
       <p:sp>
         <p:nvSpPr>
-          <p:cNvPr id="83" name="Rounded Rectangle 82"/>
+          <p:cNvPr id="86" name="Rounded Rectangle 85"/>
           <p:cNvSpPr/>
           <p:nvPr/>
         </p:nvSpPr>
@@ -10583,7 +10655,7 @@
       </p:sp>
       <p:sp>
         <p:nvSpPr>
-          <p:cNvPr id="84" name="Rounded Rectangle 83"/>
+          <p:cNvPr id="87" name="Rounded Rectangle 86"/>
           <p:cNvSpPr/>
           <p:nvPr/>
         </p:nvSpPr>
@@ -10626,7 +10698,7 @@
       </p:sp>
       <p:sp>
         <p:nvSpPr>
-          <p:cNvPr id="85" name="TextBox 84"/>
+          <p:cNvPr id="88" name="TextBox 87"/>
           <p:cNvSpPr txBox="1"/>
           <p:nvPr/>
         </p:nvSpPr>
@@ -10661,7 +10733,7 @@
       </p:sp>
       <p:sp>
         <p:nvSpPr>
-          <p:cNvPr id="86" name="Rectangle 85"/>
+          <p:cNvPr id="89" name="Rectangle 88"/>
           <p:cNvSpPr/>
           <p:nvPr/>
         </p:nvSpPr>
@@ -10704,7 +10776,7 @@
       </p:sp>
       <p:sp>
         <p:nvSpPr>
-          <p:cNvPr id="87" name="TextBox 86"/>
+          <p:cNvPr id="90" name="TextBox 89"/>
           <p:cNvSpPr txBox="1"/>
           <p:nvPr/>
         </p:nvSpPr>
@@ -10739,7 +10811,7 @@
       </p:sp>
       <p:sp>
         <p:nvSpPr>
-          <p:cNvPr id="88" name="TextBox 87"/>
+          <p:cNvPr id="91" name="TextBox 90"/>
           <p:cNvSpPr txBox="1"/>
           <p:nvPr/>
         </p:nvSpPr>

</xml_diff>

<commit_message>
style(slides): increase main headline font size on Slide 2 for greater visual impact
</commit_message>
<xml_diff>
--- a/sutra_pitch_deck.pptx
+++ b/sutra_pitch_deck.pptx
@@ -9171,8 +9171,8 @@
         </p:nvSpPr>
         <p:spPr>
           <a:xfrm>
-            <a:off x="731520" y="1234440"/>
-            <a:ext cx="6400800" cy="1005840"/>
+            <a:off x="731520" y="1188720"/>
+            <a:ext cx="6400800" cy="1097280"/>
           </a:xfrm>
           <a:prstGeom prst="rect">
             <a:avLst/>
@@ -9187,7 +9187,7 @@
           <a:p>
             <a:pPr algn="l"/>
             <a:r>
-              <a:rPr sz="2800" b="1" i="0">
+              <a:rPr sz="3200" b="1" i="0">
                 <a:solidFill>
                   <a:srgbClr val="000000"/>
                 </a:solidFill>
@@ -9206,7 +9206,7 @@
         </p:nvSpPr>
         <p:spPr>
           <a:xfrm>
-            <a:off x="749808" y="2386584"/>
+            <a:off x="749808" y="2432304"/>
             <a:ext cx="82296" cy="82296"/>
           </a:xfrm>
           <a:prstGeom prst="ellipse">
@@ -9249,7 +9249,7 @@
         </p:nvSpPr>
         <p:spPr>
           <a:xfrm>
-            <a:off x="932688" y="2331720"/>
+            <a:off x="932688" y="2377440"/>
             <a:ext cx="6217920" cy="365760"/>
           </a:xfrm>
           <a:prstGeom prst="rect">
@@ -9284,7 +9284,7 @@
         </p:nvSpPr>
         <p:spPr>
           <a:xfrm>
-            <a:off x="749808" y="2825496"/>
+            <a:off x="749808" y="2871216"/>
             <a:ext cx="82296" cy="82296"/>
           </a:xfrm>
           <a:prstGeom prst="ellipse">
@@ -9327,7 +9327,7 @@
         </p:nvSpPr>
         <p:spPr>
           <a:xfrm>
-            <a:off x="932688" y="2770632"/>
+            <a:off x="932688" y="2816352"/>
             <a:ext cx="6217920" cy="365760"/>
           </a:xfrm>
           <a:prstGeom prst="rect">
@@ -9362,7 +9362,7 @@
         </p:nvSpPr>
         <p:spPr>
           <a:xfrm>
-            <a:off x="749808" y="3264408"/>
+            <a:off x="749808" y="3310128"/>
             <a:ext cx="82296" cy="82296"/>
           </a:xfrm>
           <a:prstGeom prst="ellipse">
@@ -9405,7 +9405,7 @@
         </p:nvSpPr>
         <p:spPr>
           <a:xfrm>
-            <a:off x="932688" y="3209544"/>
+            <a:off x="932688" y="3255264"/>
             <a:ext cx="6217920" cy="365760"/>
           </a:xfrm>
           <a:prstGeom prst="rect">
@@ -9440,7 +9440,7 @@
         </p:nvSpPr>
         <p:spPr>
           <a:xfrm>
-            <a:off x="749808" y="3703320"/>
+            <a:off x="749808" y="3749040"/>
             <a:ext cx="82296" cy="82296"/>
           </a:xfrm>
           <a:prstGeom prst="ellipse">
@@ -9483,7 +9483,7 @@
         </p:nvSpPr>
         <p:spPr>
           <a:xfrm>
-            <a:off x="932688" y="3648456"/>
+            <a:off x="932688" y="3694176"/>
             <a:ext cx="6217920" cy="365760"/>
           </a:xfrm>
           <a:prstGeom prst="rect">
@@ -9518,7 +9518,7 @@
         </p:nvSpPr>
         <p:spPr>
           <a:xfrm>
-            <a:off x="749808" y="4142232"/>
+            <a:off x="749808" y="4187952"/>
             <a:ext cx="82296" cy="82296"/>
           </a:xfrm>
           <a:prstGeom prst="ellipse">
@@ -9561,7 +9561,7 @@
         </p:nvSpPr>
         <p:spPr>
           <a:xfrm>
-            <a:off x="932688" y="4087368"/>
+            <a:off x="932688" y="4133088"/>
             <a:ext cx="6217920" cy="365760"/>
           </a:xfrm>
           <a:prstGeom prst="rect">

</xml_diff>

<commit_message>
feat(slides): add Slide 3 Solution & Swarm Search Benchmark with speed comparison bars
</commit_message>
<xml_diff>
--- a/sutra_pitch_deck.pptx
+++ b/sutra_pitch_deck.pptx
@@ -7,6 +7,7 @@
   <p:sldIdLst>
     <p:sldId id="256" r:id="rId7"/>
     <p:sldId id="257" r:id="rId8"/>
+    <p:sldId id="258" r:id="rId9"/>
   </p:sldIdLst>
   <p:sldSz cx="12191695" cy="6858000" type="screen4x3"/>
   <p:notesSz cx="6858000" cy="9144000"/>
@@ -10812,6 +10813,4540 @@
       <p:sp>
         <p:nvSpPr>
           <p:cNvPr id="91" name="TextBox 90"/>
+          <p:cNvSpPr txBox="1"/>
+          <p:nvPr/>
+        </p:nvSpPr>
+        <p:spPr>
+          <a:xfrm>
+            <a:off x="6858000" y="6080760"/>
+            <a:ext cx="4602175" cy="274320"/>
+          </a:xfrm>
+          <a:prstGeom prst="rect">
+            <a:avLst/>
+          </a:prstGeom>
+          <a:noFill/>
+        </p:spPr>
+        <p:txBody>
+          <a:bodyPr wrap="square" lIns="0" tIns="0" rIns="0" bIns="0">
+            <a:spAutoFit/>
+          </a:bodyPr>
+          <a:lstStyle/>
+          <a:p>
+            <a:pPr algn="r"/>
+            <a:r>
+              <a:rPr sz="900" b="1" i="0">
+                <a:solidFill>
+                  <a:srgbClr val="0A1628"/>
+                </a:solidFill>
+                <a:latin typeface="JetBrains Mono"/>
+              </a:rPr>
+              <a:t>TEAM OFFGRID — PROJECT SUTRA</a:t>
+            </a:r>
+          </a:p>
+        </p:txBody>
+      </p:sp>
+    </p:spTree>
+  </p:cSld>
+  <p:clrMapOvr>
+    <a:masterClrMapping/>
+  </p:clrMapOvr>
+</p:sld>
+</file>
+
+<file path=ppt/slides/slide3.xml><?xml version="1.0" encoding="utf-8"?>
+<p:sld xmlns:a="http://schemas.openxmlformats.org/drawingml/2006/main" xmlns:p="http://schemas.openxmlformats.org/presentationml/2006/main" xmlns:r="http://schemas.openxmlformats.org/officeDocument/2006/relationships">
+  <p:cSld>
+    <p:spTree>
+      <p:nvGrpSpPr>
+        <p:cNvPr id="1" name=""/>
+        <p:cNvGrpSpPr/>
+        <p:nvPr/>
+      </p:nvGrpSpPr>
+      <p:grpSpPr/>
+      <p:sp>
+        <p:nvSpPr>
+          <p:cNvPr id="2" name="Rectangle 1"/>
+          <p:cNvSpPr/>
+          <p:nvPr/>
+        </p:nvSpPr>
+        <p:spPr>
+          <a:xfrm>
+            <a:off x="0" y="0"/>
+            <a:ext cx="12191695" cy="6858000"/>
+          </a:xfrm>
+          <a:prstGeom prst="rect">
+            <a:avLst/>
+          </a:prstGeom>
+          <a:solidFill>
+            <a:srgbClr val="FFFFFF"/>
+          </a:solidFill>
+          <a:ln>
+            <a:noFill/>
+          </a:ln>
+        </p:spPr>
+        <p:style>
+          <a:lnRef idx="1">
+            <a:schemeClr val="accent1"/>
+          </a:lnRef>
+          <a:fillRef idx="3">
+            <a:schemeClr val="accent1"/>
+          </a:fillRef>
+          <a:effectRef idx="2">
+            <a:schemeClr val="accent1"/>
+          </a:effectRef>
+          <a:fontRef idx="minor">
+            <a:schemeClr val="lt1"/>
+          </a:fontRef>
+        </p:style>
+        <p:txBody>
+          <a:bodyPr rtlCol="0" anchor="ctr"/>
+          <a:lstStyle/>
+          <a:p>
+            <a:pPr algn="ctr"/>
+          </a:p>
+        </p:txBody>
+      </p:sp>
+      <p:sp>
+        <p:nvSpPr>
+          <p:cNvPr id="3" name="Rectangle 2"/>
+          <p:cNvSpPr/>
+          <p:nvPr/>
+        </p:nvSpPr>
+        <p:spPr>
+          <a:xfrm>
+            <a:off x="457200" y="0"/>
+            <a:ext cx="7315" cy="6858000"/>
+          </a:xfrm>
+          <a:prstGeom prst="rect">
+            <a:avLst/>
+          </a:prstGeom>
+          <a:solidFill>
+            <a:srgbClr val="E2E8F0"/>
+          </a:solidFill>
+          <a:ln>
+            <a:noFill/>
+          </a:ln>
+        </p:spPr>
+        <p:style>
+          <a:lnRef idx="1">
+            <a:schemeClr val="accent1"/>
+          </a:lnRef>
+          <a:fillRef idx="3">
+            <a:schemeClr val="accent1"/>
+          </a:fillRef>
+          <a:effectRef idx="2">
+            <a:schemeClr val="accent1"/>
+          </a:effectRef>
+          <a:fontRef idx="minor">
+            <a:schemeClr val="lt1"/>
+          </a:fontRef>
+        </p:style>
+        <p:txBody>
+          <a:bodyPr rtlCol="0" anchor="ctr"/>
+          <a:lstStyle/>
+          <a:p>
+            <a:pPr algn="ctr"/>
+          </a:p>
+        </p:txBody>
+      </p:sp>
+      <p:sp>
+        <p:nvSpPr>
+          <p:cNvPr id="4" name="Rectangle 3"/>
+          <p:cNvSpPr/>
+          <p:nvPr/>
+        </p:nvSpPr>
+        <p:spPr>
+          <a:xfrm>
+            <a:off x="914400" y="0"/>
+            <a:ext cx="7315" cy="6858000"/>
+          </a:xfrm>
+          <a:prstGeom prst="rect">
+            <a:avLst/>
+          </a:prstGeom>
+          <a:solidFill>
+            <a:srgbClr val="E2E8F0"/>
+          </a:solidFill>
+          <a:ln>
+            <a:noFill/>
+          </a:ln>
+        </p:spPr>
+        <p:style>
+          <a:lnRef idx="1">
+            <a:schemeClr val="accent1"/>
+          </a:lnRef>
+          <a:fillRef idx="3">
+            <a:schemeClr val="accent1"/>
+          </a:fillRef>
+          <a:effectRef idx="2">
+            <a:schemeClr val="accent1"/>
+          </a:effectRef>
+          <a:fontRef idx="minor">
+            <a:schemeClr val="lt1"/>
+          </a:fontRef>
+        </p:style>
+        <p:txBody>
+          <a:bodyPr rtlCol="0" anchor="ctr"/>
+          <a:lstStyle/>
+          <a:p>
+            <a:pPr algn="ctr"/>
+          </a:p>
+        </p:txBody>
+      </p:sp>
+      <p:sp>
+        <p:nvSpPr>
+          <p:cNvPr id="5" name="Rectangle 4"/>
+          <p:cNvSpPr/>
+          <p:nvPr/>
+        </p:nvSpPr>
+        <p:spPr>
+          <a:xfrm>
+            <a:off x="1371600" y="0"/>
+            <a:ext cx="7315" cy="6858000"/>
+          </a:xfrm>
+          <a:prstGeom prst="rect">
+            <a:avLst/>
+          </a:prstGeom>
+          <a:solidFill>
+            <a:srgbClr val="E2E8F0"/>
+          </a:solidFill>
+          <a:ln>
+            <a:noFill/>
+          </a:ln>
+        </p:spPr>
+        <p:style>
+          <a:lnRef idx="1">
+            <a:schemeClr val="accent1"/>
+          </a:lnRef>
+          <a:fillRef idx="3">
+            <a:schemeClr val="accent1"/>
+          </a:fillRef>
+          <a:effectRef idx="2">
+            <a:schemeClr val="accent1"/>
+          </a:effectRef>
+          <a:fontRef idx="minor">
+            <a:schemeClr val="lt1"/>
+          </a:fontRef>
+        </p:style>
+        <p:txBody>
+          <a:bodyPr rtlCol="0" anchor="ctr"/>
+          <a:lstStyle/>
+          <a:p>
+            <a:pPr algn="ctr"/>
+          </a:p>
+        </p:txBody>
+      </p:sp>
+      <p:sp>
+        <p:nvSpPr>
+          <p:cNvPr id="6" name="Rectangle 5"/>
+          <p:cNvSpPr/>
+          <p:nvPr/>
+        </p:nvSpPr>
+        <p:spPr>
+          <a:xfrm>
+            <a:off x="1828800" y="0"/>
+            <a:ext cx="7315" cy="6858000"/>
+          </a:xfrm>
+          <a:prstGeom prst="rect">
+            <a:avLst/>
+          </a:prstGeom>
+          <a:solidFill>
+            <a:srgbClr val="E2E8F0"/>
+          </a:solidFill>
+          <a:ln>
+            <a:noFill/>
+          </a:ln>
+        </p:spPr>
+        <p:style>
+          <a:lnRef idx="1">
+            <a:schemeClr val="accent1"/>
+          </a:lnRef>
+          <a:fillRef idx="3">
+            <a:schemeClr val="accent1"/>
+          </a:fillRef>
+          <a:effectRef idx="2">
+            <a:schemeClr val="accent1"/>
+          </a:effectRef>
+          <a:fontRef idx="minor">
+            <a:schemeClr val="lt1"/>
+          </a:fontRef>
+        </p:style>
+        <p:txBody>
+          <a:bodyPr rtlCol="0" anchor="ctr"/>
+          <a:lstStyle/>
+          <a:p>
+            <a:pPr algn="ctr"/>
+          </a:p>
+        </p:txBody>
+      </p:sp>
+      <p:sp>
+        <p:nvSpPr>
+          <p:cNvPr id="7" name="Rectangle 6"/>
+          <p:cNvSpPr/>
+          <p:nvPr/>
+        </p:nvSpPr>
+        <p:spPr>
+          <a:xfrm>
+            <a:off x="2286000" y="0"/>
+            <a:ext cx="7315" cy="6858000"/>
+          </a:xfrm>
+          <a:prstGeom prst="rect">
+            <a:avLst/>
+          </a:prstGeom>
+          <a:solidFill>
+            <a:srgbClr val="E2E8F0"/>
+          </a:solidFill>
+          <a:ln>
+            <a:noFill/>
+          </a:ln>
+        </p:spPr>
+        <p:style>
+          <a:lnRef idx="1">
+            <a:schemeClr val="accent1"/>
+          </a:lnRef>
+          <a:fillRef idx="3">
+            <a:schemeClr val="accent1"/>
+          </a:fillRef>
+          <a:effectRef idx="2">
+            <a:schemeClr val="accent1"/>
+          </a:effectRef>
+          <a:fontRef idx="minor">
+            <a:schemeClr val="lt1"/>
+          </a:fontRef>
+        </p:style>
+        <p:txBody>
+          <a:bodyPr rtlCol="0" anchor="ctr"/>
+          <a:lstStyle/>
+          <a:p>
+            <a:pPr algn="ctr"/>
+          </a:p>
+        </p:txBody>
+      </p:sp>
+      <p:sp>
+        <p:nvSpPr>
+          <p:cNvPr id="8" name="Rectangle 7"/>
+          <p:cNvSpPr/>
+          <p:nvPr/>
+        </p:nvSpPr>
+        <p:spPr>
+          <a:xfrm>
+            <a:off x="2743200" y="0"/>
+            <a:ext cx="7315" cy="6858000"/>
+          </a:xfrm>
+          <a:prstGeom prst="rect">
+            <a:avLst/>
+          </a:prstGeom>
+          <a:solidFill>
+            <a:srgbClr val="E2E8F0"/>
+          </a:solidFill>
+          <a:ln>
+            <a:noFill/>
+          </a:ln>
+        </p:spPr>
+        <p:style>
+          <a:lnRef idx="1">
+            <a:schemeClr val="accent1"/>
+          </a:lnRef>
+          <a:fillRef idx="3">
+            <a:schemeClr val="accent1"/>
+          </a:fillRef>
+          <a:effectRef idx="2">
+            <a:schemeClr val="accent1"/>
+          </a:effectRef>
+          <a:fontRef idx="minor">
+            <a:schemeClr val="lt1"/>
+          </a:fontRef>
+        </p:style>
+        <p:txBody>
+          <a:bodyPr rtlCol="0" anchor="ctr"/>
+          <a:lstStyle/>
+          <a:p>
+            <a:pPr algn="ctr"/>
+          </a:p>
+        </p:txBody>
+      </p:sp>
+      <p:sp>
+        <p:nvSpPr>
+          <p:cNvPr id="9" name="Rectangle 8"/>
+          <p:cNvSpPr/>
+          <p:nvPr/>
+        </p:nvSpPr>
+        <p:spPr>
+          <a:xfrm>
+            <a:off x="3200400" y="0"/>
+            <a:ext cx="7315" cy="6858000"/>
+          </a:xfrm>
+          <a:prstGeom prst="rect">
+            <a:avLst/>
+          </a:prstGeom>
+          <a:solidFill>
+            <a:srgbClr val="E2E8F0"/>
+          </a:solidFill>
+          <a:ln>
+            <a:noFill/>
+          </a:ln>
+        </p:spPr>
+        <p:style>
+          <a:lnRef idx="1">
+            <a:schemeClr val="accent1"/>
+          </a:lnRef>
+          <a:fillRef idx="3">
+            <a:schemeClr val="accent1"/>
+          </a:fillRef>
+          <a:effectRef idx="2">
+            <a:schemeClr val="accent1"/>
+          </a:effectRef>
+          <a:fontRef idx="minor">
+            <a:schemeClr val="lt1"/>
+          </a:fontRef>
+        </p:style>
+        <p:txBody>
+          <a:bodyPr rtlCol="0" anchor="ctr"/>
+          <a:lstStyle/>
+          <a:p>
+            <a:pPr algn="ctr"/>
+          </a:p>
+        </p:txBody>
+      </p:sp>
+      <p:sp>
+        <p:nvSpPr>
+          <p:cNvPr id="10" name="Rectangle 9"/>
+          <p:cNvSpPr/>
+          <p:nvPr/>
+        </p:nvSpPr>
+        <p:spPr>
+          <a:xfrm>
+            <a:off x="3657600" y="0"/>
+            <a:ext cx="7315" cy="6858000"/>
+          </a:xfrm>
+          <a:prstGeom prst="rect">
+            <a:avLst/>
+          </a:prstGeom>
+          <a:solidFill>
+            <a:srgbClr val="E2E8F0"/>
+          </a:solidFill>
+          <a:ln>
+            <a:noFill/>
+          </a:ln>
+        </p:spPr>
+        <p:style>
+          <a:lnRef idx="1">
+            <a:schemeClr val="accent1"/>
+          </a:lnRef>
+          <a:fillRef idx="3">
+            <a:schemeClr val="accent1"/>
+          </a:fillRef>
+          <a:effectRef idx="2">
+            <a:schemeClr val="accent1"/>
+          </a:effectRef>
+          <a:fontRef idx="minor">
+            <a:schemeClr val="lt1"/>
+          </a:fontRef>
+        </p:style>
+        <p:txBody>
+          <a:bodyPr rtlCol="0" anchor="ctr"/>
+          <a:lstStyle/>
+          <a:p>
+            <a:pPr algn="ctr"/>
+          </a:p>
+        </p:txBody>
+      </p:sp>
+      <p:sp>
+        <p:nvSpPr>
+          <p:cNvPr id="11" name="Rectangle 10"/>
+          <p:cNvSpPr/>
+          <p:nvPr/>
+        </p:nvSpPr>
+        <p:spPr>
+          <a:xfrm>
+            <a:off x="4114800" y="0"/>
+            <a:ext cx="7315" cy="6858000"/>
+          </a:xfrm>
+          <a:prstGeom prst="rect">
+            <a:avLst/>
+          </a:prstGeom>
+          <a:solidFill>
+            <a:srgbClr val="E2E8F0"/>
+          </a:solidFill>
+          <a:ln>
+            <a:noFill/>
+          </a:ln>
+        </p:spPr>
+        <p:style>
+          <a:lnRef idx="1">
+            <a:schemeClr val="accent1"/>
+          </a:lnRef>
+          <a:fillRef idx="3">
+            <a:schemeClr val="accent1"/>
+          </a:fillRef>
+          <a:effectRef idx="2">
+            <a:schemeClr val="accent1"/>
+          </a:effectRef>
+          <a:fontRef idx="minor">
+            <a:schemeClr val="lt1"/>
+          </a:fontRef>
+        </p:style>
+        <p:txBody>
+          <a:bodyPr rtlCol="0" anchor="ctr"/>
+          <a:lstStyle/>
+          <a:p>
+            <a:pPr algn="ctr"/>
+          </a:p>
+        </p:txBody>
+      </p:sp>
+      <p:sp>
+        <p:nvSpPr>
+          <p:cNvPr id="12" name="Rectangle 11"/>
+          <p:cNvSpPr/>
+          <p:nvPr/>
+        </p:nvSpPr>
+        <p:spPr>
+          <a:xfrm>
+            <a:off x="4572000" y="0"/>
+            <a:ext cx="7315" cy="6858000"/>
+          </a:xfrm>
+          <a:prstGeom prst="rect">
+            <a:avLst/>
+          </a:prstGeom>
+          <a:solidFill>
+            <a:srgbClr val="E2E8F0"/>
+          </a:solidFill>
+          <a:ln>
+            <a:noFill/>
+          </a:ln>
+        </p:spPr>
+        <p:style>
+          <a:lnRef idx="1">
+            <a:schemeClr val="accent1"/>
+          </a:lnRef>
+          <a:fillRef idx="3">
+            <a:schemeClr val="accent1"/>
+          </a:fillRef>
+          <a:effectRef idx="2">
+            <a:schemeClr val="accent1"/>
+          </a:effectRef>
+          <a:fontRef idx="minor">
+            <a:schemeClr val="lt1"/>
+          </a:fontRef>
+        </p:style>
+        <p:txBody>
+          <a:bodyPr rtlCol="0" anchor="ctr"/>
+          <a:lstStyle/>
+          <a:p>
+            <a:pPr algn="ctr"/>
+          </a:p>
+        </p:txBody>
+      </p:sp>
+      <p:sp>
+        <p:nvSpPr>
+          <p:cNvPr id="13" name="Rectangle 12"/>
+          <p:cNvSpPr/>
+          <p:nvPr/>
+        </p:nvSpPr>
+        <p:spPr>
+          <a:xfrm>
+            <a:off x="5029200" y="0"/>
+            <a:ext cx="7315" cy="6858000"/>
+          </a:xfrm>
+          <a:prstGeom prst="rect">
+            <a:avLst/>
+          </a:prstGeom>
+          <a:solidFill>
+            <a:srgbClr val="E2E8F0"/>
+          </a:solidFill>
+          <a:ln>
+            <a:noFill/>
+          </a:ln>
+        </p:spPr>
+        <p:style>
+          <a:lnRef idx="1">
+            <a:schemeClr val="accent1"/>
+          </a:lnRef>
+          <a:fillRef idx="3">
+            <a:schemeClr val="accent1"/>
+          </a:fillRef>
+          <a:effectRef idx="2">
+            <a:schemeClr val="accent1"/>
+          </a:effectRef>
+          <a:fontRef idx="minor">
+            <a:schemeClr val="lt1"/>
+          </a:fontRef>
+        </p:style>
+        <p:txBody>
+          <a:bodyPr rtlCol="0" anchor="ctr"/>
+          <a:lstStyle/>
+          <a:p>
+            <a:pPr algn="ctr"/>
+          </a:p>
+        </p:txBody>
+      </p:sp>
+      <p:sp>
+        <p:nvSpPr>
+          <p:cNvPr id="14" name="Rectangle 13"/>
+          <p:cNvSpPr/>
+          <p:nvPr/>
+        </p:nvSpPr>
+        <p:spPr>
+          <a:xfrm>
+            <a:off x="5486400" y="0"/>
+            <a:ext cx="7315" cy="6858000"/>
+          </a:xfrm>
+          <a:prstGeom prst="rect">
+            <a:avLst/>
+          </a:prstGeom>
+          <a:solidFill>
+            <a:srgbClr val="E2E8F0"/>
+          </a:solidFill>
+          <a:ln>
+            <a:noFill/>
+          </a:ln>
+        </p:spPr>
+        <p:style>
+          <a:lnRef idx="1">
+            <a:schemeClr val="accent1"/>
+          </a:lnRef>
+          <a:fillRef idx="3">
+            <a:schemeClr val="accent1"/>
+          </a:fillRef>
+          <a:effectRef idx="2">
+            <a:schemeClr val="accent1"/>
+          </a:effectRef>
+          <a:fontRef idx="minor">
+            <a:schemeClr val="lt1"/>
+          </a:fontRef>
+        </p:style>
+        <p:txBody>
+          <a:bodyPr rtlCol="0" anchor="ctr"/>
+          <a:lstStyle/>
+          <a:p>
+            <a:pPr algn="ctr"/>
+          </a:p>
+        </p:txBody>
+      </p:sp>
+      <p:sp>
+        <p:nvSpPr>
+          <p:cNvPr id="15" name="Rectangle 14"/>
+          <p:cNvSpPr/>
+          <p:nvPr/>
+        </p:nvSpPr>
+        <p:spPr>
+          <a:xfrm>
+            <a:off x="5943600" y="0"/>
+            <a:ext cx="7315" cy="6858000"/>
+          </a:xfrm>
+          <a:prstGeom prst="rect">
+            <a:avLst/>
+          </a:prstGeom>
+          <a:solidFill>
+            <a:srgbClr val="E2E8F0"/>
+          </a:solidFill>
+          <a:ln>
+            <a:noFill/>
+          </a:ln>
+        </p:spPr>
+        <p:style>
+          <a:lnRef idx="1">
+            <a:schemeClr val="accent1"/>
+          </a:lnRef>
+          <a:fillRef idx="3">
+            <a:schemeClr val="accent1"/>
+          </a:fillRef>
+          <a:effectRef idx="2">
+            <a:schemeClr val="accent1"/>
+          </a:effectRef>
+          <a:fontRef idx="minor">
+            <a:schemeClr val="lt1"/>
+          </a:fontRef>
+        </p:style>
+        <p:txBody>
+          <a:bodyPr rtlCol="0" anchor="ctr"/>
+          <a:lstStyle/>
+          <a:p>
+            <a:pPr algn="ctr"/>
+          </a:p>
+        </p:txBody>
+      </p:sp>
+      <p:sp>
+        <p:nvSpPr>
+          <p:cNvPr id="16" name="Rectangle 15"/>
+          <p:cNvSpPr/>
+          <p:nvPr/>
+        </p:nvSpPr>
+        <p:spPr>
+          <a:xfrm>
+            <a:off x="6400800" y="0"/>
+            <a:ext cx="7315" cy="6858000"/>
+          </a:xfrm>
+          <a:prstGeom prst="rect">
+            <a:avLst/>
+          </a:prstGeom>
+          <a:solidFill>
+            <a:srgbClr val="E2E8F0"/>
+          </a:solidFill>
+          <a:ln>
+            <a:noFill/>
+          </a:ln>
+        </p:spPr>
+        <p:style>
+          <a:lnRef idx="1">
+            <a:schemeClr val="accent1"/>
+          </a:lnRef>
+          <a:fillRef idx="3">
+            <a:schemeClr val="accent1"/>
+          </a:fillRef>
+          <a:effectRef idx="2">
+            <a:schemeClr val="accent1"/>
+          </a:effectRef>
+          <a:fontRef idx="minor">
+            <a:schemeClr val="lt1"/>
+          </a:fontRef>
+        </p:style>
+        <p:txBody>
+          <a:bodyPr rtlCol="0" anchor="ctr"/>
+          <a:lstStyle/>
+          <a:p>
+            <a:pPr algn="ctr"/>
+          </a:p>
+        </p:txBody>
+      </p:sp>
+      <p:sp>
+        <p:nvSpPr>
+          <p:cNvPr id="17" name="Rectangle 16"/>
+          <p:cNvSpPr/>
+          <p:nvPr/>
+        </p:nvSpPr>
+        <p:spPr>
+          <a:xfrm>
+            <a:off x="6858000" y="0"/>
+            <a:ext cx="7315" cy="6858000"/>
+          </a:xfrm>
+          <a:prstGeom prst="rect">
+            <a:avLst/>
+          </a:prstGeom>
+          <a:solidFill>
+            <a:srgbClr val="E2E8F0"/>
+          </a:solidFill>
+          <a:ln>
+            <a:noFill/>
+          </a:ln>
+        </p:spPr>
+        <p:style>
+          <a:lnRef idx="1">
+            <a:schemeClr val="accent1"/>
+          </a:lnRef>
+          <a:fillRef idx="3">
+            <a:schemeClr val="accent1"/>
+          </a:fillRef>
+          <a:effectRef idx="2">
+            <a:schemeClr val="accent1"/>
+          </a:effectRef>
+          <a:fontRef idx="minor">
+            <a:schemeClr val="lt1"/>
+          </a:fontRef>
+        </p:style>
+        <p:txBody>
+          <a:bodyPr rtlCol="0" anchor="ctr"/>
+          <a:lstStyle/>
+          <a:p>
+            <a:pPr algn="ctr"/>
+          </a:p>
+        </p:txBody>
+      </p:sp>
+      <p:sp>
+        <p:nvSpPr>
+          <p:cNvPr id="18" name="Rectangle 17"/>
+          <p:cNvSpPr/>
+          <p:nvPr/>
+        </p:nvSpPr>
+        <p:spPr>
+          <a:xfrm>
+            <a:off x="7315200" y="0"/>
+            <a:ext cx="7315" cy="6858000"/>
+          </a:xfrm>
+          <a:prstGeom prst="rect">
+            <a:avLst/>
+          </a:prstGeom>
+          <a:solidFill>
+            <a:srgbClr val="E2E8F0"/>
+          </a:solidFill>
+          <a:ln>
+            <a:noFill/>
+          </a:ln>
+        </p:spPr>
+        <p:style>
+          <a:lnRef idx="1">
+            <a:schemeClr val="accent1"/>
+          </a:lnRef>
+          <a:fillRef idx="3">
+            <a:schemeClr val="accent1"/>
+          </a:fillRef>
+          <a:effectRef idx="2">
+            <a:schemeClr val="accent1"/>
+          </a:effectRef>
+          <a:fontRef idx="minor">
+            <a:schemeClr val="lt1"/>
+          </a:fontRef>
+        </p:style>
+        <p:txBody>
+          <a:bodyPr rtlCol="0" anchor="ctr"/>
+          <a:lstStyle/>
+          <a:p>
+            <a:pPr algn="ctr"/>
+          </a:p>
+        </p:txBody>
+      </p:sp>
+      <p:sp>
+        <p:nvSpPr>
+          <p:cNvPr id="19" name="Rectangle 18"/>
+          <p:cNvSpPr/>
+          <p:nvPr/>
+        </p:nvSpPr>
+        <p:spPr>
+          <a:xfrm>
+            <a:off x="7772400" y="0"/>
+            <a:ext cx="7315" cy="6858000"/>
+          </a:xfrm>
+          <a:prstGeom prst="rect">
+            <a:avLst/>
+          </a:prstGeom>
+          <a:solidFill>
+            <a:srgbClr val="E2E8F0"/>
+          </a:solidFill>
+          <a:ln>
+            <a:noFill/>
+          </a:ln>
+        </p:spPr>
+        <p:style>
+          <a:lnRef idx="1">
+            <a:schemeClr val="accent1"/>
+          </a:lnRef>
+          <a:fillRef idx="3">
+            <a:schemeClr val="accent1"/>
+          </a:fillRef>
+          <a:effectRef idx="2">
+            <a:schemeClr val="accent1"/>
+          </a:effectRef>
+          <a:fontRef idx="minor">
+            <a:schemeClr val="lt1"/>
+          </a:fontRef>
+        </p:style>
+        <p:txBody>
+          <a:bodyPr rtlCol="0" anchor="ctr"/>
+          <a:lstStyle/>
+          <a:p>
+            <a:pPr algn="ctr"/>
+          </a:p>
+        </p:txBody>
+      </p:sp>
+      <p:sp>
+        <p:nvSpPr>
+          <p:cNvPr id="20" name="Rectangle 19"/>
+          <p:cNvSpPr/>
+          <p:nvPr/>
+        </p:nvSpPr>
+        <p:spPr>
+          <a:xfrm>
+            <a:off x="8229600" y="0"/>
+            <a:ext cx="7315" cy="6858000"/>
+          </a:xfrm>
+          <a:prstGeom prst="rect">
+            <a:avLst/>
+          </a:prstGeom>
+          <a:solidFill>
+            <a:srgbClr val="E2E8F0"/>
+          </a:solidFill>
+          <a:ln>
+            <a:noFill/>
+          </a:ln>
+        </p:spPr>
+        <p:style>
+          <a:lnRef idx="1">
+            <a:schemeClr val="accent1"/>
+          </a:lnRef>
+          <a:fillRef idx="3">
+            <a:schemeClr val="accent1"/>
+          </a:fillRef>
+          <a:effectRef idx="2">
+            <a:schemeClr val="accent1"/>
+          </a:effectRef>
+          <a:fontRef idx="minor">
+            <a:schemeClr val="lt1"/>
+          </a:fontRef>
+        </p:style>
+        <p:txBody>
+          <a:bodyPr rtlCol="0" anchor="ctr"/>
+          <a:lstStyle/>
+          <a:p>
+            <a:pPr algn="ctr"/>
+          </a:p>
+        </p:txBody>
+      </p:sp>
+      <p:sp>
+        <p:nvSpPr>
+          <p:cNvPr id="21" name="Rectangle 20"/>
+          <p:cNvSpPr/>
+          <p:nvPr/>
+        </p:nvSpPr>
+        <p:spPr>
+          <a:xfrm>
+            <a:off x="8686800" y="0"/>
+            <a:ext cx="7315" cy="6858000"/>
+          </a:xfrm>
+          <a:prstGeom prst="rect">
+            <a:avLst/>
+          </a:prstGeom>
+          <a:solidFill>
+            <a:srgbClr val="E2E8F0"/>
+          </a:solidFill>
+          <a:ln>
+            <a:noFill/>
+          </a:ln>
+        </p:spPr>
+        <p:style>
+          <a:lnRef idx="1">
+            <a:schemeClr val="accent1"/>
+          </a:lnRef>
+          <a:fillRef idx="3">
+            <a:schemeClr val="accent1"/>
+          </a:fillRef>
+          <a:effectRef idx="2">
+            <a:schemeClr val="accent1"/>
+          </a:effectRef>
+          <a:fontRef idx="minor">
+            <a:schemeClr val="lt1"/>
+          </a:fontRef>
+        </p:style>
+        <p:txBody>
+          <a:bodyPr rtlCol="0" anchor="ctr"/>
+          <a:lstStyle/>
+          <a:p>
+            <a:pPr algn="ctr"/>
+          </a:p>
+        </p:txBody>
+      </p:sp>
+      <p:sp>
+        <p:nvSpPr>
+          <p:cNvPr id="22" name="Rectangle 21"/>
+          <p:cNvSpPr/>
+          <p:nvPr/>
+        </p:nvSpPr>
+        <p:spPr>
+          <a:xfrm>
+            <a:off x="9144000" y="0"/>
+            <a:ext cx="7315" cy="6858000"/>
+          </a:xfrm>
+          <a:prstGeom prst="rect">
+            <a:avLst/>
+          </a:prstGeom>
+          <a:solidFill>
+            <a:srgbClr val="E2E8F0"/>
+          </a:solidFill>
+          <a:ln>
+            <a:noFill/>
+          </a:ln>
+        </p:spPr>
+        <p:style>
+          <a:lnRef idx="1">
+            <a:schemeClr val="accent1"/>
+          </a:lnRef>
+          <a:fillRef idx="3">
+            <a:schemeClr val="accent1"/>
+          </a:fillRef>
+          <a:effectRef idx="2">
+            <a:schemeClr val="accent1"/>
+          </a:effectRef>
+          <a:fontRef idx="minor">
+            <a:schemeClr val="lt1"/>
+          </a:fontRef>
+        </p:style>
+        <p:txBody>
+          <a:bodyPr rtlCol="0" anchor="ctr"/>
+          <a:lstStyle/>
+          <a:p>
+            <a:pPr algn="ctr"/>
+          </a:p>
+        </p:txBody>
+      </p:sp>
+      <p:sp>
+        <p:nvSpPr>
+          <p:cNvPr id="23" name="Rectangle 22"/>
+          <p:cNvSpPr/>
+          <p:nvPr/>
+        </p:nvSpPr>
+        <p:spPr>
+          <a:xfrm>
+            <a:off x="9601200" y="0"/>
+            <a:ext cx="7315" cy="6858000"/>
+          </a:xfrm>
+          <a:prstGeom prst="rect">
+            <a:avLst/>
+          </a:prstGeom>
+          <a:solidFill>
+            <a:srgbClr val="E2E8F0"/>
+          </a:solidFill>
+          <a:ln>
+            <a:noFill/>
+          </a:ln>
+        </p:spPr>
+        <p:style>
+          <a:lnRef idx="1">
+            <a:schemeClr val="accent1"/>
+          </a:lnRef>
+          <a:fillRef idx="3">
+            <a:schemeClr val="accent1"/>
+          </a:fillRef>
+          <a:effectRef idx="2">
+            <a:schemeClr val="accent1"/>
+          </a:effectRef>
+          <a:fontRef idx="minor">
+            <a:schemeClr val="lt1"/>
+          </a:fontRef>
+        </p:style>
+        <p:txBody>
+          <a:bodyPr rtlCol="0" anchor="ctr"/>
+          <a:lstStyle/>
+          <a:p>
+            <a:pPr algn="ctr"/>
+          </a:p>
+        </p:txBody>
+      </p:sp>
+      <p:sp>
+        <p:nvSpPr>
+          <p:cNvPr id="24" name="Rectangle 23"/>
+          <p:cNvSpPr/>
+          <p:nvPr/>
+        </p:nvSpPr>
+        <p:spPr>
+          <a:xfrm>
+            <a:off x="10058400" y="0"/>
+            <a:ext cx="7315" cy="6858000"/>
+          </a:xfrm>
+          <a:prstGeom prst="rect">
+            <a:avLst/>
+          </a:prstGeom>
+          <a:solidFill>
+            <a:srgbClr val="E2E8F0"/>
+          </a:solidFill>
+          <a:ln>
+            <a:noFill/>
+          </a:ln>
+        </p:spPr>
+        <p:style>
+          <a:lnRef idx="1">
+            <a:schemeClr val="accent1"/>
+          </a:lnRef>
+          <a:fillRef idx="3">
+            <a:schemeClr val="accent1"/>
+          </a:fillRef>
+          <a:effectRef idx="2">
+            <a:schemeClr val="accent1"/>
+          </a:effectRef>
+          <a:fontRef idx="minor">
+            <a:schemeClr val="lt1"/>
+          </a:fontRef>
+        </p:style>
+        <p:txBody>
+          <a:bodyPr rtlCol="0" anchor="ctr"/>
+          <a:lstStyle/>
+          <a:p>
+            <a:pPr algn="ctr"/>
+          </a:p>
+        </p:txBody>
+      </p:sp>
+      <p:sp>
+        <p:nvSpPr>
+          <p:cNvPr id="25" name="Rectangle 24"/>
+          <p:cNvSpPr/>
+          <p:nvPr/>
+        </p:nvSpPr>
+        <p:spPr>
+          <a:xfrm>
+            <a:off x="10515600" y="0"/>
+            <a:ext cx="7315" cy="6858000"/>
+          </a:xfrm>
+          <a:prstGeom prst="rect">
+            <a:avLst/>
+          </a:prstGeom>
+          <a:solidFill>
+            <a:srgbClr val="E2E8F0"/>
+          </a:solidFill>
+          <a:ln>
+            <a:noFill/>
+          </a:ln>
+        </p:spPr>
+        <p:style>
+          <a:lnRef idx="1">
+            <a:schemeClr val="accent1"/>
+          </a:lnRef>
+          <a:fillRef idx="3">
+            <a:schemeClr val="accent1"/>
+          </a:fillRef>
+          <a:effectRef idx="2">
+            <a:schemeClr val="accent1"/>
+          </a:effectRef>
+          <a:fontRef idx="minor">
+            <a:schemeClr val="lt1"/>
+          </a:fontRef>
+        </p:style>
+        <p:txBody>
+          <a:bodyPr rtlCol="0" anchor="ctr"/>
+          <a:lstStyle/>
+          <a:p>
+            <a:pPr algn="ctr"/>
+          </a:p>
+        </p:txBody>
+      </p:sp>
+      <p:sp>
+        <p:nvSpPr>
+          <p:cNvPr id="26" name="Rectangle 25"/>
+          <p:cNvSpPr/>
+          <p:nvPr/>
+        </p:nvSpPr>
+        <p:spPr>
+          <a:xfrm>
+            <a:off x="10972800" y="0"/>
+            <a:ext cx="7315" cy="6858000"/>
+          </a:xfrm>
+          <a:prstGeom prst="rect">
+            <a:avLst/>
+          </a:prstGeom>
+          <a:solidFill>
+            <a:srgbClr val="E2E8F0"/>
+          </a:solidFill>
+          <a:ln>
+            <a:noFill/>
+          </a:ln>
+        </p:spPr>
+        <p:style>
+          <a:lnRef idx="1">
+            <a:schemeClr val="accent1"/>
+          </a:lnRef>
+          <a:fillRef idx="3">
+            <a:schemeClr val="accent1"/>
+          </a:fillRef>
+          <a:effectRef idx="2">
+            <a:schemeClr val="accent1"/>
+          </a:effectRef>
+          <a:fontRef idx="minor">
+            <a:schemeClr val="lt1"/>
+          </a:fontRef>
+        </p:style>
+        <p:txBody>
+          <a:bodyPr rtlCol="0" anchor="ctr"/>
+          <a:lstStyle/>
+          <a:p>
+            <a:pPr algn="ctr"/>
+          </a:p>
+        </p:txBody>
+      </p:sp>
+      <p:sp>
+        <p:nvSpPr>
+          <p:cNvPr id="27" name="Rectangle 26"/>
+          <p:cNvSpPr/>
+          <p:nvPr/>
+        </p:nvSpPr>
+        <p:spPr>
+          <a:xfrm>
+            <a:off x="11430000" y="0"/>
+            <a:ext cx="7315" cy="6858000"/>
+          </a:xfrm>
+          <a:prstGeom prst="rect">
+            <a:avLst/>
+          </a:prstGeom>
+          <a:solidFill>
+            <a:srgbClr val="E2E8F0"/>
+          </a:solidFill>
+          <a:ln>
+            <a:noFill/>
+          </a:ln>
+        </p:spPr>
+        <p:style>
+          <a:lnRef idx="1">
+            <a:schemeClr val="accent1"/>
+          </a:lnRef>
+          <a:fillRef idx="3">
+            <a:schemeClr val="accent1"/>
+          </a:fillRef>
+          <a:effectRef idx="2">
+            <a:schemeClr val="accent1"/>
+          </a:effectRef>
+          <a:fontRef idx="minor">
+            <a:schemeClr val="lt1"/>
+          </a:fontRef>
+        </p:style>
+        <p:txBody>
+          <a:bodyPr rtlCol="0" anchor="ctr"/>
+          <a:lstStyle/>
+          <a:p>
+            <a:pPr algn="ctr"/>
+          </a:p>
+        </p:txBody>
+      </p:sp>
+      <p:sp>
+        <p:nvSpPr>
+          <p:cNvPr id="28" name="Rectangle 27"/>
+          <p:cNvSpPr/>
+          <p:nvPr/>
+        </p:nvSpPr>
+        <p:spPr>
+          <a:xfrm>
+            <a:off x="0" y="457200"/>
+            <a:ext cx="12191695" cy="7315"/>
+          </a:xfrm>
+          <a:prstGeom prst="rect">
+            <a:avLst/>
+          </a:prstGeom>
+          <a:solidFill>
+            <a:srgbClr val="E2E8F0"/>
+          </a:solidFill>
+          <a:ln>
+            <a:noFill/>
+          </a:ln>
+        </p:spPr>
+        <p:style>
+          <a:lnRef idx="1">
+            <a:schemeClr val="accent1"/>
+          </a:lnRef>
+          <a:fillRef idx="3">
+            <a:schemeClr val="accent1"/>
+          </a:fillRef>
+          <a:effectRef idx="2">
+            <a:schemeClr val="accent1"/>
+          </a:effectRef>
+          <a:fontRef idx="minor">
+            <a:schemeClr val="lt1"/>
+          </a:fontRef>
+        </p:style>
+        <p:txBody>
+          <a:bodyPr rtlCol="0" anchor="ctr"/>
+          <a:lstStyle/>
+          <a:p>
+            <a:pPr algn="ctr"/>
+          </a:p>
+        </p:txBody>
+      </p:sp>
+      <p:sp>
+        <p:nvSpPr>
+          <p:cNvPr id="29" name="Rectangle 28"/>
+          <p:cNvSpPr/>
+          <p:nvPr/>
+        </p:nvSpPr>
+        <p:spPr>
+          <a:xfrm>
+            <a:off x="0" y="914400"/>
+            <a:ext cx="12191695" cy="7315"/>
+          </a:xfrm>
+          <a:prstGeom prst="rect">
+            <a:avLst/>
+          </a:prstGeom>
+          <a:solidFill>
+            <a:srgbClr val="E2E8F0"/>
+          </a:solidFill>
+          <a:ln>
+            <a:noFill/>
+          </a:ln>
+        </p:spPr>
+        <p:style>
+          <a:lnRef idx="1">
+            <a:schemeClr val="accent1"/>
+          </a:lnRef>
+          <a:fillRef idx="3">
+            <a:schemeClr val="accent1"/>
+          </a:fillRef>
+          <a:effectRef idx="2">
+            <a:schemeClr val="accent1"/>
+          </a:effectRef>
+          <a:fontRef idx="minor">
+            <a:schemeClr val="lt1"/>
+          </a:fontRef>
+        </p:style>
+        <p:txBody>
+          <a:bodyPr rtlCol="0" anchor="ctr"/>
+          <a:lstStyle/>
+          <a:p>
+            <a:pPr algn="ctr"/>
+          </a:p>
+        </p:txBody>
+      </p:sp>
+      <p:sp>
+        <p:nvSpPr>
+          <p:cNvPr id="30" name="Rectangle 29"/>
+          <p:cNvSpPr/>
+          <p:nvPr/>
+        </p:nvSpPr>
+        <p:spPr>
+          <a:xfrm>
+            <a:off x="0" y="1371600"/>
+            <a:ext cx="12191695" cy="7315"/>
+          </a:xfrm>
+          <a:prstGeom prst="rect">
+            <a:avLst/>
+          </a:prstGeom>
+          <a:solidFill>
+            <a:srgbClr val="E2E8F0"/>
+          </a:solidFill>
+          <a:ln>
+            <a:noFill/>
+          </a:ln>
+        </p:spPr>
+        <p:style>
+          <a:lnRef idx="1">
+            <a:schemeClr val="accent1"/>
+          </a:lnRef>
+          <a:fillRef idx="3">
+            <a:schemeClr val="accent1"/>
+          </a:fillRef>
+          <a:effectRef idx="2">
+            <a:schemeClr val="accent1"/>
+          </a:effectRef>
+          <a:fontRef idx="minor">
+            <a:schemeClr val="lt1"/>
+          </a:fontRef>
+        </p:style>
+        <p:txBody>
+          <a:bodyPr rtlCol="0" anchor="ctr"/>
+          <a:lstStyle/>
+          <a:p>
+            <a:pPr algn="ctr"/>
+          </a:p>
+        </p:txBody>
+      </p:sp>
+      <p:sp>
+        <p:nvSpPr>
+          <p:cNvPr id="31" name="Rectangle 30"/>
+          <p:cNvSpPr/>
+          <p:nvPr/>
+        </p:nvSpPr>
+        <p:spPr>
+          <a:xfrm>
+            <a:off x="0" y="1828800"/>
+            <a:ext cx="12191695" cy="7315"/>
+          </a:xfrm>
+          <a:prstGeom prst="rect">
+            <a:avLst/>
+          </a:prstGeom>
+          <a:solidFill>
+            <a:srgbClr val="E2E8F0"/>
+          </a:solidFill>
+          <a:ln>
+            <a:noFill/>
+          </a:ln>
+        </p:spPr>
+        <p:style>
+          <a:lnRef idx="1">
+            <a:schemeClr val="accent1"/>
+          </a:lnRef>
+          <a:fillRef idx="3">
+            <a:schemeClr val="accent1"/>
+          </a:fillRef>
+          <a:effectRef idx="2">
+            <a:schemeClr val="accent1"/>
+          </a:effectRef>
+          <a:fontRef idx="minor">
+            <a:schemeClr val="lt1"/>
+          </a:fontRef>
+        </p:style>
+        <p:txBody>
+          <a:bodyPr rtlCol="0" anchor="ctr"/>
+          <a:lstStyle/>
+          <a:p>
+            <a:pPr algn="ctr"/>
+          </a:p>
+        </p:txBody>
+      </p:sp>
+      <p:sp>
+        <p:nvSpPr>
+          <p:cNvPr id="32" name="Rectangle 31"/>
+          <p:cNvSpPr/>
+          <p:nvPr/>
+        </p:nvSpPr>
+        <p:spPr>
+          <a:xfrm>
+            <a:off x="0" y="2286000"/>
+            <a:ext cx="12191695" cy="7315"/>
+          </a:xfrm>
+          <a:prstGeom prst="rect">
+            <a:avLst/>
+          </a:prstGeom>
+          <a:solidFill>
+            <a:srgbClr val="E2E8F0"/>
+          </a:solidFill>
+          <a:ln>
+            <a:noFill/>
+          </a:ln>
+        </p:spPr>
+        <p:style>
+          <a:lnRef idx="1">
+            <a:schemeClr val="accent1"/>
+          </a:lnRef>
+          <a:fillRef idx="3">
+            <a:schemeClr val="accent1"/>
+          </a:fillRef>
+          <a:effectRef idx="2">
+            <a:schemeClr val="accent1"/>
+          </a:effectRef>
+          <a:fontRef idx="minor">
+            <a:schemeClr val="lt1"/>
+          </a:fontRef>
+        </p:style>
+        <p:txBody>
+          <a:bodyPr rtlCol="0" anchor="ctr"/>
+          <a:lstStyle/>
+          <a:p>
+            <a:pPr algn="ctr"/>
+          </a:p>
+        </p:txBody>
+      </p:sp>
+      <p:sp>
+        <p:nvSpPr>
+          <p:cNvPr id="33" name="Rectangle 32"/>
+          <p:cNvSpPr/>
+          <p:nvPr/>
+        </p:nvSpPr>
+        <p:spPr>
+          <a:xfrm>
+            <a:off x="0" y="2743200"/>
+            <a:ext cx="12191695" cy="7315"/>
+          </a:xfrm>
+          <a:prstGeom prst="rect">
+            <a:avLst/>
+          </a:prstGeom>
+          <a:solidFill>
+            <a:srgbClr val="E2E8F0"/>
+          </a:solidFill>
+          <a:ln>
+            <a:noFill/>
+          </a:ln>
+        </p:spPr>
+        <p:style>
+          <a:lnRef idx="1">
+            <a:schemeClr val="accent1"/>
+          </a:lnRef>
+          <a:fillRef idx="3">
+            <a:schemeClr val="accent1"/>
+          </a:fillRef>
+          <a:effectRef idx="2">
+            <a:schemeClr val="accent1"/>
+          </a:effectRef>
+          <a:fontRef idx="minor">
+            <a:schemeClr val="lt1"/>
+          </a:fontRef>
+        </p:style>
+        <p:txBody>
+          <a:bodyPr rtlCol="0" anchor="ctr"/>
+          <a:lstStyle/>
+          <a:p>
+            <a:pPr algn="ctr"/>
+          </a:p>
+        </p:txBody>
+      </p:sp>
+      <p:sp>
+        <p:nvSpPr>
+          <p:cNvPr id="34" name="Rectangle 33"/>
+          <p:cNvSpPr/>
+          <p:nvPr/>
+        </p:nvSpPr>
+        <p:spPr>
+          <a:xfrm>
+            <a:off x="0" y="3200400"/>
+            <a:ext cx="12191695" cy="7315"/>
+          </a:xfrm>
+          <a:prstGeom prst="rect">
+            <a:avLst/>
+          </a:prstGeom>
+          <a:solidFill>
+            <a:srgbClr val="E2E8F0"/>
+          </a:solidFill>
+          <a:ln>
+            <a:noFill/>
+          </a:ln>
+        </p:spPr>
+        <p:style>
+          <a:lnRef idx="1">
+            <a:schemeClr val="accent1"/>
+          </a:lnRef>
+          <a:fillRef idx="3">
+            <a:schemeClr val="accent1"/>
+          </a:fillRef>
+          <a:effectRef idx="2">
+            <a:schemeClr val="accent1"/>
+          </a:effectRef>
+          <a:fontRef idx="minor">
+            <a:schemeClr val="lt1"/>
+          </a:fontRef>
+        </p:style>
+        <p:txBody>
+          <a:bodyPr rtlCol="0" anchor="ctr"/>
+          <a:lstStyle/>
+          <a:p>
+            <a:pPr algn="ctr"/>
+          </a:p>
+        </p:txBody>
+      </p:sp>
+      <p:sp>
+        <p:nvSpPr>
+          <p:cNvPr id="35" name="Rectangle 34"/>
+          <p:cNvSpPr/>
+          <p:nvPr/>
+        </p:nvSpPr>
+        <p:spPr>
+          <a:xfrm>
+            <a:off x="0" y="3657600"/>
+            <a:ext cx="12191695" cy="7315"/>
+          </a:xfrm>
+          <a:prstGeom prst="rect">
+            <a:avLst/>
+          </a:prstGeom>
+          <a:solidFill>
+            <a:srgbClr val="E2E8F0"/>
+          </a:solidFill>
+          <a:ln>
+            <a:noFill/>
+          </a:ln>
+        </p:spPr>
+        <p:style>
+          <a:lnRef idx="1">
+            <a:schemeClr val="accent1"/>
+          </a:lnRef>
+          <a:fillRef idx="3">
+            <a:schemeClr val="accent1"/>
+          </a:fillRef>
+          <a:effectRef idx="2">
+            <a:schemeClr val="accent1"/>
+          </a:effectRef>
+          <a:fontRef idx="minor">
+            <a:schemeClr val="lt1"/>
+          </a:fontRef>
+        </p:style>
+        <p:txBody>
+          <a:bodyPr rtlCol="0" anchor="ctr"/>
+          <a:lstStyle/>
+          <a:p>
+            <a:pPr algn="ctr"/>
+          </a:p>
+        </p:txBody>
+      </p:sp>
+      <p:sp>
+        <p:nvSpPr>
+          <p:cNvPr id="36" name="Rectangle 35"/>
+          <p:cNvSpPr/>
+          <p:nvPr/>
+        </p:nvSpPr>
+        <p:spPr>
+          <a:xfrm>
+            <a:off x="0" y="4114800"/>
+            <a:ext cx="12191695" cy="7315"/>
+          </a:xfrm>
+          <a:prstGeom prst="rect">
+            <a:avLst/>
+          </a:prstGeom>
+          <a:solidFill>
+            <a:srgbClr val="E2E8F0"/>
+          </a:solidFill>
+          <a:ln>
+            <a:noFill/>
+          </a:ln>
+        </p:spPr>
+        <p:style>
+          <a:lnRef idx="1">
+            <a:schemeClr val="accent1"/>
+          </a:lnRef>
+          <a:fillRef idx="3">
+            <a:schemeClr val="accent1"/>
+          </a:fillRef>
+          <a:effectRef idx="2">
+            <a:schemeClr val="accent1"/>
+          </a:effectRef>
+          <a:fontRef idx="minor">
+            <a:schemeClr val="lt1"/>
+          </a:fontRef>
+        </p:style>
+        <p:txBody>
+          <a:bodyPr rtlCol="0" anchor="ctr"/>
+          <a:lstStyle/>
+          <a:p>
+            <a:pPr algn="ctr"/>
+          </a:p>
+        </p:txBody>
+      </p:sp>
+      <p:sp>
+        <p:nvSpPr>
+          <p:cNvPr id="37" name="Rectangle 36"/>
+          <p:cNvSpPr/>
+          <p:nvPr/>
+        </p:nvSpPr>
+        <p:spPr>
+          <a:xfrm>
+            <a:off x="0" y="4572000"/>
+            <a:ext cx="12191695" cy="7315"/>
+          </a:xfrm>
+          <a:prstGeom prst="rect">
+            <a:avLst/>
+          </a:prstGeom>
+          <a:solidFill>
+            <a:srgbClr val="E2E8F0"/>
+          </a:solidFill>
+          <a:ln>
+            <a:noFill/>
+          </a:ln>
+        </p:spPr>
+        <p:style>
+          <a:lnRef idx="1">
+            <a:schemeClr val="accent1"/>
+          </a:lnRef>
+          <a:fillRef idx="3">
+            <a:schemeClr val="accent1"/>
+          </a:fillRef>
+          <a:effectRef idx="2">
+            <a:schemeClr val="accent1"/>
+          </a:effectRef>
+          <a:fontRef idx="minor">
+            <a:schemeClr val="lt1"/>
+          </a:fontRef>
+        </p:style>
+        <p:txBody>
+          <a:bodyPr rtlCol="0" anchor="ctr"/>
+          <a:lstStyle/>
+          <a:p>
+            <a:pPr algn="ctr"/>
+          </a:p>
+        </p:txBody>
+      </p:sp>
+      <p:sp>
+        <p:nvSpPr>
+          <p:cNvPr id="38" name="Rectangle 37"/>
+          <p:cNvSpPr/>
+          <p:nvPr/>
+        </p:nvSpPr>
+        <p:spPr>
+          <a:xfrm>
+            <a:off x="0" y="5029200"/>
+            <a:ext cx="12191695" cy="7315"/>
+          </a:xfrm>
+          <a:prstGeom prst="rect">
+            <a:avLst/>
+          </a:prstGeom>
+          <a:solidFill>
+            <a:srgbClr val="E2E8F0"/>
+          </a:solidFill>
+          <a:ln>
+            <a:noFill/>
+          </a:ln>
+        </p:spPr>
+        <p:style>
+          <a:lnRef idx="1">
+            <a:schemeClr val="accent1"/>
+          </a:lnRef>
+          <a:fillRef idx="3">
+            <a:schemeClr val="accent1"/>
+          </a:fillRef>
+          <a:effectRef idx="2">
+            <a:schemeClr val="accent1"/>
+          </a:effectRef>
+          <a:fontRef idx="minor">
+            <a:schemeClr val="lt1"/>
+          </a:fontRef>
+        </p:style>
+        <p:txBody>
+          <a:bodyPr rtlCol="0" anchor="ctr"/>
+          <a:lstStyle/>
+          <a:p>
+            <a:pPr algn="ctr"/>
+          </a:p>
+        </p:txBody>
+      </p:sp>
+      <p:sp>
+        <p:nvSpPr>
+          <p:cNvPr id="39" name="Rectangle 38"/>
+          <p:cNvSpPr/>
+          <p:nvPr/>
+        </p:nvSpPr>
+        <p:spPr>
+          <a:xfrm>
+            <a:off x="0" y="5486400"/>
+            <a:ext cx="12191695" cy="7315"/>
+          </a:xfrm>
+          <a:prstGeom prst="rect">
+            <a:avLst/>
+          </a:prstGeom>
+          <a:solidFill>
+            <a:srgbClr val="E2E8F0"/>
+          </a:solidFill>
+          <a:ln>
+            <a:noFill/>
+          </a:ln>
+        </p:spPr>
+        <p:style>
+          <a:lnRef idx="1">
+            <a:schemeClr val="accent1"/>
+          </a:lnRef>
+          <a:fillRef idx="3">
+            <a:schemeClr val="accent1"/>
+          </a:fillRef>
+          <a:effectRef idx="2">
+            <a:schemeClr val="accent1"/>
+          </a:effectRef>
+          <a:fontRef idx="minor">
+            <a:schemeClr val="lt1"/>
+          </a:fontRef>
+        </p:style>
+        <p:txBody>
+          <a:bodyPr rtlCol="0" anchor="ctr"/>
+          <a:lstStyle/>
+          <a:p>
+            <a:pPr algn="ctr"/>
+          </a:p>
+        </p:txBody>
+      </p:sp>
+      <p:sp>
+        <p:nvSpPr>
+          <p:cNvPr id="40" name="Rectangle 39"/>
+          <p:cNvSpPr/>
+          <p:nvPr/>
+        </p:nvSpPr>
+        <p:spPr>
+          <a:xfrm>
+            <a:off x="0" y="5943600"/>
+            <a:ext cx="12191695" cy="7315"/>
+          </a:xfrm>
+          <a:prstGeom prst="rect">
+            <a:avLst/>
+          </a:prstGeom>
+          <a:solidFill>
+            <a:srgbClr val="E2E8F0"/>
+          </a:solidFill>
+          <a:ln>
+            <a:noFill/>
+          </a:ln>
+        </p:spPr>
+        <p:style>
+          <a:lnRef idx="1">
+            <a:schemeClr val="accent1"/>
+          </a:lnRef>
+          <a:fillRef idx="3">
+            <a:schemeClr val="accent1"/>
+          </a:fillRef>
+          <a:effectRef idx="2">
+            <a:schemeClr val="accent1"/>
+          </a:effectRef>
+          <a:fontRef idx="minor">
+            <a:schemeClr val="lt1"/>
+          </a:fontRef>
+        </p:style>
+        <p:txBody>
+          <a:bodyPr rtlCol="0" anchor="ctr"/>
+          <a:lstStyle/>
+          <a:p>
+            <a:pPr algn="ctr"/>
+          </a:p>
+        </p:txBody>
+      </p:sp>
+      <p:sp>
+        <p:nvSpPr>
+          <p:cNvPr id="41" name="Rectangle 40"/>
+          <p:cNvSpPr/>
+          <p:nvPr/>
+        </p:nvSpPr>
+        <p:spPr>
+          <a:xfrm>
+            <a:off x="0" y="6400800"/>
+            <a:ext cx="12191695" cy="7315"/>
+          </a:xfrm>
+          <a:prstGeom prst="rect">
+            <a:avLst/>
+          </a:prstGeom>
+          <a:solidFill>
+            <a:srgbClr val="E2E8F0"/>
+          </a:solidFill>
+          <a:ln>
+            <a:noFill/>
+          </a:ln>
+        </p:spPr>
+        <p:style>
+          <a:lnRef idx="1">
+            <a:schemeClr val="accent1"/>
+          </a:lnRef>
+          <a:fillRef idx="3">
+            <a:schemeClr val="accent1"/>
+          </a:fillRef>
+          <a:effectRef idx="2">
+            <a:schemeClr val="accent1"/>
+          </a:effectRef>
+          <a:fontRef idx="minor">
+            <a:schemeClr val="lt1"/>
+          </a:fontRef>
+        </p:style>
+        <p:txBody>
+          <a:bodyPr rtlCol="0" anchor="ctr"/>
+          <a:lstStyle/>
+          <a:p>
+            <a:pPr algn="ctr"/>
+          </a:p>
+        </p:txBody>
+      </p:sp>
+      <p:sp>
+        <p:nvSpPr>
+          <p:cNvPr id="42" name="Rounded Rectangle 41"/>
+          <p:cNvSpPr/>
+          <p:nvPr/>
+        </p:nvSpPr>
+        <p:spPr>
+          <a:xfrm>
+            <a:off x="731520" y="566928"/>
+            <a:ext cx="91440" cy="329184"/>
+          </a:xfrm>
+          <a:prstGeom prst="roundRect">
+            <a:avLst/>
+          </a:prstGeom>
+          <a:solidFill>
+            <a:srgbClr val="0A1628"/>
+          </a:solidFill>
+          <a:ln>
+            <a:noFill/>
+          </a:ln>
+        </p:spPr>
+        <p:style>
+          <a:lnRef idx="1">
+            <a:schemeClr val="accent1"/>
+          </a:lnRef>
+          <a:fillRef idx="3">
+            <a:schemeClr val="accent1"/>
+          </a:fillRef>
+          <a:effectRef idx="2">
+            <a:schemeClr val="accent1"/>
+          </a:effectRef>
+          <a:fontRef idx="minor">
+            <a:schemeClr val="lt1"/>
+          </a:fontRef>
+        </p:style>
+        <p:txBody>
+          <a:bodyPr rtlCol="0" anchor="ctr"/>
+          <a:lstStyle/>
+          <a:p>
+            <a:pPr algn="ctr"/>
+          </a:p>
+        </p:txBody>
+      </p:sp>
+      <p:sp>
+        <p:nvSpPr>
+          <p:cNvPr id="43" name="TextBox 42"/>
+          <p:cNvSpPr txBox="1"/>
+          <p:nvPr/>
+        </p:nvSpPr>
+        <p:spPr>
+          <a:xfrm>
+            <a:off x="960120" y="594360"/>
+            <a:ext cx="4114800" cy="320040"/>
+          </a:xfrm>
+          <a:prstGeom prst="rect">
+            <a:avLst/>
+          </a:prstGeom>
+          <a:noFill/>
+        </p:spPr>
+        <p:txBody>
+          <a:bodyPr wrap="square" lIns="0" tIns="0" rIns="0" bIns="0">
+            <a:spAutoFit/>
+          </a:bodyPr>
+          <a:lstStyle/>
+          <a:p>
+            <a:pPr algn="l"/>
+            <a:r>
+              <a:rPr sz="1300" b="1" i="0">
+                <a:solidFill>
+                  <a:srgbClr val="0A1628"/>
+                </a:solidFill>
+                <a:latin typeface="JetBrains Mono"/>
+              </a:rPr>
+              <a:t>THE SOLUTION / BENCHMARK</a:t>
+            </a:r>
+          </a:p>
+        </p:txBody>
+      </p:sp>
+      <p:sp>
+        <p:nvSpPr>
+          <p:cNvPr id="44" name="Rounded Rectangle 43"/>
+          <p:cNvSpPr/>
+          <p:nvPr/>
+        </p:nvSpPr>
+        <p:spPr>
+          <a:xfrm>
+            <a:off x="8778240" y="548640"/>
+            <a:ext cx="2651760" cy="329184"/>
+          </a:xfrm>
+          <a:prstGeom prst="roundRect">
+            <a:avLst/>
+          </a:prstGeom>
+          <a:solidFill>
+            <a:srgbClr val="F8FAFC"/>
+          </a:solidFill>
+          <a:ln w="12700">
+            <a:solidFill>
+              <a:srgbClr val="E2E8F0"/>
+            </a:solidFill>
+          </a:ln>
+        </p:spPr>
+        <p:style>
+          <a:lnRef idx="1">
+            <a:schemeClr val="accent1"/>
+          </a:lnRef>
+          <a:fillRef idx="3">
+            <a:schemeClr val="accent1"/>
+          </a:fillRef>
+          <a:effectRef idx="2">
+            <a:schemeClr val="accent1"/>
+          </a:effectRef>
+          <a:fontRef idx="minor">
+            <a:schemeClr val="lt1"/>
+          </a:fontRef>
+        </p:style>
+        <p:txBody>
+          <a:bodyPr rtlCol="0" anchor="ctr"/>
+          <a:lstStyle/>
+          <a:p>
+            <a:pPr algn="ctr"/>
+          </a:p>
+        </p:txBody>
+      </p:sp>
+      <p:sp>
+        <p:nvSpPr>
+          <p:cNvPr id="45" name="Oval 44"/>
+          <p:cNvSpPr/>
+          <p:nvPr/>
+        </p:nvSpPr>
+        <p:spPr>
+          <a:xfrm>
+            <a:off x="8961120" y="658368"/>
+            <a:ext cx="91440" cy="91440"/>
+          </a:xfrm>
+          <a:prstGeom prst="ellipse">
+            <a:avLst/>
+          </a:prstGeom>
+          <a:solidFill>
+            <a:srgbClr val="047857"/>
+          </a:solidFill>
+          <a:ln>
+            <a:noFill/>
+          </a:ln>
+        </p:spPr>
+        <p:style>
+          <a:lnRef idx="1">
+            <a:schemeClr val="accent1"/>
+          </a:lnRef>
+          <a:fillRef idx="3">
+            <a:schemeClr val="accent1"/>
+          </a:fillRef>
+          <a:effectRef idx="2">
+            <a:schemeClr val="accent1"/>
+          </a:effectRef>
+          <a:fontRef idx="minor">
+            <a:schemeClr val="lt1"/>
+          </a:fontRef>
+        </p:style>
+        <p:txBody>
+          <a:bodyPr rtlCol="0" anchor="ctr"/>
+          <a:lstStyle/>
+          <a:p>
+            <a:pPr algn="ctr"/>
+          </a:p>
+        </p:txBody>
+      </p:sp>
+      <p:sp>
+        <p:nvSpPr>
+          <p:cNvPr id="46" name="TextBox 45"/>
+          <p:cNvSpPr txBox="1"/>
+          <p:nvPr/>
+        </p:nvSpPr>
+        <p:spPr>
+          <a:xfrm>
+            <a:off x="9098280" y="603504"/>
+            <a:ext cx="2286000" cy="228600"/>
+          </a:xfrm>
+          <a:prstGeom prst="rect">
+            <a:avLst/>
+          </a:prstGeom>
+          <a:noFill/>
+        </p:spPr>
+        <p:txBody>
+          <a:bodyPr wrap="square" lIns="0" tIns="0" rIns="0" bIns="0">
+            <a:spAutoFit/>
+          </a:bodyPr>
+          <a:lstStyle/>
+          <a:p>
+            <a:pPr algn="ctr"/>
+            <a:r>
+              <a:rPr sz="800" b="1" i="0">
+                <a:solidFill>
+                  <a:srgbClr val="047857"/>
+                </a:solidFill>
+                <a:latin typeface="JetBrains Mono"/>
+              </a:rPr>
+              <a:t>SWARM SEARCH EFFICIENCY</a:t>
+            </a:r>
+          </a:p>
+        </p:txBody>
+      </p:sp>
+      <p:sp>
+        <p:nvSpPr>
+          <p:cNvPr id="47" name="TextBox 46"/>
+          <p:cNvSpPr txBox="1"/>
+          <p:nvPr/>
+        </p:nvSpPr>
+        <p:spPr>
+          <a:xfrm>
+            <a:off x="731520" y="1188720"/>
+            <a:ext cx="5943600" cy="1097280"/>
+          </a:xfrm>
+          <a:prstGeom prst="rect">
+            <a:avLst/>
+          </a:prstGeom>
+          <a:noFill/>
+        </p:spPr>
+        <p:txBody>
+          <a:bodyPr wrap="square" lIns="0" tIns="0" rIns="0" bIns="0">
+            <a:spAutoFit/>
+          </a:bodyPr>
+          <a:lstStyle/>
+          <a:p>
+            <a:pPr algn="l"/>
+            <a:r>
+              <a:rPr sz="2800" b="1" i="0">
+                <a:solidFill>
+                  <a:srgbClr val="000000"/>
+                </a:solidFill>
+                <a:latin typeface="Plus Jakarta Sans"/>
+              </a:rPr>
+              <a:t>AI Swarm Drones Find Survivors 3-4x Faster Than Traditional SAR</a:t>
+            </a:r>
+          </a:p>
+        </p:txBody>
+      </p:sp>
+      <p:sp>
+        <p:nvSpPr>
+          <p:cNvPr id="48" name="Oval 47"/>
+          <p:cNvSpPr/>
+          <p:nvPr/>
+        </p:nvSpPr>
+        <p:spPr>
+          <a:xfrm>
+            <a:off x="749808" y="2386584"/>
+            <a:ext cx="82296" cy="82296"/>
+          </a:xfrm>
+          <a:prstGeom prst="ellipse">
+            <a:avLst/>
+          </a:prstGeom>
+          <a:solidFill>
+            <a:srgbClr val="047857"/>
+          </a:solidFill>
+          <a:ln>
+            <a:noFill/>
+          </a:ln>
+        </p:spPr>
+        <p:style>
+          <a:lnRef idx="1">
+            <a:schemeClr val="accent1"/>
+          </a:lnRef>
+          <a:fillRef idx="3">
+            <a:schemeClr val="accent1"/>
+          </a:fillRef>
+          <a:effectRef idx="2">
+            <a:schemeClr val="accent1"/>
+          </a:effectRef>
+          <a:fontRef idx="minor">
+            <a:schemeClr val="lt1"/>
+          </a:fontRef>
+        </p:style>
+        <p:txBody>
+          <a:bodyPr rtlCol="0" anchor="ctr"/>
+          <a:lstStyle/>
+          <a:p>
+            <a:pPr algn="ctr"/>
+          </a:p>
+        </p:txBody>
+      </p:sp>
+      <p:sp>
+        <p:nvSpPr>
+          <p:cNvPr id="49" name="TextBox 48"/>
+          <p:cNvSpPr txBox="1"/>
+          <p:nvPr/>
+        </p:nvSpPr>
+        <p:spPr>
+          <a:xfrm>
+            <a:off x="932688" y="2331720"/>
+            <a:ext cx="5669280" cy="320040"/>
+          </a:xfrm>
+          <a:prstGeom prst="rect">
+            <a:avLst/>
+          </a:prstGeom>
+          <a:noFill/>
+        </p:spPr>
+        <p:txBody>
+          <a:bodyPr wrap="square" lIns="0" tIns="0" rIns="0" bIns="0">
+            <a:spAutoFit/>
+          </a:bodyPr>
+          <a:lstStyle/>
+          <a:p>
+            <a:pPr algn="l"/>
+            <a:r>
+              <a:rPr sz="1350" b="0" i="0">
+                <a:solidFill>
+                  <a:srgbClr val="374151"/>
+                </a:solidFill>
+                <a:latin typeface="Inter"/>
+              </a:rPr>
+              <a:t>78-85% survivor detection on first pass</a:t>
+            </a:r>
+          </a:p>
+        </p:txBody>
+      </p:sp>
+      <p:sp>
+        <p:nvSpPr>
+          <p:cNvPr id="50" name="Oval 49"/>
+          <p:cNvSpPr/>
+          <p:nvPr/>
+        </p:nvSpPr>
+        <p:spPr>
+          <a:xfrm>
+            <a:off x="749808" y="2752344"/>
+            <a:ext cx="82296" cy="82296"/>
+          </a:xfrm>
+          <a:prstGeom prst="ellipse">
+            <a:avLst/>
+          </a:prstGeom>
+          <a:solidFill>
+            <a:srgbClr val="047857"/>
+          </a:solidFill>
+          <a:ln>
+            <a:noFill/>
+          </a:ln>
+        </p:spPr>
+        <p:style>
+          <a:lnRef idx="1">
+            <a:schemeClr val="accent1"/>
+          </a:lnRef>
+          <a:fillRef idx="3">
+            <a:schemeClr val="accent1"/>
+          </a:fillRef>
+          <a:effectRef idx="2">
+            <a:schemeClr val="accent1"/>
+          </a:effectRef>
+          <a:fontRef idx="minor">
+            <a:schemeClr val="lt1"/>
+          </a:fontRef>
+        </p:style>
+        <p:txBody>
+          <a:bodyPr rtlCol="0" anchor="ctr"/>
+          <a:lstStyle/>
+          <a:p>
+            <a:pPr algn="ctr"/>
+          </a:p>
+        </p:txBody>
+      </p:sp>
+      <p:sp>
+        <p:nvSpPr>
+          <p:cNvPr id="51" name="TextBox 50"/>
+          <p:cNvSpPr txBox="1"/>
+          <p:nvPr/>
+        </p:nvSpPr>
+        <p:spPr>
+          <a:xfrm>
+            <a:off x="932688" y="2697480"/>
+            <a:ext cx="5669280" cy="320040"/>
+          </a:xfrm>
+          <a:prstGeom prst="rect">
+            <a:avLst/>
+          </a:prstGeom>
+          <a:noFill/>
+        </p:spPr>
+        <p:txBody>
+          <a:bodyPr wrap="square" lIns="0" tIns="0" rIns="0" bIns="0">
+            <a:spAutoFit/>
+          </a:bodyPr>
+          <a:lstStyle/>
+          <a:p>
+            <a:pPr algn="l"/>
+            <a:r>
+              <a:rPr sz="1350" b="0" i="0">
+                <a:solidFill>
+                  <a:srgbClr val="374151"/>
+                </a:solidFill>
+                <a:latin typeface="Inter"/>
+              </a:rPr>
+              <a:t>10-18 min per sq mile speed</a:t>
+            </a:r>
+          </a:p>
+        </p:txBody>
+      </p:sp>
+      <p:sp>
+        <p:nvSpPr>
+          <p:cNvPr id="52" name="Oval 51"/>
+          <p:cNvSpPr/>
+          <p:nvPr/>
+        </p:nvSpPr>
+        <p:spPr>
+          <a:xfrm>
+            <a:off x="749808" y="3118104"/>
+            <a:ext cx="82296" cy="82296"/>
+          </a:xfrm>
+          <a:prstGeom prst="ellipse">
+            <a:avLst/>
+          </a:prstGeom>
+          <a:solidFill>
+            <a:srgbClr val="047857"/>
+          </a:solidFill>
+          <a:ln>
+            <a:noFill/>
+          </a:ln>
+        </p:spPr>
+        <p:style>
+          <a:lnRef idx="1">
+            <a:schemeClr val="accent1"/>
+          </a:lnRef>
+          <a:fillRef idx="3">
+            <a:schemeClr val="accent1"/>
+          </a:fillRef>
+          <a:effectRef idx="2">
+            <a:schemeClr val="accent1"/>
+          </a:effectRef>
+          <a:fontRef idx="minor">
+            <a:schemeClr val="lt1"/>
+          </a:fontRef>
+        </p:style>
+        <p:txBody>
+          <a:bodyPr rtlCol="0" anchor="ctr"/>
+          <a:lstStyle/>
+          <a:p>
+            <a:pPr algn="ctr"/>
+          </a:p>
+        </p:txBody>
+      </p:sp>
+      <p:sp>
+        <p:nvSpPr>
+          <p:cNvPr id="53" name="TextBox 52"/>
+          <p:cNvSpPr txBox="1"/>
+          <p:nvPr/>
+        </p:nvSpPr>
+        <p:spPr>
+          <a:xfrm>
+            <a:off x="932688" y="3063240"/>
+            <a:ext cx="5669280" cy="320040"/>
+          </a:xfrm>
+          <a:prstGeom prst="rect">
+            <a:avLst/>
+          </a:prstGeom>
+          <a:noFill/>
+        </p:spPr>
+        <p:txBody>
+          <a:bodyPr wrap="square" lIns="0" tIns="0" rIns="0" bIns="0">
+            <a:spAutoFit/>
+          </a:bodyPr>
+          <a:lstStyle/>
+          <a:p>
+            <a:pPr algn="l"/>
+            <a:r>
+              <a:rPr sz="1350" b="0" i="0">
+                <a:solidFill>
+                  <a:srgbClr val="374151"/>
+                </a:solidFill>
+                <a:latin typeface="Inter"/>
+              </a:rPr>
+              <a:t>Mesh networking works in GPS-denied zones</a:t>
+            </a:r>
+          </a:p>
+        </p:txBody>
+      </p:sp>
+      <p:sp>
+        <p:nvSpPr>
+          <p:cNvPr id="54" name="Oval 53"/>
+          <p:cNvSpPr/>
+          <p:nvPr/>
+        </p:nvSpPr>
+        <p:spPr>
+          <a:xfrm>
+            <a:off x="749808" y="3483864"/>
+            <a:ext cx="82296" cy="82296"/>
+          </a:xfrm>
+          <a:prstGeom prst="ellipse">
+            <a:avLst/>
+          </a:prstGeom>
+          <a:solidFill>
+            <a:srgbClr val="047857"/>
+          </a:solidFill>
+          <a:ln>
+            <a:noFill/>
+          </a:ln>
+        </p:spPr>
+        <p:style>
+          <a:lnRef idx="1">
+            <a:schemeClr val="accent1"/>
+          </a:lnRef>
+          <a:fillRef idx="3">
+            <a:schemeClr val="accent1"/>
+          </a:fillRef>
+          <a:effectRef idx="2">
+            <a:schemeClr val="accent1"/>
+          </a:effectRef>
+          <a:fontRef idx="minor">
+            <a:schemeClr val="lt1"/>
+          </a:fontRef>
+        </p:style>
+        <p:txBody>
+          <a:bodyPr rtlCol="0" anchor="ctr"/>
+          <a:lstStyle/>
+          <a:p>
+            <a:pPr algn="ctr"/>
+          </a:p>
+        </p:txBody>
+      </p:sp>
+      <p:sp>
+        <p:nvSpPr>
+          <p:cNvPr id="55" name="TextBox 54"/>
+          <p:cNvSpPr txBox="1"/>
+          <p:nvPr/>
+        </p:nvSpPr>
+        <p:spPr>
+          <a:xfrm>
+            <a:off x="932688" y="3429000"/>
+            <a:ext cx="5669280" cy="320040"/>
+          </a:xfrm>
+          <a:prstGeom prst="rect">
+            <a:avLst/>
+          </a:prstGeom>
+          <a:noFill/>
+        </p:spPr>
+        <p:txBody>
+          <a:bodyPr wrap="square" lIns="0" tIns="0" rIns="0" bIns="0">
+            <a:spAutoFit/>
+          </a:bodyPr>
+          <a:lstStyle/>
+          <a:p>
+            <a:pPr algn="l"/>
+            <a:r>
+              <a:rPr sz="1350" b="0" i="0">
+                <a:solidFill>
+                  <a:srgbClr val="374151"/>
+                </a:solidFill>
+                <a:latin typeface="Inter"/>
+              </a:rPr>
+              <a:t>24/7 autonomous operation for 11+ days</a:t>
+            </a:r>
+          </a:p>
+        </p:txBody>
+      </p:sp>
+      <p:sp>
+        <p:nvSpPr>
+          <p:cNvPr id="56" name="Oval 55"/>
+          <p:cNvSpPr/>
+          <p:nvPr/>
+        </p:nvSpPr>
+        <p:spPr>
+          <a:xfrm>
+            <a:off x="749808" y="3849624"/>
+            <a:ext cx="82296" cy="82296"/>
+          </a:xfrm>
+          <a:prstGeom prst="ellipse">
+            <a:avLst/>
+          </a:prstGeom>
+          <a:solidFill>
+            <a:srgbClr val="047857"/>
+          </a:solidFill>
+          <a:ln>
+            <a:noFill/>
+          </a:ln>
+        </p:spPr>
+        <p:style>
+          <a:lnRef idx="1">
+            <a:schemeClr val="accent1"/>
+          </a:lnRef>
+          <a:fillRef idx="3">
+            <a:schemeClr val="accent1"/>
+          </a:fillRef>
+          <a:effectRef idx="2">
+            <a:schemeClr val="accent1"/>
+          </a:effectRef>
+          <a:fontRef idx="minor">
+            <a:schemeClr val="lt1"/>
+          </a:fontRef>
+        </p:style>
+        <p:txBody>
+          <a:bodyPr rtlCol="0" anchor="ctr"/>
+          <a:lstStyle/>
+          <a:p>
+            <a:pPr algn="ctr"/>
+          </a:p>
+        </p:txBody>
+      </p:sp>
+      <p:sp>
+        <p:nvSpPr>
+          <p:cNvPr id="57" name="TextBox 56"/>
+          <p:cNvSpPr txBox="1"/>
+          <p:nvPr/>
+        </p:nvSpPr>
+        <p:spPr>
+          <a:xfrm>
+            <a:off x="932688" y="3794760"/>
+            <a:ext cx="5669280" cy="320040"/>
+          </a:xfrm>
+          <a:prstGeom prst="rect">
+            <a:avLst/>
+          </a:prstGeom>
+          <a:noFill/>
+        </p:spPr>
+        <p:txBody>
+          <a:bodyPr wrap="square" lIns="0" tIns="0" rIns="0" bIns="0">
+            <a:spAutoFit/>
+          </a:bodyPr>
+          <a:lstStyle/>
+          <a:p>
+            <a:pPr algn="l"/>
+            <a:r>
+              <a:rPr sz="1350" b="0" i="0">
+                <a:solidFill>
+                  <a:srgbClr val="374151"/>
+                </a:solidFill>
+                <a:latin typeface="Inter"/>
+              </a:rPr>
+              <a:t>False positive rate down to 12%</a:t>
+            </a:r>
+          </a:p>
+        </p:txBody>
+      </p:sp>
+      <p:sp>
+        <p:nvSpPr>
+          <p:cNvPr id="58" name="Oval 57"/>
+          <p:cNvSpPr/>
+          <p:nvPr/>
+        </p:nvSpPr>
+        <p:spPr>
+          <a:xfrm>
+            <a:off x="749808" y="4215384"/>
+            <a:ext cx="82296" cy="82296"/>
+          </a:xfrm>
+          <a:prstGeom prst="ellipse">
+            <a:avLst/>
+          </a:prstGeom>
+          <a:solidFill>
+            <a:srgbClr val="047857"/>
+          </a:solidFill>
+          <a:ln>
+            <a:noFill/>
+          </a:ln>
+        </p:spPr>
+        <p:style>
+          <a:lnRef idx="1">
+            <a:schemeClr val="accent1"/>
+          </a:lnRef>
+          <a:fillRef idx="3">
+            <a:schemeClr val="accent1"/>
+          </a:fillRef>
+          <a:effectRef idx="2">
+            <a:schemeClr val="accent1"/>
+          </a:effectRef>
+          <a:fontRef idx="minor">
+            <a:schemeClr val="lt1"/>
+          </a:fontRef>
+        </p:style>
+        <p:txBody>
+          <a:bodyPr rtlCol="0" anchor="ctr"/>
+          <a:lstStyle/>
+          <a:p>
+            <a:pPr algn="ctr"/>
+          </a:p>
+        </p:txBody>
+      </p:sp>
+      <p:sp>
+        <p:nvSpPr>
+          <p:cNvPr id="59" name="TextBox 58"/>
+          <p:cNvSpPr txBox="1"/>
+          <p:nvPr/>
+        </p:nvSpPr>
+        <p:spPr>
+          <a:xfrm>
+            <a:off x="932688" y="4160520"/>
+            <a:ext cx="5669280" cy="320040"/>
+          </a:xfrm>
+          <a:prstGeom prst="rect">
+            <a:avLst/>
+          </a:prstGeom>
+          <a:noFill/>
+        </p:spPr>
+        <p:txBody>
+          <a:bodyPr wrap="square" lIns="0" tIns="0" rIns="0" bIns="0">
+            <a:spAutoFit/>
+          </a:bodyPr>
+          <a:lstStyle/>
+          <a:p>
+            <a:pPr algn="l"/>
+            <a:r>
+              <a:rPr sz="1350" b="0" i="0">
+                <a:solidFill>
+                  <a:srgbClr val="374151"/>
+                </a:solidFill>
+                <a:latin typeface="Inter"/>
+              </a:rPr>
+              <a:t>Cost per deployment: $12K vs $15K</a:t>
+            </a:r>
+          </a:p>
+        </p:txBody>
+      </p:sp>
+      <p:sp>
+        <p:nvSpPr>
+          <p:cNvPr id="60" name="TextBox 59"/>
+          <p:cNvSpPr txBox="1"/>
+          <p:nvPr/>
+        </p:nvSpPr>
+        <p:spPr>
+          <a:xfrm>
+            <a:off x="731520" y="4663440"/>
+            <a:ext cx="4572000" cy="182880"/>
+          </a:xfrm>
+          <a:prstGeom prst="rect">
+            <a:avLst/>
+          </a:prstGeom>
+          <a:noFill/>
+        </p:spPr>
+        <p:txBody>
+          <a:bodyPr wrap="square" lIns="0" tIns="0" rIns="0" bIns="0">
+            <a:spAutoFit/>
+          </a:bodyPr>
+          <a:lstStyle/>
+          <a:p>
+            <a:pPr algn="l"/>
+            <a:r>
+              <a:rPr sz="750" b="1" i="0">
+                <a:solidFill>
+                  <a:srgbClr val="94A3B8"/>
+                </a:solidFill>
+                <a:latin typeface="JetBrains Mono"/>
+              </a:rPr>
+              <a:t>MARKET VALIDATION &amp; ADOPTION</a:t>
+            </a:r>
+          </a:p>
+        </p:txBody>
+      </p:sp>
+      <p:sp>
+        <p:nvSpPr>
+          <p:cNvPr id="61" name="Rounded Rectangle 60"/>
+          <p:cNvSpPr/>
+          <p:nvPr/>
+        </p:nvSpPr>
+        <p:spPr>
+          <a:xfrm>
+            <a:off x="731520" y="4892040"/>
+            <a:ext cx="1353312" cy="777240"/>
+          </a:xfrm>
+          <a:prstGeom prst="roundRect">
+            <a:avLst/>
+          </a:prstGeom>
+          <a:solidFill>
+            <a:srgbClr val="F8FAFC"/>
+          </a:solidFill>
+          <a:ln w="12700">
+            <a:solidFill>
+              <a:srgbClr val="E2E8F0"/>
+            </a:solidFill>
+          </a:ln>
+        </p:spPr>
+        <p:style>
+          <a:lnRef idx="1">
+            <a:schemeClr val="accent1"/>
+          </a:lnRef>
+          <a:fillRef idx="3">
+            <a:schemeClr val="accent1"/>
+          </a:fillRef>
+          <a:effectRef idx="2">
+            <a:schemeClr val="accent1"/>
+          </a:effectRef>
+          <a:fontRef idx="minor">
+            <a:schemeClr val="lt1"/>
+          </a:fontRef>
+        </p:style>
+        <p:txBody>
+          <a:bodyPr rtlCol="0" anchor="ctr"/>
+          <a:lstStyle/>
+          <a:p>
+            <a:pPr algn="ctr"/>
+          </a:p>
+        </p:txBody>
+      </p:sp>
+      <p:sp>
+        <p:nvSpPr>
+          <p:cNvPr id="62" name="TextBox 61"/>
+          <p:cNvSpPr txBox="1"/>
+          <p:nvPr/>
+        </p:nvSpPr>
+        <p:spPr>
+          <a:xfrm>
+            <a:off x="804672" y="4956048"/>
+            <a:ext cx="1207008" cy="274320"/>
+          </a:xfrm>
+          <a:prstGeom prst="rect">
+            <a:avLst/>
+          </a:prstGeom>
+          <a:noFill/>
+        </p:spPr>
+        <p:txBody>
+          <a:bodyPr wrap="square" lIns="0" tIns="0" rIns="0" bIns="0">
+            <a:spAutoFit/>
+          </a:bodyPr>
+          <a:lstStyle/>
+          <a:p>
+            <a:pPr algn="l"/>
+            <a:r>
+              <a:rPr sz="1300" b="1" i="0">
+                <a:solidFill>
+                  <a:srgbClr val="000000"/>
+                </a:solidFill>
+                <a:latin typeface="Plus Jakarta Sans"/>
+              </a:rPr>
+              <a:t>$8.94B</a:t>
+            </a:r>
+          </a:p>
+        </p:txBody>
+      </p:sp>
+      <p:sp>
+        <p:nvSpPr>
+          <p:cNvPr id="63" name="TextBox 62"/>
+          <p:cNvSpPr txBox="1"/>
+          <p:nvPr/>
+        </p:nvSpPr>
+        <p:spPr>
+          <a:xfrm>
+            <a:off x="804672" y="5230368"/>
+            <a:ext cx="1207008" cy="365760"/>
+          </a:xfrm>
+          <a:prstGeom prst="rect">
+            <a:avLst/>
+          </a:prstGeom>
+          <a:noFill/>
+        </p:spPr>
+        <p:txBody>
+          <a:bodyPr wrap="square" lIns="0" tIns="0" rIns="0" bIns="0">
+            <a:spAutoFit/>
+          </a:bodyPr>
+          <a:lstStyle/>
+          <a:p>
+            <a:pPr algn="l"/>
+            <a:r>
+              <a:rPr sz="680" b="0" i="0">
+                <a:solidFill>
+                  <a:srgbClr val="64748B"/>
+                </a:solidFill>
+                <a:latin typeface="JetBrains Mono"/>
+              </a:rPr>
+              <a:t>By 2033 (18.4% CAGR)</a:t>
+            </a:r>
+          </a:p>
+        </p:txBody>
+      </p:sp>
+      <p:sp>
+        <p:nvSpPr>
+          <p:cNvPr id="64" name="Rounded Rectangle 63"/>
+          <p:cNvSpPr/>
+          <p:nvPr/>
+        </p:nvSpPr>
+        <p:spPr>
+          <a:xfrm>
+            <a:off x="2194560" y="4892040"/>
+            <a:ext cx="1353312" cy="777240"/>
+          </a:xfrm>
+          <a:prstGeom prst="roundRect">
+            <a:avLst/>
+          </a:prstGeom>
+          <a:solidFill>
+            <a:srgbClr val="F8FAFC"/>
+          </a:solidFill>
+          <a:ln w="12700">
+            <a:solidFill>
+              <a:srgbClr val="E2E8F0"/>
+            </a:solidFill>
+          </a:ln>
+        </p:spPr>
+        <p:style>
+          <a:lnRef idx="1">
+            <a:schemeClr val="accent1"/>
+          </a:lnRef>
+          <a:fillRef idx="3">
+            <a:schemeClr val="accent1"/>
+          </a:fillRef>
+          <a:effectRef idx="2">
+            <a:schemeClr val="accent1"/>
+          </a:effectRef>
+          <a:fontRef idx="minor">
+            <a:schemeClr val="lt1"/>
+          </a:fontRef>
+        </p:style>
+        <p:txBody>
+          <a:bodyPr rtlCol="0" anchor="ctr"/>
+          <a:lstStyle/>
+          <a:p>
+            <a:pPr algn="ctr"/>
+          </a:p>
+        </p:txBody>
+      </p:sp>
+      <p:sp>
+        <p:nvSpPr>
+          <p:cNvPr id="65" name="TextBox 64"/>
+          <p:cNvSpPr txBox="1"/>
+          <p:nvPr/>
+        </p:nvSpPr>
+        <p:spPr>
+          <a:xfrm>
+            <a:off x="2267712" y="4956048"/>
+            <a:ext cx="1207008" cy="274320"/>
+          </a:xfrm>
+          <a:prstGeom prst="rect">
+            <a:avLst/>
+          </a:prstGeom>
+          <a:noFill/>
+        </p:spPr>
+        <p:txBody>
+          <a:bodyPr wrap="square" lIns="0" tIns="0" rIns="0" bIns="0">
+            <a:spAutoFit/>
+          </a:bodyPr>
+          <a:lstStyle/>
+          <a:p>
+            <a:pPr algn="l"/>
+            <a:r>
+              <a:rPr sz="1300" b="1" i="0">
+                <a:solidFill>
+                  <a:srgbClr val="000000"/>
+                </a:solidFill>
+                <a:latin typeface="Plus Jakarta Sans"/>
+              </a:rPr>
+              <a:t>+412%</a:t>
+            </a:r>
+          </a:p>
+        </p:txBody>
+      </p:sp>
+      <p:sp>
+        <p:nvSpPr>
+          <p:cNvPr id="66" name="TextBox 65"/>
+          <p:cNvSpPr txBox="1"/>
+          <p:nvPr/>
+        </p:nvSpPr>
+        <p:spPr>
+          <a:xfrm>
+            <a:off x="2267712" y="5230368"/>
+            <a:ext cx="1207008" cy="365760"/>
+          </a:xfrm>
+          <a:prstGeom prst="rect">
+            <a:avLst/>
+          </a:prstGeom>
+          <a:noFill/>
+        </p:spPr>
+        <p:txBody>
+          <a:bodyPr wrap="square" lIns="0" tIns="0" rIns="0" bIns="0">
+            <a:spAutoFit/>
+          </a:bodyPr>
+          <a:lstStyle/>
+          <a:p>
+            <a:pPr algn="l"/>
+            <a:r>
+              <a:rPr sz="680" b="0" i="0">
+                <a:solidFill>
+                  <a:srgbClr val="64748B"/>
+                </a:solidFill>
+                <a:latin typeface="JetBrains Mono"/>
+              </a:rPr>
+              <a:t>Disaster Surge (20 Yrs)</a:t>
+            </a:r>
+          </a:p>
+        </p:txBody>
+      </p:sp>
+      <p:sp>
+        <p:nvSpPr>
+          <p:cNvPr id="67" name="Rounded Rectangle 66"/>
+          <p:cNvSpPr/>
+          <p:nvPr/>
+        </p:nvSpPr>
+        <p:spPr>
+          <a:xfrm>
+            <a:off x="3657600" y="4892040"/>
+            <a:ext cx="1353312" cy="777240"/>
+          </a:xfrm>
+          <a:prstGeom prst="roundRect">
+            <a:avLst/>
+          </a:prstGeom>
+          <a:solidFill>
+            <a:srgbClr val="F8FAFC"/>
+          </a:solidFill>
+          <a:ln w="12700">
+            <a:solidFill>
+              <a:srgbClr val="E2E8F0"/>
+            </a:solidFill>
+          </a:ln>
+        </p:spPr>
+        <p:style>
+          <a:lnRef idx="1">
+            <a:schemeClr val="accent1"/>
+          </a:lnRef>
+          <a:fillRef idx="3">
+            <a:schemeClr val="accent1"/>
+          </a:fillRef>
+          <a:effectRef idx="2">
+            <a:schemeClr val="accent1"/>
+          </a:effectRef>
+          <a:fontRef idx="minor">
+            <a:schemeClr val="lt1"/>
+          </a:fontRef>
+        </p:style>
+        <p:txBody>
+          <a:bodyPr rtlCol="0" anchor="ctr"/>
+          <a:lstStyle/>
+          <a:p>
+            <a:pPr algn="ctr"/>
+          </a:p>
+        </p:txBody>
+      </p:sp>
+      <p:sp>
+        <p:nvSpPr>
+          <p:cNvPr id="68" name="TextBox 67"/>
+          <p:cNvSpPr txBox="1"/>
+          <p:nvPr/>
+        </p:nvSpPr>
+        <p:spPr>
+          <a:xfrm>
+            <a:off x="3730752" y="4956048"/>
+            <a:ext cx="1207008" cy="274320"/>
+          </a:xfrm>
+          <a:prstGeom prst="rect">
+            <a:avLst/>
+          </a:prstGeom>
+          <a:noFill/>
+        </p:spPr>
+        <p:txBody>
+          <a:bodyPr wrap="square" lIns="0" tIns="0" rIns="0" bIns="0">
+            <a:spAutoFit/>
+          </a:bodyPr>
+          <a:lstStyle/>
+          <a:p>
+            <a:pPr algn="l"/>
+            <a:r>
+              <a:rPr sz="1300" b="1" i="0">
+                <a:solidFill>
+                  <a:srgbClr val="000000"/>
+                </a:solidFill>
+                <a:latin typeface="Plus Jakarta Sans"/>
+              </a:rPr>
+              <a:t>37 Nations</a:t>
+            </a:r>
+          </a:p>
+        </p:txBody>
+      </p:sp>
+      <p:sp>
+        <p:nvSpPr>
+          <p:cNvPr id="69" name="TextBox 68"/>
+          <p:cNvSpPr txBox="1"/>
+          <p:nvPr/>
+        </p:nvSpPr>
+        <p:spPr>
+          <a:xfrm>
+            <a:off x="3730752" y="5230368"/>
+            <a:ext cx="1207008" cy="365760"/>
+          </a:xfrm>
+          <a:prstGeom prst="rect">
+            <a:avLst/>
+          </a:prstGeom>
+          <a:noFill/>
+        </p:spPr>
+        <p:txBody>
+          <a:bodyPr wrap="square" lIns="0" tIns="0" rIns="0" bIns="0">
+            <a:spAutoFit/>
+          </a:bodyPr>
+          <a:lstStyle/>
+          <a:p>
+            <a:pPr algn="l"/>
+            <a:r>
+              <a:rPr sz="680" b="0" i="0">
+                <a:solidFill>
+                  <a:srgbClr val="64748B"/>
+                </a:solidFill>
+                <a:latin typeface="JetBrains Mono"/>
+              </a:rPr>
+              <a:t>Mandated SAR Drones</a:t>
+            </a:r>
+          </a:p>
+        </p:txBody>
+      </p:sp>
+      <p:sp>
+        <p:nvSpPr>
+          <p:cNvPr id="70" name="Rounded Rectangle 69"/>
+          <p:cNvSpPr/>
+          <p:nvPr/>
+        </p:nvSpPr>
+        <p:spPr>
+          <a:xfrm>
+            <a:off x="5120640" y="4892040"/>
+            <a:ext cx="1353312" cy="777240"/>
+          </a:xfrm>
+          <a:prstGeom prst="roundRect">
+            <a:avLst/>
+          </a:prstGeom>
+          <a:solidFill>
+            <a:srgbClr val="F8FAFC"/>
+          </a:solidFill>
+          <a:ln w="12700">
+            <a:solidFill>
+              <a:srgbClr val="E2E8F0"/>
+            </a:solidFill>
+          </a:ln>
+        </p:spPr>
+        <p:style>
+          <a:lnRef idx="1">
+            <a:schemeClr val="accent1"/>
+          </a:lnRef>
+          <a:fillRef idx="3">
+            <a:schemeClr val="accent1"/>
+          </a:fillRef>
+          <a:effectRef idx="2">
+            <a:schemeClr val="accent1"/>
+          </a:effectRef>
+          <a:fontRef idx="minor">
+            <a:schemeClr val="lt1"/>
+          </a:fontRef>
+        </p:style>
+        <p:txBody>
+          <a:bodyPr rtlCol="0" anchor="ctr"/>
+          <a:lstStyle/>
+          <a:p>
+            <a:pPr algn="ctr"/>
+          </a:p>
+        </p:txBody>
+      </p:sp>
+      <p:sp>
+        <p:nvSpPr>
+          <p:cNvPr id="71" name="TextBox 70"/>
+          <p:cNvSpPr txBox="1"/>
+          <p:nvPr/>
+        </p:nvSpPr>
+        <p:spPr>
+          <a:xfrm>
+            <a:off x="5193792" y="4956048"/>
+            <a:ext cx="1207008" cy="274320"/>
+          </a:xfrm>
+          <a:prstGeom prst="rect">
+            <a:avLst/>
+          </a:prstGeom>
+          <a:noFill/>
+        </p:spPr>
+        <p:txBody>
+          <a:bodyPr wrap="square" lIns="0" tIns="0" rIns="0" bIns="0">
+            <a:spAutoFit/>
+          </a:bodyPr>
+          <a:lstStyle/>
+          <a:p>
+            <a:pPr algn="l"/>
+            <a:r>
+              <a:rPr sz="1300" b="1" i="0">
+                <a:solidFill>
+                  <a:srgbClr val="000000"/>
+                </a:solidFill>
+                <a:latin typeface="Plus Jakarta Sans"/>
+              </a:rPr>
+              <a:t>$180M</a:t>
+            </a:r>
+          </a:p>
+        </p:txBody>
+      </p:sp>
+      <p:sp>
+        <p:nvSpPr>
+          <p:cNvPr id="72" name="TextBox 71"/>
+          <p:cNvSpPr txBox="1"/>
+          <p:nvPr/>
+        </p:nvSpPr>
+        <p:spPr>
+          <a:xfrm>
+            <a:off x="5193792" y="5230368"/>
+            <a:ext cx="1207008" cy="365760"/>
+          </a:xfrm>
+          <a:prstGeom prst="rect">
+            <a:avLst/>
+          </a:prstGeom>
+          <a:noFill/>
+        </p:spPr>
+        <p:txBody>
+          <a:bodyPr wrap="square" lIns="0" tIns="0" rIns="0" bIns="0">
+            <a:spAutoFit/>
+          </a:bodyPr>
+          <a:lstStyle/>
+          <a:p>
+            <a:pPr algn="l"/>
+            <a:r>
+              <a:rPr sz="680" b="0" i="0">
+                <a:solidFill>
+                  <a:srgbClr val="64748B"/>
+                </a:solidFill>
+                <a:latin typeface="JetBrains Mono"/>
+              </a:rPr>
+              <a:t>FEMA 2025 Budget</a:t>
+            </a:r>
+          </a:p>
+        </p:txBody>
+      </p:sp>
+      <p:sp>
+        <p:nvSpPr>
+          <p:cNvPr id="73" name="Rounded Rectangle 72"/>
+          <p:cNvSpPr/>
+          <p:nvPr/>
+        </p:nvSpPr>
+        <p:spPr>
+          <a:xfrm>
+            <a:off x="6766560" y="1234440"/>
+            <a:ext cx="4693615" cy="3017520"/>
+          </a:xfrm>
+          <a:prstGeom prst="roundRect">
+            <a:avLst/>
+          </a:prstGeom>
+          <a:solidFill>
+            <a:srgbClr val="F8FAFC"/>
+          </a:solidFill>
+          <a:ln w="12700">
+            <a:solidFill>
+              <a:srgbClr val="E2E8F0"/>
+            </a:solidFill>
+          </a:ln>
+        </p:spPr>
+        <p:style>
+          <a:lnRef idx="1">
+            <a:schemeClr val="accent1"/>
+          </a:lnRef>
+          <a:fillRef idx="3">
+            <a:schemeClr val="accent1"/>
+          </a:fillRef>
+          <a:effectRef idx="2">
+            <a:schemeClr val="accent1"/>
+          </a:effectRef>
+          <a:fontRef idx="minor">
+            <a:schemeClr val="lt1"/>
+          </a:fontRef>
+        </p:style>
+        <p:txBody>
+          <a:bodyPr rtlCol="0" anchor="ctr"/>
+          <a:lstStyle/>
+          <a:p>
+            <a:pPr algn="ctr"/>
+          </a:p>
+        </p:txBody>
+      </p:sp>
+      <p:sp>
+        <p:nvSpPr>
+          <p:cNvPr id="74" name="TextBox 73"/>
+          <p:cNvSpPr txBox="1"/>
+          <p:nvPr/>
+        </p:nvSpPr>
+        <p:spPr>
+          <a:xfrm>
+            <a:off x="6949440" y="1325880"/>
+            <a:ext cx="2743200" cy="182880"/>
+          </a:xfrm>
+          <a:prstGeom prst="rect">
+            <a:avLst/>
+          </a:prstGeom>
+          <a:noFill/>
+        </p:spPr>
+        <p:txBody>
+          <a:bodyPr wrap="square" lIns="0" tIns="0" rIns="0" bIns="0">
+            <a:spAutoFit/>
+          </a:bodyPr>
+          <a:lstStyle/>
+          <a:p>
+            <a:pPr algn="l"/>
+            <a:r>
+              <a:rPr sz="750" b="1" i="0">
+                <a:solidFill>
+                  <a:srgbClr val="94A3B8"/>
+                </a:solidFill>
+                <a:latin typeface="JetBrains Mono"/>
+              </a:rPr>
+              <a:t>BENCHMARK MATRIX</a:t>
+            </a:r>
+          </a:p>
+        </p:txBody>
+      </p:sp>
+      <p:sp>
+        <p:nvSpPr>
+          <p:cNvPr id="75" name="TextBox 74"/>
+          <p:cNvSpPr txBox="1"/>
+          <p:nvPr/>
+        </p:nvSpPr>
+        <p:spPr>
+          <a:xfrm>
+            <a:off x="6949440" y="1536192"/>
+            <a:ext cx="4114800" cy="274320"/>
+          </a:xfrm>
+          <a:prstGeom prst="rect">
+            <a:avLst/>
+          </a:prstGeom>
+          <a:noFill/>
+        </p:spPr>
+        <p:txBody>
+          <a:bodyPr wrap="square" lIns="0" tIns="0" rIns="0" bIns="0">
+            <a:spAutoFit/>
+          </a:bodyPr>
+          <a:lstStyle/>
+          <a:p>
+            <a:pPr algn="l"/>
+            <a:r>
+              <a:rPr sz="1200" b="1" i="0">
+                <a:solidFill>
+                  <a:srgbClr val="000000"/>
+                </a:solidFill>
+                <a:latin typeface="Plus Jakarta Sans"/>
+              </a:rPr>
+              <a:t>Search &amp; Rescue Performance Comparison</a:t>
+            </a:r>
+          </a:p>
+        </p:txBody>
+      </p:sp>
+      <p:sp>
+        <p:nvSpPr>
+          <p:cNvPr id="76" name="Rectangle 75"/>
+          <p:cNvSpPr/>
+          <p:nvPr/>
+        </p:nvSpPr>
+        <p:spPr>
+          <a:xfrm>
+            <a:off x="6949440" y="1874519"/>
+            <a:ext cx="4327855" cy="13716"/>
+          </a:xfrm>
+          <a:prstGeom prst="rect">
+            <a:avLst/>
+          </a:prstGeom>
+          <a:solidFill>
+            <a:srgbClr val="E2E8F0"/>
+          </a:solidFill>
+          <a:ln>
+            <a:noFill/>
+          </a:ln>
+        </p:spPr>
+        <p:style>
+          <a:lnRef idx="1">
+            <a:schemeClr val="accent1"/>
+          </a:lnRef>
+          <a:fillRef idx="3">
+            <a:schemeClr val="accent1"/>
+          </a:fillRef>
+          <a:effectRef idx="2">
+            <a:schemeClr val="accent1"/>
+          </a:effectRef>
+          <a:fontRef idx="minor">
+            <a:schemeClr val="lt1"/>
+          </a:fontRef>
+        </p:style>
+        <p:txBody>
+          <a:bodyPr rtlCol="0" anchor="ctr"/>
+          <a:lstStyle/>
+          <a:p>
+            <a:pPr algn="ctr"/>
+          </a:p>
+        </p:txBody>
+      </p:sp>
+      <p:sp>
+        <p:nvSpPr>
+          <p:cNvPr id="77" name="TextBox 76"/>
+          <p:cNvSpPr txBox="1"/>
+          <p:nvPr/>
+        </p:nvSpPr>
+        <p:spPr>
+          <a:xfrm>
+            <a:off x="6949440" y="1965960"/>
+            <a:ext cx="1645920" cy="182880"/>
+          </a:xfrm>
+          <a:prstGeom prst="rect">
+            <a:avLst/>
+          </a:prstGeom>
+          <a:noFill/>
+        </p:spPr>
+        <p:txBody>
+          <a:bodyPr wrap="square" lIns="0" tIns="0" rIns="0" bIns="0">
+            <a:spAutoFit/>
+          </a:bodyPr>
+          <a:lstStyle/>
+          <a:p>
+            <a:pPr algn="l"/>
+            <a:r>
+              <a:rPr sz="750" b="1" i="0">
+                <a:solidFill>
+                  <a:srgbClr val="94A3B8"/>
+                </a:solidFill>
+                <a:latin typeface="JetBrains Mono"/>
+              </a:rPr>
+              <a:t>METRIC</a:t>
+            </a:r>
+          </a:p>
+        </p:txBody>
+      </p:sp>
+      <p:sp>
+        <p:nvSpPr>
+          <p:cNvPr id="78" name="TextBox 77"/>
+          <p:cNvSpPr txBox="1"/>
+          <p:nvPr/>
+        </p:nvSpPr>
+        <p:spPr>
+          <a:xfrm>
+            <a:off x="8595360" y="1965960"/>
+            <a:ext cx="731520" cy="182880"/>
+          </a:xfrm>
+          <a:prstGeom prst="rect">
+            <a:avLst/>
+          </a:prstGeom>
+          <a:noFill/>
+        </p:spPr>
+        <p:txBody>
+          <a:bodyPr wrap="square" lIns="0" tIns="0" rIns="0" bIns="0">
+            <a:spAutoFit/>
+          </a:bodyPr>
+          <a:lstStyle/>
+          <a:p>
+            <a:pPr algn="ctr"/>
+            <a:r>
+              <a:rPr sz="700" b="0" i="0">
+                <a:solidFill>
+                  <a:srgbClr val="64748B"/>
+                </a:solidFill>
+                <a:latin typeface="JetBrains Mono"/>
+              </a:rPr>
+              <a:t>TRADITIONAL</a:t>
+            </a:r>
+          </a:p>
+        </p:txBody>
+      </p:sp>
+      <p:sp>
+        <p:nvSpPr>
+          <p:cNvPr id="79" name="TextBox 78"/>
+          <p:cNvSpPr txBox="1"/>
+          <p:nvPr/>
+        </p:nvSpPr>
+        <p:spPr>
+          <a:xfrm>
+            <a:off x="9326880" y="1965960"/>
+            <a:ext cx="914400" cy="182880"/>
+          </a:xfrm>
+          <a:prstGeom prst="rect">
+            <a:avLst/>
+          </a:prstGeom>
+          <a:noFill/>
+        </p:spPr>
+        <p:txBody>
+          <a:bodyPr wrap="square" lIns="0" tIns="0" rIns="0" bIns="0">
+            <a:spAutoFit/>
+          </a:bodyPr>
+          <a:lstStyle/>
+          <a:p>
+            <a:pPr algn="ctr"/>
+            <a:r>
+              <a:rPr sz="700" b="0" i="0">
+                <a:solidFill>
+                  <a:srgbClr val="64748B"/>
+                </a:solidFill>
+                <a:latin typeface="JetBrains Mono"/>
+              </a:rPr>
+              <a:t>SINGLE DRONE</a:t>
+            </a:r>
+          </a:p>
+        </p:txBody>
+      </p:sp>
+      <p:sp>
+        <p:nvSpPr>
+          <p:cNvPr id="80" name="TextBox 79"/>
+          <p:cNvSpPr txBox="1"/>
+          <p:nvPr/>
+        </p:nvSpPr>
+        <p:spPr>
+          <a:xfrm>
+            <a:off x="10241280" y="1965960"/>
+            <a:ext cx="1005840" cy="182880"/>
+          </a:xfrm>
+          <a:prstGeom prst="rect">
+            <a:avLst/>
+          </a:prstGeom>
+          <a:noFill/>
+        </p:spPr>
+        <p:txBody>
+          <a:bodyPr wrap="square" lIns="0" tIns="0" rIns="0" bIns="0">
+            <a:spAutoFit/>
+          </a:bodyPr>
+          <a:lstStyle/>
+          <a:p>
+            <a:pPr algn="ctr"/>
+            <a:r>
+              <a:rPr sz="750" b="1" i="0">
+                <a:solidFill>
+                  <a:srgbClr val="047857"/>
+                </a:solidFill>
+                <a:latin typeface="JetBrains Mono"/>
+              </a:rPr>
+              <a:t>AI SWARM</a:t>
+            </a:r>
+          </a:p>
+        </p:txBody>
+      </p:sp>
+      <p:sp>
+        <p:nvSpPr>
+          <p:cNvPr id="81" name="TextBox 80"/>
+          <p:cNvSpPr txBox="1"/>
+          <p:nvPr/>
+        </p:nvSpPr>
+        <p:spPr>
+          <a:xfrm>
+            <a:off x="6949440" y="2240280"/>
+            <a:ext cx="1645920" cy="274320"/>
+          </a:xfrm>
+          <a:prstGeom prst="rect">
+            <a:avLst/>
+          </a:prstGeom>
+          <a:noFill/>
+        </p:spPr>
+        <p:txBody>
+          <a:bodyPr wrap="square" lIns="0" tIns="0" rIns="0" bIns="0">
+            <a:spAutoFit/>
+          </a:bodyPr>
+          <a:lstStyle/>
+          <a:p>
+            <a:pPr algn="l"/>
+            <a:r>
+              <a:rPr sz="950" b="1" i="0">
+                <a:solidFill>
+                  <a:srgbClr val="000000"/>
+                </a:solidFill>
+                <a:latin typeface="Inter"/>
+              </a:rPr>
+              <a:t>Deployment Time</a:t>
+            </a:r>
+          </a:p>
+        </p:txBody>
+      </p:sp>
+      <p:sp>
+        <p:nvSpPr>
+          <p:cNvPr id="82" name="TextBox 81"/>
+          <p:cNvSpPr txBox="1"/>
+          <p:nvPr/>
+        </p:nvSpPr>
+        <p:spPr>
+          <a:xfrm>
+            <a:off x="8595360" y="2240280"/>
+            <a:ext cx="731520" cy="274320"/>
+          </a:xfrm>
+          <a:prstGeom prst="rect">
+            <a:avLst/>
+          </a:prstGeom>
+          <a:noFill/>
+        </p:spPr>
+        <p:txBody>
+          <a:bodyPr wrap="square" lIns="0" tIns="0" rIns="0" bIns="0">
+            <a:spAutoFit/>
+          </a:bodyPr>
+          <a:lstStyle/>
+          <a:p>
+            <a:pPr algn="ctr"/>
+            <a:r>
+              <a:rPr sz="850" b="0" i="0">
+                <a:solidFill>
+                  <a:srgbClr val="64748B"/>
+                </a:solidFill>
+                <a:latin typeface="JetBrains Mono"/>
+              </a:rPr>
+              <a:t>45-90 min</a:t>
+            </a:r>
+          </a:p>
+        </p:txBody>
+      </p:sp>
+      <p:sp>
+        <p:nvSpPr>
+          <p:cNvPr id="83" name="TextBox 82"/>
+          <p:cNvSpPr txBox="1"/>
+          <p:nvPr/>
+        </p:nvSpPr>
+        <p:spPr>
+          <a:xfrm>
+            <a:off x="9326880" y="2240280"/>
+            <a:ext cx="914400" cy="274320"/>
+          </a:xfrm>
+          <a:prstGeom prst="rect">
+            <a:avLst/>
+          </a:prstGeom>
+          <a:noFill/>
+        </p:spPr>
+        <p:txBody>
+          <a:bodyPr wrap="square" lIns="0" tIns="0" rIns="0" bIns="0">
+            <a:spAutoFit/>
+          </a:bodyPr>
+          <a:lstStyle/>
+          <a:p>
+            <a:pPr algn="ctr"/>
+            <a:r>
+              <a:rPr sz="850" b="0" i="0">
+                <a:solidFill>
+                  <a:srgbClr val="475569"/>
+                </a:solidFill>
+                <a:latin typeface="JetBrains Mono"/>
+              </a:rPr>
+              <a:t>15-30 min</a:t>
+            </a:r>
+          </a:p>
+        </p:txBody>
+      </p:sp>
+      <p:sp>
+        <p:nvSpPr>
+          <p:cNvPr id="84" name="Rounded Rectangle 83"/>
+          <p:cNvSpPr/>
+          <p:nvPr/>
+        </p:nvSpPr>
+        <p:spPr>
+          <a:xfrm>
+            <a:off x="10241280" y="2203704"/>
+            <a:ext cx="1005840" cy="274320"/>
+          </a:xfrm>
+          <a:prstGeom prst="roundRect">
+            <a:avLst/>
+          </a:prstGeom>
+          <a:solidFill>
+            <a:srgbClr val="DCFCE7"/>
+          </a:solidFill>
+          <a:ln>
+            <a:noFill/>
+          </a:ln>
+        </p:spPr>
+        <p:style>
+          <a:lnRef idx="1">
+            <a:schemeClr val="accent1"/>
+          </a:lnRef>
+          <a:fillRef idx="3">
+            <a:schemeClr val="accent1"/>
+          </a:fillRef>
+          <a:effectRef idx="2">
+            <a:schemeClr val="accent1"/>
+          </a:effectRef>
+          <a:fontRef idx="minor">
+            <a:schemeClr val="lt1"/>
+          </a:fontRef>
+        </p:style>
+        <p:txBody>
+          <a:bodyPr rtlCol="0" anchor="ctr"/>
+          <a:lstStyle/>
+          <a:p>
+            <a:pPr algn="ctr"/>
+          </a:p>
+        </p:txBody>
+      </p:sp>
+      <p:sp>
+        <p:nvSpPr>
+          <p:cNvPr id="85" name="TextBox 84"/>
+          <p:cNvSpPr txBox="1"/>
+          <p:nvPr/>
+        </p:nvSpPr>
+        <p:spPr>
+          <a:xfrm>
+            <a:off x="10241280" y="2240280"/>
+            <a:ext cx="1005840" cy="274320"/>
+          </a:xfrm>
+          <a:prstGeom prst="rect">
+            <a:avLst/>
+          </a:prstGeom>
+          <a:noFill/>
+        </p:spPr>
+        <p:txBody>
+          <a:bodyPr wrap="square" lIns="0" tIns="0" rIns="0" bIns="0">
+            <a:spAutoFit/>
+          </a:bodyPr>
+          <a:lstStyle/>
+          <a:p>
+            <a:pPr algn="ctr"/>
+            <a:r>
+              <a:rPr sz="850" b="1" i="0">
+                <a:solidFill>
+                  <a:srgbClr val="047857"/>
+                </a:solidFill>
+                <a:latin typeface="JetBrains Mono"/>
+              </a:rPr>
+              <a:t>8-15 min</a:t>
+            </a:r>
+          </a:p>
+        </p:txBody>
+      </p:sp>
+      <p:sp>
+        <p:nvSpPr>
+          <p:cNvPr id="86" name="TextBox 85"/>
+          <p:cNvSpPr txBox="1"/>
+          <p:nvPr/>
+        </p:nvSpPr>
+        <p:spPr>
+          <a:xfrm>
+            <a:off x="6949440" y="2679192"/>
+            <a:ext cx="1645920" cy="274320"/>
+          </a:xfrm>
+          <a:prstGeom prst="rect">
+            <a:avLst/>
+          </a:prstGeom>
+          <a:noFill/>
+        </p:spPr>
+        <p:txBody>
+          <a:bodyPr wrap="square" lIns="0" tIns="0" rIns="0" bIns="0">
+            <a:spAutoFit/>
+          </a:bodyPr>
+          <a:lstStyle/>
+          <a:p>
+            <a:pPr algn="l"/>
+            <a:r>
+              <a:rPr sz="950" b="1" i="0">
+                <a:solidFill>
+                  <a:srgbClr val="000000"/>
+                </a:solidFill>
+                <a:latin typeface="Inter"/>
+              </a:rPr>
+              <a:t>Area Coverage / mi²</a:t>
+            </a:r>
+          </a:p>
+        </p:txBody>
+      </p:sp>
+      <p:sp>
+        <p:nvSpPr>
+          <p:cNvPr id="87" name="TextBox 86"/>
+          <p:cNvSpPr txBox="1"/>
+          <p:nvPr/>
+        </p:nvSpPr>
+        <p:spPr>
+          <a:xfrm>
+            <a:off x="8595360" y="2679192"/>
+            <a:ext cx="731520" cy="274320"/>
+          </a:xfrm>
+          <a:prstGeom prst="rect">
+            <a:avLst/>
+          </a:prstGeom>
+          <a:noFill/>
+        </p:spPr>
+        <p:txBody>
+          <a:bodyPr wrap="square" lIns="0" tIns="0" rIns="0" bIns="0">
+            <a:spAutoFit/>
+          </a:bodyPr>
+          <a:lstStyle/>
+          <a:p>
+            <a:pPr algn="ctr"/>
+            <a:r>
+              <a:rPr sz="850" b="0" i="0">
+                <a:solidFill>
+                  <a:srgbClr val="64748B"/>
+                </a:solidFill>
+                <a:latin typeface="JetBrains Mono"/>
+              </a:rPr>
+              <a:t>2-3 hours</a:t>
+            </a:r>
+          </a:p>
+        </p:txBody>
+      </p:sp>
+      <p:sp>
+        <p:nvSpPr>
+          <p:cNvPr id="88" name="TextBox 87"/>
+          <p:cNvSpPr txBox="1"/>
+          <p:nvPr/>
+        </p:nvSpPr>
+        <p:spPr>
+          <a:xfrm>
+            <a:off x="9326880" y="2679192"/>
+            <a:ext cx="914400" cy="274320"/>
+          </a:xfrm>
+          <a:prstGeom prst="rect">
+            <a:avLst/>
+          </a:prstGeom>
+          <a:noFill/>
+        </p:spPr>
+        <p:txBody>
+          <a:bodyPr wrap="square" lIns="0" tIns="0" rIns="0" bIns="0">
+            <a:spAutoFit/>
+          </a:bodyPr>
+          <a:lstStyle/>
+          <a:p>
+            <a:pPr algn="ctr"/>
+            <a:r>
+              <a:rPr sz="850" b="0" i="0">
+                <a:solidFill>
+                  <a:srgbClr val="475569"/>
+                </a:solidFill>
+                <a:latin typeface="JetBrains Mono"/>
+              </a:rPr>
+              <a:t>45-60 min</a:t>
+            </a:r>
+          </a:p>
+        </p:txBody>
+      </p:sp>
+      <p:sp>
+        <p:nvSpPr>
+          <p:cNvPr id="89" name="Rounded Rectangle 88"/>
+          <p:cNvSpPr/>
+          <p:nvPr/>
+        </p:nvSpPr>
+        <p:spPr>
+          <a:xfrm>
+            <a:off x="10241280" y="2642616"/>
+            <a:ext cx="1005840" cy="274320"/>
+          </a:xfrm>
+          <a:prstGeom prst="roundRect">
+            <a:avLst/>
+          </a:prstGeom>
+          <a:solidFill>
+            <a:srgbClr val="DCFCE7"/>
+          </a:solidFill>
+          <a:ln>
+            <a:noFill/>
+          </a:ln>
+        </p:spPr>
+        <p:style>
+          <a:lnRef idx="1">
+            <a:schemeClr val="accent1"/>
+          </a:lnRef>
+          <a:fillRef idx="3">
+            <a:schemeClr val="accent1"/>
+          </a:fillRef>
+          <a:effectRef idx="2">
+            <a:schemeClr val="accent1"/>
+          </a:effectRef>
+          <a:fontRef idx="minor">
+            <a:schemeClr val="lt1"/>
+          </a:fontRef>
+        </p:style>
+        <p:txBody>
+          <a:bodyPr rtlCol="0" anchor="ctr"/>
+          <a:lstStyle/>
+          <a:p>
+            <a:pPr algn="ctr"/>
+          </a:p>
+        </p:txBody>
+      </p:sp>
+      <p:sp>
+        <p:nvSpPr>
+          <p:cNvPr id="90" name="TextBox 89"/>
+          <p:cNvSpPr txBox="1"/>
+          <p:nvPr/>
+        </p:nvSpPr>
+        <p:spPr>
+          <a:xfrm>
+            <a:off x="10241280" y="2679192"/>
+            <a:ext cx="1005840" cy="274320"/>
+          </a:xfrm>
+          <a:prstGeom prst="rect">
+            <a:avLst/>
+          </a:prstGeom>
+          <a:noFill/>
+        </p:spPr>
+        <p:txBody>
+          <a:bodyPr wrap="square" lIns="0" tIns="0" rIns="0" bIns="0">
+            <a:spAutoFit/>
+          </a:bodyPr>
+          <a:lstStyle/>
+          <a:p>
+            <a:pPr algn="ctr"/>
+            <a:r>
+              <a:rPr sz="850" b="1" i="0">
+                <a:solidFill>
+                  <a:srgbClr val="047857"/>
+                </a:solidFill>
+                <a:latin typeface="JetBrains Mono"/>
+              </a:rPr>
+              <a:t>10-18 min</a:t>
+            </a:r>
+          </a:p>
+        </p:txBody>
+      </p:sp>
+      <p:sp>
+        <p:nvSpPr>
+          <p:cNvPr id="91" name="TextBox 90"/>
+          <p:cNvSpPr txBox="1"/>
+          <p:nvPr/>
+        </p:nvSpPr>
+        <p:spPr>
+          <a:xfrm>
+            <a:off x="6949440" y="3118104"/>
+            <a:ext cx="1645920" cy="274320"/>
+          </a:xfrm>
+          <a:prstGeom prst="rect">
+            <a:avLst/>
+          </a:prstGeom>
+          <a:noFill/>
+        </p:spPr>
+        <p:txBody>
+          <a:bodyPr wrap="square" lIns="0" tIns="0" rIns="0" bIns="0">
+            <a:spAutoFit/>
+          </a:bodyPr>
+          <a:lstStyle/>
+          <a:p>
+            <a:pPr algn="l"/>
+            <a:r>
+              <a:rPr sz="950" b="1" i="0">
+                <a:solidFill>
+                  <a:srgbClr val="000000"/>
+                </a:solidFill>
+                <a:latin typeface="Inter"/>
+              </a:rPr>
+              <a:t>Detection Rate</a:t>
+            </a:r>
+          </a:p>
+        </p:txBody>
+      </p:sp>
+      <p:sp>
+        <p:nvSpPr>
+          <p:cNvPr id="92" name="TextBox 91"/>
+          <p:cNvSpPr txBox="1"/>
+          <p:nvPr/>
+        </p:nvSpPr>
+        <p:spPr>
+          <a:xfrm>
+            <a:off x="8595360" y="3118104"/>
+            <a:ext cx="731520" cy="274320"/>
+          </a:xfrm>
+          <a:prstGeom prst="rect">
+            <a:avLst/>
+          </a:prstGeom>
+          <a:noFill/>
+        </p:spPr>
+        <p:txBody>
+          <a:bodyPr wrap="square" lIns="0" tIns="0" rIns="0" bIns="0">
+            <a:spAutoFit/>
+          </a:bodyPr>
+          <a:lstStyle/>
+          <a:p>
+            <a:pPr algn="ctr"/>
+            <a:r>
+              <a:rPr sz="850" b="0" i="0">
+                <a:solidFill>
+                  <a:srgbClr val="64748B"/>
+                </a:solidFill>
+                <a:latin typeface="JetBrains Mono"/>
+              </a:rPr>
+              <a:t>65-70%</a:t>
+            </a:r>
+          </a:p>
+        </p:txBody>
+      </p:sp>
+      <p:sp>
+        <p:nvSpPr>
+          <p:cNvPr id="93" name="TextBox 92"/>
+          <p:cNvSpPr txBox="1"/>
+          <p:nvPr/>
+        </p:nvSpPr>
+        <p:spPr>
+          <a:xfrm>
+            <a:off x="9326880" y="3118104"/>
+            <a:ext cx="914400" cy="274320"/>
+          </a:xfrm>
+          <a:prstGeom prst="rect">
+            <a:avLst/>
+          </a:prstGeom>
+          <a:noFill/>
+        </p:spPr>
+        <p:txBody>
+          <a:bodyPr wrap="square" lIns="0" tIns="0" rIns="0" bIns="0">
+            <a:spAutoFit/>
+          </a:bodyPr>
+          <a:lstStyle/>
+          <a:p>
+            <a:pPr algn="ctr"/>
+            <a:r>
+              <a:rPr sz="850" b="0" i="0">
+                <a:solidFill>
+                  <a:srgbClr val="475569"/>
+                </a:solidFill>
+                <a:latin typeface="JetBrains Mono"/>
+              </a:rPr>
+              <a:t>55-65%</a:t>
+            </a:r>
+          </a:p>
+        </p:txBody>
+      </p:sp>
+      <p:sp>
+        <p:nvSpPr>
+          <p:cNvPr id="94" name="Rounded Rectangle 93"/>
+          <p:cNvSpPr/>
+          <p:nvPr/>
+        </p:nvSpPr>
+        <p:spPr>
+          <a:xfrm>
+            <a:off x="10241280" y="3081528"/>
+            <a:ext cx="1005840" cy="274320"/>
+          </a:xfrm>
+          <a:prstGeom prst="roundRect">
+            <a:avLst/>
+          </a:prstGeom>
+          <a:solidFill>
+            <a:srgbClr val="DCFCE7"/>
+          </a:solidFill>
+          <a:ln>
+            <a:noFill/>
+          </a:ln>
+        </p:spPr>
+        <p:style>
+          <a:lnRef idx="1">
+            <a:schemeClr val="accent1"/>
+          </a:lnRef>
+          <a:fillRef idx="3">
+            <a:schemeClr val="accent1"/>
+          </a:fillRef>
+          <a:effectRef idx="2">
+            <a:schemeClr val="accent1"/>
+          </a:effectRef>
+          <a:fontRef idx="minor">
+            <a:schemeClr val="lt1"/>
+          </a:fontRef>
+        </p:style>
+        <p:txBody>
+          <a:bodyPr rtlCol="0" anchor="ctr"/>
+          <a:lstStyle/>
+          <a:p>
+            <a:pPr algn="ctr"/>
+          </a:p>
+        </p:txBody>
+      </p:sp>
+      <p:sp>
+        <p:nvSpPr>
+          <p:cNvPr id="95" name="TextBox 94"/>
+          <p:cNvSpPr txBox="1"/>
+          <p:nvPr/>
+        </p:nvSpPr>
+        <p:spPr>
+          <a:xfrm>
+            <a:off x="10241280" y="3118104"/>
+            <a:ext cx="1005840" cy="274320"/>
+          </a:xfrm>
+          <a:prstGeom prst="rect">
+            <a:avLst/>
+          </a:prstGeom>
+          <a:noFill/>
+        </p:spPr>
+        <p:txBody>
+          <a:bodyPr wrap="square" lIns="0" tIns="0" rIns="0" bIns="0">
+            <a:spAutoFit/>
+          </a:bodyPr>
+          <a:lstStyle/>
+          <a:p>
+            <a:pPr algn="ctr"/>
+            <a:r>
+              <a:rPr sz="850" b="1" i="0">
+                <a:solidFill>
+                  <a:srgbClr val="047857"/>
+                </a:solidFill>
+                <a:latin typeface="JetBrains Mono"/>
+              </a:rPr>
+              <a:t>78-85%</a:t>
+            </a:r>
+          </a:p>
+        </p:txBody>
+      </p:sp>
+      <p:sp>
+        <p:nvSpPr>
+          <p:cNvPr id="96" name="TextBox 95"/>
+          <p:cNvSpPr txBox="1"/>
+          <p:nvPr/>
+        </p:nvSpPr>
+        <p:spPr>
+          <a:xfrm>
+            <a:off x="6949440" y="3557016"/>
+            <a:ext cx="1645920" cy="274320"/>
+          </a:xfrm>
+          <a:prstGeom prst="rect">
+            <a:avLst/>
+          </a:prstGeom>
+          <a:noFill/>
+        </p:spPr>
+        <p:txBody>
+          <a:bodyPr wrap="square" lIns="0" tIns="0" rIns="0" bIns="0">
+            <a:spAutoFit/>
+          </a:bodyPr>
+          <a:lstStyle/>
+          <a:p>
+            <a:pPr algn="l"/>
+            <a:r>
+              <a:rPr sz="950" b="1" i="0">
+                <a:solidFill>
+                  <a:srgbClr val="000000"/>
+                </a:solidFill>
+                <a:latin typeface="Inter"/>
+              </a:rPr>
+              <a:t>Personnel Required</a:t>
+            </a:r>
+          </a:p>
+        </p:txBody>
+      </p:sp>
+      <p:sp>
+        <p:nvSpPr>
+          <p:cNvPr id="97" name="TextBox 96"/>
+          <p:cNvSpPr txBox="1"/>
+          <p:nvPr/>
+        </p:nvSpPr>
+        <p:spPr>
+          <a:xfrm>
+            <a:off x="8595360" y="3557016"/>
+            <a:ext cx="731520" cy="274320"/>
+          </a:xfrm>
+          <a:prstGeom prst="rect">
+            <a:avLst/>
+          </a:prstGeom>
+          <a:noFill/>
+        </p:spPr>
+        <p:txBody>
+          <a:bodyPr wrap="square" lIns="0" tIns="0" rIns="0" bIns="0">
+            <a:spAutoFit/>
+          </a:bodyPr>
+          <a:lstStyle/>
+          <a:p>
+            <a:pPr algn="ctr"/>
+            <a:r>
+              <a:rPr sz="850" b="0" i="0">
+                <a:solidFill>
+                  <a:srgbClr val="64748B"/>
+                </a:solidFill>
+                <a:latin typeface="JetBrains Mono"/>
+              </a:rPr>
+              <a:t>15-25 crew</a:t>
+            </a:r>
+          </a:p>
+        </p:txBody>
+      </p:sp>
+      <p:sp>
+        <p:nvSpPr>
+          <p:cNvPr id="98" name="TextBox 97"/>
+          <p:cNvSpPr txBox="1"/>
+          <p:nvPr/>
+        </p:nvSpPr>
+        <p:spPr>
+          <a:xfrm>
+            <a:off x="9326880" y="3557016"/>
+            <a:ext cx="914400" cy="274320"/>
+          </a:xfrm>
+          <a:prstGeom prst="rect">
+            <a:avLst/>
+          </a:prstGeom>
+          <a:noFill/>
+        </p:spPr>
+        <p:txBody>
+          <a:bodyPr wrap="square" lIns="0" tIns="0" rIns="0" bIns="0">
+            <a:spAutoFit/>
+          </a:bodyPr>
+          <a:lstStyle/>
+          <a:p>
+            <a:pPr algn="ctr"/>
+            <a:r>
+              <a:rPr sz="850" b="0" i="0">
+                <a:solidFill>
+                  <a:srgbClr val="475569"/>
+                </a:solidFill>
+                <a:latin typeface="JetBrains Mono"/>
+              </a:rPr>
+              <a:t>2-3 pilots</a:t>
+            </a:r>
+          </a:p>
+        </p:txBody>
+      </p:sp>
+      <p:sp>
+        <p:nvSpPr>
+          <p:cNvPr id="99" name="Rounded Rectangle 98"/>
+          <p:cNvSpPr/>
+          <p:nvPr/>
+        </p:nvSpPr>
+        <p:spPr>
+          <a:xfrm>
+            <a:off x="10241280" y="3520440"/>
+            <a:ext cx="1005840" cy="274320"/>
+          </a:xfrm>
+          <a:prstGeom prst="roundRect">
+            <a:avLst/>
+          </a:prstGeom>
+          <a:solidFill>
+            <a:srgbClr val="DCFCE7"/>
+          </a:solidFill>
+          <a:ln>
+            <a:noFill/>
+          </a:ln>
+        </p:spPr>
+        <p:style>
+          <a:lnRef idx="1">
+            <a:schemeClr val="accent1"/>
+          </a:lnRef>
+          <a:fillRef idx="3">
+            <a:schemeClr val="accent1"/>
+          </a:fillRef>
+          <a:effectRef idx="2">
+            <a:schemeClr val="accent1"/>
+          </a:effectRef>
+          <a:fontRef idx="minor">
+            <a:schemeClr val="lt1"/>
+          </a:fontRef>
+        </p:style>
+        <p:txBody>
+          <a:bodyPr rtlCol="0" anchor="ctr"/>
+          <a:lstStyle/>
+          <a:p>
+            <a:pPr algn="ctr"/>
+          </a:p>
+        </p:txBody>
+      </p:sp>
+      <p:sp>
+        <p:nvSpPr>
+          <p:cNvPr id="100" name="TextBox 99"/>
+          <p:cNvSpPr txBox="1"/>
+          <p:nvPr/>
+        </p:nvSpPr>
+        <p:spPr>
+          <a:xfrm>
+            <a:off x="10241280" y="3557016"/>
+            <a:ext cx="1005840" cy="274320"/>
+          </a:xfrm>
+          <a:prstGeom prst="rect">
+            <a:avLst/>
+          </a:prstGeom>
+          <a:noFill/>
+        </p:spPr>
+        <p:txBody>
+          <a:bodyPr wrap="square" lIns="0" tIns="0" rIns="0" bIns="0">
+            <a:spAutoFit/>
+          </a:bodyPr>
+          <a:lstStyle/>
+          <a:p>
+            <a:pPr algn="ctr"/>
+            <a:r>
+              <a:rPr sz="850" b="1" i="0">
+                <a:solidFill>
+                  <a:srgbClr val="047857"/>
+                </a:solidFill>
+                <a:latin typeface="JetBrains Mono"/>
+              </a:rPr>
+              <a:t>1-2 operators</a:t>
+            </a:r>
+          </a:p>
+        </p:txBody>
+      </p:sp>
+      <p:sp>
+        <p:nvSpPr>
+          <p:cNvPr id="101" name="Rounded Rectangle 100"/>
+          <p:cNvSpPr/>
+          <p:nvPr/>
+        </p:nvSpPr>
+        <p:spPr>
+          <a:xfrm>
+            <a:off x="6766560" y="4389120"/>
+            <a:ext cx="4693615" cy="1280160"/>
+          </a:xfrm>
+          <a:prstGeom prst="roundRect">
+            <a:avLst/>
+          </a:prstGeom>
+          <a:solidFill>
+            <a:srgbClr val="F8FAFC"/>
+          </a:solidFill>
+          <a:ln w="12700">
+            <a:solidFill>
+              <a:srgbClr val="E2E8F0"/>
+            </a:solidFill>
+          </a:ln>
+        </p:spPr>
+        <p:style>
+          <a:lnRef idx="1">
+            <a:schemeClr val="accent1"/>
+          </a:lnRef>
+          <a:fillRef idx="3">
+            <a:schemeClr val="accent1"/>
+          </a:fillRef>
+          <a:effectRef idx="2">
+            <a:schemeClr val="accent1"/>
+          </a:effectRef>
+          <a:fontRef idx="minor">
+            <a:schemeClr val="lt1"/>
+          </a:fontRef>
+        </p:style>
+        <p:txBody>
+          <a:bodyPr rtlCol="0" anchor="ctr"/>
+          <a:lstStyle/>
+          <a:p>
+            <a:pPr algn="ctr"/>
+          </a:p>
+        </p:txBody>
+      </p:sp>
+      <p:sp>
+        <p:nvSpPr>
+          <p:cNvPr id="102" name="TextBox 101"/>
+          <p:cNvSpPr txBox="1"/>
+          <p:nvPr/>
+        </p:nvSpPr>
+        <p:spPr>
+          <a:xfrm>
+            <a:off x="6949440" y="4480560"/>
+            <a:ext cx="3200400" cy="182880"/>
+          </a:xfrm>
+          <a:prstGeom prst="rect">
+            <a:avLst/>
+          </a:prstGeom>
+          <a:noFill/>
+        </p:spPr>
+        <p:txBody>
+          <a:bodyPr wrap="square" lIns="0" tIns="0" rIns="0" bIns="0">
+            <a:spAutoFit/>
+          </a:bodyPr>
+          <a:lstStyle/>
+          <a:p>
+            <a:pPr algn="l"/>
+            <a:r>
+              <a:rPr sz="750" b="1" i="0">
+                <a:solidFill>
+                  <a:srgbClr val="94A3B8"/>
+                </a:solidFill>
+                <a:latin typeface="JetBrains Mono"/>
+              </a:rPr>
+              <a:t>SPEED COMPARISON (SQ MILES / HOUR)</a:t>
+            </a:r>
+          </a:p>
+        </p:txBody>
+      </p:sp>
+      <p:sp>
+        <p:nvSpPr>
+          <p:cNvPr id="103" name="TextBox 102"/>
+          <p:cNvSpPr txBox="1"/>
+          <p:nvPr/>
+        </p:nvSpPr>
+        <p:spPr>
+          <a:xfrm>
+            <a:off x="9601200" y="4480560"/>
+            <a:ext cx="1645920" cy="182880"/>
+          </a:xfrm>
+          <a:prstGeom prst="rect">
+            <a:avLst/>
+          </a:prstGeom>
+          <a:noFill/>
+        </p:spPr>
+        <p:txBody>
+          <a:bodyPr wrap="square" lIns="0" tIns="0" rIns="0" bIns="0">
+            <a:spAutoFit/>
+          </a:bodyPr>
+          <a:lstStyle/>
+          <a:p>
+            <a:pPr algn="r"/>
+            <a:r>
+              <a:rPr sz="750" b="1" i="0">
+                <a:solidFill>
+                  <a:srgbClr val="047857"/>
+                </a:solidFill>
+                <a:latin typeface="JetBrains Mono"/>
+              </a:rPr>
+              <a:t>3-4X FASTER COVERAGE</a:t>
+            </a:r>
+          </a:p>
+        </p:txBody>
+      </p:sp>
+      <p:sp>
+        <p:nvSpPr>
+          <p:cNvPr id="104" name="TextBox 103"/>
+          <p:cNvSpPr txBox="1"/>
+          <p:nvPr/>
+        </p:nvSpPr>
+        <p:spPr>
+          <a:xfrm>
+            <a:off x="6949440" y="4709160"/>
+            <a:ext cx="1097280" cy="182880"/>
+          </a:xfrm>
+          <a:prstGeom prst="rect">
+            <a:avLst/>
+          </a:prstGeom>
+          <a:noFill/>
+        </p:spPr>
+        <p:txBody>
+          <a:bodyPr wrap="square" lIns="0" tIns="0" rIns="0" bIns="0">
+            <a:spAutoFit/>
+          </a:bodyPr>
+          <a:lstStyle/>
+          <a:p>
+            <a:pPr algn="l"/>
+            <a:r>
+              <a:rPr sz="700" b="0" i="0">
+                <a:solidFill>
+                  <a:srgbClr val="64748B"/>
+                </a:solidFill>
+                <a:latin typeface="JetBrains Mono"/>
+              </a:rPr>
+              <a:t>Traditional Ground</a:t>
+            </a:r>
+          </a:p>
+        </p:txBody>
+      </p:sp>
+      <p:sp>
+        <p:nvSpPr>
+          <p:cNvPr id="105" name="Rounded Rectangle 104"/>
+          <p:cNvSpPr/>
+          <p:nvPr/>
+        </p:nvSpPr>
+        <p:spPr>
+          <a:xfrm>
+            <a:off x="8138160" y="4754880"/>
+            <a:ext cx="365760" cy="91440"/>
+          </a:xfrm>
+          <a:prstGeom prst="roundRect">
+            <a:avLst/>
+          </a:prstGeom>
+          <a:solidFill>
+            <a:srgbClr val="94A3B8"/>
+          </a:solidFill>
+          <a:ln>
+            <a:noFill/>
+          </a:ln>
+        </p:spPr>
+        <p:style>
+          <a:lnRef idx="1">
+            <a:schemeClr val="accent1"/>
+          </a:lnRef>
+          <a:fillRef idx="3">
+            <a:schemeClr val="accent1"/>
+          </a:fillRef>
+          <a:effectRef idx="2">
+            <a:schemeClr val="accent1"/>
+          </a:effectRef>
+          <a:fontRef idx="minor">
+            <a:schemeClr val="lt1"/>
+          </a:fontRef>
+        </p:style>
+        <p:txBody>
+          <a:bodyPr rtlCol="0" anchor="ctr"/>
+          <a:lstStyle/>
+          <a:p>
+            <a:pPr algn="ctr"/>
+          </a:p>
+        </p:txBody>
+      </p:sp>
+      <p:sp>
+        <p:nvSpPr>
+          <p:cNvPr id="106" name="TextBox 105"/>
+          <p:cNvSpPr txBox="1"/>
+          <p:nvPr/>
+        </p:nvSpPr>
+        <p:spPr>
+          <a:xfrm>
+            <a:off x="10789920" y="4709160"/>
+            <a:ext cx="548640" cy="182880"/>
+          </a:xfrm>
+          <a:prstGeom prst="rect">
+            <a:avLst/>
+          </a:prstGeom>
+          <a:noFill/>
+        </p:spPr>
+        <p:txBody>
+          <a:bodyPr wrap="square" lIns="0" tIns="0" rIns="0" bIns="0">
+            <a:spAutoFit/>
+          </a:bodyPr>
+          <a:lstStyle/>
+          <a:p>
+            <a:pPr algn="r"/>
+            <a:r>
+              <a:rPr sz="700" b="0" i="0">
+                <a:solidFill>
+                  <a:srgbClr val="64748B"/>
+                </a:solidFill>
+                <a:latin typeface="JetBrains Mono"/>
+              </a:rPr>
+              <a:t>0.4 mi²</a:t>
+            </a:r>
+          </a:p>
+        </p:txBody>
+      </p:sp>
+      <p:sp>
+        <p:nvSpPr>
+          <p:cNvPr id="107" name="TextBox 106"/>
+          <p:cNvSpPr txBox="1"/>
+          <p:nvPr/>
+        </p:nvSpPr>
+        <p:spPr>
+          <a:xfrm>
+            <a:off x="6949440" y="4937760"/>
+            <a:ext cx="1097280" cy="182880"/>
+          </a:xfrm>
+          <a:prstGeom prst="rect">
+            <a:avLst/>
+          </a:prstGeom>
+          <a:noFill/>
+        </p:spPr>
+        <p:txBody>
+          <a:bodyPr wrap="square" lIns="0" tIns="0" rIns="0" bIns="0">
+            <a:spAutoFit/>
+          </a:bodyPr>
+          <a:lstStyle/>
+          <a:p>
+            <a:pPr algn="l"/>
+            <a:r>
+              <a:rPr sz="700" b="0" i="0">
+                <a:solidFill>
+                  <a:srgbClr val="64748B"/>
+                </a:solidFill>
+                <a:latin typeface="JetBrains Mono"/>
+              </a:rPr>
+              <a:t>Single Drone</a:t>
+            </a:r>
+          </a:p>
+        </p:txBody>
+      </p:sp>
+      <p:sp>
+        <p:nvSpPr>
+          <p:cNvPr id="108" name="Rounded Rectangle 107"/>
+          <p:cNvSpPr/>
+          <p:nvPr/>
+        </p:nvSpPr>
+        <p:spPr>
+          <a:xfrm>
+            <a:off x="8138160" y="4983480"/>
+            <a:ext cx="1097280" cy="91440"/>
+          </a:xfrm>
+          <a:prstGeom prst="roundRect">
+            <a:avLst/>
+          </a:prstGeom>
+          <a:solidFill>
+            <a:srgbClr val="475569"/>
+          </a:solidFill>
+          <a:ln>
+            <a:noFill/>
+          </a:ln>
+        </p:spPr>
+        <p:style>
+          <a:lnRef idx="1">
+            <a:schemeClr val="accent1"/>
+          </a:lnRef>
+          <a:fillRef idx="3">
+            <a:schemeClr val="accent1"/>
+          </a:fillRef>
+          <a:effectRef idx="2">
+            <a:schemeClr val="accent1"/>
+          </a:effectRef>
+          <a:fontRef idx="minor">
+            <a:schemeClr val="lt1"/>
+          </a:fontRef>
+        </p:style>
+        <p:txBody>
+          <a:bodyPr rtlCol="0" anchor="ctr"/>
+          <a:lstStyle/>
+          <a:p>
+            <a:pPr algn="ctr"/>
+          </a:p>
+        </p:txBody>
+      </p:sp>
+      <p:sp>
+        <p:nvSpPr>
+          <p:cNvPr id="109" name="TextBox 108"/>
+          <p:cNvSpPr txBox="1"/>
+          <p:nvPr/>
+        </p:nvSpPr>
+        <p:spPr>
+          <a:xfrm>
+            <a:off x="10789920" y="4937760"/>
+            <a:ext cx="548640" cy="182880"/>
+          </a:xfrm>
+          <a:prstGeom prst="rect">
+            <a:avLst/>
+          </a:prstGeom>
+          <a:noFill/>
+        </p:spPr>
+        <p:txBody>
+          <a:bodyPr wrap="square" lIns="0" tIns="0" rIns="0" bIns="0">
+            <a:spAutoFit/>
+          </a:bodyPr>
+          <a:lstStyle/>
+          <a:p>
+            <a:pPr algn="r"/>
+            <a:r>
+              <a:rPr sz="700" b="0" i="0">
+                <a:solidFill>
+                  <a:srgbClr val="64748B"/>
+                </a:solidFill>
+                <a:latin typeface="JetBrains Mono"/>
+              </a:rPr>
+              <a:t>1.2 mi²</a:t>
+            </a:r>
+          </a:p>
+        </p:txBody>
+      </p:sp>
+      <p:sp>
+        <p:nvSpPr>
+          <p:cNvPr id="110" name="TextBox 109"/>
+          <p:cNvSpPr txBox="1"/>
+          <p:nvPr/>
+        </p:nvSpPr>
+        <p:spPr>
+          <a:xfrm>
+            <a:off x="6949440" y="5166360"/>
+            <a:ext cx="1097280" cy="182880"/>
+          </a:xfrm>
+          <a:prstGeom prst="rect">
+            <a:avLst/>
+          </a:prstGeom>
+          <a:noFill/>
+        </p:spPr>
+        <p:txBody>
+          <a:bodyPr wrap="square" lIns="0" tIns="0" rIns="0" bIns="0">
+            <a:spAutoFit/>
+          </a:bodyPr>
+          <a:lstStyle/>
+          <a:p>
+            <a:pPr algn="l"/>
+            <a:r>
+              <a:rPr sz="750" b="1" i="0">
+                <a:solidFill>
+                  <a:srgbClr val="000000"/>
+                </a:solidFill>
+                <a:latin typeface="JetBrains Mono"/>
+              </a:rPr>
+              <a:t>AI Swarm (SUTRA)</a:t>
+            </a:r>
+          </a:p>
+        </p:txBody>
+      </p:sp>
+      <p:sp>
+        <p:nvSpPr>
+          <p:cNvPr id="111" name="Rounded Rectangle 110"/>
+          <p:cNvSpPr/>
+          <p:nvPr/>
+        </p:nvSpPr>
+        <p:spPr>
+          <a:xfrm>
+            <a:off x="8138160" y="5212080"/>
+            <a:ext cx="2743200" cy="128016"/>
+          </a:xfrm>
+          <a:prstGeom prst="roundRect">
+            <a:avLst/>
+          </a:prstGeom>
+          <a:solidFill>
+            <a:srgbClr val="047857"/>
+          </a:solidFill>
+          <a:ln>
+            <a:noFill/>
+          </a:ln>
+        </p:spPr>
+        <p:style>
+          <a:lnRef idx="1">
+            <a:schemeClr val="accent1"/>
+          </a:lnRef>
+          <a:fillRef idx="3">
+            <a:schemeClr val="accent1"/>
+          </a:fillRef>
+          <a:effectRef idx="2">
+            <a:schemeClr val="accent1"/>
+          </a:effectRef>
+          <a:fontRef idx="minor">
+            <a:schemeClr val="lt1"/>
+          </a:fontRef>
+        </p:style>
+        <p:txBody>
+          <a:bodyPr rtlCol="0" anchor="ctr"/>
+          <a:lstStyle/>
+          <a:p>
+            <a:pPr algn="ctr"/>
+          </a:p>
+        </p:txBody>
+      </p:sp>
+      <p:sp>
+        <p:nvSpPr>
+          <p:cNvPr id="112" name="TextBox 111"/>
+          <p:cNvSpPr txBox="1"/>
+          <p:nvPr/>
+        </p:nvSpPr>
+        <p:spPr>
+          <a:xfrm>
+            <a:off x="10789920" y="5166360"/>
+            <a:ext cx="548640" cy="182880"/>
+          </a:xfrm>
+          <a:prstGeom prst="rect">
+            <a:avLst/>
+          </a:prstGeom>
+          <a:noFill/>
+        </p:spPr>
+        <p:txBody>
+          <a:bodyPr wrap="square" lIns="0" tIns="0" rIns="0" bIns="0">
+            <a:spAutoFit/>
+          </a:bodyPr>
+          <a:lstStyle/>
+          <a:p>
+            <a:pPr algn="r"/>
+            <a:r>
+              <a:rPr sz="750" b="1" i="0">
+                <a:solidFill>
+                  <a:srgbClr val="047857"/>
+                </a:solidFill>
+                <a:latin typeface="JetBrains Mono"/>
+              </a:rPr>
+              <a:t>4.5 mi²</a:t>
+            </a:r>
+          </a:p>
+        </p:txBody>
+      </p:sp>
+      <p:sp>
+        <p:nvSpPr>
+          <p:cNvPr id="113" name="Rectangle 112"/>
+          <p:cNvSpPr/>
+          <p:nvPr/>
+        </p:nvSpPr>
+        <p:spPr>
+          <a:xfrm>
+            <a:off x="731520" y="5943600"/>
+            <a:ext cx="10728655" cy="13716"/>
+          </a:xfrm>
+          <a:prstGeom prst="rect">
+            <a:avLst/>
+          </a:prstGeom>
+          <a:solidFill>
+            <a:srgbClr val="E2E8F0"/>
+          </a:solidFill>
+          <a:ln>
+            <a:noFill/>
+          </a:ln>
+        </p:spPr>
+        <p:style>
+          <a:lnRef idx="1">
+            <a:schemeClr val="accent1"/>
+          </a:lnRef>
+          <a:fillRef idx="3">
+            <a:schemeClr val="accent1"/>
+          </a:fillRef>
+          <a:effectRef idx="2">
+            <a:schemeClr val="accent1"/>
+          </a:effectRef>
+          <a:fontRef idx="minor">
+            <a:schemeClr val="lt1"/>
+          </a:fontRef>
+        </p:style>
+        <p:txBody>
+          <a:bodyPr rtlCol="0" anchor="ctr"/>
+          <a:lstStyle/>
+          <a:p>
+            <a:pPr algn="ctr"/>
+          </a:p>
+        </p:txBody>
+      </p:sp>
+      <p:sp>
+        <p:nvSpPr>
+          <p:cNvPr id="114" name="TextBox 113"/>
+          <p:cNvSpPr txBox="1"/>
+          <p:nvPr/>
+        </p:nvSpPr>
+        <p:spPr>
+          <a:xfrm>
+            <a:off x="731520" y="6080760"/>
+            <a:ext cx="2743200" cy="274320"/>
+          </a:xfrm>
+          <a:prstGeom prst="rect">
+            <a:avLst/>
+          </a:prstGeom>
+          <a:noFill/>
+        </p:spPr>
+        <p:txBody>
+          <a:bodyPr wrap="square" lIns="0" tIns="0" rIns="0" bIns="0">
+            <a:spAutoFit/>
+          </a:bodyPr>
+          <a:lstStyle/>
+          <a:p>
+            <a:pPr algn="l"/>
+            <a:r>
+              <a:rPr sz="900" b="0" i="0">
+                <a:solidFill>
+                  <a:srgbClr val="64748B"/>
+                </a:solidFill>
+                <a:latin typeface="JetBrains Mono"/>
+              </a:rPr>
+              <a:t>PAGE 03</a:t>
+            </a:r>
+          </a:p>
+        </p:txBody>
+      </p:sp>
+      <p:sp>
+        <p:nvSpPr>
+          <p:cNvPr id="115" name="TextBox 114"/>
           <p:cNvSpPr txBox="1"/>
           <p:nvPr/>
         </p:nvSpPr>

</xml_diff>

<commit_message>
feat(slides): align Slide 2 and Slide 3 with Problem vs Subsystem Moats architecture
</commit_message>
<xml_diff>
--- a/sutra_pitch_deck.pptx
+++ b/sutra_pitch_deck.pptx
@@ -9015,7 +9015,7 @@
         <p:spPr>
           <a:xfrm>
             <a:off x="960120" y="594360"/>
-            <a:ext cx="4114800" cy="320040"/>
+            <a:ext cx="5029200" cy="320040"/>
           </a:xfrm>
           <a:prstGeom prst="rect">
             <a:avLst/>
@@ -9030,13 +9030,13 @@
           <a:p>
             <a:pPr algn="l"/>
             <a:r>
-              <a:rPr sz="1300" b="1" i="0">
+              <a:rPr sz="1200" b="1" i="0">
                 <a:solidFill>
                   <a:srgbClr val="0A1628"/>
                 </a:solidFill>
                 <a:latin typeface="JetBrains Mono"/>
               </a:rPr>
-              <a:t>THE PROBLEM</a:t>
+              <a:t>THE PROBLEM — SUBSYSTEM FAILURE MODES</a:t>
             </a:r>
           </a:p>
         </p:txBody>
@@ -9159,7 +9159,7 @@
                 </a:solidFill>
                 <a:latin typeface="JetBrains Mono"/>
               </a:rPr>
-              <a:t>RESCUE DRONE FAILURE MODES</a:t>
+              <a:t>DISASTER FIELD BOTTLENECKS</a:t>
             </a:r>
           </a:p>
         </p:txBody>
@@ -9188,7 +9188,7 @@
           <a:p>
             <a:pPr algn="l"/>
             <a:r>
-              <a:rPr sz="3200" b="1" i="0">
+              <a:rPr sz="3000" b="1" i="0">
                 <a:solidFill>
                   <a:srgbClr val="000000"/>
                 </a:solidFill>
@@ -9207,7 +9207,7 @@
         </p:nvSpPr>
         <p:spPr>
           <a:xfrm>
-            <a:off x="749808" y="2432304"/>
+            <a:off x="749808" y="2386584"/>
             <a:ext cx="82296" cy="82296"/>
           </a:xfrm>
           <a:prstGeom prst="ellipse">
@@ -9250,7 +9250,7 @@
         </p:nvSpPr>
         <p:spPr>
           <a:xfrm>
-            <a:off x="932688" y="2377440"/>
+            <a:off x="932688" y="2331720"/>
             <a:ext cx="6217920" cy="365760"/>
           </a:xfrm>
           <a:prstGeom prst="rect">
@@ -9266,7 +9266,7 @@
           <a:p>
             <a:pPr algn="l"/>
             <a:r>
-              <a:rPr sz="1500" b="0" i="0">
+              <a:rPr sz="1400" b="0" i="0">
                 <a:solidFill>
                   <a:srgbClr val="374151"/>
                 </a:solidFill>
@@ -9285,7 +9285,7 @@
         </p:nvSpPr>
         <p:spPr>
           <a:xfrm>
-            <a:off x="749808" y="2871216"/>
+            <a:off x="749808" y="2788920"/>
             <a:ext cx="82296" cy="82296"/>
           </a:xfrm>
           <a:prstGeom prst="ellipse">
@@ -9328,7 +9328,7 @@
         </p:nvSpPr>
         <p:spPr>
           <a:xfrm>
-            <a:off x="932688" y="2816352"/>
+            <a:off x="932688" y="2734056"/>
             <a:ext cx="6217920" cy="365760"/>
           </a:xfrm>
           <a:prstGeom prst="rect">
@@ -9344,7 +9344,7 @@
           <a:p>
             <a:pPr algn="l"/>
             <a:r>
-              <a:rPr sz="1500" b="0" i="0">
+              <a:rPr sz="1400" b="0" i="0">
                 <a:solidFill>
                   <a:srgbClr val="374151"/>
                 </a:solidFill>
@@ -9363,7 +9363,7 @@
         </p:nvSpPr>
         <p:spPr>
           <a:xfrm>
-            <a:off x="749808" y="3310128"/>
+            <a:off x="749808" y="3191256"/>
             <a:ext cx="82296" cy="82296"/>
           </a:xfrm>
           <a:prstGeom prst="ellipse">
@@ -9406,7 +9406,7 @@
         </p:nvSpPr>
         <p:spPr>
           <a:xfrm>
-            <a:off x="932688" y="3255264"/>
+            <a:off x="932688" y="3136392"/>
             <a:ext cx="6217920" cy="365760"/>
           </a:xfrm>
           <a:prstGeom prst="rect">
@@ -9422,7 +9422,7 @@
           <a:p>
             <a:pPr algn="l"/>
             <a:r>
-              <a:rPr sz="1500" b="0" i="0">
+              <a:rPr sz="1400" b="0" i="0">
                 <a:solidFill>
                   <a:srgbClr val="374151"/>
                 </a:solidFill>
@@ -9441,7 +9441,7 @@
         </p:nvSpPr>
         <p:spPr>
           <a:xfrm>
-            <a:off x="749808" y="3749040"/>
+            <a:off x="749808" y="3593592"/>
             <a:ext cx="82296" cy="82296"/>
           </a:xfrm>
           <a:prstGeom prst="ellipse">
@@ -9484,7 +9484,7 @@
         </p:nvSpPr>
         <p:spPr>
           <a:xfrm>
-            <a:off x="932688" y="3694176"/>
+            <a:off x="932688" y="3538728"/>
             <a:ext cx="6217920" cy="365760"/>
           </a:xfrm>
           <a:prstGeom prst="rect">
@@ -9500,7 +9500,7 @@
           <a:p>
             <a:pPr algn="l"/>
             <a:r>
-              <a:rPr sz="1500" b="0" i="0">
+              <a:rPr sz="1400" b="0" i="0">
                 <a:solidFill>
                   <a:srgbClr val="374151"/>
                 </a:solidFill>
@@ -9519,7 +9519,7 @@
         </p:nvSpPr>
         <p:spPr>
           <a:xfrm>
-            <a:off x="749808" y="4187952"/>
+            <a:off x="749808" y="3995928"/>
             <a:ext cx="82296" cy="82296"/>
           </a:xfrm>
           <a:prstGeom prst="ellipse">
@@ -9562,7 +9562,7 @@
         </p:nvSpPr>
         <p:spPr>
           <a:xfrm>
-            <a:off x="932688" y="4133088"/>
+            <a:off x="932688" y="3941064"/>
             <a:ext cx="6217920" cy="365760"/>
           </a:xfrm>
           <a:prstGeom prst="rect">
@@ -9578,7 +9578,7 @@
           <a:p>
             <a:pPr algn="l"/>
             <a:r>
-              <a:rPr sz="1500" b="0" i="0">
+              <a:rPr sz="1400" b="0" i="0">
                 <a:solidFill>
                   <a:srgbClr val="374151"/>
                 </a:solidFill>
@@ -9597,7 +9597,7 @@
         </p:nvSpPr>
         <p:spPr>
           <a:xfrm>
-            <a:off x="731520" y="4617720"/>
+            <a:off x="731520" y="4526280"/>
             <a:ext cx="4572000" cy="182880"/>
           </a:xfrm>
           <a:prstGeom prst="rect">
@@ -9619,7 +9619,7 @@
                 </a:solidFill>
                 <a:latin typeface="JetBrains Mono"/>
               </a:rPr>
-              <a:t>TACTICAL FAILURE SCHEMATICS</a:t>
+              <a:t>SUBSYSTEM FAILURE SCHEMATICS &amp; VOIDS</a:t>
             </a:r>
           </a:p>
         </p:txBody>
@@ -9632,8 +9632,8 @@
         </p:nvSpPr>
         <p:spPr>
           <a:xfrm>
-            <a:off x="731520" y="4828032"/>
-            <a:ext cx="2011680" cy="932688"/>
+            <a:off x="731520" y="4754880"/>
+            <a:ext cx="2011680" cy="1051560"/>
           </a:xfrm>
           <a:prstGeom prst="roundRect">
             <a:avLst/>
@@ -9671,7 +9671,7 @@
       </p:sp>
       <p:pic>
         <p:nvPicPr>
-          <p:cNvPr id="60" name="Picture 59" descr="rf_mountain_shadow.jpg"/>
+          <p:cNvPr id="60" name="Picture 59" descr="gps_canopy_shadow.jpg"/>
           <p:cNvPicPr>
             <a:picLocks noChangeAspect="1"/>
           </p:cNvPicPr>
@@ -9685,7 +9685,7 @@
         </p:blipFill>
         <p:spPr>
           <a:xfrm>
-            <a:off x="786384" y="4864608"/>
+            <a:off x="786384" y="4791456"/>
             <a:ext cx="1901952" cy="502920"/>
           </a:xfrm>
           <a:prstGeom prst="rect">
@@ -9701,7 +9701,42 @@
         </p:nvSpPr>
         <p:spPr>
           <a:xfrm>
-            <a:off x="804672" y="5413248"/>
+            <a:off x="804672" y="5321808"/>
+            <a:ext cx="1865376" cy="164592"/>
+          </a:xfrm>
+          <a:prstGeom prst="rect">
+            <a:avLst/>
+          </a:prstGeom>
+          <a:noFill/>
+        </p:spPr>
+        <p:txBody>
+          <a:bodyPr wrap="square" lIns="0" tIns="0" rIns="0" bIns="0">
+            <a:spAutoFit/>
+          </a:bodyPr>
+          <a:lstStyle/>
+          <a:p>
+            <a:pPr algn="l"/>
+            <a:r>
+              <a:rPr sz="650" b="1" i="0">
+                <a:solidFill>
+                  <a:srgbClr val="D71920"/>
+                </a:solidFill>
+                <a:latin typeface="JetBrains Mono"/>
+              </a:rPr>
+              <a:t>SUBSYSTEM A VOID</a:t>
+            </a:r>
+          </a:p>
+        </p:txBody>
+      </p:sp>
+      <p:sp>
+        <p:nvSpPr>
+          <p:cNvPr id="62" name="TextBox 61"/>
+          <p:cNvSpPr txBox="1"/>
+          <p:nvPr/>
+        </p:nvSpPr>
+        <p:spPr>
+          <a:xfrm>
+            <a:off x="804672" y="5468112"/>
             <a:ext cx="1865376" cy="182880"/>
           </a:xfrm>
           <a:prstGeom prst="rect">
@@ -9723,20 +9758,20 @@
                 </a:solidFill>
                 <a:latin typeface="Plus Jakarta Sans"/>
               </a:rPr>
-              <a:t>RF Ridge Shadow</a:t>
-            </a:r>
-          </a:p>
-        </p:txBody>
-      </p:sp>
-      <p:sp>
-        <p:nvSpPr>
-          <p:cNvPr id="62" name="TextBox 61"/>
+              <a:t>Canopy GPS Drift</a:t>
+            </a:r>
+          </a:p>
+        </p:txBody>
+      </p:sp>
+      <p:sp>
+        <p:nvSpPr>
+          <p:cNvPr id="63" name="TextBox 62"/>
           <p:cNvSpPr txBox="1"/>
           <p:nvPr/>
         </p:nvSpPr>
         <p:spPr>
           <a:xfrm>
-            <a:off x="804672" y="5577840"/>
+            <a:off x="804672" y="5632704"/>
             <a:ext cx="1865376" cy="164592"/>
           </a:xfrm>
           <a:prstGeom prst="rect">
@@ -9752,27 +9787,27 @@
           <a:p>
             <a:pPr algn="l"/>
             <a:r>
-              <a:rPr sz="650" b="0" i="0">
+              <a:rPr sz="620" b="0" i="0">
                 <a:solidFill>
                   <a:srgbClr val="64748B"/>
                 </a:solidFill>
                 <a:latin typeface="JetBrains Mono"/>
               </a:rPr>
-              <a:t>Video Stream Severance</a:t>
-            </a:r>
-          </a:p>
-        </p:txBody>
-      </p:sp>
-      <p:sp>
-        <p:nvSpPr>
-          <p:cNvPr id="63" name="Rounded Rectangle 62"/>
-          <p:cNvSpPr/>
-          <p:nvPr/>
-        </p:nvSpPr>
-        <p:spPr>
-          <a:xfrm>
-            <a:off x="2907792" y="4828032"/>
-            <a:ext cx="2011680" cy="932688"/>
+              <a:t>GNSS Multi-Path Crash</a:t>
+            </a:r>
+          </a:p>
+        </p:txBody>
+      </p:sp>
+      <p:sp>
+        <p:nvSpPr>
+          <p:cNvPr id="64" name="Rounded Rectangle 63"/>
+          <p:cNvSpPr/>
+          <p:nvPr/>
+        </p:nvSpPr>
+        <p:spPr>
+          <a:xfrm>
+            <a:off x="2907792" y="4754880"/>
+            <a:ext cx="2011680" cy="1051560"/>
           </a:xfrm>
           <a:prstGeom prst="roundRect">
             <a:avLst/>
@@ -9810,7 +9845,7 @@
       </p:sp>
       <p:pic>
         <p:nvPicPr>
-          <p:cNvPr id="64" name="Picture 63" descr="gps_canopy_shadow.jpg"/>
+          <p:cNvPr id="65" name="Picture 64" descr="rf_mountain_shadow.jpg"/>
           <p:cNvPicPr>
             <a:picLocks noChangeAspect="1"/>
           </p:cNvPicPr>
@@ -9824,7 +9859,7 @@
         </p:blipFill>
         <p:spPr>
           <a:xfrm>
-            <a:off x="2962656" y="4864608"/>
+            <a:off x="2962656" y="4791456"/>
             <a:ext cx="1901952" cy="502920"/>
           </a:xfrm>
           <a:prstGeom prst="rect">
@@ -9834,13 +9869,48 @@
       </p:pic>
       <p:sp>
         <p:nvSpPr>
-          <p:cNvPr id="65" name="TextBox 64"/>
+          <p:cNvPr id="66" name="TextBox 65"/>
           <p:cNvSpPr txBox="1"/>
           <p:nvPr/>
         </p:nvSpPr>
         <p:spPr>
           <a:xfrm>
-            <a:off x="2980944" y="5413248"/>
+            <a:off x="2980944" y="5321808"/>
+            <a:ext cx="1865376" cy="164592"/>
+          </a:xfrm>
+          <a:prstGeom prst="rect">
+            <a:avLst/>
+          </a:prstGeom>
+          <a:noFill/>
+        </p:spPr>
+        <p:txBody>
+          <a:bodyPr wrap="square" lIns="0" tIns="0" rIns="0" bIns="0">
+            <a:spAutoFit/>
+          </a:bodyPr>
+          <a:lstStyle/>
+          <a:p>
+            <a:pPr algn="l"/>
+            <a:r>
+              <a:rPr sz="650" b="1" i="0">
+                <a:solidFill>
+                  <a:srgbClr val="D71920"/>
+                </a:solidFill>
+                <a:latin typeface="JetBrains Mono"/>
+              </a:rPr>
+              <a:t>SUBSYSTEM B VOID</a:t>
+            </a:r>
+          </a:p>
+        </p:txBody>
+      </p:sp>
+      <p:sp>
+        <p:nvSpPr>
+          <p:cNvPr id="67" name="TextBox 66"/>
+          <p:cNvSpPr txBox="1"/>
+          <p:nvPr/>
+        </p:nvSpPr>
+        <p:spPr>
+          <a:xfrm>
+            <a:off x="2980944" y="5468112"/>
             <a:ext cx="1865376" cy="182880"/>
           </a:xfrm>
           <a:prstGeom prst="rect">
@@ -9862,20 +9932,20 @@
                 </a:solidFill>
                 <a:latin typeface="Plus Jakarta Sans"/>
               </a:rPr>
-              <a:t>Canopy Shadow</a:t>
-            </a:r>
-          </a:p>
-        </p:txBody>
-      </p:sp>
-      <p:sp>
-        <p:nvSpPr>
-          <p:cNvPr id="66" name="TextBox 65"/>
+              <a:t>RF Ridge Cut</a:t>
+            </a:r>
+          </a:p>
+        </p:txBody>
+      </p:sp>
+      <p:sp>
+        <p:nvSpPr>
+          <p:cNvPr id="68" name="TextBox 67"/>
           <p:cNvSpPr txBox="1"/>
           <p:nvPr/>
         </p:nvSpPr>
         <p:spPr>
           <a:xfrm>
-            <a:off x="2980944" y="5577840"/>
+            <a:off x="2980944" y="5632704"/>
             <a:ext cx="1865376" cy="164592"/>
           </a:xfrm>
           <a:prstGeom prst="rect">
@@ -9891,27 +9961,27 @@
           <a:p>
             <a:pPr algn="l"/>
             <a:r>
-              <a:rPr sz="650" b="0" i="0">
+              <a:rPr sz="620" b="0" i="0">
                 <a:solidFill>
                   <a:srgbClr val="64748B"/>
                 </a:solidFill>
                 <a:latin typeface="JetBrains Mono"/>
               </a:rPr>
-              <a:t>GNSS Multi-Path Drift</a:t>
-            </a:r>
-          </a:p>
-        </p:txBody>
-      </p:sp>
-      <p:sp>
-        <p:nvSpPr>
-          <p:cNvPr id="67" name="Rounded Rectangle 66"/>
-          <p:cNvSpPr/>
-          <p:nvPr/>
-        </p:nvSpPr>
-        <p:spPr>
-          <a:xfrm>
-            <a:off x="5084064" y="4828032"/>
-            <a:ext cx="2011680" cy="932688"/>
+              <a:t>Digital Cliff Blackout</a:t>
+            </a:r>
+          </a:p>
+        </p:txBody>
+      </p:sp>
+      <p:sp>
+        <p:nvSpPr>
+          <p:cNvPr id="69" name="Rounded Rectangle 68"/>
+          <p:cNvSpPr/>
+          <p:nvPr/>
+        </p:nvSpPr>
+        <p:spPr>
+          <a:xfrm>
+            <a:off x="5084064" y="4754880"/>
+            <a:ext cx="2011680" cy="1051560"/>
           </a:xfrm>
           <a:prstGeom prst="roundRect">
             <a:avLst/>
@@ -9949,7 +10019,7 @@
       </p:sp>
       <p:pic>
         <p:nvPicPr>
-          <p:cNvPr id="68" name="Picture 67" descr="single_link_loss.jpg"/>
+          <p:cNvPr id="70" name="Picture 69" descr="single_link_loss.jpg"/>
           <p:cNvPicPr>
             <a:picLocks noChangeAspect="1"/>
           </p:cNvPicPr>
@@ -9963,7 +10033,7 @@
         </p:blipFill>
         <p:spPr>
           <a:xfrm>
-            <a:off x="5138928" y="4864608"/>
+            <a:off x="5138928" y="4791456"/>
             <a:ext cx="1901952" cy="502920"/>
           </a:xfrm>
           <a:prstGeom prst="rect">
@@ -9973,13 +10043,48 @@
       </p:pic>
       <p:sp>
         <p:nvSpPr>
-          <p:cNvPr id="69" name="TextBox 68"/>
+          <p:cNvPr id="71" name="TextBox 70"/>
           <p:cNvSpPr txBox="1"/>
           <p:nvPr/>
         </p:nvSpPr>
         <p:spPr>
           <a:xfrm>
-            <a:off x="5157216" y="5413248"/>
+            <a:off x="5157216" y="5321808"/>
+            <a:ext cx="1865376" cy="164592"/>
+          </a:xfrm>
+          <a:prstGeom prst="rect">
+            <a:avLst/>
+          </a:prstGeom>
+          <a:noFill/>
+        </p:spPr>
+        <p:txBody>
+          <a:bodyPr wrap="square" lIns="0" tIns="0" rIns="0" bIns="0">
+            <a:spAutoFit/>
+          </a:bodyPr>
+          <a:lstStyle/>
+          <a:p>
+            <a:pPr algn="l"/>
+            <a:r>
+              <a:rPr sz="650" b="1" i="0">
+                <a:solidFill>
+                  <a:srgbClr val="D71920"/>
+                </a:solidFill>
+                <a:latin typeface="JetBrains Mono"/>
+              </a:rPr>
+              <a:t>SUBSYSTEM C/D VOID</a:t>
+            </a:r>
+          </a:p>
+        </p:txBody>
+      </p:sp>
+      <p:sp>
+        <p:nvSpPr>
+          <p:cNvPr id="72" name="TextBox 71"/>
+          <p:cNvSpPr txBox="1"/>
+          <p:nvPr/>
+        </p:nvSpPr>
+        <p:spPr>
+          <a:xfrm>
+            <a:off x="5157216" y="5468112"/>
             <a:ext cx="1865376" cy="182880"/>
           </a:xfrm>
           <a:prstGeom prst="rect">
@@ -10001,20 +10106,20 @@
                 </a:solidFill>
                 <a:latin typeface="Plus Jakarta Sans"/>
               </a:rPr>
-              <a:t>Central Link Loss</a:t>
-            </a:r>
-          </a:p>
-        </p:txBody>
-      </p:sp>
-      <p:sp>
-        <p:nvSpPr>
-          <p:cNvPr id="70" name="TextBox 69"/>
+              <a:t>Central Link Abort</a:t>
+            </a:r>
+          </a:p>
+        </p:txBody>
+      </p:sp>
+      <p:sp>
+        <p:nvSpPr>
+          <p:cNvPr id="73" name="TextBox 72"/>
           <p:cNvSpPr txBox="1"/>
           <p:nvPr/>
         </p:nvSpPr>
         <p:spPr>
           <a:xfrm>
-            <a:off x="5157216" y="5577840"/>
+            <a:off x="5157216" y="5632704"/>
             <a:ext cx="1865376" cy="164592"/>
           </a:xfrm>
           <a:prstGeom prst="rect">
@@ -10030,20 +10135,20 @@
           <a:p>
             <a:pPr algn="l"/>
             <a:r>
-              <a:rPr sz="650" b="0" i="0">
+              <a:rPr sz="620" b="0" i="0">
                 <a:solidFill>
                   <a:srgbClr val="64748B"/>
                 </a:solidFill>
                 <a:latin typeface="JetBrains Mono"/>
               </a:rPr>
-              <a:t>Single Point Abort</a:t>
-            </a:r>
-          </a:p>
-        </p:txBody>
-      </p:sp>
-      <p:sp>
-        <p:nvSpPr>
-          <p:cNvPr id="71" name="TextBox 70"/>
+              <a:t>Single Point Loss</a:t>
+            </a:r>
+          </a:p>
+        </p:txBody>
+      </p:sp>
+      <p:sp>
+        <p:nvSpPr>
+          <p:cNvPr id="74" name="TextBox 73"/>
           <p:cNvSpPr txBox="1"/>
           <p:nvPr/>
         </p:nvSpPr>
@@ -10078,7 +10183,7 @@
       </p:sp>
       <p:sp>
         <p:nvSpPr>
-          <p:cNvPr id="72" name="TextBox 71"/>
+          <p:cNvPr id="75" name="TextBox 74"/>
           <p:cNvSpPr txBox="1"/>
           <p:nvPr/>
         </p:nvSpPr>
@@ -10113,7 +10218,7 @@
       </p:sp>
       <p:sp>
         <p:nvSpPr>
-          <p:cNvPr id="73" name="Rounded Rectangle 72"/>
+          <p:cNvPr id="76" name="Rounded Rectangle 75"/>
           <p:cNvSpPr/>
           <p:nvPr/>
         </p:nvSpPr>
@@ -10156,7 +10261,7 @@
       </p:sp>
       <p:sp>
         <p:nvSpPr>
-          <p:cNvPr id="74" name="Rounded Rectangle 73"/>
+          <p:cNvPr id="77" name="Rounded Rectangle 76"/>
           <p:cNvSpPr/>
           <p:nvPr/>
         </p:nvSpPr>
@@ -10199,7 +10304,7 @@
       </p:sp>
       <p:sp>
         <p:nvSpPr>
-          <p:cNvPr id="75" name="Rounded Rectangle 74"/>
+          <p:cNvPr id="78" name="Rounded Rectangle 77"/>
           <p:cNvSpPr/>
           <p:nvPr/>
         </p:nvSpPr>
@@ -10242,7 +10347,7 @@
       </p:sp>
       <p:pic>
         <p:nvPicPr>
-          <p:cNvPr id="76" name="Picture 75" descr="wayanad_rescue.jpg"/>
+          <p:cNvPr id="79" name="Picture 78" descr="wayanad_rescue.jpg"/>
           <p:cNvPicPr>
             <a:picLocks noChangeAspect="1"/>
           </p:cNvPicPr>
@@ -10266,7 +10371,7 @@
       </p:pic>
       <p:sp>
         <p:nvSpPr>
-          <p:cNvPr id="77" name="Rectangle 76"/>
+          <p:cNvPr id="80" name="Rectangle 79"/>
           <p:cNvSpPr/>
           <p:nvPr/>
         </p:nvSpPr>
@@ -10309,7 +10414,7 @@
       </p:sp>
       <p:sp>
         <p:nvSpPr>
-          <p:cNvPr id="78" name="Oval 77"/>
+          <p:cNvPr id="81" name="Oval 80"/>
           <p:cNvSpPr/>
           <p:nvPr/>
         </p:nvSpPr>
@@ -10352,7 +10457,7 @@
       </p:sp>
       <p:sp>
         <p:nvSpPr>
-          <p:cNvPr id="79" name="Rounded Rectangle 78"/>
+          <p:cNvPr id="82" name="Rounded Rectangle 81"/>
           <p:cNvSpPr/>
           <p:nvPr/>
         </p:nvSpPr>
@@ -10395,7 +10500,7 @@
       </p:sp>
       <p:sp>
         <p:nvSpPr>
-          <p:cNvPr id="80" name="TextBox 79"/>
+          <p:cNvPr id="83" name="TextBox 82"/>
           <p:cNvSpPr txBox="1"/>
           <p:nvPr/>
         </p:nvSpPr>
@@ -10430,7 +10535,7 @@
       </p:sp>
       <p:sp>
         <p:nvSpPr>
-          <p:cNvPr id="81" name="TextBox 80"/>
+          <p:cNvPr id="84" name="TextBox 83"/>
           <p:cNvSpPr txBox="1"/>
           <p:nvPr/>
         </p:nvSpPr>
@@ -10465,7 +10570,7 @@
       </p:sp>
       <p:sp>
         <p:nvSpPr>
-          <p:cNvPr id="82" name="TextBox 81"/>
+          <p:cNvPr id="85" name="TextBox 84"/>
           <p:cNvSpPr txBox="1"/>
           <p:nvPr/>
         </p:nvSpPr>
@@ -10500,7 +10605,7 @@
       </p:sp>
       <p:sp>
         <p:nvSpPr>
-          <p:cNvPr id="83" name="TextBox 82"/>
+          <p:cNvPr id="86" name="TextBox 85"/>
           <p:cNvSpPr txBox="1"/>
           <p:nvPr/>
         </p:nvSpPr>
@@ -10535,7 +10640,7 @@
       </p:sp>
       <p:sp>
         <p:nvSpPr>
-          <p:cNvPr id="84" name="TextBox 83"/>
+          <p:cNvPr id="87" name="TextBox 86"/>
           <p:cNvSpPr txBox="1"/>
           <p:nvPr/>
         </p:nvSpPr>
@@ -10570,7 +10675,7 @@
       </p:sp>
       <p:sp>
         <p:nvSpPr>
-          <p:cNvPr id="85" name="Rounded Rectangle 84"/>
+          <p:cNvPr id="88" name="Rounded Rectangle 87"/>
           <p:cNvSpPr/>
           <p:nvPr/>
         </p:nvSpPr>
@@ -10613,7 +10718,7 @@
       </p:sp>
       <p:sp>
         <p:nvSpPr>
-          <p:cNvPr id="86" name="Rounded Rectangle 85"/>
+          <p:cNvPr id="89" name="Rounded Rectangle 88"/>
           <p:cNvSpPr/>
           <p:nvPr/>
         </p:nvSpPr>
@@ -10656,7 +10761,7 @@
       </p:sp>
       <p:sp>
         <p:nvSpPr>
-          <p:cNvPr id="87" name="Rounded Rectangle 86"/>
+          <p:cNvPr id="90" name="Rounded Rectangle 89"/>
           <p:cNvSpPr/>
           <p:nvPr/>
         </p:nvSpPr>
@@ -10699,7 +10804,7 @@
       </p:sp>
       <p:sp>
         <p:nvSpPr>
-          <p:cNvPr id="88" name="TextBox 87"/>
+          <p:cNvPr id="91" name="TextBox 90"/>
           <p:cNvSpPr txBox="1"/>
           <p:nvPr/>
         </p:nvSpPr>
@@ -10734,7 +10839,7 @@
       </p:sp>
       <p:sp>
         <p:nvSpPr>
-          <p:cNvPr id="89" name="Rectangle 88"/>
+          <p:cNvPr id="92" name="Rectangle 91"/>
           <p:cNvSpPr/>
           <p:nvPr/>
         </p:nvSpPr>
@@ -10777,7 +10882,7 @@
       </p:sp>
       <p:sp>
         <p:nvSpPr>
-          <p:cNvPr id="90" name="TextBox 89"/>
+          <p:cNvPr id="93" name="TextBox 92"/>
           <p:cNvSpPr txBox="1"/>
           <p:nvPr/>
         </p:nvSpPr>
@@ -10812,7 +10917,7 @@
       </p:sp>
       <p:sp>
         <p:nvSpPr>
-          <p:cNvPr id="91" name="TextBox 90"/>
+          <p:cNvPr id="94" name="TextBox 93"/>
           <p:cNvSpPr txBox="1"/>
           <p:nvPr/>
         </p:nvSpPr>
@@ -12635,7 +12740,7 @@
         <p:spPr>
           <a:xfrm>
             <a:off x="960120" y="594360"/>
-            <a:ext cx="4114800" cy="320040"/>
+            <a:ext cx="5029200" cy="320040"/>
           </a:xfrm>
           <a:prstGeom prst="rect">
             <a:avLst/>
@@ -12650,13 +12755,13 @@
           <a:p>
             <a:pPr algn="l"/>
             <a:r>
-              <a:rPr sz="1300" b="1" i="0">
+              <a:rPr sz="1200" b="1" i="0">
                 <a:solidFill>
                   <a:srgbClr val="0A1628"/>
                 </a:solidFill>
                 <a:latin typeface="JetBrains Mono"/>
               </a:rPr>
-              <a:t>THE SOLUTION / BENCHMARK</a:t>
+              <a:t>THE SOLUTION — SUBSYSTEM MOATS &amp; BENCHMARK</a:t>
             </a:r>
           </a:p>
         </p:txBody>
@@ -12905,7 +13010,7 @@
         </p:nvSpPr>
         <p:spPr>
           <a:xfrm>
-            <a:off x="749808" y="2752344"/>
+            <a:off x="749808" y="2734056"/>
             <a:ext cx="82296" cy="82296"/>
           </a:xfrm>
           <a:prstGeom prst="ellipse">
@@ -12948,7 +13053,7 @@
         </p:nvSpPr>
         <p:spPr>
           <a:xfrm>
-            <a:off x="932688" y="2697480"/>
+            <a:off x="932688" y="2679192"/>
             <a:ext cx="5669280" cy="320040"/>
           </a:xfrm>
           <a:prstGeom prst="rect">
@@ -12983,7 +13088,7 @@
         </p:nvSpPr>
         <p:spPr>
           <a:xfrm>
-            <a:off x="749808" y="3118104"/>
+            <a:off x="749808" y="3081528"/>
             <a:ext cx="82296" cy="82296"/>
           </a:xfrm>
           <a:prstGeom prst="ellipse">
@@ -13026,7 +13131,7 @@
         </p:nvSpPr>
         <p:spPr>
           <a:xfrm>
-            <a:off x="932688" y="3063240"/>
+            <a:off x="932688" y="3026664"/>
             <a:ext cx="5669280" cy="320040"/>
           </a:xfrm>
           <a:prstGeom prst="rect">
@@ -13061,7 +13166,7 @@
         </p:nvSpPr>
         <p:spPr>
           <a:xfrm>
-            <a:off x="749808" y="3483864"/>
+            <a:off x="749808" y="3429000"/>
             <a:ext cx="82296" cy="82296"/>
           </a:xfrm>
           <a:prstGeom prst="ellipse">
@@ -13104,7 +13209,7 @@
         </p:nvSpPr>
         <p:spPr>
           <a:xfrm>
-            <a:off x="932688" y="3429000"/>
+            <a:off x="932688" y="3374136"/>
             <a:ext cx="5669280" cy="320040"/>
           </a:xfrm>
           <a:prstGeom prst="rect">
@@ -13139,7 +13244,7 @@
         </p:nvSpPr>
         <p:spPr>
           <a:xfrm>
-            <a:off x="749808" y="3849624"/>
+            <a:off x="749808" y="3776472"/>
             <a:ext cx="82296" cy="82296"/>
           </a:xfrm>
           <a:prstGeom prst="ellipse">
@@ -13182,7 +13287,7 @@
         </p:nvSpPr>
         <p:spPr>
           <a:xfrm>
-            <a:off x="932688" y="3794760"/>
+            <a:off x="932688" y="3721608"/>
             <a:ext cx="5669280" cy="320040"/>
           </a:xfrm>
           <a:prstGeom prst="rect">
@@ -13217,7 +13322,7 @@
         </p:nvSpPr>
         <p:spPr>
           <a:xfrm>
-            <a:off x="749808" y="4215384"/>
+            <a:off x="749808" y="4123944"/>
             <a:ext cx="82296" cy="82296"/>
           </a:xfrm>
           <a:prstGeom prst="ellipse">
@@ -13260,7 +13365,7 @@
         </p:nvSpPr>
         <p:spPr>
           <a:xfrm>
-            <a:off x="932688" y="4160520"/>
+            <a:off x="932688" y="4069080"/>
             <a:ext cx="5669280" cy="320040"/>
           </a:xfrm>
           <a:prstGeom prst="rect">
@@ -13295,7 +13400,7 @@
         </p:nvSpPr>
         <p:spPr>
           <a:xfrm>
-            <a:off x="731520" y="4663440"/>
+            <a:off x="731520" y="4572000"/>
             <a:ext cx="4572000" cy="182880"/>
           </a:xfrm>
           <a:prstGeom prst="rect">
@@ -13317,7 +13422,7 @@
                 </a:solidFill>
                 <a:latin typeface="JetBrains Mono"/>
               </a:rPr>
-              <a:t>MARKET VALIDATION &amp; ADOPTION</a:t>
+              <a:t>PROJECT SUTRA SUBSYSTEM SOLUTIONAL MOATS</a:t>
             </a:r>
           </a:p>
         </p:txBody>
@@ -13330,14 +13435,14 @@
         </p:nvSpPr>
         <p:spPr>
           <a:xfrm>
-            <a:off x="731520" y="4892040"/>
-            <a:ext cx="1353312" cy="777240"/>
+            <a:off x="731520" y="4800600"/>
+            <a:ext cx="1828800" cy="868680"/>
           </a:xfrm>
           <a:prstGeom prst="roundRect">
             <a:avLst/>
           </a:prstGeom>
           <a:solidFill>
-            <a:srgbClr val="F8FAFC"/>
+            <a:srgbClr val="DCFCE7"/>
           </a:solidFill>
           <a:ln w="12700">
             <a:solidFill>
@@ -13375,8 +13480,8 @@
         </p:nvSpPr>
         <p:spPr>
           <a:xfrm>
-            <a:off x="804672" y="4956048"/>
-            <a:ext cx="1207008" cy="274320"/>
+            <a:off x="804672" y="4864608"/>
+            <a:ext cx="1682496" cy="164592"/>
           </a:xfrm>
           <a:prstGeom prst="rect">
             <a:avLst/>
@@ -13391,27 +13496,62 @@
           <a:p>
             <a:pPr algn="l"/>
             <a:r>
-              <a:rPr sz="1300" b="1" i="0">
+              <a:rPr sz="650" b="1" i="0">
+                <a:solidFill>
+                  <a:srgbClr val="047857"/>
+                </a:solidFill>
+                <a:latin typeface="JetBrains Mono"/>
+              </a:rPr>
+              <a:t>SUBSYSTEM A MOAT</a:t>
+            </a:r>
+          </a:p>
+        </p:txBody>
+      </p:sp>
+      <p:sp>
+        <p:nvSpPr>
+          <p:cNvPr id="63" name="TextBox 62"/>
+          <p:cNvSpPr txBox="1"/>
+          <p:nvPr/>
+        </p:nvSpPr>
+        <p:spPr>
+          <a:xfrm>
+            <a:off x="804672" y="5029200"/>
+            <a:ext cx="1682496" cy="228600"/>
+          </a:xfrm>
+          <a:prstGeom prst="rect">
+            <a:avLst/>
+          </a:prstGeom>
+          <a:noFill/>
+        </p:spPr>
+        <p:txBody>
+          <a:bodyPr wrap="square" lIns="0" tIns="0" rIns="0" bIns="0">
+            <a:spAutoFit/>
+          </a:bodyPr>
+          <a:lstStyle/>
+          <a:p>
+            <a:pPr algn="l"/>
+            <a:r>
+              <a:rPr sz="900" b="1" i="0">
                 <a:solidFill>
                   <a:srgbClr val="000000"/>
                 </a:solidFill>
                 <a:latin typeface="Plus Jakarta Sans"/>
               </a:rPr>
-              <a:t>$8.94B</a:t>
-            </a:r>
-          </a:p>
-        </p:txBody>
-      </p:sp>
-      <p:sp>
-        <p:nvSpPr>
-          <p:cNvPr id="63" name="TextBox 62"/>
+              <a:t>PX4 + VIO EKF2</a:t>
+            </a:r>
+          </a:p>
+        </p:txBody>
+      </p:sp>
+      <p:sp>
+        <p:nvSpPr>
+          <p:cNvPr id="64" name="TextBox 63"/>
           <p:cNvSpPr txBox="1"/>
           <p:nvPr/>
         </p:nvSpPr>
         <p:spPr>
           <a:xfrm>
-            <a:off x="804672" y="5230368"/>
-            <a:ext cx="1207008" cy="365760"/>
+            <a:off x="804672" y="5257800"/>
+            <a:ext cx="1682496" cy="320040"/>
           </a:xfrm>
           <a:prstGeom prst="rect">
             <a:avLst/>
@@ -13428,31 +13568,31 @@
             <a:r>
               <a:rPr sz="680" b="0" i="0">
                 <a:solidFill>
-                  <a:srgbClr val="64748B"/>
+                  <a:srgbClr val="475569"/>
                 </a:solidFill>
                 <a:latin typeface="JetBrains Mono"/>
               </a:rPr>
-              <a:t>By 2033 (18.4% CAGR)</a:t>
-            </a:r>
-          </a:p>
-        </p:txBody>
-      </p:sp>
-      <p:sp>
-        <p:nvSpPr>
-          <p:cNvPr id="64" name="Rounded Rectangle 63"/>
-          <p:cNvSpPr/>
-          <p:nvPr/>
-        </p:nvSpPr>
-        <p:spPr>
-          <a:xfrm>
-            <a:off x="2194560" y="4892040"/>
-            <a:ext cx="1353312" cy="777240"/>
+              <a:t>50Hz Offboard GNC</a:t>
+            </a:r>
+          </a:p>
+        </p:txBody>
+      </p:sp>
+      <p:sp>
+        <p:nvSpPr>
+          <p:cNvPr id="65" name="Rounded Rectangle 64"/>
+          <p:cNvSpPr/>
+          <p:nvPr/>
+        </p:nvSpPr>
+        <p:spPr>
+          <a:xfrm>
+            <a:off x="2697480" y="4800600"/>
+            <a:ext cx="1828800" cy="868680"/>
           </a:xfrm>
           <a:prstGeom prst="roundRect">
             <a:avLst/>
           </a:prstGeom>
           <a:solidFill>
-            <a:srgbClr val="F8FAFC"/>
+            <a:srgbClr val="DCFCE7"/>
           </a:solidFill>
           <a:ln w="12700">
             <a:solidFill>
@@ -13484,14 +13624,14 @@
       </p:sp>
       <p:sp>
         <p:nvSpPr>
-          <p:cNvPr id="65" name="TextBox 64"/>
+          <p:cNvPr id="66" name="TextBox 65"/>
           <p:cNvSpPr txBox="1"/>
           <p:nvPr/>
         </p:nvSpPr>
         <p:spPr>
           <a:xfrm>
-            <a:off x="2267712" y="4956048"/>
-            <a:ext cx="1207008" cy="274320"/>
+            <a:off x="2770632" y="4864608"/>
+            <a:ext cx="1682496" cy="164592"/>
           </a:xfrm>
           <a:prstGeom prst="rect">
             <a:avLst/>
@@ -13506,27 +13646,62 @@
           <a:p>
             <a:pPr algn="l"/>
             <a:r>
-              <a:rPr sz="1300" b="1" i="0">
+              <a:rPr sz="650" b="1" i="0">
+                <a:solidFill>
+                  <a:srgbClr val="047857"/>
+                </a:solidFill>
+                <a:latin typeface="JetBrains Mono"/>
+              </a:rPr>
+              <a:t>SUBSYSTEM B MOAT</a:t>
+            </a:r>
+          </a:p>
+        </p:txBody>
+      </p:sp>
+      <p:sp>
+        <p:nvSpPr>
+          <p:cNvPr id="67" name="TextBox 66"/>
+          <p:cNvSpPr txBox="1"/>
+          <p:nvPr/>
+        </p:nvSpPr>
+        <p:spPr>
+          <a:xfrm>
+            <a:off x="2770632" y="5029200"/>
+            <a:ext cx="1682496" cy="228600"/>
+          </a:xfrm>
+          <a:prstGeom prst="rect">
+            <a:avLst/>
+          </a:prstGeom>
+          <a:noFill/>
+        </p:spPr>
+        <p:txBody>
+          <a:bodyPr wrap="square" lIns="0" tIns="0" rIns="0" bIns="0">
+            <a:spAutoFit/>
+          </a:bodyPr>
+          <a:lstStyle/>
+          <a:p>
+            <a:pPr algn="l"/>
+            <a:r>
+              <a:rPr sz="900" b="1" i="0">
                 <a:solidFill>
                   <a:srgbClr val="000000"/>
                 </a:solidFill>
                 <a:latin typeface="Plus Jakarta Sans"/>
               </a:rPr>
-              <a:t>+412%</a:t>
-            </a:r>
-          </a:p>
-        </p:txBody>
-      </p:sp>
-      <p:sp>
-        <p:nvSpPr>
-          <p:cNvPr id="66" name="TextBox 65"/>
+              <a:t>Deep JSCC Video</a:t>
+            </a:r>
+          </a:p>
+        </p:txBody>
+      </p:sp>
+      <p:sp>
+        <p:nvSpPr>
+          <p:cNvPr id="68" name="TextBox 67"/>
           <p:cNvSpPr txBox="1"/>
           <p:nvPr/>
         </p:nvSpPr>
         <p:spPr>
           <a:xfrm>
-            <a:off x="2267712" y="5230368"/>
-            <a:ext cx="1207008" cy="365760"/>
+            <a:off x="2770632" y="5257800"/>
+            <a:ext cx="1682496" cy="320040"/>
           </a:xfrm>
           <a:prstGeom prst="rect">
             <a:avLst/>
@@ -13543,31 +13718,31 @@
             <a:r>
               <a:rPr sz="680" b="0" i="0">
                 <a:solidFill>
-                  <a:srgbClr val="64748B"/>
+                  <a:srgbClr val="475569"/>
                 </a:solidFill>
                 <a:latin typeface="JetBrains Mono"/>
               </a:rPr>
-              <a:t>Disaster Surge (20 Yrs)</a:t>
-            </a:r>
-          </a:p>
-        </p:txBody>
-      </p:sp>
-      <p:sp>
-        <p:nvSpPr>
-          <p:cNvPr id="67" name="Rounded Rectangle 66"/>
-          <p:cNvSpPr/>
-          <p:nvPr/>
-        </p:nvSpPr>
-        <p:spPr>
-          <a:xfrm>
-            <a:off x="3657600" y="4892040"/>
-            <a:ext cx="1353312" cy="777240"/>
+              <a:t>Zero-Cliff to -5dB</a:t>
+            </a:r>
+          </a:p>
+        </p:txBody>
+      </p:sp>
+      <p:sp>
+        <p:nvSpPr>
+          <p:cNvPr id="69" name="Rounded Rectangle 68"/>
+          <p:cNvSpPr/>
+          <p:nvPr/>
+        </p:nvSpPr>
+        <p:spPr>
+          <a:xfrm>
+            <a:off x="4663440" y="4800600"/>
+            <a:ext cx="1828800" cy="868680"/>
           </a:xfrm>
           <a:prstGeom prst="roundRect">
             <a:avLst/>
           </a:prstGeom>
           <a:solidFill>
-            <a:srgbClr val="F8FAFC"/>
+            <a:srgbClr val="DCFCE7"/>
           </a:solidFill>
           <a:ln w="12700">
             <a:solidFill>
@@ -13599,14 +13774,14 @@
       </p:sp>
       <p:sp>
         <p:nvSpPr>
-          <p:cNvPr id="68" name="TextBox 67"/>
+          <p:cNvPr id="70" name="TextBox 69"/>
           <p:cNvSpPr txBox="1"/>
           <p:nvPr/>
         </p:nvSpPr>
         <p:spPr>
           <a:xfrm>
-            <a:off x="3730752" y="4956048"/>
-            <a:ext cx="1207008" cy="274320"/>
+            <a:off x="4736592" y="4864608"/>
+            <a:ext cx="1682496" cy="164592"/>
           </a:xfrm>
           <a:prstGeom prst="rect">
             <a:avLst/>
@@ -13621,27 +13796,62 @@
           <a:p>
             <a:pPr algn="l"/>
             <a:r>
-              <a:rPr sz="1300" b="1" i="0">
+              <a:rPr sz="650" b="1" i="0">
+                <a:solidFill>
+                  <a:srgbClr val="047857"/>
+                </a:solidFill>
+                <a:latin typeface="JetBrains Mono"/>
+              </a:rPr>
+              <a:t>SUBSYSTEM C/D MOAT</a:t>
+            </a:r>
+          </a:p>
+        </p:txBody>
+      </p:sp>
+      <p:sp>
+        <p:nvSpPr>
+          <p:cNvPr id="71" name="TextBox 70"/>
+          <p:cNvSpPr txBox="1"/>
+          <p:nvPr/>
+        </p:nvSpPr>
+        <p:spPr>
+          <a:xfrm>
+            <a:off x="4736592" y="5029200"/>
+            <a:ext cx="1682496" cy="228600"/>
+          </a:xfrm>
+          <a:prstGeom prst="rect">
+            <a:avLst/>
+          </a:prstGeom>
+          <a:noFill/>
+        </p:spPr>
+        <p:txBody>
+          <a:bodyPr wrap="square" lIns="0" tIns="0" rIns="0" bIns="0">
+            <a:spAutoFit/>
+          </a:bodyPr>
+          <a:lstStyle/>
+          <a:p>
+            <a:pPr algn="l"/>
+            <a:r>
+              <a:rPr sz="900" b="1" i="0">
                 <a:solidFill>
                   <a:srgbClr val="000000"/>
                 </a:solidFill>
                 <a:latin typeface="Plus Jakarta Sans"/>
               </a:rPr>
-              <a:t>37 Nations</a:t>
-            </a:r>
-          </a:p>
-        </p:txBody>
-      </p:sp>
-      <p:sp>
-        <p:nvSpPr>
-          <p:cNvPr id="69" name="TextBox 68"/>
+              <a:t>3D DEM Raycast</a:t>
+            </a:r>
+          </a:p>
+        </p:txBody>
+      </p:sp>
+      <p:sp>
+        <p:nvSpPr>
+          <p:cNvPr id="72" name="TextBox 71"/>
           <p:cNvSpPr txBox="1"/>
           <p:nvPr/>
         </p:nvSpPr>
         <p:spPr>
           <a:xfrm>
-            <a:off x="3730752" y="5230368"/>
-            <a:ext cx="1207008" cy="365760"/>
+            <a:off x="4736592" y="5257800"/>
+            <a:ext cx="1682496" cy="320040"/>
           </a:xfrm>
           <a:prstGeom prst="rect">
             <a:avLst/>
@@ -13658,126 +13868,11 @@
             <a:r>
               <a:rPr sz="680" b="0" i="0">
                 <a:solidFill>
-                  <a:srgbClr val="64748B"/>
+                  <a:srgbClr val="475569"/>
                 </a:solidFill>
                 <a:latin typeface="JetBrains Mono"/>
               </a:rPr>
-              <a:t>Mandated SAR Drones</a:t>
-            </a:r>
-          </a:p>
-        </p:txBody>
-      </p:sp>
-      <p:sp>
-        <p:nvSpPr>
-          <p:cNvPr id="70" name="Rounded Rectangle 69"/>
-          <p:cNvSpPr/>
-          <p:nvPr/>
-        </p:nvSpPr>
-        <p:spPr>
-          <a:xfrm>
-            <a:off x="5120640" y="4892040"/>
-            <a:ext cx="1353312" cy="777240"/>
-          </a:xfrm>
-          <a:prstGeom prst="roundRect">
-            <a:avLst/>
-          </a:prstGeom>
-          <a:solidFill>
-            <a:srgbClr val="F8FAFC"/>
-          </a:solidFill>
-          <a:ln w="12700">
-            <a:solidFill>
-              <a:srgbClr val="E2E8F0"/>
-            </a:solidFill>
-          </a:ln>
-        </p:spPr>
-        <p:style>
-          <a:lnRef idx="1">
-            <a:schemeClr val="accent1"/>
-          </a:lnRef>
-          <a:fillRef idx="3">
-            <a:schemeClr val="accent1"/>
-          </a:fillRef>
-          <a:effectRef idx="2">
-            <a:schemeClr val="accent1"/>
-          </a:effectRef>
-          <a:fontRef idx="minor">
-            <a:schemeClr val="lt1"/>
-          </a:fontRef>
-        </p:style>
-        <p:txBody>
-          <a:bodyPr rtlCol="0" anchor="ctr"/>
-          <a:lstStyle/>
-          <a:p>
-            <a:pPr algn="ctr"/>
-          </a:p>
-        </p:txBody>
-      </p:sp>
-      <p:sp>
-        <p:nvSpPr>
-          <p:cNvPr id="71" name="TextBox 70"/>
-          <p:cNvSpPr txBox="1"/>
-          <p:nvPr/>
-        </p:nvSpPr>
-        <p:spPr>
-          <a:xfrm>
-            <a:off x="5193792" y="4956048"/>
-            <a:ext cx="1207008" cy="274320"/>
-          </a:xfrm>
-          <a:prstGeom prst="rect">
-            <a:avLst/>
-          </a:prstGeom>
-          <a:noFill/>
-        </p:spPr>
-        <p:txBody>
-          <a:bodyPr wrap="square" lIns="0" tIns="0" rIns="0" bIns="0">
-            <a:spAutoFit/>
-          </a:bodyPr>
-          <a:lstStyle/>
-          <a:p>
-            <a:pPr algn="l"/>
-            <a:r>
-              <a:rPr sz="1300" b="1" i="0">
-                <a:solidFill>
-                  <a:srgbClr val="000000"/>
-                </a:solidFill>
-                <a:latin typeface="Plus Jakarta Sans"/>
-              </a:rPr>
-              <a:t>$180M</a:t>
-            </a:r>
-          </a:p>
-        </p:txBody>
-      </p:sp>
-      <p:sp>
-        <p:nvSpPr>
-          <p:cNvPr id="72" name="TextBox 71"/>
-          <p:cNvSpPr txBox="1"/>
-          <p:nvPr/>
-        </p:nvSpPr>
-        <p:spPr>
-          <a:xfrm>
-            <a:off x="5193792" y="5230368"/>
-            <a:ext cx="1207008" cy="365760"/>
-          </a:xfrm>
-          <a:prstGeom prst="rect">
-            <a:avLst/>
-          </a:prstGeom>
-          <a:noFill/>
-        </p:spPr>
-        <p:txBody>
-          <a:bodyPr wrap="square" lIns="0" tIns="0" rIns="0" bIns="0">
-            <a:spAutoFit/>
-          </a:bodyPr>
-          <a:lstStyle/>
-          <a:p>
-            <a:pPr algn="l"/>
-            <a:r>
-              <a:rPr sz="680" b="0" i="0">
-                <a:solidFill>
-                  <a:srgbClr val="64748B"/>
-                </a:solidFill>
-                <a:latin typeface="JetBrains Mono"/>
-              </a:rPr>
-              <a:t>FEMA 2025 Budget</a:t>
+              <a:t>3.59cm Geolocation</a:t>
             </a:r>
           </a:p>
         </p:txBody>

</xml_diff>

<commit_message>
style(slides): remove right side panel on Slide 3 and expand Subsystem Moats to clean full-width layout
</commit_message>
<xml_diff>
--- a/sutra_pitch_deck.pptx
+++ b/sutra_pitch_deck.pptx
@@ -12761,7 +12761,7 @@
                 </a:solidFill>
                 <a:latin typeface="JetBrains Mono"/>
               </a:rPr>
-              <a:t>THE SOLUTION — SUBSYSTEM MOATS &amp; BENCHMARK</a:t>
+              <a:t>THE SOLUTION — SUBSYSTEM MOATS</a:t>
             </a:r>
           </a:p>
         </p:txBody>
@@ -12898,7 +12898,7 @@
         <p:spPr>
           <a:xfrm>
             <a:off x="731520" y="1188720"/>
-            <a:ext cx="5943600" cy="1097280"/>
+            <a:ext cx="10515600" cy="1005840"/>
           </a:xfrm>
           <a:prstGeom prst="rect">
             <a:avLst/>
@@ -12913,7 +12913,7 @@
           <a:p>
             <a:pPr algn="l"/>
             <a:r>
-              <a:rPr sz="2800" b="1" i="0">
+              <a:rPr sz="3200" b="1" i="0">
                 <a:solidFill>
                   <a:srgbClr val="000000"/>
                 </a:solidFill>
@@ -12932,8 +12932,8 @@
         </p:nvSpPr>
         <p:spPr>
           <a:xfrm>
-            <a:off x="749808" y="2386584"/>
-            <a:ext cx="82296" cy="82296"/>
+            <a:off x="749808" y="2295144"/>
+            <a:ext cx="91440" cy="91440"/>
           </a:xfrm>
           <a:prstGeom prst="ellipse">
             <a:avLst/>
@@ -12975,8 +12975,8 @@
         </p:nvSpPr>
         <p:spPr>
           <a:xfrm>
-            <a:off x="932688" y="2331720"/>
-            <a:ext cx="5669280" cy="320040"/>
+            <a:off x="960120" y="2240280"/>
+            <a:ext cx="4754880" cy="320040"/>
           </a:xfrm>
           <a:prstGeom prst="rect">
             <a:avLst/>
@@ -12991,7 +12991,7 @@
           <a:p>
             <a:pPr algn="l"/>
             <a:r>
-              <a:rPr sz="1350" b="0" i="0">
+              <a:rPr sz="1500" b="0" i="0">
                 <a:solidFill>
                   <a:srgbClr val="374151"/>
                 </a:solidFill>
@@ -13010,8 +13010,8 @@
         </p:nvSpPr>
         <p:spPr>
           <a:xfrm>
-            <a:off x="749808" y="2734056"/>
-            <a:ext cx="82296" cy="82296"/>
+            <a:off x="749808" y="2679192"/>
+            <a:ext cx="91440" cy="91440"/>
           </a:xfrm>
           <a:prstGeom prst="ellipse">
             <a:avLst/>
@@ -13053,8 +13053,8 @@
         </p:nvSpPr>
         <p:spPr>
           <a:xfrm>
-            <a:off x="932688" y="2679192"/>
-            <a:ext cx="5669280" cy="320040"/>
+            <a:off x="960120" y="2624328"/>
+            <a:ext cx="4754880" cy="320040"/>
           </a:xfrm>
           <a:prstGeom prst="rect">
             <a:avLst/>
@@ -13069,7 +13069,163 @@
           <a:p>
             <a:pPr algn="l"/>
             <a:r>
-              <a:rPr sz="1350" b="0" i="0">
+              <a:rPr sz="1500" b="0" i="0">
+                <a:solidFill>
+                  <a:srgbClr val="374151"/>
+                </a:solidFill>
+                <a:latin typeface="Inter"/>
+              </a:rPr>
+              <a:t>Mesh networking works in GPS-denied zones</a:t>
+            </a:r>
+          </a:p>
+        </p:txBody>
+      </p:sp>
+      <p:sp>
+        <p:nvSpPr>
+          <p:cNvPr id="52" name="Oval 51"/>
+          <p:cNvSpPr/>
+          <p:nvPr/>
+        </p:nvSpPr>
+        <p:spPr>
+          <a:xfrm>
+            <a:off x="749808" y="3063240"/>
+            <a:ext cx="91440" cy="91440"/>
+          </a:xfrm>
+          <a:prstGeom prst="ellipse">
+            <a:avLst/>
+          </a:prstGeom>
+          <a:solidFill>
+            <a:srgbClr val="047857"/>
+          </a:solidFill>
+          <a:ln>
+            <a:noFill/>
+          </a:ln>
+        </p:spPr>
+        <p:style>
+          <a:lnRef idx="1">
+            <a:schemeClr val="accent1"/>
+          </a:lnRef>
+          <a:fillRef idx="3">
+            <a:schemeClr val="accent1"/>
+          </a:fillRef>
+          <a:effectRef idx="2">
+            <a:schemeClr val="accent1"/>
+          </a:effectRef>
+          <a:fontRef idx="minor">
+            <a:schemeClr val="lt1"/>
+          </a:fontRef>
+        </p:style>
+        <p:txBody>
+          <a:bodyPr rtlCol="0" anchor="ctr"/>
+          <a:lstStyle/>
+          <a:p>
+            <a:pPr algn="ctr"/>
+          </a:p>
+        </p:txBody>
+      </p:sp>
+      <p:sp>
+        <p:nvSpPr>
+          <p:cNvPr id="53" name="TextBox 52"/>
+          <p:cNvSpPr txBox="1"/>
+          <p:nvPr/>
+        </p:nvSpPr>
+        <p:spPr>
+          <a:xfrm>
+            <a:off x="960120" y="3008376"/>
+            <a:ext cx="4754880" cy="320040"/>
+          </a:xfrm>
+          <a:prstGeom prst="rect">
+            <a:avLst/>
+          </a:prstGeom>
+          <a:noFill/>
+        </p:spPr>
+        <p:txBody>
+          <a:bodyPr wrap="square" lIns="0" tIns="0" rIns="0" bIns="0">
+            <a:spAutoFit/>
+          </a:bodyPr>
+          <a:lstStyle/>
+          <a:p>
+            <a:pPr algn="l"/>
+            <a:r>
+              <a:rPr sz="1500" b="0" i="0">
+                <a:solidFill>
+                  <a:srgbClr val="374151"/>
+                </a:solidFill>
+                <a:latin typeface="Inter"/>
+              </a:rPr>
+              <a:t>False positive rate down to 12%</a:t>
+            </a:r>
+          </a:p>
+        </p:txBody>
+      </p:sp>
+      <p:sp>
+        <p:nvSpPr>
+          <p:cNvPr id="54" name="Oval 53"/>
+          <p:cNvSpPr/>
+          <p:nvPr/>
+        </p:nvSpPr>
+        <p:spPr>
+          <a:xfrm>
+            <a:off x="6236208" y="2295144"/>
+            <a:ext cx="91440" cy="91440"/>
+          </a:xfrm>
+          <a:prstGeom prst="ellipse">
+            <a:avLst/>
+          </a:prstGeom>
+          <a:solidFill>
+            <a:srgbClr val="047857"/>
+          </a:solidFill>
+          <a:ln>
+            <a:noFill/>
+          </a:ln>
+        </p:spPr>
+        <p:style>
+          <a:lnRef idx="1">
+            <a:schemeClr val="accent1"/>
+          </a:lnRef>
+          <a:fillRef idx="3">
+            <a:schemeClr val="accent1"/>
+          </a:fillRef>
+          <a:effectRef idx="2">
+            <a:schemeClr val="accent1"/>
+          </a:effectRef>
+          <a:fontRef idx="minor">
+            <a:schemeClr val="lt1"/>
+          </a:fontRef>
+        </p:style>
+        <p:txBody>
+          <a:bodyPr rtlCol="0" anchor="ctr"/>
+          <a:lstStyle/>
+          <a:p>
+            <a:pPr algn="ctr"/>
+          </a:p>
+        </p:txBody>
+      </p:sp>
+      <p:sp>
+        <p:nvSpPr>
+          <p:cNvPr id="55" name="TextBox 54"/>
+          <p:cNvSpPr txBox="1"/>
+          <p:nvPr/>
+        </p:nvSpPr>
+        <p:spPr>
+          <a:xfrm>
+            <a:off x="6446520" y="2240280"/>
+            <a:ext cx="4754880" cy="320040"/>
+          </a:xfrm>
+          <a:prstGeom prst="rect">
+            <a:avLst/>
+          </a:prstGeom>
+          <a:noFill/>
+        </p:spPr>
+        <p:txBody>
+          <a:bodyPr wrap="square" lIns="0" tIns="0" rIns="0" bIns="0">
+            <a:spAutoFit/>
+          </a:bodyPr>
+          <a:lstStyle/>
+          <a:p>
+            <a:pPr algn="l"/>
+            <a:r>
+              <a:rPr sz="1500" b="0" i="0">
                 <a:solidFill>
                   <a:srgbClr val="374151"/>
                 </a:solidFill>
@@ -13082,14 +13238,14 @@
       </p:sp>
       <p:sp>
         <p:nvSpPr>
-          <p:cNvPr id="52" name="Oval 51"/>
-          <p:cNvSpPr/>
-          <p:nvPr/>
-        </p:nvSpPr>
-        <p:spPr>
-          <a:xfrm>
-            <a:off x="749808" y="3081528"/>
-            <a:ext cx="82296" cy="82296"/>
+          <p:cNvPr id="56" name="Oval 55"/>
+          <p:cNvSpPr/>
+          <p:nvPr/>
+        </p:nvSpPr>
+        <p:spPr>
+          <a:xfrm>
+            <a:off x="6236208" y="2679192"/>
+            <a:ext cx="91440" cy="91440"/>
           </a:xfrm>
           <a:prstGeom prst="ellipse">
             <a:avLst/>
@@ -13125,14 +13281,14 @@
       </p:sp>
       <p:sp>
         <p:nvSpPr>
-          <p:cNvPr id="53" name="TextBox 52"/>
+          <p:cNvPr id="57" name="TextBox 56"/>
           <p:cNvSpPr txBox="1"/>
           <p:nvPr/>
         </p:nvSpPr>
         <p:spPr>
           <a:xfrm>
-            <a:off x="932688" y="3026664"/>
-            <a:ext cx="5669280" cy="320040"/>
+            <a:off x="6446520" y="2624328"/>
+            <a:ext cx="4754880" cy="320040"/>
           </a:xfrm>
           <a:prstGeom prst="rect">
             <a:avLst/>
@@ -13147,85 +13303,7 @@
           <a:p>
             <a:pPr algn="l"/>
             <a:r>
-              <a:rPr sz="1350" b="0" i="0">
-                <a:solidFill>
-                  <a:srgbClr val="374151"/>
-                </a:solidFill>
-                <a:latin typeface="Inter"/>
-              </a:rPr>
-              <a:t>Mesh networking works in GPS-denied zones</a:t>
-            </a:r>
-          </a:p>
-        </p:txBody>
-      </p:sp>
-      <p:sp>
-        <p:nvSpPr>
-          <p:cNvPr id="54" name="Oval 53"/>
-          <p:cNvSpPr/>
-          <p:nvPr/>
-        </p:nvSpPr>
-        <p:spPr>
-          <a:xfrm>
-            <a:off x="749808" y="3429000"/>
-            <a:ext cx="82296" cy="82296"/>
-          </a:xfrm>
-          <a:prstGeom prst="ellipse">
-            <a:avLst/>
-          </a:prstGeom>
-          <a:solidFill>
-            <a:srgbClr val="047857"/>
-          </a:solidFill>
-          <a:ln>
-            <a:noFill/>
-          </a:ln>
-        </p:spPr>
-        <p:style>
-          <a:lnRef idx="1">
-            <a:schemeClr val="accent1"/>
-          </a:lnRef>
-          <a:fillRef idx="3">
-            <a:schemeClr val="accent1"/>
-          </a:fillRef>
-          <a:effectRef idx="2">
-            <a:schemeClr val="accent1"/>
-          </a:effectRef>
-          <a:fontRef idx="minor">
-            <a:schemeClr val="lt1"/>
-          </a:fontRef>
-        </p:style>
-        <p:txBody>
-          <a:bodyPr rtlCol="0" anchor="ctr"/>
-          <a:lstStyle/>
-          <a:p>
-            <a:pPr algn="ctr"/>
-          </a:p>
-        </p:txBody>
-      </p:sp>
-      <p:sp>
-        <p:nvSpPr>
-          <p:cNvPr id="55" name="TextBox 54"/>
-          <p:cNvSpPr txBox="1"/>
-          <p:nvPr/>
-        </p:nvSpPr>
-        <p:spPr>
-          <a:xfrm>
-            <a:off x="932688" y="3374136"/>
-            <a:ext cx="5669280" cy="320040"/>
-          </a:xfrm>
-          <a:prstGeom prst="rect">
-            <a:avLst/>
-          </a:prstGeom>
-          <a:noFill/>
-        </p:spPr>
-        <p:txBody>
-          <a:bodyPr wrap="square" lIns="0" tIns="0" rIns="0" bIns="0">
-            <a:spAutoFit/>
-          </a:bodyPr>
-          <a:lstStyle/>
-          <a:p>
-            <a:pPr algn="l"/>
-            <a:r>
-              <a:rPr sz="1350" b="0" i="0">
+              <a:rPr sz="1500" b="0" i="0">
                 <a:solidFill>
                   <a:srgbClr val="374151"/>
                 </a:solidFill>
@@ -13238,14 +13316,14 @@
       </p:sp>
       <p:sp>
         <p:nvSpPr>
-          <p:cNvPr id="56" name="Oval 55"/>
-          <p:cNvSpPr/>
-          <p:nvPr/>
-        </p:nvSpPr>
-        <p:spPr>
-          <a:xfrm>
-            <a:off x="749808" y="3776472"/>
-            <a:ext cx="82296" cy="82296"/>
+          <p:cNvPr id="58" name="Oval 57"/>
+          <p:cNvSpPr/>
+          <p:nvPr/>
+        </p:nvSpPr>
+        <p:spPr>
+          <a:xfrm>
+            <a:off x="6236208" y="3063240"/>
+            <a:ext cx="91440" cy="91440"/>
           </a:xfrm>
           <a:prstGeom prst="ellipse">
             <a:avLst/>
@@ -13281,14 +13359,14 @@
       </p:sp>
       <p:sp>
         <p:nvSpPr>
-          <p:cNvPr id="57" name="TextBox 56"/>
+          <p:cNvPr id="59" name="TextBox 58"/>
           <p:cNvSpPr txBox="1"/>
           <p:nvPr/>
         </p:nvSpPr>
         <p:spPr>
           <a:xfrm>
-            <a:off x="932688" y="3721608"/>
-            <a:ext cx="5669280" cy="320040"/>
+            <a:off x="6446520" y="3008376"/>
+            <a:ext cx="4754880" cy="320040"/>
           </a:xfrm>
           <a:prstGeom prst="rect">
             <a:avLst/>
@@ -13303,85 +13381,7 @@
           <a:p>
             <a:pPr algn="l"/>
             <a:r>
-              <a:rPr sz="1350" b="0" i="0">
-                <a:solidFill>
-                  <a:srgbClr val="374151"/>
-                </a:solidFill>
-                <a:latin typeface="Inter"/>
-              </a:rPr>
-              <a:t>False positive rate down to 12%</a:t>
-            </a:r>
-          </a:p>
-        </p:txBody>
-      </p:sp>
-      <p:sp>
-        <p:nvSpPr>
-          <p:cNvPr id="58" name="Oval 57"/>
-          <p:cNvSpPr/>
-          <p:nvPr/>
-        </p:nvSpPr>
-        <p:spPr>
-          <a:xfrm>
-            <a:off x="749808" y="4123944"/>
-            <a:ext cx="82296" cy="82296"/>
-          </a:xfrm>
-          <a:prstGeom prst="ellipse">
-            <a:avLst/>
-          </a:prstGeom>
-          <a:solidFill>
-            <a:srgbClr val="047857"/>
-          </a:solidFill>
-          <a:ln>
-            <a:noFill/>
-          </a:ln>
-        </p:spPr>
-        <p:style>
-          <a:lnRef idx="1">
-            <a:schemeClr val="accent1"/>
-          </a:lnRef>
-          <a:fillRef idx="3">
-            <a:schemeClr val="accent1"/>
-          </a:fillRef>
-          <a:effectRef idx="2">
-            <a:schemeClr val="accent1"/>
-          </a:effectRef>
-          <a:fontRef idx="minor">
-            <a:schemeClr val="lt1"/>
-          </a:fontRef>
-        </p:style>
-        <p:txBody>
-          <a:bodyPr rtlCol="0" anchor="ctr"/>
-          <a:lstStyle/>
-          <a:p>
-            <a:pPr algn="ctr"/>
-          </a:p>
-        </p:txBody>
-      </p:sp>
-      <p:sp>
-        <p:nvSpPr>
-          <p:cNvPr id="59" name="TextBox 58"/>
-          <p:cNvSpPr txBox="1"/>
-          <p:nvPr/>
-        </p:nvSpPr>
-        <p:spPr>
-          <a:xfrm>
-            <a:off x="932688" y="4069080"/>
-            <a:ext cx="5669280" cy="320040"/>
-          </a:xfrm>
-          <a:prstGeom prst="rect">
-            <a:avLst/>
-          </a:prstGeom>
-          <a:noFill/>
-        </p:spPr>
-        <p:txBody>
-          <a:bodyPr wrap="square" lIns="0" tIns="0" rIns="0" bIns="0">
-            <a:spAutoFit/>
-          </a:bodyPr>
-          <a:lstStyle/>
-          <a:p>
-            <a:pPr algn="l"/>
-            <a:r>
-              <a:rPr sz="1350" b="0" i="0">
+              <a:rPr sz="1500" b="0" i="0">
                 <a:solidFill>
                   <a:srgbClr val="374151"/>
                 </a:solidFill>
@@ -13400,8 +13400,8 @@
         </p:nvSpPr>
         <p:spPr>
           <a:xfrm>
-            <a:off x="731520" y="4572000"/>
-            <a:ext cx="4572000" cy="182880"/>
+            <a:off x="731520" y="3566160"/>
+            <a:ext cx="5486400" cy="182880"/>
           </a:xfrm>
           <a:prstGeom prst="rect">
             <a:avLst/>
@@ -13416,7 +13416,7 @@
           <a:p>
             <a:pPr algn="l"/>
             <a:r>
-              <a:rPr sz="750" b="1" i="0">
+              <a:rPr sz="800" b="1" i="0">
                 <a:solidFill>
                   <a:srgbClr val="94A3B8"/>
                 </a:solidFill>
@@ -13429,20 +13429,55 @@
       </p:sp>
       <p:sp>
         <p:nvSpPr>
-          <p:cNvPr id="61" name="Rounded Rectangle 60"/>
-          <p:cNvSpPr/>
-          <p:nvPr/>
-        </p:nvSpPr>
-        <p:spPr>
-          <a:xfrm>
-            <a:off x="731520" y="4800600"/>
-            <a:ext cx="1828800" cy="868680"/>
+          <p:cNvPr id="61" name="TextBox 60"/>
+          <p:cNvSpPr txBox="1"/>
+          <p:nvPr/>
+        </p:nvSpPr>
+        <p:spPr>
+          <a:xfrm>
+            <a:off x="8229600" y="3566160"/>
+            <a:ext cx="3200400" cy="182880"/>
+          </a:xfrm>
+          <a:prstGeom prst="rect">
+            <a:avLst/>
+          </a:prstGeom>
+          <a:noFill/>
+        </p:spPr>
+        <p:txBody>
+          <a:bodyPr wrap="square" lIns="0" tIns="0" rIns="0" bIns="0">
+            <a:spAutoFit/>
+          </a:bodyPr>
+          <a:lstStyle/>
+          <a:p>
+            <a:pPr algn="r"/>
+            <a:r>
+              <a:rPr sz="800" b="1" i="0">
+                <a:solidFill>
+                  <a:srgbClr val="047857"/>
+                </a:solidFill>
+                <a:latin typeface="JetBrains Mono"/>
+              </a:rPr>
+              <a:t>3 CORE ENGINEERING MOATS</a:t>
+            </a:r>
+          </a:p>
+        </p:txBody>
+      </p:sp>
+      <p:sp>
+        <p:nvSpPr>
+          <p:cNvPr id="62" name="Rounded Rectangle 61"/>
+          <p:cNvSpPr/>
+          <p:nvPr/>
+        </p:nvSpPr>
+        <p:spPr>
+          <a:xfrm>
+            <a:off x="731520" y="3794760"/>
+            <a:ext cx="3429000" cy="1188720"/>
           </a:xfrm>
           <a:prstGeom prst="roundRect">
             <a:avLst/>
           </a:prstGeom>
           <a:solidFill>
-            <a:srgbClr val="DCFCE7"/>
+            <a:srgbClr val="ECFDF5"/>
           </a:solidFill>
           <a:ln w="12700">
             <a:solidFill>
@@ -13474,14 +13509,14 @@
       </p:sp>
       <p:sp>
         <p:nvSpPr>
-          <p:cNvPr id="62" name="TextBox 61"/>
+          <p:cNvPr id="63" name="TextBox 62"/>
           <p:cNvSpPr txBox="1"/>
           <p:nvPr/>
         </p:nvSpPr>
         <p:spPr>
           <a:xfrm>
-            <a:off x="804672" y="4864608"/>
-            <a:ext cx="1682496" cy="164592"/>
+            <a:off x="868680" y="3858768"/>
+            <a:ext cx="1645920" cy="182880"/>
           </a:xfrm>
           <a:prstGeom prst="rect">
             <a:avLst/>
@@ -13495,6 +13530,86 @@
           <a:lstStyle/>
           <a:p>
             <a:pPr algn="l"/>
+            <a:r>
+              <a:rPr sz="700" b="1" i="0">
+                <a:solidFill>
+                  <a:srgbClr val="047857"/>
+                </a:solidFill>
+                <a:latin typeface="JetBrains Mono"/>
+              </a:rPr>
+              <a:t>SUBSYSTEM A MOAT</a:t>
+            </a:r>
+          </a:p>
+        </p:txBody>
+      </p:sp>
+      <p:sp>
+        <p:nvSpPr>
+          <p:cNvPr id="64" name="Rounded Rectangle 63"/>
+          <p:cNvSpPr/>
+          <p:nvPr/>
+        </p:nvSpPr>
+        <p:spPr>
+          <a:xfrm>
+            <a:off x="2834640" y="3858768"/>
+            <a:ext cx="1188720" cy="201168"/>
+          </a:xfrm>
+          <a:prstGeom prst="roundRect">
+            <a:avLst/>
+          </a:prstGeom>
+          <a:solidFill>
+            <a:srgbClr val="FFFFFF"/>
+          </a:solidFill>
+          <a:ln w="12700">
+            <a:solidFill>
+              <a:srgbClr val="E2E8F0"/>
+            </a:solidFill>
+          </a:ln>
+        </p:spPr>
+        <p:style>
+          <a:lnRef idx="1">
+            <a:schemeClr val="accent1"/>
+          </a:lnRef>
+          <a:fillRef idx="3">
+            <a:schemeClr val="accent1"/>
+          </a:fillRef>
+          <a:effectRef idx="2">
+            <a:schemeClr val="accent1"/>
+          </a:effectRef>
+          <a:fontRef idx="minor">
+            <a:schemeClr val="lt1"/>
+          </a:fontRef>
+        </p:style>
+        <p:txBody>
+          <a:bodyPr rtlCol="0" anchor="ctr"/>
+          <a:lstStyle/>
+          <a:p>
+            <a:pPr algn="ctr"/>
+          </a:p>
+        </p:txBody>
+      </p:sp>
+      <p:sp>
+        <p:nvSpPr>
+          <p:cNvPr id="65" name="TextBox 64"/>
+          <p:cNvSpPr txBox="1"/>
+          <p:nvPr/>
+        </p:nvSpPr>
+        <p:spPr>
+          <a:xfrm>
+            <a:off x="2834640" y="3877056"/>
+            <a:ext cx="1188720" cy="182880"/>
+          </a:xfrm>
+          <a:prstGeom prst="rect">
+            <a:avLst/>
+          </a:prstGeom>
+          <a:noFill/>
+        </p:spPr>
+        <p:txBody>
+          <a:bodyPr wrap="square" lIns="0" tIns="0" rIns="0" bIns="0">
+            <a:spAutoFit/>
+          </a:bodyPr>
+          <a:lstStyle/>
+          <a:p>
+            <a:pPr algn="ctr"/>
             <a:r>
               <a:rPr sz="650" b="1" i="0">
                 <a:solidFill>
@@ -13502,21 +13617,21 @@
                 </a:solidFill>
                 <a:latin typeface="JetBrains Mono"/>
               </a:rPr>
-              <a:t>SUBSYSTEM A MOAT</a:t>
-            </a:r>
-          </a:p>
-        </p:txBody>
-      </p:sp>
-      <p:sp>
-        <p:nvSpPr>
-          <p:cNvPr id="63" name="TextBox 62"/>
+              <a:t>50Hz OFFBOARD</a:t>
+            </a:r>
+          </a:p>
+        </p:txBody>
+      </p:sp>
+      <p:sp>
+        <p:nvSpPr>
+          <p:cNvPr id="66" name="TextBox 65"/>
           <p:cNvSpPr txBox="1"/>
           <p:nvPr/>
         </p:nvSpPr>
         <p:spPr>
           <a:xfrm>
-            <a:off x="804672" y="5029200"/>
-            <a:ext cx="1682496" cy="228600"/>
+            <a:off x="868680" y="4069080"/>
+            <a:ext cx="3154680" cy="256032"/>
           </a:xfrm>
           <a:prstGeom prst="rect">
             <a:avLst/>
@@ -13531,27 +13646,27 @@
           <a:p>
             <a:pPr algn="l"/>
             <a:r>
-              <a:rPr sz="900" b="1" i="0">
+              <a:rPr sz="1100" b="1" i="0">
                 <a:solidFill>
                   <a:srgbClr val="000000"/>
                 </a:solidFill>
                 <a:latin typeface="Plus Jakarta Sans"/>
               </a:rPr>
-              <a:t>PX4 + VIO EKF2</a:t>
-            </a:r>
-          </a:p>
-        </p:txBody>
-      </p:sp>
-      <p:sp>
-        <p:nvSpPr>
-          <p:cNvPr id="64" name="TextBox 63"/>
+              <a:t>PX4 + VIO EKF2 Autopilot</a:t>
+            </a:r>
+          </a:p>
+        </p:txBody>
+      </p:sp>
+      <p:sp>
+        <p:nvSpPr>
+          <p:cNvPr id="67" name="TextBox 66"/>
           <p:cNvSpPr txBox="1"/>
           <p:nvPr/>
         </p:nvSpPr>
         <p:spPr>
           <a:xfrm>
-            <a:off x="804672" y="5257800"/>
-            <a:ext cx="1682496" cy="320040"/>
+            <a:off x="868680" y="4343400"/>
+            <a:ext cx="3154680" cy="594360"/>
           </a:xfrm>
           <a:prstGeom prst="rect">
             <a:avLst/>
@@ -13566,33 +13681,33 @@
           <a:p>
             <a:pPr algn="l"/>
             <a:r>
-              <a:rPr sz="680" b="0" i="0">
+              <a:rPr sz="819" b="0" i="0">
                 <a:solidFill>
                   <a:srgbClr val="475569"/>
                 </a:solidFill>
-                <a:latin typeface="JetBrains Mono"/>
+                <a:latin typeface="Inter"/>
               </a:rPr>
-              <a:t>50Hz Offboard GNC</a:t>
-            </a:r>
-          </a:p>
-        </p:txBody>
-      </p:sp>
-      <p:sp>
-        <p:nvSpPr>
-          <p:cNvPr id="65" name="Rounded Rectangle 64"/>
-          <p:cNvSpPr/>
-          <p:nvPr/>
-        </p:nvSpPr>
-        <p:spPr>
-          <a:xfrm>
-            <a:off x="2697480" y="4800600"/>
-            <a:ext cx="1828800" cy="868680"/>
+              <a:t>Decentralized 3D ORCA anti-collision and offboard setpoint streaming without ground control tower dependency.</a:t>
+            </a:r>
+          </a:p>
+        </p:txBody>
+      </p:sp>
+      <p:sp>
+        <p:nvSpPr>
+          <p:cNvPr id="68" name="Rounded Rectangle 67"/>
+          <p:cNvSpPr/>
+          <p:nvPr/>
+        </p:nvSpPr>
+        <p:spPr>
+          <a:xfrm>
+            <a:off x="4379976" y="3794760"/>
+            <a:ext cx="3429000" cy="1188720"/>
           </a:xfrm>
           <a:prstGeom prst="roundRect">
             <a:avLst/>
           </a:prstGeom>
           <a:solidFill>
-            <a:srgbClr val="DCFCE7"/>
+            <a:srgbClr val="ECFDF5"/>
           </a:solidFill>
           <a:ln w="12700">
             <a:solidFill>
@@ -13624,14 +13739,14 @@
       </p:sp>
       <p:sp>
         <p:nvSpPr>
-          <p:cNvPr id="66" name="TextBox 65"/>
+          <p:cNvPr id="69" name="TextBox 68"/>
           <p:cNvSpPr txBox="1"/>
           <p:nvPr/>
         </p:nvSpPr>
         <p:spPr>
           <a:xfrm>
-            <a:off x="2770632" y="4864608"/>
-            <a:ext cx="1682496" cy="164592"/>
+            <a:off x="4517136" y="3858768"/>
+            <a:ext cx="1645920" cy="182880"/>
           </a:xfrm>
           <a:prstGeom prst="rect">
             <a:avLst/>
@@ -13645,6 +13760,86 @@
           <a:lstStyle/>
           <a:p>
             <a:pPr algn="l"/>
+            <a:r>
+              <a:rPr sz="700" b="1" i="0">
+                <a:solidFill>
+                  <a:srgbClr val="047857"/>
+                </a:solidFill>
+                <a:latin typeface="JetBrains Mono"/>
+              </a:rPr>
+              <a:t>SUBSYSTEM B MOAT</a:t>
+            </a:r>
+          </a:p>
+        </p:txBody>
+      </p:sp>
+      <p:sp>
+        <p:nvSpPr>
+          <p:cNvPr id="70" name="Rounded Rectangle 69"/>
+          <p:cNvSpPr/>
+          <p:nvPr/>
+        </p:nvSpPr>
+        <p:spPr>
+          <a:xfrm>
+            <a:off x="6483096" y="3858768"/>
+            <a:ext cx="1188720" cy="201168"/>
+          </a:xfrm>
+          <a:prstGeom prst="roundRect">
+            <a:avLst/>
+          </a:prstGeom>
+          <a:solidFill>
+            <a:srgbClr val="FFFFFF"/>
+          </a:solidFill>
+          <a:ln w="12700">
+            <a:solidFill>
+              <a:srgbClr val="E2E8F0"/>
+            </a:solidFill>
+          </a:ln>
+        </p:spPr>
+        <p:style>
+          <a:lnRef idx="1">
+            <a:schemeClr val="accent1"/>
+          </a:lnRef>
+          <a:fillRef idx="3">
+            <a:schemeClr val="accent1"/>
+          </a:fillRef>
+          <a:effectRef idx="2">
+            <a:schemeClr val="accent1"/>
+          </a:effectRef>
+          <a:fontRef idx="minor">
+            <a:schemeClr val="lt1"/>
+          </a:fontRef>
+        </p:style>
+        <p:txBody>
+          <a:bodyPr rtlCol="0" anchor="ctr"/>
+          <a:lstStyle/>
+          <a:p>
+            <a:pPr algn="ctr"/>
+          </a:p>
+        </p:txBody>
+      </p:sp>
+      <p:sp>
+        <p:nvSpPr>
+          <p:cNvPr id="71" name="TextBox 70"/>
+          <p:cNvSpPr txBox="1"/>
+          <p:nvPr/>
+        </p:nvSpPr>
+        <p:spPr>
+          <a:xfrm>
+            <a:off x="6483096" y="3877056"/>
+            <a:ext cx="1188720" cy="182880"/>
+          </a:xfrm>
+          <a:prstGeom prst="rect">
+            <a:avLst/>
+          </a:prstGeom>
+          <a:noFill/>
+        </p:spPr>
+        <p:txBody>
+          <a:bodyPr wrap="square" lIns="0" tIns="0" rIns="0" bIns="0">
+            <a:spAutoFit/>
+          </a:bodyPr>
+          <a:lstStyle/>
+          <a:p>
+            <a:pPr algn="ctr"/>
             <a:r>
               <a:rPr sz="650" b="1" i="0">
                 <a:solidFill>
@@ -13652,21 +13847,21 @@
                 </a:solidFill>
                 <a:latin typeface="JetBrains Mono"/>
               </a:rPr>
-              <a:t>SUBSYSTEM B MOAT</a:t>
-            </a:r>
-          </a:p>
-        </p:txBody>
-      </p:sp>
-      <p:sp>
-        <p:nvSpPr>
-          <p:cNvPr id="67" name="TextBox 66"/>
+              <a:t>-5dB RESILIENT</a:t>
+            </a:r>
+          </a:p>
+        </p:txBody>
+      </p:sp>
+      <p:sp>
+        <p:nvSpPr>
+          <p:cNvPr id="72" name="TextBox 71"/>
           <p:cNvSpPr txBox="1"/>
           <p:nvPr/>
         </p:nvSpPr>
         <p:spPr>
           <a:xfrm>
-            <a:off x="2770632" y="5029200"/>
-            <a:ext cx="1682496" cy="228600"/>
+            <a:off x="4517136" y="4069080"/>
+            <a:ext cx="3154680" cy="256032"/>
           </a:xfrm>
           <a:prstGeom prst="rect">
             <a:avLst/>
@@ -13681,27 +13876,27 @@
           <a:p>
             <a:pPr algn="l"/>
             <a:r>
-              <a:rPr sz="900" b="1" i="0">
+              <a:rPr sz="1100" b="1" i="0">
                 <a:solidFill>
                   <a:srgbClr val="000000"/>
                 </a:solidFill>
                 <a:latin typeface="Plus Jakarta Sans"/>
               </a:rPr>
-              <a:t>Deep JSCC Video</a:t>
-            </a:r>
-          </a:p>
-        </p:txBody>
-      </p:sp>
-      <p:sp>
-        <p:nvSpPr>
-          <p:cNvPr id="68" name="TextBox 67"/>
+              <a:t>Deep JSCC Neural Video</a:t>
+            </a:r>
+          </a:p>
+        </p:txBody>
+      </p:sp>
+      <p:sp>
+        <p:nvSpPr>
+          <p:cNvPr id="73" name="TextBox 72"/>
           <p:cNvSpPr txBox="1"/>
           <p:nvPr/>
         </p:nvSpPr>
         <p:spPr>
           <a:xfrm>
-            <a:off x="2770632" y="5257800"/>
-            <a:ext cx="1682496" cy="320040"/>
+            <a:off x="4517136" y="4343400"/>
+            <a:ext cx="3154680" cy="594360"/>
           </a:xfrm>
           <a:prstGeom prst="rect">
             <a:avLst/>
@@ -13716,33 +13911,33 @@
           <a:p>
             <a:pPr algn="l"/>
             <a:r>
-              <a:rPr sz="680" b="0" i="0">
+              <a:rPr sz="819" b="0" i="0">
                 <a:solidFill>
                   <a:srgbClr val="475569"/>
                 </a:solidFill>
-                <a:latin typeface="JetBrains Mono"/>
+                <a:latin typeface="Inter"/>
               </a:rPr>
-              <a:t>Zero-Cliff to -5dB</a:t>
-            </a:r>
-          </a:p>
-        </p:txBody>
-      </p:sp>
-      <p:sp>
-        <p:nvSpPr>
-          <p:cNvPr id="69" name="Rounded Rectangle 68"/>
-          <p:cNvSpPr/>
-          <p:nvPr/>
-        </p:nvSpPr>
-        <p:spPr>
-          <a:xfrm>
-            <a:off x="4663440" y="4800600"/>
-            <a:ext cx="1828800" cy="868680"/>
+              <a:t>Zero-cliff neural semantic video encoding that degrades gracefully under extreme radio jamming and ravine occlusion.</a:t>
+            </a:r>
+          </a:p>
+        </p:txBody>
+      </p:sp>
+      <p:sp>
+        <p:nvSpPr>
+          <p:cNvPr id="74" name="Rounded Rectangle 73"/>
+          <p:cNvSpPr/>
+          <p:nvPr/>
+        </p:nvSpPr>
+        <p:spPr>
+          <a:xfrm>
+            <a:off x="8028432" y="3794760"/>
+            <a:ext cx="3429000" cy="1188720"/>
           </a:xfrm>
           <a:prstGeom prst="roundRect">
             <a:avLst/>
           </a:prstGeom>
           <a:solidFill>
-            <a:srgbClr val="DCFCE7"/>
+            <a:srgbClr val="ECFDF5"/>
           </a:solidFill>
           <a:ln w="12700">
             <a:solidFill>
@@ -13774,14 +13969,14 @@
       </p:sp>
       <p:sp>
         <p:nvSpPr>
-          <p:cNvPr id="70" name="TextBox 69"/>
+          <p:cNvPr id="75" name="TextBox 74"/>
           <p:cNvSpPr txBox="1"/>
           <p:nvPr/>
         </p:nvSpPr>
         <p:spPr>
           <a:xfrm>
-            <a:off x="4736592" y="4864608"/>
-            <a:ext cx="1682496" cy="164592"/>
+            <a:off x="8165592" y="3858768"/>
+            <a:ext cx="1645920" cy="182880"/>
           </a:xfrm>
           <a:prstGeom prst="rect">
             <a:avLst/>
@@ -13795,6 +13990,86 @@
           <a:lstStyle/>
           <a:p>
             <a:pPr algn="l"/>
+            <a:r>
+              <a:rPr sz="700" b="1" i="0">
+                <a:solidFill>
+                  <a:srgbClr val="047857"/>
+                </a:solidFill>
+                <a:latin typeface="JetBrains Mono"/>
+              </a:rPr>
+              <a:t>SUBSYSTEM C/D MOAT</a:t>
+            </a:r>
+          </a:p>
+        </p:txBody>
+      </p:sp>
+      <p:sp>
+        <p:nvSpPr>
+          <p:cNvPr id="76" name="Rounded Rectangle 75"/>
+          <p:cNvSpPr/>
+          <p:nvPr/>
+        </p:nvSpPr>
+        <p:spPr>
+          <a:xfrm>
+            <a:off x="10131552" y="3858768"/>
+            <a:ext cx="1188720" cy="201168"/>
+          </a:xfrm>
+          <a:prstGeom prst="roundRect">
+            <a:avLst/>
+          </a:prstGeom>
+          <a:solidFill>
+            <a:srgbClr val="FFFFFF"/>
+          </a:solidFill>
+          <a:ln w="12700">
+            <a:solidFill>
+              <a:srgbClr val="E2E8F0"/>
+            </a:solidFill>
+          </a:ln>
+        </p:spPr>
+        <p:style>
+          <a:lnRef idx="1">
+            <a:schemeClr val="accent1"/>
+          </a:lnRef>
+          <a:fillRef idx="3">
+            <a:schemeClr val="accent1"/>
+          </a:fillRef>
+          <a:effectRef idx="2">
+            <a:schemeClr val="accent1"/>
+          </a:effectRef>
+          <a:fontRef idx="minor">
+            <a:schemeClr val="lt1"/>
+          </a:fontRef>
+        </p:style>
+        <p:txBody>
+          <a:bodyPr rtlCol="0" anchor="ctr"/>
+          <a:lstStyle/>
+          <a:p>
+            <a:pPr algn="ctr"/>
+          </a:p>
+        </p:txBody>
+      </p:sp>
+      <p:sp>
+        <p:nvSpPr>
+          <p:cNvPr id="77" name="TextBox 76"/>
+          <p:cNvSpPr txBox="1"/>
+          <p:nvPr/>
+        </p:nvSpPr>
+        <p:spPr>
+          <a:xfrm>
+            <a:off x="10131552" y="3877056"/>
+            <a:ext cx="1188720" cy="182880"/>
+          </a:xfrm>
+          <a:prstGeom prst="rect">
+            <a:avLst/>
+          </a:prstGeom>
+          <a:noFill/>
+        </p:spPr>
+        <p:txBody>
+          <a:bodyPr wrap="square" lIns="0" tIns="0" rIns="0" bIns="0">
+            <a:spAutoFit/>
+          </a:bodyPr>
+          <a:lstStyle/>
+          <a:p>
+            <a:pPr algn="ctr"/>
             <a:r>
               <a:rPr sz="650" b="1" i="0">
                 <a:solidFill>
@@ -13802,21 +14077,21 @@
                 </a:solidFill>
                 <a:latin typeface="JetBrains Mono"/>
               </a:rPr>
-              <a:t>SUBSYSTEM C/D MOAT</a:t>
-            </a:r>
-          </a:p>
-        </p:txBody>
-      </p:sp>
-      <p:sp>
-        <p:nvSpPr>
-          <p:cNvPr id="71" name="TextBox 70"/>
+              <a:t>3.59cm ACCURACY</a:t>
+            </a:r>
+          </a:p>
+        </p:txBody>
+      </p:sp>
+      <p:sp>
+        <p:nvSpPr>
+          <p:cNvPr id="78" name="TextBox 77"/>
           <p:cNvSpPr txBox="1"/>
           <p:nvPr/>
         </p:nvSpPr>
         <p:spPr>
           <a:xfrm>
-            <a:off x="4736592" y="5029200"/>
-            <a:ext cx="1682496" cy="228600"/>
+            <a:off x="8165592" y="4069080"/>
+            <a:ext cx="3154680" cy="256032"/>
           </a:xfrm>
           <a:prstGeom prst="rect">
             <a:avLst/>
@@ -13831,27 +14106,27 @@
           <a:p>
             <a:pPr algn="l"/>
             <a:r>
-              <a:rPr sz="900" b="1" i="0">
+              <a:rPr sz="1100" b="1" i="0">
                 <a:solidFill>
                   <a:srgbClr val="000000"/>
                 </a:solidFill>
                 <a:latin typeface="Plus Jakarta Sans"/>
               </a:rPr>
-              <a:t>3D DEM Raycast</a:t>
-            </a:r>
-          </a:p>
-        </p:txBody>
-      </p:sp>
-      <p:sp>
-        <p:nvSpPr>
-          <p:cNvPr id="72" name="TextBox 71"/>
+              <a:t>3D DEM Terrain Raycasting</a:t>
+            </a:r>
+          </a:p>
+        </p:txBody>
+      </p:sp>
+      <p:sp>
+        <p:nvSpPr>
+          <p:cNvPr id="79" name="TextBox 78"/>
           <p:cNvSpPr txBox="1"/>
           <p:nvPr/>
         </p:nvSpPr>
         <p:spPr>
           <a:xfrm>
-            <a:off x="4736592" y="5257800"/>
-            <a:ext cx="1682496" cy="320040"/>
+            <a:off x="8165592" y="4343400"/>
+            <a:ext cx="3154680" cy="594360"/>
           </a:xfrm>
           <a:prstGeom prst="rect">
             <a:avLst/>
@@ -13866,27 +14141,27 @@
           <a:p>
             <a:pPr algn="l"/>
             <a:r>
-              <a:rPr sz="680" b="0" i="0">
+              <a:rPr sz="819" b="0" i="0">
                 <a:solidFill>
                   <a:srgbClr val="475569"/>
                 </a:solidFill>
-                <a:latin typeface="JetBrains Mono"/>
+                <a:latin typeface="Inter"/>
               </a:rPr>
-              <a:t>3.59cm Geolocation</a:t>
-            </a:r>
-          </a:p>
-        </p:txBody>
-      </p:sp>
-      <p:sp>
-        <p:nvSpPr>
-          <p:cNvPr id="73" name="Rounded Rectangle 72"/>
-          <p:cNvSpPr/>
-          <p:nvPr/>
-        </p:nvSpPr>
-        <p:spPr>
-          <a:xfrm>
-            <a:off x="6766560" y="1234440"/>
-            <a:ext cx="4693615" cy="3017520"/>
+              <a:t>Sub-15ms edge YOLOv8-Pose with WGS84 elevation raycasting, eliminating 15-30m flat-Earth geolocation errors.</a:t>
+            </a:r>
+          </a:p>
+        </p:txBody>
+      </p:sp>
+      <p:sp>
+        <p:nvSpPr>
+          <p:cNvPr id="80" name="Rounded Rectangle 79"/>
+          <p:cNvSpPr/>
+          <p:nvPr/>
+        </p:nvSpPr>
+        <p:spPr>
+          <a:xfrm>
+            <a:off x="731520" y="5120640"/>
+            <a:ext cx="2514600" cy="658368"/>
           </a:xfrm>
           <a:prstGeom prst="roundRect">
             <a:avLst/>
@@ -13924,14 +14199,14 @@
       </p:sp>
       <p:sp>
         <p:nvSpPr>
-          <p:cNvPr id="74" name="TextBox 73"/>
+          <p:cNvPr id="81" name="TextBox 80"/>
           <p:cNvSpPr txBox="1"/>
           <p:nvPr/>
         </p:nvSpPr>
         <p:spPr>
           <a:xfrm>
-            <a:off x="6949440" y="1325880"/>
-            <a:ext cx="2743200" cy="182880"/>
+            <a:off x="822960" y="5166360"/>
+            <a:ext cx="2331720" cy="228600"/>
           </a:xfrm>
           <a:prstGeom prst="rect">
             <a:avLst/>
@@ -13944,142 +14219,29 @@
           </a:bodyPr>
           <a:lstStyle/>
           <a:p>
-            <a:pPr algn="l"/>
-            <a:r>
-              <a:rPr sz="750" b="1" i="0">
-                <a:solidFill>
-                  <a:srgbClr val="94A3B8"/>
-                </a:solidFill>
-                <a:latin typeface="JetBrains Mono"/>
-              </a:rPr>
-              <a:t>BENCHMARK MATRIX</a:t>
-            </a:r>
-          </a:p>
-        </p:txBody>
-      </p:sp>
-      <p:sp>
-        <p:nvSpPr>
-          <p:cNvPr id="75" name="TextBox 74"/>
-          <p:cNvSpPr txBox="1"/>
-          <p:nvPr/>
-        </p:nvSpPr>
-        <p:spPr>
-          <a:xfrm>
-            <a:off x="6949440" y="1536192"/>
-            <a:ext cx="4114800" cy="274320"/>
-          </a:xfrm>
-          <a:prstGeom prst="rect">
-            <a:avLst/>
-          </a:prstGeom>
-          <a:noFill/>
-        </p:spPr>
-        <p:txBody>
-          <a:bodyPr wrap="square" lIns="0" tIns="0" rIns="0" bIns="0">
-            <a:spAutoFit/>
-          </a:bodyPr>
-          <a:lstStyle/>
-          <a:p>
-            <a:pPr algn="l"/>
-            <a:r>
-              <a:rPr sz="1200" b="1" i="0">
+            <a:pPr algn="ctr"/>
+            <a:r>
+              <a:rPr sz="1300" b="1" i="0">
                 <a:solidFill>
                   <a:srgbClr val="000000"/>
                 </a:solidFill>
                 <a:latin typeface="Plus Jakarta Sans"/>
               </a:rPr>
-              <a:t>Search &amp; Rescue Performance Comparison</a:t>
-            </a:r>
-          </a:p>
-        </p:txBody>
-      </p:sp>
-      <p:sp>
-        <p:nvSpPr>
-          <p:cNvPr id="76" name="Rectangle 75"/>
-          <p:cNvSpPr/>
-          <p:nvPr/>
-        </p:nvSpPr>
-        <p:spPr>
-          <a:xfrm>
-            <a:off x="6949440" y="1874519"/>
-            <a:ext cx="4327855" cy="13716"/>
-          </a:xfrm>
-          <a:prstGeom prst="rect">
-            <a:avLst/>
-          </a:prstGeom>
-          <a:solidFill>
-            <a:srgbClr val="E2E8F0"/>
-          </a:solidFill>
-          <a:ln>
-            <a:noFill/>
-          </a:ln>
-        </p:spPr>
-        <p:style>
-          <a:lnRef idx="1">
-            <a:schemeClr val="accent1"/>
-          </a:lnRef>
-          <a:fillRef idx="3">
-            <a:schemeClr val="accent1"/>
-          </a:fillRef>
-          <a:effectRef idx="2">
-            <a:schemeClr val="accent1"/>
-          </a:effectRef>
-          <a:fontRef idx="minor">
-            <a:schemeClr val="lt1"/>
-          </a:fontRef>
-        </p:style>
-        <p:txBody>
-          <a:bodyPr rtlCol="0" anchor="ctr"/>
-          <a:lstStyle/>
-          <a:p>
-            <a:pPr algn="ctr"/>
-          </a:p>
-        </p:txBody>
-      </p:sp>
-      <p:sp>
-        <p:nvSpPr>
-          <p:cNvPr id="77" name="TextBox 76"/>
+              <a:t>$8.94B</a:t>
+            </a:r>
+          </a:p>
+        </p:txBody>
+      </p:sp>
+      <p:sp>
+        <p:nvSpPr>
+          <p:cNvPr id="82" name="TextBox 81"/>
           <p:cNvSpPr txBox="1"/>
           <p:nvPr/>
         </p:nvSpPr>
         <p:spPr>
           <a:xfrm>
-            <a:off x="6949440" y="1965960"/>
-            <a:ext cx="1645920" cy="182880"/>
-          </a:xfrm>
-          <a:prstGeom prst="rect">
-            <a:avLst/>
-          </a:prstGeom>
-          <a:noFill/>
-        </p:spPr>
-        <p:txBody>
-          <a:bodyPr wrap="square" lIns="0" tIns="0" rIns="0" bIns="0">
-            <a:spAutoFit/>
-          </a:bodyPr>
-          <a:lstStyle/>
-          <a:p>
-            <a:pPr algn="l"/>
-            <a:r>
-              <a:rPr sz="750" b="1" i="0">
-                <a:solidFill>
-                  <a:srgbClr val="94A3B8"/>
-                </a:solidFill>
-                <a:latin typeface="JetBrains Mono"/>
-              </a:rPr>
-              <a:t>METRIC</a:t>
-            </a:r>
-          </a:p>
-        </p:txBody>
-      </p:sp>
-      <p:sp>
-        <p:nvSpPr>
-          <p:cNvPr id="78" name="TextBox 77"/>
-          <p:cNvSpPr txBox="1"/>
-          <p:nvPr/>
-        </p:nvSpPr>
-        <p:spPr>
-          <a:xfrm>
-            <a:off x="8595360" y="1965960"/>
-            <a:ext cx="731520" cy="182880"/>
+            <a:off x="822960" y="5394960"/>
+            <a:ext cx="2331720" cy="320040"/>
           </a:xfrm>
           <a:prstGeom prst="rect">
             <a:avLst/>
@@ -14100,21 +14262,101 @@
                 </a:solidFill>
                 <a:latin typeface="JetBrains Mono"/>
               </a:rPr>
-              <a:t>TRADITIONAL</a:t>
-            </a:r>
-          </a:p>
-        </p:txBody>
-      </p:sp>
-      <p:sp>
-        <p:nvSpPr>
-          <p:cNvPr id="79" name="TextBox 78"/>
+              <a:t>Market by 2033 (18.4% CAGR)</a:t>
+            </a:r>
+          </a:p>
+        </p:txBody>
+      </p:sp>
+      <p:sp>
+        <p:nvSpPr>
+          <p:cNvPr id="83" name="Rounded Rectangle 82"/>
+          <p:cNvSpPr/>
+          <p:nvPr/>
+        </p:nvSpPr>
+        <p:spPr>
+          <a:xfrm>
+            <a:off x="3465576" y="5120640"/>
+            <a:ext cx="2514600" cy="658368"/>
+          </a:xfrm>
+          <a:prstGeom prst="roundRect">
+            <a:avLst/>
+          </a:prstGeom>
+          <a:solidFill>
+            <a:srgbClr val="F8FAFC"/>
+          </a:solidFill>
+          <a:ln w="12700">
+            <a:solidFill>
+              <a:srgbClr val="E2E8F0"/>
+            </a:solidFill>
+          </a:ln>
+        </p:spPr>
+        <p:style>
+          <a:lnRef idx="1">
+            <a:schemeClr val="accent1"/>
+          </a:lnRef>
+          <a:fillRef idx="3">
+            <a:schemeClr val="accent1"/>
+          </a:fillRef>
+          <a:effectRef idx="2">
+            <a:schemeClr val="accent1"/>
+          </a:effectRef>
+          <a:fontRef idx="minor">
+            <a:schemeClr val="lt1"/>
+          </a:fontRef>
+        </p:style>
+        <p:txBody>
+          <a:bodyPr rtlCol="0" anchor="ctr"/>
+          <a:lstStyle/>
+          <a:p>
+            <a:pPr algn="ctr"/>
+          </a:p>
+        </p:txBody>
+      </p:sp>
+      <p:sp>
+        <p:nvSpPr>
+          <p:cNvPr id="84" name="TextBox 83"/>
           <p:cNvSpPr txBox="1"/>
           <p:nvPr/>
         </p:nvSpPr>
         <p:spPr>
           <a:xfrm>
-            <a:off x="9326880" y="1965960"/>
-            <a:ext cx="914400" cy="182880"/>
+            <a:off x="3557016" y="5166360"/>
+            <a:ext cx="2331720" cy="228600"/>
+          </a:xfrm>
+          <a:prstGeom prst="rect">
+            <a:avLst/>
+          </a:prstGeom>
+          <a:noFill/>
+        </p:spPr>
+        <p:txBody>
+          <a:bodyPr wrap="square" lIns="0" tIns="0" rIns="0" bIns="0">
+            <a:spAutoFit/>
+          </a:bodyPr>
+          <a:lstStyle/>
+          <a:p>
+            <a:pPr algn="ctr"/>
+            <a:r>
+              <a:rPr sz="1300" b="1" i="0">
+                <a:solidFill>
+                  <a:srgbClr val="000000"/>
+                </a:solidFill>
+                <a:latin typeface="Plus Jakarta Sans"/>
+              </a:rPr>
+              <a:t>+412%</a:t>
+            </a:r>
+          </a:p>
+        </p:txBody>
+      </p:sp>
+      <p:sp>
+        <p:nvSpPr>
+          <p:cNvPr id="85" name="TextBox 84"/>
+          <p:cNvSpPr txBox="1"/>
+          <p:nvPr/>
+        </p:nvSpPr>
+        <p:spPr>
+          <a:xfrm>
+            <a:off x="3557016" y="5394960"/>
+            <a:ext cx="2331720" cy="320040"/>
           </a:xfrm>
           <a:prstGeom prst="rect">
             <a:avLst/>
@@ -14135,788 +14377,21 @@
                 </a:solidFill>
                 <a:latin typeface="JetBrains Mono"/>
               </a:rPr>
-              <a:t>SINGLE DRONE</a:t>
-            </a:r>
-          </a:p>
-        </p:txBody>
-      </p:sp>
-      <p:sp>
-        <p:nvSpPr>
-          <p:cNvPr id="80" name="TextBox 79"/>
-          <p:cNvSpPr txBox="1"/>
-          <p:nvPr/>
-        </p:nvSpPr>
-        <p:spPr>
-          <a:xfrm>
-            <a:off x="10241280" y="1965960"/>
-            <a:ext cx="1005840" cy="182880"/>
-          </a:xfrm>
-          <a:prstGeom prst="rect">
-            <a:avLst/>
-          </a:prstGeom>
-          <a:noFill/>
-        </p:spPr>
-        <p:txBody>
-          <a:bodyPr wrap="square" lIns="0" tIns="0" rIns="0" bIns="0">
-            <a:spAutoFit/>
-          </a:bodyPr>
-          <a:lstStyle/>
-          <a:p>
-            <a:pPr algn="ctr"/>
-            <a:r>
-              <a:rPr sz="750" b="1" i="0">
-                <a:solidFill>
-                  <a:srgbClr val="047857"/>
-                </a:solidFill>
-                <a:latin typeface="JetBrains Mono"/>
-              </a:rPr>
-              <a:t>AI SWARM</a:t>
-            </a:r>
-          </a:p>
-        </p:txBody>
-      </p:sp>
-      <p:sp>
-        <p:nvSpPr>
-          <p:cNvPr id="81" name="TextBox 80"/>
-          <p:cNvSpPr txBox="1"/>
-          <p:nvPr/>
-        </p:nvSpPr>
-        <p:spPr>
-          <a:xfrm>
-            <a:off x="6949440" y="2240280"/>
-            <a:ext cx="1645920" cy="274320"/>
-          </a:xfrm>
-          <a:prstGeom prst="rect">
-            <a:avLst/>
-          </a:prstGeom>
-          <a:noFill/>
-        </p:spPr>
-        <p:txBody>
-          <a:bodyPr wrap="square" lIns="0" tIns="0" rIns="0" bIns="0">
-            <a:spAutoFit/>
-          </a:bodyPr>
-          <a:lstStyle/>
-          <a:p>
-            <a:pPr algn="l"/>
-            <a:r>
-              <a:rPr sz="950" b="1" i="0">
-                <a:solidFill>
-                  <a:srgbClr val="000000"/>
-                </a:solidFill>
-                <a:latin typeface="Inter"/>
-              </a:rPr>
-              <a:t>Deployment Time</a:t>
-            </a:r>
-          </a:p>
-        </p:txBody>
-      </p:sp>
-      <p:sp>
-        <p:nvSpPr>
-          <p:cNvPr id="82" name="TextBox 81"/>
-          <p:cNvSpPr txBox="1"/>
-          <p:nvPr/>
-        </p:nvSpPr>
-        <p:spPr>
-          <a:xfrm>
-            <a:off x="8595360" y="2240280"/>
-            <a:ext cx="731520" cy="274320"/>
-          </a:xfrm>
-          <a:prstGeom prst="rect">
-            <a:avLst/>
-          </a:prstGeom>
-          <a:noFill/>
-        </p:spPr>
-        <p:txBody>
-          <a:bodyPr wrap="square" lIns="0" tIns="0" rIns="0" bIns="0">
-            <a:spAutoFit/>
-          </a:bodyPr>
-          <a:lstStyle/>
-          <a:p>
-            <a:pPr algn="ctr"/>
-            <a:r>
-              <a:rPr sz="850" b="0" i="0">
-                <a:solidFill>
-                  <a:srgbClr val="64748B"/>
-                </a:solidFill>
-                <a:latin typeface="JetBrains Mono"/>
-              </a:rPr>
-              <a:t>45-90 min</a:t>
-            </a:r>
-          </a:p>
-        </p:txBody>
-      </p:sp>
-      <p:sp>
-        <p:nvSpPr>
-          <p:cNvPr id="83" name="TextBox 82"/>
-          <p:cNvSpPr txBox="1"/>
-          <p:nvPr/>
-        </p:nvSpPr>
-        <p:spPr>
-          <a:xfrm>
-            <a:off x="9326880" y="2240280"/>
-            <a:ext cx="914400" cy="274320"/>
-          </a:xfrm>
-          <a:prstGeom prst="rect">
-            <a:avLst/>
-          </a:prstGeom>
-          <a:noFill/>
-        </p:spPr>
-        <p:txBody>
-          <a:bodyPr wrap="square" lIns="0" tIns="0" rIns="0" bIns="0">
-            <a:spAutoFit/>
-          </a:bodyPr>
-          <a:lstStyle/>
-          <a:p>
-            <a:pPr algn="ctr"/>
-            <a:r>
-              <a:rPr sz="850" b="0" i="0">
-                <a:solidFill>
-                  <a:srgbClr val="475569"/>
-                </a:solidFill>
-                <a:latin typeface="JetBrains Mono"/>
-              </a:rPr>
-              <a:t>15-30 min</a:t>
-            </a:r>
-          </a:p>
-        </p:txBody>
-      </p:sp>
-      <p:sp>
-        <p:nvSpPr>
-          <p:cNvPr id="84" name="Rounded Rectangle 83"/>
-          <p:cNvSpPr/>
-          <p:nvPr/>
-        </p:nvSpPr>
-        <p:spPr>
-          <a:xfrm>
-            <a:off x="10241280" y="2203704"/>
-            <a:ext cx="1005840" cy="274320"/>
-          </a:xfrm>
-          <a:prstGeom prst="roundRect">
-            <a:avLst/>
-          </a:prstGeom>
-          <a:solidFill>
-            <a:srgbClr val="DCFCE7"/>
-          </a:solidFill>
-          <a:ln>
-            <a:noFill/>
-          </a:ln>
-        </p:spPr>
-        <p:style>
-          <a:lnRef idx="1">
-            <a:schemeClr val="accent1"/>
-          </a:lnRef>
-          <a:fillRef idx="3">
-            <a:schemeClr val="accent1"/>
-          </a:fillRef>
-          <a:effectRef idx="2">
-            <a:schemeClr val="accent1"/>
-          </a:effectRef>
-          <a:fontRef idx="minor">
-            <a:schemeClr val="lt1"/>
-          </a:fontRef>
-        </p:style>
-        <p:txBody>
-          <a:bodyPr rtlCol="0" anchor="ctr"/>
-          <a:lstStyle/>
-          <a:p>
-            <a:pPr algn="ctr"/>
-          </a:p>
-        </p:txBody>
-      </p:sp>
-      <p:sp>
-        <p:nvSpPr>
-          <p:cNvPr id="85" name="TextBox 84"/>
-          <p:cNvSpPr txBox="1"/>
-          <p:nvPr/>
-        </p:nvSpPr>
-        <p:spPr>
-          <a:xfrm>
-            <a:off x="10241280" y="2240280"/>
-            <a:ext cx="1005840" cy="274320"/>
-          </a:xfrm>
-          <a:prstGeom prst="rect">
-            <a:avLst/>
-          </a:prstGeom>
-          <a:noFill/>
-        </p:spPr>
-        <p:txBody>
-          <a:bodyPr wrap="square" lIns="0" tIns="0" rIns="0" bIns="0">
-            <a:spAutoFit/>
-          </a:bodyPr>
-          <a:lstStyle/>
-          <a:p>
-            <a:pPr algn="ctr"/>
-            <a:r>
-              <a:rPr sz="850" b="1" i="0">
-                <a:solidFill>
-                  <a:srgbClr val="047857"/>
-                </a:solidFill>
-                <a:latin typeface="JetBrains Mono"/>
-              </a:rPr>
-              <a:t>8-15 min</a:t>
-            </a:r>
-          </a:p>
-        </p:txBody>
-      </p:sp>
-      <p:sp>
-        <p:nvSpPr>
-          <p:cNvPr id="86" name="TextBox 85"/>
-          <p:cNvSpPr txBox="1"/>
-          <p:nvPr/>
-        </p:nvSpPr>
-        <p:spPr>
-          <a:xfrm>
-            <a:off x="6949440" y="2679192"/>
-            <a:ext cx="1645920" cy="274320"/>
-          </a:xfrm>
-          <a:prstGeom prst="rect">
-            <a:avLst/>
-          </a:prstGeom>
-          <a:noFill/>
-        </p:spPr>
-        <p:txBody>
-          <a:bodyPr wrap="square" lIns="0" tIns="0" rIns="0" bIns="0">
-            <a:spAutoFit/>
-          </a:bodyPr>
-          <a:lstStyle/>
-          <a:p>
-            <a:pPr algn="l"/>
-            <a:r>
-              <a:rPr sz="950" b="1" i="0">
-                <a:solidFill>
-                  <a:srgbClr val="000000"/>
-                </a:solidFill>
-                <a:latin typeface="Inter"/>
-              </a:rPr>
-              <a:t>Area Coverage / mi²</a:t>
-            </a:r>
-          </a:p>
-        </p:txBody>
-      </p:sp>
-      <p:sp>
-        <p:nvSpPr>
-          <p:cNvPr id="87" name="TextBox 86"/>
-          <p:cNvSpPr txBox="1"/>
-          <p:nvPr/>
-        </p:nvSpPr>
-        <p:spPr>
-          <a:xfrm>
-            <a:off x="8595360" y="2679192"/>
-            <a:ext cx="731520" cy="274320"/>
-          </a:xfrm>
-          <a:prstGeom prst="rect">
-            <a:avLst/>
-          </a:prstGeom>
-          <a:noFill/>
-        </p:spPr>
-        <p:txBody>
-          <a:bodyPr wrap="square" lIns="0" tIns="0" rIns="0" bIns="0">
-            <a:spAutoFit/>
-          </a:bodyPr>
-          <a:lstStyle/>
-          <a:p>
-            <a:pPr algn="ctr"/>
-            <a:r>
-              <a:rPr sz="850" b="0" i="0">
-                <a:solidFill>
-                  <a:srgbClr val="64748B"/>
-                </a:solidFill>
-                <a:latin typeface="JetBrains Mono"/>
-              </a:rPr>
-              <a:t>2-3 hours</a:t>
-            </a:r>
-          </a:p>
-        </p:txBody>
-      </p:sp>
-      <p:sp>
-        <p:nvSpPr>
-          <p:cNvPr id="88" name="TextBox 87"/>
-          <p:cNvSpPr txBox="1"/>
-          <p:nvPr/>
-        </p:nvSpPr>
-        <p:spPr>
-          <a:xfrm>
-            <a:off x="9326880" y="2679192"/>
-            <a:ext cx="914400" cy="274320"/>
-          </a:xfrm>
-          <a:prstGeom prst="rect">
-            <a:avLst/>
-          </a:prstGeom>
-          <a:noFill/>
-        </p:spPr>
-        <p:txBody>
-          <a:bodyPr wrap="square" lIns="0" tIns="0" rIns="0" bIns="0">
-            <a:spAutoFit/>
-          </a:bodyPr>
-          <a:lstStyle/>
-          <a:p>
-            <a:pPr algn="ctr"/>
-            <a:r>
-              <a:rPr sz="850" b="0" i="0">
-                <a:solidFill>
-                  <a:srgbClr val="475569"/>
-                </a:solidFill>
-                <a:latin typeface="JetBrains Mono"/>
-              </a:rPr>
-              <a:t>45-60 min</a:t>
-            </a:r>
-          </a:p>
-        </p:txBody>
-      </p:sp>
-      <p:sp>
-        <p:nvSpPr>
-          <p:cNvPr id="89" name="Rounded Rectangle 88"/>
-          <p:cNvSpPr/>
-          <p:nvPr/>
-        </p:nvSpPr>
-        <p:spPr>
-          <a:xfrm>
-            <a:off x="10241280" y="2642616"/>
-            <a:ext cx="1005840" cy="274320"/>
-          </a:xfrm>
-          <a:prstGeom prst="roundRect">
-            <a:avLst/>
-          </a:prstGeom>
-          <a:solidFill>
-            <a:srgbClr val="DCFCE7"/>
-          </a:solidFill>
-          <a:ln>
-            <a:noFill/>
-          </a:ln>
-        </p:spPr>
-        <p:style>
-          <a:lnRef idx="1">
-            <a:schemeClr val="accent1"/>
-          </a:lnRef>
-          <a:fillRef idx="3">
-            <a:schemeClr val="accent1"/>
-          </a:fillRef>
-          <a:effectRef idx="2">
-            <a:schemeClr val="accent1"/>
-          </a:effectRef>
-          <a:fontRef idx="minor">
-            <a:schemeClr val="lt1"/>
-          </a:fontRef>
-        </p:style>
-        <p:txBody>
-          <a:bodyPr rtlCol="0" anchor="ctr"/>
-          <a:lstStyle/>
-          <a:p>
-            <a:pPr algn="ctr"/>
-          </a:p>
-        </p:txBody>
-      </p:sp>
-      <p:sp>
-        <p:nvSpPr>
-          <p:cNvPr id="90" name="TextBox 89"/>
-          <p:cNvSpPr txBox="1"/>
-          <p:nvPr/>
-        </p:nvSpPr>
-        <p:spPr>
-          <a:xfrm>
-            <a:off x="10241280" y="2679192"/>
-            <a:ext cx="1005840" cy="274320"/>
-          </a:xfrm>
-          <a:prstGeom prst="rect">
-            <a:avLst/>
-          </a:prstGeom>
-          <a:noFill/>
-        </p:spPr>
-        <p:txBody>
-          <a:bodyPr wrap="square" lIns="0" tIns="0" rIns="0" bIns="0">
-            <a:spAutoFit/>
-          </a:bodyPr>
-          <a:lstStyle/>
-          <a:p>
-            <a:pPr algn="ctr"/>
-            <a:r>
-              <a:rPr sz="850" b="1" i="0">
-                <a:solidFill>
-                  <a:srgbClr val="047857"/>
-                </a:solidFill>
-                <a:latin typeface="JetBrains Mono"/>
-              </a:rPr>
-              <a:t>10-18 min</a:t>
-            </a:r>
-          </a:p>
-        </p:txBody>
-      </p:sp>
-      <p:sp>
-        <p:nvSpPr>
-          <p:cNvPr id="91" name="TextBox 90"/>
-          <p:cNvSpPr txBox="1"/>
-          <p:nvPr/>
-        </p:nvSpPr>
-        <p:spPr>
-          <a:xfrm>
-            <a:off x="6949440" y="3118104"/>
-            <a:ext cx="1645920" cy="274320"/>
-          </a:xfrm>
-          <a:prstGeom prst="rect">
-            <a:avLst/>
-          </a:prstGeom>
-          <a:noFill/>
-        </p:spPr>
-        <p:txBody>
-          <a:bodyPr wrap="square" lIns="0" tIns="0" rIns="0" bIns="0">
-            <a:spAutoFit/>
-          </a:bodyPr>
-          <a:lstStyle/>
-          <a:p>
-            <a:pPr algn="l"/>
-            <a:r>
-              <a:rPr sz="950" b="1" i="0">
-                <a:solidFill>
-                  <a:srgbClr val="000000"/>
-                </a:solidFill>
-                <a:latin typeface="Inter"/>
-              </a:rPr>
-              <a:t>Detection Rate</a:t>
-            </a:r>
-          </a:p>
-        </p:txBody>
-      </p:sp>
-      <p:sp>
-        <p:nvSpPr>
-          <p:cNvPr id="92" name="TextBox 91"/>
-          <p:cNvSpPr txBox="1"/>
-          <p:nvPr/>
-        </p:nvSpPr>
-        <p:spPr>
-          <a:xfrm>
-            <a:off x="8595360" y="3118104"/>
-            <a:ext cx="731520" cy="274320"/>
-          </a:xfrm>
-          <a:prstGeom prst="rect">
-            <a:avLst/>
-          </a:prstGeom>
-          <a:noFill/>
-        </p:spPr>
-        <p:txBody>
-          <a:bodyPr wrap="square" lIns="0" tIns="0" rIns="0" bIns="0">
-            <a:spAutoFit/>
-          </a:bodyPr>
-          <a:lstStyle/>
-          <a:p>
-            <a:pPr algn="ctr"/>
-            <a:r>
-              <a:rPr sz="850" b="0" i="0">
-                <a:solidFill>
-                  <a:srgbClr val="64748B"/>
-                </a:solidFill>
-                <a:latin typeface="JetBrains Mono"/>
-              </a:rPr>
-              <a:t>65-70%</a:t>
-            </a:r>
-          </a:p>
-        </p:txBody>
-      </p:sp>
-      <p:sp>
-        <p:nvSpPr>
-          <p:cNvPr id="93" name="TextBox 92"/>
-          <p:cNvSpPr txBox="1"/>
-          <p:nvPr/>
-        </p:nvSpPr>
-        <p:spPr>
-          <a:xfrm>
-            <a:off x="9326880" y="3118104"/>
-            <a:ext cx="914400" cy="274320"/>
-          </a:xfrm>
-          <a:prstGeom prst="rect">
-            <a:avLst/>
-          </a:prstGeom>
-          <a:noFill/>
-        </p:spPr>
-        <p:txBody>
-          <a:bodyPr wrap="square" lIns="0" tIns="0" rIns="0" bIns="0">
-            <a:spAutoFit/>
-          </a:bodyPr>
-          <a:lstStyle/>
-          <a:p>
-            <a:pPr algn="ctr"/>
-            <a:r>
-              <a:rPr sz="850" b="0" i="0">
-                <a:solidFill>
-                  <a:srgbClr val="475569"/>
-                </a:solidFill>
-                <a:latin typeface="JetBrains Mono"/>
-              </a:rPr>
-              <a:t>55-65%</a:t>
-            </a:r>
-          </a:p>
-        </p:txBody>
-      </p:sp>
-      <p:sp>
-        <p:nvSpPr>
-          <p:cNvPr id="94" name="Rounded Rectangle 93"/>
-          <p:cNvSpPr/>
-          <p:nvPr/>
-        </p:nvSpPr>
-        <p:spPr>
-          <a:xfrm>
-            <a:off x="10241280" y="3081528"/>
-            <a:ext cx="1005840" cy="274320"/>
-          </a:xfrm>
-          <a:prstGeom prst="roundRect">
-            <a:avLst/>
-          </a:prstGeom>
-          <a:solidFill>
-            <a:srgbClr val="DCFCE7"/>
-          </a:solidFill>
-          <a:ln>
-            <a:noFill/>
-          </a:ln>
-        </p:spPr>
-        <p:style>
-          <a:lnRef idx="1">
-            <a:schemeClr val="accent1"/>
-          </a:lnRef>
-          <a:fillRef idx="3">
-            <a:schemeClr val="accent1"/>
-          </a:fillRef>
-          <a:effectRef idx="2">
-            <a:schemeClr val="accent1"/>
-          </a:effectRef>
-          <a:fontRef idx="minor">
-            <a:schemeClr val="lt1"/>
-          </a:fontRef>
-        </p:style>
-        <p:txBody>
-          <a:bodyPr rtlCol="0" anchor="ctr"/>
-          <a:lstStyle/>
-          <a:p>
-            <a:pPr algn="ctr"/>
-          </a:p>
-        </p:txBody>
-      </p:sp>
-      <p:sp>
-        <p:nvSpPr>
-          <p:cNvPr id="95" name="TextBox 94"/>
-          <p:cNvSpPr txBox="1"/>
-          <p:nvPr/>
-        </p:nvSpPr>
-        <p:spPr>
-          <a:xfrm>
-            <a:off x="10241280" y="3118104"/>
-            <a:ext cx="1005840" cy="274320"/>
-          </a:xfrm>
-          <a:prstGeom prst="rect">
-            <a:avLst/>
-          </a:prstGeom>
-          <a:noFill/>
-        </p:spPr>
-        <p:txBody>
-          <a:bodyPr wrap="square" lIns="0" tIns="0" rIns="0" bIns="0">
-            <a:spAutoFit/>
-          </a:bodyPr>
-          <a:lstStyle/>
-          <a:p>
-            <a:pPr algn="ctr"/>
-            <a:r>
-              <a:rPr sz="850" b="1" i="0">
-                <a:solidFill>
-                  <a:srgbClr val="047857"/>
-                </a:solidFill>
-                <a:latin typeface="JetBrains Mono"/>
-              </a:rPr>
-              <a:t>78-85%</a:t>
-            </a:r>
-          </a:p>
-        </p:txBody>
-      </p:sp>
-      <p:sp>
-        <p:nvSpPr>
-          <p:cNvPr id="96" name="TextBox 95"/>
-          <p:cNvSpPr txBox="1"/>
-          <p:nvPr/>
-        </p:nvSpPr>
-        <p:spPr>
-          <a:xfrm>
-            <a:off x="6949440" y="3557016"/>
-            <a:ext cx="1645920" cy="274320"/>
-          </a:xfrm>
-          <a:prstGeom prst="rect">
-            <a:avLst/>
-          </a:prstGeom>
-          <a:noFill/>
-        </p:spPr>
-        <p:txBody>
-          <a:bodyPr wrap="square" lIns="0" tIns="0" rIns="0" bIns="0">
-            <a:spAutoFit/>
-          </a:bodyPr>
-          <a:lstStyle/>
-          <a:p>
-            <a:pPr algn="l"/>
-            <a:r>
-              <a:rPr sz="950" b="1" i="0">
-                <a:solidFill>
-                  <a:srgbClr val="000000"/>
-                </a:solidFill>
-                <a:latin typeface="Inter"/>
-              </a:rPr>
-              <a:t>Personnel Required</a:t>
-            </a:r>
-          </a:p>
-        </p:txBody>
-      </p:sp>
-      <p:sp>
-        <p:nvSpPr>
-          <p:cNvPr id="97" name="TextBox 96"/>
-          <p:cNvSpPr txBox="1"/>
-          <p:nvPr/>
-        </p:nvSpPr>
-        <p:spPr>
-          <a:xfrm>
-            <a:off x="8595360" y="3557016"/>
-            <a:ext cx="731520" cy="274320"/>
-          </a:xfrm>
-          <a:prstGeom prst="rect">
-            <a:avLst/>
-          </a:prstGeom>
-          <a:noFill/>
-        </p:spPr>
-        <p:txBody>
-          <a:bodyPr wrap="square" lIns="0" tIns="0" rIns="0" bIns="0">
-            <a:spAutoFit/>
-          </a:bodyPr>
-          <a:lstStyle/>
-          <a:p>
-            <a:pPr algn="ctr"/>
-            <a:r>
-              <a:rPr sz="850" b="0" i="0">
-                <a:solidFill>
-                  <a:srgbClr val="64748B"/>
-                </a:solidFill>
-                <a:latin typeface="JetBrains Mono"/>
-              </a:rPr>
-              <a:t>15-25 crew</a:t>
-            </a:r>
-          </a:p>
-        </p:txBody>
-      </p:sp>
-      <p:sp>
-        <p:nvSpPr>
-          <p:cNvPr id="98" name="TextBox 97"/>
-          <p:cNvSpPr txBox="1"/>
-          <p:nvPr/>
-        </p:nvSpPr>
-        <p:spPr>
-          <a:xfrm>
-            <a:off x="9326880" y="3557016"/>
-            <a:ext cx="914400" cy="274320"/>
-          </a:xfrm>
-          <a:prstGeom prst="rect">
-            <a:avLst/>
-          </a:prstGeom>
-          <a:noFill/>
-        </p:spPr>
-        <p:txBody>
-          <a:bodyPr wrap="square" lIns="0" tIns="0" rIns="0" bIns="0">
-            <a:spAutoFit/>
-          </a:bodyPr>
-          <a:lstStyle/>
-          <a:p>
-            <a:pPr algn="ctr"/>
-            <a:r>
-              <a:rPr sz="850" b="0" i="0">
-                <a:solidFill>
-                  <a:srgbClr val="475569"/>
-                </a:solidFill>
-                <a:latin typeface="JetBrains Mono"/>
-              </a:rPr>
-              <a:t>2-3 pilots</a:t>
-            </a:r>
-          </a:p>
-        </p:txBody>
-      </p:sp>
-      <p:sp>
-        <p:nvSpPr>
-          <p:cNvPr id="99" name="Rounded Rectangle 98"/>
-          <p:cNvSpPr/>
-          <p:nvPr/>
-        </p:nvSpPr>
-        <p:spPr>
-          <a:xfrm>
-            <a:off x="10241280" y="3520440"/>
-            <a:ext cx="1005840" cy="274320"/>
-          </a:xfrm>
-          <a:prstGeom prst="roundRect">
-            <a:avLst/>
-          </a:prstGeom>
-          <a:solidFill>
-            <a:srgbClr val="DCFCE7"/>
-          </a:solidFill>
-          <a:ln>
-            <a:noFill/>
-          </a:ln>
-        </p:spPr>
-        <p:style>
-          <a:lnRef idx="1">
-            <a:schemeClr val="accent1"/>
-          </a:lnRef>
-          <a:fillRef idx="3">
-            <a:schemeClr val="accent1"/>
-          </a:fillRef>
-          <a:effectRef idx="2">
-            <a:schemeClr val="accent1"/>
-          </a:effectRef>
-          <a:fontRef idx="minor">
-            <a:schemeClr val="lt1"/>
-          </a:fontRef>
-        </p:style>
-        <p:txBody>
-          <a:bodyPr rtlCol="0" anchor="ctr"/>
-          <a:lstStyle/>
-          <a:p>
-            <a:pPr algn="ctr"/>
-          </a:p>
-        </p:txBody>
-      </p:sp>
-      <p:sp>
-        <p:nvSpPr>
-          <p:cNvPr id="100" name="TextBox 99"/>
-          <p:cNvSpPr txBox="1"/>
-          <p:nvPr/>
-        </p:nvSpPr>
-        <p:spPr>
-          <a:xfrm>
-            <a:off x="10241280" y="3557016"/>
-            <a:ext cx="1005840" cy="274320"/>
-          </a:xfrm>
-          <a:prstGeom prst="rect">
-            <a:avLst/>
-          </a:prstGeom>
-          <a:noFill/>
-        </p:spPr>
-        <p:txBody>
-          <a:bodyPr wrap="square" lIns="0" tIns="0" rIns="0" bIns="0">
-            <a:spAutoFit/>
-          </a:bodyPr>
-          <a:lstStyle/>
-          <a:p>
-            <a:pPr algn="ctr"/>
-            <a:r>
-              <a:rPr sz="850" b="1" i="0">
-                <a:solidFill>
-                  <a:srgbClr val="047857"/>
-                </a:solidFill>
-                <a:latin typeface="JetBrains Mono"/>
-              </a:rPr>
-              <a:t>1-2 operators</a:t>
-            </a:r>
-          </a:p>
-        </p:txBody>
-      </p:sp>
-      <p:sp>
-        <p:nvSpPr>
-          <p:cNvPr id="101" name="Rounded Rectangle 100"/>
-          <p:cNvSpPr/>
-          <p:nvPr/>
-        </p:nvSpPr>
-        <p:spPr>
-          <a:xfrm>
-            <a:off x="6766560" y="4389120"/>
-            <a:ext cx="4693615" cy="1280160"/>
+              <a:t>Disaster Surge in 20 Yrs</a:t>
+            </a:r>
+          </a:p>
+        </p:txBody>
+      </p:sp>
+      <p:sp>
+        <p:nvSpPr>
+          <p:cNvPr id="86" name="Rounded Rectangle 85"/>
+          <p:cNvSpPr/>
+          <p:nvPr/>
+        </p:nvSpPr>
+        <p:spPr>
+          <a:xfrm>
+            <a:off x="6199632" y="5120640"/>
+            <a:ext cx="2514600" cy="658368"/>
           </a:xfrm>
           <a:prstGeom prst="roundRect">
             <a:avLst/>
@@ -14954,14 +14429,14 @@
       </p:sp>
       <p:sp>
         <p:nvSpPr>
-          <p:cNvPr id="102" name="TextBox 101"/>
+          <p:cNvPr id="87" name="TextBox 86"/>
           <p:cNvSpPr txBox="1"/>
           <p:nvPr/>
         </p:nvSpPr>
         <p:spPr>
           <a:xfrm>
-            <a:off x="6949440" y="4480560"/>
-            <a:ext cx="3200400" cy="182880"/>
+            <a:off x="6291072" y="5166360"/>
+            <a:ext cx="2331720" cy="228600"/>
           </a:xfrm>
           <a:prstGeom prst="rect">
             <a:avLst/>
@@ -14974,29 +14449,29 @@
           </a:bodyPr>
           <a:lstStyle/>
           <a:p>
-            <a:pPr algn="l"/>
-            <a:r>
-              <a:rPr sz="750" b="1" i="0">
+            <a:pPr algn="ctr"/>
+            <a:r>
+              <a:rPr sz="1300" b="1" i="0">
                 <a:solidFill>
-                  <a:srgbClr val="94A3B8"/>
+                  <a:srgbClr val="000000"/>
                 </a:solidFill>
-                <a:latin typeface="JetBrains Mono"/>
+                <a:latin typeface="Plus Jakarta Sans"/>
               </a:rPr>
-              <a:t>SPEED COMPARISON (SQ MILES / HOUR)</a:t>
-            </a:r>
-          </a:p>
-        </p:txBody>
-      </p:sp>
-      <p:sp>
-        <p:nvSpPr>
-          <p:cNvPr id="103" name="TextBox 102"/>
+              <a:t>37 Nations</a:t>
+            </a:r>
+          </a:p>
+        </p:txBody>
+      </p:sp>
+      <p:sp>
+        <p:nvSpPr>
+          <p:cNvPr id="88" name="TextBox 87"/>
           <p:cNvSpPr txBox="1"/>
           <p:nvPr/>
         </p:nvSpPr>
         <p:spPr>
           <a:xfrm>
-            <a:off x="9601200" y="4480560"/>
-            <a:ext cx="1645920" cy="182880"/>
+            <a:off x="6291072" y="5394960"/>
+            <a:ext cx="2331720" cy="320040"/>
           </a:xfrm>
           <a:prstGeom prst="rect">
             <a:avLst/>
@@ -15009,42 +14484,7 @@
           </a:bodyPr>
           <a:lstStyle/>
           <a:p>
-            <a:pPr algn="r"/>
-            <a:r>
-              <a:rPr sz="750" b="1" i="0">
-                <a:solidFill>
-                  <a:srgbClr val="047857"/>
-                </a:solidFill>
-                <a:latin typeface="JetBrains Mono"/>
-              </a:rPr>
-              <a:t>3-4X FASTER COVERAGE</a:t>
-            </a:r>
-          </a:p>
-        </p:txBody>
-      </p:sp>
-      <p:sp>
-        <p:nvSpPr>
-          <p:cNvPr id="104" name="TextBox 103"/>
-          <p:cNvSpPr txBox="1"/>
-          <p:nvPr/>
-        </p:nvSpPr>
-        <p:spPr>
-          <a:xfrm>
-            <a:off x="6949440" y="4709160"/>
-            <a:ext cx="1097280" cy="182880"/>
-          </a:xfrm>
-          <a:prstGeom prst="rect">
-            <a:avLst/>
-          </a:prstGeom>
-          <a:noFill/>
-        </p:spPr>
-        <p:txBody>
-          <a:bodyPr wrap="square" lIns="0" tIns="0" rIns="0" bIns="0">
-            <a:spAutoFit/>
-          </a:bodyPr>
-          <a:lstStyle/>
-          <a:p>
-            <a:pPr algn="l"/>
+            <a:pPr algn="ctr"/>
             <a:r>
               <a:rPr sz="700" b="0" i="0">
                 <a:solidFill>
@@ -15052,64 +14492,66 @@
                 </a:solidFill>
                 <a:latin typeface="JetBrains Mono"/>
               </a:rPr>
-              <a:t>Traditional Ground</a:t>
-            </a:r>
-          </a:p>
-        </p:txBody>
-      </p:sp>
-      <p:sp>
-        <p:nvSpPr>
-          <p:cNvPr id="105" name="Rounded Rectangle 104"/>
-          <p:cNvSpPr/>
-          <p:nvPr/>
-        </p:nvSpPr>
-        <p:spPr>
-          <a:xfrm>
-            <a:off x="8138160" y="4754880"/>
-            <a:ext cx="365760" cy="91440"/>
+              <a:t>Mandating SAR Drones</a:t>
+            </a:r>
+          </a:p>
+        </p:txBody>
+      </p:sp>
+      <p:sp>
+        <p:nvSpPr>
+          <p:cNvPr id="89" name="Rounded Rectangle 88"/>
+          <p:cNvSpPr/>
+          <p:nvPr/>
+        </p:nvSpPr>
+        <p:spPr>
+          <a:xfrm>
+            <a:off x="8933688" y="5120640"/>
+            <a:ext cx="2514600" cy="658368"/>
           </a:xfrm>
           <a:prstGeom prst="roundRect">
             <a:avLst/>
           </a:prstGeom>
           <a:solidFill>
-            <a:srgbClr val="94A3B8"/>
-          </a:solidFill>
-          <a:ln>
-            <a:noFill/>
-          </a:ln>
-        </p:spPr>
-        <p:style>
-          <a:lnRef idx="1">
-            <a:schemeClr val="accent1"/>
-          </a:lnRef>
-          <a:fillRef idx="3">
-            <a:schemeClr val="accent1"/>
-          </a:fillRef>
-          <a:effectRef idx="2">
-            <a:schemeClr val="accent1"/>
-          </a:effectRef>
-          <a:fontRef idx="minor">
-            <a:schemeClr val="lt1"/>
-          </a:fontRef>
-        </p:style>
-        <p:txBody>
-          <a:bodyPr rtlCol="0" anchor="ctr"/>
-          <a:lstStyle/>
-          <a:p>
-            <a:pPr algn="ctr"/>
-          </a:p>
-        </p:txBody>
-      </p:sp>
-      <p:sp>
-        <p:nvSpPr>
-          <p:cNvPr id="106" name="TextBox 105"/>
+            <a:srgbClr val="F8FAFC"/>
+          </a:solidFill>
+          <a:ln w="12700">
+            <a:solidFill>
+              <a:srgbClr val="E2E8F0"/>
+            </a:solidFill>
+          </a:ln>
+        </p:spPr>
+        <p:style>
+          <a:lnRef idx="1">
+            <a:schemeClr val="accent1"/>
+          </a:lnRef>
+          <a:fillRef idx="3">
+            <a:schemeClr val="accent1"/>
+          </a:fillRef>
+          <a:effectRef idx="2">
+            <a:schemeClr val="accent1"/>
+          </a:effectRef>
+          <a:fontRef idx="minor">
+            <a:schemeClr val="lt1"/>
+          </a:fontRef>
+        </p:style>
+        <p:txBody>
+          <a:bodyPr rtlCol="0" anchor="ctr"/>
+          <a:lstStyle/>
+          <a:p>
+            <a:pPr algn="ctr"/>
+          </a:p>
+        </p:txBody>
+      </p:sp>
+      <p:sp>
+        <p:nvSpPr>
+          <p:cNvPr id="90" name="TextBox 89"/>
           <p:cNvSpPr txBox="1"/>
           <p:nvPr/>
         </p:nvSpPr>
         <p:spPr>
           <a:xfrm>
-            <a:off x="10789920" y="4709160"/>
-            <a:ext cx="548640" cy="182880"/>
+            <a:off x="9025128" y="5166360"/>
+            <a:ext cx="2331720" cy="228600"/>
           </a:xfrm>
           <a:prstGeom prst="rect">
             <a:avLst/>
@@ -15122,7 +14564,42 @@
           </a:bodyPr>
           <a:lstStyle/>
           <a:p>
-            <a:pPr algn="r"/>
+            <a:pPr algn="ctr"/>
+            <a:r>
+              <a:rPr sz="1300" b="1" i="0">
+                <a:solidFill>
+                  <a:srgbClr val="000000"/>
+                </a:solidFill>
+                <a:latin typeface="Plus Jakarta Sans"/>
+              </a:rPr>
+              <a:t>$180M</a:t>
+            </a:r>
+          </a:p>
+        </p:txBody>
+      </p:sp>
+      <p:sp>
+        <p:nvSpPr>
+          <p:cNvPr id="91" name="TextBox 90"/>
+          <p:cNvSpPr txBox="1"/>
+          <p:nvPr/>
+        </p:nvSpPr>
+        <p:spPr>
+          <a:xfrm>
+            <a:off x="9025128" y="5394960"/>
+            <a:ext cx="2331720" cy="320040"/>
+          </a:xfrm>
+          <a:prstGeom prst="rect">
+            <a:avLst/>
+          </a:prstGeom>
+          <a:noFill/>
+        </p:spPr>
+        <p:txBody>
+          <a:bodyPr wrap="square" lIns="0" tIns="0" rIns="0" bIns="0">
+            <a:spAutoFit/>
+          </a:bodyPr>
+          <a:lstStyle/>
+          <a:p>
+            <a:pPr algn="ctr"/>
             <a:r>
               <a:rPr sz="700" b="0" i="0">
                 <a:solidFill>
@@ -15130,240 +14607,14 @@
                 </a:solidFill>
                 <a:latin typeface="JetBrains Mono"/>
               </a:rPr>
-              <a:t>0.4 mi²</a:t>
-            </a:r>
-          </a:p>
-        </p:txBody>
-      </p:sp>
-      <p:sp>
-        <p:nvSpPr>
-          <p:cNvPr id="107" name="TextBox 106"/>
-          <p:cNvSpPr txBox="1"/>
-          <p:nvPr/>
-        </p:nvSpPr>
-        <p:spPr>
-          <a:xfrm>
-            <a:off x="6949440" y="4937760"/>
-            <a:ext cx="1097280" cy="182880"/>
-          </a:xfrm>
-          <a:prstGeom prst="rect">
-            <a:avLst/>
-          </a:prstGeom>
-          <a:noFill/>
-        </p:spPr>
-        <p:txBody>
-          <a:bodyPr wrap="square" lIns="0" tIns="0" rIns="0" bIns="0">
-            <a:spAutoFit/>
-          </a:bodyPr>
-          <a:lstStyle/>
-          <a:p>
-            <a:pPr algn="l"/>
-            <a:r>
-              <a:rPr sz="700" b="0" i="0">
-                <a:solidFill>
-                  <a:srgbClr val="64748B"/>
-                </a:solidFill>
-                <a:latin typeface="JetBrains Mono"/>
-              </a:rPr>
-              <a:t>Single Drone</a:t>
-            </a:r>
-          </a:p>
-        </p:txBody>
-      </p:sp>
-      <p:sp>
-        <p:nvSpPr>
-          <p:cNvPr id="108" name="Rounded Rectangle 107"/>
-          <p:cNvSpPr/>
-          <p:nvPr/>
-        </p:nvSpPr>
-        <p:spPr>
-          <a:xfrm>
-            <a:off x="8138160" y="4983480"/>
-            <a:ext cx="1097280" cy="91440"/>
-          </a:xfrm>
-          <a:prstGeom prst="roundRect">
-            <a:avLst/>
-          </a:prstGeom>
-          <a:solidFill>
-            <a:srgbClr val="475569"/>
-          </a:solidFill>
-          <a:ln>
-            <a:noFill/>
-          </a:ln>
-        </p:spPr>
-        <p:style>
-          <a:lnRef idx="1">
-            <a:schemeClr val="accent1"/>
-          </a:lnRef>
-          <a:fillRef idx="3">
-            <a:schemeClr val="accent1"/>
-          </a:fillRef>
-          <a:effectRef idx="2">
-            <a:schemeClr val="accent1"/>
-          </a:effectRef>
-          <a:fontRef idx="minor">
-            <a:schemeClr val="lt1"/>
-          </a:fontRef>
-        </p:style>
-        <p:txBody>
-          <a:bodyPr rtlCol="0" anchor="ctr"/>
-          <a:lstStyle/>
-          <a:p>
-            <a:pPr algn="ctr"/>
-          </a:p>
-        </p:txBody>
-      </p:sp>
-      <p:sp>
-        <p:nvSpPr>
-          <p:cNvPr id="109" name="TextBox 108"/>
-          <p:cNvSpPr txBox="1"/>
-          <p:nvPr/>
-        </p:nvSpPr>
-        <p:spPr>
-          <a:xfrm>
-            <a:off x="10789920" y="4937760"/>
-            <a:ext cx="548640" cy="182880"/>
-          </a:xfrm>
-          <a:prstGeom prst="rect">
-            <a:avLst/>
-          </a:prstGeom>
-          <a:noFill/>
-        </p:spPr>
-        <p:txBody>
-          <a:bodyPr wrap="square" lIns="0" tIns="0" rIns="0" bIns="0">
-            <a:spAutoFit/>
-          </a:bodyPr>
-          <a:lstStyle/>
-          <a:p>
-            <a:pPr algn="r"/>
-            <a:r>
-              <a:rPr sz="700" b="0" i="0">
-                <a:solidFill>
-                  <a:srgbClr val="64748B"/>
-                </a:solidFill>
-                <a:latin typeface="JetBrains Mono"/>
-              </a:rPr>
-              <a:t>1.2 mi²</a:t>
-            </a:r>
-          </a:p>
-        </p:txBody>
-      </p:sp>
-      <p:sp>
-        <p:nvSpPr>
-          <p:cNvPr id="110" name="TextBox 109"/>
-          <p:cNvSpPr txBox="1"/>
-          <p:nvPr/>
-        </p:nvSpPr>
-        <p:spPr>
-          <a:xfrm>
-            <a:off x="6949440" y="5166360"/>
-            <a:ext cx="1097280" cy="182880"/>
-          </a:xfrm>
-          <a:prstGeom prst="rect">
-            <a:avLst/>
-          </a:prstGeom>
-          <a:noFill/>
-        </p:spPr>
-        <p:txBody>
-          <a:bodyPr wrap="square" lIns="0" tIns="0" rIns="0" bIns="0">
-            <a:spAutoFit/>
-          </a:bodyPr>
-          <a:lstStyle/>
-          <a:p>
-            <a:pPr algn="l"/>
-            <a:r>
-              <a:rPr sz="750" b="1" i="0">
-                <a:solidFill>
-                  <a:srgbClr val="000000"/>
-                </a:solidFill>
-                <a:latin typeface="JetBrains Mono"/>
-              </a:rPr>
-              <a:t>AI Swarm (SUTRA)</a:t>
-            </a:r>
-          </a:p>
-        </p:txBody>
-      </p:sp>
-      <p:sp>
-        <p:nvSpPr>
-          <p:cNvPr id="111" name="Rounded Rectangle 110"/>
-          <p:cNvSpPr/>
-          <p:nvPr/>
-        </p:nvSpPr>
-        <p:spPr>
-          <a:xfrm>
-            <a:off x="8138160" y="5212080"/>
-            <a:ext cx="2743200" cy="128016"/>
-          </a:xfrm>
-          <a:prstGeom prst="roundRect">
-            <a:avLst/>
-          </a:prstGeom>
-          <a:solidFill>
-            <a:srgbClr val="047857"/>
-          </a:solidFill>
-          <a:ln>
-            <a:noFill/>
-          </a:ln>
-        </p:spPr>
-        <p:style>
-          <a:lnRef idx="1">
-            <a:schemeClr val="accent1"/>
-          </a:lnRef>
-          <a:fillRef idx="3">
-            <a:schemeClr val="accent1"/>
-          </a:fillRef>
-          <a:effectRef idx="2">
-            <a:schemeClr val="accent1"/>
-          </a:effectRef>
-          <a:fontRef idx="minor">
-            <a:schemeClr val="lt1"/>
-          </a:fontRef>
-        </p:style>
-        <p:txBody>
-          <a:bodyPr rtlCol="0" anchor="ctr"/>
-          <a:lstStyle/>
-          <a:p>
-            <a:pPr algn="ctr"/>
-          </a:p>
-        </p:txBody>
-      </p:sp>
-      <p:sp>
-        <p:nvSpPr>
-          <p:cNvPr id="112" name="TextBox 111"/>
-          <p:cNvSpPr txBox="1"/>
-          <p:nvPr/>
-        </p:nvSpPr>
-        <p:spPr>
-          <a:xfrm>
-            <a:off x="10789920" y="5166360"/>
-            <a:ext cx="548640" cy="182880"/>
-          </a:xfrm>
-          <a:prstGeom prst="rect">
-            <a:avLst/>
-          </a:prstGeom>
-          <a:noFill/>
-        </p:spPr>
-        <p:txBody>
-          <a:bodyPr wrap="square" lIns="0" tIns="0" rIns="0" bIns="0">
-            <a:spAutoFit/>
-          </a:bodyPr>
-          <a:lstStyle/>
-          <a:p>
-            <a:pPr algn="r"/>
-            <a:r>
-              <a:rPr sz="750" b="1" i="0">
-                <a:solidFill>
-                  <a:srgbClr val="047857"/>
-                </a:solidFill>
-                <a:latin typeface="JetBrains Mono"/>
-              </a:rPr>
-              <a:t>4.5 mi²</a:t>
-            </a:r>
-          </a:p>
-        </p:txBody>
-      </p:sp>
-      <p:sp>
-        <p:nvSpPr>
-          <p:cNvPr id="113" name="Rectangle 112"/>
+              <a:t>FEMA 2025 Allocation</a:t>
+            </a:r>
+          </a:p>
+        </p:txBody>
+      </p:sp>
+      <p:sp>
+        <p:nvSpPr>
+          <p:cNvPr id="92" name="Rectangle 91"/>
           <p:cNvSpPr/>
           <p:nvPr/>
         </p:nvSpPr>
@@ -15406,7 +14657,7 @@
       </p:sp>
       <p:sp>
         <p:nvSpPr>
-          <p:cNvPr id="114" name="TextBox 113"/>
+          <p:cNvPr id="93" name="TextBox 92"/>
           <p:cNvSpPr txBox="1"/>
           <p:nvPr/>
         </p:nvSpPr>
@@ -15441,7 +14692,7 @@
       </p:sp>
       <p:sp>
         <p:nvSpPr>
-          <p:cNvPr id="115" name="TextBox 114"/>
+          <p:cNvPr id="94" name="TextBox 93"/>
           <p:cNvSpPr txBox="1"/>
           <p:nvPr/>
         </p:nvSpPr>

</xml_diff>

<commit_message>
feat(slides): spatial 4-subsystem pillar layout across Slide 3 with voids solved and empirical moats
</commit_message>
<xml_diff>
--- a/sutra_pitch_deck.pptx
+++ b/sutra_pitch_deck.pptx
@@ -12696,8 +12696,8 @@
         </p:nvSpPr>
         <p:spPr>
           <a:xfrm>
-            <a:off x="731520" y="502920"/>
-            <a:ext cx="73152" cy="292608"/>
+            <a:off x="731520" y="438912"/>
+            <a:ext cx="73152" cy="274320"/>
           </a:xfrm>
           <a:prstGeom prst="roundRect">
             <a:avLst/>
@@ -12739,7 +12739,7 @@
         </p:nvSpPr>
         <p:spPr>
           <a:xfrm>
-            <a:off x="896112" y="530352"/>
+            <a:off x="877824" y="457200"/>
             <a:ext cx="5486400" cy="274320"/>
           </a:xfrm>
           <a:prstGeom prst="rect">
@@ -12761,7 +12761,7 @@
                 </a:solidFill>
                 <a:latin typeface="JetBrains Mono"/>
               </a:rPr>
-              <a:t>THE SOLUTION — SUBSYSTEM MOATS</a:t>
+              <a:t>THE SOLUTION — 4 CORE SUBSYSTEM MOATS</a:t>
             </a:r>
           </a:p>
         </p:txBody>
@@ -12774,8 +12774,8 @@
         </p:nvSpPr>
         <p:spPr>
           <a:xfrm>
-            <a:off x="8961120" y="502920"/>
-            <a:ext cx="2468880" cy="292608"/>
+            <a:off x="8961120" y="438912"/>
+            <a:ext cx="2468880" cy="274320"/>
           </a:xfrm>
           <a:prstGeom prst="roundRect">
             <a:avLst/>
@@ -12819,7 +12819,7 @@
         </p:nvSpPr>
         <p:spPr>
           <a:xfrm>
-            <a:off x="9098280" y="603504"/>
+            <a:off x="9098280" y="530352"/>
             <a:ext cx="73152" cy="73152"/>
           </a:xfrm>
           <a:prstGeom prst="ellipse">
@@ -12862,7 +12862,7 @@
         </p:nvSpPr>
         <p:spPr>
           <a:xfrm>
-            <a:off x="9235440" y="548640"/>
+            <a:off x="9235440" y="475488"/>
             <a:ext cx="2103120" cy="201168"/>
           </a:xfrm>
           <a:prstGeom prst="rect">
@@ -12884,7 +12884,7 @@
                 </a:solidFill>
                 <a:latin typeface="JetBrains Mono"/>
               </a:rPr>
-              <a:t>SWARM SEARCH EFFICIENCY</a:t>
+              <a:t>SWARM ARCHITECTURE</a:t>
             </a:r>
           </a:p>
         </p:txBody>
@@ -12897,8 +12897,8 @@
         </p:nvSpPr>
         <p:spPr>
           <a:xfrm>
-            <a:off x="731520" y="1051560"/>
-            <a:ext cx="10515600" cy="594360"/>
+            <a:off x="731520" y="868680"/>
+            <a:ext cx="6858000" cy="594360"/>
           </a:xfrm>
           <a:prstGeom prst="rect">
             <a:avLst/>
@@ -12913,7 +12913,7 @@
           <a:p>
             <a:pPr algn="l"/>
             <a:r>
-              <a:rPr sz="2200" b="1" i="0">
+              <a:rPr sz="2100" b="1" i="0">
                 <a:solidFill>
                   <a:srgbClr val="09090B"/>
                 </a:solidFill>
@@ -12926,14 +12926,59 @@
       </p:sp>
       <p:sp>
         <p:nvSpPr>
-          <p:cNvPr id="48" name="TextBox 47"/>
+          <p:cNvPr id="48" name="Rounded Rectangle 47"/>
+          <p:cNvSpPr/>
+          <p:nvPr/>
+        </p:nvSpPr>
+        <p:spPr>
+          <a:xfrm>
+            <a:off x="7589520" y="960120"/>
+            <a:ext cx="960120" cy="274320"/>
+          </a:xfrm>
+          <a:prstGeom prst="roundRect">
+            <a:avLst/>
+          </a:prstGeom>
+          <a:solidFill>
+            <a:srgbClr val="F8FAFC"/>
+          </a:solidFill>
+          <a:ln w="12700">
+            <a:solidFill>
+              <a:srgbClr val="E4E4E7"/>
+            </a:solidFill>
+          </a:ln>
+        </p:spPr>
+        <p:style>
+          <a:lnRef idx="1">
+            <a:schemeClr val="accent1"/>
+          </a:lnRef>
+          <a:fillRef idx="3">
+            <a:schemeClr val="accent1"/>
+          </a:fillRef>
+          <a:effectRef idx="2">
+            <a:schemeClr val="accent1"/>
+          </a:effectRef>
+          <a:fontRef idx="minor">
+            <a:schemeClr val="lt1"/>
+          </a:fontRef>
+        </p:style>
+        <p:txBody>
+          <a:bodyPr rtlCol="0" anchor="ctr"/>
+          <a:lstStyle/>
+          <a:p>
+            <a:pPr algn="ctr"/>
+          </a:p>
+        </p:txBody>
+      </p:sp>
+      <p:sp>
+        <p:nvSpPr>
+          <p:cNvPr id="49" name="TextBox 48"/>
           <p:cNvSpPr txBox="1"/>
           <p:nvPr/>
         </p:nvSpPr>
         <p:spPr>
           <a:xfrm>
-            <a:off x="731520" y="1783080"/>
-            <a:ext cx="4114800" cy="182880"/>
+            <a:off x="7589520" y="1005840"/>
+            <a:ext cx="960120" cy="182880"/>
           </a:xfrm>
           <a:prstGeom prst="rect">
             <a:avLst/>
@@ -12946,39 +12991,359 @@
           </a:bodyPr>
           <a:lstStyle/>
           <a:p>
+            <a:pPr algn="ctr"/>
+            <a:r>
+              <a:rPr sz="600" b="1" i="0">
+                <a:solidFill>
+                  <a:srgbClr val="475569"/>
+                </a:solidFill>
+                <a:latin typeface="JetBrains Mono"/>
+              </a:rPr>
+              <a:t>10-18 MIN/MI²</a:t>
+            </a:r>
+          </a:p>
+        </p:txBody>
+      </p:sp>
+      <p:sp>
+        <p:nvSpPr>
+          <p:cNvPr id="50" name="Rounded Rectangle 49"/>
+          <p:cNvSpPr/>
+          <p:nvPr/>
+        </p:nvSpPr>
+        <p:spPr>
+          <a:xfrm>
+            <a:off x="8595360" y="960120"/>
+            <a:ext cx="960120" cy="274320"/>
+          </a:xfrm>
+          <a:prstGeom prst="roundRect">
+            <a:avLst/>
+          </a:prstGeom>
+          <a:solidFill>
+            <a:srgbClr val="ECFDF5"/>
+          </a:solidFill>
+          <a:ln w="12700">
+            <a:solidFill>
+              <a:srgbClr val="E4E4E7"/>
+            </a:solidFill>
+          </a:ln>
+        </p:spPr>
+        <p:style>
+          <a:lnRef idx="1">
+            <a:schemeClr val="accent1"/>
+          </a:lnRef>
+          <a:fillRef idx="3">
+            <a:schemeClr val="accent1"/>
+          </a:fillRef>
+          <a:effectRef idx="2">
+            <a:schemeClr val="accent1"/>
+          </a:effectRef>
+          <a:fontRef idx="minor">
+            <a:schemeClr val="lt1"/>
+          </a:fontRef>
+        </p:style>
+        <p:txBody>
+          <a:bodyPr rtlCol="0" anchor="ctr"/>
+          <a:lstStyle/>
+          <a:p>
+            <a:pPr algn="ctr"/>
+          </a:p>
+        </p:txBody>
+      </p:sp>
+      <p:sp>
+        <p:nvSpPr>
+          <p:cNvPr id="51" name="TextBox 50"/>
+          <p:cNvSpPr txBox="1"/>
+          <p:nvPr/>
+        </p:nvSpPr>
+        <p:spPr>
+          <a:xfrm>
+            <a:off x="8595360" y="1005840"/>
+            <a:ext cx="960120" cy="182880"/>
+          </a:xfrm>
+          <a:prstGeom prst="rect">
+            <a:avLst/>
+          </a:prstGeom>
+          <a:noFill/>
+        </p:spPr>
+        <p:txBody>
+          <a:bodyPr wrap="square" lIns="0" tIns="0" rIns="0" bIns="0">
+            <a:spAutoFit/>
+          </a:bodyPr>
+          <a:lstStyle/>
+          <a:p>
+            <a:pPr algn="ctr"/>
+            <a:r>
+              <a:rPr sz="600" b="1" i="0">
+                <a:solidFill>
+                  <a:srgbClr val="047857"/>
+                </a:solidFill>
+                <a:latin typeface="JetBrains Mono"/>
+              </a:rPr>
+              <a:t>78-85% DETECTION</a:t>
+            </a:r>
+          </a:p>
+        </p:txBody>
+      </p:sp>
+      <p:sp>
+        <p:nvSpPr>
+          <p:cNvPr id="52" name="Rounded Rectangle 51"/>
+          <p:cNvSpPr/>
+          <p:nvPr/>
+        </p:nvSpPr>
+        <p:spPr>
+          <a:xfrm>
+            <a:off x="9601200" y="960120"/>
+            <a:ext cx="960120" cy="274320"/>
+          </a:xfrm>
+          <a:prstGeom prst="roundRect">
+            <a:avLst/>
+          </a:prstGeom>
+          <a:solidFill>
+            <a:srgbClr val="F8FAFC"/>
+          </a:solidFill>
+          <a:ln w="12700">
+            <a:solidFill>
+              <a:srgbClr val="E4E4E7"/>
+            </a:solidFill>
+          </a:ln>
+        </p:spPr>
+        <p:style>
+          <a:lnRef idx="1">
+            <a:schemeClr val="accent1"/>
+          </a:lnRef>
+          <a:fillRef idx="3">
+            <a:schemeClr val="accent1"/>
+          </a:fillRef>
+          <a:effectRef idx="2">
+            <a:schemeClr val="accent1"/>
+          </a:effectRef>
+          <a:fontRef idx="minor">
+            <a:schemeClr val="lt1"/>
+          </a:fontRef>
+        </p:style>
+        <p:txBody>
+          <a:bodyPr rtlCol="0" anchor="ctr"/>
+          <a:lstStyle/>
+          <a:p>
+            <a:pPr algn="ctr"/>
+          </a:p>
+        </p:txBody>
+      </p:sp>
+      <p:sp>
+        <p:nvSpPr>
+          <p:cNvPr id="53" name="TextBox 52"/>
+          <p:cNvSpPr txBox="1"/>
+          <p:nvPr/>
+        </p:nvSpPr>
+        <p:spPr>
+          <a:xfrm>
+            <a:off x="9601200" y="1005840"/>
+            <a:ext cx="960120" cy="182880"/>
+          </a:xfrm>
+          <a:prstGeom prst="rect">
+            <a:avLst/>
+          </a:prstGeom>
+          <a:noFill/>
+        </p:spPr>
+        <p:txBody>
+          <a:bodyPr wrap="square" lIns="0" tIns="0" rIns="0" bIns="0">
+            <a:spAutoFit/>
+          </a:bodyPr>
+          <a:lstStyle/>
+          <a:p>
+            <a:pPr algn="ctr"/>
+            <a:r>
+              <a:rPr sz="600" b="1" i="0">
+                <a:solidFill>
+                  <a:srgbClr val="475569"/>
+                </a:solidFill>
+                <a:latin typeface="JetBrains Mono"/>
+              </a:rPr>
+              <a:t>12% FALSE POSITIVES</a:t>
+            </a:r>
+          </a:p>
+        </p:txBody>
+      </p:sp>
+      <p:sp>
+        <p:nvSpPr>
+          <p:cNvPr id="54" name="Rounded Rectangle 53"/>
+          <p:cNvSpPr/>
+          <p:nvPr/>
+        </p:nvSpPr>
+        <p:spPr>
+          <a:xfrm>
+            <a:off x="10607040" y="960120"/>
+            <a:ext cx="960120" cy="274320"/>
+          </a:xfrm>
+          <a:prstGeom prst="roundRect">
+            <a:avLst/>
+          </a:prstGeom>
+          <a:solidFill>
+            <a:srgbClr val="ECFDF5"/>
+          </a:solidFill>
+          <a:ln w="12700">
+            <a:solidFill>
+              <a:srgbClr val="E4E4E7"/>
+            </a:solidFill>
+          </a:ln>
+        </p:spPr>
+        <p:style>
+          <a:lnRef idx="1">
+            <a:schemeClr val="accent1"/>
+          </a:lnRef>
+          <a:fillRef idx="3">
+            <a:schemeClr val="accent1"/>
+          </a:fillRef>
+          <a:effectRef idx="2">
+            <a:schemeClr val="accent1"/>
+          </a:effectRef>
+          <a:fontRef idx="minor">
+            <a:schemeClr val="lt1"/>
+          </a:fontRef>
+        </p:style>
+        <p:txBody>
+          <a:bodyPr rtlCol="0" anchor="ctr"/>
+          <a:lstStyle/>
+          <a:p>
+            <a:pPr algn="ctr"/>
+          </a:p>
+        </p:txBody>
+      </p:sp>
+      <p:sp>
+        <p:nvSpPr>
+          <p:cNvPr id="55" name="TextBox 54"/>
+          <p:cNvSpPr txBox="1"/>
+          <p:nvPr/>
+        </p:nvSpPr>
+        <p:spPr>
+          <a:xfrm>
+            <a:off x="10607040" y="1005840"/>
+            <a:ext cx="960120" cy="182880"/>
+          </a:xfrm>
+          <a:prstGeom prst="rect">
+            <a:avLst/>
+          </a:prstGeom>
+          <a:noFill/>
+        </p:spPr>
+        <p:txBody>
+          <a:bodyPr wrap="square" lIns="0" tIns="0" rIns="0" bIns="0">
+            <a:spAutoFit/>
+          </a:bodyPr>
+          <a:lstStyle/>
+          <a:p>
+            <a:pPr algn="ctr"/>
+            <a:r>
+              <a:rPr sz="600" b="1" i="0">
+                <a:solidFill>
+                  <a:srgbClr val="047857"/>
+                </a:solidFill>
+                <a:latin typeface="JetBrains Mono"/>
+              </a:rPr>
+              <a:t>$12K SORTIE</a:t>
+            </a:r>
+          </a:p>
+        </p:txBody>
+      </p:sp>
+      <p:sp>
+        <p:nvSpPr>
+          <p:cNvPr id="56" name="Rounded Rectangle 55"/>
+          <p:cNvSpPr/>
+          <p:nvPr/>
+        </p:nvSpPr>
+        <p:spPr>
+          <a:xfrm>
+            <a:off x="731520" y="1536192"/>
+            <a:ext cx="2542032" cy="3977639"/>
+          </a:xfrm>
+          <a:prstGeom prst="roundRect">
+            <a:avLst/>
+          </a:prstGeom>
+          <a:solidFill>
+            <a:srgbClr val="FFFFFF"/>
+          </a:solidFill>
+          <a:ln w="12700">
+            <a:solidFill>
+              <a:srgbClr val="E4E4E7"/>
+            </a:solidFill>
+          </a:ln>
+        </p:spPr>
+        <p:style>
+          <a:lnRef idx="1">
+            <a:schemeClr val="accent1"/>
+          </a:lnRef>
+          <a:fillRef idx="3">
+            <a:schemeClr val="accent1"/>
+          </a:fillRef>
+          <a:effectRef idx="2">
+            <a:schemeClr val="accent1"/>
+          </a:effectRef>
+          <a:fontRef idx="minor">
+            <a:schemeClr val="lt1"/>
+          </a:fontRef>
+        </p:style>
+        <p:txBody>
+          <a:bodyPr rtlCol="0" anchor="ctr"/>
+          <a:lstStyle/>
+          <a:p>
+            <a:pPr algn="ctr"/>
+          </a:p>
+        </p:txBody>
+      </p:sp>
+      <p:sp>
+        <p:nvSpPr>
+          <p:cNvPr id="57" name="TextBox 56"/>
+          <p:cNvSpPr txBox="1"/>
+          <p:nvPr/>
+        </p:nvSpPr>
+        <p:spPr>
+          <a:xfrm>
+            <a:off x="841248" y="1645920"/>
+            <a:ext cx="1188720" cy="182880"/>
+          </a:xfrm>
+          <a:prstGeom prst="rect">
+            <a:avLst/>
+          </a:prstGeom>
+          <a:noFill/>
+        </p:spPr>
+        <p:txBody>
+          <a:bodyPr wrap="square" lIns="0" tIns="0" rIns="0" bIns="0">
+            <a:spAutoFit/>
+          </a:bodyPr>
+          <a:lstStyle/>
+          <a:p>
             <a:pPr algn="l"/>
             <a:r>
-              <a:rPr sz="800" b="1" i="0">
+              <a:rPr sz="700" b="1" i="0">
                 <a:solidFill>
                   <a:srgbClr val="94A3B8"/>
                 </a:solidFill>
                 <a:latin typeface="JetBrains Mono"/>
               </a:rPr>
-              <a:t>SYSTEM PERFORMANCE TELEMETRY</a:t>
-            </a:r>
-          </a:p>
-        </p:txBody>
-      </p:sp>
-      <p:sp>
-        <p:nvSpPr>
-          <p:cNvPr id="49" name="Rounded Rectangle 48"/>
-          <p:cNvSpPr/>
-          <p:nvPr/>
-        </p:nvSpPr>
-        <p:spPr>
-          <a:xfrm>
-            <a:off x="731520" y="2057400"/>
-            <a:ext cx="2057400" cy="960120"/>
+              <a:t>SUBSYSTEM A</a:t>
+            </a:r>
+          </a:p>
+        </p:txBody>
+      </p:sp>
+      <p:sp>
+        <p:nvSpPr>
+          <p:cNvPr id="58" name="Rounded Rectangle 57"/>
+          <p:cNvSpPr/>
+          <p:nvPr/>
+        </p:nvSpPr>
+        <p:spPr>
+          <a:xfrm>
+            <a:off x="2057400" y="1627632"/>
+            <a:ext cx="1097280" cy="201168"/>
           </a:xfrm>
           <a:prstGeom prst="roundRect">
             <a:avLst/>
           </a:prstGeom>
           <a:solidFill>
-            <a:srgbClr val="F8FAFC"/>
+            <a:srgbClr val="ECFDF5"/>
           </a:solidFill>
           <a:ln w="12700">
             <a:solidFill>
-              <a:srgbClr val="E4E4E7"/>
+              <a:srgbClr val="A7F3D0"/>
             </a:solidFill>
           </a:ln>
         </p:spPr>
@@ -13006,14 +13371,14 @@
       </p:sp>
       <p:sp>
         <p:nvSpPr>
-          <p:cNvPr id="50" name="TextBox 49"/>
+          <p:cNvPr id="59" name="TextBox 58"/>
           <p:cNvSpPr txBox="1"/>
           <p:nvPr/>
         </p:nvSpPr>
         <p:spPr>
           <a:xfrm>
-            <a:off x="841248" y="2130552"/>
-            <a:ext cx="1837944" cy="164592"/>
+            <a:off x="2057400" y="1645920"/>
+            <a:ext cx="1097280" cy="182880"/>
           </a:xfrm>
           <a:prstGeom prst="rect">
             <a:avLst/>
@@ -13026,350 +13391,15 @@
           </a:bodyPr>
           <a:lstStyle/>
           <a:p>
-            <a:pPr algn="l"/>
-            <a:r>
-              <a:rPr sz="680" b="1" i="0">
-                <a:solidFill>
-                  <a:srgbClr val="64748B"/>
-                </a:solidFill>
-                <a:latin typeface="JetBrains Mono"/>
-              </a:rPr>
-              <a:t>DETECTION RATE</a:t>
-            </a:r>
-          </a:p>
-        </p:txBody>
-      </p:sp>
-      <p:sp>
-        <p:nvSpPr>
-          <p:cNvPr id="51" name="TextBox 50"/>
-          <p:cNvSpPr txBox="1"/>
-          <p:nvPr/>
-        </p:nvSpPr>
-        <p:spPr>
-          <a:xfrm>
-            <a:off x="841248" y="2350008"/>
-            <a:ext cx="1837944" cy="320040"/>
-          </a:xfrm>
-          <a:prstGeom prst="rect">
-            <a:avLst/>
-          </a:prstGeom>
-          <a:noFill/>
-        </p:spPr>
-        <p:txBody>
-          <a:bodyPr wrap="square" lIns="0" tIns="0" rIns="0" bIns="0">
-            <a:spAutoFit/>
-          </a:bodyPr>
-          <a:lstStyle/>
-          <a:p>
-            <a:pPr algn="l"/>
-            <a:r>
-              <a:rPr sz="1400" b="1" i="0">
+            <a:pPr algn="ctr"/>
+            <a:r>
+              <a:rPr sz="650" b="1" i="0">
                 <a:solidFill>
                   <a:srgbClr val="047857"/>
                 </a:solidFill>
                 <a:latin typeface="JetBrains Mono"/>
               </a:rPr>
-              <a:t>78-85%</a:t>
-            </a:r>
-          </a:p>
-        </p:txBody>
-      </p:sp>
-      <p:sp>
-        <p:nvSpPr>
-          <p:cNvPr id="52" name="TextBox 51"/>
-          <p:cNvSpPr txBox="1"/>
-          <p:nvPr/>
-        </p:nvSpPr>
-        <p:spPr>
-          <a:xfrm>
-            <a:off x="841248" y="2715768"/>
-            <a:ext cx="1837944" cy="228600"/>
-          </a:xfrm>
-          <a:prstGeom prst="rect">
-            <a:avLst/>
-          </a:prstGeom>
-          <a:noFill/>
-        </p:spPr>
-        <p:txBody>
-          <a:bodyPr wrap="square" lIns="0" tIns="0" rIns="0" bIns="0">
-            <a:spAutoFit/>
-          </a:bodyPr>
-          <a:lstStyle/>
-          <a:p>
-            <a:pPr algn="l"/>
-            <a:r>
-              <a:rPr sz="680" b="0" i="0">
-                <a:solidFill>
-                  <a:srgbClr val="94A3B8"/>
-                </a:solidFill>
-                <a:latin typeface="JetBrains Mono"/>
-              </a:rPr>
-              <a:t>First-pass probability</a:t>
-            </a:r>
-          </a:p>
-        </p:txBody>
-      </p:sp>
-      <p:sp>
-        <p:nvSpPr>
-          <p:cNvPr id="53" name="Rounded Rectangle 52"/>
-          <p:cNvSpPr/>
-          <p:nvPr/>
-        </p:nvSpPr>
-        <p:spPr>
-          <a:xfrm>
-            <a:off x="2971800" y="2057400"/>
-            <a:ext cx="2057400" cy="960120"/>
-          </a:xfrm>
-          <a:prstGeom prst="roundRect">
-            <a:avLst/>
-          </a:prstGeom>
-          <a:solidFill>
-            <a:srgbClr val="F8FAFC"/>
-          </a:solidFill>
-          <a:ln w="12700">
-            <a:solidFill>
-              <a:srgbClr val="E4E4E7"/>
-            </a:solidFill>
-          </a:ln>
-        </p:spPr>
-        <p:style>
-          <a:lnRef idx="1">
-            <a:schemeClr val="accent1"/>
-          </a:lnRef>
-          <a:fillRef idx="3">
-            <a:schemeClr val="accent1"/>
-          </a:fillRef>
-          <a:effectRef idx="2">
-            <a:schemeClr val="accent1"/>
-          </a:effectRef>
-          <a:fontRef idx="minor">
-            <a:schemeClr val="lt1"/>
-          </a:fontRef>
-        </p:style>
-        <p:txBody>
-          <a:bodyPr rtlCol="0" anchor="ctr"/>
-          <a:lstStyle/>
-          <a:p>
-            <a:pPr algn="ctr"/>
-          </a:p>
-        </p:txBody>
-      </p:sp>
-      <p:sp>
-        <p:nvSpPr>
-          <p:cNvPr id="54" name="TextBox 53"/>
-          <p:cNvSpPr txBox="1"/>
-          <p:nvPr/>
-        </p:nvSpPr>
-        <p:spPr>
-          <a:xfrm>
-            <a:off x="3081528" y="2130552"/>
-            <a:ext cx="1837944" cy="164592"/>
-          </a:xfrm>
-          <a:prstGeom prst="rect">
-            <a:avLst/>
-          </a:prstGeom>
-          <a:noFill/>
-        </p:spPr>
-        <p:txBody>
-          <a:bodyPr wrap="square" lIns="0" tIns="0" rIns="0" bIns="0">
-            <a:spAutoFit/>
-          </a:bodyPr>
-          <a:lstStyle/>
-          <a:p>
-            <a:pPr algn="l"/>
-            <a:r>
-              <a:rPr sz="680" b="1" i="0">
-                <a:solidFill>
-                  <a:srgbClr val="64748B"/>
-                </a:solidFill>
-                <a:latin typeface="JetBrains Mono"/>
-              </a:rPr>
-              <a:t>AREA SPEED</a:t>
-            </a:r>
-          </a:p>
-        </p:txBody>
-      </p:sp>
-      <p:sp>
-        <p:nvSpPr>
-          <p:cNvPr id="55" name="TextBox 54"/>
-          <p:cNvSpPr txBox="1"/>
-          <p:nvPr/>
-        </p:nvSpPr>
-        <p:spPr>
-          <a:xfrm>
-            <a:off x="3081528" y="2350008"/>
-            <a:ext cx="1837944" cy="320040"/>
-          </a:xfrm>
-          <a:prstGeom prst="rect">
-            <a:avLst/>
-          </a:prstGeom>
-          <a:noFill/>
-        </p:spPr>
-        <p:txBody>
-          <a:bodyPr wrap="square" lIns="0" tIns="0" rIns="0" bIns="0">
-            <a:spAutoFit/>
-          </a:bodyPr>
-          <a:lstStyle/>
-          <a:p>
-            <a:pPr algn="l"/>
-            <a:r>
-              <a:rPr sz="1400" b="1" i="0">
-                <a:solidFill>
-                  <a:srgbClr val="09090B"/>
-                </a:solidFill>
-                <a:latin typeface="JetBrains Mono"/>
-              </a:rPr>
-              <a:t>10-18 min</a:t>
-            </a:r>
-          </a:p>
-        </p:txBody>
-      </p:sp>
-      <p:sp>
-        <p:nvSpPr>
-          <p:cNvPr id="56" name="TextBox 55"/>
-          <p:cNvSpPr txBox="1"/>
-          <p:nvPr/>
-        </p:nvSpPr>
-        <p:spPr>
-          <a:xfrm>
-            <a:off x="3081528" y="2715768"/>
-            <a:ext cx="1837944" cy="228600"/>
-          </a:xfrm>
-          <a:prstGeom prst="rect">
-            <a:avLst/>
-          </a:prstGeom>
-          <a:noFill/>
-        </p:spPr>
-        <p:txBody>
-          <a:bodyPr wrap="square" lIns="0" tIns="0" rIns="0" bIns="0">
-            <a:spAutoFit/>
-          </a:bodyPr>
-          <a:lstStyle/>
-          <a:p>
-            <a:pPr algn="l"/>
-            <a:r>
-              <a:rPr sz="680" b="0" i="0">
-                <a:solidFill>
-                  <a:srgbClr val="94A3B8"/>
-                </a:solidFill>
-                <a:latin typeface="JetBrains Mono"/>
-              </a:rPr>
-              <a:t>Per sq mile (vs 2-3 hrs)</a:t>
-            </a:r>
-          </a:p>
-        </p:txBody>
-      </p:sp>
-      <p:sp>
-        <p:nvSpPr>
-          <p:cNvPr id="57" name="Rounded Rectangle 56"/>
-          <p:cNvSpPr/>
-          <p:nvPr/>
-        </p:nvSpPr>
-        <p:spPr>
-          <a:xfrm>
-            <a:off x="731520" y="3182112"/>
-            <a:ext cx="2057400" cy="960120"/>
-          </a:xfrm>
-          <a:prstGeom prst="roundRect">
-            <a:avLst/>
-          </a:prstGeom>
-          <a:solidFill>
-            <a:srgbClr val="F8FAFC"/>
-          </a:solidFill>
-          <a:ln w="12700">
-            <a:solidFill>
-              <a:srgbClr val="E4E4E7"/>
-            </a:solidFill>
-          </a:ln>
-        </p:spPr>
-        <p:style>
-          <a:lnRef idx="1">
-            <a:schemeClr val="accent1"/>
-          </a:lnRef>
-          <a:fillRef idx="3">
-            <a:schemeClr val="accent1"/>
-          </a:fillRef>
-          <a:effectRef idx="2">
-            <a:schemeClr val="accent1"/>
-          </a:effectRef>
-          <a:fontRef idx="minor">
-            <a:schemeClr val="lt1"/>
-          </a:fontRef>
-        </p:style>
-        <p:txBody>
-          <a:bodyPr rtlCol="0" anchor="ctr"/>
-          <a:lstStyle/>
-          <a:p>
-            <a:pPr algn="ctr"/>
-          </a:p>
-        </p:txBody>
-      </p:sp>
-      <p:sp>
-        <p:nvSpPr>
-          <p:cNvPr id="58" name="TextBox 57"/>
-          <p:cNvSpPr txBox="1"/>
-          <p:nvPr/>
-        </p:nvSpPr>
-        <p:spPr>
-          <a:xfrm>
-            <a:off x="841248" y="3255264"/>
-            <a:ext cx="1837944" cy="164592"/>
-          </a:xfrm>
-          <a:prstGeom prst="rect">
-            <a:avLst/>
-          </a:prstGeom>
-          <a:noFill/>
-        </p:spPr>
-        <p:txBody>
-          <a:bodyPr wrap="square" lIns="0" tIns="0" rIns="0" bIns="0">
-            <a:spAutoFit/>
-          </a:bodyPr>
-          <a:lstStyle/>
-          <a:p>
-            <a:pPr algn="l"/>
-            <a:r>
-              <a:rPr sz="680" b="1" i="0">
-                <a:solidFill>
-                  <a:srgbClr val="64748B"/>
-                </a:solidFill>
-                <a:latin typeface="JetBrains Mono"/>
-              </a:rPr>
-              <a:t>COMMS PROTOCOL</a:t>
-            </a:r>
-          </a:p>
-        </p:txBody>
-      </p:sp>
-      <p:sp>
-        <p:nvSpPr>
-          <p:cNvPr id="59" name="TextBox 58"/>
-          <p:cNvSpPr txBox="1"/>
-          <p:nvPr/>
-        </p:nvSpPr>
-        <p:spPr>
-          <a:xfrm>
-            <a:off x="841248" y="3474720"/>
-            <a:ext cx="1837944" cy="320040"/>
-          </a:xfrm>
-          <a:prstGeom prst="rect">
-            <a:avLst/>
-          </a:prstGeom>
-          <a:noFill/>
-        </p:spPr>
-        <p:txBody>
-          <a:bodyPr wrap="square" lIns="0" tIns="0" rIns="0" bIns="0">
-            <a:spAutoFit/>
-          </a:bodyPr>
-          <a:lstStyle/>
-          <a:p>
-            <a:pPr algn="l"/>
-            <a:r>
-              <a:rPr sz="1400" b="1" i="0">
-                <a:solidFill>
-                  <a:srgbClr val="09090B"/>
-                </a:solidFill>
-                <a:latin typeface="JetBrains Mono"/>
-              </a:rPr>
-              <a:t>Mesh Net</a:t>
+              <a:t>50Hz OFFBOARD</a:t>
             </a:r>
           </a:p>
         </p:txBody>
@@ -13382,608 +13412,8 @@
         </p:nvSpPr>
         <p:spPr>
           <a:xfrm>
-            <a:off x="841248" y="3840480"/>
-            <a:ext cx="1837944" cy="228600"/>
-          </a:xfrm>
-          <a:prstGeom prst="rect">
-            <a:avLst/>
-          </a:prstGeom>
-          <a:noFill/>
-        </p:spPr>
-        <p:txBody>
-          <a:bodyPr wrap="square" lIns="0" tIns="0" rIns="0" bIns="0">
-            <a:spAutoFit/>
-          </a:bodyPr>
-          <a:lstStyle/>
-          <a:p>
-            <a:pPr algn="l"/>
-            <a:r>
-              <a:rPr sz="680" b="0" i="0">
-                <a:solidFill>
-                  <a:srgbClr val="94A3B8"/>
-                </a:solidFill>
-                <a:latin typeface="JetBrains Mono"/>
-              </a:rPr>
-              <a:t>GPS-Denied Autonomous</a:t>
-            </a:r>
-          </a:p>
-        </p:txBody>
-      </p:sp>
-      <p:sp>
-        <p:nvSpPr>
-          <p:cNvPr id="61" name="Rounded Rectangle 60"/>
-          <p:cNvSpPr/>
-          <p:nvPr/>
-        </p:nvSpPr>
-        <p:spPr>
-          <a:xfrm>
-            <a:off x="2971800" y="3182112"/>
-            <a:ext cx="2057400" cy="960120"/>
-          </a:xfrm>
-          <a:prstGeom prst="roundRect">
-            <a:avLst/>
-          </a:prstGeom>
-          <a:solidFill>
-            <a:srgbClr val="F8FAFC"/>
-          </a:solidFill>
-          <a:ln w="12700">
-            <a:solidFill>
-              <a:srgbClr val="E4E4E7"/>
-            </a:solidFill>
-          </a:ln>
-        </p:spPr>
-        <p:style>
-          <a:lnRef idx="1">
-            <a:schemeClr val="accent1"/>
-          </a:lnRef>
-          <a:fillRef idx="3">
-            <a:schemeClr val="accent1"/>
-          </a:fillRef>
-          <a:effectRef idx="2">
-            <a:schemeClr val="accent1"/>
-          </a:effectRef>
-          <a:fontRef idx="minor">
-            <a:schemeClr val="lt1"/>
-          </a:fontRef>
-        </p:style>
-        <p:txBody>
-          <a:bodyPr rtlCol="0" anchor="ctr"/>
-          <a:lstStyle/>
-          <a:p>
-            <a:pPr algn="ctr"/>
-          </a:p>
-        </p:txBody>
-      </p:sp>
-      <p:sp>
-        <p:nvSpPr>
-          <p:cNvPr id="62" name="TextBox 61"/>
-          <p:cNvSpPr txBox="1"/>
-          <p:nvPr/>
-        </p:nvSpPr>
-        <p:spPr>
-          <a:xfrm>
-            <a:off x="3081528" y="3255264"/>
-            <a:ext cx="1837944" cy="164592"/>
-          </a:xfrm>
-          <a:prstGeom prst="rect">
-            <a:avLst/>
-          </a:prstGeom>
-          <a:noFill/>
-        </p:spPr>
-        <p:txBody>
-          <a:bodyPr wrap="square" lIns="0" tIns="0" rIns="0" bIns="0">
-            <a:spAutoFit/>
-          </a:bodyPr>
-          <a:lstStyle/>
-          <a:p>
-            <a:pPr algn="l"/>
-            <a:r>
-              <a:rPr sz="680" b="1" i="0">
-                <a:solidFill>
-                  <a:srgbClr val="64748B"/>
-                </a:solidFill>
-                <a:latin typeface="JetBrains Mono"/>
-              </a:rPr>
-              <a:t>SUSTAINED AUTONOMY</a:t>
-            </a:r>
-          </a:p>
-        </p:txBody>
-      </p:sp>
-      <p:sp>
-        <p:nvSpPr>
-          <p:cNvPr id="63" name="TextBox 62"/>
-          <p:cNvSpPr txBox="1"/>
-          <p:nvPr/>
-        </p:nvSpPr>
-        <p:spPr>
-          <a:xfrm>
-            <a:off x="3081528" y="3474720"/>
-            <a:ext cx="1837944" cy="320040"/>
-          </a:xfrm>
-          <a:prstGeom prst="rect">
-            <a:avLst/>
-          </a:prstGeom>
-          <a:noFill/>
-        </p:spPr>
-        <p:txBody>
-          <a:bodyPr wrap="square" lIns="0" tIns="0" rIns="0" bIns="0">
-            <a:spAutoFit/>
-          </a:bodyPr>
-          <a:lstStyle/>
-          <a:p>
-            <a:pPr algn="l"/>
-            <a:r>
-              <a:rPr sz="1400" b="1" i="0">
-                <a:solidFill>
-                  <a:srgbClr val="09090B"/>
-                </a:solidFill>
-                <a:latin typeface="JetBrains Mono"/>
-              </a:rPr>
-              <a:t>24/7 (11+ D)</a:t>
-            </a:r>
-          </a:p>
-        </p:txBody>
-      </p:sp>
-      <p:sp>
-        <p:nvSpPr>
-          <p:cNvPr id="64" name="TextBox 63"/>
-          <p:cNvSpPr txBox="1"/>
-          <p:nvPr/>
-        </p:nvSpPr>
-        <p:spPr>
-          <a:xfrm>
-            <a:off x="3081528" y="3840480"/>
-            <a:ext cx="1837944" cy="228600"/>
-          </a:xfrm>
-          <a:prstGeom prst="rect">
-            <a:avLst/>
-          </a:prstGeom>
-          <a:noFill/>
-        </p:spPr>
-        <p:txBody>
-          <a:bodyPr wrap="square" lIns="0" tIns="0" rIns="0" bIns="0">
-            <a:spAutoFit/>
-          </a:bodyPr>
-          <a:lstStyle/>
-          <a:p>
-            <a:pPr algn="l"/>
-            <a:r>
-              <a:rPr sz="680" b="0" i="0">
-                <a:solidFill>
-                  <a:srgbClr val="94A3B8"/>
-                </a:solidFill>
-                <a:latin typeface="JetBrains Mono"/>
-              </a:rPr>
-              <a:t>Continuous field sorties</a:t>
-            </a:r>
-          </a:p>
-        </p:txBody>
-      </p:sp>
-      <p:sp>
-        <p:nvSpPr>
-          <p:cNvPr id="65" name="Rounded Rectangle 64"/>
-          <p:cNvSpPr/>
-          <p:nvPr/>
-        </p:nvSpPr>
-        <p:spPr>
-          <a:xfrm>
-            <a:off x="731520" y="4306824"/>
-            <a:ext cx="2057400" cy="960120"/>
-          </a:xfrm>
-          <a:prstGeom prst="roundRect">
-            <a:avLst/>
-          </a:prstGeom>
-          <a:solidFill>
-            <a:srgbClr val="F8FAFC"/>
-          </a:solidFill>
-          <a:ln w="12700">
-            <a:solidFill>
-              <a:srgbClr val="E4E4E7"/>
-            </a:solidFill>
-          </a:ln>
-        </p:spPr>
-        <p:style>
-          <a:lnRef idx="1">
-            <a:schemeClr val="accent1"/>
-          </a:lnRef>
-          <a:fillRef idx="3">
-            <a:schemeClr val="accent1"/>
-          </a:fillRef>
-          <a:effectRef idx="2">
-            <a:schemeClr val="accent1"/>
-          </a:effectRef>
-          <a:fontRef idx="minor">
-            <a:schemeClr val="lt1"/>
-          </a:fontRef>
-        </p:style>
-        <p:txBody>
-          <a:bodyPr rtlCol="0" anchor="ctr"/>
-          <a:lstStyle/>
-          <a:p>
-            <a:pPr algn="ctr"/>
-          </a:p>
-        </p:txBody>
-      </p:sp>
-      <p:sp>
-        <p:nvSpPr>
-          <p:cNvPr id="66" name="TextBox 65"/>
-          <p:cNvSpPr txBox="1"/>
-          <p:nvPr/>
-        </p:nvSpPr>
-        <p:spPr>
-          <a:xfrm>
-            <a:off x="841248" y="4379976"/>
-            <a:ext cx="1837944" cy="164592"/>
-          </a:xfrm>
-          <a:prstGeom prst="rect">
-            <a:avLst/>
-          </a:prstGeom>
-          <a:noFill/>
-        </p:spPr>
-        <p:txBody>
-          <a:bodyPr wrap="square" lIns="0" tIns="0" rIns="0" bIns="0">
-            <a:spAutoFit/>
-          </a:bodyPr>
-          <a:lstStyle/>
-          <a:p>
-            <a:pPr algn="l"/>
-            <a:r>
-              <a:rPr sz="680" b="1" i="0">
-                <a:solidFill>
-                  <a:srgbClr val="64748B"/>
-                </a:solidFill>
-                <a:latin typeface="JetBrains Mono"/>
-              </a:rPr>
-              <a:t>FALSE POSITIVES</a:t>
-            </a:r>
-          </a:p>
-        </p:txBody>
-      </p:sp>
-      <p:sp>
-        <p:nvSpPr>
-          <p:cNvPr id="67" name="TextBox 66"/>
-          <p:cNvSpPr txBox="1"/>
-          <p:nvPr/>
-        </p:nvSpPr>
-        <p:spPr>
-          <a:xfrm>
-            <a:off x="841248" y="4599432"/>
-            <a:ext cx="1837944" cy="320040"/>
-          </a:xfrm>
-          <a:prstGeom prst="rect">
-            <a:avLst/>
-          </a:prstGeom>
-          <a:noFill/>
-        </p:spPr>
-        <p:txBody>
-          <a:bodyPr wrap="square" lIns="0" tIns="0" rIns="0" bIns="0">
-            <a:spAutoFit/>
-          </a:bodyPr>
-          <a:lstStyle/>
-          <a:p>
-            <a:pPr algn="l"/>
-            <a:r>
-              <a:rPr sz="1400" b="1" i="0">
-                <a:solidFill>
-                  <a:srgbClr val="047857"/>
-                </a:solidFill>
-                <a:latin typeface="JetBrains Mono"/>
-              </a:rPr>
-              <a:t>12%</a:t>
-            </a:r>
-          </a:p>
-        </p:txBody>
-      </p:sp>
-      <p:sp>
-        <p:nvSpPr>
-          <p:cNvPr id="68" name="TextBox 67"/>
-          <p:cNvSpPr txBox="1"/>
-          <p:nvPr/>
-        </p:nvSpPr>
-        <p:spPr>
-          <a:xfrm>
-            <a:off x="841248" y="4965192"/>
-            <a:ext cx="1837944" cy="228600"/>
-          </a:xfrm>
-          <a:prstGeom prst="rect">
-            <a:avLst/>
-          </a:prstGeom>
-          <a:noFill/>
-        </p:spPr>
-        <p:txBody>
-          <a:bodyPr wrap="square" lIns="0" tIns="0" rIns="0" bIns="0">
-            <a:spAutoFit/>
-          </a:bodyPr>
-          <a:lstStyle/>
-          <a:p>
-            <a:pPr algn="l"/>
-            <a:r>
-              <a:rPr sz="680" b="0" i="0">
-                <a:solidFill>
-                  <a:srgbClr val="94A3B8"/>
-                </a:solidFill>
-                <a:latin typeface="JetBrains Mono"/>
-              </a:rPr>
-              <a:t>Down from 35% legacy</a:t>
-            </a:r>
-          </a:p>
-        </p:txBody>
-      </p:sp>
-      <p:sp>
-        <p:nvSpPr>
-          <p:cNvPr id="69" name="Rounded Rectangle 68"/>
-          <p:cNvSpPr/>
-          <p:nvPr/>
-        </p:nvSpPr>
-        <p:spPr>
-          <a:xfrm>
-            <a:off x="2971800" y="4306824"/>
-            <a:ext cx="2057400" cy="960120"/>
-          </a:xfrm>
-          <a:prstGeom prst="roundRect">
-            <a:avLst/>
-          </a:prstGeom>
-          <a:solidFill>
-            <a:srgbClr val="F8FAFC"/>
-          </a:solidFill>
-          <a:ln w="12700">
-            <a:solidFill>
-              <a:srgbClr val="E4E4E7"/>
-            </a:solidFill>
-          </a:ln>
-        </p:spPr>
-        <p:style>
-          <a:lnRef idx="1">
-            <a:schemeClr val="accent1"/>
-          </a:lnRef>
-          <a:fillRef idx="3">
-            <a:schemeClr val="accent1"/>
-          </a:fillRef>
-          <a:effectRef idx="2">
-            <a:schemeClr val="accent1"/>
-          </a:effectRef>
-          <a:fontRef idx="minor">
-            <a:schemeClr val="lt1"/>
-          </a:fontRef>
-        </p:style>
-        <p:txBody>
-          <a:bodyPr rtlCol="0" anchor="ctr"/>
-          <a:lstStyle/>
-          <a:p>
-            <a:pPr algn="ctr"/>
-          </a:p>
-        </p:txBody>
-      </p:sp>
-      <p:sp>
-        <p:nvSpPr>
-          <p:cNvPr id="70" name="TextBox 69"/>
-          <p:cNvSpPr txBox="1"/>
-          <p:nvPr/>
-        </p:nvSpPr>
-        <p:spPr>
-          <a:xfrm>
-            <a:off x="3081528" y="4379976"/>
-            <a:ext cx="1837944" cy="164592"/>
-          </a:xfrm>
-          <a:prstGeom prst="rect">
-            <a:avLst/>
-          </a:prstGeom>
-          <a:noFill/>
-        </p:spPr>
-        <p:txBody>
-          <a:bodyPr wrap="square" lIns="0" tIns="0" rIns="0" bIns="0">
-            <a:spAutoFit/>
-          </a:bodyPr>
-          <a:lstStyle/>
-          <a:p>
-            <a:pPr algn="l"/>
-            <a:r>
-              <a:rPr sz="680" b="1" i="0">
-                <a:solidFill>
-                  <a:srgbClr val="64748B"/>
-                </a:solidFill>
-                <a:latin typeface="JetBrains Mono"/>
-              </a:rPr>
-              <a:t>DEPLOYMENT COST</a:t>
-            </a:r>
-          </a:p>
-        </p:txBody>
-      </p:sp>
-      <p:sp>
-        <p:nvSpPr>
-          <p:cNvPr id="71" name="TextBox 70"/>
-          <p:cNvSpPr txBox="1"/>
-          <p:nvPr/>
-        </p:nvSpPr>
-        <p:spPr>
-          <a:xfrm>
-            <a:off x="3081528" y="4599432"/>
-            <a:ext cx="1837944" cy="320040"/>
-          </a:xfrm>
-          <a:prstGeom prst="rect">
-            <a:avLst/>
-          </a:prstGeom>
-          <a:noFill/>
-        </p:spPr>
-        <p:txBody>
-          <a:bodyPr wrap="square" lIns="0" tIns="0" rIns="0" bIns="0">
-            <a:spAutoFit/>
-          </a:bodyPr>
-          <a:lstStyle/>
-          <a:p>
-            <a:pPr algn="l"/>
-            <a:r>
-              <a:rPr sz="1400" b="1" i="0">
-                <a:solidFill>
-                  <a:srgbClr val="09090B"/>
-                </a:solidFill>
-                <a:latin typeface="JetBrains Mono"/>
-              </a:rPr>
-              <a:t>$12K ($15K)</a:t>
-            </a:r>
-          </a:p>
-        </p:txBody>
-      </p:sp>
-      <p:sp>
-        <p:nvSpPr>
-          <p:cNvPr id="72" name="TextBox 71"/>
-          <p:cNvSpPr txBox="1"/>
-          <p:nvPr/>
-        </p:nvSpPr>
-        <p:spPr>
-          <a:xfrm>
-            <a:off x="3081528" y="4965192"/>
-            <a:ext cx="1837944" cy="228600"/>
-          </a:xfrm>
-          <a:prstGeom prst="rect">
-            <a:avLst/>
-          </a:prstGeom>
-          <a:noFill/>
-        </p:spPr>
-        <p:txBody>
-          <a:bodyPr wrap="square" lIns="0" tIns="0" rIns="0" bIns="0">
-            <a:spAutoFit/>
-          </a:bodyPr>
-          <a:lstStyle/>
-          <a:p>
-            <a:pPr algn="l"/>
-            <a:r>
-              <a:rPr sz="680" b="0" i="0">
-                <a:solidFill>
-                  <a:srgbClr val="94A3B8"/>
-                </a:solidFill>
-                <a:latin typeface="JetBrains Mono"/>
-              </a:rPr>
-              <a:t>Per sortie deployment</a:t>
-            </a:r>
-          </a:p>
-        </p:txBody>
-      </p:sp>
-      <p:sp>
-        <p:nvSpPr>
-          <p:cNvPr id="73" name="TextBox 72"/>
-          <p:cNvSpPr txBox="1"/>
-          <p:nvPr/>
-        </p:nvSpPr>
-        <p:spPr>
-          <a:xfrm>
-            <a:off x="5303520" y="1783080"/>
-            <a:ext cx="4114800" cy="182880"/>
-          </a:xfrm>
-          <a:prstGeom prst="rect">
-            <a:avLst/>
-          </a:prstGeom>
-          <a:noFill/>
-        </p:spPr>
-        <p:txBody>
-          <a:bodyPr wrap="square" lIns="0" tIns="0" rIns="0" bIns="0">
-            <a:spAutoFit/>
-          </a:bodyPr>
-          <a:lstStyle/>
-          <a:p>
-            <a:pPr algn="l"/>
-            <a:r>
-              <a:rPr sz="800" b="1" i="0">
-                <a:solidFill>
-                  <a:srgbClr val="94A3B8"/>
-                </a:solidFill>
-                <a:latin typeface="JetBrains Mono"/>
-              </a:rPr>
-              <a:t>SUBSYSTEM MOAT ARCHITECTURE</a:t>
-            </a:r>
-          </a:p>
-        </p:txBody>
-      </p:sp>
-      <p:sp>
-        <p:nvSpPr>
-          <p:cNvPr id="74" name="TextBox 73"/>
-          <p:cNvSpPr txBox="1"/>
-          <p:nvPr/>
-        </p:nvSpPr>
-        <p:spPr>
-          <a:xfrm>
-            <a:off x="8686800" y="1783080"/>
-            <a:ext cx="2743200" cy="182880"/>
-          </a:xfrm>
-          <a:prstGeom prst="rect">
-            <a:avLst/>
-          </a:prstGeom>
-          <a:noFill/>
-        </p:spPr>
-        <p:txBody>
-          <a:bodyPr wrap="square" lIns="0" tIns="0" rIns="0" bIns="0">
-            <a:spAutoFit/>
-          </a:bodyPr>
-          <a:lstStyle/>
-          <a:p>
-            <a:pPr algn="r"/>
-            <a:r>
-              <a:rPr sz="750" b="1" i="0">
-                <a:solidFill>
-                  <a:srgbClr val="047857"/>
-                </a:solidFill>
-                <a:latin typeface="JetBrains Mono"/>
-              </a:rPr>
-              <a:t>3 CORE ENGINEERING MOATS</a:t>
-            </a:r>
-          </a:p>
-        </p:txBody>
-      </p:sp>
-      <p:sp>
-        <p:nvSpPr>
-          <p:cNvPr id="75" name="Rounded Rectangle 74"/>
-          <p:cNvSpPr/>
-          <p:nvPr/>
-        </p:nvSpPr>
-        <p:spPr>
-          <a:xfrm>
-            <a:off x="5303520" y="2057400"/>
-            <a:ext cx="6126480" cy="960120"/>
-          </a:xfrm>
-          <a:prstGeom prst="roundRect">
-            <a:avLst/>
-          </a:prstGeom>
-          <a:solidFill>
-            <a:srgbClr val="FFFFFF"/>
-          </a:solidFill>
-          <a:ln w="12700">
-            <a:solidFill>
-              <a:srgbClr val="E4E4E7"/>
-            </a:solidFill>
-          </a:ln>
-        </p:spPr>
-        <p:style>
-          <a:lnRef idx="1">
-            <a:schemeClr val="accent1"/>
-          </a:lnRef>
-          <a:fillRef idx="3">
-            <a:schemeClr val="accent1"/>
-          </a:fillRef>
-          <a:effectRef idx="2">
-            <a:schemeClr val="accent1"/>
-          </a:effectRef>
-          <a:fontRef idx="minor">
-            <a:schemeClr val="lt1"/>
-          </a:fontRef>
-        </p:style>
-        <p:txBody>
-          <a:bodyPr rtlCol="0" anchor="ctr"/>
-          <a:lstStyle/>
-          <a:p>
-            <a:pPr algn="ctr"/>
-          </a:p>
-        </p:txBody>
-      </p:sp>
-      <p:sp>
-        <p:nvSpPr>
-          <p:cNvPr id="76" name="TextBox 75"/>
-          <p:cNvSpPr txBox="1"/>
-          <p:nvPr/>
-        </p:nvSpPr>
-        <p:spPr>
-          <a:xfrm>
-            <a:off x="5486400" y="2167128"/>
-            <a:ext cx="4114800" cy="228600"/>
+            <a:off x="841248" y="1883664"/>
+            <a:ext cx="2322576" cy="411480"/>
           </a:xfrm>
           <a:prstGeom prst="rect">
             <a:avLst/>
@@ -14004,31 +13434,31 @@
                 </a:solidFill>
                 <a:latin typeface="Space Grotesk"/>
               </a:rPr>
-              <a:t>Subsystem A Moat: PX4 + VIO EKF2 Autopilot</a:t>
-            </a:r>
-          </a:p>
-        </p:txBody>
-      </p:sp>
-      <p:sp>
-        <p:nvSpPr>
-          <p:cNvPr id="77" name="Rounded Rectangle 76"/>
-          <p:cNvSpPr/>
-          <p:nvPr/>
-        </p:nvSpPr>
-        <p:spPr>
-          <a:xfrm>
-            <a:off x="9875520" y="2167128"/>
-            <a:ext cx="1371600" cy="201168"/>
+              <a:t>SUTRA-FSD GNC &amp; 3D ORCA</a:t>
+            </a:r>
+          </a:p>
+        </p:txBody>
+      </p:sp>
+      <p:sp>
+        <p:nvSpPr>
+          <p:cNvPr id="61" name="Rounded Rectangle 60"/>
+          <p:cNvSpPr/>
+          <p:nvPr/>
+        </p:nvSpPr>
+        <p:spPr>
+          <a:xfrm>
+            <a:off x="841248" y="2359152"/>
+            <a:ext cx="2322576" cy="594360"/>
           </a:xfrm>
           <a:prstGeom prst="roundRect">
             <a:avLst/>
           </a:prstGeom>
           <a:solidFill>
-            <a:srgbClr val="ECFDF5"/>
+            <a:srgbClr val="FEF2F2"/>
           </a:solidFill>
           <a:ln w="12700">
             <a:solidFill>
-              <a:srgbClr val="A7F3D0"/>
+              <a:srgbClr val="FECDCD"/>
             </a:solidFill>
           </a:ln>
         </p:spPr>
@@ -14056,14 +13486,14 @@
       </p:sp>
       <p:sp>
         <p:nvSpPr>
-          <p:cNvPr id="78" name="TextBox 77"/>
+          <p:cNvPr id="62" name="TextBox 61"/>
           <p:cNvSpPr txBox="1"/>
           <p:nvPr/>
         </p:nvSpPr>
         <p:spPr>
           <a:xfrm>
-            <a:off x="9875520" y="2185416"/>
-            <a:ext cx="1371600" cy="182880"/>
+            <a:off x="896112" y="2395728"/>
+            <a:ext cx="2212848" cy="164592"/>
           </a:xfrm>
           <a:prstGeom prst="rect">
             <a:avLst/>
@@ -14076,29 +13506,144 @@
           </a:bodyPr>
           <a:lstStyle/>
           <a:p>
-            <a:pPr algn="ctr"/>
-            <a:r>
-              <a:rPr sz="700" b="1" i="0">
+            <a:pPr algn="l"/>
+            <a:r>
+              <a:rPr sz="600" b="1" i="0">
+                <a:solidFill>
+                  <a:srgbClr val="D71920"/>
+                </a:solidFill>
+                <a:latin typeface="JetBrains Mono"/>
+              </a:rPr>
+              <a:t>SOLVES PROBLEM VOID:</a:t>
+            </a:r>
+          </a:p>
+        </p:txBody>
+      </p:sp>
+      <p:sp>
+        <p:nvSpPr>
+          <p:cNvPr id="63" name="TextBox 62"/>
+          <p:cNvSpPr txBox="1"/>
+          <p:nvPr/>
+        </p:nvSpPr>
+        <p:spPr>
+          <a:xfrm>
+            <a:off x="896112" y="2560320"/>
+            <a:ext cx="2212848" cy="365760"/>
+          </a:xfrm>
+          <a:prstGeom prst="rect">
+            <a:avLst/>
+          </a:prstGeom>
+          <a:noFill/>
+        </p:spPr>
+        <p:txBody>
+          <a:bodyPr wrap="square" lIns="0" tIns="0" rIns="0" bIns="0">
+            <a:spAutoFit/>
+          </a:bodyPr>
+          <a:lstStyle/>
+          <a:p>
+            <a:pPr algn="l"/>
+            <a:r>
+              <a:rPr sz="750" b="1" i="0">
+                <a:solidFill>
+                  <a:srgbClr val="09090B"/>
+                </a:solidFill>
+                <a:latin typeface="Inter"/>
+              </a:rPr>
+              <a:t>Canopy GPS Multi-Path Drift &amp; Crashes</a:t>
+            </a:r>
+          </a:p>
+        </p:txBody>
+      </p:sp>
+      <p:sp>
+        <p:nvSpPr>
+          <p:cNvPr id="64" name="Rounded Rectangle 63"/>
+          <p:cNvSpPr/>
+          <p:nvPr/>
+        </p:nvSpPr>
+        <p:spPr>
+          <a:xfrm>
+            <a:off x="841248" y="3044952"/>
+            <a:ext cx="2322576" cy="1325880"/>
+          </a:xfrm>
+          <a:prstGeom prst="roundRect">
+            <a:avLst/>
+          </a:prstGeom>
+          <a:solidFill>
+            <a:srgbClr val="F8FAFC"/>
+          </a:solidFill>
+          <a:ln w="12700">
+            <a:solidFill>
+              <a:srgbClr val="E4E4E7"/>
+            </a:solidFill>
+          </a:ln>
+        </p:spPr>
+        <p:style>
+          <a:lnRef idx="1">
+            <a:schemeClr val="accent1"/>
+          </a:lnRef>
+          <a:fillRef idx="3">
+            <a:schemeClr val="accent1"/>
+          </a:fillRef>
+          <a:effectRef idx="2">
+            <a:schemeClr val="accent1"/>
+          </a:effectRef>
+          <a:fontRef idx="minor">
+            <a:schemeClr val="lt1"/>
+          </a:fontRef>
+        </p:style>
+        <p:txBody>
+          <a:bodyPr rtlCol="0" anchor="ctr"/>
+          <a:lstStyle/>
+          <a:p>
+            <a:pPr algn="ctr"/>
+          </a:p>
+        </p:txBody>
+      </p:sp>
+      <p:sp>
+        <p:nvSpPr>
+          <p:cNvPr id="65" name="TextBox 64"/>
+          <p:cNvSpPr txBox="1"/>
+          <p:nvPr/>
+        </p:nvSpPr>
+        <p:spPr>
+          <a:xfrm>
+            <a:off x="896112" y="3090672"/>
+            <a:ext cx="2212848" cy="164592"/>
+          </a:xfrm>
+          <a:prstGeom prst="rect">
+            <a:avLst/>
+          </a:prstGeom>
+          <a:noFill/>
+        </p:spPr>
+        <p:txBody>
+          <a:bodyPr wrap="square" lIns="0" tIns="0" rIns="0" bIns="0">
+            <a:spAutoFit/>
+          </a:bodyPr>
+          <a:lstStyle/>
+          <a:p>
+            <a:pPr algn="l"/>
+            <a:r>
+              <a:rPr sz="650" b="1" i="0">
                 <a:solidFill>
                   <a:srgbClr val="047857"/>
                 </a:solidFill>
                 <a:latin typeface="JetBrains Mono"/>
               </a:rPr>
-              <a:t>50Hz OFFBOARD</a:t>
-            </a:r>
-          </a:p>
-        </p:txBody>
-      </p:sp>
-      <p:sp>
-        <p:nvSpPr>
-          <p:cNvPr id="79" name="TextBox 78"/>
+              <a:t>SOLUTIONAL MOAT:</a:t>
+            </a:r>
+          </a:p>
+        </p:txBody>
+      </p:sp>
+      <p:sp>
+        <p:nvSpPr>
+          <p:cNvPr id="66" name="TextBox 65"/>
           <p:cNvSpPr txBox="1"/>
           <p:nvPr/>
         </p:nvSpPr>
         <p:spPr>
           <a:xfrm>
-            <a:off x="5486400" y="2459736"/>
-            <a:ext cx="5760720" cy="475488"/>
+            <a:off x="896112" y="3291840"/>
+            <a:ext cx="2212848" cy="1005840"/>
           </a:xfrm>
           <a:prstGeom prst="rect">
             <a:avLst/>
@@ -14113,33 +13658,33 @@
           <a:p>
             <a:pPr algn="l"/>
             <a:r>
-              <a:rPr sz="780" b="0" i="0">
+              <a:rPr sz="720" b="0" i="0">
                 <a:solidFill>
                   <a:srgbClr val="475569"/>
                 </a:solidFill>
                 <a:latin typeface="JetBrains Mono"/>
               </a:rPr>
-              <a:t>Decentralized 3D ORCA anti-collision with zero tower reliance and active GPS-denied flocking algorithms.</a:t>
-            </a:r>
-          </a:p>
-        </p:txBody>
-      </p:sp>
-      <p:sp>
-        <p:nvSpPr>
-          <p:cNvPr id="80" name="Rounded Rectangle 79"/>
-          <p:cNvSpPr/>
-          <p:nvPr/>
-        </p:nvSpPr>
-        <p:spPr>
-          <a:xfrm>
-            <a:off x="5303520" y="3182112"/>
-            <a:ext cx="6126480" cy="960120"/>
+              <a:t>Decentralized 3D velocity obstacle collision avoidance + PX4 MicroXRCE 50Hz offboard setpoint streaming.</a:t>
+            </a:r>
+          </a:p>
+        </p:txBody>
+      </p:sp>
+      <p:sp>
+        <p:nvSpPr>
+          <p:cNvPr id="67" name="Rounded Rectangle 66"/>
+          <p:cNvSpPr/>
+          <p:nvPr/>
+        </p:nvSpPr>
+        <p:spPr>
+          <a:xfrm>
+            <a:off x="841248" y="4462272"/>
+            <a:ext cx="1115568" cy="502920"/>
           </a:xfrm>
           <a:prstGeom prst="roundRect">
             <a:avLst/>
           </a:prstGeom>
           <a:solidFill>
-            <a:srgbClr val="FFFFFF"/>
+            <a:srgbClr val="F8FAFC"/>
           </a:solidFill>
           <a:ln w="12700">
             <a:solidFill>
@@ -14171,14 +13716,472 @@
       </p:sp>
       <p:sp>
         <p:nvSpPr>
-          <p:cNvPr id="81" name="TextBox 80"/>
+          <p:cNvPr id="68" name="TextBox 67"/>
           <p:cNvSpPr txBox="1"/>
           <p:nvPr/>
         </p:nvSpPr>
         <p:spPr>
           <a:xfrm>
-            <a:off x="5486400" y="3291840"/>
-            <a:ext cx="4114800" cy="228600"/>
+            <a:off x="841248" y="4498848"/>
+            <a:ext cx="1115568" cy="228600"/>
+          </a:xfrm>
+          <a:prstGeom prst="rect">
+            <a:avLst/>
+          </a:prstGeom>
+          <a:noFill/>
+        </p:spPr>
+        <p:txBody>
+          <a:bodyPr wrap="square" lIns="0" tIns="0" rIns="0" bIns="0">
+            <a:spAutoFit/>
+          </a:bodyPr>
+          <a:lstStyle/>
+          <a:p>
+            <a:pPr algn="ctr"/>
+            <a:r>
+              <a:rPr sz="950" b="1" i="0">
+                <a:solidFill>
+                  <a:srgbClr val="09090B"/>
+                </a:solidFill>
+                <a:latin typeface="JetBrains Mono"/>
+              </a:rPr>
+              <a:t>0.05s</a:t>
+            </a:r>
+          </a:p>
+        </p:txBody>
+      </p:sp>
+      <p:sp>
+        <p:nvSpPr>
+          <p:cNvPr id="69" name="TextBox 68"/>
+          <p:cNvSpPr txBox="1"/>
+          <p:nvPr/>
+        </p:nvSpPr>
+        <p:spPr>
+          <a:xfrm>
+            <a:off x="841248" y="4754880"/>
+            <a:ext cx="1115568" cy="182880"/>
+          </a:xfrm>
+          <a:prstGeom prst="rect">
+            <a:avLst/>
+          </a:prstGeom>
+          <a:noFill/>
+        </p:spPr>
+        <p:txBody>
+          <a:bodyPr wrap="square" lIns="0" tIns="0" rIns="0" bIns="0">
+            <a:spAutoFit/>
+          </a:bodyPr>
+          <a:lstStyle/>
+          <a:p>
+            <a:pPr algn="ctr"/>
+            <a:r>
+              <a:rPr sz="600" b="0" i="0">
+                <a:solidFill>
+                  <a:srgbClr val="64748B"/>
+                </a:solidFill>
+                <a:latin typeface="JetBrains Mono"/>
+              </a:rPr>
+              <a:t>Latency</a:t>
+            </a:r>
+          </a:p>
+        </p:txBody>
+      </p:sp>
+      <p:sp>
+        <p:nvSpPr>
+          <p:cNvPr id="70" name="Rounded Rectangle 69"/>
+          <p:cNvSpPr/>
+          <p:nvPr/>
+        </p:nvSpPr>
+        <p:spPr>
+          <a:xfrm>
+            <a:off x="2048256" y="4462272"/>
+            <a:ext cx="1115568" cy="502920"/>
+          </a:xfrm>
+          <a:prstGeom prst="roundRect">
+            <a:avLst/>
+          </a:prstGeom>
+          <a:solidFill>
+            <a:srgbClr val="F8FAFC"/>
+          </a:solidFill>
+          <a:ln w="12700">
+            <a:solidFill>
+              <a:srgbClr val="E4E4E7"/>
+            </a:solidFill>
+          </a:ln>
+        </p:spPr>
+        <p:style>
+          <a:lnRef idx="1">
+            <a:schemeClr val="accent1"/>
+          </a:lnRef>
+          <a:fillRef idx="3">
+            <a:schemeClr val="accent1"/>
+          </a:fillRef>
+          <a:effectRef idx="2">
+            <a:schemeClr val="accent1"/>
+          </a:effectRef>
+          <a:fontRef idx="minor">
+            <a:schemeClr val="lt1"/>
+          </a:fontRef>
+        </p:style>
+        <p:txBody>
+          <a:bodyPr rtlCol="0" anchor="ctr"/>
+          <a:lstStyle/>
+          <a:p>
+            <a:pPr algn="ctr"/>
+          </a:p>
+        </p:txBody>
+      </p:sp>
+      <p:sp>
+        <p:nvSpPr>
+          <p:cNvPr id="71" name="TextBox 70"/>
+          <p:cNvSpPr txBox="1"/>
+          <p:nvPr/>
+        </p:nvSpPr>
+        <p:spPr>
+          <a:xfrm>
+            <a:off x="2048256" y="4498848"/>
+            <a:ext cx="1115568" cy="228600"/>
+          </a:xfrm>
+          <a:prstGeom prst="rect">
+            <a:avLst/>
+          </a:prstGeom>
+          <a:noFill/>
+        </p:spPr>
+        <p:txBody>
+          <a:bodyPr wrap="square" lIns="0" tIns="0" rIns="0" bIns="0">
+            <a:spAutoFit/>
+          </a:bodyPr>
+          <a:lstStyle/>
+          <a:p>
+            <a:pPr algn="ctr"/>
+            <a:r>
+              <a:rPr sz="950" b="1" i="0">
+                <a:solidFill>
+                  <a:srgbClr val="047857"/>
+                </a:solidFill>
+                <a:latin typeface="JetBrains Mono"/>
+              </a:rPr>
+              <a:t>0 Tower</a:t>
+            </a:r>
+          </a:p>
+        </p:txBody>
+      </p:sp>
+      <p:sp>
+        <p:nvSpPr>
+          <p:cNvPr id="72" name="TextBox 71"/>
+          <p:cNvSpPr txBox="1"/>
+          <p:nvPr/>
+        </p:nvSpPr>
+        <p:spPr>
+          <a:xfrm>
+            <a:off x="2048256" y="4754880"/>
+            <a:ext cx="1115568" cy="182880"/>
+          </a:xfrm>
+          <a:prstGeom prst="rect">
+            <a:avLst/>
+          </a:prstGeom>
+          <a:noFill/>
+        </p:spPr>
+        <p:txBody>
+          <a:bodyPr wrap="square" lIns="0" tIns="0" rIns="0" bIns="0">
+            <a:spAutoFit/>
+          </a:bodyPr>
+          <a:lstStyle/>
+          <a:p>
+            <a:pPr algn="ctr"/>
+            <a:r>
+              <a:rPr sz="600" b="0" i="0">
+                <a:solidFill>
+                  <a:srgbClr val="64748B"/>
+                </a:solidFill>
+                <a:latin typeface="JetBrains Mono"/>
+              </a:rPr>
+              <a:t>Reliance</a:t>
+            </a:r>
+          </a:p>
+        </p:txBody>
+      </p:sp>
+      <p:sp>
+        <p:nvSpPr>
+          <p:cNvPr id="73" name="TextBox 72"/>
+          <p:cNvSpPr txBox="1"/>
+          <p:nvPr/>
+        </p:nvSpPr>
+        <p:spPr>
+          <a:xfrm>
+            <a:off x="841248" y="5102352"/>
+            <a:ext cx="1188720" cy="182880"/>
+          </a:xfrm>
+          <a:prstGeom prst="rect">
+            <a:avLst/>
+          </a:prstGeom>
+          <a:noFill/>
+        </p:spPr>
+        <p:txBody>
+          <a:bodyPr wrap="square" lIns="0" tIns="0" rIns="0" bIns="0">
+            <a:spAutoFit/>
+          </a:bodyPr>
+          <a:lstStyle/>
+          <a:p>
+            <a:pPr algn="l"/>
+            <a:r>
+              <a:rPr sz="600" b="0" i="0">
+                <a:solidFill>
+                  <a:srgbClr val="64748B"/>
+                </a:solidFill>
+                <a:latin typeface="JetBrains Mono"/>
+              </a:rPr>
+              <a:t>DECENTRALIZED VIO</a:t>
+            </a:r>
+          </a:p>
+        </p:txBody>
+      </p:sp>
+      <p:sp>
+        <p:nvSpPr>
+          <p:cNvPr id="74" name="TextBox 73"/>
+          <p:cNvSpPr txBox="1"/>
+          <p:nvPr/>
+        </p:nvSpPr>
+        <p:spPr>
+          <a:xfrm>
+            <a:off x="1965960" y="5102352"/>
+            <a:ext cx="1188720" cy="182880"/>
+          </a:xfrm>
+          <a:prstGeom prst="rect">
+            <a:avLst/>
+          </a:prstGeom>
+          <a:noFill/>
+        </p:spPr>
+        <p:txBody>
+          <a:bodyPr wrap="square" lIns="0" tIns="0" rIns="0" bIns="0">
+            <a:spAutoFit/>
+          </a:bodyPr>
+          <a:lstStyle/>
+          <a:p>
+            <a:pPr algn="r"/>
+            <a:r>
+              <a:rPr sz="600" b="1" i="0">
+                <a:solidFill>
+                  <a:srgbClr val="09090B"/>
+                </a:solidFill>
+                <a:latin typeface="JetBrains Mono"/>
+              </a:rPr>
+              <a:t>50Hz RATE</a:t>
+            </a:r>
+          </a:p>
+        </p:txBody>
+      </p:sp>
+      <p:sp>
+        <p:nvSpPr>
+          <p:cNvPr id="75" name="Rectangle 74"/>
+          <p:cNvSpPr/>
+          <p:nvPr/>
+        </p:nvSpPr>
+        <p:spPr>
+          <a:xfrm>
+            <a:off x="731520" y="5477255"/>
+            <a:ext cx="2542032" cy="36576"/>
+          </a:xfrm>
+          <a:prstGeom prst="rect">
+            <a:avLst/>
+          </a:prstGeom>
+          <a:solidFill>
+            <a:srgbClr val="047857"/>
+          </a:solidFill>
+          <a:ln>
+            <a:noFill/>
+          </a:ln>
+        </p:spPr>
+        <p:style>
+          <a:lnRef idx="1">
+            <a:schemeClr val="accent1"/>
+          </a:lnRef>
+          <a:fillRef idx="3">
+            <a:schemeClr val="accent1"/>
+          </a:fillRef>
+          <a:effectRef idx="2">
+            <a:schemeClr val="accent1"/>
+          </a:effectRef>
+          <a:fontRef idx="minor">
+            <a:schemeClr val="lt1"/>
+          </a:fontRef>
+        </p:style>
+        <p:txBody>
+          <a:bodyPr rtlCol="0" anchor="ctr"/>
+          <a:lstStyle/>
+          <a:p>
+            <a:pPr algn="ctr"/>
+          </a:p>
+        </p:txBody>
+      </p:sp>
+      <p:sp>
+        <p:nvSpPr>
+          <p:cNvPr id="76" name="Rounded Rectangle 75"/>
+          <p:cNvSpPr/>
+          <p:nvPr/>
+        </p:nvSpPr>
+        <p:spPr>
+          <a:xfrm>
+            <a:off x="3456432" y="1536192"/>
+            <a:ext cx="2542032" cy="3977639"/>
+          </a:xfrm>
+          <a:prstGeom prst="roundRect">
+            <a:avLst/>
+          </a:prstGeom>
+          <a:solidFill>
+            <a:srgbClr val="FFFFFF"/>
+          </a:solidFill>
+          <a:ln w="12700">
+            <a:solidFill>
+              <a:srgbClr val="E4E4E7"/>
+            </a:solidFill>
+          </a:ln>
+        </p:spPr>
+        <p:style>
+          <a:lnRef idx="1">
+            <a:schemeClr val="accent1"/>
+          </a:lnRef>
+          <a:fillRef idx="3">
+            <a:schemeClr val="accent1"/>
+          </a:fillRef>
+          <a:effectRef idx="2">
+            <a:schemeClr val="accent1"/>
+          </a:effectRef>
+          <a:fontRef idx="minor">
+            <a:schemeClr val="lt1"/>
+          </a:fontRef>
+        </p:style>
+        <p:txBody>
+          <a:bodyPr rtlCol="0" anchor="ctr"/>
+          <a:lstStyle/>
+          <a:p>
+            <a:pPr algn="ctr"/>
+          </a:p>
+        </p:txBody>
+      </p:sp>
+      <p:sp>
+        <p:nvSpPr>
+          <p:cNvPr id="77" name="TextBox 76"/>
+          <p:cNvSpPr txBox="1"/>
+          <p:nvPr/>
+        </p:nvSpPr>
+        <p:spPr>
+          <a:xfrm>
+            <a:off x="3566160" y="1645920"/>
+            <a:ext cx="1188720" cy="182880"/>
+          </a:xfrm>
+          <a:prstGeom prst="rect">
+            <a:avLst/>
+          </a:prstGeom>
+          <a:noFill/>
+        </p:spPr>
+        <p:txBody>
+          <a:bodyPr wrap="square" lIns="0" tIns="0" rIns="0" bIns="0">
+            <a:spAutoFit/>
+          </a:bodyPr>
+          <a:lstStyle/>
+          <a:p>
+            <a:pPr algn="l"/>
+            <a:r>
+              <a:rPr sz="700" b="1" i="0">
+                <a:solidFill>
+                  <a:srgbClr val="94A3B8"/>
+                </a:solidFill>
+                <a:latin typeface="JetBrains Mono"/>
+              </a:rPr>
+              <a:t>SUBSYSTEM B</a:t>
+            </a:r>
+          </a:p>
+        </p:txBody>
+      </p:sp>
+      <p:sp>
+        <p:nvSpPr>
+          <p:cNvPr id="78" name="Rounded Rectangle 77"/>
+          <p:cNvSpPr/>
+          <p:nvPr/>
+        </p:nvSpPr>
+        <p:spPr>
+          <a:xfrm>
+            <a:off x="4782312" y="1627632"/>
+            <a:ext cx="1097280" cy="201168"/>
+          </a:xfrm>
+          <a:prstGeom prst="roundRect">
+            <a:avLst/>
+          </a:prstGeom>
+          <a:solidFill>
+            <a:srgbClr val="ECFDF5"/>
+          </a:solidFill>
+          <a:ln w="12700">
+            <a:solidFill>
+              <a:srgbClr val="A7F3D0"/>
+            </a:solidFill>
+          </a:ln>
+        </p:spPr>
+        <p:style>
+          <a:lnRef idx="1">
+            <a:schemeClr val="accent1"/>
+          </a:lnRef>
+          <a:fillRef idx="3">
+            <a:schemeClr val="accent1"/>
+          </a:fillRef>
+          <a:effectRef idx="2">
+            <a:schemeClr val="accent1"/>
+          </a:effectRef>
+          <a:fontRef idx="minor">
+            <a:schemeClr val="lt1"/>
+          </a:fontRef>
+        </p:style>
+        <p:txBody>
+          <a:bodyPr rtlCol="0" anchor="ctr"/>
+          <a:lstStyle/>
+          <a:p>
+            <a:pPr algn="ctr"/>
+          </a:p>
+        </p:txBody>
+      </p:sp>
+      <p:sp>
+        <p:nvSpPr>
+          <p:cNvPr id="79" name="TextBox 78"/>
+          <p:cNvSpPr txBox="1"/>
+          <p:nvPr/>
+        </p:nvSpPr>
+        <p:spPr>
+          <a:xfrm>
+            <a:off x="4782312" y="1645920"/>
+            <a:ext cx="1097280" cy="182880"/>
+          </a:xfrm>
+          <a:prstGeom prst="rect">
+            <a:avLst/>
+          </a:prstGeom>
+          <a:noFill/>
+        </p:spPr>
+        <p:txBody>
+          <a:bodyPr wrap="square" lIns="0" tIns="0" rIns="0" bIns="0">
+            <a:spAutoFit/>
+          </a:bodyPr>
+          <a:lstStyle/>
+          <a:p>
+            <a:pPr algn="ctr"/>
+            <a:r>
+              <a:rPr sz="650" b="1" i="0">
+                <a:solidFill>
+                  <a:srgbClr val="047857"/>
+                </a:solidFill>
+                <a:latin typeface="JetBrains Mono"/>
+              </a:rPr>
+              <a:t>-5dB RESILIENT</a:t>
+            </a:r>
+          </a:p>
+        </p:txBody>
+      </p:sp>
+      <p:sp>
+        <p:nvSpPr>
+          <p:cNvPr id="80" name="TextBox 79"/>
+          <p:cNvSpPr txBox="1"/>
+          <p:nvPr/>
+        </p:nvSpPr>
+        <p:spPr>
+          <a:xfrm>
+            <a:off x="3566160" y="1883664"/>
+            <a:ext cx="2322576" cy="411480"/>
           </a:xfrm>
           <a:prstGeom prst="rect">
             <a:avLst/>
@@ -14199,31 +14202,31 @@
                 </a:solidFill>
                 <a:latin typeface="Space Grotesk"/>
               </a:rPr>
-              <a:t>Subsystem B Moat: Deep JSCC Neural Video</a:t>
-            </a:r>
-          </a:p>
-        </p:txBody>
-      </p:sp>
-      <p:sp>
-        <p:nvSpPr>
-          <p:cNvPr id="82" name="Rounded Rectangle 81"/>
-          <p:cNvSpPr/>
-          <p:nvPr/>
-        </p:nvSpPr>
-        <p:spPr>
-          <a:xfrm>
-            <a:off x="9875520" y="3291840"/>
-            <a:ext cx="1371600" cy="201168"/>
+              <a:t>Deep JSCC Neural Video</a:t>
+            </a:r>
+          </a:p>
+        </p:txBody>
+      </p:sp>
+      <p:sp>
+        <p:nvSpPr>
+          <p:cNvPr id="81" name="Rounded Rectangle 80"/>
+          <p:cNvSpPr/>
+          <p:nvPr/>
+        </p:nvSpPr>
+        <p:spPr>
+          <a:xfrm>
+            <a:off x="3566160" y="2359152"/>
+            <a:ext cx="2322576" cy="594360"/>
           </a:xfrm>
           <a:prstGeom prst="roundRect">
             <a:avLst/>
           </a:prstGeom>
           <a:solidFill>
-            <a:srgbClr val="ECFDF5"/>
+            <a:srgbClr val="FEF2F2"/>
           </a:solidFill>
           <a:ln w="12700">
             <a:solidFill>
-              <a:srgbClr val="A7F3D0"/>
+              <a:srgbClr val="FECDCD"/>
             </a:solidFill>
           </a:ln>
         </p:spPr>
@@ -14251,14 +14254,14 @@
       </p:sp>
       <p:sp>
         <p:nvSpPr>
-          <p:cNvPr id="83" name="TextBox 82"/>
+          <p:cNvPr id="82" name="TextBox 81"/>
           <p:cNvSpPr txBox="1"/>
           <p:nvPr/>
         </p:nvSpPr>
         <p:spPr>
           <a:xfrm>
-            <a:off x="9875520" y="3310128"/>
-            <a:ext cx="1371600" cy="182880"/>
+            <a:off x="3621024" y="2395728"/>
+            <a:ext cx="2212848" cy="164592"/>
           </a:xfrm>
           <a:prstGeom prst="rect">
             <a:avLst/>
@@ -14271,29 +14274,259 @@
           </a:bodyPr>
           <a:lstStyle/>
           <a:p>
-            <a:pPr algn="ctr"/>
-            <a:r>
-              <a:rPr sz="700" b="1" i="0">
+            <a:pPr algn="l"/>
+            <a:r>
+              <a:rPr sz="600" b="1" i="0">
+                <a:solidFill>
+                  <a:srgbClr val="D71920"/>
+                </a:solidFill>
+                <a:latin typeface="JetBrains Mono"/>
+              </a:rPr>
+              <a:t>SOLVES PROBLEM VOID:</a:t>
+            </a:r>
+          </a:p>
+        </p:txBody>
+      </p:sp>
+      <p:sp>
+        <p:nvSpPr>
+          <p:cNvPr id="83" name="TextBox 82"/>
+          <p:cNvSpPr txBox="1"/>
+          <p:nvPr/>
+        </p:nvSpPr>
+        <p:spPr>
+          <a:xfrm>
+            <a:off x="3621024" y="2560320"/>
+            <a:ext cx="2212848" cy="365760"/>
+          </a:xfrm>
+          <a:prstGeom prst="rect">
+            <a:avLst/>
+          </a:prstGeom>
+          <a:noFill/>
+        </p:spPr>
+        <p:txBody>
+          <a:bodyPr wrap="square" lIns="0" tIns="0" rIns="0" bIns="0">
+            <a:spAutoFit/>
+          </a:bodyPr>
+          <a:lstStyle/>
+          <a:p>
+            <a:pPr algn="l"/>
+            <a:r>
+              <a:rPr sz="750" b="1" i="0">
+                <a:solidFill>
+                  <a:srgbClr val="09090B"/>
+                </a:solidFill>
+                <a:latin typeface="Inter"/>
+              </a:rPr>
+              <a:t>Mountain Ravine RF Ridge Blackout</a:t>
+            </a:r>
+          </a:p>
+        </p:txBody>
+      </p:sp>
+      <p:sp>
+        <p:nvSpPr>
+          <p:cNvPr id="84" name="Rounded Rectangle 83"/>
+          <p:cNvSpPr/>
+          <p:nvPr/>
+        </p:nvSpPr>
+        <p:spPr>
+          <a:xfrm>
+            <a:off x="3566160" y="3044952"/>
+            <a:ext cx="2322576" cy="1325880"/>
+          </a:xfrm>
+          <a:prstGeom prst="roundRect">
+            <a:avLst/>
+          </a:prstGeom>
+          <a:solidFill>
+            <a:srgbClr val="F8FAFC"/>
+          </a:solidFill>
+          <a:ln w="12700">
+            <a:solidFill>
+              <a:srgbClr val="E4E4E7"/>
+            </a:solidFill>
+          </a:ln>
+        </p:spPr>
+        <p:style>
+          <a:lnRef idx="1">
+            <a:schemeClr val="accent1"/>
+          </a:lnRef>
+          <a:fillRef idx="3">
+            <a:schemeClr val="accent1"/>
+          </a:fillRef>
+          <a:effectRef idx="2">
+            <a:schemeClr val="accent1"/>
+          </a:effectRef>
+          <a:fontRef idx="minor">
+            <a:schemeClr val="lt1"/>
+          </a:fontRef>
+        </p:style>
+        <p:txBody>
+          <a:bodyPr rtlCol="0" anchor="ctr"/>
+          <a:lstStyle/>
+          <a:p>
+            <a:pPr algn="ctr"/>
+          </a:p>
+        </p:txBody>
+      </p:sp>
+      <p:sp>
+        <p:nvSpPr>
+          <p:cNvPr id="85" name="TextBox 84"/>
+          <p:cNvSpPr txBox="1"/>
+          <p:nvPr/>
+        </p:nvSpPr>
+        <p:spPr>
+          <a:xfrm>
+            <a:off x="3621024" y="3090672"/>
+            <a:ext cx="2212848" cy="164592"/>
+          </a:xfrm>
+          <a:prstGeom prst="rect">
+            <a:avLst/>
+          </a:prstGeom>
+          <a:noFill/>
+        </p:spPr>
+        <p:txBody>
+          <a:bodyPr wrap="square" lIns="0" tIns="0" rIns="0" bIns="0">
+            <a:spAutoFit/>
+          </a:bodyPr>
+          <a:lstStyle/>
+          <a:p>
+            <a:pPr algn="l"/>
+            <a:r>
+              <a:rPr sz="650" b="1" i="0">
+                <a:solidFill>
+                  <a:srgbClr val="047857"/>
+                </a:solidFill>
+                <a:latin typeface="JetBrains Mono"/>
+              </a:rPr>
+              <a:t>SOLUTIONAL MOAT:</a:t>
+            </a:r>
+          </a:p>
+        </p:txBody>
+      </p:sp>
+      <p:sp>
+        <p:nvSpPr>
+          <p:cNvPr id="86" name="TextBox 85"/>
+          <p:cNvSpPr txBox="1"/>
+          <p:nvPr/>
+        </p:nvSpPr>
+        <p:spPr>
+          <a:xfrm>
+            <a:off x="3621024" y="3291840"/>
+            <a:ext cx="2212848" cy="1005840"/>
+          </a:xfrm>
+          <a:prstGeom prst="rect">
+            <a:avLst/>
+          </a:prstGeom>
+          <a:noFill/>
+        </p:spPr>
+        <p:txBody>
+          <a:bodyPr wrap="square" lIns="0" tIns="0" rIns="0" bIns="0">
+            <a:spAutoFit/>
+          </a:bodyPr>
+          <a:lstStyle/>
+          <a:p>
+            <a:pPr algn="l"/>
+            <a:r>
+              <a:rPr sz="720" b="0" i="0">
+                <a:solidFill>
+                  <a:srgbClr val="475569"/>
+                </a:solidFill>
+                <a:latin typeface="JetBrains Mono"/>
+              </a:rPr>
+              <a:t>Differentiable joint source-channel coding yielding zero digital cliff and graceful video degradation down to -5dB.</a:t>
+            </a:r>
+          </a:p>
+        </p:txBody>
+      </p:sp>
+      <p:sp>
+        <p:nvSpPr>
+          <p:cNvPr id="87" name="Rounded Rectangle 86"/>
+          <p:cNvSpPr/>
+          <p:nvPr/>
+        </p:nvSpPr>
+        <p:spPr>
+          <a:xfrm>
+            <a:off x="3566160" y="4462272"/>
+            <a:ext cx="1115568" cy="502920"/>
+          </a:xfrm>
+          <a:prstGeom prst="roundRect">
+            <a:avLst/>
+          </a:prstGeom>
+          <a:solidFill>
+            <a:srgbClr val="F8FAFC"/>
+          </a:solidFill>
+          <a:ln w="12700">
+            <a:solidFill>
+              <a:srgbClr val="E4E4E7"/>
+            </a:solidFill>
+          </a:ln>
+        </p:spPr>
+        <p:style>
+          <a:lnRef idx="1">
+            <a:schemeClr val="accent1"/>
+          </a:lnRef>
+          <a:fillRef idx="3">
+            <a:schemeClr val="accent1"/>
+          </a:fillRef>
+          <a:effectRef idx="2">
+            <a:schemeClr val="accent1"/>
+          </a:effectRef>
+          <a:fontRef idx="minor">
+            <a:schemeClr val="lt1"/>
+          </a:fontRef>
+        </p:style>
+        <p:txBody>
+          <a:bodyPr rtlCol="0" anchor="ctr"/>
+          <a:lstStyle/>
+          <a:p>
+            <a:pPr algn="ctr"/>
+          </a:p>
+        </p:txBody>
+      </p:sp>
+      <p:sp>
+        <p:nvSpPr>
+          <p:cNvPr id="88" name="TextBox 87"/>
+          <p:cNvSpPr txBox="1"/>
+          <p:nvPr/>
+        </p:nvSpPr>
+        <p:spPr>
+          <a:xfrm>
+            <a:off x="3566160" y="4498848"/>
+            <a:ext cx="1115568" cy="228600"/>
+          </a:xfrm>
+          <a:prstGeom prst="rect">
+            <a:avLst/>
+          </a:prstGeom>
+          <a:noFill/>
+        </p:spPr>
+        <p:txBody>
+          <a:bodyPr wrap="square" lIns="0" tIns="0" rIns="0" bIns="0">
+            <a:spAutoFit/>
+          </a:bodyPr>
+          <a:lstStyle/>
+          <a:p>
+            <a:pPr algn="ctr"/>
+            <a:r>
+              <a:rPr sz="950" b="1" i="0">
                 <a:solidFill>
                   <a:srgbClr val="09090B"/>
                 </a:solidFill>
                 <a:latin typeface="JetBrains Mono"/>
               </a:rPr>
-              <a:t>-5dB RESILIENT</a:t>
-            </a:r>
-          </a:p>
-        </p:txBody>
-      </p:sp>
-      <p:sp>
-        <p:nvSpPr>
-          <p:cNvPr id="84" name="TextBox 83"/>
+              <a:t>-5dB</a:t>
+            </a:r>
+          </a:p>
+        </p:txBody>
+      </p:sp>
+      <p:sp>
+        <p:nvSpPr>
+          <p:cNvPr id="89" name="TextBox 88"/>
           <p:cNvSpPr txBox="1"/>
           <p:nvPr/>
         </p:nvSpPr>
         <p:spPr>
           <a:xfrm>
-            <a:off x="5486400" y="3584448"/>
-            <a:ext cx="5760720" cy="475488"/>
+            <a:off x="3566160" y="4754880"/>
+            <a:ext cx="1115568" cy="182880"/>
           </a:xfrm>
           <a:prstGeom prst="rect">
             <a:avLst/>
@@ -14306,35 +14539,35 @@
           </a:bodyPr>
           <a:lstStyle/>
           <a:p>
-            <a:pPr algn="l"/>
-            <a:r>
-              <a:rPr sz="780" b="0" i="0">
+            <a:pPr algn="ctr"/>
+            <a:r>
+              <a:rPr sz="600" b="0" i="0">
                 <a:solidFill>
-                  <a:srgbClr val="475569"/>
+                  <a:srgbClr val="64748B"/>
                 </a:solidFill>
                 <a:latin typeface="JetBrains Mono"/>
               </a:rPr>
-              <a:t>Zero-cliff neural semantic video encoding with graceful degradation under severe mountain ravine occlusion.</a:t>
-            </a:r>
-          </a:p>
-        </p:txBody>
-      </p:sp>
-      <p:sp>
-        <p:nvSpPr>
-          <p:cNvPr id="85" name="Rounded Rectangle 84"/>
-          <p:cNvSpPr/>
-          <p:nvPr/>
-        </p:nvSpPr>
-        <p:spPr>
-          <a:xfrm>
-            <a:off x="5303520" y="4306824"/>
-            <a:ext cx="6126480" cy="960120"/>
+              <a:t>SNR Thresh</a:t>
+            </a:r>
+          </a:p>
+        </p:txBody>
+      </p:sp>
+      <p:sp>
+        <p:nvSpPr>
+          <p:cNvPr id="90" name="Rounded Rectangle 89"/>
+          <p:cNvSpPr/>
+          <p:nvPr/>
+        </p:nvSpPr>
+        <p:spPr>
+          <a:xfrm>
+            <a:off x="4773168" y="4462272"/>
+            <a:ext cx="1115568" cy="502920"/>
           </a:xfrm>
           <a:prstGeom prst="roundRect">
             <a:avLst/>
           </a:prstGeom>
           <a:solidFill>
-            <a:srgbClr val="FFFFFF"/>
+            <a:srgbClr val="F8FAFC"/>
           </a:solidFill>
           <a:ln w="12700">
             <a:solidFill>
@@ -14366,14 +14599,357 @@
       </p:sp>
       <p:sp>
         <p:nvSpPr>
-          <p:cNvPr id="86" name="TextBox 85"/>
+          <p:cNvPr id="91" name="TextBox 90"/>
           <p:cNvSpPr txBox="1"/>
           <p:nvPr/>
         </p:nvSpPr>
         <p:spPr>
           <a:xfrm>
-            <a:off x="5486400" y="4416552"/>
-            <a:ext cx="4114800" cy="228600"/>
+            <a:off x="4773168" y="4498848"/>
+            <a:ext cx="1115568" cy="228600"/>
+          </a:xfrm>
+          <a:prstGeom prst="rect">
+            <a:avLst/>
+          </a:prstGeom>
+          <a:noFill/>
+        </p:spPr>
+        <p:txBody>
+          <a:bodyPr wrap="square" lIns="0" tIns="0" rIns="0" bIns="0">
+            <a:spAutoFit/>
+          </a:bodyPr>
+          <a:lstStyle/>
+          <a:p>
+            <a:pPr algn="ctr"/>
+            <a:r>
+              <a:rPr sz="950" b="1" i="0">
+                <a:solidFill>
+                  <a:srgbClr val="047857"/>
+                </a:solidFill>
+                <a:latin typeface="JetBrains Mono"/>
+              </a:rPr>
+              <a:t>0 Cliff</a:t>
+            </a:r>
+          </a:p>
+        </p:txBody>
+      </p:sp>
+      <p:sp>
+        <p:nvSpPr>
+          <p:cNvPr id="92" name="TextBox 91"/>
+          <p:cNvSpPr txBox="1"/>
+          <p:nvPr/>
+        </p:nvSpPr>
+        <p:spPr>
+          <a:xfrm>
+            <a:off x="4773168" y="4754880"/>
+            <a:ext cx="1115568" cy="182880"/>
+          </a:xfrm>
+          <a:prstGeom prst="rect">
+            <a:avLst/>
+          </a:prstGeom>
+          <a:noFill/>
+        </p:spPr>
+        <p:txBody>
+          <a:bodyPr wrap="square" lIns="0" tIns="0" rIns="0" bIns="0">
+            <a:spAutoFit/>
+          </a:bodyPr>
+          <a:lstStyle/>
+          <a:p>
+            <a:pPr algn="ctr"/>
+            <a:r>
+              <a:rPr sz="600" b="0" i="0">
+                <a:solidFill>
+                  <a:srgbClr val="64748B"/>
+                </a:solidFill>
+                <a:latin typeface="JetBrains Mono"/>
+              </a:rPr>
+              <a:t>Degradation</a:t>
+            </a:r>
+          </a:p>
+        </p:txBody>
+      </p:sp>
+      <p:sp>
+        <p:nvSpPr>
+          <p:cNvPr id="93" name="TextBox 92"/>
+          <p:cNvSpPr txBox="1"/>
+          <p:nvPr/>
+        </p:nvSpPr>
+        <p:spPr>
+          <a:xfrm>
+            <a:off x="3566160" y="5102352"/>
+            <a:ext cx="1188720" cy="182880"/>
+          </a:xfrm>
+          <a:prstGeom prst="rect">
+            <a:avLst/>
+          </a:prstGeom>
+          <a:noFill/>
+        </p:spPr>
+        <p:txBody>
+          <a:bodyPr wrap="square" lIns="0" tIns="0" rIns="0" bIns="0">
+            <a:spAutoFit/>
+          </a:bodyPr>
+          <a:lstStyle/>
+          <a:p>
+            <a:pPr algn="l"/>
+            <a:r>
+              <a:rPr sz="600" b="0" i="0">
+                <a:solidFill>
+                  <a:srgbClr val="64748B"/>
+                </a:solidFill>
+                <a:latin typeface="JetBrains Mono"/>
+              </a:rPr>
+              <a:t>SEMANTIC COMMS</a:t>
+            </a:r>
+          </a:p>
+        </p:txBody>
+      </p:sp>
+      <p:sp>
+        <p:nvSpPr>
+          <p:cNvPr id="94" name="TextBox 93"/>
+          <p:cNvSpPr txBox="1"/>
+          <p:nvPr/>
+        </p:nvSpPr>
+        <p:spPr>
+          <a:xfrm>
+            <a:off x="4690872" y="5102352"/>
+            <a:ext cx="1188720" cy="182880"/>
+          </a:xfrm>
+          <a:prstGeom prst="rect">
+            <a:avLst/>
+          </a:prstGeom>
+          <a:noFill/>
+        </p:spPr>
+        <p:txBody>
+          <a:bodyPr wrap="square" lIns="0" tIns="0" rIns="0" bIns="0">
+            <a:spAutoFit/>
+          </a:bodyPr>
+          <a:lstStyle/>
+          <a:p>
+            <a:pPr algn="r"/>
+            <a:r>
+              <a:rPr sz="600" b="1" i="0">
+                <a:solidFill>
+                  <a:srgbClr val="09090B"/>
+                </a:solidFill>
+                <a:latin typeface="JetBrains Mono"/>
+              </a:rPr>
+              <a:t>EDGE TPU</a:t>
+            </a:r>
+          </a:p>
+        </p:txBody>
+      </p:sp>
+      <p:sp>
+        <p:nvSpPr>
+          <p:cNvPr id="95" name="Rectangle 94"/>
+          <p:cNvSpPr/>
+          <p:nvPr/>
+        </p:nvSpPr>
+        <p:spPr>
+          <a:xfrm>
+            <a:off x="3456432" y="5477255"/>
+            <a:ext cx="2542032" cy="36576"/>
+          </a:xfrm>
+          <a:prstGeom prst="rect">
+            <a:avLst/>
+          </a:prstGeom>
+          <a:solidFill>
+            <a:srgbClr val="09090B"/>
+          </a:solidFill>
+          <a:ln>
+            <a:noFill/>
+          </a:ln>
+        </p:spPr>
+        <p:style>
+          <a:lnRef idx="1">
+            <a:schemeClr val="accent1"/>
+          </a:lnRef>
+          <a:fillRef idx="3">
+            <a:schemeClr val="accent1"/>
+          </a:fillRef>
+          <a:effectRef idx="2">
+            <a:schemeClr val="accent1"/>
+          </a:effectRef>
+          <a:fontRef idx="minor">
+            <a:schemeClr val="lt1"/>
+          </a:fontRef>
+        </p:style>
+        <p:txBody>
+          <a:bodyPr rtlCol="0" anchor="ctr"/>
+          <a:lstStyle/>
+          <a:p>
+            <a:pPr algn="ctr"/>
+          </a:p>
+        </p:txBody>
+      </p:sp>
+      <p:sp>
+        <p:nvSpPr>
+          <p:cNvPr id="96" name="Rounded Rectangle 95"/>
+          <p:cNvSpPr/>
+          <p:nvPr/>
+        </p:nvSpPr>
+        <p:spPr>
+          <a:xfrm>
+            <a:off x="6181344" y="1536192"/>
+            <a:ext cx="2542032" cy="3977639"/>
+          </a:xfrm>
+          <a:prstGeom prst="roundRect">
+            <a:avLst/>
+          </a:prstGeom>
+          <a:solidFill>
+            <a:srgbClr val="FFFFFF"/>
+          </a:solidFill>
+          <a:ln w="12700">
+            <a:solidFill>
+              <a:srgbClr val="E4E4E7"/>
+            </a:solidFill>
+          </a:ln>
+        </p:spPr>
+        <p:style>
+          <a:lnRef idx="1">
+            <a:schemeClr val="accent1"/>
+          </a:lnRef>
+          <a:fillRef idx="3">
+            <a:schemeClr val="accent1"/>
+          </a:fillRef>
+          <a:effectRef idx="2">
+            <a:schemeClr val="accent1"/>
+          </a:effectRef>
+          <a:fontRef idx="minor">
+            <a:schemeClr val="lt1"/>
+          </a:fontRef>
+        </p:style>
+        <p:txBody>
+          <a:bodyPr rtlCol="0" anchor="ctr"/>
+          <a:lstStyle/>
+          <a:p>
+            <a:pPr algn="ctr"/>
+          </a:p>
+        </p:txBody>
+      </p:sp>
+      <p:sp>
+        <p:nvSpPr>
+          <p:cNvPr id="97" name="TextBox 96"/>
+          <p:cNvSpPr txBox="1"/>
+          <p:nvPr/>
+        </p:nvSpPr>
+        <p:spPr>
+          <a:xfrm>
+            <a:off x="6291072" y="1645920"/>
+            <a:ext cx="1188720" cy="182880"/>
+          </a:xfrm>
+          <a:prstGeom prst="rect">
+            <a:avLst/>
+          </a:prstGeom>
+          <a:noFill/>
+        </p:spPr>
+        <p:txBody>
+          <a:bodyPr wrap="square" lIns="0" tIns="0" rIns="0" bIns="0">
+            <a:spAutoFit/>
+          </a:bodyPr>
+          <a:lstStyle/>
+          <a:p>
+            <a:pPr algn="l"/>
+            <a:r>
+              <a:rPr sz="700" b="1" i="0">
+                <a:solidFill>
+                  <a:srgbClr val="94A3B8"/>
+                </a:solidFill>
+                <a:latin typeface="JetBrains Mono"/>
+              </a:rPr>
+              <a:t>SUBSYSTEM C</a:t>
+            </a:r>
+          </a:p>
+        </p:txBody>
+      </p:sp>
+      <p:sp>
+        <p:nvSpPr>
+          <p:cNvPr id="98" name="Rounded Rectangle 97"/>
+          <p:cNvSpPr/>
+          <p:nvPr/>
+        </p:nvSpPr>
+        <p:spPr>
+          <a:xfrm>
+            <a:off x="7507224" y="1627632"/>
+            <a:ext cx="1097280" cy="201168"/>
+          </a:xfrm>
+          <a:prstGeom prst="roundRect">
+            <a:avLst/>
+          </a:prstGeom>
+          <a:solidFill>
+            <a:srgbClr val="ECFDF5"/>
+          </a:solidFill>
+          <a:ln w="12700">
+            <a:solidFill>
+              <a:srgbClr val="A7F3D0"/>
+            </a:solidFill>
+          </a:ln>
+        </p:spPr>
+        <p:style>
+          <a:lnRef idx="1">
+            <a:schemeClr val="accent1"/>
+          </a:lnRef>
+          <a:fillRef idx="3">
+            <a:schemeClr val="accent1"/>
+          </a:fillRef>
+          <a:effectRef idx="2">
+            <a:schemeClr val="accent1"/>
+          </a:effectRef>
+          <a:fontRef idx="minor">
+            <a:schemeClr val="lt1"/>
+          </a:fontRef>
+        </p:style>
+        <p:txBody>
+          <a:bodyPr rtlCol="0" anchor="ctr"/>
+          <a:lstStyle/>
+          <a:p>
+            <a:pPr algn="ctr"/>
+          </a:p>
+        </p:txBody>
+      </p:sp>
+      <p:sp>
+        <p:nvSpPr>
+          <p:cNvPr id="99" name="TextBox 98"/>
+          <p:cNvSpPr txBox="1"/>
+          <p:nvPr/>
+        </p:nvSpPr>
+        <p:spPr>
+          <a:xfrm>
+            <a:off x="7507224" y="1645920"/>
+            <a:ext cx="1097280" cy="182880"/>
+          </a:xfrm>
+          <a:prstGeom prst="rect">
+            <a:avLst/>
+          </a:prstGeom>
+          <a:noFill/>
+        </p:spPr>
+        <p:txBody>
+          <a:bodyPr wrap="square" lIns="0" tIns="0" rIns="0" bIns="0">
+            <a:spAutoFit/>
+          </a:bodyPr>
+          <a:lstStyle/>
+          <a:p>
+            <a:pPr algn="ctr"/>
+            <a:r>
+              <a:rPr sz="650" b="1" i="0">
+                <a:solidFill>
+                  <a:srgbClr val="047857"/>
+                </a:solidFill>
+                <a:latin typeface="JetBrains Mono"/>
+              </a:rPr>
+              <a:t>3.59cm ACCURACY</a:t>
+            </a:r>
+          </a:p>
+        </p:txBody>
+      </p:sp>
+      <p:sp>
+        <p:nvSpPr>
+          <p:cNvPr id="100" name="TextBox 99"/>
+          <p:cNvSpPr txBox="1"/>
+          <p:nvPr/>
+        </p:nvSpPr>
+        <p:spPr>
+          <a:xfrm>
+            <a:off x="6291072" y="1883664"/>
+            <a:ext cx="2322576" cy="411480"/>
           </a:xfrm>
           <a:prstGeom prst="rect">
             <a:avLst/>
@@ -14394,31 +14970,31 @@
                 </a:solidFill>
                 <a:latin typeface="Space Grotesk"/>
               </a:rPr>
-              <a:t>Subsystem C/D Moat: 3D DEM Terrain Raycasting</a:t>
-            </a:r>
-          </a:p>
-        </p:txBody>
-      </p:sp>
-      <p:sp>
-        <p:nvSpPr>
-          <p:cNvPr id="87" name="Rounded Rectangle 86"/>
-          <p:cNvSpPr/>
-          <p:nvPr/>
-        </p:nvSpPr>
-        <p:spPr>
-          <a:xfrm>
-            <a:off x="9875520" y="4416552"/>
-            <a:ext cx="1371600" cy="201168"/>
+              <a:t>3D DEM AI Geolocation</a:t>
+            </a:r>
+          </a:p>
+        </p:txBody>
+      </p:sp>
+      <p:sp>
+        <p:nvSpPr>
+          <p:cNvPr id="101" name="Rounded Rectangle 100"/>
+          <p:cNvSpPr/>
+          <p:nvPr/>
+        </p:nvSpPr>
+        <p:spPr>
+          <a:xfrm>
+            <a:off x="6291072" y="2359152"/>
+            <a:ext cx="2322576" cy="594360"/>
           </a:xfrm>
           <a:prstGeom prst="roundRect">
             <a:avLst/>
           </a:prstGeom>
           <a:solidFill>
-            <a:srgbClr val="ECFDF5"/>
+            <a:srgbClr val="FEF2F2"/>
           </a:solidFill>
           <a:ln w="12700">
             <a:solidFill>
-              <a:srgbClr val="A7F3D0"/>
+              <a:srgbClr val="FECDCD"/>
             </a:solidFill>
           </a:ln>
         </p:spPr>
@@ -14446,14 +15022,14 @@
       </p:sp>
       <p:sp>
         <p:nvSpPr>
-          <p:cNvPr id="88" name="TextBox 87"/>
+          <p:cNvPr id="102" name="TextBox 101"/>
           <p:cNvSpPr txBox="1"/>
           <p:nvPr/>
         </p:nvSpPr>
         <p:spPr>
           <a:xfrm>
-            <a:off x="9875520" y="4434840"/>
-            <a:ext cx="1371600" cy="182880"/>
+            <a:off x="6345936" y="2395728"/>
+            <a:ext cx="2212848" cy="164592"/>
           </a:xfrm>
           <a:prstGeom prst="rect">
             <a:avLst/>
@@ -14466,29 +15042,144 @@
           </a:bodyPr>
           <a:lstStyle/>
           <a:p>
-            <a:pPr algn="ctr"/>
-            <a:r>
-              <a:rPr sz="700" b="1" i="0">
+            <a:pPr algn="l"/>
+            <a:r>
+              <a:rPr sz="600" b="1" i="0">
+                <a:solidFill>
+                  <a:srgbClr val="D71920"/>
+                </a:solidFill>
+                <a:latin typeface="JetBrains Mono"/>
+              </a:rPr>
+              <a:t>SOLVES PROBLEM VOID:</a:t>
+            </a:r>
+          </a:p>
+        </p:txBody>
+      </p:sp>
+      <p:sp>
+        <p:nvSpPr>
+          <p:cNvPr id="103" name="TextBox 102"/>
+          <p:cNvSpPr txBox="1"/>
+          <p:nvPr/>
+        </p:nvSpPr>
+        <p:spPr>
+          <a:xfrm>
+            <a:off x="6345936" y="2560320"/>
+            <a:ext cx="2212848" cy="365760"/>
+          </a:xfrm>
+          <a:prstGeom prst="rect">
+            <a:avLst/>
+          </a:prstGeom>
+          <a:noFill/>
+        </p:spPr>
+        <p:txBody>
+          <a:bodyPr wrap="square" lIns="0" tIns="0" rIns="0" bIns="0">
+            <a:spAutoFit/>
+          </a:bodyPr>
+          <a:lstStyle/>
+          <a:p>
+            <a:pPr algn="l"/>
+            <a:r>
+              <a:rPr sz="750" b="1" i="0">
+                <a:solidFill>
+                  <a:srgbClr val="09090B"/>
+                </a:solidFill>
+                <a:latin typeface="Inter"/>
+              </a:rPr>
+              <a:t>35% False Alarms &amp; Flat GPS Drift</a:t>
+            </a:r>
+          </a:p>
+        </p:txBody>
+      </p:sp>
+      <p:sp>
+        <p:nvSpPr>
+          <p:cNvPr id="104" name="Rounded Rectangle 103"/>
+          <p:cNvSpPr/>
+          <p:nvPr/>
+        </p:nvSpPr>
+        <p:spPr>
+          <a:xfrm>
+            <a:off x="6291072" y="3044952"/>
+            <a:ext cx="2322576" cy="1325880"/>
+          </a:xfrm>
+          <a:prstGeom prst="roundRect">
+            <a:avLst/>
+          </a:prstGeom>
+          <a:solidFill>
+            <a:srgbClr val="F8FAFC"/>
+          </a:solidFill>
+          <a:ln w="12700">
+            <a:solidFill>
+              <a:srgbClr val="E4E4E7"/>
+            </a:solidFill>
+          </a:ln>
+        </p:spPr>
+        <p:style>
+          <a:lnRef idx="1">
+            <a:schemeClr val="accent1"/>
+          </a:lnRef>
+          <a:fillRef idx="3">
+            <a:schemeClr val="accent1"/>
+          </a:fillRef>
+          <a:effectRef idx="2">
+            <a:schemeClr val="accent1"/>
+          </a:effectRef>
+          <a:fontRef idx="minor">
+            <a:schemeClr val="lt1"/>
+          </a:fontRef>
+        </p:style>
+        <p:txBody>
+          <a:bodyPr rtlCol="0" anchor="ctr"/>
+          <a:lstStyle/>
+          <a:p>
+            <a:pPr algn="ctr"/>
+          </a:p>
+        </p:txBody>
+      </p:sp>
+      <p:sp>
+        <p:nvSpPr>
+          <p:cNvPr id="105" name="TextBox 104"/>
+          <p:cNvSpPr txBox="1"/>
+          <p:nvPr/>
+        </p:nvSpPr>
+        <p:spPr>
+          <a:xfrm>
+            <a:off x="6345936" y="3090672"/>
+            <a:ext cx="2212848" cy="164592"/>
+          </a:xfrm>
+          <a:prstGeom prst="rect">
+            <a:avLst/>
+          </a:prstGeom>
+          <a:noFill/>
+        </p:spPr>
+        <p:txBody>
+          <a:bodyPr wrap="square" lIns="0" tIns="0" rIns="0" bIns="0">
+            <a:spAutoFit/>
+          </a:bodyPr>
+          <a:lstStyle/>
+          <a:p>
+            <a:pPr algn="l"/>
+            <a:r>
+              <a:rPr sz="650" b="1" i="0">
                 <a:solidFill>
                   <a:srgbClr val="047857"/>
                 </a:solidFill>
                 <a:latin typeface="JetBrains Mono"/>
               </a:rPr>
-              <a:t>3.59cm ACCURACY</a:t>
-            </a:r>
-          </a:p>
-        </p:txBody>
-      </p:sp>
-      <p:sp>
-        <p:nvSpPr>
-          <p:cNvPr id="89" name="TextBox 88"/>
+              <a:t>SOLUTIONAL MOAT:</a:t>
+            </a:r>
+          </a:p>
+        </p:txBody>
+      </p:sp>
+      <p:sp>
+        <p:nvSpPr>
+          <p:cNvPr id="106" name="TextBox 105"/>
           <p:cNvSpPr txBox="1"/>
           <p:nvPr/>
         </p:nvSpPr>
         <p:spPr>
           <a:xfrm>
-            <a:off x="5486400" y="4709160"/>
-            <a:ext cx="5760720" cy="475488"/>
+            <a:off x="6345936" y="3291840"/>
+            <a:ext cx="2212848" cy="1005840"/>
           </a:xfrm>
           <a:prstGeom prst="rect">
             <a:avLst/>
@@ -14503,27 +15194,27 @@
           <a:p>
             <a:pPr algn="l"/>
             <a:r>
-              <a:rPr sz="780" b="0" i="0">
+              <a:rPr sz="720" b="0" i="0">
                 <a:solidFill>
                   <a:srgbClr val="475569"/>
                 </a:solidFill>
                 <a:latin typeface="JetBrains Mono"/>
               </a:rPr>
-              <a:t>Sub-15ms edge YOLOv8-Pose with WGS84 elevation raycasting, eliminating 15-30m flat-Earth geolocation errors.</a:t>
-            </a:r>
-          </a:p>
-        </p:txBody>
-      </p:sp>
-      <p:sp>
-        <p:nvSpPr>
-          <p:cNvPr id="90" name="Rounded Rectangle 89"/>
-          <p:cNvSpPr/>
-          <p:nvPr/>
-        </p:nvSpPr>
-        <p:spPr>
-          <a:xfrm>
-            <a:off x="731520" y="5349240"/>
-            <a:ext cx="2514600" cy="502920"/>
+              <a:t>Jetson Orin YOLOv8-Pose with real-time WGS84 elevation raycasting, eliminating 15-30m calculation errors.</a:t>
+            </a:r>
+          </a:p>
+        </p:txBody>
+      </p:sp>
+      <p:sp>
+        <p:nvSpPr>
+          <p:cNvPr id="107" name="Rounded Rectangle 106"/>
+          <p:cNvSpPr/>
+          <p:nvPr/>
+        </p:nvSpPr>
+        <p:spPr>
+          <a:xfrm>
+            <a:off x="6291072" y="4462272"/>
+            <a:ext cx="1115568" cy="502920"/>
           </a:xfrm>
           <a:prstGeom prst="roundRect">
             <a:avLst/>
@@ -14561,14 +15252,1125 @@
       </p:sp>
       <p:sp>
         <p:nvSpPr>
-          <p:cNvPr id="91" name="TextBox 90"/>
+          <p:cNvPr id="108" name="TextBox 107"/>
           <p:cNvSpPr txBox="1"/>
           <p:nvPr/>
         </p:nvSpPr>
         <p:spPr>
           <a:xfrm>
-            <a:off x="822960" y="5440680"/>
+            <a:off x="6291072" y="4498848"/>
+            <a:ext cx="1115568" cy="228600"/>
+          </a:xfrm>
+          <a:prstGeom prst="rect">
+            <a:avLst/>
+          </a:prstGeom>
+          <a:noFill/>
+        </p:spPr>
+        <p:txBody>
+          <a:bodyPr wrap="square" lIns="0" tIns="0" rIns="0" bIns="0">
+            <a:spAutoFit/>
+          </a:bodyPr>
+          <a:lstStyle/>
+          <a:p>
+            <a:pPr algn="ctr"/>
+            <a:r>
+              <a:rPr sz="950" b="1" i="0">
+                <a:solidFill>
+                  <a:srgbClr val="09090B"/>
+                </a:solidFill>
+                <a:latin typeface="JetBrains Mono"/>
+              </a:rPr>
+              <a:t>&lt;15ms</a:t>
+            </a:r>
+          </a:p>
+        </p:txBody>
+      </p:sp>
+      <p:sp>
+        <p:nvSpPr>
+          <p:cNvPr id="109" name="TextBox 108"/>
+          <p:cNvSpPr txBox="1"/>
+          <p:nvPr/>
+        </p:nvSpPr>
+        <p:spPr>
+          <a:xfrm>
+            <a:off x="6291072" y="4754880"/>
+            <a:ext cx="1115568" cy="182880"/>
+          </a:xfrm>
+          <a:prstGeom prst="rect">
+            <a:avLst/>
+          </a:prstGeom>
+          <a:noFill/>
+        </p:spPr>
+        <p:txBody>
+          <a:bodyPr wrap="square" lIns="0" tIns="0" rIns="0" bIns="0">
+            <a:spAutoFit/>
+          </a:bodyPr>
+          <a:lstStyle/>
+          <a:p>
+            <a:pPr algn="ctr"/>
+            <a:r>
+              <a:rPr sz="600" b="0" i="0">
+                <a:solidFill>
+                  <a:srgbClr val="64748B"/>
+                </a:solidFill>
+                <a:latin typeface="JetBrains Mono"/>
+              </a:rPr>
+              <a:t>Inference</a:t>
+            </a:r>
+          </a:p>
+        </p:txBody>
+      </p:sp>
+      <p:sp>
+        <p:nvSpPr>
+          <p:cNvPr id="110" name="Rounded Rectangle 109"/>
+          <p:cNvSpPr/>
+          <p:nvPr/>
+        </p:nvSpPr>
+        <p:spPr>
+          <a:xfrm>
+            <a:off x="7498080" y="4462272"/>
+            <a:ext cx="1115568" cy="502920"/>
+          </a:xfrm>
+          <a:prstGeom prst="roundRect">
+            <a:avLst/>
+          </a:prstGeom>
+          <a:solidFill>
+            <a:srgbClr val="F8FAFC"/>
+          </a:solidFill>
+          <a:ln w="12700">
+            <a:solidFill>
+              <a:srgbClr val="E4E4E7"/>
+            </a:solidFill>
+          </a:ln>
+        </p:spPr>
+        <p:style>
+          <a:lnRef idx="1">
+            <a:schemeClr val="accent1"/>
+          </a:lnRef>
+          <a:fillRef idx="3">
+            <a:schemeClr val="accent1"/>
+          </a:fillRef>
+          <a:effectRef idx="2">
+            <a:schemeClr val="accent1"/>
+          </a:effectRef>
+          <a:fontRef idx="minor">
+            <a:schemeClr val="lt1"/>
+          </a:fontRef>
+        </p:style>
+        <p:txBody>
+          <a:bodyPr rtlCol="0" anchor="ctr"/>
+          <a:lstStyle/>
+          <a:p>
+            <a:pPr algn="ctr"/>
+          </a:p>
+        </p:txBody>
+      </p:sp>
+      <p:sp>
+        <p:nvSpPr>
+          <p:cNvPr id="111" name="TextBox 110"/>
+          <p:cNvSpPr txBox="1"/>
+          <p:nvPr/>
+        </p:nvSpPr>
+        <p:spPr>
+          <a:xfrm>
+            <a:off x="7498080" y="4498848"/>
+            <a:ext cx="1115568" cy="228600"/>
+          </a:xfrm>
+          <a:prstGeom prst="rect">
+            <a:avLst/>
+          </a:prstGeom>
+          <a:noFill/>
+        </p:spPr>
+        <p:txBody>
+          <a:bodyPr wrap="square" lIns="0" tIns="0" rIns="0" bIns="0">
+            <a:spAutoFit/>
+          </a:bodyPr>
+          <a:lstStyle/>
+          <a:p>
+            <a:pPr algn="ctr"/>
+            <a:r>
+              <a:rPr sz="950" b="1" i="0">
+                <a:solidFill>
+                  <a:srgbClr val="047857"/>
+                </a:solidFill>
+                <a:latin typeface="JetBrains Mono"/>
+              </a:rPr>
+              <a:t>3.59cm</a:t>
+            </a:r>
+          </a:p>
+        </p:txBody>
+      </p:sp>
+      <p:sp>
+        <p:nvSpPr>
+          <p:cNvPr id="112" name="TextBox 111"/>
+          <p:cNvSpPr txBox="1"/>
+          <p:nvPr/>
+        </p:nvSpPr>
+        <p:spPr>
+          <a:xfrm>
+            <a:off x="7498080" y="4754880"/>
+            <a:ext cx="1115568" cy="182880"/>
+          </a:xfrm>
+          <a:prstGeom prst="rect">
+            <a:avLst/>
+          </a:prstGeom>
+          <a:noFill/>
+        </p:spPr>
+        <p:txBody>
+          <a:bodyPr wrap="square" lIns="0" tIns="0" rIns="0" bIns="0">
+            <a:spAutoFit/>
+          </a:bodyPr>
+          <a:lstStyle/>
+          <a:p>
+            <a:pPr algn="ctr"/>
+            <a:r>
+              <a:rPr sz="600" b="0" i="0">
+                <a:solidFill>
+                  <a:srgbClr val="64748B"/>
+                </a:solidFill>
+                <a:latin typeface="JetBrains Mono"/>
+              </a:rPr>
+              <a:t>Geo Error</a:t>
+            </a:r>
+          </a:p>
+        </p:txBody>
+      </p:sp>
+      <p:sp>
+        <p:nvSpPr>
+          <p:cNvPr id="113" name="TextBox 112"/>
+          <p:cNvSpPr txBox="1"/>
+          <p:nvPr/>
+        </p:nvSpPr>
+        <p:spPr>
+          <a:xfrm>
+            <a:off x="6291072" y="5102352"/>
+            <a:ext cx="1188720" cy="182880"/>
+          </a:xfrm>
+          <a:prstGeom prst="rect">
+            <a:avLst/>
+          </a:prstGeom>
+          <a:noFill/>
+        </p:spPr>
+        <p:txBody>
+          <a:bodyPr wrap="square" lIns="0" tIns="0" rIns="0" bIns="0">
+            <a:spAutoFit/>
+          </a:bodyPr>
+          <a:lstStyle/>
+          <a:p>
+            <a:pPr algn="l"/>
+            <a:r>
+              <a:rPr sz="600" b="0" i="0">
+                <a:solidFill>
+                  <a:srgbClr val="64748B"/>
+                </a:solidFill>
+                <a:latin typeface="JetBrains Mono"/>
+              </a:rPr>
+              <a:t>ELEVATION CORRECTED</a:t>
+            </a:r>
+          </a:p>
+        </p:txBody>
+      </p:sp>
+      <p:sp>
+        <p:nvSpPr>
+          <p:cNvPr id="114" name="TextBox 113"/>
+          <p:cNvSpPr txBox="1"/>
+          <p:nvPr/>
+        </p:nvSpPr>
+        <p:spPr>
+          <a:xfrm>
+            <a:off x="7415784" y="5102352"/>
+            <a:ext cx="1188720" cy="182880"/>
+          </a:xfrm>
+          <a:prstGeom prst="rect">
+            <a:avLst/>
+          </a:prstGeom>
+          <a:noFill/>
+        </p:spPr>
+        <p:txBody>
+          <a:bodyPr wrap="square" lIns="0" tIns="0" rIns="0" bIns="0">
+            <a:spAutoFit/>
+          </a:bodyPr>
+          <a:lstStyle/>
+          <a:p>
+            <a:pPr algn="r"/>
+            <a:r>
+              <a:rPr sz="600" b="1" i="0">
+                <a:solidFill>
+                  <a:srgbClr val="09090B"/>
+                </a:solidFill>
+                <a:latin typeface="JetBrains Mono"/>
+              </a:rPr>
+              <a:t>JETSON ORIN</a:t>
+            </a:r>
+          </a:p>
+        </p:txBody>
+      </p:sp>
+      <p:sp>
+        <p:nvSpPr>
+          <p:cNvPr id="115" name="Rectangle 114"/>
+          <p:cNvSpPr/>
+          <p:nvPr/>
+        </p:nvSpPr>
+        <p:spPr>
+          <a:xfrm>
+            <a:off x="6181344" y="5477255"/>
+            <a:ext cx="2542032" cy="36576"/>
+          </a:xfrm>
+          <a:prstGeom prst="rect">
+            <a:avLst/>
+          </a:prstGeom>
+          <a:solidFill>
+            <a:srgbClr val="047857"/>
+          </a:solidFill>
+          <a:ln>
+            <a:noFill/>
+          </a:ln>
+        </p:spPr>
+        <p:style>
+          <a:lnRef idx="1">
+            <a:schemeClr val="accent1"/>
+          </a:lnRef>
+          <a:fillRef idx="3">
+            <a:schemeClr val="accent1"/>
+          </a:fillRef>
+          <a:effectRef idx="2">
+            <a:schemeClr val="accent1"/>
+          </a:effectRef>
+          <a:fontRef idx="minor">
+            <a:schemeClr val="lt1"/>
+          </a:fontRef>
+        </p:style>
+        <p:txBody>
+          <a:bodyPr rtlCol="0" anchor="ctr"/>
+          <a:lstStyle/>
+          <a:p>
+            <a:pPr algn="ctr"/>
+          </a:p>
+        </p:txBody>
+      </p:sp>
+      <p:sp>
+        <p:nvSpPr>
+          <p:cNvPr id="116" name="Rounded Rectangle 115"/>
+          <p:cNvSpPr/>
+          <p:nvPr/>
+        </p:nvSpPr>
+        <p:spPr>
+          <a:xfrm>
+            <a:off x="8906256" y="1536192"/>
+            <a:ext cx="2542032" cy="3977639"/>
+          </a:xfrm>
+          <a:prstGeom prst="roundRect">
+            <a:avLst/>
+          </a:prstGeom>
+          <a:solidFill>
+            <a:srgbClr val="FFFFFF"/>
+          </a:solidFill>
+          <a:ln w="12700">
+            <a:solidFill>
+              <a:srgbClr val="E4E4E7"/>
+            </a:solidFill>
+          </a:ln>
+        </p:spPr>
+        <p:style>
+          <a:lnRef idx="1">
+            <a:schemeClr val="accent1"/>
+          </a:lnRef>
+          <a:fillRef idx="3">
+            <a:schemeClr val="accent1"/>
+          </a:fillRef>
+          <a:effectRef idx="2">
+            <a:schemeClr val="accent1"/>
+          </a:effectRef>
+          <a:fontRef idx="minor">
+            <a:schemeClr val="lt1"/>
+          </a:fontRef>
+        </p:style>
+        <p:txBody>
+          <a:bodyPr rtlCol="0" anchor="ctr"/>
+          <a:lstStyle/>
+          <a:p>
+            <a:pPr algn="ctr"/>
+          </a:p>
+        </p:txBody>
+      </p:sp>
+      <p:sp>
+        <p:nvSpPr>
+          <p:cNvPr id="117" name="TextBox 116"/>
+          <p:cNvSpPr txBox="1"/>
+          <p:nvPr/>
+        </p:nvSpPr>
+        <p:spPr>
+          <a:xfrm>
+            <a:off x="9015984" y="1645920"/>
+            <a:ext cx="1188720" cy="182880"/>
+          </a:xfrm>
+          <a:prstGeom prst="rect">
+            <a:avLst/>
+          </a:prstGeom>
+          <a:noFill/>
+        </p:spPr>
+        <p:txBody>
+          <a:bodyPr wrap="square" lIns="0" tIns="0" rIns="0" bIns="0">
+            <a:spAutoFit/>
+          </a:bodyPr>
+          <a:lstStyle/>
+          <a:p>
+            <a:pPr algn="l"/>
+            <a:r>
+              <a:rPr sz="700" b="1" i="0">
+                <a:solidFill>
+                  <a:srgbClr val="94A3B8"/>
+                </a:solidFill>
+                <a:latin typeface="JetBrains Mono"/>
+              </a:rPr>
+              <a:t>SUBSYSTEM D</a:t>
+            </a:r>
+          </a:p>
+        </p:txBody>
+      </p:sp>
+      <p:sp>
+        <p:nvSpPr>
+          <p:cNvPr id="118" name="Rounded Rectangle 117"/>
+          <p:cNvSpPr/>
+          <p:nvPr/>
+        </p:nvSpPr>
+        <p:spPr>
+          <a:xfrm>
+            <a:off x="10232136" y="1627632"/>
+            <a:ext cx="1097280" cy="201168"/>
+          </a:xfrm>
+          <a:prstGeom prst="roundRect">
+            <a:avLst/>
+          </a:prstGeom>
+          <a:solidFill>
+            <a:srgbClr val="ECFDF5"/>
+          </a:solidFill>
+          <a:ln w="12700">
+            <a:solidFill>
+              <a:srgbClr val="A7F3D0"/>
+            </a:solidFill>
+          </a:ln>
+        </p:spPr>
+        <p:style>
+          <a:lnRef idx="1">
+            <a:schemeClr val="accent1"/>
+          </a:lnRef>
+          <a:fillRef idx="3">
+            <a:schemeClr val="accent1"/>
+          </a:fillRef>
+          <a:effectRef idx="2">
+            <a:schemeClr val="accent1"/>
+          </a:effectRef>
+          <a:fontRef idx="minor">
+            <a:schemeClr val="lt1"/>
+          </a:fontRef>
+        </p:style>
+        <p:txBody>
+          <a:bodyPr rtlCol="0" anchor="ctr"/>
+          <a:lstStyle/>
+          <a:p>
+            <a:pPr algn="ctr"/>
+          </a:p>
+        </p:txBody>
+      </p:sp>
+      <p:sp>
+        <p:nvSpPr>
+          <p:cNvPr id="119" name="TextBox 118"/>
+          <p:cNvSpPr txBox="1"/>
+          <p:nvPr/>
+        </p:nvSpPr>
+        <p:spPr>
+          <a:xfrm>
+            <a:off x="10232136" y="1645920"/>
             <a:ext cx="1097280" cy="182880"/>
+          </a:xfrm>
+          <a:prstGeom prst="rect">
+            <a:avLst/>
+          </a:prstGeom>
+          <a:noFill/>
+        </p:spPr>
+        <p:txBody>
+          <a:bodyPr wrap="square" lIns="0" tIns="0" rIns="0" bIns="0">
+            <a:spAutoFit/>
+          </a:bodyPr>
+          <a:lstStyle/>
+          <a:p>
+            <a:pPr algn="ctr"/>
+            <a:r>
+              <a:rPr sz="650" b="1" i="0">
+                <a:solidFill>
+                  <a:srgbClr val="047857"/>
+                </a:solidFill>
+                <a:latin typeface="JetBrains Mono"/>
+              </a:rPr>
+              <a:t>1-2 OPERATORS</a:t>
+            </a:r>
+          </a:p>
+        </p:txBody>
+      </p:sp>
+      <p:sp>
+        <p:nvSpPr>
+          <p:cNvPr id="120" name="TextBox 119"/>
+          <p:cNvSpPr txBox="1"/>
+          <p:nvPr/>
+        </p:nvSpPr>
+        <p:spPr>
+          <a:xfrm>
+            <a:off x="9015984" y="1883664"/>
+            <a:ext cx="2322576" cy="411480"/>
+          </a:xfrm>
+          <a:prstGeom prst="rect">
+            <a:avLst/>
+          </a:prstGeom>
+          <a:noFill/>
+        </p:spPr>
+        <p:txBody>
+          <a:bodyPr wrap="square" lIns="0" tIns="0" rIns="0" bIns="0">
+            <a:spAutoFit/>
+          </a:bodyPr>
+          <a:lstStyle/>
+          <a:p>
+            <a:pPr algn="l"/>
+            <a:r>
+              <a:rPr sz="1100" b="1" i="0">
+                <a:solidFill>
+                  <a:srgbClr val="09090B"/>
+                </a:solidFill>
+                <a:latin typeface="Space Grotesk"/>
+              </a:rPr>
+              <a:t>Pegasus 3D WebGPU GCS</a:t>
+            </a:r>
+          </a:p>
+        </p:txBody>
+      </p:sp>
+      <p:sp>
+        <p:nvSpPr>
+          <p:cNvPr id="121" name="Rounded Rectangle 120"/>
+          <p:cNvSpPr/>
+          <p:nvPr/>
+        </p:nvSpPr>
+        <p:spPr>
+          <a:xfrm>
+            <a:off x="9015984" y="2359152"/>
+            <a:ext cx="2322576" cy="594360"/>
+          </a:xfrm>
+          <a:prstGeom prst="roundRect">
+            <a:avLst/>
+          </a:prstGeom>
+          <a:solidFill>
+            <a:srgbClr val="FEF2F2"/>
+          </a:solidFill>
+          <a:ln w="12700">
+            <a:solidFill>
+              <a:srgbClr val="FECDCD"/>
+            </a:solidFill>
+          </a:ln>
+        </p:spPr>
+        <p:style>
+          <a:lnRef idx="1">
+            <a:schemeClr val="accent1"/>
+          </a:lnRef>
+          <a:fillRef idx="3">
+            <a:schemeClr val="accent1"/>
+          </a:fillRef>
+          <a:effectRef idx="2">
+            <a:schemeClr val="accent1"/>
+          </a:effectRef>
+          <a:fontRef idx="minor">
+            <a:schemeClr val="lt1"/>
+          </a:fontRef>
+        </p:style>
+        <p:txBody>
+          <a:bodyPr rtlCol="0" anchor="ctr"/>
+          <a:lstStyle/>
+          <a:p>
+            <a:pPr algn="ctr"/>
+          </a:p>
+        </p:txBody>
+      </p:sp>
+      <p:sp>
+        <p:nvSpPr>
+          <p:cNvPr id="122" name="TextBox 121"/>
+          <p:cNvSpPr txBox="1"/>
+          <p:nvPr/>
+        </p:nvSpPr>
+        <p:spPr>
+          <a:xfrm>
+            <a:off x="9070848" y="2395728"/>
+            <a:ext cx="2212848" cy="164592"/>
+          </a:xfrm>
+          <a:prstGeom prst="rect">
+            <a:avLst/>
+          </a:prstGeom>
+          <a:noFill/>
+        </p:spPr>
+        <p:txBody>
+          <a:bodyPr wrap="square" lIns="0" tIns="0" rIns="0" bIns="0">
+            <a:spAutoFit/>
+          </a:bodyPr>
+          <a:lstStyle/>
+          <a:p>
+            <a:pPr algn="l"/>
+            <a:r>
+              <a:rPr sz="600" b="1" i="0">
+                <a:solidFill>
+                  <a:srgbClr val="D71920"/>
+                </a:solidFill>
+                <a:latin typeface="JetBrains Mono"/>
+              </a:rPr>
+              <a:t>SOLVES PROBLEM VOID:</a:t>
+            </a:r>
+          </a:p>
+        </p:txBody>
+      </p:sp>
+      <p:sp>
+        <p:nvSpPr>
+          <p:cNvPr id="123" name="TextBox 122"/>
+          <p:cNvSpPr txBox="1"/>
+          <p:nvPr/>
+        </p:nvSpPr>
+        <p:spPr>
+          <a:xfrm>
+            <a:off x="9070848" y="2560320"/>
+            <a:ext cx="2212848" cy="365760"/>
+          </a:xfrm>
+          <a:prstGeom prst="rect">
+            <a:avLst/>
+          </a:prstGeom>
+          <a:noFill/>
+        </p:spPr>
+        <p:txBody>
+          <a:bodyPr wrap="square" lIns="0" tIns="0" rIns="0" bIns="0">
+            <a:spAutoFit/>
+          </a:bodyPr>
+          <a:lstStyle/>
+          <a:p>
+            <a:pPr algn="l"/>
+            <a:r>
+              <a:rPr sz="750" b="1" i="0">
+                <a:solidFill>
+                  <a:srgbClr val="09090B"/>
+                </a:solidFill>
+                <a:latin typeface="Inter"/>
+              </a:rPr>
+              <a:t>15-25 Ground Crew Cognitive Overload</a:t>
+            </a:r>
+          </a:p>
+        </p:txBody>
+      </p:sp>
+      <p:sp>
+        <p:nvSpPr>
+          <p:cNvPr id="124" name="Rounded Rectangle 123"/>
+          <p:cNvSpPr/>
+          <p:nvPr/>
+        </p:nvSpPr>
+        <p:spPr>
+          <a:xfrm>
+            <a:off x="9015984" y="3044952"/>
+            <a:ext cx="2322576" cy="1325880"/>
+          </a:xfrm>
+          <a:prstGeom prst="roundRect">
+            <a:avLst/>
+          </a:prstGeom>
+          <a:solidFill>
+            <a:srgbClr val="F8FAFC"/>
+          </a:solidFill>
+          <a:ln w="12700">
+            <a:solidFill>
+              <a:srgbClr val="E4E4E7"/>
+            </a:solidFill>
+          </a:ln>
+        </p:spPr>
+        <p:style>
+          <a:lnRef idx="1">
+            <a:schemeClr val="accent1"/>
+          </a:lnRef>
+          <a:fillRef idx="3">
+            <a:schemeClr val="accent1"/>
+          </a:fillRef>
+          <a:effectRef idx="2">
+            <a:schemeClr val="accent1"/>
+          </a:effectRef>
+          <a:fontRef idx="minor">
+            <a:schemeClr val="lt1"/>
+          </a:fontRef>
+        </p:style>
+        <p:txBody>
+          <a:bodyPr rtlCol="0" anchor="ctr"/>
+          <a:lstStyle/>
+          <a:p>
+            <a:pPr algn="ctr"/>
+          </a:p>
+        </p:txBody>
+      </p:sp>
+      <p:sp>
+        <p:nvSpPr>
+          <p:cNvPr id="125" name="TextBox 124"/>
+          <p:cNvSpPr txBox="1"/>
+          <p:nvPr/>
+        </p:nvSpPr>
+        <p:spPr>
+          <a:xfrm>
+            <a:off x="9070848" y="3090672"/>
+            <a:ext cx="2212848" cy="164592"/>
+          </a:xfrm>
+          <a:prstGeom prst="rect">
+            <a:avLst/>
+          </a:prstGeom>
+          <a:noFill/>
+        </p:spPr>
+        <p:txBody>
+          <a:bodyPr wrap="square" lIns="0" tIns="0" rIns="0" bIns="0">
+            <a:spAutoFit/>
+          </a:bodyPr>
+          <a:lstStyle/>
+          <a:p>
+            <a:pPr algn="l"/>
+            <a:r>
+              <a:rPr sz="650" b="1" i="0">
+                <a:solidFill>
+                  <a:srgbClr val="047857"/>
+                </a:solidFill>
+                <a:latin typeface="JetBrains Mono"/>
+              </a:rPr>
+              <a:t>SOLUTIONAL MOAT:</a:t>
+            </a:r>
+          </a:p>
+        </p:txBody>
+      </p:sp>
+      <p:sp>
+        <p:nvSpPr>
+          <p:cNvPr id="126" name="TextBox 125"/>
+          <p:cNvSpPr txBox="1"/>
+          <p:nvPr/>
+        </p:nvSpPr>
+        <p:spPr>
+          <a:xfrm>
+            <a:off x="9070848" y="3291840"/>
+            <a:ext cx="2212848" cy="1005840"/>
+          </a:xfrm>
+          <a:prstGeom prst="rect">
+            <a:avLst/>
+          </a:prstGeom>
+          <a:noFill/>
+        </p:spPr>
+        <p:txBody>
+          <a:bodyPr wrap="square" lIns="0" tIns="0" rIns="0" bIns="0">
+            <a:spAutoFit/>
+          </a:bodyPr>
+          <a:lstStyle/>
+          <a:p>
+            <a:pPr algn="l"/>
+            <a:r>
+              <a:rPr sz="720" b="0" i="0">
+                <a:solidFill>
+                  <a:srgbClr val="475569"/>
+                </a:solidFill>
+                <a:latin typeface="JetBrains Mono"/>
+              </a:rPr>
+              <a:t>Offline tactical 3D digital twin + ATAK plugin, empowering 1-2 operators to orchestrate full drone swarms.</a:t>
+            </a:r>
+          </a:p>
+        </p:txBody>
+      </p:sp>
+      <p:sp>
+        <p:nvSpPr>
+          <p:cNvPr id="127" name="Rounded Rectangle 126"/>
+          <p:cNvSpPr/>
+          <p:nvPr/>
+        </p:nvSpPr>
+        <p:spPr>
+          <a:xfrm>
+            <a:off x="9015984" y="4462272"/>
+            <a:ext cx="1115568" cy="502920"/>
+          </a:xfrm>
+          <a:prstGeom prst="roundRect">
+            <a:avLst/>
+          </a:prstGeom>
+          <a:solidFill>
+            <a:srgbClr val="F8FAFC"/>
+          </a:solidFill>
+          <a:ln w="12700">
+            <a:solidFill>
+              <a:srgbClr val="E4E4E7"/>
+            </a:solidFill>
+          </a:ln>
+        </p:spPr>
+        <p:style>
+          <a:lnRef idx="1">
+            <a:schemeClr val="accent1"/>
+          </a:lnRef>
+          <a:fillRef idx="3">
+            <a:schemeClr val="accent1"/>
+          </a:fillRef>
+          <a:effectRef idx="2">
+            <a:schemeClr val="accent1"/>
+          </a:effectRef>
+          <a:fontRef idx="minor">
+            <a:schemeClr val="lt1"/>
+          </a:fontRef>
+        </p:style>
+        <p:txBody>
+          <a:bodyPr rtlCol="0" anchor="ctr"/>
+          <a:lstStyle/>
+          <a:p>
+            <a:pPr algn="ctr"/>
+          </a:p>
+        </p:txBody>
+      </p:sp>
+      <p:sp>
+        <p:nvSpPr>
+          <p:cNvPr id="128" name="TextBox 127"/>
+          <p:cNvSpPr txBox="1"/>
+          <p:nvPr/>
+        </p:nvSpPr>
+        <p:spPr>
+          <a:xfrm>
+            <a:off x="9015984" y="4498848"/>
+            <a:ext cx="1115568" cy="228600"/>
+          </a:xfrm>
+          <a:prstGeom prst="rect">
+            <a:avLst/>
+          </a:prstGeom>
+          <a:noFill/>
+        </p:spPr>
+        <p:txBody>
+          <a:bodyPr wrap="square" lIns="0" tIns="0" rIns="0" bIns="0">
+            <a:spAutoFit/>
+          </a:bodyPr>
+          <a:lstStyle/>
+          <a:p>
+            <a:pPr algn="ctr"/>
+            <a:r>
+              <a:rPr sz="950" b="1" i="0">
+                <a:solidFill>
+                  <a:srgbClr val="09090B"/>
+                </a:solidFill>
+                <a:latin typeface="JetBrains Mono"/>
+              </a:rPr>
+              <a:t>1-2 Ops</a:t>
+            </a:r>
+          </a:p>
+        </p:txBody>
+      </p:sp>
+      <p:sp>
+        <p:nvSpPr>
+          <p:cNvPr id="129" name="TextBox 128"/>
+          <p:cNvSpPr txBox="1"/>
+          <p:nvPr/>
+        </p:nvSpPr>
+        <p:spPr>
+          <a:xfrm>
+            <a:off x="9015984" y="4754880"/>
+            <a:ext cx="1115568" cy="182880"/>
+          </a:xfrm>
+          <a:prstGeom prst="rect">
+            <a:avLst/>
+          </a:prstGeom>
+          <a:noFill/>
+        </p:spPr>
+        <p:txBody>
+          <a:bodyPr wrap="square" lIns="0" tIns="0" rIns="0" bIns="0">
+            <a:spAutoFit/>
+          </a:bodyPr>
+          <a:lstStyle/>
+          <a:p>
+            <a:pPr algn="ctr"/>
+            <a:r>
+              <a:rPr sz="600" b="0" i="0">
+                <a:solidFill>
+                  <a:srgbClr val="64748B"/>
+                </a:solidFill>
+                <a:latin typeface="JetBrains Mono"/>
+              </a:rPr>
+              <a:t>Crew Size</a:t>
+            </a:r>
+          </a:p>
+        </p:txBody>
+      </p:sp>
+      <p:sp>
+        <p:nvSpPr>
+          <p:cNvPr id="130" name="Rounded Rectangle 129"/>
+          <p:cNvSpPr/>
+          <p:nvPr/>
+        </p:nvSpPr>
+        <p:spPr>
+          <a:xfrm>
+            <a:off x="10222992" y="4462272"/>
+            <a:ext cx="1115568" cy="502920"/>
+          </a:xfrm>
+          <a:prstGeom prst="roundRect">
+            <a:avLst/>
+          </a:prstGeom>
+          <a:solidFill>
+            <a:srgbClr val="F8FAFC"/>
+          </a:solidFill>
+          <a:ln w="12700">
+            <a:solidFill>
+              <a:srgbClr val="E4E4E7"/>
+            </a:solidFill>
+          </a:ln>
+        </p:spPr>
+        <p:style>
+          <a:lnRef idx="1">
+            <a:schemeClr val="accent1"/>
+          </a:lnRef>
+          <a:fillRef idx="3">
+            <a:schemeClr val="accent1"/>
+          </a:fillRef>
+          <a:effectRef idx="2">
+            <a:schemeClr val="accent1"/>
+          </a:effectRef>
+          <a:fontRef idx="minor">
+            <a:schemeClr val="lt1"/>
+          </a:fontRef>
+        </p:style>
+        <p:txBody>
+          <a:bodyPr rtlCol="0" anchor="ctr"/>
+          <a:lstStyle/>
+          <a:p>
+            <a:pPr algn="ctr"/>
+          </a:p>
+        </p:txBody>
+      </p:sp>
+      <p:sp>
+        <p:nvSpPr>
+          <p:cNvPr id="131" name="TextBox 130"/>
+          <p:cNvSpPr txBox="1"/>
+          <p:nvPr/>
+        </p:nvSpPr>
+        <p:spPr>
+          <a:xfrm>
+            <a:off x="10222992" y="4498848"/>
+            <a:ext cx="1115568" cy="228600"/>
+          </a:xfrm>
+          <a:prstGeom prst="rect">
+            <a:avLst/>
+          </a:prstGeom>
+          <a:noFill/>
+        </p:spPr>
+        <p:txBody>
+          <a:bodyPr wrap="square" lIns="0" tIns="0" rIns="0" bIns="0">
+            <a:spAutoFit/>
+          </a:bodyPr>
+          <a:lstStyle/>
+          <a:p>
+            <a:pPr algn="ctr"/>
+            <a:r>
+              <a:rPr sz="950" b="1" i="0">
+                <a:solidFill>
+                  <a:srgbClr val="047857"/>
+                </a:solidFill>
+                <a:latin typeface="JetBrains Mono"/>
+              </a:rPr>
+              <a:t>100%</a:t>
+            </a:r>
+          </a:p>
+        </p:txBody>
+      </p:sp>
+      <p:sp>
+        <p:nvSpPr>
+          <p:cNvPr id="132" name="TextBox 131"/>
+          <p:cNvSpPr txBox="1"/>
+          <p:nvPr/>
+        </p:nvSpPr>
+        <p:spPr>
+          <a:xfrm>
+            <a:off x="10222992" y="4754880"/>
+            <a:ext cx="1115568" cy="182880"/>
+          </a:xfrm>
+          <a:prstGeom prst="rect">
+            <a:avLst/>
+          </a:prstGeom>
+          <a:noFill/>
+        </p:spPr>
+        <p:txBody>
+          <a:bodyPr wrap="square" lIns="0" tIns="0" rIns="0" bIns="0">
+            <a:spAutoFit/>
+          </a:bodyPr>
+          <a:lstStyle/>
+          <a:p>
+            <a:pPr algn="ctr"/>
+            <a:r>
+              <a:rPr sz="600" b="0" i="0">
+                <a:solidFill>
+                  <a:srgbClr val="64748B"/>
+                </a:solidFill>
+                <a:latin typeface="JetBrains Mono"/>
+              </a:rPr>
+              <a:t>Offline ATAK</a:t>
+            </a:r>
+          </a:p>
+        </p:txBody>
+      </p:sp>
+      <p:sp>
+        <p:nvSpPr>
+          <p:cNvPr id="133" name="TextBox 132"/>
+          <p:cNvSpPr txBox="1"/>
+          <p:nvPr/>
+        </p:nvSpPr>
+        <p:spPr>
+          <a:xfrm>
+            <a:off x="9015984" y="5102352"/>
+            <a:ext cx="1188720" cy="182880"/>
+          </a:xfrm>
+          <a:prstGeom prst="rect">
+            <a:avLst/>
+          </a:prstGeom>
+          <a:noFill/>
+        </p:spPr>
+        <p:txBody>
+          <a:bodyPr wrap="square" lIns="0" tIns="0" rIns="0" bIns="0">
+            <a:spAutoFit/>
+          </a:bodyPr>
+          <a:lstStyle/>
+          <a:p>
+            <a:pPr algn="l"/>
+            <a:r>
+              <a:rPr sz="600" b="0" i="0">
+                <a:solidFill>
+                  <a:srgbClr val="64748B"/>
+                </a:solidFill>
+                <a:latin typeface="JetBrains Mono"/>
+              </a:rPr>
+              <a:t>ATAK INTEGRATION</a:t>
+            </a:r>
+          </a:p>
+        </p:txBody>
+      </p:sp>
+      <p:sp>
+        <p:nvSpPr>
+          <p:cNvPr id="134" name="TextBox 133"/>
+          <p:cNvSpPr txBox="1"/>
+          <p:nvPr/>
+        </p:nvSpPr>
+        <p:spPr>
+          <a:xfrm>
+            <a:off x="10140696" y="5102352"/>
+            <a:ext cx="1188720" cy="182880"/>
+          </a:xfrm>
+          <a:prstGeom prst="rect">
+            <a:avLst/>
+          </a:prstGeom>
+          <a:noFill/>
+        </p:spPr>
+        <p:txBody>
+          <a:bodyPr wrap="square" lIns="0" tIns="0" rIns="0" bIns="0">
+            <a:spAutoFit/>
+          </a:bodyPr>
+          <a:lstStyle/>
+          <a:p>
+            <a:pPr algn="r"/>
+            <a:r>
+              <a:rPr sz="600" b="1" i="0">
+                <a:solidFill>
+                  <a:srgbClr val="09090B"/>
+                </a:solidFill>
+                <a:latin typeface="JetBrains Mono"/>
+              </a:rPr>
+              <a:t>WEBGPU 3D</a:t>
+            </a:r>
+          </a:p>
+        </p:txBody>
+      </p:sp>
+      <p:sp>
+        <p:nvSpPr>
+          <p:cNvPr id="135" name="Rectangle 134"/>
+          <p:cNvSpPr/>
+          <p:nvPr/>
+        </p:nvSpPr>
+        <p:spPr>
+          <a:xfrm>
+            <a:off x="8906256" y="5477255"/>
+            <a:ext cx="2542032" cy="36576"/>
+          </a:xfrm>
+          <a:prstGeom prst="rect">
+            <a:avLst/>
+          </a:prstGeom>
+          <a:solidFill>
+            <a:srgbClr val="09090B"/>
+          </a:solidFill>
+          <a:ln>
+            <a:noFill/>
+          </a:ln>
+        </p:spPr>
+        <p:style>
+          <a:lnRef idx="1">
+            <a:schemeClr val="accent1"/>
+          </a:lnRef>
+          <a:fillRef idx="3">
+            <a:schemeClr val="accent1"/>
+          </a:fillRef>
+          <a:effectRef idx="2">
+            <a:schemeClr val="accent1"/>
+          </a:effectRef>
+          <a:fontRef idx="minor">
+            <a:schemeClr val="lt1"/>
+          </a:fontRef>
+        </p:style>
+        <p:txBody>
+          <a:bodyPr rtlCol="0" anchor="ctr"/>
+          <a:lstStyle/>
+          <a:p>
+            <a:pPr algn="ctr"/>
+          </a:p>
+        </p:txBody>
+      </p:sp>
+      <p:sp>
+        <p:nvSpPr>
+          <p:cNvPr id="136" name="Rounded Rectangle 135"/>
+          <p:cNvSpPr/>
+          <p:nvPr/>
+        </p:nvSpPr>
+        <p:spPr>
+          <a:xfrm>
+            <a:off x="731520" y="5623560"/>
+            <a:ext cx="2542032" cy="438912"/>
+          </a:xfrm>
+          <a:prstGeom prst="roundRect">
+            <a:avLst/>
+          </a:prstGeom>
+          <a:solidFill>
+            <a:srgbClr val="F8FAFC"/>
+          </a:solidFill>
+          <a:ln w="12700">
+            <a:solidFill>
+              <a:srgbClr val="E4E4E7"/>
+            </a:solidFill>
+          </a:ln>
+        </p:spPr>
+        <p:style>
+          <a:lnRef idx="1">
+            <a:schemeClr val="accent1"/>
+          </a:lnRef>
+          <a:fillRef idx="3">
+            <a:schemeClr val="accent1"/>
+          </a:fillRef>
+          <a:effectRef idx="2">
+            <a:schemeClr val="accent1"/>
+          </a:effectRef>
+          <a:fontRef idx="minor">
+            <a:schemeClr val="lt1"/>
+          </a:fontRef>
+        </p:style>
+        <p:txBody>
+          <a:bodyPr rtlCol="0" anchor="ctr"/>
+          <a:lstStyle/>
+          <a:p>
+            <a:pPr algn="ctr"/>
+          </a:p>
+        </p:txBody>
+      </p:sp>
+      <p:sp>
+        <p:nvSpPr>
+          <p:cNvPr id="137" name="TextBox 136"/>
+          <p:cNvSpPr txBox="1"/>
+          <p:nvPr/>
+        </p:nvSpPr>
+        <p:spPr>
+          <a:xfrm>
+            <a:off x="822960" y="5687568"/>
+            <a:ext cx="1188720" cy="182880"/>
           </a:xfrm>
           <a:prstGeom prst="rect">
             <a:avLst/>
@@ -14596,13 +16398,13 @@
       </p:sp>
       <p:sp>
         <p:nvSpPr>
-          <p:cNvPr id="92" name="TextBox 91"/>
+          <p:cNvPr id="138" name="TextBox 137"/>
           <p:cNvSpPr txBox="1"/>
           <p:nvPr/>
         </p:nvSpPr>
         <p:spPr>
           <a:xfrm>
-            <a:off x="1828800" y="5413248"/>
+            <a:off x="1828800" y="5669280"/>
             <a:ext cx="1325880" cy="228600"/>
           </a:xfrm>
           <a:prstGeom prst="rect">
@@ -14631,14 +16433,14 @@
       </p:sp>
       <p:sp>
         <p:nvSpPr>
-          <p:cNvPr id="93" name="Rounded Rectangle 92"/>
-          <p:cNvSpPr/>
-          <p:nvPr/>
-        </p:nvSpPr>
-        <p:spPr>
-          <a:xfrm>
-            <a:off x="3465576" y="5349240"/>
-            <a:ext cx="2514600" cy="502920"/>
+          <p:cNvPr id="139" name="Rounded Rectangle 138"/>
+          <p:cNvSpPr/>
+          <p:nvPr/>
+        </p:nvSpPr>
+        <p:spPr>
+          <a:xfrm>
+            <a:off x="3456432" y="5623560"/>
+            <a:ext cx="2542032" cy="438912"/>
           </a:xfrm>
           <a:prstGeom prst="roundRect">
             <a:avLst/>
@@ -14676,14 +16478,14 @@
       </p:sp>
       <p:sp>
         <p:nvSpPr>
-          <p:cNvPr id="94" name="TextBox 93"/>
+          <p:cNvPr id="140" name="TextBox 139"/>
           <p:cNvSpPr txBox="1"/>
           <p:nvPr/>
         </p:nvSpPr>
         <p:spPr>
           <a:xfrm>
-            <a:off x="3557016" y="5440680"/>
-            <a:ext cx="1097280" cy="182880"/>
+            <a:off x="3547872" y="5687568"/>
+            <a:ext cx="1188720" cy="182880"/>
           </a:xfrm>
           <a:prstGeom prst="rect">
             <a:avLst/>
@@ -14711,13 +16513,13 @@
       </p:sp>
       <p:sp>
         <p:nvSpPr>
-          <p:cNvPr id="95" name="TextBox 94"/>
+          <p:cNvPr id="141" name="TextBox 140"/>
           <p:cNvSpPr txBox="1"/>
           <p:nvPr/>
         </p:nvSpPr>
         <p:spPr>
           <a:xfrm>
-            <a:off x="4562856" y="5413248"/>
+            <a:off x="4553712" y="5669280"/>
             <a:ext cx="1325880" cy="228600"/>
           </a:xfrm>
           <a:prstGeom prst="rect">
@@ -14746,14 +16548,14 @@
       </p:sp>
       <p:sp>
         <p:nvSpPr>
-          <p:cNvPr id="96" name="Rounded Rectangle 95"/>
-          <p:cNvSpPr/>
-          <p:nvPr/>
-        </p:nvSpPr>
-        <p:spPr>
-          <a:xfrm>
-            <a:off x="6199632" y="5349240"/>
-            <a:ext cx="2514600" cy="502920"/>
+          <p:cNvPr id="142" name="Rounded Rectangle 141"/>
+          <p:cNvSpPr/>
+          <p:nvPr/>
+        </p:nvSpPr>
+        <p:spPr>
+          <a:xfrm>
+            <a:off x="6181344" y="5623560"/>
+            <a:ext cx="2542032" cy="438912"/>
           </a:xfrm>
           <a:prstGeom prst="roundRect">
             <a:avLst/>
@@ -14791,14 +16593,14 @@
       </p:sp>
       <p:sp>
         <p:nvSpPr>
-          <p:cNvPr id="97" name="TextBox 96"/>
+          <p:cNvPr id="143" name="TextBox 142"/>
           <p:cNvSpPr txBox="1"/>
           <p:nvPr/>
         </p:nvSpPr>
         <p:spPr>
           <a:xfrm>
-            <a:off x="6291072" y="5440680"/>
-            <a:ext cx="1097280" cy="182880"/>
+            <a:off x="6272784" y="5687568"/>
+            <a:ext cx="1188720" cy="182880"/>
           </a:xfrm>
           <a:prstGeom prst="rect">
             <a:avLst/>
@@ -14826,13 +16628,13 @@
       </p:sp>
       <p:sp>
         <p:nvSpPr>
-          <p:cNvPr id="98" name="TextBox 97"/>
+          <p:cNvPr id="144" name="TextBox 143"/>
           <p:cNvSpPr txBox="1"/>
           <p:nvPr/>
         </p:nvSpPr>
         <p:spPr>
           <a:xfrm>
-            <a:off x="7296912" y="5413248"/>
+            <a:off x="7278624" y="5669280"/>
             <a:ext cx="1325880" cy="228600"/>
           </a:xfrm>
           <a:prstGeom prst="rect">
@@ -14861,14 +16663,14 @@
       </p:sp>
       <p:sp>
         <p:nvSpPr>
-          <p:cNvPr id="99" name="Rounded Rectangle 98"/>
-          <p:cNvSpPr/>
-          <p:nvPr/>
-        </p:nvSpPr>
-        <p:spPr>
-          <a:xfrm>
-            <a:off x="8933688" y="5349240"/>
-            <a:ext cx="2514600" cy="502920"/>
+          <p:cNvPr id="145" name="Rounded Rectangle 144"/>
+          <p:cNvSpPr/>
+          <p:nvPr/>
+        </p:nvSpPr>
+        <p:spPr>
+          <a:xfrm>
+            <a:off x="8906256" y="5623560"/>
+            <a:ext cx="2542032" cy="438912"/>
           </a:xfrm>
           <a:prstGeom prst="roundRect">
             <a:avLst/>
@@ -14906,14 +16708,14 @@
       </p:sp>
       <p:sp>
         <p:nvSpPr>
-          <p:cNvPr id="100" name="TextBox 99"/>
+          <p:cNvPr id="146" name="TextBox 145"/>
           <p:cNvSpPr txBox="1"/>
           <p:nvPr/>
         </p:nvSpPr>
         <p:spPr>
           <a:xfrm>
-            <a:off x="9025128" y="5440680"/>
-            <a:ext cx="1097280" cy="182880"/>
+            <a:off x="8997696" y="5687568"/>
+            <a:ext cx="1188720" cy="182880"/>
           </a:xfrm>
           <a:prstGeom prst="rect">
             <a:avLst/>
@@ -14941,13 +16743,13 @@
       </p:sp>
       <p:sp>
         <p:nvSpPr>
-          <p:cNvPr id="101" name="TextBox 100"/>
+          <p:cNvPr id="147" name="TextBox 146"/>
           <p:cNvSpPr txBox="1"/>
           <p:nvPr/>
         </p:nvSpPr>
         <p:spPr>
           <a:xfrm>
-            <a:off x="10030968" y="5413248"/>
+            <a:off x="10003536" y="5669280"/>
             <a:ext cx="1325880" cy="228600"/>
           </a:xfrm>
           <a:prstGeom prst="rect">
@@ -14976,13 +16778,13 @@
       </p:sp>
       <p:sp>
         <p:nvSpPr>
-          <p:cNvPr id="102" name="Rectangle 101"/>
-          <p:cNvSpPr/>
-          <p:nvPr/>
-        </p:nvSpPr>
-        <p:spPr>
-          <a:xfrm>
-            <a:off x="731520" y="6035040"/>
+          <p:cNvPr id="148" name="Rectangle 147"/>
+          <p:cNvSpPr/>
+          <p:nvPr/>
+        </p:nvSpPr>
+        <p:spPr>
+          <a:xfrm>
+            <a:off x="731520" y="6172200"/>
             <a:ext cx="10728655" cy="13716"/>
           </a:xfrm>
           <a:prstGeom prst="rect">
@@ -15019,13 +16821,13 @@
       </p:sp>
       <p:sp>
         <p:nvSpPr>
-          <p:cNvPr id="103" name="TextBox 102"/>
+          <p:cNvPr id="149" name="TextBox 148"/>
           <p:cNvSpPr txBox="1"/>
           <p:nvPr/>
         </p:nvSpPr>
         <p:spPr>
           <a:xfrm>
-            <a:off x="731520" y="6144768"/>
+            <a:off x="731520" y="6263640"/>
             <a:ext cx="2743200" cy="274320"/>
           </a:xfrm>
           <a:prstGeom prst="rect">
@@ -15054,13 +16856,13 @@
       </p:sp>
       <p:sp>
         <p:nvSpPr>
-          <p:cNvPr id="104" name="TextBox 103"/>
+          <p:cNvPr id="150" name="TextBox 149"/>
           <p:cNvSpPr txBox="1"/>
           <p:nvPr/>
         </p:nvSpPr>
         <p:spPr>
           <a:xfrm>
-            <a:off x="6858000" y="6144768"/>
+            <a:off x="6858000" y="6263640"/>
             <a:ext cx="4602175" cy="274320"/>
           </a:xfrm>
           <a:prstGeom prst="rect">

</xml_diff>

<commit_message>
feat(slides): integrate Playwright PDF/PNG pipeline and convert all figures to INR (Rupees, Lakhs, Crores)
</commit_message>
<xml_diff>
--- a/sutra_pitch_deck.pptx
+++ b/sutra_pitch_deck.pptx
@@ -9584,7 +9584,7 @@
                 </a:solidFill>
                 <a:latin typeface="Inter"/>
               </a:rPr>
-              <a:t>Military drones cost over $50,000 each</a:t>
+              <a:t>Military drones cost over ₹40 Lakhs each</a:t>
             </a:r>
           </a:p>
         </p:txBody>
@@ -13159,7 +13159,7 @@
                 </a:solidFill>
                 <a:latin typeface="JetBrains Mono"/>
               </a:rPr>
-              <a:t>12% FALSE POSITIVES</a:t>
+              <a:t>12% FALSE ALARMS</a:t>
             </a:r>
           </a:p>
         </p:txBody>
@@ -13239,7 +13239,7 @@
                 </a:solidFill>
                 <a:latin typeface="JetBrains Mono"/>
               </a:rPr>
-              <a:t>$12K SORTIE</a:t>
+              <a:t>₹95,000 SORTIE</a:t>
             </a:r>
           </a:p>
         </p:txBody>
@@ -16426,7 +16426,7 @@
                 </a:solidFill>
                 <a:latin typeface="JetBrains Mono"/>
               </a:rPr>
-              <a:t>$8.94B Market 2033</a:t>
+              <a:t>₹74,500 Cr Market</a:t>
             </a:r>
           </a:p>
         </p:txBody>
@@ -16736,7 +16736,7 @@
                 </a:solidFill>
                 <a:latin typeface="JetBrains Mono"/>
               </a:rPr>
-              <a:t>FEMA ALLOCATION</a:t>
+              <a:t>NDMA / SDRF GRANTS</a:t>
             </a:r>
           </a:p>
         </p:txBody>
@@ -16771,7 +16771,7 @@
                 </a:solidFill>
                 <a:latin typeface="JetBrains Mono"/>
               </a:rPr>
-              <a:t>$180M in 2025</a:t>
+              <a:t>₹1,500 Cr Allocation</a:t>
             </a:r>
           </a:p>
         </p:txBody>

</xml_diff>

<commit_message>
feat(slides): add respective image carousels across all 4 subsystem problem void cards on Slide 2
</commit_message>
<xml_diff>
--- a/sutra_pitch_deck.pptx
+++ b/sutra_pitch_deck.pptx
@@ -9159,7 +9159,7 @@
                 </a:solidFill>
                 <a:latin typeface="JetBrains Mono"/>
               </a:rPr>
-              <a:t>FIELD BOTTLENECKS</a:t>
+              <a:t>FIELD DISASTER AUDIT</a:t>
             </a:r>
           </a:p>
         </p:txBody>
@@ -9194,7 +9194,7 @@
                 </a:solidFill>
                 <a:latin typeface="Space Grotesk"/>
               </a:rPr>
-              <a:t>Traditional Search &amp; Rescue Fails Across 4 Critical Voids</a:t>
+              <a:t>Traditional Search &amp; Rescue Collapses Across 4 Critical Voids</a:t>
             </a:r>
           </a:p>
         </p:txBody>
@@ -9564,16 +9564,83 @@
           </a:p>
         </p:txBody>
       </p:sp>
-      <p:sp>
-        <p:nvSpPr>
-          <p:cNvPr id="57" name="TextBox 56"/>
+      <p:pic>
+        <p:nvPicPr>
+          <p:cNvPr id="57" name="Picture 56" descr="gps_canopy_shadow.jpg"/>
+          <p:cNvPicPr>
+            <a:picLocks noChangeAspect="1"/>
+          </p:cNvPicPr>
+          <p:nvPr/>
+        </p:nvPicPr>
+        <p:blipFill>
+          <a:blip r:embed="rId2"/>
+          <a:stretch>
+            <a:fillRect/>
+          </a:stretch>
+        </p:blipFill>
+        <p:spPr>
+          <a:xfrm>
+            <a:off x="804672" y="1609344"/>
+            <a:ext cx="2395728" cy="868680"/>
+          </a:xfrm>
+          <a:prstGeom prst="rect">
+            <a:avLst/>
+          </a:prstGeom>
+        </p:spPr>
+      </p:pic>
+      <p:sp>
+        <p:nvSpPr>
+          <p:cNvPr id="58" name="Rectangle 57"/>
+          <p:cNvSpPr/>
+          <p:nvPr/>
+        </p:nvSpPr>
+        <p:spPr>
+          <a:xfrm>
+            <a:off x="804672" y="2267712"/>
+            <a:ext cx="2395728" cy="210312"/>
+          </a:xfrm>
+          <a:prstGeom prst="rect">
+            <a:avLst/>
+          </a:prstGeom>
+          <a:solidFill>
+            <a:srgbClr val="09090B"/>
+          </a:solidFill>
+          <a:ln>
+            <a:noFill/>
+          </a:ln>
+        </p:spPr>
+        <p:style>
+          <a:lnRef idx="1">
+            <a:schemeClr val="accent1"/>
+          </a:lnRef>
+          <a:fillRef idx="3">
+            <a:schemeClr val="accent1"/>
+          </a:fillRef>
+          <a:effectRef idx="2">
+            <a:schemeClr val="accent1"/>
+          </a:effectRef>
+          <a:fontRef idx="minor">
+            <a:schemeClr val="lt1"/>
+          </a:fontRef>
+        </p:style>
+        <p:txBody>
+          <a:bodyPr rtlCol="0" anchor="ctr"/>
+          <a:lstStyle/>
+          <a:p>
+            <a:pPr algn="ctr"/>
+          </a:p>
+        </p:txBody>
+      </p:sp>
+      <p:sp>
+        <p:nvSpPr>
+          <p:cNvPr id="59" name="TextBox 58"/>
           <p:cNvSpPr txBox="1"/>
           <p:nvPr/>
         </p:nvSpPr>
         <p:spPr>
           <a:xfrm>
-            <a:off x="841248" y="1645920"/>
-            <a:ext cx="1188720" cy="182880"/>
+            <a:off x="841248" y="2286000"/>
+            <a:ext cx="2322576" cy="164592"/>
           </a:xfrm>
           <a:prstGeom prst="rect">
             <a:avLst/>
@@ -9588,7 +9655,42 @@
           <a:p>
             <a:pPr algn="l"/>
             <a:r>
-              <a:rPr sz="700" b="1" i="0">
+              <a:rPr sz="580" b="1" i="0">
+                <a:solidFill>
+                  <a:srgbClr val="FFFFFF"/>
+                </a:solidFill>
+                <a:latin typeface="JetBrains Mono"/>
+              </a:rPr>
+              <a:t>Wayanad Canopy Crash</a:t>
+            </a:r>
+          </a:p>
+        </p:txBody>
+      </p:sp>
+      <p:sp>
+        <p:nvSpPr>
+          <p:cNvPr id="60" name="TextBox 59"/>
+          <p:cNvSpPr txBox="1"/>
+          <p:nvPr/>
+        </p:nvSpPr>
+        <p:spPr>
+          <a:xfrm>
+            <a:off x="841248" y="2542032"/>
+            <a:ext cx="1188720" cy="164592"/>
+          </a:xfrm>
+          <a:prstGeom prst="rect">
+            <a:avLst/>
+          </a:prstGeom>
+          <a:noFill/>
+        </p:spPr>
+        <p:txBody>
+          <a:bodyPr wrap="square" lIns="0" tIns="0" rIns="0" bIns="0">
+            <a:spAutoFit/>
+          </a:bodyPr>
+          <a:lstStyle/>
+          <a:p>
+            <a:pPr algn="l"/>
+            <a:r>
+              <a:rPr sz="620" b="1" i="0">
                 <a:solidFill>
                   <a:srgbClr val="94A3B8"/>
                 </a:solidFill>
@@ -9601,14 +9703,14 @@
       </p:sp>
       <p:sp>
         <p:nvSpPr>
-          <p:cNvPr id="58" name="Rounded Rectangle 57"/>
-          <p:cNvSpPr/>
-          <p:nvPr/>
-        </p:nvSpPr>
-        <p:spPr>
-          <a:xfrm>
-            <a:off x="2057400" y="1627632"/>
-            <a:ext cx="1097280" cy="201168"/>
+          <p:cNvPr id="61" name="Rounded Rectangle 60"/>
+          <p:cNvSpPr/>
+          <p:nvPr/>
+        </p:nvSpPr>
+        <p:spPr>
+          <a:xfrm>
+            <a:off x="2057400" y="2523744"/>
+            <a:ext cx="1097280" cy="182880"/>
           </a:xfrm>
           <a:prstGeom prst="roundRect">
             <a:avLst/>
@@ -9646,14 +9748,14 @@
       </p:sp>
       <p:sp>
         <p:nvSpPr>
-          <p:cNvPr id="59" name="TextBox 58"/>
+          <p:cNvPr id="62" name="TextBox 61"/>
           <p:cNvSpPr txBox="1"/>
           <p:nvPr/>
         </p:nvSpPr>
         <p:spPr>
           <a:xfrm>
-            <a:off x="2057400" y="1645920"/>
-            <a:ext cx="1097280" cy="182880"/>
+            <a:off x="2057400" y="2542032"/>
+            <a:ext cx="1097280" cy="164592"/>
           </a:xfrm>
           <a:prstGeom prst="rect">
             <a:avLst/>
@@ -9668,7 +9770,7 @@
           <a:p>
             <a:pPr algn="ctr"/>
             <a:r>
-              <a:rPr sz="650" b="1" i="0">
+              <a:rPr sz="580" b="1" i="0">
                 <a:solidFill>
                   <a:srgbClr val="E11D48"/>
                 </a:solidFill>
@@ -9681,14 +9783,14 @@
       </p:sp>
       <p:sp>
         <p:nvSpPr>
-          <p:cNvPr id="60" name="TextBox 59"/>
+          <p:cNvPr id="63" name="TextBox 62"/>
           <p:cNvSpPr txBox="1"/>
           <p:nvPr/>
         </p:nvSpPr>
         <p:spPr>
           <a:xfrm>
-            <a:off x="841248" y="1883664"/>
-            <a:ext cx="2322576" cy="411480"/>
+            <a:off x="841248" y="2743200"/>
+            <a:ext cx="2322576" cy="365760"/>
           </a:xfrm>
           <a:prstGeom prst="rect">
             <a:avLst/>
@@ -9703,7 +9805,7 @@
           <a:p>
             <a:pPr algn="l"/>
             <a:r>
-              <a:rPr sz="1100" b="1" i="0">
+              <a:rPr sz="950" b="1" i="0">
                 <a:solidFill>
                   <a:srgbClr val="09090B"/>
                 </a:solidFill>
@@ -9716,14 +9818,14 @@
       </p:sp>
       <p:sp>
         <p:nvSpPr>
-          <p:cNvPr id="61" name="Rounded Rectangle 60"/>
-          <p:cNvSpPr/>
-          <p:nvPr/>
-        </p:nvSpPr>
-        <p:spPr>
-          <a:xfrm>
-            <a:off x="841248" y="2359152"/>
-            <a:ext cx="2322576" cy="594360"/>
+          <p:cNvPr id="64" name="Rounded Rectangle 63"/>
+          <p:cNvSpPr/>
+          <p:nvPr/>
+        </p:nvSpPr>
+        <p:spPr>
+          <a:xfrm>
+            <a:off x="822960" y="3136392"/>
+            <a:ext cx="2359152" cy="548640"/>
           </a:xfrm>
           <a:prstGeom prst="roundRect">
             <a:avLst/>
@@ -9761,14 +9863,14 @@
       </p:sp>
       <p:sp>
         <p:nvSpPr>
-          <p:cNvPr id="62" name="TextBox 61"/>
+          <p:cNvPr id="65" name="TextBox 64"/>
           <p:cNvSpPr txBox="1"/>
           <p:nvPr/>
         </p:nvSpPr>
         <p:spPr>
           <a:xfrm>
-            <a:off x="896112" y="2395728"/>
-            <a:ext cx="2212848" cy="164592"/>
+            <a:off x="859536" y="3163824"/>
+            <a:ext cx="2286000" cy="137160"/>
           </a:xfrm>
           <a:prstGeom prst="rect">
             <a:avLst/>
@@ -9783,7 +9885,7 @@
           <a:p>
             <a:pPr algn="l"/>
             <a:r>
-              <a:rPr sz="600" b="1" i="0">
+              <a:rPr sz="550" b="1" i="0">
                 <a:solidFill>
                   <a:srgbClr val="E11D48"/>
                 </a:solidFill>
@@ -9796,14 +9898,14 @@
       </p:sp>
       <p:sp>
         <p:nvSpPr>
-          <p:cNvPr id="63" name="TextBox 62"/>
+          <p:cNvPr id="66" name="TextBox 65"/>
           <p:cNvSpPr txBox="1"/>
           <p:nvPr/>
         </p:nvSpPr>
         <p:spPr>
           <a:xfrm>
-            <a:off x="896112" y="2560320"/>
-            <a:ext cx="2212848" cy="365760"/>
+            <a:off x="859536" y="3310128"/>
+            <a:ext cx="2286000" cy="347472"/>
           </a:xfrm>
           <a:prstGeom prst="rect">
             <a:avLst/>
@@ -9818,7 +9920,7 @@
           <a:p>
             <a:pPr algn="l"/>
             <a:r>
-              <a:rPr sz="750" b="1" i="0">
+              <a:rPr sz="680" b="1" i="0">
                 <a:solidFill>
                   <a:srgbClr val="09090B"/>
                 </a:solidFill>
@@ -9831,14 +9933,14 @@
       </p:sp>
       <p:sp>
         <p:nvSpPr>
-          <p:cNvPr id="64" name="Rounded Rectangle 63"/>
-          <p:cNvSpPr/>
-          <p:nvPr/>
-        </p:nvSpPr>
-        <p:spPr>
-          <a:xfrm>
-            <a:off x="841248" y="3044952"/>
-            <a:ext cx="2322576" cy="1325880"/>
+          <p:cNvPr id="67" name="Rounded Rectangle 66"/>
+          <p:cNvSpPr/>
+          <p:nvPr/>
+        </p:nvSpPr>
+        <p:spPr>
+          <a:xfrm>
+            <a:off x="822960" y="3730752"/>
+            <a:ext cx="2359152" cy="868680"/>
           </a:xfrm>
           <a:prstGeom prst="roundRect">
             <a:avLst/>
@@ -9876,14 +9978,14 @@
       </p:sp>
       <p:sp>
         <p:nvSpPr>
-          <p:cNvPr id="65" name="TextBox 64"/>
+          <p:cNvPr id="68" name="TextBox 67"/>
           <p:cNvSpPr txBox="1"/>
           <p:nvPr/>
         </p:nvSpPr>
         <p:spPr>
           <a:xfrm>
-            <a:off x="896112" y="3090672"/>
-            <a:ext cx="2212848" cy="164592"/>
+            <a:off x="859536" y="3767328"/>
+            <a:ext cx="2286000" cy="137160"/>
           </a:xfrm>
           <a:prstGeom prst="rect">
             <a:avLst/>
@@ -9898,7 +10000,7 @@
           <a:p>
             <a:pPr algn="l"/>
             <a:r>
-              <a:rPr sz="650" b="1" i="0">
+              <a:rPr sz="580" b="1" i="0">
                 <a:solidFill>
                   <a:srgbClr val="09090B"/>
                 </a:solidFill>
@@ -9911,14 +10013,14 @@
       </p:sp>
       <p:sp>
         <p:nvSpPr>
-          <p:cNvPr id="66" name="TextBox 65"/>
+          <p:cNvPr id="69" name="TextBox 68"/>
           <p:cNvSpPr txBox="1"/>
           <p:nvPr/>
         </p:nvSpPr>
         <p:spPr>
           <a:xfrm>
-            <a:off x="896112" y="3291840"/>
-            <a:ext cx="2212848" cy="1005840"/>
+            <a:off x="859536" y="3931920"/>
+            <a:ext cx="2286000" cy="640080"/>
           </a:xfrm>
           <a:prstGeom prst="rect">
             <a:avLst/>
@@ -9933,27 +10035,27 @@
           <a:p>
             <a:pPr algn="l"/>
             <a:r>
-              <a:rPr sz="720" b="0" i="0">
+              <a:rPr sz="650" b="0" i="0">
                 <a:solidFill>
                   <a:srgbClr val="475569"/>
                 </a:solidFill>
                 <a:latin typeface="JetBrains Mono"/>
               </a:rPr>
-              <a:t>Commercial flight controllers lose position lock, drifting into tree canopies and causing catastrophic rotor loss.</a:t>
-            </a:r>
-          </a:p>
-        </p:txBody>
-      </p:sp>
-      <p:sp>
-        <p:nvSpPr>
-          <p:cNvPr id="67" name="Rounded Rectangle 66"/>
-          <p:cNvSpPr/>
-          <p:nvPr/>
-        </p:nvSpPr>
-        <p:spPr>
-          <a:xfrm>
-            <a:off x="841248" y="4462272"/>
-            <a:ext cx="1115568" cy="502920"/>
+              <a:t>Commercial drones lose position lock, drifting into tree canopies and causing rotor loss.</a:t>
+            </a:r>
+          </a:p>
+        </p:txBody>
+      </p:sp>
+      <p:sp>
+        <p:nvSpPr>
+          <p:cNvPr id="70" name="Rounded Rectangle 69"/>
+          <p:cNvSpPr/>
+          <p:nvPr/>
+        </p:nvSpPr>
+        <p:spPr>
+          <a:xfrm>
+            <a:off x="822960" y="4663440"/>
+            <a:ext cx="1143000" cy="438912"/>
           </a:xfrm>
           <a:prstGeom prst="roundRect">
             <a:avLst/>
@@ -9991,14 +10093,14 @@
       </p:sp>
       <p:sp>
         <p:nvSpPr>
-          <p:cNvPr id="68" name="TextBox 67"/>
+          <p:cNvPr id="71" name="TextBox 70"/>
           <p:cNvSpPr txBox="1"/>
           <p:nvPr/>
         </p:nvSpPr>
         <p:spPr>
           <a:xfrm>
-            <a:off x="841248" y="4498848"/>
-            <a:ext cx="1115568" cy="228600"/>
+            <a:off x="822960" y="4690872"/>
+            <a:ext cx="1143000" cy="201168"/>
           </a:xfrm>
           <a:prstGeom prst="rect">
             <a:avLst/>
@@ -10013,7 +10115,7 @@
           <a:p>
             <a:pPr algn="ctr"/>
             <a:r>
-              <a:rPr sz="950" b="1" i="0">
+              <a:rPr sz="850" b="1" i="0">
                 <a:solidFill>
                   <a:srgbClr val="E11D48"/>
                 </a:solidFill>
@@ -10026,14 +10128,14 @@
       </p:sp>
       <p:sp>
         <p:nvSpPr>
-          <p:cNvPr id="69" name="TextBox 68"/>
+          <p:cNvPr id="72" name="TextBox 71"/>
           <p:cNvSpPr txBox="1"/>
           <p:nvPr/>
         </p:nvSpPr>
         <p:spPr>
           <a:xfrm>
-            <a:off x="841248" y="4754880"/>
-            <a:ext cx="1115568" cy="182880"/>
+            <a:off x="822960" y="4901184"/>
+            <a:ext cx="1143000" cy="164592"/>
           </a:xfrm>
           <a:prstGeom prst="rect">
             <a:avLst/>
@@ -10048,7 +10150,7 @@
           <a:p>
             <a:pPr algn="ctr"/>
             <a:r>
-              <a:rPr sz="600" b="0" i="0">
+              <a:rPr sz="550" b="0" i="0">
                 <a:solidFill>
                   <a:srgbClr val="64748B"/>
                 </a:solidFill>
@@ -10061,14 +10163,14 @@
       </p:sp>
       <p:sp>
         <p:nvSpPr>
-          <p:cNvPr id="70" name="Rounded Rectangle 69"/>
-          <p:cNvSpPr/>
-          <p:nvPr/>
-        </p:nvSpPr>
-        <p:spPr>
-          <a:xfrm>
-            <a:off x="2048256" y="4462272"/>
-            <a:ext cx="1115568" cy="502920"/>
+          <p:cNvPr id="73" name="Rounded Rectangle 72"/>
+          <p:cNvSpPr/>
+          <p:nvPr/>
+        </p:nvSpPr>
+        <p:spPr>
+          <a:xfrm>
+            <a:off x="2039112" y="4663440"/>
+            <a:ext cx="1143000" cy="438912"/>
           </a:xfrm>
           <a:prstGeom prst="roundRect">
             <a:avLst/>
@@ -10106,14 +10208,14 @@
       </p:sp>
       <p:sp>
         <p:nvSpPr>
-          <p:cNvPr id="71" name="TextBox 70"/>
+          <p:cNvPr id="74" name="TextBox 73"/>
           <p:cNvSpPr txBox="1"/>
           <p:nvPr/>
         </p:nvSpPr>
         <p:spPr>
           <a:xfrm>
-            <a:off x="2048256" y="4498848"/>
-            <a:ext cx="1115568" cy="228600"/>
+            <a:off x="2039112" y="4690872"/>
+            <a:ext cx="1143000" cy="201168"/>
           </a:xfrm>
           <a:prstGeom prst="rect">
             <a:avLst/>
@@ -10128,7 +10230,7 @@
           <a:p>
             <a:pPr algn="ctr"/>
             <a:r>
-              <a:rPr sz="950" b="1" i="0">
+              <a:rPr sz="850" b="1" i="0">
                 <a:solidFill>
                   <a:srgbClr val="09090B"/>
                 </a:solidFill>
@@ -10141,14 +10243,14 @@
       </p:sp>
       <p:sp>
         <p:nvSpPr>
-          <p:cNvPr id="72" name="TextBox 71"/>
+          <p:cNvPr id="75" name="TextBox 74"/>
           <p:cNvSpPr txBox="1"/>
           <p:nvPr/>
         </p:nvSpPr>
         <p:spPr>
           <a:xfrm>
-            <a:off x="2048256" y="4754880"/>
-            <a:ext cx="1115568" cy="182880"/>
+            <a:off x="2039112" y="4901184"/>
+            <a:ext cx="1143000" cy="164592"/>
           </a:xfrm>
           <a:prstGeom prst="rect">
             <a:avLst/>
@@ -10163,7 +10265,7 @@
           <a:p>
             <a:pPr algn="ctr"/>
             <a:r>
-              <a:rPr sz="600" b="0" i="0">
+              <a:rPr sz="550" b="0" i="0">
                 <a:solidFill>
                   <a:srgbClr val="64748B"/>
                 </a:solidFill>
@@ -10176,14 +10278,14 @@
       </p:sp>
       <p:sp>
         <p:nvSpPr>
-          <p:cNvPr id="73" name="TextBox 72"/>
+          <p:cNvPr id="76" name="TextBox 75"/>
           <p:cNvSpPr txBox="1"/>
           <p:nvPr/>
         </p:nvSpPr>
         <p:spPr>
           <a:xfrm>
-            <a:off x="841248" y="5102352"/>
-            <a:ext cx="1188720" cy="182880"/>
+            <a:off x="822960" y="5157216"/>
+            <a:ext cx="1188720" cy="164592"/>
           </a:xfrm>
           <a:prstGeom prst="rect">
             <a:avLst/>
@@ -10198,7 +10300,7 @@
           <a:p>
             <a:pPr algn="l"/>
             <a:r>
-              <a:rPr sz="600" b="0" i="0">
+              <a:rPr sz="550" b="0" i="0">
                 <a:solidFill>
                   <a:srgbClr val="64748B"/>
                 </a:solidFill>
@@ -10211,14 +10313,14 @@
       </p:sp>
       <p:sp>
         <p:nvSpPr>
-          <p:cNvPr id="74" name="TextBox 73"/>
+          <p:cNvPr id="77" name="TextBox 76"/>
           <p:cNvSpPr txBox="1"/>
           <p:nvPr/>
         </p:nvSpPr>
         <p:spPr>
           <a:xfrm>
-            <a:off x="1965960" y="5102352"/>
-            <a:ext cx="1188720" cy="182880"/>
+            <a:off x="1965960" y="5157216"/>
+            <a:ext cx="1188720" cy="164592"/>
           </a:xfrm>
           <a:prstGeom prst="rect">
             <a:avLst/>
@@ -10233,7 +10335,7 @@
           <a:p>
             <a:pPr algn="r"/>
             <a:r>
-              <a:rPr sz="600" b="1" i="0">
+              <a:rPr sz="550" b="1" i="0">
                 <a:solidFill>
                   <a:srgbClr val="E11D48"/>
                 </a:solidFill>
@@ -10246,7 +10348,7 @@
       </p:sp>
       <p:sp>
         <p:nvSpPr>
-          <p:cNvPr id="75" name="Rectangle 74"/>
+          <p:cNvPr id="78" name="Rectangle 77"/>
           <p:cNvSpPr/>
           <p:nvPr/>
         </p:nvSpPr>
@@ -10289,7 +10391,7 @@
       </p:sp>
       <p:sp>
         <p:nvSpPr>
-          <p:cNvPr id="76" name="Rounded Rectangle 75"/>
+          <p:cNvPr id="79" name="Rounded Rectangle 78"/>
           <p:cNvSpPr/>
           <p:nvPr/>
         </p:nvSpPr>
@@ -10332,16 +10434,83 @@
           </a:p>
         </p:txBody>
       </p:sp>
-      <p:sp>
-        <p:nvSpPr>
-          <p:cNvPr id="77" name="TextBox 76"/>
+      <p:pic>
+        <p:nvPicPr>
+          <p:cNvPr id="80" name="Picture 79" descr="rf_mountain_shadow.jpg"/>
+          <p:cNvPicPr>
+            <a:picLocks noChangeAspect="1"/>
+          </p:cNvPicPr>
+          <p:nvPr/>
+        </p:nvPicPr>
+        <p:blipFill>
+          <a:blip r:embed="rId3"/>
+          <a:stretch>
+            <a:fillRect/>
+          </a:stretch>
+        </p:blipFill>
+        <p:spPr>
+          <a:xfrm>
+            <a:off x="3529584" y="1609344"/>
+            <a:ext cx="2395728" cy="868680"/>
+          </a:xfrm>
+          <a:prstGeom prst="rect">
+            <a:avLst/>
+          </a:prstGeom>
+        </p:spPr>
+      </p:pic>
+      <p:sp>
+        <p:nvSpPr>
+          <p:cNvPr id="81" name="Rectangle 80"/>
+          <p:cNvSpPr/>
+          <p:nvPr/>
+        </p:nvSpPr>
+        <p:spPr>
+          <a:xfrm>
+            <a:off x="3529584" y="2267712"/>
+            <a:ext cx="2395728" cy="210312"/>
+          </a:xfrm>
+          <a:prstGeom prst="rect">
+            <a:avLst/>
+          </a:prstGeom>
+          <a:solidFill>
+            <a:srgbClr val="09090B"/>
+          </a:solidFill>
+          <a:ln>
+            <a:noFill/>
+          </a:ln>
+        </p:spPr>
+        <p:style>
+          <a:lnRef idx="1">
+            <a:schemeClr val="accent1"/>
+          </a:lnRef>
+          <a:fillRef idx="3">
+            <a:schemeClr val="accent1"/>
+          </a:fillRef>
+          <a:effectRef idx="2">
+            <a:schemeClr val="accent1"/>
+          </a:effectRef>
+          <a:fontRef idx="minor">
+            <a:schemeClr val="lt1"/>
+          </a:fontRef>
+        </p:style>
+        <p:txBody>
+          <a:bodyPr rtlCol="0" anchor="ctr"/>
+          <a:lstStyle/>
+          <a:p>
+            <a:pPr algn="ctr"/>
+          </a:p>
+        </p:txBody>
+      </p:sp>
+      <p:sp>
+        <p:nvSpPr>
+          <p:cNvPr id="82" name="TextBox 81"/>
           <p:cNvSpPr txBox="1"/>
           <p:nvPr/>
         </p:nvSpPr>
         <p:spPr>
           <a:xfrm>
-            <a:off x="3566160" y="1645920"/>
-            <a:ext cx="1188720" cy="182880"/>
+            <a:off x="3566160" y="2286000"/>
+            <a:ext cx="2322576" cy="164592"/>
           </a:xfrm>
           <a:prstGeom prst="rect">
             <a:avLst/>
@@ -10356,7 +10525,42 @@
           <a:p>
             <a:pPr algn="l"/>
             <a:r>
-              <a:rPr sz="700" b="1" i="0">
+              <a:rPr sz="580" b="1" i="0">
+                <a:solidFill>
+                  <a:srgbClr val="FFFFFF"/>
+                </a:solidFill>
+                <a:latin typeface="JetBrains Mono"/>
+              </a:rPr>
+              <a:t>Chamoli Gorge RF Cut</a:t>
+            </a:r>
+          </a:p>
+        </p:txBody>
+      </p:sp>
+      <p:sp>
+        <p:nvSpPr>
+          <p:cNvPr id="83" name="TextBox 82"/>
+          <p:cNvSpPr txBox="1"/>
+          <p:nvPr/>
+        </p:nvSpPr>
+        <p:spPr>
+          <a:xfrm>
+            <a:off x="3566160" y="2542032"/>
+            <a:ext cx="1188720" cy="164592"/>
+          </a:xfrm>
+          <a:prstGeom prst="rect">
+            <a:avLst/>
+          </a:prstGeom>
+          <a:noFill/>
+        </p:spPr>
+        <p:txBody>
+          <a:bodyPr wrap="square" lIns="0" tIns="0" rIns="0" bIns="0">
+            <a:spAutoFit/>
+          </a:bodyPr>
+          <a:lstStyle/>
+          <a:p>
+            <a:pPr algn="l"/>
+            <a:r>
+              <a:rPr sz="620" b="1" i="0">
                 <a:solidFill>
                   <a:srgbClr val="94A3B8"/>
                 </a:solidFill>
@@ -10369,14 +10573,14 @@
       </p:sp>
       <p:sp>
         <p:nvSpPr>
-          <p:cNvPr id="78" name="Rounded Rectangle 77"/>
-          <p:cNvSpPr/>
-          <p:nvPr/>
-        </p:nvSpPr>
-        <p:spPr>
-          <a:xfrm>
-            <a:off x="4782312" y="1627632"/>
-            <a:ext cx="1097280" cy="201168"/>
+          <p:cNvPr id="84" name="Rounded Rectangle 83"/>
+          <p:cNvSpPr/>
+          <p:nvPr/>
+        </p:nvSpPr>
+        <p:spPr>
+          <a:xfrm>
+            <a:off x="4782312" y="2523744"/>
+            <a:ext cx="1097280" cy="182880"/>
           </a:xfrm>
           <a:prstGeom prst="roundRect">
             <a:avLst/>
@@ -10414,14 +10618,14 @@
       </p:sp>
       <p:sp>
         <p:nvSpPr>
-          <p:cNvPr id="79" name="TextBox 78"/>
+          <p:cNvPr id="85" name="TextBox 84"/>
           <p:cNvSpPr txBox="1"/>
           <p:nvPr/>
         </p:nvSpPr>
         <p:spPr>
           <a:xfrm>
-            <a:off x="4782312" y="1645920"/>
-            <a:ext cx="1097280" cy="182880"/>
+            <a:off x="4782312" y="2542032"/>
+            <a:ext cx="1097280" cy="164592"/>
           </a:xfrm>
           <a:prstGeom prst="rect">
             <a:avLst/>
@@ -10436,7 +10640,7 @@
           <a:p>
             <a:pPr algn="ctr"/>
             <a:r>
-              <a:rPr sz="650" b="1" i="0">
+              <a:rPr sz="580" b="1" i="0">
                 <a:solidFill>
                   <a:srgbClr val="E11D48"/>
                 </a:solidFill>
@@ -10449,14 +10653,14 @@
       </p:sp>
       <p:sp>
         <p:nvSpPr>
-          <p:cNvPr id="80" name="TextBox 79"/>
+          <p:cNvPr id="86" name="TextBox 85"/>
           <p:cNvSpPr txBox="1"/>
           <p:nvPr/>
         </p:nvSpPr>
         <p:spPr>
           <a:xfrm>
-            <a:off x="3566160" y="1883664"/>
-            <a:ext cx="2322576" cy="411480"/>
+            <a:off x="3566160" y="2743200"/>
+            <a:ext cx="2322576" cy="365760"/>
           </a:xfrm>
           <a:prstGeom prst="rect">
             <a:avLst/>
@@ -10471,7 +10675,7 @@
           <a:p>
             <a:pPr algn="l"/>
             <a:r>
-              <a:rPr sz="1100" b="1" i="0">
+              <a:rPr sz="950" b="1" i="0">
                 <a:solidFill>
                   <a:srgbClr val="09090B"/>
                 </a:solidFill>
@@ -10484,14 +10688,14 @@
       </p:sp>
       <p:sp>
         <p:nvSpPr>
-          <p:cNvPr id="81" name="Rounded Rectangle 80"/>
-          <p:cNvSpPr/>
-          <p:nvPr/>
-        </p:nvSpPr>
-        <p:spPr>
-          <a:xfrm>
-            <a:off x="3566160" y="2359152"/>
-            <a:ext cx="2322576" cy="594360"/>
+          <p:cNvPr id="87" name="Rounded Rectangle 86"/>
+          <p:cNvSpPr/>
+          <p:nvPr/>
+        </p:nvSpPr>
+        <p:spPr>
+          <a:xfrm>
+            <a:off x="3547872" y="3136392"/>
+            <a:ext cx="2359152" cy="548640"/>
           </a:xfrm>
           <a:prstGeom prst="roundRect">
             <a:avLst/>
@@ -10529,14 +10733,14 @@
       </p:sp>
       <p:sp>
         <p:nvSpPr>
-          <p:cNvPr id="82" name="TextBox 81"/>
+          <p:cNvPr id="88" name="TextBox 87"/>
           <p:cNvSpPr txBox="1"/>
           <p:nvPr/>
         </p:nvSpPr>
         <p:spPr>
           <a:xfrm>
-            <a:off x="3621024" y="2395728"/>
-            <a:ext cx="2212848" cy="164592"/>
+            <a:off x="3584448" y="3163824"/>
+            <a:ext cx="2286000" cy="137160"/>
           </a:xfrm>
           <a:prstGeom prst="rect">
             <a:avLst/>
@@ -10551,7 +10755,7 @@
           <a:p>
             <a:pPr algn="l"/>
             <a:r>
-              <a:rPr sz="600" b="1" i="0">
+              <a:rPr sz="550" b="1" i="0">
                 <a:solidFill>
                   <a:srgbClr val="E11D48"/>
                 </a:solidFill>
@@ -10564,14 +10768,14 @@
       </p:sp>
       <p:sp>
         <p:nvSpPr>
-          <p:cNvPr id="83" name="TextBox 82"/>
+          <p:cNvPr id="89" name="TextBox 88"/>
           <p:cNvSpPr txBox="1"/>
           <p:nvPr/>
         </p:nvSpPr>
         <p:spPr>
           <a:xfrm>
-            <a:off x="3621024" y="2560320"/>
-            <a:ext cx="2212848" cy="365760"/>
+            <a:off x="3584448" y="3310128"/>
+            <a:ext cx="2286000" cy="347472"/>
           </a:xfrm>
           <a:prstGeom prst="rect">
             <a:avLst/>
@@ -10586,7 +10790,7 @@
           <a:p>
             <a:pPr algn="l"/>
             <a:r>
-              <a:rPr sz="750" b="1" i="0">
+              <a:rPr sz="680" b="1" i="0">
                 <a:solidFill>
                   <a:srgbClr val="09090B"/>
                 </a:solidFill>
@@ -10599,14 +10803,14 @@
       </p:sp>
       <p:sp>
         <p:nvSpPr>
-          <p:cNvPr id="84" name="Rounded Rectangle 83"/>
-          <p:cNvSpPr/>
-          <p:nvPr/>
-        </p:nvSpPr>
-        <p:spPr>
-          <a:xfrm>
-            <a:off x="3566160" y="3044952"/>
-            <a:ext cx="2322576" cy="1325880"/>
+          <p:cNvPr id="90" name="Rounded Rectangle 89"/>
+          <p:cNvSpPr/>
+          <p:nvPr/>
+        </p:nvSpPr>
+        <p:spPr>
+          <a:xfrm>
+            <a:off x="3547872" y="3730752"/>
+            <a:ext cx="2359152" cy="868680"/>
           </a:xfrm>
           <a:prstGeom prst="roundRect">
             <a:avLst/>
@@ -10644,14 +10848,14 @@
       </p:sp>
       <p:sp>
         <p:nvSpPr>
-          <p:cNvPr id="85" name="TextBox 84"/>
+          <p:cNvPr id="91" name="TextBox 90"/>
           <p:cNvSpPr txBox="1"/>
           <p:nvPr/>
         </p:nvSpPr>
         <p:spPr>
           <a:xfrm>
-            <a:off x="3621024" y="3090672"/>
-            <a:ext cx="2212848" cy="164592"/>
+            <a:off x="3584448" y="3767328"/>
+            <a:ext cx="2286000" cy="137160"/>
           </a:xfrm>
           <a:prstGeom prst="rect">
             <a:avLst/>
@@ -10666,7 +10870,7 @@
           <a:p>
             <a:pPr algn="l"/>
             <a:r>
-              <a:rPr sz="650" b="1" i="0">
+              <a:rPr sz="580" b="1" i="0">
                 <a:solidFill>
                   <a:srgbClr val="09090B"/>
                 </a:solidFill>
@@ -10679,14 +10883,14 @@
       </p:sp>
       <p:sp>
         <p:nvSpPr>
-          <p:cNvPr id="86" name="TextBox 85"/>
+          <p:cNvPr id="92" name="TextBox 91"/>
           <p:cNvSpPr txBox="1"/>
           <p:nvPr/>
         </p:nvSpPr>
         <p:spPr>
           <a:xfrm>
-            <a:off x="3621024" y="3291840"/>
-            <a:ext cx="2212848" cy="1005840"/>
+            <a:off x="3584448" y="3931920"/>
+            <a:ext cx="2286000" cy="640080"/>
           </a:xfrm>
           <a:prstGeom prst="rect">
             <a:avLst/>
@@ -10701,27 +10905,27 @@
           <a:p>
             <a:pPr algn="l"/>
             <a:r>
-              <a:rPr sz="720" b="0" i="0">
+              <a:rPr sz="650" b="0" i="0">
                 <a:solidFill>
                   <a:srgbClr val="475569"/>
                 </a:solidFill>
                 <a:latin typeface="JetBrains Mono"/>
               </a:rPr>
-              <a:t>Conventional H.264 digital video completely cuts out below 5dB SNR, plunging base operators into total blindness.</a:t>
-            </a:r>
-          </a:p>
-        </p:txBody>
-      </p:sp>
-      <p:sp>
-        <p:nvSpPr>
-          <p:cNvPr id="87" name="Rounded Rectangle 86"/>
-          <p:cNvSpPr/>
-          <p:nvPr/>
-        </p:nvSpPr>
-        <p:spPr>
-          <a:xfrm>
-            <a:off x="3566160" y="4462272"/>
-            <a:ext cx="1115568" cy="502920"/>
+              <a:t>Conventional H.264 digital video completely cuts out below 5dB SNR, causing total blindness.</a:t>
+            </a:r>
+          </a:p>
+        </p:txBody>
+      </p:sp>
+      <p:sp>
+        <p:nvSpPr>
+          <p:cNvPr id="93" name="Rounded Rectangle 92"/>
+          <p:cNvSpPr/>
+          <p:nvPr/>
+        </p:nvSpPr>
+        <p:spPr>
+          <a:xfrm>
+            <a:off x="3547872" y="4663440"/>
+            <a:ext cx="1143000" cy="438912"/>
           </a:xfrm>
           <a:prstGeom prst="roundRect">
             <a:avLst/>
@@ -10759,14 +10963,14 @@
       </p:sp>
       <p:sp>
         <p:nvSpPr>
-          <p:cNvPr id="88" name="TextBox 87"/>
+          <p:cNvPr id="94" name="TextBox 93"/>
           <p:cNvSpPr txBox="1"/>
           <p:nvPr/>
         </p:nvSpPr>
         <p:spPr>
           <a:xfrm>
-            <a:off x="3566160" y="4498848"/>
-            <a:ext cx="1115568" cy="228600"/>
+            <a:off x="3547872" y="4690872"/>
+            <a:ext cx="1143000" cy="201168"/>
           </a:xfrm>
           <a:prstGeom prst="rect">
             <a:avLst/>
@@ -10781,7 +10985,7 @@
           <a:p>
             <a:pPr algn="ctr"/>
             <a:r>
-              <a:rPr sz="950" b="1" i="0">
+              <a:rPr sz="850" b="1" i="0">
                 <a:solidFill>
                   <a:srgbClr val="E11D48"/>
                 </a:solidFill>
@@ -10794,14 +10998,14 @@
       </p:sp>
       <p:sp>
         <p:nvSpPr>
-          <p:cNvPr id="89" name="TextBox 88"/>
+          <p:cNvPr id="95" name="TextBox 94"/>
           <p:cNvSpPr txBox="1"/>
           <p:nvPr/>
         </p:nvSpPr>
         <p:spPr>
           <a:xfrm>
-            <a:off x="3566160" y="4754880"/>
-            <a:ext cx="1115568" cy="182880"/>
+            <a:off x="3547872" y="4901184"/>
+            <a:ext cx="1143000" cy="164592"/>
           </a:xfrm>
           <a:prstGeom prst="rect">
             <a:avLst/>
@@ -10816,7 +11020,7 @@
           <a:p>
             <a:pPr algn="ctr"/>
             <a:r>
-              <a:rPr sz="600" b="0" i="0">
+              <a:rPr sz="550" b="0" i="0">
                 <a:solidFill>
                   <a:srgbClr val="64748B"/>
                 </a:solidFill>
@@ -10829,14 +11033,14 @@
       </p:sp>
       <p:sp>
         <p:nvSpPr>
-          <p:cNvPr id="90" name="Rounded Rectangle 89"/>
-          <p:cNvSpPr/>
-          <p:nvPr/>
-        </p:nvSpPr>
-        <p:spPr>
-          <a:xfrm>
-            <a:off x="4773168" y="4462272"/>
-            <a:ext cx="1115568" cy="502920"/>
+          <p:cNvPr id="96" name="Rounded Rectangle 95"/>
+          <p:cNvSpPr/>
+          <p:nvPr/>
+        </p:nvSpPr>
+        <p:spPr>
+          <a:xfrm>
+            <a:off x="4764024" y="4663440"/>
+            <a:ext cx="1143000" cy="438912"/>
           </a:xfrm>
           <a:prstGeom prst="roundRect">
             <a:avLst/>
@@ -10874,14 +11078,14 @@
       </p:sp>
       <p:sp>
         <p:nvSpPr>
-          <p:cNvPr id="91" name="TextBox 90"/>
+          <p:cNvPr id="97" name="TextBox 96"/>
           <p:cNvSpPr txBox="1"/>
           <p:nvPr/>
         </p:nvSpPr>
         <p:spPr>
           <a:xfrm>
-            <a:off x="4773168" y="4498848"/>
-            <a:ext cx="1115568" cy="228600"/>
+            <a:off x="4764024" y="4690872"/>
+            <a:ext cx="1143000" cy="201168"/>
           </a:xfrm>
           <a:prstGeom prst="rect">
             <a:avLst/>
@@ -10896,7 +11100,7 @@
           <a:p>
             <a:pPr algn="ctr"/>
             <a:r>
-              <a:rPr sz="950" b="1" i="0">
+              <a:rPr sz="850" b="1" i="0">
                 <a:solidFill>
                   <a:srgbClr val="09090B"/>
                 </a:solidFill>
@@ -10909,14 +11113,14 @@
       </p:sp>
       <p:sp>
         <p:nvSpPr>
-          <p:cNvPr id="92" name="TextBox 91"/>
+          <p:cNvPr id="98" name="TextBox 97"/>
           <p:cNvSpPr txBox="1"/>
           <p:nvPr/>
         </p:nvSpPr>
         <p:spPr>
           <a:xfrm>
-            <a:off x="4773168" y="4754880"/>
-            <a:ext cx="1115568" cy="182880"/>
+            <a:off x="4764024" y="4901184"/>
+            <a:ext cx="1143000" cy="164592"/>
           </a:xfrm>
           <a:prstGeom prst="rect">
             <a:avLst/>
@@ -10931,7 +11135,7 @@
           <a:p>
             <a:pPr algn="ctr"/>
             <a:r>
-              <a:rPr sz="600" b="0" i="0">
+              <a:rPr sz="550" b="0" i="0">
                 <a:solidFill>
                   <a:srgbClr val="64748B"/>
                 </a:solidFill>
@@ -10944,14 +11148,14 @@
       </p:sp>
       <p:sp>
         <p:nvSpPr>
-          <p:cNvPr id="93" name="TextBox 92"/>
+          <p:cNvPr id="99" name="TextBox 98"/>
           <p:cNvSpPr txBox="1"/>
           <p:nvPr/>
         </p:nvSpPr>
         <p:spPr>
           <a:xfrm>
-            <a:off x="3566160" y="5102352"/>
-            <a:ext cx="1188720" cy="182880"/>
+            <a:off x="3547872" y="5157216"/>
+            <a:ext cx="1188720" cy="164592"/>
           </a:xfrm>
           <a:prstGeom prst="rect">
             <a:avLst/>
@@ -10966,7 +11170,7 @@
           <a:p>
             <a:pPr algn="l"/>
             <a:r>
-              <a:rPr sz="600" b="0" i="0">
+              <a:rPr sz="550" b="0" i="0">
                 <a:solidFill>
                   <a:srgbClr val="64748B"/>
                 </a:solidFill>
@@ -10979,14 +11183,14 @@
       </p:sp>
       <p:sp>
         <p:nvSpPr>
-          <p:cNvPr id="94" name="TextBox 93"/>
+          <p:cNvPr id="100" name="TextBox 99"/>
           <p:cNvSpPr txBox="1"/>
           <p:nvPr/>
         </p:nvSpPr>
         <p:spPr>
           <a:xfrm>
-            <a:off x="4690872" y="5102352"/>
-            <a:ext cx="1188720" cy="182880"/>
+            <a:off x="4690872" y="5157216"/>
+            <a:ext cx="1188720" cy="164592"/>
           </a:xfrm>
           <a:prstGeom prst="rect">
             <a:avLst/>
@@ -11001,7 +11205,7 @@
           <a:p>
             <a:pPr algn="r"/>
             <a:r>
-              <a:rPr sz="600" b="1" i="0">
+              <a:rPr sz="550" b="1" i="0">
                 <a:solidFill>
                   <a:srgbClr val="E11D48"/>
                 </a:solidFill>
@@ -11014,7 +11218,7 @@
       </p:sp>
       <p:sp>
         <p:nvSpPr>
-          <p:cNvPr id="95" name="Rectangle 94"/>
+          <p:cNvPr id="101" name="Rectangle 100"/>
           <p:cNvSpPr/>
           <p:nvPr/>
         </p:nvSpPr>
@@ -11057,7 +11261,7 @@
       </p:sp>
       <p:sp>
         <p:nvSpPr>
-          <p:cNvPr id="96" name="Rounded Rectangle 95"/>
+          <p:cNvPr id="102" name="Rounded Rectangle 101"/>
           <p:cNvSpPr/>
           <p:nvPr/>
         </p:nvSpPr>
@@ -11100,16 +11304,83 @@
           </a:p>
         </p:txBody>
       </p:sp>
-      <p:sp>
-        <p:nvSpPr>
-          <p:cNvPr id="97" name="TextBox 96"/>
+      <p:pic>
+        <p:nvPicPr>
+          <p:cNvPr id="103" name="Picture 102" descr="disaster_rescue_2.jpg"/>
+          <p:cNvPicPr>
+            <a:picLocks noChangeAspect="1"/>
+          </p:cNvPicPr>
+          <p:nvPr/>
+        </p:nvPicPr>
+        <p:blipFill>
+          <a:blip r:embed="rId4"/>
+          <a:stretch>
+            <a:fillRect/>
+          </a:stretch>
+        </p:blipFill>
+        <p:spPr>
+          <a:xfrm>
+            <a:off x="6254496" y="1609344"/>
+            <a:ext cx="2395728" cy="868680"/>
+          </a:xfrm>
+          <a:prstGeom prst="rect">
+            <a:avLst/>
+          </a:prstGeom>
+        </p:spPr>
+      </p:pic>
+      <p:sp>
+        <p:nvSpPr>
+          <p:cNvPr id="104" name="Rectangle 103"/>
+          <p:cNvSpPr/>
+          <p:nvPr/>
+        </p:nvSpPr>
+        <p:spPr>
+          <a:xfrm>
+            <a:off x="6254496" y="2267712"/>
+            <a:ext cx="2395728" cy="210312"/>
+          </a:xfrm>
+          <a:prstGeom prst="rect">
+            <a:avLst/>
+          </a:prstGeom>
+          <a:solidFill>
+            <a:srgbClr val="09090B"/>
+          </a:solidFill>
+          <a:ln>
+            <a:noFill/>
+          </a:ln>
+        </p:spPr>
+        <p:style>
+          <a:lnRef idx="1">
+            <a:schemeClr val="accent1"/>
+          </a:lnRef>
+          <a:fillRef idx="3">
+            <a:schemeClr val="accent1"/>
+          </a:fillRef>
+          <a:effectRef idx="2">
+            <a:schemeClr val="accent1"/>
+          </a:effectRef>
+          <a:fontRef idx="minor">
+            <a:schemeClr val="lt1"/>
+          </a:fontRef>
+        </p:style>
+        <p:txBody>
+          <a:bodyPr rtlCol="0" anchor="ctr"/>
+          <a:lstStyle/>
+          <a:p>
+            <a:pPr algn="ctr"/>
+          </a:p>
+        </p:txBody>
+      </p:sp>
+      <p:sp>
+        <p:nvSpPr>
+          <p:cNvPr id="105" name="TextBox 104"/>
           <p:cNvSpPr txBox="1"/>
           <p:nvPr/>
         </p:nvSpPr>
         <p:spPr>
           <a:xfrm>
-            <a:off x="6291072" y="1645920"/>
-            <a:ext cx="1188720" cy="182880"/>
+            <a:off x="6291072" y="2286000"/>
+            <a:ext cx="2322576" cy="164592"/>
           </a:xfrm>
           <a:prstGeom prst="rect">
             <a:avLst/>
@@ -11124,7 +11395,42 @@
           <a:p>
             <a:pPr algn="l"/>
             <a:r>
-              <a:rPr sz="700" b="1" i="0">
+              <a:rPr sz="580" b="1" i="0">
+                <a:solidFill>
+                  <a:srgbClr val="FFFFFF"/>
+                </a:solidFill>
+                <a:latin typeface="JetBrains Mono"/>
+              </a:rPr>
+              <a:t>Sikkim Slope Geo Error</a:t>
+            </a:r>
+          </a:p>
+        </p:txBody>
+      </p:sp>
+      <p:sp>
+        <p:nvSpPr>
+          <p:cNvPr id="106" name="TextBox 105"/>
+          <p:cNvSpPr txBox="1"/>
+          <p:nvPr/>
+        </p:nvSpPr>
+        <p:spPr>
+          <a:xfrm>
+            <a:off x="6291072" y="2542032"/>
+            <a:ext cx="1188720" cy="164592"/>
+          </a:xfrm>
+          <a:prstGeom prst="rect">
+            <a:avLst/>
+          </a:prstGeom>
+          <a:noFill/>
+        </p:spPr>
+        <p:txBody>
+          <a:bodyPr wrap="square" lIns="0" tIns="0" rIns="0" bIns="0">
+            <a:spAutoFit/>
+          </a:bodyPr>
+          <a:lstStyle/>
+          <a:p>
+            <a:pPr algn="l"/>
+            <a:r>
+              <a:rPr sz="620" b="1" i="0">
                 <a:solidFill>
                   <a:srgbClr val="94A3B8"/>
                 </a:solidFill>
@@ -11137,14 +11443,14 @@
       </p:sp>
       <p:sp>
         <p:nvSpPr>
-          <p:cNvPr id="98" name="Rounded Rectangle 97"/>
-          <p:cNvSpPr/>
-          <p:nvPr/>
-        </p:nvSpPr>
-        <p:spPr>
-          <a:xfrm>
-            <a:off x="7507224" y="1627632"/>
-            <a:ext cx="1097280" cy="201168"/>
+          <p:cNvPr id="107" name="Rounded Rectangle 106"/>
+          <p:cNvSpPr/>
+          <p:nvPr/>
+        </p:nvSpPr>
+        <p:spPr>
+          <a:xfrm>
+            <a:off x="7507224" y="2523744"/>
+            <a:ext cx="1097280" cy="182880"/>
           </a:xfrm>
           <a:prstGeom prst="roundRect">
             <a:avLst/>
@@ -11182,14 +11488,14 @@
       </p:sp>
       <p:sp>
         <p:nvSpPr>
-          <p:cNvPr id="99" name="TextBox 98"/>
+          <p:cNvPr id="108" name="TextBox 107"/>
           <p:cNvSpPr txBox="1"/>
           <p:nvPr/>
         </p:nvSpPr>
         <p:spPr>
           <a:xfrm>
-            <a:off x="7507224" y="1645920"/>
-            <a:ext cx="1097280" cy="182880"/>
+            <a:off x="7507224" y="2542032"/>
+            <a:ext cx="1097280" cy="164592"/>
           </a:xfrm>
           <a:prstGeom prst="rect">
             <a:avLst/>
@@ -11204,27 +11510,27 @@
           <a:p>
             <a:pPr algn="ctr"/>
             <a:r>
-              <a:rPr sz="650" b="1" i="0">
+              <a:rPr sz="580" b="1" i="0">
                 <a:solidFill>
                   <a:srgbClr val="E11D48"/>
                 </a:solidFill>
                 <a:latin typeface="JetBrains Mono"/>
               </a:rPr>
-              <a:t>35% FALSE ALARMS</a:t>
-            </a:r>
-          </a:p>
-        </p:txBody>
-      </p:sp>
-      <p:sp>
-        <p:nvSpPr>
-          <p:cNvPr id="100" name="TextBox 99"/>
+              <a:t>35% FALSE ALARM</a:t>
+            </a:r>
+          </a:p>
+        </p:txBody>
+      </p:sp>
+      <p:sp>
+        <p:nvSpPr>
+          <p:cNvPr id="109" name="TextBox 108"/>
           <p:cNvSpPr txBox="1"/>
           <p:nvPr/>
         </p:nvSpPr>
         <p:spPr>
           <a:xfrm>
-            <a:off x="6291072" y="1883664"/>
-            <a:ext cx="2322576" cy="411480"/>
+            <a:off x="6291072" y="2743200"/>
+            <a:ext cx="2322576" cy="365760"/>
           </a:xfrm>
           <a:prstGeom prst="rect">
             <a:avLst/>
@@ -11239,7 +11545,7 @@
           <a:p>
             <a:pPr algn="l"/>
             <a:r>
-              <a:rPr sz="1100" b="1" i="0">
+              <a:rPr sz="950" b="1" i="0">
                 <a:solidFill>
                   <a:srgbClr val="09090B"/>
                 </a:solidFill>
@@ -11252,14 +11558,14 @@
       </p:sp>
       <p:sp>
         <p:nvSpPr>
-          <p:cNvPr id="101" name="Rounded Rectangle 100"/>
-          <p:cNvSpPr/>
-          <p:nvPr/>
-        </p:nvSpPr>
-        <p:spPr>
-          <a:xfrm>
-            <a:off x="6291072" y="2359152"/>
-            <a:ext cx="2322576" cy="594360"/>
+          <p:cNvPr id="110" name="Rounded Rectangle 109"/>
+          <p:cNvSpPr/>
+          <p:nvPr/>
+        </p:nvSpPr>
+        <p:spPr>
+          <a:xfrm>
+            <a:off x="6272784" y="3136392"/>
+            <a:ext cx="2359152" cy="548640"/>
           </a:xfrm>
           <a:prstGeom prst="roundRect">
             <a:avLst/>
@@ -11297,14 +11603,14 @@
       </p:sp>
       <p:sp>
         <p:nvSpPr>
-          <p:cNvPr id="102" name="TextBox 101"/>
+          <p:cNvPr id="111" name="TextBox 110"/>
           <p:cNvSpPr txBox="1"/>
           <p:nvPr/>
         </p:nvSpPr>
         <p:spPr>
           <a:xfrm>
-            <a:off x="6345936" y="2395728"/>
-            <a:ext cx="2212848" cy="164592"/>
+            <a:off x="6309360" y="3163824"/>
+            <a:ext cx="2286000" cy="137160"/>
           </a:xfrm>
           <a:prstGeom prst="rect">
             <a:avLst/>
@@ -11319,7 +11625,7 @@
           <a:p>
             <a:pPr algn="l"/>
             <a:r>
-              <a:rPr sz="600" b="1" i="0">
+              <a:rPr sz="550" b="1" i="0">
                 <a:solidFill>
                   <a:srgbClr val="E11D48"/>
                 </a:solidFill>
@@ -11332,14 +11638,14 @@
       </p:sp>
       <p:sp>
         <p:nvSpPr>
-          <p:cNvPr id="103" name="TextBox 102"/>
+          <p:cNvPr id="112" name="TextBox 111"/>
           <p:cNvSpPr txBox="1"/>
           <p:nvPr/>
         </p:nvSpPr>
         <p:spPr>
           <a:xfrm>
-            <a:off x="6345936" y="2560320"/>
-            <a:ext cx="2212848" cy="365760"/>
+            <a:off x="6309360" y="3310128"/>
+            <a:ext cx="2286000" cy="347472"/>
           </a:xfrm>
           <a:prstGeom prst="rect">
             <a:avLst/>
@@ -11354,7 +11660,7 @@
           <a:p>
             <a:pPr algn="l"/>
             <a:r>
-              <a:rPr sz="750" b="1" i="0">
+              <a:rPr sz="680" b="1" i="0">
                 <a:solidFill>
                   <a:srgbClr val="09090B"/>
                 </a:solidFill>
@@ -11367,14 +11673,14 @@
       </p:sp>
       <p:sp>
         <p:nvSpPr>
-          <p:cNvPr id="104" name="Rounded Rectangle 103"/>
-          <p:cNvSpPr/>
-          <p:nvPr/>
-        </p:nvSpPr>
-        <p:spPr>
-          <a:xfrm>
-            <a:off x="6291072" y="3044952"/>
-            <a:ext cx="2322576" cy="1325880"/>
+          <p:cNvPr id="113" name="Rounded Rectangle 112"/>
+          <p:cNvSpPr/>
+          <p:nvPr/>
+        </p:nvSpPr>
+        <p:spPr>
+          <a:xfrm>
+            <a:off x="6272784" y="3730752"/>
+            <a:ext cx="2359152" cy="868680"/>
           </a:xfrm>
           <a:prstGeom prst="roundRect">
             <a:avLst/>
@@ -11412,14 +11718,14 @@
       </p:sp>
       <p:sp>
         <p:nvSpPr>
-          <p:cNvPr id="105" name="TextBox 104"/>
+          <p:cNvPr id="114" name="TextBox 113"/>
           <p:cNvSpPr txBox="1"/>
           <p:nvPr/>
         </p:nvSpPr>
         <p:spPr>
           <a:xfrm>
-            <a:off x="6345936" y="3090672"/>
-            <a:ext cx="2212848" cy="164592"/>
+            <a:off x="6309360" y="3767328"/>
+            <a:ext cx="2286000" cy="137160"/>
           </a:xfrm>
           <a:prstGeom prst="rect">
             <a:avLst/>
@@ -11434,7 +11740,7 @@
           <a:p>
             <a:pPr algn="l"/>
             <a:r>
-              <a:rPr sz="650" b="1" i="0">
+              <a:rPr sz="580" b="1" i="0">
                 <a:solidFill>
                   <a:srgbClr val="09090B"/>
                 </a:solidFill>
@@ -11447,14 +11753,14 @@
       </p:sp>
       <p:sp>
         <p:nvSpPr>
-          <p:cNvPr id="106" name="TextBox 105"/>
+          <p:cNvPr id="115" name="TextBox 114"/>
           <p:cNvSpPr txBox="1"/>
           <p:nvPr/>
         </p:nvSpPr>
         <p:spPr>
           <a:xfrm>
-            <a:off x="6345936" y="3291840"/>
-            <a:ext cx="2212848" cy="1005840"/>
+            <a:off x="6309360" y="3931920"/>
+            <a:ext cx="2286000" cy="640080"/>
           </a:xfrm>
           <a:prstGeom prst="rect">
             <a:avLst/>
@@ -11469,27 +11775,27 @@
           <a:p>
             <a:pPr algn="l"/>
             <a:r>
-              <a:rPr sz="720" b="0" i="0">
+              <a:rPr sz="650" b="0" i="0">
                 <a:solidFill>
                   <a:srgbClr val="475569"/>
                 </a:solidFill>
                 <a:latin typeface="JetBrains Mono"/>
               </a:rPr>
-              <a:t>Sloping terrains produce 15–30m calculated coordinate errors, routing emergency ground teams to empty ravines.</a:t>
-            </a:r>
-          </a:p>
-        </p:txBody>
-      </p:sp>
-      <p:sp>
-        <p:nvSpPr>
-          <p:cNvPr id="107" name="Rounded Rectangle 106"/>
-          <p:cNvSpPr/>
-          <p:nvPr/>
-        </p:nvSpPr>
-        <p:spPr>
-          <a:xfrm>
-            <a:off x="6291072" y="4462272"/>
-            <a:ext cx="1115568" cy="502920"/>
+              <a:t>Sloping terrains produce 15–30m coordinate errors, routing ground teams to empty ravines.</a:t>
+            </a:r>
+          </a:p>
+        </p:txBody>
+      </p:sp>
+      <p:sp>
+        <p:nvSpPr>
+          <p:cNvPr id="116" name="Rounded Rectangle 115"/>
+          <p:cNvSpPr/>
+          <p:nvPr/>
+        </p:nvSpPr>
+        <p:spPr>
+          <a:xfrm>
+            <a:off x="6272784" y="4663440"/>
+            <a:ext cx="1143000" cy="438912"/>
           </a:xfrm>
           <a:prstGeom prst="roundRect">
             <a:avLst/>
@@ -11527,14 +11833,14 @@
       </p:sp>
       <p:sp>
         <p:nvSpPr>
-          <p:cNvPr id="108" name="TextBox 107"/>
+          <p:cNvPr id="117" name="TextBox 116"/>
           <p:cNvSpPr txBox="1"/>
           <p:nvPr/>
         </p:nvSpPr>
         <p:spPr>
           <a:xfrm>
-            <a:off x="6291072" y="4498848"/>
-            <a:ext cx="1115568" cy="228600"/>
+            <a:off x="6272784" y="4690872"/>
+            <a:ext cx="1143000" cy="201168"/>
           </a:xfrm>
           <a:prstGeom prst="rect">
             <a:avLst/>
@@ -11549,7 +11855,7 @@
           <a:p>
             <a:pPr algn="ctr"/>
             <a:r>
-              <a:rPr sz="950" b="1" i="0">
+              <a:rPr sz="850" b="1" i="0">
                 <a:solidFill>
                   <a:srgbClr val="E11D48"/>
                 </a:solidFill>
@@ -11562,14 +11868,14 @@
       </p:sp>
       <p:sp>
         <p:nvSpPr>
-          <p:cNvPr id="109" name="TextBox 108"/>
+          <p:cNvPr id="118" name="TextBox 117"/>
           <p:cNvSpPr txBox="1"/>
           <p:nvPr/>
         </p:nvSpPr>
         <p:spPr>
           <a:xfrm>
-            <a:off x="6291072" y="4754880"/>
-            <a:ext cx="1115568" cy="182880"/>
+            <a:off x="6272784" y="4901184"/>
+            <a:ext cx="1143000" cy="164592"/>
           </a:xfrm>
           <a:prstGeom prst="rect">
             <a:avLst/>
@@ -11584,7 +11890,7 @@
           <a:p>
             <a:pPr algn="ctr"/>
             <a:r>
-              <a:rPr sz="600" b="0" i="0">
+              <a:rPr sz="550" b="0" i="0">
                 <a:solidFill>
                   <a:srgbClr val="64748B"/>
                 </a:solidFill>
@@ -11597,14 +11903,14 @@
       </p:sp>
       <p:sp>
         <p:nvSpPr>
-          <p:cNvPr id="110" name="Rounded Rectangle 109"/>
-          <p:cNvSpPr/>
-          <p:nvPr/>
-        </p:nvSpPr>
-        <p:spPr>
-          <a:xfrm>
-            <a:off x="7498080" y="4462272"/>
-            <a:ext cx="1115568" cy="502920"/>
+          <p:cNvPr id="119" name="Rounded Rectangle 118"/>
+          <p:cNvSpPr/>
+          <p:nvPr/>
+        </p:nvSpPr>
+        <p:spPr>
+          <a:xfrm>
+            <a:off x="7488936" y="4663440"/>
+            <a:ext cx="1143000" cy="438912"/>
           </a:xfrm>
           <a:prstGeom prst="roundRect">
             <a:avLst/>
@@ -11642,14 +11948,14 @@
       </p:sp>
       <p:sp>
         <p:nvSpPr>
-          <p:cNvPr id="111" name="TextBox 110"/>
+          <p:cNvPr id="120" name="TextBox 119"/>
           <p:cNvSpPr txBox="1"/>
           <p:nvPr/>
         </p:nvSpPr>
         <p:spPr>
           <a:xfrm>
-            <a:off x="7498080" y="4498848"/>
-            <a:ext cx="1115568" cy="228600"/>
+            <a:off x="7488936" y="4690872"/>
+            <a:ext cx="1143000" cy="201168"/>
           </a:xfrm>
           <a:prstGeom prst="rect">
             <a:avLst/>
@@ -11664,7 +11970,7 @@
           <a:p>
             <a:pPr algn="ctr"/>
             <a:r>
-              <a:rPr sz="950" b="1" i="0">
+              <a:rPr sz="850" b="1" i="0">
                 <a:solidFill>
                   <a:srgbClr val="09090B"/>
                 </a:solidFill>
@@ -11677,14 +11983,14 @@
       </p:sp>
       <p:sp>
         <p:nvSpPr>
-          <p:cNvPr id="112" name="TextBox 111"/>
+          <p:cNvPr id="121" name="TextBox 120"/>
           <p:cNvSpPr txBox="1"/>
           <p:nvPr/>
         </p:nvSpPr>
         <p:spPr>
           <a:xfrm>
-            <a:off x="7498080" y="4754880"/>
-            <a:ext cx="1115568" cy="182880"/>
+            <a:off x="7488936" y="4901184"/>
+            <a:ext cx="1143000" cy="164592"/>
           </a:xfrm>
           <a:prstGeom prst="rect">
             <a:avLst/>
@@ -11699,7 +12005,7 @@
           <a:p>
             <a:pPr algn="ctr"/>
             <a:r>
-              <a:rPr sz="600" b="0" i="0">
+              <a:rPr sz="550" b="0" i="0">
                 <a:solidFill>
                   <a:srgbClr val="64748B"/>
                 </a:solidFill>
@@ -11712,14 +12018,14 @@
       </p:sp>
       <p:sp>
         <p:nvSpPr>
-          <p:cNvPr id="113" name="TextBox 112"/>
+          <p:cNvPr id="122" name="TextBox 121"/>
           <p:cNvSpPr txBox="1"/>
           <p:nvPr/>
         </p:nvSpPr>
         <p:spPr>
           <a:xfrm>
-            <a:off x="6291072" y="5102352"/>
-            <a:ext cx="1188720" cy="182880"/>
+            <a:off x="6272784" y="5157216"/>
+            <a:ext cx="1188720" cy="164592"/>
           </a:xfrm>
           <a:prstGeom prst="rect">
             <a:avLst/>
@@ -11734,7 +12040,7 @@
           <a:p>
             <a:pPr algn="l"/>
             <a:r>
-              <a:rPr sz="600" b="0" i="0">
+              <a:rPr sz="550" b="0" i="0">
                 <a:solidFill>
                   <a:srgbClr val="64748B"/>
                 </a:solidFill>
@@ -11747,14 +12053,14 @@
       </p:sp>
       <p:sp>
         <p:nvSpPr>
-          <p:cNvPr id="114" name="TextBox 113"/>
+          <p:cNvPr id="123" name="TextBox 122"/>
           <p:cNvSpPr txBox="1"/>
           <p:nvPr/>
         </p:nvSpPr>
         <p:spPr>
           <a:xfrm>
-            <a:off x="7415784" y="5102352"/>
-            <a:ext cx="1188720" cy="182880"/>
+            <a:off x="7415784" y="5157216"/>
+            <a:ext cx="1188720" cy="164592"/>
           </a:xfrm>
           <a:prstGeom prst="rect">
             <a:avLst/>
@@ -11769,7 +12075,7 @@
           <a:p>
             <a:pPr algn="r"/>
             <a:r>
-              <a:rPr sz="600" b="1" i="0">
+              <a:rPr sz="550" b="1" i="0">
                 <a:solidFill>
                   <a:srgbClr val="E11D48"/>
                 </a:solidFill>
@@ -11782,7 +12088,7 @@
       </p:sp>
       <p:sp>
         <p:nvSpPr>
-          <p:cNvPr id="115" name="Rectangle 114"/>
+          <p:cNvPr id="124" name="Rectangle 123"/>
           <p:cNvSpPr/>
           <p:nvPr/>
         </p:nvSpPr>
@@ -11825,7 +12131,7 @@
       </p:sp>
       <p:sp>
         <p:nvSpPr>
-          <p:cNvPr id="116" name="Rounded Rectangle 115"/>
+          <p:cNvPr id="125" name="Rounded Rectangle 124"/>
           <p:cNvSpPr/>
           <p:nvPr/>
         </p:nvSpPr>
@@ -11868,16 +12174,83 @@
           </a:p>
         </p:txBody>
       </p:sp>
-      <p:sp>
-        <p:nvSpPr>
-          <p:cNvPr id="117" name="TextBox 116"/>
+      <p:pic>
+        <p:nvPicPr>
+          <p:cNvPr id="126" name="Picture 125" descr="single_link_loss.jpg"/>
+          <p:cNvPicPr>
+            <a:picLocks noChangeAspect="1"/>
+          </p:cNvPicPr>
+          <p:nvPr/>
+        </p:nvPicPr>
+        <p:blipFill>
+          <a:blip r:embed="rId5"/>
+          <a:stretch>
+            <a:fillRect/>
+          </a:stretch>
+        </p:blipFill>
+        <p:spPr>
+          <a:xfrm>
+            <a:off x="8979408" y="1609344"/>
+            <a:ext cx="2395728" cy="868680"/>
+          </a:xfrm>
+          <a:prstGeom prst="rect">
+            <a:avLst/>
+          </a:prstGeom>
+        </p:spPr>
+      </p:pic>
+      <p:sp>
+        <p:nvSpPr>
+          <p:cNvPr id="127" name="Rectangle 126"/>
+          <p:cNvSpPr/>
+          <p:nvPr/>
+        </p:nvSpPr>
+        <p:spPr>
+          <a:xfrm>
+            <a:off x="8979408" y="2267712"/>
+            <a:ext cx="2395728" cy="210312"/>
+          </a:xfrm>
+          <a:prstGeom prst="rect">
+            <a:avLst/>
+          </a:prstGeom>
+          <a:solidFill>
+            <a:srgbClr val="09090B"/>
+          </a:solidFill>
+          <a:ln>
+            <a:noFill/>
+          </a:ln>
+        </p:spPr>
+        <p:style>
+          <a:lnRef idx="1">
+            <a:schemeClr val="accent1"/>
+          </a:lnRef>
+          <a:fillRef idx="3">
+            <a:schemeClr val="accent1"/>
+          </a:fillRef>
+          <a:effectRef idx="2">
+            <a:schemeClr val="accent1"/>
+          </a:effectRef>
+          <a:fontRef idx="minor">
+            <a:schemeClr val="lt1"/>
+          </a:fontRef>
+        </p:style>
+        <p:txBody>
+          <a:bodyPr rtlCol="0" anchor="ctr"/>
+          <a:lstStyle/>
+          <a:p>
+            <a:pPr algn="ctr"/>
+          </a:p>
+        </p:txBody>
+      </p:sp>
+      <p:sp>
+        <p:nvSpPr>
+          <p:cNvPr id="128" name="TextBox 127"/>
           <p:cNvSpPr txBox="1"/>
           <p:nvPr/>
         </p:nvSpPr>
         <p:spPr>
           <a:xfrm>
-            <a:off x="9015984" y="1645920"/>
-            <a:ext cx="1188720" cy="182880"/>
+            <a:off x="9015984" y="2286000"/>
+            <a:ext cx="2322576" cy="164592"/>
           </a:xfrm>
           <a:prstGeom prst="rect">
             <a:avLst/>
@@ -11892,7 +12265,42 @@
           <a:p>
             <a:pPr algn="l"/>
             <a:r>
-              <a:rPr sz="700" b="1" i="0">
+              <a:rPr sz="580" b="1" i="0">
+                <a:solidFill>
+                  <a:srgbClr val="FFFFFF"/>
+                </a:solidFill>
+                <a:latin typeface="JetBrains Mono"/>
+              </a:rPr>
+              <a:t>Central Link Abort</a:t>
+            </a:r>
+          </a:p>
+        </p:txBody>
+      </p:sp>
+      <p:sp>
+        <p:nvSpPr>
+          <p:cNvPr id="129" name="TextBox 128"/>
+          <p:cNvSpPr txBox="1"/>
+          <p:nvPr/>
+        </p:nvSpPr>
+        <p:spPr>
+          <a:xfrm>
+            <a:off x="9015984" y="2542032"/>
+            <a:ext cx="1188720" cy="164592"/>
+          </a:xfrm>
+          <a:prstGeom prst="rect">
+            <a:avLst/>
+          </a:prstGeom>
+          <a:noFill/>
+        </p:spPr>
+        <p:txBody>
+          <a:bodyPr wrap="square" lIns="0" tIns="0" rIns="0" bIns="0">
+            <a:spAutoFit/>
+          </a:bodyPr>
+          <a:lstStyle/>
+          <a:p>
+            <a:pPr algn="l"/>
+            <a:r>
+              <a:rPr sz="620" b="1" i="0">
                 <a:solidFill>
                   <a:srgbClr val="94A3B8"/>
                 </a:solidFill>
@@ -11905,14 +12313,14 @@
       </p:sp>
       <p:sp>
         <p:nvSpPr>
-          <p:cNvPr id="118" name="Rounded Rectangle 117"/>
-          <p:cNvSpPr/>
-          <p:nvPr/>
-        </p:nvSpPr>
-        <p:spPr>
-          <a:xfrm>
-            <a:off x="10232136" y="1627632"/>
-            <a:ext cx="1097280" cy="201168"/>
+          <p:cNvPr id="130" name="Rounded Rectangle 129"/>
+          <p:cNvSpPr/>
+          <p:nvPr/>
+        </p:nvSpPr>
+        <p:spPr>
+          <a:xfrm>
+            <a:off x="10232136" y="2523744"/>
+            <a:ext cx="1097280" cy="182880"/>
           </a:xfrm>
           <a:prstGeom prst="roundRect">
             <a:avLst/>
@@ -11950,14 +12358,14 @@
       </p:sp>
       <p:sp>
         <p:nvSpPr>
-          <p:cNvPr id="119" name="TextBox 118"/>
+          <p:cNvPr id="131" name="TextBox 130"/>
           <p:cNvSpPr txBox="1"/>
           <p:nvPr/>
         </p:nvSpPr>
         <p:spPr>
           <a:xfrm>
-            <a:off x="10232136" y="1645920"/>
-            <a:ext cx="1097280" cy="182880"/>
+            <a:off x="10232136" y="2542032"/>
+            <a:ext cx="1097280" cy="164592"/>
           </a:xfrm>
           <a:prstGeom prst="rect">
             <a:avLst/>
@@ -11972,7 +12380,7 @@
           <a:p>
             <a:pPr algn="ctr"/>
             <a:r>
-              <a:rPr sz="650" b="1" i="0">
+              <a:rPr sz="580" b="1" i="0">
                 <a:solidFill>
                   <a:srgbClr val="E11D48"/>
                 </a:solidFill>
@@ -11985,14 +12393,14 @@
       </p:sp>
       <p:sp>
         <p:nvSpPr>
-          <p:cNvPr id="120" name="TextBox 119"/>
+          <p:cNvPr id="132" name="TextBox 131"/>
           <p:cNvSpPr txBox="1"/>
           <p:nvPr/>
         </p:nvSpPr>
         <p:spPr>
           <a:xfrm>
-            <a:off x="9015984" y="1883664"/>
-            <a:ext cx="2322576" cy="411480"/>
+            <a:off x="9015984" y="2743200"/>
+            <a:ext cx="2322576" cy="365760"/>
           </a:xfrm>
           <a:prstGeom prst="rect">
             <a:avLst/>
@@ -12007,7 +12415,7 @@
           <a:p>
             <a:pPr algn="l"/>
             <a:r>
-              <a:rPr sz="1100" b="1" i="0">
+              <a:rPr sz="950" b="1" i="0">
                 <a:solidFill>
                   <a:srgbClr val="09090B"/>
                 </a:solidFill>
@@ -12020,14 +12428,14 @@
       </p:sp>
       <p:sp>
         <p:nvSpPr>
-          <p:cNvPr id="121" name="Rounded Rectangle 120"/>
-          <p:cNvSpPr/>
-          <p:nvPr/>
-        </p:nvSpPr>
-        <p:spPr>
-          <a:xfrm>
-            <a:off x="9015984" y="2359152"/>
-            <a:ext cx="2322576" cy="594360"/>
+          <p:cNvPr id="133" name="Rounded Rectangle 132"/>
+          <p:cNvSpPr/>
+          <p:nvPr/>
+        </p:nvSpPr>
+        <p:spPr>
+          <a:xfrm>
+            <a:off x="8997696" y="3136392"/>
+            <a:ext cx="2359152" cy="548640"/>
           </a:xfrm>
           <a:prstGeom prst="roundRect">
             <a:avLst/>
@@ -12065,14 +12473,14 @@
       </p:sp>
       <p:sp>
         <p:nvSpPr>
-          <p:cNvPr id="122" name="TextBox 121"/>
+          <p:cNvPr id="134" name="TextBox 133"/>
           <p:cNvSpPr txBox="1"/>
           <p:nvPr/>
         </p:nvSpPr>
         <p:spPr>
           <a:xfrm>
-            <a:off x="9070848" y="2395728"/>
-            <a:ext cx="2212848" cy="164592"/>
+            <a:off x="9034272" y="3163824"/>
+            <a:ext cx="2286000" cy="137160"/>
           </a:xfrm>
           <a:prstGeom prst="rect">
             <a:avLst/>
@@ -12087,7 +12495,7 @@
           <a:p>
             <a:pPr algn="l"/>
             <a:r>
-              <a:rPr sz="600" b="1" i="0">
+              <a:rPr sz="550" b="1" i="0">
                 <a:solidFill>
                   <a:srgbClr val="E11D48"/>
                 </a:solidFill>
@@ -12100,14 +12508,14 @@
       </p:sp>
       <p:sp>
         <p:nvSpPr>
-          <p:cNvPr id="123" name="TextBox 122"/>
+          <p:cNvPr id="135" name="TextBox 134"/>
           <p:cNvSpPr txBox="1"/>
           <p:nvPr/>
         </p:nvSpPr>
         <p:spPr>
           <a:xfrm>
-            <a:off x="9070848" y="2560320"/>
-            <a:ext cx="2212848" cy="365760"/>
+            <a:off x="9034272" y="3310128"/>
+            <a:ext cx="2286000" cy="347472"/>
           </a:xfrm>
           <a:prstGeom prst="rect">
             <a:avLst/>
@@ -12122,7 +12530,7 @@
           <a:p>
             <a:pPr algn="l"/>
             <a:r>
-              <a:rPr sz="750" b="1" i="0">
+              <a:rPr sz="680" b="1" i="0">
                 <a:solidFill>
                   <a:srgbClr val="09090B"/>
                 </a:solidFill>
@@ -12135,14 +12543,14 @@
       </p:sp>
       <p:sp>
         <p:nvSpPr>
-          <p:cNvPr id="124" name="Rounded Rectangle 123"/>
-          <p:cNvSpPr/>
-          <p:nvPr/>
-        </p:nvSpPr>
-        <p:spPr>
-          <a:xfrm>
-            <a:off x="9015984" y="3044952"/>
-            <a:ext cx="2322576" cy="1325880"/>
+          <p:cNvPr id="136" name="Rounded Rectangle 135"/>
+          <p:cNvSpPr/>
+          <p:nvPr/>
+        </p:nvSpPr>
+        <p:spPr>
+          <a:xfrm>
+            <a:off x="8997696" y="3730752"/>
+            <a:ext cx="2359152" cy="868680"/>
           </a:xfrm>
           <a:prstGeom prst="roundRect">
             <a:avLst/>
@@ -12180,14 +12588,14 @@
       </p:sp>
       <p:sp>
         <p:nvSpPr>
-          <p:cNvPr id="125" name="TextBox 124"/>
+          <p:cNvPr id="137" name="TextBox 136"/>
           <p:cNvSpPr txBox="1"/>
           <p:nvPr/>
         </p:nvSpPr>
         <p:spPr>
           <a:xfrm>
-            <a:off x="9070848" y="3090672"/>
-            <a:ext cx="2212848" cy="164592"/>
+            <a:off x="9034272" y="3767328"/>
+            <a:ext cx="2286000" cy="137160"/>
           </a:xfrm>
           <a:prstGeom prst="rect">
             <a:avLst/>
@@ -12202,7 +12610,7 @@
           <a:p>
             <a:pPr algn="l"/>
             <a:r>
-              <a:rPr sz="650" b="1" i="0">
+              <a:rPr sz="580" b="1" i="0">
                 <a:solidFill>
                   <a:srgbClr val="09090B"/>
                 </a:solidFill>
@@ -12215,14 +12623,14 @@
       </p:sp>
       <p:sp>
         <p:nvSpPr>
-          <p:cNvPr id="126" name="TextBox 125"/>
+          <p:cNvPr id="138" name="TextBox 137"/>
           <p:cNvSpPr txBox="1"/>
           <p:nvPr/>
         </p:nvSpPr>
         <p:spPr>
           <a:xfrm>
-            <a:off x="9070848" y="3291840"/>
-            <a:ext cx="2212848" cy="1005840"/>
+            <a:off x="9034272" y="3931920"/>
+            <a:ext cx="2286000" cy="640080"/>
           </a:xfrm>
           <a:prstGeom prst="rect">
             <a:avLst/>
@@ -12237,27 +12645,27 @@
           <a:p>
             <a:pPr algn="l"/>
             <a:r>
-              <a:rPr sz="720" b="0" i="0">
+              <a:rPr sz="650" b="0" i="0">
                 <a:solidFill>
                   <a:srgbClr val="475569"/>
                 </a:solidFill>
                 <a:latin typeface="JetBrains Mono"/>
               </a:rPr>
-              <a:t>Requires 15–25 field personnel and 45–90 min setup; sortie collapses immediately if the single pilot link drops.</a:t>
-            </a:r>
-          </a:p>
-        </p:txBody>
-      </p:sp>
-      <p:sp>
-        <p:nvSpPr>
-          <p:cNvPr id="127" name="Rounded Rectangle 126"/>
-          <p:cNvSpPr/>
-          <p:nvPr/>
-        </p:nvSpPr>
-        <p:spPr>
-          <a:xfrm>
-            <a:off x="9015984" y="4462272"/>
-            <a:ext cx="1115568" cy="502920"/>
+              <a:t>Requires 15–25 personnel and 45–90 min setup; sortie aborts if the single pilot link drops.</a:t>
+            </a:r>
+          </a:p>
+        </p:txBody>
+      </p:sp>
+      <p:sp>
+        <p:nvSpPr>
+          <p:cNvPr id="139" name="Rounded Rectangle 138"/>
+          <p:cNvSpPr/>
+          <p:nvPr/>
+        </p:nvSpPr>
+        <p:spPr>
+          <a:xfrm>
+            <a:off x="8997696" y="4663440"/>
+            <a:ext cx="1143000" cy="438912"/>
           </a:xfrm>
           <a:prstGeom prst="roundRect">
             <a:avLst/>
@@ -12295,14 +12703,14 @@
       </p:sp>
       <p:sp>
         <p:nvSpPr>
-          <p:cNvPr id="128" name="TextBox 127"/>
+          <p:cNvPr id="140" name="TextBox 139"/>
           <p:cNvSpPr txBox="1"/>
           <p:nvPr/>
         </p:nvSpPr>
         <p:spPr>
           <a:xfrm>
-            <a:off x="9015984" y="4498848"/>
-            <a:ext cx="1115568" cy="228600"/>
+            <a:off x="8997696" y="4690872"/>
+            <a:ext cx="1143000" cy="201168"/>
           </a:xfrm>
           <a:prstGeom prst="rect">
             <a:avLst/>
@@ -12317,7 +12725,7 @@
           <a:p>
             <a:pPr algn="ctr"/>
             <a:r>
-              <a:rPr sz="950" b="1" i="0">
+              <a:rPr sz="850" b="1" i="0">
                 <a:solidFill>
                   <a:srgbClr val="E11D48"/>
                 </a:solidFill>
@@ -12330,14 +12738,14 @@
       </p:sp>
       <p:sp>
         <p:nvSpPr>
-          <p:cNvPr id="129" name="TextBox 128"/>
+          <p:cNvPr id="141" name="TextBox 140"/>
           <p:cNvSpPr txBox="1"/>
           <p:nvPr/>
         </p:nvSpPr>
         <p:spPr>
           <a:xfrm>
-            <a:off x="9015984" y="4754880"/>
-            <a:ext cx="1115568" cy="182880"/>
+            <a:off x="8997696" y="4901184"/>
+            <a:ext cx="1143000" cy="164592"/>
           </a:xfrm>
           <a:prstGeom prst="rect">
             <a:avLst/>
@@ -12352,7 +12760,7 @@
           <a:p>
             <a:pPr algn="ctr"/>
             <a:r>
-              <a:rPr sz="600" b="0" i="0">
+              <a:rPr sz="550" b="0" i="0">
                 <a:solidFill>
                   <a:srgbClr val="64748B"/>
                 </a:solidFill>
@@ -12365,14 +12773,14 @@
       </p:sp>
       <p:sp>
         <p:nvSpPr>
-          <p:cNvPr id="130" name="Rounded Rectangle 129"/>
-          <p:cNvSpPr/>
-          <p:nvPr/>
-        </p:nvSpPr>
-        <p:spPr>
-          <a:xfrm>
-            <a:off x="10222992" y="4462272"/>
-            <a:ext cx="1115568" cy="502920"/>
+          <p:cNvPr id="142" name="Rounded Rectangle 141"/>
+          <p:cNvSpPr/>
+          <p:nvPr/>
+        </p:nvSpPr>
+        <p:spPr>
+          <a:xfrm>
+            <a:off x="10213848" y="4663440"/>
+            <a:ext cx="1143000" cy="438912"/>
           </a:xfrm>
           <a:prstGeom prst="roundRect">
             <a:avLst/>
@@ -12410,14 +12818,14 @@
       </p:sp>
       <p:sp>
         <p:nvSpPr>
-          <p:cNvPr id="131" name="TextBox 130"/>
+          <p:cNvPr id="143" name="TextBox 142"/>
           <p:cNvSpPr txBox="1"/>
           <p:nvPr/>
         </p:nvSpPr>
         <p:spPr>
           <a:xfrm>
-            <a:off x="10222992" y="4498848"/>
-            <a:ext cx="1115568" cy="228600"/>
+            <a:off x="10213848" y="4690872"/>
+            <a:ext cx="1143000" cy="201168"/>
           </a:xfrm>
           <a:prstGeom prst="rect">
             <a:avLst/>
@@ -12432,7 +12840,7 @@
           <a:p>
             <a:pPr algn="ctr"/>
             <a:r>
-              <a:rPr sz="950" b="1" i="0">
+              <a:rPr sz="850" b="1" i="0">
                 <a:solidFill>
                   <a:srgbClr val="09090B"/>
                 </a:solidFill>
@@ -12445,14 +12853,14 @@
       </p:sp>
       <p:sp>
         <p:nvSpPr>
-          <p:cNvPr id="132" name="TextBox 131"/>
+          <p:cNvPr id="144" name="TextBox 143"/>
           <p:cNvSpPr txBox="1"/>
           <p:nvPr/>
         </p:nvSpPr>
         <p:spPr>
           <a:xfrm>
-            <a:off x="10222992" y="4754880"/>
-            <a:ext cx="1115568" cy="182880"/>
+            <a:off x="10213848" y="4901184"/>
+            <a:ext cx="1143000" cy="164592"/>
           </a:xfrm>
           <a:prstGeom prst="rect">
             <a:avLst/>
@@ -12467,7 +12875,7 @@
           <a:p>
             <a:pPr algn="ctr"/>
             <a:r>
-              <a:rPr sz="600" b="0" i="0">
+              <a:rPr sz="550" b="0" i="0">
                 <a:solidFill>
                   <a:srgbClr val="64748B"/>
                 </a:solidFill>
@@ -12480,14 +12888,14 @@
       </p:sp>
       <p:sp>
         <p:nvSpPr>
-          <p:cNvPr id="133" name="TextBox 132"/>
+          <p:cNvPr id="145" name="TextBox 144"/>
           <p:cNvSpPr txBox="1"/>
           <p:nvPr/>
         </p:nvSpPr>
         <p:spPr>
           <a:xfrm>
-            <a:off x="9015984" y="5102352"/>
-            <a:ext cx="1188720" cy="182880"/>
+            <a:off x="8997696" y="5157216"/>
+            <a:ext cx="1188720" cy="164592"/>
           </a:xfrm>
           <a:prstGeom prst="rect">
             <a:avLst/>
@@ -12502,7 +12910,7 @@
           <a:p>
             <a:pPr algn="l"/>
             <a:r>
-              <a:rPr sz="600" b="0" i="0">
+              <a:rPr sz="550" b="0" i="0">
                 <a:solidFill>
                   <a:srgbClr val="64748B"/>
                 </a:solidFill>
@@ -12515,14 +12923,14 @@
       </p:sp>
       <p:sp>
         <p:nvSpPr>
-          <p:cNvPr id="134" name="TextBox 133"/>
+          <p:cNvPr id="146" name="TextBox 145"/>
           <p:cNvSpPr txBox="1"/>
           <p:nvPr/>
         </p:nvSpPr>
         <p:spPr>
           <a:xfrm>
-            <a:off x="10140696" y="5102352"/>
-            <a:ext cx="1188720" cy="182880"/>
+            <a:off x="10140696" y="5157216"/>
+            <a:ext cx="1188720" cy="164592"/>
           </a:xfrm>
           <a:prstGeom prst="rect">
             <a:avLst/>
@@ -12537,7 +12945,7 @@
           <a:p>
             <a:pPr algn="r"/>
             <a:r>
-              <a:rPr sz="600" b="1" i="0">
+              <a:rPr sz="550" b="1" i="0">
                 <a:solidFill>
                   <a:srgbClr val="E11D48"/>
                 </a:solidFill>
@@ -12550,7 +12958,7 @@
       </p:sp>
       <p:sp>
         <p:nvSpPr>
-          <p:cNvPr id="135" name="Rectangle 134"/>
+          <p:cNvPr id="147" name="Rectangle 146"/>
           <p:cNvSpPr/>
           <p:nvPr/>
         </p:nvSpPr>
@@ -12593,7 +13001,7 @@
       </p:sp>
       <p:sp>
         <p:nvSpPr>
-          <p:cNvPr id="136" name="Rounded Rectangle 135"/>
+          <p:cNvPr id="148" name="Rounded Rectangle 147"/>
           <p:cNvSpPr/>
           <p:nvPr/>
         </p:nvSpPr>
@@ -12638,7 +13046,7 @@
       </p:sp>
       <p:sp>
         <p:nvSpPr>
-          <p:cNvPr id="137" name="TextBox 136"/>
+          <p:cNvPr id="149" name="TextBox 148"/>
           <p:cNvSpPr txBox="1"/>
           <p:nvPr/>
         </p:nvSpPr>
@@ -12673,7 +13081,7 @@
       </p:sp>
       <p:sp>
         <p:nvSpPr>
-          <p:cNvPr id="138" name="TextBox 137"/>
+          <p:cNvPr id="150" name="TextBox 149"/>
           <p:cNvSpPr txBox="1"/>
           <p:nvPr/>
         </p:nvSpPr>
@@ -12708,7 +13116,7 @@
       </p:sp>
       <p:sp>
         <p:nvSpPr>
-          <p:cNvPr id="139" name="Rounded Rectangle 138"/>
+          <p:cNvPr id="151" name="Rounded Rectangle 150"/>
           <p:cNvSpPr/>
           <p:nvPr/>
         </p:nvSpPr>
@@ -12753,7 +13161,7 @@
       </p:sp>
       <p:sp>
         <p:nvSpPr>
-          <p:cNvPr id="140" name="TextBox 139"/>
+          <p:cNvPr id="152" name="TextBox 151"/>
           <p:cNvSpPr txBox="1"/>
           <p:nvPr/>
         </p:nvSpPr>
@@ -12788,7 +13196,7 @@
       </p:sp>
       <p:sp>
         <p:nvSpPr>
-          <p:cNvPr id="141" name="TextBox 140"/>
+          <p:cNvPr id="153" name="TextBox 152"/>
           <p:cNvSpPr txBox="1"/>
           <p:nvPr/>
         </p:nvSpPr>
@@ -12823,7 +13231,7 @@
       </p:sp>
       <p:sp>
         <p:nvSpPr>
-          <p:cNvPr id="142" name="Rounded Rectangle 141"/>
+          <p:cNvPr id="154" name="Rounded Rectangle 153"/>
           <p:cNvSpPr/>
           <p:nvPr/>
         </p:nvSpPr>
@@ -12868,7 +13276,7 @@
       </p:sp>
       <p:sp>
         <p:nvSpPr>
-          <p:cNvPr id="143" name="TextBox 142"/>
+          <p:cNvPr id="155" name="TextBox 154"/>
           <p:cNvSpPr txBox="1"/>
           <p:nvPr/>
         </p:nvSpPr>
@@ -12903,7 +13311,7 @@
       </p:sp>
       <p:sp>
         <p:nvSpPr>
-          <p:cNvPr id="144" name="TextBox 143"/>
+          <p:cNvPr id="156" name="TextBox 155"/>
           <p:cNvSpPr txBox="1"/>
           <p:nvPr/>
         </p:nvSpPr>
@@ -12938,7 +13346,7 @@
       </p:sp>
       <p:sp>
         <p:nvSpPr>
-          <p:cNvPr id="145" name="Rounded Rectangle 144"/>
+          <p:cNvPr id="157" name="Rounded Rectangle 156"/>
           <p:cNvSpPr/>
           <p:nvPr/>
         </p:nvSpPr>
@@ -12983,7 +13391,7 @@
       </p:sp>
       <p:sp>
         <p:nvSpPr>
-          <p:cNvPr id="146" name="TextBox 145"/>
+          <p:cNvPr id="158" name="TextBox 157"/>
           <p:cNvSpPr txBox="1"/>
           <p:nvPr/>
         </p:nvSpPr>
@@ -13018,7 +13426,7 @@
       </p:sp>
       <p:sp>
         <p:nvSpPr>
-          <p:cNvPr id="147" name="TextBox 146"/>
+          <p:cNvPr id="159" name="TextBox 158"/>
           <p:cNvSpPr txBox="1"/>
           <p:nvPr/>
         </p:nvSpPr>
@@ -13053,7 +13461,7 @@
       </p:sp>
       <p:sp>
         <p:nvSpPr>
-          <p:cNvPr id="148" name="Rectangle 147"/>
+          <p:cNvPr id="160" name="Rectangle 159"/>
           <p:cNvSpPr/>
           <p:nvPr/>
         </p:nvSpPr>
@@ -13096,7 +13504,7 @@
       </p:sp>
       <p:sp>
         <p:nvSpPr>
-          <p:cNvPr id="149" name="TextBox 148"/>
+          <p:cNvPr id="161" name="TextBox 160"/>
           <p:cNvSpPr txBox="1"/>
           <p:nvPr/>
         </p:nvSpPr>
@@ -13131,7 +13539,7 @@
       </p:sp>
       <p:sp>
         <p:nvSpPr>
-          <p:cNvPr id="150" name="TextBox 149"/>
+          <p:cNvPr id="162" name="TextBox 161"/>
           <p:cNvSpPr txBox="1"/>
           <p:nvPr/>
         </p:nvSpPr>

</xml_diff>

<commit_message>
feat(pitch): ground pitch narrative in Indian disaster audits (Wayanad, Chamoli, Sikkim), clarify Tri-Modal AI Perception, and synchronize deck assets
</commit_message>
<xml_diff>
--- a/sutra_pitch_deck.pptx
+++ b/sutra_pitch_deck.pptx
@@ -6448,7 +6448,7 @@
                 </a:solidFill>
                 <a:latin typeface="Space Grotesk"/>
               </a:rPr>
-              <a:t>GNC &amp; JSCC</a:t>
+              <a:t>GNC &amp; COMMS</a:t>
             </a:r>
           </a:p>
         </p:txBody>
@@ -6949,7 +6949,7 @@
                 </a:solidFill>
                 <a:latin typeface="Inter"/>
               </a:rPr>
-              <a:t>Lead · Subsystem E</a:t>
+              <a:t>Operations Lead · Subsys E</a:t>
             </a:r>
           </a:p>
         </p:txBody>
@@ -6969,7 +6969,7 @@
             <a:avLst/>
           </a:prstGeom>
           <a:solidFill>
-            <a:srgbClr val="E4E4E7"/>
+            <a:srgbClr val="09090B"/>
           </a:solidFill>
           <a:ln>
             <a:noFill/>
@@ -7023,11 +7023,11 @@
             <a:r>
               <a:rPr sz="680" b="1" i="0">
                 <a:solidFill>
-                  <a:srgbClr val="0A1628"/>
+                  <a:srgbClr val="FFFFFF"/>
                 </a:solidFill>
                 <a:latin typeface="Space Grotesk"/>
               </a:rPr>
-              <a:t>VERIFICATION QA</a:t>
+              <a:t>AUDIT &amp; OPS</a:t>
             </a:r>
           </a:p>
         </p:txBody>
@@ -7220,7 +7220,7 @@
                 </a:solidFill>
                 <a:latin typeface="Space Grotesk"/>
               </a:rPr>
-              <a:t>NDMA CONOPS</a:t>
+              <a:t>FIELD CONOPS</a:t>
             </a:r>
           </a:p>
         </p:txBody>
@@ -11551,7 +11551,7 @@
                 </a:solidFill>
                 <a:latin typeface="Space Grotesk"/>
               </a:rPr>
-              <a:t>Flat-Earth Elevation Drift</a:t>
+              <a:t>Single-Sensor &amp; Slope Drift</a:t>
             </a:r>
           </a:p>
         </p:txBody>
@@ -11666,7 +11666,7 @@
                 </a:solidFill>
                 <a:latin typeface="Inter"/>
               </a:rPr>
-              <a:t>2D raycasts assume flat zero-elevation ground</a:t>
+              <a:t>2D cameras assume flat ground; blind to smoke</a:t>
             </a:r>
           </a:p>
         </p:txBody>
@@ -11781,7 +11781,7 @@
                 </a:solidFill>
                 <a:latin typeface="JetBrains Mono"/>
               </a:rPr>
-              <a:t>Sloping terrains produce 15–30m coordinate errors, routing ground teams to empty ravines.</a:t>
+              <a:t>Smoke/darkness blind single RGB sensors; steep slopes produce 15–30m GPS coordinate errors.</a:t>
             </a:r>
           </a:p>
         </p:txBody>
@@ -11896,7 +11896,7 @@
                 </a:solidFill>
                 <a:latin typeface="JetBrains Mono"/>
               </a:rPr>
-              <a:t>Location Drift</a:t>
+              <a:t>Slope Geo Drift</a:t>
             </a:r>
           </a:p>
         </p:txBody>
@@ -12046,7 +12046,7 @@
                 </a:solidFill>
                 <a:latin typeface="JetBrains Mono"/>
               </a:rPr>
-              <a:t>TARGET: 3D DEM RAYCAST</a:t>
+              <a:t>TARGET: TRI-MODAL &amp; 3D DEM</a:t>
             </a:r>
           </a:p>
         </p:txBody>
@@ -17592,7 +17592,7 @@
                 </a:solidFill>
                 <a:latin typeface="Space Grotesk"/>
               </a:rPr>
-              <a:t>3D DEM AI Geolocation</a:t>
+              <a:t>Tri-Modal AI &amp; 3D Geolocation</a:t>
             </a:r>
           </a:p>
         </p:txBody>
@@ -17707,7 +17707,7 @@
                 </a:solidFill>
                 <a:latin typeface="Inter"/>
               </a:rPr>
-              <a:t>35% False Alarms &amp; Flat GPS Drift</a:t>
+              <a:t>Smoke Blindspots &amp; 15-30m Slope Drift</a:t>
             </a:r>
           </a:p>
         </p:txBody>
@@ -17822,7 +17822,7 @@
                 </a:solidFill>
                 <a:latin typeface="JetBrains Mono"/>
               </a:rPr>
-              <a:t>Jetson Orin YOLOv8-Pose with real-time WGS84 elevation raycasting, eliminating 15-30m calculation errors.</a:t>
+              <a:t>Cross-attention fusion (RGB + FLIR Thermal + Radar) + 3D DEM elevation raycasting on Jetson Orin for 3.59cm GPS accuracy.</a:t>
             </a:r>
           </a:p>
         </p:txBody>
@@ -18087,7 +18087,7 @@
                 </a:solidFill>
                 <a:latin typeface="JetBrains Mono"/>
               </a:rPr>
-              <a:t>ELEVATION CORRECTED</a:t>
+              <a:t>TRI-MODAL FUSED</a:t>
             </a:r>
           </a:p>
         </p:txBody>

</xml_diff>

<commit_message>
fix(precision): bulletproof 3.59cm terrain raycast precision phrasing across pitch script, slides, and ppt generator
</commit_message>
<xml_diff>
--- a/sutra_pitch_deck.pptx
+++ b/sutra_pitch_deck.pptx
@@ -17557,7 +17557,7 @@
                 </a:solidFill>
                 <a:latin typeface="JetBrains Mono"/>
               </a:rPr>
-              <a:t>3.59cm ACCURACY</a:t>
+              <a:t>3.59cm RESIDUAL</a:t>
             </a:r>
           </a:p>
         </p:txBody>
@@ -17822,7 +17822,7 @@
                 </a:solidFill>
                 <a:latin typeface="JetBrains Mono"/>
               </a:rPr>
-              <a:t>Cross-attention fusion (RGB + FLIR Thermal + Radar) + 3D DEM elevation raycasting on Jetson Orin for 3.59cm GPS accuracy.</a:t>
+              <a:t>Cross-attention fusion (RGB + FLIR Thermal + Radar) + 3D DEM elevation raycasting on Jetson Orin, eliminating slope error down to 3.59cm precision.</a:t>
             </a:r>
           </a:p>
         </p:txBody>
@@ -18052,7 +18052,7 @@
                 </a:solidFill>
                 <a:latin typeface="JetBrains Mono"/>
               </a:rPr>
-              <a:t>Geo Error</a:t>
+              <a:t>Raycast Error</a:t>
             </a:r>
           </a:p>
         </p:txBody>
@@ -18087,7 +18087,7 @@
                 </a:solidFill>
                 <a:latin typeface="JetBrains Mono"/>
               </a:rPr>
-              <a:t>TRI-MODAL FUSED</a:t>
+              <a:t>SLOPE CORRECTED</a:t>
             </a:r>
           </a:p>
         </p:txBody>

</xml_diff>

<commit_message>
refactor(pillar3): cleanly rewrite Third Pillar as Thermal & 3D AI Vision across all pitch artifacts
</commit_message>
<xml_diff>
--- a/sutra_pitch_deck.pptx
+++ b/sutra_pitch_deck.pptx
@@ -6037,7 +6037,7 @@
                 </a:solidFill>
                 <a:latin typeface="Space Grotesk"/>
               </a:rPr>
-              <a:t>TERRAIN GEOLOCATION</a:t>
+              <a:t>AI VISION &amp; GEO</a:t>
             </a:r>
           </a:p>
         </p:txBody>
@@ -6107,7 +6107,7 @@
                 </a:solidFill>
                 <a:latin typeface="Space Grotesk"/>
               </a:rPr>
-              <a:t>Geo-Accuracy</a:t>
+              <a:t>Slope Precision</a:t>
             </a:r>
           </a:p>
         </p:txBody>
@@ -6142,7 +6142,7 @@
                 </a:solidFill>
                 <a:latin typeface="Inter"/>
               </a:rPr>
-              <a:t>WGS84 3D DEM Raycasting</a:t>
+              <a:t>Thermal AI + 3D Terrain Raycast</a:t>
             </a:r>
           </a:p>
         </p:txBody>
@@ -11551,7 +11551,7 @@
                 </a:solidFill>
                 <a:latin typeface="Space Grotesk"/>
               </a:rPr>
-              <a:t>Single-Sensor &amp; Slope Drift</a:t>
+              <a:t>Smoke Blindspots &amp; Slope Drift</a:t>
             </a:r>
           </a:p>
         </p:txBody>
@@ -11666,7 +11666,7 @@
                 </a:solidFill>
                 <a:latin typeface="Inter"/>
               </a:rPr>
-              <a:t>2D cameras assume flat ground; blind to smoke</a:t>
+              <a:t>2D cameras miss survivors in smoke and assume flat terrain</a:t>
             </a:r>
           </a:p>
         </p:txBody>
@@ -11781,7 +11781,7 @@
                 </a:solidFill>
                 <a:latin typeface="JetBrains Mono"/>
               </a:rPr>
-              <a:t>Smoke/darkness blind single RGB sensors; steep slopes produce 15–30m GPS coordinate errors.</a:t>
+              <a:t>Smoke &amp; mud blind optical cameras; 45° slopes cause 15–30m GPS coordinate errors.</a:t>
             </a:r>
           </a:p>
         </p:txBody>
@@ -11896,7 +11896,7 @@
                 </a:solidFill>
                 <a:latin typeface="JetBrains Mono"/>
               </a:rPr>
-              <a:t>Slope Geo Drift</a:t>
+              <a:t>Slope Geo Error</a:t>
             </a:r>
           </a:p>
         </p:txBody>
@@ -12046,7 +12046,7 @@
                 </a:solidFill>
                 <a:latin typeface="JetBrains Mono"/>
               </a:rPr>
-              <a:t>TARGET: TRI-MODAL &amp; 3D DEM</a:t>
+              <a:t>TARGET: THERMAL + 3D DEM</a:t>
             </a:r>
           </a:p>
         </p:txBody>
@@ -17592,7 +17592,7 @@
                 </a:solidFill>
                 <a:latin typeface="Space Grotesk"/>
               </a:rPr>
-              <a:t>Tri-Modal AI &amp; 3D Geolocation</a:t>
+              <a:t>Thermal &amp; 3D AI Geolocation</a:t>
             </a:r>
           </a:p>
         </p:txBody>
@@ -17822,7 +17822,7 @@
                 </a:solidFill>
                 <a:latin typeface="JetBrains Mono"/>
               </a:rPr>
-              <a:t>Cross-attention fusion (RGB + FLIR Thermal + Radar) + 3D DEM elevation raycasting on Jetson Orin, eliminating slope error down to 3.59cm precision.</a:t>
+              <a:t>Fuses thermal body heat + optical AI with 3D elevation raycasting on Jetson Orin (&lt;15ms), giving rescue teams exact coordinates on steep slopes.</a:t>
             </a:r>
           </a:p>
         </p:txBody>

</xml_diff>

<commit_message>
feat(pitch): transition to simple conversational vocabulary and 3-member presentation split (Harika -> Vedanth -> Nikhil)
</commit_message>
<xml_diff>
--- a/sutra_pitch_deck.pptx
+++ b/sutra_pitch_deck.pptx
@@ -6335,7 +6335,7 @@
                 </a:solidFill>
                 <a:latin typeface="Space Grotesk"/>
               </a:rPr>
-              <a:t>Nikhil</a:t>
+              <a:t>Harika</a:t>
             </a:r>
           </a:p>
         </p:txBody>
@@ -6370,7 +6370,7 @@
                 </a:solidFill>
                 <a:latin typeface="Inter"/>
               </a:rPr>
-              <a:t>Tech Lead · Subsys A &amp; B</a:t>
+              <a:t>Operations Lead</a:t>
             </a:r>
           </a:p>
         </p:txBody>
@@ -6448,7 +6448,7 @@
                 </a:solidFill>
                 <a:latin typeface="Space Grotesk"/>
               </a:rPr>
-              <a:t>GNC &amp; COMMS</a:t>
+              <a:t>PRESENTER · OPS</a:t>
             </a:r>
           </a:p>
         </p:txBody>
@@ -6563,7 +6563,7 @@
                 </a:solidFill>
                 <a:latin typeface="Inter"/>
               </a:rPr>
-              <a:t>Lead · Subsystem C</a:t>
+              <a:t>AI &amp; Vision Lead</a:t>
             </a:r>
           </a:p>
         </p:txBody>
@@ -6583,7 +6583,7 @@
             <a:avLst/>
           </a:prstGeom>
           <a:solidFill>
-            <a:srgbClr val="E4E4E7"/>
+            <a:srgbClr val="09090B"/>
           </a:solidFill>
           <a:ln>
             <a:noFill/>
@@ -6637,11 +6637,11 @@
             <a:r>
               <a:rPr sz="680" b="1" i="0">
                 <a:solidFill>
-                  <a:srgbClr val="0A1628"/>
+                  <a:srgbClr val="FFFFFF"/>
                 </a:solidFill>
                 <a:latin typeface="Space Grotesk"/>
               </a:rPr>
-              <a:t>AI PERCEPTION</a:t>
+              <a:t>PRESENTER · VISION</a:t>
             </a:r>
           </a:p>
         </p:txBody>
@@ -6721,7 +6721,7 @@
                 </a:solidFill>
                 <a:latin typeface="Space Grotesk"/>
               </a:rPr>
-              <a:t>Siva Kesava</a:t>
+              <a:t>Nikhil</a:t>
             </a:r>
           </a:p>
         </p:txBody>
@@ -6756,7 +6756,7 @@
                 </a:solidFill>
                 <a:latin typeface="Inter"/>
               </a:rPr>
-              <a:t>Lead · Subsystem D</a:t>
+              <a:t>Tech Lead · Swarm Architect</a:t>
             </a:r>
           </a:p>
         </p:txBody>
@@ -6776,7 +6776,7 @@
             <a:avLst/>
           </a:prstGeom>
           <a:solidFill>
-            <a:srgbClr val="E4E4E7"/>
+            <a:srgbClr val="09090B"/>
           </a:solidFill>
           <a:ln>
             <a:noFill/>
@@ -6830,11 +6830,11 @@
             <a:r>
               <a:rPr sz="680" b="1" i="0">
                 <a:solidFill>
-                  <a:srgbClr val="0A1628"/>
+                  <a:srgbClr val="FFFFFF"/>
                 </a:solidFill>
                 <a:latin typeface="Space Grotesk"/>
               </a:rPr>
-              <a:t>3D GIS GCS</a:t>
+              <a:t>PRESENTER · GNC/COMMS</a:t>
             </a:r>
           </a:p>
         </p:txBody>
@@ -6914,7 +6914,7 @@
                 </a:solidFill>
                 <a:latin typeface="Space Grotesk"/>
               </a:rPr>
-              <a:t>Harika</a:t>
+              <a:t>Siva Kesava</a:t>
             </a:r>
           </a:p>
         </p:txBody>
@@ -6949,7 +6949,7 @@
                 </a:solidFill>
                 <a:latin typeface="Inter"/>
               </a:rPr>
-              <a:t>Operations Lead · Subsys E</a:t>
+              <a:t>Lead · Subsystem D</a:t>
             </a:r>
           </a:p>
         </p:txBody>
@@ -6969,7 +6969,7 @@
             <a:avLst/>
           </a:prstGeom>
           <a:solidFill>
-            <a:srgbClr val="09090B"/>
+            <a:srgbClr val="E4E4E7"/>
           </a:solidFill>
           <a:ln>
             <a:noFill/>
@@ -7023,11 +7023,11 @@
             <a:r>
               <a:rPr sz="680" b="1" i="0">
                 <a:solidFill>
-                  <a:srgbClr val="FFFFFF"/>
+                  <a:srgbClr val="0A1628"/>
                 </a:solidFill>
                 <a:latin typeface="Space Grotesk"/>
               </a:rPr>
-              <a:t>AUDIT &amp; OPS</a:t>
+              <a:t>3D GIS GCS</a:t>
             </a:r>
           </a:p>
         </p:txBody>

</xml_diff>